<commit_message>
refactor: preview uses template data instead of hardcoded styles
- template-loader.ts: extract PlaceholderStyle (position, fontSize,
  fontColor, fontName, bold, align) and DecoRect from layout XML
- SlidePreview.tsx: render using TemplateData — preview matches PPTX
- App.tsx: load template at startup, pass to SlidePreview
- Fix template placeholder colors with minimal defRPr color overrides

Co-Authored-By: Claude Opus 4.6 (1M context) <noreply@anthropic.com>
</commit_message>
<xml_diff>
--- a/public/templates/slide/Midnight_Executive_30_TemplateOnly.pptx
+++ b/public/templates/slide/Midnight_Executive_30_TemplateOnly.pptx
@@ -206,7 +206,15 @@
         </p:spPr>
         <p:txBody>
           <a:bodyPr wrap="square" anchor="t" anchorCtr="0"/>
-          <a:lstStyle/>
+          <a:lstStyle>
+            <a:defPPr>
+              <a:defRPr>
+                <a:solidFill>
+                  <a:srgbClr val="FFFFFF"/>
+                </a:solidFill>
+              </a:defRPr>
+            </a:defPPr>
+          </a:lstStyle>
           <a:p>
             <a:pPr algn="l">
               <a:buNone/>
@@ -236,7 +244,15 @@
         </p:spPr>
         <p:txBody>
           <a:bodyPr wrap="square" anchor="t" anchorCtr="0"/>
-          <a:lstStyle/>
+          <a:lstStyle>
+            <a:defPPr>
+              <a:defRPr>
+                <a:solidFill>
+                  <a:srgbClr val="FFFFFF"/>
+                </a:solidFill>
+              </a:defRPr>
+            </a:defPPr>
+          </a:lstStyle>
           <a:p>
             <a:pPr algn="l">
               <a:buNone/>
@@ -266,7 +282,15 @@
         </p:spPr>
         <p:txBody>
           <a:bodyPr wrap="square" anchor="t" anchorCtr="0"/>
-          <a:lstStyle/>
+          <a:lstStyle>
+            <a:defPPr>
+              <a:defRPr>
+                <a:solidFill>
+                  <a:srgbClr val="CADCFC"/>
+                </a:solidFill>
+              </a:defRPr>
+            </a:defPPr>
+          </a:lstStyle>
           <a:p>
             <a:pPr algn="l">
               <a:buNone/>
@@ -296,7 +320,15 @@
         </p:spPr>
         <p:txBody>
           <a:bodyPr wrap="square" anchor="t" anchorCtr="0"/>
-          <a:lstStyle/>
+          <a:lstStyle>
+            <a:defPPr>
+              <a:defRPr>
+                <a:solidFill>
+                  <a:srgbClr val="CADCFC"/>
+                </a:solidFill>
+              </a:defRPr>
+            </a:defPPr>
+          </a:lstStyle>
           <a:p>
             <a:pPr algn="l">
               <a:buNone/>
@@ -326,7 +358,15 @@
         </p:spPr>
         <p:txBody>
           <a:bodyPr wrap="square" anchor="t" anchorCtr="0"/>
-          <a:lstStyle/>
+          <a:lstStyle>
+            <a:defPPr>
+              <a:defRPr>
+                <a:solidFill>
+                  <a:srgbClr val="CADCFC"/>
+                </a:solidFill>
+              </a:defRPr>
+            </a:defPPr>
+          </a:lstStyle>
           <a:p>
             <a:pPr algn="l">
               <a:buNone/>
@@ -401,7 +441,15 @@
         </p:spPr>
         <p:txBody>
           <a:bodyPr wrap="square" anchor="t" anchorCtr="0"/>
-          <a:lstStyle/>
+          <a:lstStyle>
+            <a:defPPr>
+              <a:defRPr>
+                <a:solidFill>
+                  <a:srgbClr val="FFFFFF"/>
+                </a:solidFill>
+              </a:defRPr>
+            </a:defPPr>
+          </a:lstStyle>
           <a:p>
             <a:pPr algn="l">
               <a:buNone/>
@@ -431,7 +479,15 @@
         </p:spPr>
         <p:txBody>
           <a:bodyPr wrap="square" anchor="t" anchorCtr="0"/>
-          <a:lstStyle/>
+          <a:lstStyle>
+            <a:defPPr>
+              <a:defRPr>
+                <a:solidFill>
+                  <a:srgbClr val="CADCFC"/>
+                </a:solidFill>
+              </a:defRPr>
+            </a:defPPr>
+          </a:lstStyle>
           <a:p>
             <a:pPr algn="l">
               <a:buNone/>
@@ -509,7 +565,15 @@
         </p:spPr>
         <p:txBody>
           <a:bodyPr wrap="square" anchor="t" anchorCtr="0"/>
-          <a:lstStyle/>
+          <a:lstStyle>
+            <a:defPPr>
+              <a:defRPr>
+                <a:solidFill>
+                  <a:srgbClr val="1E293B"/>
+                </a:solidFill>
+              </a:defRPr>
+            </a:defPPr>
+          </a:lstStyle>
           <a:p>
             <a:pPr algn="l">
               <a:buNone/>
@@ -539,7 +603,15 @@
         </p:spPr>
         <p:txBody>
           <a:bodyPr wrap="square" anchor="t" anchorCtr="0"/>
-          <a:lstStyle/>
+          <a:lstStyle>
+            <a:defPPr>
+              <a:defRPr>
+                <a:solidFill>
+                  <a:srgbClr val="1E293B"/>
+                </a:solidFill>
+              </a:defRPr>
+            </a:defPPr>
+          </a:lstStyle>
           <a:p>
             <a:pPr algn="l">
               <a:buNone/>
@@ -569,7 +641,15 @@
         </p:spPr>
         <p:txBody>
           <a:bodyPr wrap="square" anchor="t" anchorCtr="0"/>
-          <a:lstStyle/>
+          <a:lstStyle>
+            <a:defPPr>
+              <a:defRPr>
+                <a:solidFill>
+                  <a:srgbClr val="94A3B8"/>
+                </a:solidFill>
+              </a:defRPr>
+            </a:defPPr>
+          </a:lstStyle>
           <a:p>
             <a:pPr algn="r">
               <a:buNone/>
@@ -644,7 +724,15 @@
         </p:spPr>
         <p:txBody>
           <a:bodyPr wrap="square" anchor="t" anchorCtr="0"/>
-          <a:lstStyle/>
+          <a:lstStyle>
+            <a:defPPr>
+              <a:defRPr>
+                <a:solidFill>
+                  <a:srgbClr val="FFFFFF"/>
+                </a:solidFill>
+              </a:defRPr>
+            </a:defPPr>
+          </a:lstStyle>
           <a:p>
             <a:pPr algn="l">
               <a:buNone/>
@@ -674,7 +762,15 @@
         </p:spPr>
         <p:txBody>
           <a:bodyPr wrap="square" anchor="t" anchorCtr="0"/>
-          <a:lstStyle/>
+          <a:lstStyle>
+            <a:defPPr>
+              <a:defRPr>
+                <a:solidFill>
+                  <a:srgbClr val="CADCFC"/>
+                </a:solidFill>
+              </a:defRPr>
+            </a:defPPr>
+          </a:lstStyle>
           <a:p>
             <a:pPr algn="l">
               <a:buNone/>
@@ -704,7 +800,15 @@
         </p:spPr>
         <p:txBody>
           <a:bodyPr wrap="square" anchor="t" anchorCtr="0"/>
-          <a:lstStyle/>
+          <a:lstStyle>
+            <a:defPPr>
+              <a:defRPr>
+                <a:solidFill>
+                  <a:srgbClr val="1E293B"/>
+                </a:solidFill>
+              </a:defRPr>
+            </a:defPPr>
+          </a:lstStyle>
           <a:p>
             <a:pPr algn="l">
               <a:buNone/>
@@ -734,7 +838,15 @@
         </p:spPr>
         <p:txBody>
           <a:bodyPr wrap="square" anchor="t" anchorCtr="0"/>
-          <a:lstStyle/>
+          <a:lstStyle>
+            <a:defPPr>
+              <a:defRPr>
+                <a:solidFill>
+                  <a:srgbClr val="1E293B"/>
+                </a:solidFill>
+              </a:defRPr>
+            </a:defPPr>
+          </a:lstStyle>
           <a:p>
             <a:pPr algn="l">
               <a:buNone/>
@@ -764,7 +876,15 @@
         </p:spPr>
         <p:txBody>
           <a:bodyPr wrap="square" anchor="t" anchorCtr="0"/>
-          <a:lstStyle/>
+          <a:lstStyle>
+            <a:defPPr>
+              <a:defRPr>
+                <a:solidFill>
+                  <a:srgbClr val="94A3B8"/>
+                </a:solidFill>
+              </a:defRPr>
+            </a:defPPr>
+          </a:lstStyle>
           <a:p>
             <a:pPr algn="r">
               <a:buNone/>
@@ -929,7 +1049,15 @@
         </p:spPr>
         <p:txBody>
           <a:bodyPr wrap="square" anchor="t" anchorCtr="0"/>
-          <a:lstStyle/>
+          <a:lstStyle>
+            <a:defPPr>
+              <a:defRPr>
+                <a:solidFill>
+                  <a:srgbClr val="FFFFFF"/>
+                </a:solidFill>
+              </a:defRPr>
+            </a:defPPr>
+          </a:lstStyle>
           <a:p>
             <a:pPr algn="l">
               <a:buNone/>
@@ -959,7 +1087,15 @@
         </p:spPr>
         <p:txBody>
           <a:bodyPr wrap="square" anchor="t" anchorCtr="0"/>
-          <a:lstStyle/>
+          <a:lstStyle>
+            <a:defPPr>
+              <a:defRPr>
+                <a:solidFill>
+                  <a:srgbClr val="FFFFFF"/>
+                </a:solidFill>
+              </a:defRPr>
+            </a:defPPr>
+          </a:lstStyle>
           <a:p>
             <a:pPr algn="l">
               <a:buNone/>
@@ -989,7 +1125,15 @@
         </p:spPr>
         <p:txBody>
           <a:bodyPr wrap="square" anchor="t" anchorCtr="0"/>
-          <a:lstStyle/>
+          <a:lstStyle>
+            <a:defPPr>
+              <a:defRPr>
+                <a:solidFill>
+                  <a:srgbClr val="CADCFC"/>
+                </a:solidFill>
+              </a:defRPr>
+            </a:defPPr>
+          </a:lstStyle>
           <a:p>
             <a:pPr algn="l">
               <a:buNone/>
@@ -1019,7 +1163,15 @@
         </p:spPr>
         <p:txBody>
           <a:bodyPr wrap="square" anchor="t" anchorCtr="0"/>
-          <a:lstStyle/>
+          <a:lstStyle>
+            <a:defPPr>
+              <a:defRPr>
+                <a:solidFill>
+                  <a:srgbClr val="CADCFC"/>
+                </a:solidFill>
+              </a:defRPr>
+            </a:defPPr>
+          </a:lstStyle>
           <a:p>
             <a:pPr algn="l">
               <a:buNone/>
@@ -1053,7 +1205,15 @@
         </p:spPr>
         <p:txBody>
           <a:bodyPr wrap="square" anchor="t" anchorCtr="0"/>
-          <a:lstStyle/>
+          <a:lstStyle>
+            <a:defPPr>
+              <a:defRPr>
+                <a:solidFill>
+                  <a:srgbClr val="CADCFC"/>
+                </a:solidFill>
+              </a:defRPr>
+            </a:defPPr>
+          </a:lstStyle>
           <a:p>
             <a:pPr algn="l">
               <a:buNone/>
@@ -1256,7 +1416,15 @@
         </p:spPr>
         <p:txBody>
           <a:bodyPr wrap="square" anchor="t" anchorCtr="0"/>
-          <a:lstStyle/>
+          <a:lstStyle>
+            <a:defPPr>
+              <a:defRPr>
+                <a:solidFill>
+                  <a:srgbClr val="FFFFFF"/>
+                </a:solidFill>
+              </a:defRPr>
+            </a:defPPr>
+          </a:lstStyle>
           <a:p>
             <a:pPr algn="l">
               <a:buNone/>
@@ -1286,7 +1454,15 @@
         </p:spPr>
         <p:txBody>
           <a:bodyPr wrap="square" anchor="t" anchorCtr="0"/>
-          <a:lstStyle/>
+          <a:lstStyle>
+            <a:defPPr>
+              <a:defRPr>
+                <a:solidFill>
+                  <a:srgbClr val="FFFFFF"/>
+                </a:solidFill>
+              </a:defRPr>
+            </a:defPPr>
+          </a:lstStyle>
           <a:p>
             <a:pPr algn="l">
               <a:buNone/>
@@ -1316,7 +1492,15 @@
         </p:spPr>
         <p:txBody>
           <a:bodyPr wrap="square" anchor="t" anchorCtr="0"/>
-          <a:lstStyle/>
+          <a:lstStyle>
+            <a:defPPr>
+              <a:defRPr>
+                <a:solidFill>
+                  <a:srgbClr val="CADCFC"/>
+                </a:solidFill>
+              </a:defRPr>
+            </a:defPPr>
+          </a:lstStyle>
           <a:p>
             <a:pPr algn="l">
               <a:buNone/>
@@ -1346,7 +1530,15 @@
         </p:spPr>
         <p:txBody>
           <a:bodyPr wrap="square" anchor="t" anchorCtr="0"/>
-          <a:lstStyle/>
+          <a:lstStyle>
+            <a:defPPr>
+              <a:defRPr>
+                <a:solidFill>
+                  <a:srgbClr val="CADCFC"/>
+                </a:solidFill>
+              </a:defRPr>
+            </a:defPPr>
+          </a:lstStyle>
           <a:p>
             <a:pPr algn="l">
               <a:buNone/>
@@ -1377,7 +1569,15 @@
         </p:spPr>
         <p:txBody>
           <a:bodyPr wrap="square" anchor="t" anchorCtr="0"/>
-          <a:lstStyle/>
+          <a:lstStyle>
+            <a:defPPr>
+              <a:defRPr>
+                <a:solidFill>
+                  <a:srgbClr val="CADCFC"/>
+                </a:solidFill>
+              </a:defRPr>
+            </a:defPPr>
+          </a:lstStyle>
           <a:p>
             <a:pPr algn="l">
               <a:buNone/>
@@ -1510,7 +1710,15 @@
         </p:spPr>
         <p:txBody>
           <a:bodyPr wrap="square" anchor="t" anchorCtr="0"/>
-          <a:lstStyle/>
+          <a:lstStyle>
+            <a:defPPr>
+              <a:defRPr>
+                <a:solidFill>
+                  <a:srgbClr val="3B82F6"/>
+                </a:solidFill>
+              </a:defRPr>
+            </a:defPPr>
+          </a:lstStyle>
           <a:p>
             <a:pPr algn="l">
               <a:buNone/>
@@ -1540,7 +1748,15 @@
         </p:spPr>
         <p:txBody>
           <a:bodyPr wrap="square" anchor="t" anchorCtr="0"/>
-          <a:lstStyle/>
+          <a:lstStyle>
+            <a:defPPr>
+              <a:defRPr>
+                <a:solidFill>
+                  <a:srgbClr val="FFFFFF"/>
+                </a:solidFill>
+              </a:defRPr>
+            </a:defPPr>
+          </a:lstStyle>
           <a:p>
             <a:pPr algn="l">
               <a:buNone/>
@@ -1570,7 +1786,15 @@
         </p:spPr>
         <p:txBody>
           <a:bodyPr wrap="square" anchor="t" anchorCtr="0"/>
-          <a:lstStyle/>
+          <a:lstStyle>
+            <a:defPPr>
+              <a:defRPr>
+                <a:solidFill>
+                  <a:srgbClr val="CADCFC"/>
+                </a:solidFill>
+              </a:defRPr>
+            </a:defPPr>
+          </a:lstStyle>
           <a:p>
             <a:pPr algn="l">
               <a:buNone/>
@@ -1671,7 +1895,15 @@
         </p:spPr>
         <p:txBody>
           <a:bodyPr wrap="square" anchor="t" anchorCtr="0"/>
-          <a:lstStyle/>
+          <a:lstStyle>
+            <a:defPPr>
+              <a:defRPr>
+                <a:solidFill>
+                  <a:srgbClr val="3B82F6"/>
+                </a:solidFill>
+              </a:defRPr>
+            </a:defPPr>
+          </a:lstStyle>
           <a:p>
             <a:pPr algn="ctr">
               <a:buNone/>
@@ -1701,7 +1933,15 @@
         </p:spPr>
         <p:txBody>
           <a:bodyPr wrap="square" anchor="t" anchorCtr="0"/>
-          <a:lstStyle/>
+          <a:lstStyle>
+            <a:defPPr>
+              <a:defRPr>
+                <a:solidFill>
+                  <a:srgbClr val="CADCFC"/>
+                </a:solidFill>
+              </a:defRPr>
+            </a:defPPr>
+          </a:lstStyle>
           <a:p>
             <a:pPr algn="ctr">
               <a:buNone/>
@@ -1731,7 +1971,15 @@
         </p:spPr>
         <p:txBody>
           <a:bodyPr wrap="square" anchor="t" anchorCtr="0"/>
-          <a:lstStyle/>
+          <a:lstStyle>
+            <a:defPPr>
+              <a:defRPr>
+                <a:solidFill>
+                  <a:srgbClr val="FFFFFF"/>
+                </a:solidFill>
+              </a:defRPr>
+            </a:defPPr>
+          </a:lstStyle>
           <a:p>
             <a:pPr algn="l">
               <a:buNone/>
@@ -1761,7 +2009,15 @@
         </p:spPr>
         <p:txBody>
           <a:bodyPr wrap="square" anchor="t" anchorCtr="0"/>
-          <a:lstStyle/>
+          <a:lstStyle>
+            <a:defPPr>
+              <a:defRPr>
+                <a:solidFill>
+                  <a:srgbClr val="CADCFC"/>
+                </a:solidFill>
+              </a:defRPr>
+            </a:defPPr>
+          </a:lstStyle>
           <a:p>
             <a:pPr algn="l">
               <a:buNone/>
@@ -1924,7 +2180,15 @@
         </p:spPr>
         <p:txBody>
           <a:bodyPr wrap="square" anchor="t" anchorCtr="0"/>
-          <a:lstStyle/>
+          <a:lstStyle>
+            <a:defPPr>
+              <a:defRPr>
+                <a:solidFill>
+                  <a:srgbClr val="3B82F6"/>
+                </a:solidFill>
+              </a:defRPr>
+            </a:defPPr>
+          </a:lstStyle>
           <a:p>
             <a:pPr algn="l">
               <a:buNone/>
@@ -1954,7 +2218,15 @@
         </p:spPr>
         <p:txBody>
           <a:bodyPr wrap="square" anchor="t" anchorCtr="0"/>
-          <a:lstStyle/>
+          <a:lstStyle>
+            <a:defPPr>
+              <a:defRPr>
+                <a:solidFill>
+                  <a:srgbClr val="FFFFFF"/>
+                </a:solidFill>
+              </a:defRPr>
+            </a:defPPr>
+          </a:lstStyle>
           <a:p>
             <a:pPr algn="l">
               <a:buNone/>
@@ -1984,7 +2256,15 @@
         </p:spPr>
         <p:txBody>
           <a:bodyPr wrap="square" anchor="t" anchorCtr="0"/>
-          <a:lstStyle/>
+          <a:lstStyle>
+            <a:defPPr>
+              <a:defRPr>
+                <a:solidFill>
+                  <a:srgbClr val="CADCFC"/>
+                </a:solidFill>
+              </a:defRPr>
+            </a:defPPr>
+          </a:lstStyle>
           <a:p>
             <a:pPr algn="l">
               <a:buNone/>
@@ -2059,7 +2339,15 @@
         </p:spPr>
         <p:txBody>
           <a:bodyPr wrap="square" anchor="t" anchorCtr="0"/>
-          <a:lstStyle/>
+          <a:lstStyle>
+            <a:defPPr>
+              <a:defRPr>
+                <a:solidFill>
+                  <a:srgbClr val="FFFFFF"/>
+                </a:solidFill>
+              </a:defRPr>
+            </a:defPPr>
+          </a:lstStyle>
           <a:p>
             <a:pPr algn="l">
               <a:buNone/>
@@ -2089,7 +2377,15 @@
         </p:spPr>
         <p:txBody>
           <a:bodyPr wrap="square" anchor="t" anchorCtr="0"/>
-          <a:lstStyle/>
+          <a:lstStyle>
+            <a:defPPr>
+              <a:defRPr>
+                <a:solidFill>
+                  <a:srgbClr val="CADCFC"/>
+                </a:solidFill>
+              </a:defRPr>
+            </a:defPPr>
+          </a:lstStyle>
           <a:p>
             <a:pPr algn="l">
               <a:buNone/>
@@ -2119,7 +2415,15 @@
         </p:spPr>
         <p:txBody>
           <a:bodyPr wrap="square" anchor="t" anchorCtr="0"/>
-          <a:lstStyle/>
+          <a:lstStyle>
+            <a:defPPr>
+              <a:defRPr>
+                <a:solidFill>
+                  <a:srgbClr val="1E293B"/>
+                </a:solidFill>
+              </a:defRPr>
+            </a:defPPr>
+          </a:lstStyle>
           <a:p>
             <a:pPr algn="l">
               <a:buNone/>
@@ -2149,7 +2453,15 @@
         </p:spPr>
         <p:txBody>
           <a:bodyPr wrap="square" anchor="t" anchorCtr="0"/>
-          <a:lstStyle/>
+          <a:lstStyle>
+            <a:defPPr>
+              <a:defRPr>
+                <a:solidFill>
+                  <a:srgbClr val="94A3B8"/>
+                </a:solidFill>
+              </a:defRPr>
+            </a:defPPr>
+          </a:lstStyle>
           <a:p>
             <a:pPr algn="r">
               <a:buNone/>
@@ -2224,7 +2536,15 @@
         </p:spPr>
         <p:txBody>
           <a:bodyPr wrap="square" anchor="t" anchorCtr="0"/>
-          <a:lstStyle/>
+          <a:lstStyle>
+            <a:defPPr>
+              <a:defRPr>
+                <a:solidFill>
+                  <a:srgbClr val="FFFFFF"/>
+                </a:solidFill>
+              </a:defRPr>
+            </a:defPPr>
+          </a:lstStyle>
           <a:p>
             <a:pPr algn="l">
               <a:buNone/>
@@ -2254,7 +2574,15 @@
         </p:spPr>
         <p:txBody>
           <a:bodyPr wrap="square" anchor="t" anchorCtr="0"/>
-          <a:lstStyle/>
+          <a:lstStyle>
+            <a:defPPr>
+              <a:defRPr>
+                <a:solidFill>
+                  <a:srgbClr val="CADCFC"/>
+                </a:solidFill>
+              </a:defRPr>
+            </a:defPPr>
+          </a:lstStyle>
           <a:p>
             <a:pPr algn="l">
               <a:buNone/>
@@ -2310,7 +2638,15 @@
         </p:spPr>
         <p:txBody>
           <a:bodyPr wrap="square" anchor="t" anchorCtr="0"/>
-          <a:lstStyle/>
+          <a:lstStyle>
+            <a:defPPr>
+              <a:defRPr>
+                <a:solidFill>
+                  <a:srgbClr val="1E293B"/>
+                </a:solidFill>
+              </a:defRPr>
+            </a:defPPr>
+          </a:lstStyle>
           <a:p>
             <a:pPr algn="l">
               <a:buNone/>
@@ -2340,7 +2676,15 @@
         </p:spPr>
         <p:txBody>
           <a:bodyPr wrap="square" anchor="t" anchorCtr="0"/>
-          <a:lstStyle/>
+          <a:lstStyle>
+            <a:defPPr>
+              <a:defRPr>
+                <a:solidFill>
+                  <a:srgbClr val="1E293B"/>
+                </a:solidFill>
+              </a:defRPr>
+            </a:defPPr>
+          </a:lstStyle>
           <a:p>
             <a:pPr algn="l">
               <a:buNone/>
@@ -2372,7 +2716,15 @@
         </p:spPr>
         <p:txBody>
           <a:bodyPr wrap="square" anchor="t" anchorCtr="0"/>
-          <a:lstStyle/>
+          <a:lstStyle>
+            <a:defPPr>
+              <a:defRPr>
+                <a:solidFill>
+                  <a:srgbClr val="94A3B8"/>
+                </a:solidFill>
+              </a:defRPr>
+            </a:defPPr>
+          </a:lstStyle>
           <a:p>
             <a:pPr algn="r">
               <a:buNone/>
@@ -2447,7 +2799,15 @@
         </p:spPr>
         <p:txBody>
           <a:bodyPr wrap="square" anchor="t" anchorCtr="0"/>
-          <a:lstStyle/>
+          <a:lstStyle>
+            <a:defPPr>
+              <a:defRPr>
+                <a:solidFill>
+                  <a:srgbClr val="FFFFFF"/>
+                </a:solidFill>
+              </a:defRPr>
+            </a:defPPr>
+          </a:lstStyle>
           <a:p>
             <a:pPr algn="l">
               <a:buNone/>
@@ -2477,7 +2837,15 @@
         </p:spPr>
         <p:txBody>
           <a:bodyPr wrap="square" anchor="t" anchorCtr="0"/>
-          <a:lstStyle/>
+          <a:lstStyle>
+            <a:defPPr>
+              <a:defRPr>
+                <a:solidFill>
+                  <a:srgbClr val="CADCFC"/>
+                </a:solidFill>
+              </a:defRPr>
+            </a:defPPr>
+          </a:lstStyle>
           <a:p>
             <a:pPr algn="l">
               <a:buNone/>
@@ -2529,7 +2897,15 @@
         </p:spPr>
         <p:txBody>
           <a:bodyPr wrap="square" anchor="t" anchorCtr="0"/>
-          <a:lstStyle/>
+          <a:lstStyle>
+            <a:defPPr>
+              <a:defRPr>
+                <a:solidFill>
+                  <a:srgbClr val="1E293B"/>
+                </a:solidFill>
+              </a:defRPr>
+            </a:defPPr>
+          </a:lstStyle>
           <a:p>
             <a:pPr algn="l">
               <a:buNone/>
@@ -2559,7 +2935,15 @@
         </p:spPr>
         <p:txBody>
           <a:bodyPr wrap="square" anchor="t" anchorCtr="0"/>
-          <a:lstStyle/>
+          <a:lstStyle>
+            <a:defPPr>
+              <a:defRPr>
+                <a:solidFill>
+                  <a:srgbClr val="1E293B"/>
+                </a:solidFill>
+              </a:defRPr>
+            </a:defPPr>
+          </a:lstStyle>
           <a:p>
             <a:pPr algn="l">
               <a:buNone/>
@@ -2589,7 +2973,15 @@
         </p:spPr>
         <p:txBody>
           <a:bodyPr wrap="square" anchor="t" anchorCtr="0"/>
-          <a:lstStyle/>
+          <a:lstStyle>
+            <a:defPPr>
+              <a:defRPr>
+                <a:solidFill>
+                  <a:srgbClr val="94A3B8"/>
+                </a:solidFill>
+              </a:defRPr>
+            </a:defPPr>
+          </a:lstStyle>
           <a:p>
             <a:pPr algn="r">
               <a:buNone/>

</xml_diff>

<commit_message>
fix: rebuild template OOXML style hierarchy properly
Theme: majorFont → Georgia (was Calibri)
Master: titleStyle/bodyStyle use theme font refs (+mj-lt/+mn-lt)
  instead of hardcoded typeface names
Layouts: lstStyle contains ONLY diffs from master —
  sz/b/color/align per placeholder as needed, font inherited from theme

This enables:
- Change theme font → all slides update
- Change master default size → non-overridden placeholders update
- Layout-specific overrides (header 28pt, subtitle 12pt, etc.) preserved

107 placeholders updated across 30 layouts.

Co-Authored-By: Claude Opus 4.6 (1M context) <noreply@anthropic.com>
</commit_message>
<xml_diff>
--- a/public/templates/slide/Midnight_Executive_30_TemplateOnly.pptx
+++ b/public/templates/slide/Midnight_Executive_30_TemplateOnly.pptx
@@ -208,9 +208,9 @@
           <a:bodyPr wrap="square" anchor="t" anchorCtr="0"/>
           <a:lstStyle>
             <a:defPPr>
-              <a:defRPr>
-                <a:solidFill>
-                  <a:srgbClr val="FFFFFF"/>
+              <a:defRPr sz="1500" b="1">
+                <a:solidFill>
+                  <a:srgbClr val="3B82F6"/>
                 </a:solidFill>
               </a:defRPr>
             </a:defPPr>
@@ -246,11 +246,7 @@
           <a:bodyPr wrap="square" anchor="t" anchorCtr="0"/>
           <a:lstStyle>
             <a:defPPr>
-              <a:defRPr>
-                <a:solidFill>
-                  <a:srgbClr val="FFFFFF"/>
-                </a:solidFill>
-              </a:defRPr>
+              <a:defRPr sz="4800"/>
             </a:defPPr>
           </a:lstStyle>
           <a:p>
@@ -284,7 +280,7 @@
           <a:bodyPr wrap="square" anchor="t" anchorCtr="0"/>
           <a:lstStyle>
             <a:defPPr>
-              <a:defRPr>
+              <a:defRPr sz="2000">
                 <a:solidFill>
                   <a:srgbClr val="CADCFC"/>
                 </a:solidFill>
@@ -360,7 +356,7 @@
           <a:bodyPr wrap="square" anchor="t" anchorCtr="0"/>
           <a:lstStyle>
             <a:defPPr>
-              <a:defRPr>
+              <a:defRPr sz="1100">
                 <a:solidFill>
                   <a:srgbClr val="CADCFC"/>
                 </a:solidFill>
@@ -443,7 +439,7 @@
           <a:bodyPr wrap="square" anchor="t" anchorCtr="0"/>
           <a:lstStyle>
             <a:defPPr>
-              <a:defRPr>
+              <a:defRPr sz="2800" b="1">
                 <a:solidFill>
                   <a:srgbClr val="FFFFFF"/>
                 </a:solidFill>
@@ -481,7 +477,7 @@
           <a:bodyPr wrap="square" anchor="t" anchorCtr="0"/>
           <a:lstStyle>
             <a:defPPr>
-              <a:defRPr>
+              <a:defRPr sz="1200">
                 <a:solidFill>
                   <a:srgbClr val="CADCFC"/>
                 </a:solidFill>
@@ -567,9 +563,9 @@
           <a:bodyPr wrap="square" anchor="t" anchorCtr="0"/>
           <a:lstStyle>
             <a:defPPr>
-              <a:defRPr>
-                <a:solidFill>
-                  <a:srgbClr val="1E293B"/>
+              <a:defRPr sz="1300">
+                <a:solidFill>
+                  <a:srgbClr val="1E2761"/>
                 </a:solidFill>
               </a:defRPr>
             </a:defPPr>
@@ -603,15 +599,7 @@
         </p:spPr>
         <p:txBody>
           <a:bodyPr wrap="square" anchor="t" anchorCtr="0"/>
-          <a:lstStyle>
-            <a:defPPr>
-              <a:defRPr>
-                <a:solidFill>
-                  <a:srgbClr val="1E293B"/>
-                </a:solidFill>
-              </a:defRPr>
-            </a:defPPr>
-          </a:lstStyle>
+          <a:lstStyle/>
           <a:p>
             <a:pPr algn="l">
               <a:buNone/>
@@ -642,8 +630,8 @@
         <p:txBody>
           <a:bodyPr wrap="square" anchor="t" anchorCtr="0"/>
           <a:lstStyle>
-            <a:defPPr>
-              <a:defRPr>
+            <a:defPPr algn="r">
+              <a:defRPr sz="1000">
                 <a:solidFill>
                   <a:srgbClr val="94A3B8"/>
                 </a:solidFill>
@@ -726,7 +714,7 @@
           <a:bodyPr wrap="square" anchor="t" anchorCtr="0"/>
           <a:lstStyle>
             <a:defPPr>
-              <a:defRPr>
+              <a:defRPr sz="2800" b="1">
                 <a:solidFill>
                   <a:srgbClr val="FFFFFF"/>
                 </a:solidFill>
@@ -764,7 +752,7 @@
           <a:bodyPr wrap="square" anchor="t" anchorCtr="0"/>
           <a:lstStyle>
             <a:defPPr>
-              <a:defRPr>
+              <a:defRPr sz="1200">
                 <a:solidFill>
                   <a:srgbClr val="CADCFC"/>
                 </a:solidFill>
@@ -800,15 +788,7 @@
         </p:spPr>
         <p:txBody>
           <a:bodyPr wrap="square" anchor="t" anchorCtr="0"/>
-          <a:lstStyle>
-            <a:defPPr>
-              <a:defRPr>
-                <a:solidFill>
-                  <a:srgbClr val="1E293B"/>
-                </a:solidFill>
-              </a:defRPr>
-            </a:defPPr>
-          </a:lstStyle>
+          <a:lstStyle/>
           <a:p>
             <a:pPr algn="l">
               <a:buNone/>
@@ -838,15 +818,7 @@
         </p:spPr>
         <p:txBody>
           <a:bodyPr wrap="square" anchor="t" anchorCtr="0"/>
-          <a:lstStyle>
-            <a:defPPr>
-              <a:defRPr>
-                <a:solidFill>
-                  <a:srgbClr val="1E293B"/>
-                </a:solidFill>
-              </a:defRPr>
-            </a:defPPr>
-          </a:lstStyle>
+          <a:lstStyle/>
           <a:p>
             <a:pPr algn="l">
               <a:buNone/>
@@ -877,8 +849,8 @@
         <p:txBody>
           <a:bodyPr wrap="square" anchor="t" anchorCtr="0"/>
           <a:lstStyle>
-            <a:defPPr>
-              <a:defRPr>
+            <a:defPPr algn="r">
+              <a:defRPr sz="1000">
                 <a:solidFill>
                   <a:srgbClr val="94A3B8"/>
                 </a:solidFill>
@@ -903,45 +875,45 @@
 </file>
 
 <file path=ppt/slideLayouts/slideLayout12.xml><?xml version='1.0' encoding='UTF-8' standalone='yes'?>
-<ns0:sldLayout xmlns:ns0="http://schemas.openxmlformats.org/presentationml/2006/main" type="twoObj" preserve="1"><ns0:cSld name="Column.2Body.MainSub"><ns0:spTree><ns0:nvGrpSpPr><ns0:cNvPr id="1" name=""/><ns0:cNvGrpSpPr/><ns0:nvPr/></ns0:nvGrpSpPr><ns0:grpSpPr><ns1:xfrm xmlns:ns1="http://schemas.openxmlformats.org/drawingml/2006/main"><ns1:off x="0" y="0"/><ns1:ext cx="0" cy="0"/><ns1:chOff x="0" y="0"/><ns1:chExt cx="0" cy="0"/></ns1:xfrm></ns0:grpSpPr><ns0:sp><ns0:nvSpPr><ns0:cNvPr id="2" name="HeaderBar"/><ns0:cNvSpPr><ns1:spLocks xmlns:ns1="http://schemas.openxmlformats.org/drawingml/2006/main" noGrp="1" noSelect="0" noRot="1" noMove="1"/></ns0:cNvSpPr><ns0:nvPr/></ns0:nvSpPr><ns0:spPr><ns2:xfrm xmlns:ns2="http://schemas.openxmlformats.org/drawingml/2006/main"><ns2:off x="0" y="0"/><ns2:ext cx="12192000" cy="1051560"/></ns2:xfrm><ns3:prstGeom xmlns:ns3="http://schemas.openxmlformats.org/drawingml/2006/main" prst="rect"/><ns4:solidFill xmlns:ns4="http://schemas.openxmlformats.org/drawingml/2006/main"><ns4:srgbClr val="1E2761"/></ns4:solidFill><ns5:ln xmlns:ns5="http://schemas.openxmlformats.org/drawingml/2006/main"><ns5:noFill/></ns5:ln></ns0:spPr></ns0:sp><ns0:sp><ns0:nvSpPr><ns0:cNvPr id="10" name="SlideTitle.Header"/><ns0:cNvSpPr><ns1:spLocks xmlns:ns1="http://schemas.openxmlformats.org/drawingml/2006/main" noGrp="1"/></ns0:cNvSpPr><ns0:nvPr><ns0:ph idx="15" type="body"/></ns0:nvPr></ns0:nvSpPr><ns0:spPr><ns2:xfrm xmlns:ns2="http://schemas.openxmlformats.org/drawingml/2006/main"><ns2:off x="731520" y="91440"/><ns2:ext cx="9144000" cy="475488"/></ns2:xfrm></ns0:spPr><ns0:txBody><ns3:bodyPr xmlns:ns3="http://schemas.openxmlformats.org/drawingml/2006/main" wrap="square" anchor="t" anchorCtr="0"/><ns4:lstStyle xmlns:ns4="http://schemas.openxmlformats.org/drawingml/2006/main"><ns4:defPPr algn="l"><ns4:buNone/><ns4:defRPr sz="2800" dirty="0" b="1"><ns4:solidFill><ns4:srgbClr val="FFFFFF"/></ns4:solidFill><ns4:latin typeface="Georgia"/><ns4:ea typeface="Georgia"/></ns4:defRPr></ns4:defPPr><ns4:lvl1pPr algn="l"><ns4:buNone/><ns4:defRPr sz="2800" dirty="0" b="1"><ns4:solidFill><ns4:srgbClr val="FFFFFF"/></ns4:solidFill><ns4:latin typeface="Georgia"/><ns4:ea typeface="Georgia"/></ns4:defRPr></ns4:lvl1pPr><ns4:lvl2pPr algn="l"><ns4:buNone/><ns4:defRPr sz="2800" dirty="0" b="1"><ns4:solidFill><ns4:srgbClr val="FFFFFF"/></ns4:solidFill><ns4:latin typeface="Georgia"/><ns4:ea typeface="Georgia"/></ns4:defRPr></ns4:lvl2pPr><ns4:lvl3pPr algn="l"><ns4:buNone/><ns4:defRPr sz="2800" dirty="0" b="1"><ns4:solidFill><ns4:srgbClr val="FFFFFF"/></ns4:solidFill><ns4:latin typeface="Georgia"/><ns4:ea typeface="Georgia"/></ns4:defRPr></ns4:lvl3pPr><ns4:lvl4pPr algn="l"><ns4:buNone/><ns4:defRPr sz="2800" dirty="0" b="1"><ns4:solidFill><ns4:srgbClr val="FFFFFF"/></ns4:solidFill><ns4:latin typeface="Georgia"/><ns4:ea typeface="Georgia"/></ns4:defRPr></ns4:lvl4pPr><ns4:lvl5pPr algn="l"><ns4:buNone/><ns4:defRPr sz="2800" dirty="0" b="1"><ns4:solidFill><ns4:srgbClr val="FFFFFF"/></ns4:solidFill><ns4:latin typeface="Georgia"/><ns4:ea typeface="Georgia"/></ns4:defRPr></ns4:lvl5pPr><ns4:lvl6pPr algn="l"><ns4:buNone/><ns4:defRPr sz="2800" dirty="0" b="1"><ns4:solidFill><ns4:srgbClr val="FFFFFF"/></ns4:solidFill><ns4:latin typeface="Georgia"/><ns4:ea typeface="Georgia"/></ns4:defRPr></ns4:lvl6pPr><ns4:lvl7pPr algn="l"><ns4:buNone/><ns4:defRPr sz="2800" dirty="0" b="1"><ns4:solidFill><ns4:srgbClr val="FFFFFF"/></ns4:solidFill><ns4:latin typeface="Georgia"/><ns4:ea typeface="Georgia"/></ns4:defRPr></ns4:lvl7pPr><ns4:lvl8pPr algn="l"><ns4:buNone/><ns4:defRPr sz="2800" dirty="0" b="1"><ns4:solidFill><ns4:srgbClr val="FFFFFF"/></ns4:solidFill><ns4:latin typeface="Georgia"/><ns4:ea typeface="Georgia"/></ns4:defRPr></ns4:lvl8pPr><ns4:lvl9pPr algn="l"><ns4:buNone/><ns4:defRPr sz="2800" dirty="0" b="1"><ns4:solidFill><ns4:srgbClr val="FFFFFF"/></ns4:solidFill><ns4:latin typeface="Georgia"/><ns4:ea typeface="Georgia"/></ns4:defRPr></ns4:lvl9pPr></ns4:lstStyle/><ns5:p xmlns:ns5="http://schemas.openxmlformats.org/drawingml/2006/main"><ns5:pPr algn="l"><ns5:buNone/></ns5:pPr><ns5:r><ns5:rPr lang="ja-JP"/><ns5:t>サブタイトル</ns5:t></ns5:r></ns5:p></ns0:txBody></ns0:sp><ns0:sp><ns0:nvSpPr><ns0:cNvPr id="20" name="Body1.Left"/><ns0:cNvSpPr><ns1:spLocks xmlns:ns1="http://schemas.openxmlformats.org/drawingml/2006/main" noGrp="1"/></ns0:cNvSpPr><ns0:nvPr><ns0:ph idx="1" type="body"/></ns0:nvPr></ns0:nvSpPr><ns0:spPr><ns2:xfrm xmlns:ns2="http://schemas.openxmlformats.org/drawingml/2006/main"><ns2:off x="731520" y="1325880"/><ns2:ext cx="6766560" cy="4937760"/></ns2:xfrm></ns0:spPr><ns0:txBody><ns3:bodyPr xmlns:ns3="http://schemas.openxmlformats.org/drawingml/2006/main" wrap="square" anchor="t" anchorCtr="0"/><ns4:lstStyle xmlns:ns4="http://schemas.openxmlformats.org/drawingml/2006/main"><ns4:defPPr algn="l"><ns4:buNone/><ns4:defRPr sz="1400" dirty="0"><ns4:solidFill><ns4:srgbClr val="1E293B"/></ns4:solidFill><ns4:latin typeface="Calibri"/><ns4:ea typeface="Calibri"/></ns4:defRPr></ns4:defPPr><ns4:lvl1pPr algn="l"><ns4:buNone/><ns4:defRPr sz="1400" dirty="0"><ns4:solidFill><ns4:srgbClr val="1E293B"/></ns4:solidFill><ns4:latin typeface="Calibri"/><ns4:ea typeface="Calibri"/></ns4:defRPr></ns4:lvl1pPr><ns4:lvl2pPr algn="l"><ns4:buNone/><ns4:defRPr sz="1400" dirty="0"><ns4:solidFill><ns4:srgbClr val="1E293B"/></ns4:solidFill><ns4:latin typeface="Calibri"/><ns4:ea typeface="Calibri"/></ns4:defRPr></ns4:lvl2pPr><ns4:lvl3pPr algn="l"><ns4:buNone/><ns4:defRPr sz="1400" dirty="0"><ns4:solidFill><ns4:srgbClr val="1E293B"/></ns4:solidFill><ns4:latin typeface="Calibri"/><ns4:ea typeface="Calibri"/></ns4:defRPr></ns4:lvl3pPr><ns4:lvl4pPr algn="l"><ns4:buNone/><ns4:defRPr sz="1400" dirty="0"><ns4:solidFill><ns4:srgbClr val="1E293B"/></ns4:solidFill><ns4:latin typeface="Calibri"/><ns4:ea typeface="Calibri"/></ns4:defRPr></ns4:lvl4pPr><ns4:lvl5pPr algn="l"><ns4:buNone/><ns4:defRPr sz="1400" dirty="0"><ns4:solidFill><ns4:srgbClr val="1E293B"/></ns4:solidFill><ns4:latin typeface="Calibri"/><ns4:ea typeface="Calibri"/></ns4:defRPr></ns4:lvl5pPr><ns4:lvl6pPr algn="l"><ns4:buNone/><ns4:defRPr sz="1400" dirty="0"><ns4:solidFill><ns4:srgbClr val="1E293B"/></ns4:solidFill><ns4:latin typeface="Calibri"/><ns4:ea typeface="Calibri"/></ns4:defRPr></ns4:lvl6pPr><ns4:lvl7pPr algn="l"><ns4:buNone/><ns4:defRPr sz="1400" dirty="0"><ns4:solidFill><ns4:srgbClr val="1E293B"/></ns4:solidFill><ns4:latin typeface="Calibri"/><ns4:ea typeface="Calibri"/></ns4:defRPr></ns4:lvl7pPr><ns4:lvl8pPr algn="l"><ns4:buNone/><ns4:defRPr sz="1400" dirty="0"><ns4:solidFill><ns4:srgbClr val="1E293B"/></ns4:solidFill><ns4:latin typeface="Calibri"/><ns4:ea typeface="Calibri"/></ns4:defRPr></ns4:lvl8pPr><ns4:lvl9pPr algn="l"><ns4:buNone/><ns4:defRPr sz="1400" dirty="0"><ns4:solidFill><ns4:srgbClr val="1E293B"/></ns4:solidFill><ns4:latin typeface="Calibri"/><ns4:ea typeface="Calibri"/></ns4:defRPr></ns4:lvl9pPr></ns4:lstStyle/><ns5:p xmlns:ns5="http://schemas.openxmlformats.org/drawingml/2006/main"><ns5:pPr algn="l"><ns5:buNone/></ns5:pPr><ns5:r><ns5:rPr lang="ja-JP"/><ns5:t>サブカラム</ns5:t></ns5:r></ns5:p></ns0:txBody></ns0:sp><ns0:sp><ns0:nvSpPr><ns0:cNvPr id="30" name="SlideNum.Footer"/><ns0:cNvSpPr><ns1:spLocks xmlns:ns1="http://schemas.openxmlformats.org/drawingml/2006/main" noGrp="1"/></ns0:cNvSpPr><ns0:nvPr><ns0:ph idx="50" type="sldNum"/></ns0:nvPr></ns0:nvSpPr><ns0:spPr><ns2:xfrm xmlns:ns2="http://schemas.openxmlformats.org/drawingml/2006/main"><ns2:off x="10972800" y="6446520"/><ns2:ext cx="1097280" cy="274320"/></ns2:xfrm></ns0:spPr><ns0:txBody><ns3:bodyPr xmlns:ns3="http://schemas.openxmlformats.org/drawingml/2006/main" wrap="square" anchor="t" anchorCtr="0"/><ns4:lstStyle xmlns:ns4="http://schemas.openxmlformats.org/drawingml/2006/main"><ns4:defPPr algn="r"><ns4:buNone/><ns4:defRPr sz="1000" dirty="0"><ns4:solidFill><ns4:srgbClr val="94A3B8"/></ns4:solidFill><ns4:latin typeface="Calibri"/><ns4:ea typeface="Calibri"/></ns4:defRPr></ns4:defPPr><ns4:lvl1pPr algn="r"><ns4:buNone/><ns4:defRPr sz="1000" dirty="0"><ns4:solidFill><ns4:srgbClr val="94A3B8"/></ns4:solidFill><ns4:latin typeface="Calibri"/><ns4:ea typeface="Calibri"/></ns4:defRPr></ns4:lvl1pPr><ns4:lvl2pPr algn="r"><ns4:buNone/><ns4:defRPr sz="1000" dirty="0"><ns4:solidFill><ns4:srgbClr val="94A3B8"/></ns4:solidFill><ns4:latin typeface="Calibri"/><ns4:ea typeface="Calibri"/></ns4:defRPr></ns4:lvl2pPr><ns4:lvl3pPr algn="r"><ns4:buNone/><ns4:defRPr sz="1000" dirty="0"><ns4:solidFill><ns4:srgbClr val="94A3B8"/></ns4:solidFill><ns4:latin typeface="Calibri"/><ns4:ea typeface="Calibri"/></ns4:defRPr></ns4:lvl3pPr><ns4:lvl4pPr algn="r"><ns4:buNone/><ns4:defRPr sz="1000" dirty="0"><ns4:solidFill><ns4:srgbClr val="94A3B8"/></ns4:solidFill><ns4:latin typeface="Calibri"/><ns4:ea typeface="Calibri"/></ns4:defRPr></ns4:lvl4pPr><ns4:lvl5pPr algn="r"><ns4:buNone/><ns4:defRPr sz="1000" dirty="0"><ns4:solidFill><ns4:srgbClr val="94A3B8"/></ns4:solidFill><ns4:latin typeface="Calibri"/><ns4:ea typeface="Calibri"/></ns4:defRPr></ns4:lvl5pPr><ns4:lvl6pPr algn="r"><ns4:buNone/><ns4:defRPr sz="1000" dirty="0"><ns4:solidFill><ns4:srgbClr val="94A3B8"/></ns4:solidFill><ns4:latin typeface="Calibri"/><ns4:ea typeface="Calibri"/></ns4:defRPr></ns4:lvl6pPr><ns4:lvl7pPr algn="r"><ns4:buNone/><ns4:defRPr sz="1000" dirty="0"><ns4:solidFill><ns4:srgbClr val="94A3B8"/></ns4:solidFill><ns4:latin typeface="Calibri"/><ns4:ea typeface="Calibri"/></ns4:defRPr></ns4:lvl7pPr><ns4:lvl8pPr algn="r"><ns4:buNone/><ns4:defRPr sz="1000" dirty="0"><ns4:solidFill><ns4:srgbClr val="94A3B8"/></ns4:solidFill><ns4:latin typeface="Calibri"/><ns4:ea typeface="Calibri"/></ns4:defRPr></ns4:lvl8pPr><ns4:lvl9pPr algn="r"><ns4:buNone/><ns4:defRPr sz="1000" dirty="0"><ns4:solidFill><ns4:srgbClr val="94A3B8"/></ns4:solidFill><ns4:latin typeface="Calibri"/><ns4:ea typeface="Calibri"/></ns4:defRPr></ns4:lvl9pPr></ns4:lstStyle><ns5:p xmlns:ns5="http://schemas.openxmlformats.org/drawingml/2006/main"><ns5:pPr algn="r"><ns5:buNone/></ns5:pPr><ns5:r><ns5:rPr lang="ja-JP"/><ns5:t>&lt;#&gt;</ns5:t></ns5:r></ns5:p></ns0:txBody></ns0:sp></ns0:spTree></ns0:cSld><ns0:clrMapOvr/></ns0:sldLayout>
+<ns0:sldLayout xmlns:ns0="http://schemas.openxmlformats.org/presentationml/2006/main" type="twoObj" preserve="1"><ns0:cSld name="Column.2Body.MainSub"><ns0:spTree><ns0:nvGrpSpPr><ns0:cNvPr id="1" name=""/><ns0:cNvGrpSpPr/><ns0:nvPr/></ns0:nvGrpSpPr><ns0:grpSpPr><ns1:xfrm xmlns:ns1="http://schemas.openxmlformats.org/drawingml/2006/main"><ns1:off x="0" y="0"/><ns1:ext cx="0" cy="0"/><ns1:chOff x="0" y="0"/><ns1:chExt cx="0" cy="0"/></ns1:xfrm></ns0:grpSpPr><ns0:sp><ns0:nvSpPr><ns0:cNvPr id="2" name="HeaderBar"/><ns0:cNvSpPr><ns1:spLocks xmlns:ns1="http://schemas.openxmlformats.org/drawingml/2006/main" noGrp="1" noSelect="0" noRot="1" noMove="1"/></ns0:cNvSpPr><ns0:nvPr/></ns0:nvSpPr><ns0:spPr><ns2:xfrm xmlns:ns2="http://schemas.openxmlformats.org/drawingml/2006/main"><ns2:off x="0" y="0"/><ns2:ext cx="12192000" cy="1051560"/></ns2:xfrm><ns3:prstGeom xmlns:ns3="http://schemas.openxmlformats.org/drawingml/2006/main" prst="rect"/><ns4:solidFill xmlns:ns4="http://schemas.openxmlformats.org/drawingml/2006/main"><ns4:srgbClr val="1E2761"/></ns4:solidFill><ns5:ln xmlns:ns5="http://schemas.openxmlformats.org/drawingml/2006/main"><ns5:noFill/></ns5:ln></ns0:spPr></ns0:sp><ns0:sp><ns0:nvSpPr><ns0:cNvPr id="10" name="SlideTitle.Header"/><ns0:cNvSpPr><ns1:spLocks xmlns:ns1="http://schemas.openxmlformats.org/drawingml/2006/main" noGrp="1"/></ns0:cNvSpPr><ns0:nvPr><ns0:ph idx="15" type="body"/></ns0:nvPr></ns0:nvSpPr><ns0:spPr><ns2:xfrm xmlns:ns2="http://schemas.openxmlformats.org/drawingml/2006/main"><ns2:off x="731520" y="91440"/><ns2:ext cx="9144000" cy="475488"/></ns2:xfrm></ns0:spPr><ns0:txBody><ns3:bodyPr xmlns:ns3="http://schemas.openxmlformats.org/drawingml/2006/main" wrap="square" anchor="t" anchorCtr="0"/><ns4:lstStyle><ns4:defPPr><ns4:defRPr sz="2800" b="1"><ns4:solidFill><ns4:srgbClr val="FFFFFF"/></ns4:solidFill></ns4:defRPr></ns4:defPPr></ns4:lstStyle><ns4:defPPr algn="l"><ns4:buNone/><ns4:defRPr sz="2800" dirty="0" b="1"><ns4:solidFill><ns4:srgbClr val="FFFFFF"/></ns4:solidFill><ns4:latin typeface="Georgia"/><ns4:ea typeface="Georgia"/></ns4:defRPr></ns4:defPPr><ns4:lvl1pPr algn="l"><ns4:buNone/><ns4:defRPr sz="2800" dirty="0" b="1"><ns4:solidFill><ns4:srgbClr val="FFFFFF"/></ns4:solidFill><ns4:latin typeface="Georgia"/><ns4:ea typeface="Georgia"/></ns4:defRPr></ns4:lvl1pPr><ns4:lvl2pPr algn="l"><ns4:buNone/><ns4:defRPr sz="2800" dirty="0" b="1"><ns4:solidFill><ns4:srgbClr val="FFFFFF"/></ns4:solidFill><ns4:latin typeface="Georgia"/><ns4:ea typeface="Georgia"/></ns4:defRPr></ns4:lvl2pPr><ns4:lvl3pPr algn="l"><ns4:buNone/><ns4:defRPr sz="2800" dirty="0" b="1"><ns4:solidFill><ns4:srgbClr val="FFFFFF"/></ns4:solidFill><ns4:latin typeface="Georgia"/><ns4:ea typeface="Georgia"/></ns4:defRPr></ns4:lvl3pPr><ns4:lvl4pPr algn="l"><ns4:buNone/><ns4:defRPr sz="2800" dirty="0" b="1"><ns4:solidFill><ns4:srgbClr val="FFFFFF"/></ns4:solidFill><ns4:latin typeface="Georgia"/><ns4:ea typeface="Georgia"/></ns4:defRPr></ns4:lvl4pPr><ns4:lvl5pPr algn="l"><ns4:buNone/><ns4:defRPr sz="2800" dirty="0" b="1"><ns4:solidFill><ns4:srgbClr val="FFFFFF"/></ns4:solidFill><ns4:latin typeface="Georgia"/><ns4:ea typeface="Georgia"/></ns4:defRPr></ns4:lvl5pPr><ns4:lvl6pPr algn="l"><ns4:buNone/><ns4:defRPr sz="2800" dirty="0" b="1"><ns4:solidFill><ns4:srgbClr val="FFFFFF"/></ns4:solidFill><ns4:latin typeface="Georgia"/><ns4:ea typeface="Georgia"/></ns4:defRPr></ns4:lvl6pPr><ns4:lvl7pPr algn="l"><ns4:buNone/><ns4:defRPr sz="2800" dirty="0" b="1"><ns4:solidFill><ns4:srgbClr val="FFFFFF"/></ns4:solidFill><ns4:latin typeface="Georgia"/><ns4:ea typeface="Georgia"/></ns4:defRPr></ns4:lvl7pPr><ns4:lvl8pPr algn="l"><ns4:buNone/><ns4:defRPr sz="2800" dirty="0" b="1"><ns4:solidFill><ns4:srgbClr val="FFFFFF"/></ns4:solidFill><ns4:latin typeface="Georgia"/><ns4:ea typeface="Georgia"/></ns4:defRPr></ns4:lvl8pPr><ns4:lvl9pPr algn="l"><ns4:buNone/><ns4:defRPr sz="2800" dirty="0" b="1"><ns4:solidFill><ns4:srgbClr val="FFFFFF"/></ns4:solidFill><ns4:latin typeface="Georgia"/><ns4:ea typeface="Georgia"/></ns4:defRPr></ns4:lvl9pPr></ns4:lstStyle/><ns5:p xmlns:ns5="http://schemas.openxmlformats.org/drawingml/2006/main"><ns5:pPr algn="l"><ns5:buNone/></ns5:pPr><ns5:r><ns5:rPr lang="ja-JP"/><ns5:t>サブタイトル</ns5:t></ns5:r></ns5:p></ns0:txBody></ns0:sp><ns0:sp><ns0:nvSpPr><ns0:cNvPr id="20" name="Body1.Left"/><ns0:cNvSpPr><ns1:spLocks xmlns:ns1="http://schemas.openxmlformats.org/drawingml/2006/main" noGrp="1"/></ns0:cNvSpPr><ns0:nvPr><ns0:ph idx="1" type="body"/></ns0:nvPr></ns0:nvSpPr><ns0:spPr><ns2:xfrm xmlns:ns2="http://schemas.openxmlformats.org/drawingml/2006/main"><ns2:off x="731520" y="1325880"/><ns2:ext cx="6766560" cy="4937760"/></ns2:xfrm></ns0:spPr><ns0:txBody><ns3:bodyPr xmlns:ns3="http://schemas.openxmlformats.org/drawingml/2006/main" wrap="square" anchor="t" anchorCtr="0"/><ns4:lstStyle/><ns4:defPPr algn="l"><ns4:buNone/><ns4:defRPr sz="1400" dirty="0"><ns4:solidFill><ns4:srgbClr val="1E293B"/></ns4:solidFill><ns4:latin typeface="Calibri"/><ns4:ea typeface="Calibri"/></ns4:defRPr></ns4:defPPr><ns4:lvl1pPr algn="l"><ns4:buNone/><ns4:defRPr sz="1400" dirty="0"><ns4:solidFill><ns4:srgbClr val="1E293B"/></ns4:solidFill><ns4:latin typeface="Calibri"/><ns4:ea typeface="Calibri"/></ns4:defRPr></ns4:lvl1pPr><ns4:lvl2pPr algn="l"><ns4:buNone/><ns4:defRPr sz="1400" dirty="0"><ns4:solidFill><ns4:srgbClr val="1E293B"/></ns4:solidFill><ns4:latin typeface="Calibri"/><ns4:ea typeface="Calibri"/></ns4:defRPr></ns4:lvl2pPr><ns4:lvl3pPr algn="l"><ns4:buNone/><ns4:defRPr sz="1400" dirty="0"><ns4:solidFill><ns4:srgbClr val="1E293B"/></ns4:solidFill><ns4:latin typeface="Calibri"/><ns4:ea typeface="Calibri"/></ns4:defRPr></ns4:lvl3pPr><ns4:lvl4pPr algn="l"><ns4:buNone/><ns4:defRPr sz="1400" dirty="0"><ns4:solidFill><ns4:srgbClr val="1E293B"/></ns4:solidFill><ns4:latin typeface="Calibri"/><ns4:ea typeface="Calibri"/></ns4:defRPr></ns4:lvl4pPr><ns4:lvl5pPr algn="l"><ns4:buNone/><ns4:defRPr sz="1400" dirty="0"><ns4:solidFill><ns4:srgbClr val="1E293B"/></ns4:solidFill><ns4:latin typeface="Calibri"/><ns4:ea typeface="Calibri"/></ns4:defRPr></ns4:lvl5pPr><ns4:lvl6pPr algn="l"><ns4:buNone/><ns4:defRPr sz="1400" dirty="0"><ns4:solidFill><ns4:srgbClr val="1E293B"/></ns4:solidFill><ns4:latin typeface="Calibri"/><ns4:ea typeface="Calibri"/></ns4:defRPr></ns4:lvl6pPr><ns4:lvl7pPr algn="l"><ns4:buNone/><ns4:defRPr sz="1400" dirty="0"><ns4:solidFill><ns4:srgbClr val="1E293B"/></ns4:solidFill><ns4:latin typeface="Calibri"/><ns4:ea typeface="Calibri"/></ns4:defRPr></ns4:lvl7pPr><ns4:lvl8pPr algn="l"><ns4:buNone/><ns4:defRPr sz="1400" dirty="0"><ns4:solidFill><ns4:srgbClr val="1E293B"/></ns4:solidFill><ns4:latin typeface="Calibri"/><ns4:ea typeface="Calibri"/></ns4:defRPr></ns4:lvl8pPr><ns4:lvl9pPr algn="l"><ns4:buNone/><ns4:defRPr sz="1400" dirty="0"><ns4:solidFill><ns4:srgbClr val="1E293B"/></ns4:solidFill><ns4:latin typeface="Calibri"/><ns4:ea typeface="Calibri"/></ns4:defRPr></ns4:lvl9pPr></ns4:lstStyle/><ns5:p xmlns:ns5="http://schemas.openxmlformats.org/drawingml/2006/main"><ns5:pPr algn="l"><ns5:buNone/></ns5:pPr><ns5:r><ns5:rPr lang="ja-JP"/><ns5:t>サブカラム</ns5:t></ns5:r></ns5:p></ns0:txBody></ns0:sp><ns0:sp><ns0:nvSpPr><ns0:cNvPr id="30" name="SlideNum.Footer"/><ns0:cNvSpPr><ns1:spLocks xmlns:ns1="http://schemas.openxmlformats.org/drawingml/2006/main" noGrp="1"/></ns0:cNvSpPr><ns0:nvPr><ns0:ph idx="50" type="sldNum"/></ns0:nvPr></ns0:nvSpPr><ns0:spPr><ns2:xfrm xmlns:ns2="http://schemas.openxmlformats.org/drawingml/2006/main"><ns2:off x="10972800" y="6446520"/><ns2:ext cx="1097280" cy="274320"/></ns2:xfrm></ns0:spPr><ns0:txBody><ns3:bodyPr xmlns:ns3="http://schemas.openxmlformats.org/drawingml/2006/main" wrap="square" anchor="t" anchorCtr="0"/><ns4:lstStyle><ns4:defPPr algn="r"><ns4:defRPr sz="1000"><ns4:solidFill><ns4:srgbClr val="94A3B8"/></ns4:solidFill></ns4:defRPr></ns4:defPPr></ns4:lstStyle><ns4:defPPr algn="r"><ns4:buNone/><ns4:defRPr sz="1000" dirty="0"><ns4:solidFill><ns4:srgbClr val="94A3B8"/></ns4:solidFill><ns4:latin typeface="Calibri"/><ns4:ea typeface="Calibri"/></ns4:defRPr></ns4:defPPr><ns4:lvl1pPr algn="r"><ns4:buNone/><ns4:defRPr sz="1000" dirty="0"><ns4:solidFill><ns4:srgbClr val="94A3B8"/></ns4:solidFill><ns4:latin typeface="Calibri"/><ns4:ea typeface="Calibri"/></ns4:defRPr></ns4:lvl1pPr><ns4:lvl2pPr algn="r"><ns4:buNone/><ns4:defRPr sz="1000" dirty="0"><ns4:solidFill><ns4:srgbClr val="94A3B8"/></ns4:solidFill><ns4:latin typeface="Calibri"/><ns4:ea typeface="Calibri"/></ns4:defRPr></ns4:lvl2pPr><ns4:lvl3pPr algn="r"><ns4:buNone/><ns4:defRPr sz="1000" dirty="0"><ns4:solidFill><ns4:srgbClr val="94A3B8"/></ns4:solidFill><ns4:latin typeface="Calibri"/><ns4:ea typeface="Calibri"/></ns4:defRPr></ns4:lvl3pPr><ns4:lvl4pPr algn="r"><ns4:buNone/><ns4:defRPr sz="1000" dirty="0"><ns4:solidFill><ns4:srgbClr val="94A3B8"/></ns4:solidFill><ns4:latin typeface="Calibri"/><ns4:ea typeface="Calibri"/></ns4:defRPr></ns4:lvl4pPr><ns4:lvl5pPr algn="r"><ns4:buNone/><ns4:defRPr sz="1000" dirty="0"><ns4:solidFill><ns4:srgbClr val="94A3B8"/></ns4:solidFill><ns4:latin typeface="Calibri"/><ns4:ea typeface="Calibri"/></ns4:defRPr></ns4:lvl5pPr><ns4:lvl6pPr algn="r"><ns4:buNone/><ns4:defRPr sz="1000" dirty="0"><ns4:solidFill><ns4:srgbClr val="94A3B8"/></ns4:solidFill><ns4:latin typeface="Calibri"/><ns4:ea typeface="Calibri"/></ns4:defRPr></ns4:lvl6pPr><ns4:lvl7pPr algn="r"><ns4:buNone/><ns4:defRPr sz="1000" dirty="0"><ns4:solidFill><ns4:srgbClr val="94A3B8"/></ns4:solidFill><ns4:latin typeface="Calibri"/><ns4:ea typeface="Calibri"/></ns4:defRPr></ns4:lvl7pPr><ns4:lvl8pPr algn="r"><ns4:buNone/><ns4:defRPr sz="1000" dirty="0"><ns4:solidFill><ns4:srgbClr val="94A3B8"/></ns4:solidFill><ns4:latin typeface="Calibri"/><ns4:ea typeface="Calibri"/></ns4:defRPr></ns4:lvl8pPr><ns4:lvl9pPr algn="r"><ns4:buNone/><ns4:defRPr sz="1000" dirty="0"><ns4:solidFill><ns4:srgbClr val="94A3B8"/></ns4:solidFill><ns4:latin typeface="Calibri"/><ns4:ea typeface="Calibri"/></ns4:defRPr></ns4:lvl9pPr></ns4:lstStyle><ns5:p xmlns:ns5="http://schemas.openxmlformats.org/drawingml/2006/main"><ns5:pPr algn="r"><ns5:buNone/></ns5:pPr><ns5:r><ns5:rPr lang="ja-JP"/><ns5:t>&lt;#&gt;</ns5:t></ns5:r></ns5:p></ns0:txBody></ns0:sp></ns0:spTree></ns0:cSld><ns0:clrMapOvr/></ns0:sldLayout>
 </file>
 
 <file path=ppt/slideLayouts/slideLayout13.xml><?xml version='1.0' encoding='UTF-8' standalone='yes'?>
-<ns0:sldLayout xmlns:ns0="http://schemas.openxmlformats.org/presentationml/2006/main" type="threeObj" preserve="1"><ns0:cSld name="Column.3Body.Equal"><ns0:spTree><ns0:nvGrpSpPr><ns0:cNvPr id="1" name=""/><ns0:cNvGrpSpPr/><ns0:nvPr/></ns0:nvGrpSpPr><ns0:grpSpPr><ns1:xfrm xmlns:ns1="http://schemas.openxmlformats.org/drawingml/2006/main"><ns1:off x="0" y="0"/><ns1:ext cx="0" cy="0"/><ns1:chOff x="0" y="0"/><ns1:chExt cx="0" cy="0"/></ns1:xfrm></ns0:grpSpPr><ns0:sp><ns0:nvSpPr><ns0:cNvPr id="2" name="HeaderBar"/><ns0:cNvSpPr><ns1:spLocks xmlns:ns1="http://schemas.openxmlformats.org/drawingml/2006/main" noGrp="1" noSelect="0" noRot="1" noMove="1"/></ns0:cNvSpPr><ns0:nvPr/></ns0:nvSpPr><ns0:spPr><ns2:xfrm xmlns:ns2="http://schemas.openxmlformats.org/drawingml/2006/main"><ns2:off x="0" y="0"/><ns2:ext cx="12192000" cy="1051560"/></ns2:xfrm><ns3:prstGeom xmlns:ns3="http://schemas.openxmlformats.org/drawingml/2006/main" prst="rect"/><ns4:solidFill xmlns:ns4="http://schemas.openxmlformats.org/drawingml/2006/main"><ns4:srgbClr val="1E2761"/></ns4:solidFill><ns5:ln xmlns:ns5="http://schemas.openxmlformats.org/drawingml/2006/main"><ns5:noFill/></ns5:ln></ns0:spPr></ns0:sp><ns0:sp><ns0:nvSpPr><ns0:cNvPr id="10" name="SlideTitle.Header"/><ns0:cNvSpPr><ns1:spLocks xmlns:ns1="http://schemas.openxmlformats.org/drawingml/2006/main" noGrp="1"/></ns0:cNvSpPr><ns0:nvPr><ns0:ph idx="15" type="body"/></ns0:nvPr></ns0:nvSpPr><ns0:spPr><ns2:xfrm xmlns:ns2="http://schemas.openxmlformats.org/drawingml/2006/main"><ns2:off x="731520" y="91440"/><ns2:ext cx="9144000" cy="475488"/></ns2:xfrm></ns0:spPr><ns0:txBody><ns3:bodyPr xmlns:ns3="http://schemas.openxmlformats.org/drawingml/2006/main" wrap="square" anchor="t" anchorCtr="0"/><ns4:lstStyle xmlns:ns4="http://schemas.openxmlformats.org/drawingml/2006/main"><ns4:defPPr algn="l"><ns4:buNone/><ns4:defRPr sz="2800" dirty="0" b="1"><ns4:solidFill><ns4:srgbClr val="FFFFFF"/></ns4:solidFill><ns4:latin typeface="Georgia"/><ns4:ea typeface="Georgia"/></ns4:defRPr></ns4:defPPr><ns4:lvl1pPr algn="l"><ns4:buNone/><ns4:defRPr sz="2800" dirty="0" b="1"><ns4:solidFill><ns4:srgbClr val="FFFFFF"/></ns4:solidFill><ns4:latin typeface="Georgia"/><ns4:ea typeface="Georgia"/></ns4:defRPr></ns4:lvl1pPr><ns4:lvl2pPr algn="l"><ns4:buNone/><ns4:defRPr sz="2800" dirty="0" b="1"><ns4:solidFill><ns4:srgbClr val="FFFFFF"/></ns4:solidFill><ns4:latin typeface="Georgia"/><ns4:ea typeface="Georgia"/></ns4:defRPr></ns4:lvl2pPr><ns4:lvl3pPr algn="l"><ns4:buNone/><ns4:defRPr sz="2800" dirty="0" b="1"><ns4:solidFill><ns4:srgbClr val="FFFFFF"/></ns4:solidFill><ns4:latin typeface="Georgia"/><ns4:ea typeface="Georgia"/></ns4:defRPr></ns4:lvl3pPr><ns4:lvl4pPr algn="l"><ns4:buNone/><ns4:defRPr sz="2800" dirty="0" b="1"><ns4:solidFill><ns4:srgbClr val="FFFFFF"/></ns4:solidFill><ns4:latin typeface="Georgia"/><ns4:ea typeface="Georgia"/></ns4:defRPr></ns4:lvl4pPr><ns4:lvl5pPr algn="l"><ns4:buNone/><ns4:defRPr sz="2800" dirty="0" b="1"><ns4:solidFill><ns4:srgbClr val="FFFFFF"/></ns4:solidFill><ns4:latin typeface="Georgia"/><ns4:ea typeface="Georgia"/></ns4:defRPr></ns4:lvl5pPr><ns4:lvl6pPr algn="l"><ns4:buNone/><ns4:defRPr sz="2800" dirty="0" b="1"><ns4:solidFill><ns4:srgbClr val="FFFFFF"/></ns4:solidFill><ns4:latin typeface="Georgia"/><ns4:ea typeface="Georgia"/></ns4:defRPr></ns4:lvl6pPr><ns4:lvl7pPr algn="l"><ns4:buNone/><ns4:defRPr sz="2800" dirty="0" b="1"><ns4:solidFill><ns4:srgbClr val="FFFFFF"/></ns4:solidFill><ns4:latin typeface="Georgia"/><ns4:ea typeface="Georgia"/></ns4:defRPr></ns4:lvl7pPr><ns4:lvl8pPr algn="l"><ns4:buNone/><ns4:defRPr sz="2800" dirty="0" b="1"><ns4:solidFill><ns4:srgbClr val="FFFFFF"/></ns4:solidFill><ns4:latin typeface="Georgia"/><ns4:ea typeface="Georgia"/></ns4:defRPr></ns4:lvl8pPr><ns4:lvl9pPr algn="l"><ns4:buNone/><ns4:defRPr sz="2800" dirty="0" b="1"><ns4:solidFill><ns4:srgbClr val="FFFFFF"/></ns4:solidFill><ns4:latin typeface="Georgia"/><ns4:ea typeface="Georgia"/></ns4:defRPr></ns4:lvl9pPr></ns4:lstStyle/><ns5:p xmlns:ns5="http://schemas.openxmlformats.org/drawingml/2006/main"><ns5:pPr algn="l"><ns5:buNone/></ns5:pPr><ns5:r><ns5:rPr lang="ja-JP"/><ns5:t>サブタイトル</ns5:t></ns5:r></ns5:p></ns0:txBody></ns0:sp><ns0:sp><ns0:nvSpPr><ns0:cNvPr id="20" name="Body1.Left"/><ns0:cNvSpPr><ns1:spLocks xmlns:ns1="http://schemas.openxmlformats.org/drawingml/2006/main" noGrp="1"/></ns0:cNvSpPr><ns0:nvPr><ns0:ph idx="1" type="body"/></ns0:nvPr></ns0:nvSpPr><ns0:spPr><ns2:xfrm xmlns:ns2="http://schemas.openxmlformats.org/drawingml/2006/main"><ns2:off x="731520" y="1325880"/><ns2:ext cx="3200400" cy="4937760"/></ns2:xfrm></ns0:spPr><ns0:txBody><ns3:bodyPr xmlns:ns3="http://schemas.openxmlformats.org/drawingml/2006/main" wrap="square" anchor="t" anchorCtr="0"/><ns4:lstStyle xmlns:ns4="http://schemas.openxmlformats.org/drawingml/2006/main"><ns4:defPPr algn="l"><ns4:buNone/><ns4:defRPr sz="1400" dirty="0"><ns4:solidFill><ns4:srgbClr val="1E293B"/></ns4:solidFill><ns4:latin typeface="Calibri"/><ns4:ea typeface="Calibri"/></ns4:defRPr></ns4:defPPr><ns4:lvl1pPr algn="l"><ns4:buNone/><ns4:defRPr sz="1400" dirty="0"><ns4:solidFill><ns4:srgbClr val="1E293B"/></ns4:solidFill><ns4:latin typeface="Calibri"/><ns4:ea typeface="Calibri"/></ns4:defRPr></ns4:lvl1pPr><ns4:lvl2pPr algn="l"><ns4:buNone/><ns4:defRPr sz="1400" dirty="0"><ns4:solidFill><ns4:srgbClr val="1E293B"/></ns4:solidFill><ns4:latin typeface="Calibri"/><ns4:ea typeface="Calibri"/></ns4:defRPr></ns4:lvl2pPr><ns4:lvl3pPr algn="l"><ns4:buNone/><ns4:defRPr sz="1400" dirty="0"><ns4:solidFill><ns4:srgbClr val="1E293B"/></ns4:solidFill><ns4:latin typeface="Calibri"/><ns4:ea typeface="Calibri"/></ns4:defRPr></ns4:lvl3pPr><ns4:lvl4pPr algn="l"><ns4:buNone/><ns4:defRPr sz="1400" dirty="0"><ns4:solidFill><ns4:srgbClr val="1E293B"/></ns4:solidFill><ns4:latin typeface="Calibri"/><ns4:ea typeface="Calibri"/></ns4:defRPr></ns4:lvl4pPr><ns4:lvl5pPr algn="l"><ns4:buNone/><ns4:defRPr sz="1400" dirty="0"><ns4:solidFill><ns4:srgbClr val="1E293B"/></ns4:solidFill><ns4:latin typeface="Calibri"/><ns4:ea typeface="Calibri"/></ns4:defRPr></ns4:lvl5pPr><ns4:lvl6pPr algn="l"><ns4:buNone/><ns4:defRPr sz="1400" dirty="0"><ns4:solidFill><ns4:srgbClr val="1E293B"/></ns4:solidFill><ns4:latin typeface="Calibri"/><ns4:ea typeface="Calibri"/></ns4:defRPr></ns4:lvl6pPr><ns4:lvl7pPr algn="l"><ns4:buNone/><ns4:defRPr sz="1400" dirty="0"><ns4:solidFill><ns4:srgbClr val="1E293B"/></ns4:solidFill><ns4:latin typeface="Calibri"/><ns4:ea typeface="Calibri"/></ns4:defRPr></ns4:lvl7pPr><ns4:lvl8pPr algn="l"><ns4:buNone/><ns4:defRPr sz="1400" dirty="0"><ns4:solidFill><ns4:srgbClr val="1E293B"/></ns4:solidFill><ns4:latin typeface="Calibri"/><ns4:ea typeface="Calibri"/></ns4:defRPr></ns4:lvl8pPr><ns4:lvl9pPr algn="l"><ns4:buNone/><ns4:defRPr sz="1400" dirty="0"><ns4:solidFill><ns4:srgbClr val="1E293B"/></ns4:solidFill><ns4:latin typeface="Calibri"/><ns4:ea typeface="Calibri"/></ns4:defRPr></ns4:lvl9pPr></ns4:lstStyle/><ns5:p xmlns:ns5="http://schemas.openxmlformats.org/drawingml/2006/main"><ns5:pPr algn="l"><ns5:buNone/></ns5:pPr><ns5:r><ns5:rPr lang="ja-JP"/><ns5:t>カラム 2</ns5:t></ns5:r></ns5:p></ns0:txBody></ns0:sp><ns0:sp><ns0:nvSpPr><ns0:cNvPr id="22" name="Body3.Right"/><ns0:cNvSpPr><ns1:spLocks xmlns:ns1="http://schemas.openxmlformats.org/drawingml/2006/main" noGrp="1"/></ns0:cNvSpPr><ns0:nvPr><ns0:ph idx="3" type="body"/></ns0:nvPr></ns0:nvSpPr><ns0:spPr><ns2:xfrm xmlns:ns2="http://schemas.openxmlformats.org/drawingml/2006/main"><ns2:off x="7863840" y="1325880"/><ns2:ext cx="3566160" cy="4937760"/></ns2:xfrm></ns0:spPr><ns0:txBody><ns3:bodyPr xmlns:ns3="http://schemas.openxmlformats.org/drawingml/2006/main" wrap="square" anchor="t" anchorCtr="0"/><ns4:lstStyle xmlns:ns4="http://schemas.openxmlformats.org/drawingml/2006/main"><ns4:defPPr algn="l"><ns4:buNone/><ns4:defRPr sz="1400" dirty="0"><ns4:solidFill><ns4:srgbClr val="1E293B"/></ns4:solidFill><ns4:latin typeface="Calibri"/><ns4:ea typeface="Calibri"/></ns4:defRPr></ns4:defPPr><ns4:lvl1pPr algn="l"><ns4:buNone/><ns4:defRPr sz="1400" dirty="0"><ns4:solidFill><ns4:srgbClr val="1E293B"/></ns4:solidFill><ns4:latin typeface="Calibri"/><ns4:ea typeface="Calibri"/></ns4:defRPr></ns4:lvl1pPr><ns4:lvl2pPr algn="l"><ns4:buNone/><ns4:defRPr sz="1400" dirty="0"><ns4:solidFill><ns4:srgbClr val="1E293B"/></ns4:solidFill><ns4:latin typeface="Calibri"/><ns4:ea typeface="Calibri"/></ns4:defRPr></ns4:lvl2pPr><ns4:lvl3pPr algn="l"><ns4:buNone/><ns4:defRPr sz="1400" dirty="0"><ns4:solidFill><ns4:srgbClr val="1E293B"/></ns4:solidFill><ns4:latin typeface="Calibri"/><ns4:ea typeface="Calibri"/></ns4:defRPr></ns4:lvl3pPr><ns4:lvl4pPr algn="l"><ns4:buNone/><ns4:defRPr sz="1400" dirty="0"><ns4:solidFill><ns4:srgbClr val="1E293B"/></ns4:solidFill><ns4:latin typeface="Calibri"/><ns4:ea typeface="Calibri"/></ns4:defRPr></ns4:lvl4pPr><ns4:lvl5pPr algn="l"><ns4:buNone/><ns4:defRPr sz="1400" dirty="0"><ns4:solidFill><ns4:srgbClr val="1E293B"/></ns4:solidFill><ns4:latin typeface="Calibri"/><ns4:ea typeface="Calibri"/></ns4:defRPr></ns4:lvl5pPr><ns4:lvl6pPr algn="l"><ns4:buNone/><ns4:defRPr sz="1400" dirty="0"><ns4:solidFill><ns4:srgbClr val="1E293B"/></ns4:solidFill><ns4:latin typeface="Calibri"/><ns4:ea typeface="Calibri"/></ns4:defRPr></ns4:lvl6pPr><ns4:lvl7pPr algn="l"><ns4:buNone/><ns4:defRPr sz="1400" dirty="0"><ns4:solidFill><ns4:srgbClr val="1E293B"/></ns4:solidFill><ns4:latin typeface="Calibri"/><ns4:ea typeface="Calibri"/></ns4:defRPr></ns4:lvl7pPr><ns4:lvl8pPr algn="l"><ns4:buNone/><ns4:defRPr sz="1400" dirty="0"><ns4:solidFill><ns4:srgbClr val="1E293B"/></ns4:solidFill><ns4:latin typeface="Calibri"/><ns4:ea typeface="Calibri"/></ns4:defRPr></ns4:lvl8pPr><ns4:lvl9pPr algn="l"><ns4:buNone/><ns4:defRPr sz="1400" dirty="0"><ns4:solidFill><ns4:srgbClr val="1E293B"/></ns4:solidFill><ns4:latin typeface="Calibri"/><ns4:ea typeface="Calibri"/></ns4:defRPr></ns4:lvl9pPr></ns4:lstStyle/><ns5:p xmlns:ns5="http://schemas.openxmlformats.org/drawingml/2006/main"><ns5:pPr algn="r"><ns5:buNone/></ns5:pPr><ns5:r><ns5:rPr lang="ja-JP"/><ns5:t>&lt;#&gt;</ns5:t></ns5:r></ns5:p></ns0:txBody></ns0:sp></ns0:spTree></ns0:cSld><ns0:clrMapOvr/></ns0:sldLayout>
+<ns0:sldLayout xmlns:ns0="http://schemas.openxmlformats.org/presentationml/2006/main" type="threeObj" preserve="1"><ns0:cSld name="Column.3Body.Equal"><ns0:spTree><ns0:nvGrpSpPr><ns0:cNvPr id="1" name=""/><ns0:cNvGrpSpPr/><ns0:nvPr/></ns0:nvGrpSpPr><ns0:grpSpPr><ns1:xfrm xmlns:ns1="http://schemas.openxmlformats.org/drawingml/2006/main"><ns1:off x="0" y="0"/><ns1:ext cx="0" cy="0"/><ns1:chOff x="0" y="0"/><ns1:chExt cx="0" cy="0"/></ns1:xfrm></ns0:grpSpPr><ns0:sp><ns0:nvSpPr><ns0:cNvPr id="2" name="HeaderBar"/><ns0:cNvSpPr><ns1:spLocks xmlns:ns1="http://schemas.openxmlformats.org/drawingml/2006/main" noGrp="1" noSelect="0" noRot="1" noMove="1"/></ns0:cNvSpPr><ns0:nvPr/></ns0:nvSpPr><ns0:spPr><ns2:xfrm xmlns:ns2="http://schemas.openxmlformats.org/drawingml/2006/main"><ns2:off x="0" y="0"/><ns2:ext cx="12192000" cy="1051560"/></ns2:xfrm><ns3:prstGeom xmlns:ns3="http://schemas.openxmlformats.org/drawingml/2006/main" prst="rect"/><ns4:solidFill xmlns:ns4="http://schemas.openxmlformats.org/drawingml/2006/main"><ns4:srgbClr val="1E2761"/></ns4:solidFill><ns5:ln xmlns:ns5="http://schemas.openxmlformats.org/drawingml/2006/main"><ns5:noFill/></ns5:ln></ns0:spPr></ns0:sp><ns0:sp><ns0:nvSpPr><ns0:cNvPr id="10" name="SlideTitle.Header"/><ns0:cNvSpPr><ns1:spLocks xmlns:ns1="http://schemas.openxmlformats.org/drawingml/2006/main" noGrp="1"/></ns0:cNvSpPr><ns0:nvPr><ns0:ph idx="15" type="body"/></ns0:nvPr></ns0:nvSpPr><ns0:spPr><ns2:xfrm xmlns:ns2="http://schemas.openxmlformats.org/drawingml/2006/main"><ns2:off x="731520" y="91440"/><ns2:ext cx="9144000" cy="475488"/></ns2:xfrm></ns0:spPr><ns0:txBody><ns3:bodyPr xmlns:ns3="http://schemas.openxmlformats.org/drawingml/2006/main" wrap="square" anchor="t" anchorCtr="0"/><ns4:lstStyle><ns4:defPPr><ns4:defRPr sz="2800" b="1"><ns4:solidFill><ns4:srgbClr val="FFFFFF"/></ns4:solidFill></ns4:defRPr></ns4:defPPr></ns4:lstStyle><ns4:defPPr algn="l"><ns4:buNone/><ns4:defRPr sz="2800" dirty="0" b="1"><ns4:solidFill><ns4:srgbClr val="FFFFFF"/></ns4:solidFill><ns4:latin typeface="Georgia"/><ns4:ea typeface="Georgia"/></ns4:defRPr></ns4:defPPr><ns4:lvl1pPr algn="l"><ns4:buNone/><ns4:defRPr sz="2800" dirty="0" b="1"><ns4:solidFill><ns4:srgbClr val="FFFFFF"/></ns4:solidFill><ns4:latin typeface="Georgia"/><ns4:ea typeface="Georgia"/></ns4:defRPr></ns4:lvl1pPr><ns4:lvl2pPr algn="l"><ns4:buNone/><ns4:defRPr sz="2800" dirty="0" b="1"><ns4:solidFill><ns4:srgbClr val="FFFFFF"/></ns4:solidFill><ns4:latin typeface="Georgia"/><ns4:ea typeface="Georgia"/></ns4:defRPr></ns4:lvl2pPr><ns4:lvl3pPr algn="l"><ns4:buNone/><ns4:defRPr sz="2800" dirty="0" b="1"><ns4:solidFill><ns4:srgbClr val="FFFFFF"/></ns4:solidFill><ns4:latin typeface="Georgia"/><ns4:ea typeface="Georgia"/></ns4:defRPr></ns4:lvl3pPr><ns4:lvl4pPr algn="l"><ns4:buNone/><ns4:defRPr sz="2800" dirty="0" b="1"><ns4:solidFill><ns4:srgbClr val="FFFFFF"/></ns4:solidFill><ns4:latin typeface="Georgia"/><ns4:ea typeface="Georgia"/></ns4:defRPr></ns4:lvl4pPr><ns4:lvl5pPr algn="l"><ns4:buNone/><ns4:defRPr sz="2800" dirty="0" b="1"><ns4:solidFill><ns4:srgbClr val="FFFFFF"/></ns4:solidFill><ns4:latin typeface="Georgia"/><ns4:ea typeface="Georgia"/></ns4:defRPr></ns4:lvl5pPr><ns4:lvl6pPr algn="l"><ns4:buNone/><ns4:defRPr sz="2800" dirty="0" b="1"><ns4:solidFill><ns4:srgbClr val="FFFFFF"/></ns4:solidFill><ns4:latin typeface="Georgia"/><ns4:ea typeface="Georgia"/></ns4:defRPr></ns4:lvl6pPr><ns4:lvl7pPr algn="l"><ns4:buNone/><ns4:defRPr sz="2800" dirty="0" b="1"><ns4:solidFill><ns4:srgbClr val="FFFFFF"/></ns4:solidFill><ns4:latin typeface="Georgia"/><ns4:ea typeface="Georgia"/></ns4:defRPr></ns4:lvl7pPr><ns4:lvl8pPr algn="l"><ns4:buNone/><ns4:defRPr sz="2800" dirty="0" b="1"><ns4:solidFill><ns4:srgbClr val="FFFFFF"/></ns4:solidFill><ns4:latin typeface="Georgia"/><ns4:ea typeface="Georgia"/></ns4:defRPr></ns4:lvl8pPr><ns4:lvl9pPr algn="l"><ns4:buNone/><ns4:defRPr sz="2800" dirty="0" b="1"><ns4:solidFill><ns4:srgbClr val="FFFFFF"/></ns4:solidFill><ns4:latin typeface="Georgia"/><ns4:ea typeface="Georgia"/></ns4:defRPr></ns4:lvl9pPr></ns4:lstStyle/><ns5:p xmlns:ns5="http://schemas.openxmlformats.org/drawingml/2006/main"><ns5:pPr algn="l"><ns5:buNone/></ns5:pPr><ns5:r><ns5:rPr lang="ja-JP"/><ns5:t>サブタイトル</ns5:t></ns5:r></ns5:p></ns0:txBody></ns0:sp><ns0:sp><ns0:nvSpPr><ns0:cNvPr id="20" name="Body1.Left"/><ns0:cNvSpPr><ns1:spLocks xmlns:ns1="http://schemas.openxmlformats.org/drawingml/2006/main" noGrp="1"/></ns0:cNvSpPr><ns0:nvPr><ns0:ph idx="1" type="body"/></ns0:nvPr></ns0:nvSpPr><ns0:spPr><ns2:xfrm xmlns:ns2="http://schemas.openxmlformats.org/drawingml/2006/main"><ns2:off x="731520" y="1325880"/><ns2:ext cx="3200400" cy="4937760"/></ns2:xfrm></ns0:spPr><ns0:txBody><ns3:bodyPr xmlns:ns3="http://schemas.openxmlformats.org/drawingml/2006/main" wrap="square" anchor="t" anchorCtr="0"/><ns4:lstStyle/><ns4:defPPr algn="l"><ns4:buNone/><ns4:defRPr sz="1400" dirty="0"><ns4:solidFill><ns4:srgbClr val="1E293B"/></ns4:solidFill><ns4:latin typeface="Calibri"/><ns4:ea typeface="Calibri"/></ns4:defRPr></ns4:defPPr><ns4:lvl1pPr algn="l"><ns4:buNone/><ns4:defRPr sz="1400" dirty="0"><ns4:solidFill><ns4:srgbClr val="1E293B"/></ns4:solidFill><ns4:latin typeface="Calibri"/><ns4:ea typeface="Calibri"/></ns4:defRPr></ns4:lvl1pPr><ns4:lvl2pPr algn="l"><ns4:buNone/><ns4:defRPr sz="1400" dirty="0"><ns4:solidFill><ns4:srgbClr val="1E293B"/></ns4:solidFill><ns4:latin typeface="Calibri"/><ns4:ea typeface="Calibri"/></ns4:defRPr></ns4:lvl2pPr><ns4:lvl3pPr algn="l"><ns4:buNone/><ns4:defRPr sz="1400" dirty="0"><ns4:solidFill><ns4:srgbClr val="1E293B"/></ns4:solidFill><ns4:latin typeface="Calibri"/><ns4:ea typeface="Calibri"/></ns4:defRPr></ns4:lvl3pPr><ns4:lvl4pPr algn="l"><ns4:buNone/><ns4:defRPr sz="1400" dirty="0"><ns4:solidFill><ns4:srgbClr val="1E293B"/></ns4:solidFill><ns4:latin typeface="Calibri"/><ns4:ea typeface="Calibri"/></ns4:defRPr></ns4:lvl4pPr><ns4:lvl5pPr algn="l"><ns4:buNone/><ns4:defRPr sz="1400" dirty="0"><ns4:solidFill><ns4:srgbClr val="1E293B"/></ns4:solidFill><ns4:latin typeface="Calibri"/><ns4:ea typeface="Calibri"/></ns4:defRPr></ns4:lvl5pPr><ns4:lvl6pPr algn="l"><ns4:buNone/><ns4:defRPr sz="1400" dirty="0"><ns4:solidFill><ns4:srgbClr val="1E293B"/></ns4:solidFill><ns4:latin typeface="Calibri"/><ns4:ea typeface="Calibri"/></ns4:defRPr></ns4:lvl6pPr><ns4:lvl7pPr algn="l"><ns4:buNone/><ns4:defRPr sz="1400" dirty="0"><ns4:solidFill><ns4:srgbClr val="1E293B"/></ns4:solidFill><ns4:latin typeface="Calibri"/><ns4:ea typeface="Calibri"/></ns4:defRPr></ns4:lvl7pPr><ns4:lvl8pPr algn="l"><ns4:buNone/><ns4:defRPr sz="1400" dirty="0"><ns4:solidFill><ns4:srgbClr val="1E293B"/></ns4:solidFill><ns4:latin typeface="Calibri"/><ns4:ea typeface="Calibri"/></ns4:defRPr></ns4:lvl8pPr><ns4:lvl9pPr algn="l"><ns4:buNone/><ns4:defRPr sz="1400" dirty="0"><ns4:solidFill><ns4:srgbClr val="1E293B"/></ns4:solidFill><ns4:latin typeface="Calibri"/><ns4:ea typeface="Calibri"/></ns4:defRPr></ns4:lvl9pPr></ns4:lstStyle/><ns5:p xmlns:ns5="http://schemas.openxmlformats.org/drawingml/2006/main"><ns5:pPr algn="l"><ns5:buNone/></ns5:pPr><ns5:r><ns5:rPr lang="ja-JP"/><ns5:t>カラム 2</ns5:t></ns5:r></ns5:p></ns0:txBody></ns0:sp><ns0:sp><ns0:nvSpPr><ns0:cNvPr id="22" name="Body3.Right"/><ns0:cNvSpPr><ns1:spLocks xmlns:ns1="http://schemas.openxmlformats.org/drawingml/2006/main" noGrp="1"/></ns0:cNvSpPr><ns0:nvPr><ns0:ph idx="3" type="body"/></ns0:nvPr></ns0:nvSpPr><ns0:spPr><ns2:xfrm xmlns:ns2="http://schemas.openxmlformats.org/drawingml/2006/main"><ns2:off x="7863840" y="1325880"/><ns2:ext cx="3566160" cy="4937760"/></ns2:xfrm></ns0:spPr><ns0:txBody><ns3:bodyPr xmlns:ns3="http://schemas.openxmlformats.org/drawingml/2006/main" wrap="square" anchor="t" anchorCtr="0"/><ns4:lstStyle/><ns4:defPPr algn="l"><ns4:buNone/><ns4:defRPr sz="1400" dirty="0"><ns4:solidFill><ns4:srgbClr val="1E293B"/></ns4:solidFill><ns4:latin typeface="Calibri"/><ns4:ea typeface="Calibri"/></ns4:defRPr></ns4:defPPr><ns4:lvl1pPr algn="l"><ns4:buNone/><ns4:defRPr sz="1400" dirty="0"><ns4:solidFill><ns4:srgbClr val="1E293B"/></ns4:solidFill><ns4:latin typeface="Calibri"/><ns4:ea typeface="Calibri"/></ns4:defRPr></ns4:lvl1pPr><ns4:lvl2pPr algn="l"><ns4:buNone/><ns4:defRPr sz="1400" dirty="0"><ns4:solidFill><ns4:srgbClr val="1E293B"/></ns4:solidFill><ns4:latin typeface="Calibri"/><ns4:ea typeface="Calibri"/></ns4:defRPr></ns4:lvl2pPr><ns4:lvl3pPr algn="l"><ns4:buNone/><ns4:defRPr sz="1400" dirty="0"><ns4:solidFill><ns4:srgbClr val="1E293B"/></ns4:solidFill><ns4:latin typeface="Calibri"/><ns4:ea typeface="Calibri"/></ns4:defRPr></ns4:lvl3pPr><ns4:lvl4pPr algn="l"><ns4:buNone/><ns4:defRPr sz="1400" dirty="0"><ns4:solidFill><ns4:srgbClr val="1E293B"/></ns4:solidFill><ns4:latin typeface="Calibri"/><ns4:ea typeface="Calibri"/></ns4:defRPr></ns4:lvl4pPr><ns4:lvl5pPr algn="l"><ns4:buNone/><ns4:defRPr sz="1400" dirty="0"><ns4:solidFill><ns4:srgbClr val="1E293B"/></ns4:solidFill><ns4:latin typeface="Calibri"/><ns4:ea typeface="Calibri"/></ns4:defRPr></ns4:lvl5pPr><ns4:lvl6pPr algn="l"><ns4:buNone/><ns4:defRPr sz="1400" dirty="0"><ns4:solidFill><ns4:srgbClr val="1E293B"/></ns4:solidFill><ns4:latin typeface="Calibri"/><ns4:ea typeface="Calibri"/></ns4:defRPr></ns4:lvl6pPr><ns4:lvl7pPr algn="l"><ns4:buNone/><ns4:defRPr sz="1400" dirty="0"><ns4:solidFill><ns4:srgbClr val="1E293B"/></ns4:solidFill><ns4:latin typeface="Calibri"/><ns4:ea typeface="Calibri"/></ns4:defRPr></ns4:lvl7pPr><ns4:lvl8pPr algn="l"><ns4:buNone/><ns4:defRPr sz="1400" dirty="0"><ns4:solidFill><ns4:srgbClr val="1E293B"/></ns4:solidFill><ns4:latin typeface="Calibri"/><ns4:ea typeface="Calibri"/></ns4:defRPr></ns4:lvl8pPr><ns4:lvl9pPr algn="l"><ns4:buNone/><ns4:defRPr sz="1400" dirty="0"><ns4:solidFill><ns4:srgbClr val="1E293B"/></ns4:solidFill><ns4:latin typeface="Calibri"/><ns4:ea typeface="Calibri"/></ns4:defRPr></ns4:lvl9pPr></ns4:lstStyle/><ns5:p xmlns:ns5="http://schemas.openxmlformats.org/drawingml/2006/main"><ns5:pPr algn="r"><ns5:buNone/></ns5:pPr><ns5:r><ns5:rPr lang="ja-JP"/><ns5:t>&lt;#&gt;</ns5:t></ns5:r></ns5:p></ns0:txBody></ns0:sp></ns0:spTree></ns0:cSld><ns0:clrMapOvr/></ns0:sldLayout>
 </file>
 
 <file path=ppt/slideLayouts/slideLayout14.xml><?xml version='1.0' encoding='UTF-8' standalone='yes'?>
-<ns0:sldLayout xmlns:ns0="http://schemas.openxmlformats.org/presentationml/2006/main" type="blank" preserve="1"><ns0:cSld name="KPI.1Value.Single"><ns0:spTree><ns0:nvGrpSpPr><ns0:cNvPr id="1" name=""/><ns0:cNvGrpSpPr/><ns0:nvPr/></ns0:nvGrpSpPr><ns0:grpSpPr><ns1:xfrm xmlns:ns1="http://schemas.openxmlformats.org/drawingml/2006/main"><ns1:off x="0" y="0"/><ns1:ext cx="0" cy="0"/><ns1:chOff x="0" y="0"/><ns1:chExt cx="0" cy="0"/></ns1:xfrm></ns0:grpSpPr><ns0:sp><ns0:nvSpPr><ns0:cNvPr id="2" name="HeaderBar"/><ns0:cNvSpPr><ns1:spLocks xmlns:ns1="http://schemas.openxmlformats.org/drawingml/2006/main" noGrp="1" noSelect="0" noRot="1" noMove="1"/></ns0:cNvSpPr><ns0:nvPr/></ns0:nvSpPr><ns0:spPr><ns2:xfrm xmlns:ns2="http://schemas.openxmlformats.org/drawingml/2006/main"><ns2:off x="0" y="0"/><ns2:ext cx="12192000" cy="1051560"/></ns2:xfrm><ns3:prstGeom xmlns:ns3="http://schemas.openxmlformats.org/drawingml/2006/main" prst="rect"/><ns4:solidFill xmlns:ns4="http://schemas.openxmlformats.org/drawingml/2006/main"><ns4:srgbClr val="1E2761"/></ns4:solidFill><ns5:ln xmlns:ns5="http://schemas.openxmlformats.org/drawingml/2006/main"><ns5:noFill/></ns5:ln></ns0:spPr></ns0:sp><ns0:sp><ns0:nvSpPr><ns0:cNvPr id="10" name="SlideTitle.Header"/><ns0:cNvSpPr><ns1:spLocks xmlns:ns1="http://schemas.openxmlformats.org/drawingml/2006/main" noGrp="1"/></ns0:cNvSpPr><ns0:nvPr><ns0:ph idx="15" type="body"/></ns0:nvPr></ns0:nvSpPr><ns0:spPr><ns2:xfrm xmlns:ns2="http://schemas.openxmlformats.org/drawingml/2006/main"><ns2:off x="731520" y="91440"/><ns2:ext cx="9144000" cy="475488"/></ns2:xfrm></ns0:spPr><ns0:txBody><ns3:bodyPr xmlns:ns3="http://schemas.openxmlformats.org/drawingml/2006/main" wrap="square" anchor="t" anchorCtr="0"/><ns4:lstStyle xmlns:ns4="http://schemas.openxmlformats.org/drawingml/2006/main"><ns4:defPPr algn="l"><ns4:buNone/><ns4:defRPr sz="2800" dirty="0" b="1"><ns4:solidFill><ns4:srgbClr val="FFFFFF"/></ns4:solidFill><ns4:latin typeface="Georgia"/><ns4:ea typeface="Georgia"/></ns4:defRPr></ns4:defPPr><ns4:lvl1pPr algn="l"><ns4:buNone/><ns4:defRPr sz="2800" dirty="0" b="1"><ns4:solidFill><ns4:srgbClr val="FFFFFF"/></ns4:solidFill><ns4:latin typeface="Georgia"/><ns4:ea typeface="Georgia"/></ns4:defRPr></ns4:lvl1pPr><ns4:lvl2pPr algn="l"><ns4:buNone/><ns4:defRPr sz="2800" dirty="0" b="1"><ns4:solidFill><ns4:srgbClr val="FFFFFF"/></ns4:solidFill><ns4:latin typeface="Georgia"/><ns4:ea typeface="Georgia"/></ns4:defRPr></ns4:lvl2pPr><ns4:lvl3pPr algn="l"><ns4:buNone/><ns4:defRPr sz="2800" dirty="0" b="1"><ns4:solidFill><ns4:srgbClr val="FFFFFF"/></ns4:solidFill><ns4:latin typeface="Georgia"/><ns4:ea typeface="Georgia"/></ns4:defRPr></ns4:lvl3pPr><ns4:lvl4pPr algn="l"><ns4:buNone/><ns4:defRPr sz="2800" dirty="0" b="1"><ns4:solidFill><ns4:srgbClr val="FFFFFF"/></ns4:solidFill><ns4:latin typeface="Georgia"/><ns4:ea typeface="Georgia"/></ns4:defRPr></ns4:lvl4pPr><ns4:lvl5pPr algn="l"><ns4:buNone/><ns4:defRPr sz="2800" dirty="0" b="1"><ns4:solidFill><ns4:srgbClr val="FFFFFF"/></ns4:solidFill><ns4:latin typeface="Georgia"/><ns4:ea typeface="Georgia"/></ns4:defRPr></ns4:lvl5pPr><ns4:lvl6pPr algn="l"><ns4:buNone/><ns4:defRPr sz="2800" dirty="0" b="1"><ns4:solidFill><ns4:srgbClr val="FFFFFF"/></ns4:solidFill><ns4:latin typeface="Georgia"/><ns4:ea typeface="Georgia"/></ns4:defRPr></ns4:lvl6pPr><ns4:lvl7pPr algn="l"><ns4:buNone/><ns4:defRPr sz="2800" dirty="0" b="1"><ns4:solidFill><ns4:srgbClr val="FFFFFF"/></ns4:solidFill><ns4:latin typeface="Georgia"/><ns4:ea typeface="Georgia"/></ns4:defRPr></ns4:lvl7pPr><ns4:lvl8pPr algn="l"><ns4:buNone/><ns4:defRPr sz="2800" dirty="0" b="1"><ns4:solidFill><ns4:srgbClr val="FFFFFF"/></ns4:solidFill><ns4:latin typeface="Georgia"/><ns4:ea typeface="Georgia"/></ns4:defRPr></ns4:lvl8pPr><ns4:lvl9pPr algn="l"><ns4:buNone/><ns4:defRPr sz="2800" dirty="0" b="1"><ns4:solidFill><ns4:srgbClr val="FFFFFF"/></ns4:solidFill><ns4:latin typeface="Georgia"/><ns4:ea typeface="Georgia"/></ns4:defRPr></ns4:lvl9pPr></ns4:lstStyle/><ns5:p xmlns:ns5="http://schemas.openxmlformats.org/drawingml/2006/main"><ns5:pPr algn="l"><ns5:buNone/></ns5:pPr><ns5:r><ns5:rPr lang="ja-JP"/><ns5:t>サブタイトル</ns5:t></ns5:r></ns5:p></ns0:txBody></ns0:sp><ns0:sp><ns0:nvSpPr><ns0:cNvPr id="5" name="StatPanel"/><ns0:cNvSpPr><ns1:spLocks xmlns:ns1="http://schemas.openxmlformats.org/drawingml/2006/main" noGrp="1" noSelect="0" noRot="1" noMove="1"/></ns0:cNvSpPr><ns0:nvPr/></ns0:nvSpPr><ns0:spPr><ns2:xfrm xmlns:ns2="http://schemas.openxmlformats.org/drawingml/2006/main"><ns2:off x="2743200" y="1645920"/><ns2:ext cx="6675120" cy="4114800"/></ns2:xfrm><ns3:prstGeom xmlns:ns3="http://schemas.openxmlformats.org/drawingml/2006/main" prst="roundRect"><ns3:avLst><ns3:gd name="adj" fmla="val 10000"/></ns3:avLst></ns3:prstGeom><ns4:solidFill xmlns:ns4="http://schemas.openxmlformats.org/drawingml/2006/main"><ns4:srgbClr val="EDF0F7"/></ns4:solidFill><ns5:ln xmlns:ns5="http://schemas.openxmlformats.org/drawingml/2006/main"><ns5:noFill/></ns5:ln></ns0:spPr></ns0:sp><ns0:sp><ns0:nvSpPr><ns0:cNvPr id="6" name="AccentDot"/><ns0:cNvSpPr><ns1:spLocks xmlns:ns1="http://schemas.openxmlformats.org/drawingml/2006/main" noGrp="1"/></ns0:cNvSpPr><ns0:nvPr/></ns0:nvSpPr><ns0:spPr><ns2:xfrm xmlns:ns2="http://schemas.openxmlformats.org/drawingml/2006/main"><ns2:off x="3154680" y="2057400"/><ns2:ext cx="274320" cy="274320"/></ns2:xfrm><ns3:prstGeom xmlns:ns3="http://schemas.openxmlformats.org/drawingml/2006/main" prst="ellipse"/><ns4:solidFill xmlns:ns4="http://schemas.openxmlformats.org/drawingml/2006/main"><ns4:srgbClr val="3B82F6"/></ns4:solidFill><ns5:ln xmlns:ns5="http://schemas.openxmlformats.org/drawingml/2006/main"><ns5:noFill/></ns5:ln></ns0:spPr></ns0:sp><ns0:sp><ns0:nvSpPr><ns0:cNvPr id="20" name="Value.Center"/><ns0:cNvSpPr><ns1:spLocks xmlns:ns1="http://schemas.openxmlformats.org/drawingml/2006/main" noGrp="1"/></ns0:cNvSpPr><ns0:nvPr><ns0:ph idx="1" type="body"/></ns0:nvPr></ns0:nvSpPr><ns0:spPr><ns2:xfrm xmlns:ns2="http://schemas.openxmlformats.org/drawingml/2006/main"><ns2:off x="3200400" y="2011680"/><ns2:ext cx="5943600" cy="1828800"/></ns2:xfrm></ns0:spPr><ns0:txBody><ns3:bodyPr xmlns:ns3="http://schemas.openxmlformats.org/drawingml/2006/main" wrap="square" anchor="t" anchorCtr="0"/><ns4:lstStyle xmlns:ns4="http://schemas.openxmlformats.org/drawingml/2006/main"><ns4:defPPr algn="ctr"><ns4:buNone/><ns4:defRPr sz="7200" dirty="0" b="1"><ns4:solidFill><ns4:srgbClr val="1E2761"/></ns4:solidFill><ns4:latin typeface="Georgia"/><ns4:ea typeface="Georgia"/></ns4:defRPr></ns4:defPPr><ns4:lvl1pPr algn="ctr"><ns4:buNone/><ns4:defRPr sz="7200" dirty="0" b="1"><ns4:solidFill><ns4:srgbClr val="1E2761"/></ns4:solidFill><ns4:latin typeface="Georgia"/><ns4:ea typeface="Georgia"/></ns4:defRPr></ns4:lvl1pPr><ns4:lvl2pPr algn="ctr"><ns4:buNone/><ns4:defRPr sz="7200" dirty="0" b="1"><ns4:solidFill><ns4:srgbClr val="1E2761"/></ns4:solidFill><ns4:latin typeface="Georgia"/><ns4:ea typeface="Georgia"/></ns4:defRPr></ns4:lvl2pPr><ns4:lvl3pPr algn="ctr"><ns4:buNone/><ns4:defRPr sz="7200" dirty="0" b="1"><ns4:solidFill><ns4:srgbClr val="1E2761"/></ns4:solidFill><ns4:latin typeface="Georgia"/><ns4:ea typeface="Georgia"/></ns4:defRPr></ns4:lvl3pPr><ns4:lvl4pPr algn="ctr"><ns4:buNone/><ns4:defRPr sz="7200" dirty="0" b="1"><ns4:solidFill><ns4:srgbClr val="1E2761"/></ns4:solidFill><ns4:latin typeface="Georgia"/><ns4:ea typeface="Georgia"/></ns4:defRPr></ns4:lvl4pPr><ns4:lvl5pPr algn="ctr"><ns4:buNone/><ns4:defRPr sz="7200" dirty="0" b="1"><ns4:solidFill><ns4:srgbClr val="1E2761"/></ns4:solidFill><ns4:latin typeface="Georgia"/><ns4:ea typeface="Georgia"/></ns4:defRPr></ns4:lvl5pPr><ns4:lvl6pPr algn="ctr"><ns4:buNone/><ns4:defRPr sz="7200" dirty="0" b="1"><ns4:solidFill><ns4:srgbClr val="1E2761"/></ns4:solidFill><ns4:latin typeface="Georgia"/><ns4:ea typeface="Georgia"/></ns4:defRPr></ns4:lvl6pPr><ns4:lvl7pPr algn="ctr"><ns4:buNone/><ns4:defRPr sz="7200" dirty="0" b="1"><ns4:solidFill><ns4:srgbClr val="1E2761"/></ns4:solidFill><ns4:latin typeface="Georgia"/><ns4:ea typeface="Georgia"/></ns4:defRPr></ns4:lvl7pPr><ns4:lvl8pPr algn="ctr"><ns4:buNone/><ns4:defRPr sz="7200" dirty="0" b="1"><ns4:solidFill><ns4:srgbClr val="1E2761"/></ns4:solidFill><ns4:latin typeface="Georgia"/><ns4:ea typeface="Georgia"/></ns4:defRPr></ns4:lvl8pPr><ns4:lvl9pPr algn="ctr"><ns4:buNone/><ns4:defRPr sz="7200" dirty="0" b="1"><ns4:solidFill><ns4:srgbClr val="1E2761"/></ns4:solidFill><ns4:latin typeface="Georgia"/><ns4:ea typeface="Georgia"/></ns4:defRPr></ns4:lvl9pPr></ns4:lstStyle/><ns5:p xmlns:ns5="http://schemas.openxmlformats.org/drawingml/2006/main"><ns5:pPr algn="ctr"><ns5:buNone/></ns5:pPr><ns5:r><ns5:rPr lang="ja-JP"/><ns5:t>指標名</ns5:t></ns5:r></ns5:p></ns0:txBody></ns0:sp><ns0:sp><ns0:nvSpPr><ns0:cNvPr id="22" name="ValueDesc.Center"/><ns0:cNvSpPr><ns1:spLocks xmlns:ns1="http://schemas.openxmlformats.org/drawingml/2006/main" noGrp="1"/></ns0:cNvSpPr><ns0:nvPr><ns0:ph idx="3" type="body"/></ns0:nvPr></ns0:nvSpPr><ns0:spPr><ns2:xfrm xmlns:ns2="http://schemas.openxmlformats.org/drawingml/2006/main"><ns2:off x="3200400" y="4389120"/><ns2:ext cx="5943600" cy="914400"/></ns2:xfrm></ns0:spPr><ns0:txBody><ns3:bodyPr xmlns:ns3="http://schemas.openxmlformats.org/drawingml/2006/main" wrap="square" anchor="t" anchorCtr="0"/><ns4:lstStyle xmlns:ns4="http://schemas.openxmlformats.org/drawingml/2006/main"><ns4:defPPr algn="ctr"><ns4:buNone/><ns4:defRPr sz="1300" dirty="0"><ns4:solidFill><ns4:srgbClr val="94A3B8"/></ns4:solidFill><ns4:latin typeface="Calibri"/><ns4:ea typeface="Calibri"/></ns4:defRPr></ns4:defPPr><ns4:lvl1pPr algn="ctr"><ns4:buNone/><ns4:defRPr sz="1300" dirty="0"><ns4:solidFill><ns4:srgbClr val="94A3B8"/></ns4:solidFill><ns4:latin typeface="Calibri"/><ns4:ea typeface="Calibri"/></ns4:defRPr></ns4:lvl1pPr><ns4:lvl2pPr algn="ctr"><ns4:buNone/><ns4:defRPr sz="1300" dirty="0"><ns4:solidFill><ns4:srgbClr val="94A3B8"/></ns4:solidFill><ns4:latin typeface="Calibri"/><ns4:ea typeface="Calibri"/></ns4:defRPr></ns4:lvl2pPr><ns4:lvl3pPr algn="ctr"><ns4:buNone/><ns4:defRPr sz="1300" dirty="0"><ns4:solidFill><ns4:srgbClr val="94A3B8"/></ns4:solidFill><ns4:latin typeface="Calibri"/><ns4:ea typeface="Calibri"/></ns4:defRPr></ns4:lvl3pPr><ns4:lvl4pPr algn="ctr"><ns4:buNone/><ns4:defRPr sz="1300" dirty="0"><ns4:solidFill><ns4:srgbClr val="94A3B8"/></ns4:solidFill><ns4:latin typeface="Calibri"/><ns4:ea typeface="Calibri"/></ns4:defRPr></ns4:lvl4pPr><ns4:lvl5pPr algn="ctr"><ns4:buNone/><ns4:defRPr sz="1300" dirty="0"><ns4:solidFill><ns4:srgbClr val="94A3B8"/></ns4:solidFill><ns4:latin typeface="Calibri"/><ns4:ea typeface="Calibri"/></ns4:defRPr></ns4:lvl5pPr><ns4:lvl6pPr algn="ctr"><ns4:buNone/><ns4:defRPr sz="1300" dirty="0"><ns4:solidFill><ns4:srgbClr val="94A3B8"/></ns4:solidFill><ns4:latin typeface="Calibri"/><ns4:ea typeface="Calibri"/></ns4:defRPr></ns4:lvl6pPr><ns4:lvl7pPr algn="ctr"><ns4:buNone/><ns4:defRPr sz="1300" dirty="0"><ns4:solidFill><ns4:srgbClr val="94A3B8"/></ns4:solidFill><ns4:latin typeface="Calibri"/><ns4:ea typeface="Calibri"/></ns4:defRPr></ns4:lvl7pPr><ns4:lvl8pPr algn="ctr"><ns4:buNone/><ns4:defRPr sz="1300" dirty="0"><ns4:solidFill><ns4:srgbClr val="94A3B8"/></ns4:solidFill><ns4:latin typeface="Calibri"/><ns4:ea typeface="Calibri"/></ns4:defRPr></ns4:lvl8pPr><ns4:lvl9pPr algn="ctr"><ns4:buNone/><ns4:defRPr sz="1300" dirty="0"><ns4:solidFill><ns4:srgbClr val="94A3B8"/></ns4:solidFill><ns4:latin typeface="Calibri"/><ns4:ea typeface="Calibri"/></ns4:defRPr></ns4:lvl9pPr></ns4:lstStyle/><ns5:p xmlns:ns5="http://schemas.openxmlformats.org/drawingml/2006/main"><ns5:pPr algn="r"><ns5:buNone/></ns5:pPr><ns5:r><ns5:rPr lang="ja-JP"/><ns5:t>&lt;#&gt;</ns5:t></ns5:r></ns5:p></ns0:txBody></ns0:sp></ns0:spTree></ns0:cSld><ns0:clrMapOvr/></ns0:sldLayout>
+<ns0:sldLayout xmlns:ns0="http://schemas.openxmlformats.org/presentationml/2006/main" type="blank" preserve="1"><ns0:cSld name="KPI.1Value.Single"><ns0:spTree><ns0:nvGrpSpPr><ns0:cNvPr id="1" name=""/><ns0:cNvGrpSpPr/><ns0:nvPr/></ns0:nvGrpSpPr><ns0:grpSpPr><ns1:xfrm xmlns:ns1="http://schemas.openxmlformats.org/drawingml/2006/main"><ns1:off x="0" y="0"/><ns1:ext cx="0" cy="0"/><ns1:chOff x="0" y="0"/><ns1:chExt cx="0" cy="0"/></ns1:xfrm></ns0:grpSpPr><ns0:sp><ns0:nvSpPr><ns0:cNvPr id="2" name="HeaderBar"/><ns0:cNvSpPr><ns1:spLocks xmlns:ns1="http://schemas.openxmlformats.org/drawingml/2006/main" noGrp="1" noSelect="0" noRot="1" noMove="1"/></ns0:cNvSpPr><ns0:nvPr/></ns0:nvSpPr><ns0:spPr><ns2:xfrm xmlns:ns2="http://schemas.openxmlformats.org/drawingml/2006/main"><ns2:off x="0" y="0"/><ns2:ext cx="12192000" cy="1051560"/></ns2:xfrm><ns3:prstGeom xmlns:ns3="http://schemas.openxmlformats.org/drawingml/2006/main" prst="rect"/><ns4:solidFill xmlns:ns4="http://schemas.openxmlformats.org/drawingml/2006/main"><ns4:srgbClr val="1E2761"/></ns4:solidFill><ns5:ln xmlns:ns5="http://schemas.openxmlformats.org/drawingml/2006/main"><ns5:noFill/></ns5:ln></ns0:spPr></ns0:sp><ns0:sp><ns0:nvSpPr><ns0:cNvPr id="10" name="SlideTitle.Header"/><ns0:cNvSpPr><ns1:spLocks xmlns:ns1="http://schemas.openxmlformats.org/drawingml/2006/main" noGrp="1"/></ns0:cNvSpPr><ns0:nvPr><ns0:ph idx="15" type="body"/></ns0:nvPr></ns0:nvSpPr><ns0:spPr><ns2:xfrm xmlns:ns2="http://schemas.openxmlformats.org/drawingml/2006/main"><ns2:off x="731520" y="91440"/><ns2:ext cx="9144000" cy="475488"/></ns2:xfrm></ns0:spPr><ns0:txBody><ns3:bodyPr xmlns:ns3="http://schemas.openxmlformats.org/drawingml/2006/main" wrap="square" anchor="t" anchorCtr="0"/><ns4:lstStyle><ns4:defPPr><ns4:defRPr sz="2800" b="1"><ns4:solidFill><ns4:srgbClr val="FFFFFF"/></ns4:solidFill></ns4:defRPr></ns4:defPPr></ns4:lstStyle><ns4:defPPr algn="l"><ns4:buNone/><ns4:defRPr sz="2800" dirty="0" b="1"><ns4:solidFill><ns4:srgbClr val="FFFFFF"/></ns4:solidFill><ns4:latin typeface="Georgia"/><ns4:ea typeface="Georgia"/></ns4:defRPr></ns4:defPPr><ns4:lvl1pPr algn="l"><ns4:buNone/><ns4:defRPr sz="2800" dirty="0" b="1"><ns4:solidFill><ns4:srgbClr val="FFFFFF"/></ns4:solidFill><ns4:latin typeface="Georgia"/><ns4:ea typeface="Georgia"/></ns4:defRPr></ns4:lvl1pPr><ns4:lvl2pPr algn="l"><ns4:buNone/><ns4:defRPr sz="2800" dirty="0" b="1"><ns4:solidFill><ns4:srgbClr val="FFFFFF"/></ns4:solidFill><ns4:latin typeface="Georgia"/><ns4:ea typeface="Georgia"/></ns4:defRPr></ns4:lvl2pPr><ns4:lvl3pPr algn="l"><ns4:buNone/><ns4:defRPr sz="2800" dirty="0" b="1"><ns4:solidFill><ns4:srgbClr val="FFFFFF"/></ns4:solidFill><ns4:latin typeface="Georgia"/><ns4:ea typeface="Georgia"/></ns4:defRPr></ns4:lvl3pPr><ns4:lvl4pPr algn="l"><ns4:buNone/><ns4:defRPr sz="2800" dirty="0" b="1"><ns4:solidFill><ns4:srgbClr val="FFFFFF"/></ns4:solidFill><ns4:latin typeface="Georgia"/><ns4:ea typeface="Georgia"/></ns4:defRPr></ns4:lvl4pPr><ns4:lvl5pPr algn="l"><ns4:buNone/><ns4:defRPr sz="2800" dirty="0" b="1"><ns4:solidFill><ns4:srgbClr val="FFFFFF"/></ns4:solidFill><ns4:latin typeface="Georgia"/><ns4:ea typeface="Georgia"/></ns4:defRPr></ns4:lvl5pPr><ns4:lvl6pPr algn="l"><ns4:buNone/><ns4:defRPr sz="2800" dirty="0" b="1"><ns4:solidFill><ns4:srgbClr val="FFFFFF"/></ns4:solidFill><ns4:latin typeface="Georgia"/><ns4:ea typeface="Georgia"/></ns4:defRPr></ns4:lvl6pPr><ns4:lvl7pPr algn="l"><ns4:buNone/><ns4:defRPr sz="2800" dirty="0" b="1"><ns4:solidFill><ns4:srgbClr val="FFFFFF"/></ns4:solidFill><ns4:latin typeface="Georgia"/><ns4:ea typeface="Georgia"/></ns4:defRPr></ns4:lvl7pPr><ns4:lvl8pPr algn="l"><ns4:buNone/><ns4:defRPr sz="2800" dirty="0" b="1"><ns4:solidFill><ns4:srgbClr val="FFFFFF"/></ns4:solidFill><ns4:latin typeface="Georgia"/><ns4:ea typeface="Georgia"/></ns4:defRPr></ns4:lvl8pPr><ns4:lvl9pPr algn="l"><ns4:buNone/><ns4:defRPr sz="2800" dirty="0" b="1"><ns4:solidFill><ns4:srgbClr val="FFFFFF"/></ns4:solidFill><ns4:latin typeface="Georgia"/><ns4:ea typeface="Georgia"/></ns4:defRPr></ns4:lvl9pPr></ns4:lstStyle/><ns5:p xmlns:ns5="http://schemas.openxmlformats.org/drawingml/2006/main"><ns5:pPr algn="l"><ns5:buNone/></ns5:pPr><ns5:r><ns5:rPr lang="ja-JP"/><ns5:t>サブタイトル</ns5:t></ns5:r></ns5:p></ns0:txBody></ns0:sp><ns0:sp><ns0:nvSpPr><ns0:cNvPr id="5" name="StatPanel"/><ns0:cNvSpPr><ns1:spLocks xmlns:ns1="http://schemas.openxmlformats.org/drawingml/2006/main" noGrp="1" noSelect="0" noRot="1" noMove="1"/></ns0:cNvSpPr><ns0:nvPr/></ns0:nvSpPr><ns0:spPr><ns2:xfrm xmlns:ns2="http://schemas.openxmlformats.org/drawingml/2006/main"><ns2:off x="2743200" y="1645920"/><ns2:ext cx="6675120" cy="4114800"/></ns2:xfrm><ns3:prstGeom xmlns:ns3="http://schemas.openxmlformats.org/drawingml/2006/main" prst="roundRect"><ns3:avLst><ns3:gd name="adj" fmla="val 10000"/></ns3:avLst></ns3:prstGeom><ns4:solidFill xmlns:ns4="http://schemas.openxmlformats.org/drawingml/2006/main"><ns4:srgbClr val="EDF0F7"/></ns4:solidFill><ns5:ln xmlns:ns5="http://schemas.openxmlformats.org/drawingml/2006/main"><ns5:noFill/></ns5:ln></ns0:spPr></ns0:sp><ns0:sp><ns0:nvSpPr><ns0:cNvPr id="6" name="AccentDot"/><ns0:cNvSpPr><ns1:spLocks xmlns:ns1="http://schemas.openxmlformats.org/drawingml/2006/main" noGrp="1"/></ns0:cNvSpPr><ns0:nvPr/></ns0:nvSpPr><ns0:spPr><ns2:xfrm xmlns:ns2="http://schemas.openxmlformats.org/drawingml/2006/main"><ns2:off x="3154680" y="2057400"/><ns2:ext cx="274320" cy="274320"/></ns2:xfrm><ns3:prstGeom xmlns:ns3="http://schemas.openxmlformats.org/drawingml/2006/main" prst="ellipse"/><ns4:solidFill xmlns:ns4="http://schemas.openxmlformats.org/drawingml/2006/main"><ns4:srgbClr val="3B82F6"/></ns4:solidFill><ns5:ln xmlns:ns5="http://schemas.openxmlformats.org/drawingml/2006/main"><ns5:noFill/></ns5:ln></ns0:spPr></ns0:sp><ns0:sp><ns0:nvSpPr><ns0:cNvPr id="20" name="Value.Center"/><ns0:cNvSpPr><ns1:spLocks xmlns:ns1="http://schemas.openxmlformats.org/drawingml/2006/main" noGrp="1"/></ns0:cNvSpPr><ns0:nvPr><ns0:ph idx="1" type="body"/></ns0:nvPr></ns0:nvSpPr><ns0:spPr><ns2:xfrm xmlns:ns2="http://schemas.openxmlformats.org/drawingml/2006/main"><ns2:off x="3200400" y="2011680"/><ns2:ext cx="5943600" cy="1828800"/></ns2:xfrm></ns0:spPr><ns0:txBody><ns3:bodyPr xmlns:ns3="http://schemas.openxmlformats.org/drawingml/2006/main" wrap="square" anchor="t" anchorCtr="0"/><ns4:lstStyle><ns4:defPPr algn="ctr"><ns4:defRPr sz="7200" b="1"><ns4:solidFill><ns4:srgbClr val="1E2761"/></ns4:solidFill></ns4:defRPr></ns4:defPPr></ns4:lstStyle><ns4:defPPr algn="ctr"><ns4:buNone/><ns4:defRPr sz="7200" dirty="0" b="1"><ns4:solidFill><ns4:srgbClr val="1E2761"/></ns4:solidFill><ns4:latin typeface="Georgia"/><ns4:ea typeface="Georgia"/></ns4:defRPr></ns4:defPPr><ns4:lvl1pPr algn="ctr"><ns4:buNone/><ns4:defRPr sz="7200" dirty="0" b="1"><ns4:solidFill><ns4:srgbClr val="1E2761"/></ns4:solidFill><ns4:latin typeface="Georgia"/><ns4:ea typeface="Georgia"/></ns4:defRPr></ns4:lvl1pPr><ns4:lvl2pPr algn="ctr"><ns4:buNone/><ns4:defRPr sz="7200" dirty="0" b="1"><ns4:solidFill><ns4:srgbClr val="1E2761"/></ns4:solidFill><ns4:latin typeface="Georgia"/><ns4:ea typeface="Georgia"/></ns4:defRPr></ns4:lvl2pPr><ns4:lvl3pPr algn="ctr"><ns4:buNone/><ns4:defRPr sz="7200" dirty="0" b="1"><ns4:solidFill><ns4:srgbClr val="1E2761"/></ns4:solidFill><ns4:latin typeface="Georgia"/><ns4:ea typeface="Georgia"/></ns4:defRPr></ns4:lvl3pPr><ns4:lvl4pPr algn="ctr"><ns4:buNone/><ns4:defRPr sz="7200" dirty="0" b="1"><ns4:solidFill><ns4:srgbClr val="1E2761"/></ns4:solidFill><ns4:latin typeface="Georgia"/><ns4:ea typeface="Georgia"/></ns4:defRPr></ns4:lvl4pPr><ns4:lvl5pPr algn="ctr"><ns4:buNone/><ns4:defRPr sz="7200" dirty="0" b="1"><ns4:solidFill><ns4:srgbClr val="1E2761"/></ns4:solidFill><ns4:latin typeface="Georgia"/><ns4:ea typeface="Georgia"/></ns4:defRPr></ns4:lvl5pPr><ns4:lvl6pPr algn="ctr"><ns4:buNone/><ns4:defRPr sz="7200" dirty="0" b="1"><ns4:solidFill><ns4:srgbClr val="1E2761"/></ns4:solidFill><ns4:latin typeface="Georgia"/><ns4:ea typeface="Georgia"/></ns4:defRPr></ns4:lvl6pPr><ns4:lvl7pPr algn="ctr"><ns4:buNone/><ns4:defRPr sz="7200" dirty="0" b="1"><ns4:solidFill><ns4:srgbClr val="1E2761"/></ns4:solidFill><ns4:latin typeface="Georgia"/><ns4:ea typeface="Georgia"/></ns4:defRPr></ns4:lvl7pPr><ns4:lvl8pPr algn="ctr"><ns4:buNone/><ns4:defRPr sz="7200" dirty="0" b="1"><ns4:solidFill><ns4:srgbClr val="1E2761"/></ns4:solidFill><ns4:latin typeface="Georgia"/><ns4:ea typeface="Georgia"/></ns4:defRPr></ns4:lvl8pPr><ns4:lvl9pPr algn="ctr"><ns4:buNone/><ns4:defRPr sz="7200" dirty="0" b="1"><ns4:solidFill><ns4:srgbClr val="1E2761"/></ns4:solidFill><ns4:latin typeface="Georgia"/><ns4:ea typeface="Georgia"/></ns4:defRPr></ns4:lvl9pPr></ns4:lstStyle/><ns5:p xmlns:ns5="http://schemas.openxmlformats.org/drawingml/2006/main"><ns5:pPr algn="ctr"><ns5:buNone/></ns5:pPr><ns5:r><ns5:rPr lang="ja-JP"/><ns5:t>指標名</ns5:t></ns5:r></ns5:p></ns0:txBody></ns0:sp><ns0:sp><ns0:nvSpPr><ns0:cNvPr id="22" name="ValueDesc.Center"/><ns0:cNvSpPr><ns1:spLocks xmlns:ns1="http://schemas.openxmlformats.org/drawingml/2006/main" noGrp="1"/></ns0:cNvSpPr><ns0:nvPr><ns0:ph idx="3" type="body"/></ns0:nvPr></ns0:nvSpPr><ns0:spPr><ns2:xfrm xmlns:ns2="http://schemas.openxmlformats.org/drawingml/2006/main"><ns2:off x="3200400" y="4389120"/><ns2:ext cx="5943600" cy="914400"/></ns2:xfrm></ns0:spPr><ns0:txBody><ns3:bodyPr xmlns:ns3="http://schemas.openxmlformats.org/drawingml/2006/main" wrap="square" anchor="t" anchorCtr="0"/><ns4:lstStyle><ns4:defPPr algn="ctr"><ns4:defRPr sz="1300"><ns4:solidFill><ns4:srgbClr val="94A3B8"/></ns4:solidFill></ns4:defRPr></ns4:defPPr></ns4:lstStyle><ns4:defPPr algn="ctr"><ns4:buNone/><ns4:defRPr sz="1300" dirty="0"><ns4:solidFill><ns4:srgbClr val="94A3B8"/></ns4:solidFill><ns4:latin typeface="Calibri"/><ns4:ea typeface="Calibri"/></ns4:defRPr></ns4:defPPr><ns4:lvl1pPr algn="ctr"><ns4:buNone/><ns4:defRPr sz="1300" dirty="0"><ns4:solidFill><ns4:srgbClr val="94A3B8"/></ns4:solidFill><ns4:latin typeface="Calibri"/><ns4:ea typeface="Calibri"/></ns4:defRPr></ns4:lvl1pPr><ns4:lvl2pPr algn="ctr"><ns4:buNone/><ns4:defRPr sz="1300" dirty="0"><ns4:solidFill><ns4:srgbClr val="94A3B8"/></ns4:solidFill><ns4:latin typeface="Calibri"/><ns4:ea typeface="Calibri"/></ns4:defRPr></ns4:lvl2pPr><ns4:lvl3pPr algn="ctr"><ns4:buNone/><ns4:defRPr sz="1300" dirty="0"><ns4:solidFill><ns4:srgbClr val="94A3B8"/></ns4:solidFill><ns4:latin typeface="Calibri"/><ns4:ea typeface="Calibri"/></ns4:defRPr></ns4:lvl3pPr><ns4:lvl4pPr algn="ctr"><ns4:buNone/><ns4:defRPr sz="1300" dirty="0"><ns4:solidFill><ns4:srgbClr val="94A3B8"/></ns4:solidFill><ns4:latin typeface="Calibri"/><ns4:ea typeface="Calibri"/></ns4:defRPr></ns4:lvl4pPr><ns4:lvl5pPr algn="ctr"><ns4:buNone/><ns4:defRPr sz="1300" dirty="0"><ns4:solidFill><ns4:srgbClr val="94A3B8"/></ns4:solidFill><ns4:latin typeface="Calibri"/><ns4:ea typeface="Calibri"/></ns4:defRPr></ns4:lvl5pPr><ns4:lvl6pPr algn="ctr"><ns4:buNone/><ns4:defRPr sz="1300" dirty="0"><ns4:solidFill><ns4:srgbClr val="94A3B8"/></ns4:solidFill><ns4:latin typeface="Calibri"/><ns4:ea typeface="Calibri"/></ns4:defRPr></ns4:lvl6pPr><ns4:lvl7pPr algn="ctr"><ns4:buNone/><ns4:defRPr sz="1300" dirty="0"><ns4:solidFill><ns4:srgbClr val="94A3B8"/></ns4:solidFill><ns4:latin typeface="Calibri"/><ns4:ea typeface="Calibri"/></ns4:defRPr></ns4:lvl7pPr><ns4:lvl8pPr algn="ctr"><ns4:buNone/><ns4:defRPr sz="1300" dirty="0"><ns4:solidFill><ns4:srgbClr val="94A3B8"/></ns4:solidFill><ns4:latin typeface="Calibri"/><ns4:ea typeface="Calibri"/></ns4:defRPr></ns4:lvl8pPr><ns4:lvl9pPr algn="ctr"><ns4:buNone/><ns4:defRPr sz="1300" dirty="0"><ns4:solidFill><ns4:srgbClr val="94A3B8"/></ns4:solidFill><ns4:latin typeface="Calibri"/><ns4:ea typeface="Calibri"/></ns4:defRPr></ns4:lvl9pPr></ns4:lstStyle/><ns5:p xmlns:ns5="http://schemas.openxmlformats.org/drawingml/2006/main"><ns5:pPr algn="r"><ns5:buNone/></ns5:pPr><ns5:r><ns5:rPr lang="ja-JP"/><ns5:t>&lt;#&gt;</ns5:t></ns5:r></ns5:p></ns0:txBody></ns0:sp></ns0:spTree></ns0:cSld><ns0:clrMapOvr/></ns0:sldLayout>
 </file>
 
 <file path=ppt/slideLayouts/slideLayout15.xml><?xml version='1.0' encoding='UTF-8' standalone='yes'?>
-<ns0:sldLayout xmlns:ns0="http://schemas.openxmlformats.org/presentationml/2006/main" type="blank" preserve="1"><ns0:cSld name="KPI.2Value.Equal"><ns0:spTree><ns0:nvGrpSpPr><ns0:cNvPr id="1" name=""/><ns0:cNvGrpSpPr/><ns0:nvPr/></ns0:nvGrpSpPr><ns0:grpSpPr><ns1:xfrm xmlns:ns1="http://schemas.openxmlformats.org/drawingml/2006/main"><ns1:off x="0" y="0"/><ns1:ext cx="0" cy="0"/><ns1:chOff x="0" y="0"/><ns1:chExt cx="0" cy="0"/></ns1:xfrm></ns0:grpSpPr><ns0:sp><ns0:nvSpPr><ns0:cNvPr id="2" name="HeaderBar"/><ns0:cNvSpPr><ns1:spLocks xmlns:ns1="http://schemas.openxmlformats.org/drawingml/2006/main" noGrp="1" noSelect="0" noRot="1" noMove="1"/></ns0:cNvSpPr><ns0:nvPr/></ns0:nvSpPr><ns0:spPr><ns2:xfrm xmlns:ns2="http://schemas.openxmlformats.org/drawingml/2006/main"><ns2:off x="0" y="0"/><ns2:ext cx="12192000" cy="1051560"/></ns2:xfrm><ns3:prstGeom xmlns:ns3="http://schemas.openxmlformats.org/drawingml/2006/main" prst="rect"/><ns4:solidFill xmlns:ns4="http://schemas.openxmlformats.org/drawingml/2006/main"><ns4:srgbClr val="1E2761"/></ns4:solidFill><ns5:ln xmlns:ns5="http://schemas.openxmlformats.org/drawingml/2006/main"><ns5:noFill/></ns5:ln></ns0:spPr></ns0:sp><ns0:sp><ns0:nvSpPr><ns0:cNvPr id="10" name="SlideTitle.Header"/><ns0:cNvSpPr><ns1:spLocks xmlns:ns1="http://schemas.openxmlformats.org/drawingml/2006/main" noGrp="1"/></ns0:cNvSpPr><ns0:nvPr><ns0:ph idx="15" type="body"/></ns0:nvPr></ns0:nvSpPr><ns0:spPr><ns2:xfrm xmlns:ns2="http://schemas.openxmlformats.org/drawingml/2006/main"><ns2:off x="731520" y="91440"/><ns2:ext cx="9144000" cy="475488"/></ns2:xfrm></ns0:spPr><ns0:txBody><ns3:bodyPr xmlns:ns3="http://schemas.openxmlformats.org/drawingml/2006/main" wrap="square" anchor="t" anchorCtr="0"/><ns4:lstStyle xmlns:ns4="http://schemas.openxmlformats.org/drawingml/2006/main"><ns4:defPPr algn="l"><ns4:buNone/><ns4:defRPr sz="2800" dirty="0" b="1"><ns4:solidFill><ns4:srgbClr val="FFFFFF"/></ns4:solidFill><ns4:latin typeface="Georgia"/><ns4:ea typeface="Georgia"/></ns4:defRPr></ns4:defPPr><ns4:lvl1pPr algn="l"><ns4:buNone/><ns4:defRPr sz="2800" dirty="0" b="1"><ns4:solidFill><ns4:srgbClr val="FFFFFF"/></ns4:solidFill><ns4:latin typeface="Georgia"/><ns4:ea typeface="Georgia"/></ns4:defRPr></ns4:lvl1pPr><ns4:lvl2pPr algn="l"><ns4:buNone/><ns4:defRPr sz="2800" dirty="0" b="1"><ns4:solidFill><ns4:srgbClr val="FFFFFF"/></ns4:solidFill><ns4:latin typeface="Georgia"/><ns4:ea typeface="Georgia"/></ns4:defRPr></ns4:lvl2pPr><ns4:lvl3pPr algn="l"><ns4:buNone/><ns4:defRPr sz="2800" dirty="0" b="1"><ns4:solidFill><ns4:srgbClr val="FFFFFF"/></ns4:solidFill><ns4:latin typeface="Georgia"/><ns4:ea typeface="Georgia"/></ns4:defRPr></ns4:lvl3pPr><ns4:lvl4pPr algn="l"><ns4:buNone/><ns4:defRPr sz="2800" dirty="0" b="1"><ns4:solidFill><ns4:srgbClr val="FFFFFF"/></ns4:solidFill><ns4:latin typeface="Georgia"/><ns4:ea typeface="Georgia"/></ns4:defRPr></ns4:lvl4pPr><ns4:lvl5pPr algn="l"><ns4:buNone/><ns4:defRPr sz="2800" dirty="0" b="1"><ns4:solidFill><ns4:srgbClr val="FFFFFF"/></ns4:solidFill><ns4:latin typeface="Georgia"/><ns4:ea typeface="Georgia"/></ns4:defRPr></ns4:lvl5pPr><ns4:lvl6pPr algn="l"><ns4:buNone/><ns4:defRPr sz="2800" dirty="0" b="1"><ns4:solidFill><ns4:srgbClr val="FFFFFF"/></ns4:solidFill><ns4:latin typeface="Georgia"/><ns4:ea typeface="Georgia"/></ns4:defRPr></ns4:lvl6pPr><ns4:lvl7pPr algn="l"><ns4:buNone/><ns4:defRPr sz="2800" dirty="0" b="1"><ns4:solidFill><ns4:srgbClr val="FFFFFF"/></ns4:solidFill><ns4:latin typeface="Georgia"/><ns4:ea typeface="Georgia"/></ns4:defRPr></ns4:lvl7pPr><ns4:lvl8pPr algn="l"><ns4:buNone/><ns4:defRPr sz="2800" dirty="0" b="1"><ns4:solidFill><ns4:srgbClr val="FFFFFF"/></ns4:solidFill><ns4:latin typeface="Georgia"/><ns4:ea typeface="Georgia"/></ns4:defRPr></ns4:lvl8pPr><ns4:lvl9pPr algn="l"><ns4:buNone/><ns4:defRPr sz="2800" dirty="0" b="1"><ns4:solidFill><ns4:srgbClr val="FFFFFF"/></ns4:solidFill><ns4:latin typeface="Georgia"/><ns4:ea typeface="Georgia"/></ns4:defRPr></ns4:lvl9pPr></ns4:lstStyle/><ns5:p xmlns:ns5="http://schemas.openxmlformats.org/drawingml/2006/main"><ns5:pPr algn="l"><ns5:buNone/></ns5:pPr><ns5:r><ns5:rPr lang="ja-JP"/><ns5:t>サブタイトル</ns5:t></ns5:r></ns5:p></ns0:txBody></ns0:sp><ns0:sp><ns0:nvSpPr><ns0:cNvPr id="5" name="Card1"/><ns0:cNvSpPr><ns1:spLocks xmlns:ns1="http://schemas.openxmlformats.org/drawingml/2006/main" noGrp="1" noSelect="0" noRot="1" noMove="1"/></ns0:cNvSpPr><ns0:nvPr/></ns0:nvSpPr><ns0:spPr><ns2:xfrm xmlns:ns2="http://schemas.openxmlformats.org/drawingml/2006/main"><ns2:off x="640080" y="1371600"/><ns2:ext cx="5120640" cy="4754880"/></ns2:xfrm><ns3:prstGeom xmlns:ns3="http://schemas.openxmlformats.org/drawingml/2006/main" prst="roundRect"><ns3:avLst><ns3:gd name="adj" fmla="val 10000"/></ns3:avLst></ns3:prstGeom><ns4:solidFill xmlns:ns4="http://schemas.openxmlformats.org/drawingml/2006/main"><ns4:srgbClr val="EDF0F7"/></ns4:solidFill><ns5:ln xmlns:ns5="http://schemas.openxmlformats.org/drawingml/2006/main"><ns5:noFill/></ns5:ln></ns0:spPr></ns0:sp><ns0:sp><ns0:nvSpPr><ns0:cNvPr id="6" name="Card2"/><ns0:cNvSpPr><ns1:spLocks xmlns:ns1="http://schemas.openxmlformats.org/drawingml/2006/main" noGrp="1" noSelect="0" noRot="1" noMove="1"/></ns0:cNvSpPr><ns0:nvPr/></ns0:nvSpPr><ns0:spPr><ns2:xfrm xmlns:ns2="http://schemas.openxmlformats.org/drawingml/2006/main"><ns2:off x="6126480" y="1371600"/><ns2:ext cx="5303520" cy="4754880"/></ns2:xfrm><ns3:prstGeom xmlns:ns3="http://schemas.openxmlformats.org/drawingml/2006/main" prst="roundRect"><ns3:avLst><ns3:gd name="adj" fmla="val 10000"/></ns3:avLst></ns3:prstGeom><ns4:solidFill xmlns:ns4="http://schemas.openxmlformats.org/drawingml/2006/main"><ns4:srgbClr val="EDF0F7"/></ns4:solidFill><ns5:ln xmlns:ns5="http://schemas.openxmlformats.org/drawingml/2006/main"><ns5:noFill/></ns5:ln></ns0:spPr></ns0:sp><ns0:sp><ns0:nvSpPr><ns0:cNvPr id="7" name="Accent1"/><ns0:cNvSpPr><ns1:spLocks xmlns:ns1="http://schemas.openxmlformats.org/drawingml/2006/main" noGrp="1" noSelect="0" noRot="1" noMove="1"/></ns0:cNvSpPr><ns0:nvPr/></ns0:nvSpPr><ns0:spPr><ns2:xfrm xmlns:ns2="http://schemas.openxmlformats.org/drawingml/2006/main"><ns2:off x="640080" y="1371600"/><ns2:ext cx="5120640" cy="73152"/></ns2:xfrm><ns3:prstGeom xmlns:ns3="http://schemas.openxmlformats.org/drawingml/2006/main" prst="rect"/><ns4:solidFill xmlns:ns4="http://schemas.openxmlformats.org/drawingml/2006/main"><ns4:srgbClr val="3B82F6"/></ns4:solidFill><ns5:ln xmlns:ns5="http://schemas.openxmlformats.org/drawingml/2006/main"><ns5:noFill/></ns5:ln></ns0:spPr></ns0:sp><ns0:sp><ns0:nvSpPr><ns0:cNvPr id="8" name="Accent2"/><ns0:cNvSpPr><ns1:spLocks xmlns:ns1="http://schemas.openxmlformats.org/drawingml/2006/main" noGrp="1" noSelect="0" noRot="1" noMove="1"/></ns0:cNvSpPr><ns0:nvPr/></ns0:nvSpPr><ns0:spPr><ns2:xfrm xmlns:ns2="http://schemas.openxmlformats.org/drawingml/2006/main"><ns2:off x="6126480" y="1371600"/><ns2:ext cx="5303520" cy="73152"/></ns2:xfrm><ns3:prstGeom xmlns:ns3="http://schemas.openxmlformats.org/drawingml/2006/main" prst="rect"/><ns4:solidFill xmlns:ns4="http://schemas.openxmlformats.org/drawingml/2006/main"><ns4:srgbClr val="06B6D4"/></ns4:solidFill><ns5:ln xmlns:ns5="http://schemas.openxmlformats.org/drawingml/2006/main"><ns5:noFill/></ns5:ln></ns0:spPr></ns0:sp><ns0:sp><ns0:nvSpPr><ns0:cNvPr id="20" name="Value1.Left"/><ns0:cNvSpPr><ns1:spLocks xmlns:ns1="http://schemas.openxmlformats.org/drawingml/2006/main" noGrp="1"/></ns0:cNvSpPr><ns0:nvPr><ns0:ph idx="1" type="body"/></ns0:nvPr></ns0:nvSpPr><ns0:spPr><ns2:xfrm xmlns:ns2="http://schemas.openxmlformats.org/drawingml/2006/main"><ns2:off x="1097280" y="1828800"/><ns2:ext cx="4206240" cy="1645920"/></ns2:xfrm></ns0:spPr><ns0:txBody><ns3:bodyPr xmlns:ns3="http://schemas.openxmlformats.org/drawingml/2006/main" wrap="square" anchor="t" anchorCtr="0"/><ns4:lstStyle xmlns:ns4="http://schemas.openxmlformats.org/drawingml/2006/main"><ns4:defPPr algn="ctr"><ns4:buNone/><ns4:defRPr sz="6000" dirty="0" b="1"><ns4:solidFill><ns4:srgbClr val="1E2761"/></ns4:solidFill><ns4:latin typeface="Georgia"/><ns4:ea typeface="Georgia"/></ns4:defRPr></ns4:defPPr><ns4:lvl1pPr algn="ctr"><ns4:buNone/><ns4:defRPr sz="6000" dirty="0" b="1"><ns4:solidFill><ns4:srgbClr val="1E2761"/></ns4:solidFill><ns4:latin typeface="Georgia"/><ns4:ea typeface="Georgia"/></ns4:defRPr></ns4:lvl1pPr><ns4:lvl2pPr algn="ctr"><ns4:buNone/><ns4:defRPr sz="6000" dirty="0" b="1"><ns4:solidFill><ns4:srgbClr val="1E2761"/></ns4:solidFill><ns4:latin typeface="Georgia"/><ns4:ea typeface="Georgia"/></ns4:defRPr></ns4:lvl2pPr><ns4:lvl3pPr algn="ctr"><ns4:buNone/><ns4:defRPr sz="6000" dirty="0" b="1"><ns4:solidFill><ns4:srgbClr val="1E2761"/></ns4:solidFill><ns4:latin typeface="Georgia"/><ns4:ea typeface="Georgia"/></ns4:defRPr></ns4:lvl3pPr><ns4:lvl4pPr algn="ctr"><ns4:buNone/><ns4:defRPr sz="6000" dirty="0" b="1"><ns4:solidFill><ns4:srgbClr val="1E2761"/></ns4:solidFill><ns4:latin typeface="Georgia"/><ns4:ea typeface="Georgia"/></ns4:defRPr></ns4:lvl4pPr><ns4:lvl5pPr algn="ctr"><ns4:buNone/><ns4:defRPr sz="6000" dirty="0" b="1"><ns4:solidFill><ns4:srgbClr val="1E2761"/></ns4:solidFill><ns4:latin typeface="Georgia"/><ns4:ea typeface="Georgia"/></ns4:defRPr></ns4:lvl5pPr><ns4:lvl6pPr algn="ctr"><ns4:buNone/><ns4:defRPr sz="6000" dirty="0" b="1"><ns4:solidFill><ns4:srgbClr val="1E2761"/></ns4:solidFill><ns4:latin typeface="Georgia"/><ns4:ea typeface="Georgia"/></ns4:defRPr></ns4:lvl6pPr><ns4:lvl7pPr algn="ctr"><ns4:buNone/><ns4:defRPr sz="6000" dirty="0" b="1"><ns4:solidFill><ns4:srgbClr val="1E2761"/></ns4:solidFill><ns4:latin typeface="Georgia"/><ns4:ea typeface="Georgia"/></ns4:defRPr></ns4:lvl7pPr><ns4:lvl8pPr algn="ctr"><ns4:buNone/><ns4:defRPr sz="6000" dirty="0" b="1"><ns4:solidFill><ns4:srgbClr val="1E2761"/></ns4:solidFill><ns4:latin typeface="Georgia"/><ns4:ea typeface="Georgia"/></ns4:defRPr></ns4:lvl8pPr><ns4:lvl9pPr algn="ctr"><ns4:buNone/><ns4:defRPr sz="6000" dirty="0" b="1"><ns4:solidFill><ns4:srgbClr val="1E2761"/></ns4:solidFill><ns4:latin typeface="Georgia"/><ns4:ea typeface="Georgia"/></ns4:defRPr></ns4:lvl9pPr></ns4:lstStyle/><ns5:p xmlns:ns5="http://schemas.openxmlformats.org/drawingml/2006/main"><ns5:pPr algn="ctr"><ns5:buNone/></ns5:pPr><ns5:r><ns5:rPr lang="ja-JP"/><ns5:t>指標名
-説明テキスト</ns5:t></ns5:r></ns5:p></ns0:txBody></ns0:sp><ns0:sp><ns0:nvSpPr><ns0:cNvPr id="22" name="Value2.Right"/><ns0:cNvSpPr><ns1:spLocks xmlns:ns1="http://schemas.openxmlformats.org/drawingml/2006/main" noGrp="1"/></ns0:cNvSpPr><ns0:nvPr><ns0:ph idx="3" type="body"/></ns0:nvPr></ns0:nvSpPr><ns0:spPr><ns2:xfrm xmlns:ns2="http://schemas.openxmlformats.org/drawingml/2006/main"><ns2:off x="6583680" y="1828800"/><ns2:ext cx="4389120" cy="1645920"/></ns2:xfrm></ns0:spPr><ns0:txBody><ns3:bodyPr xmlns:ns3="http://schemas.openxmlformats.org/drawingml/2006/main" wrap="square" anchor="t" anchorCtr="0"/><ns4:lstStyle xmlns:ns4="http://schemas.openxmlformats.org/drawingml/2006/main"><ns4:defPPr algn="ctr"><ns4:buNone/><ns4:defRPr sz="6000" dirty="0" b="1"><ns4:solidFill><ns4:srgbClr val="1E2761"/></ns4:solidFill><ns4:latin typeface="Georgia"/><ns4:ea typeface="Georgia"/></ns4:defRPr></ns4:defPPr><ns4:lvl1pPr algn="ctr"><ns4:buNone/><ns4:defRPr sz="6000" dirty="0" b="1"><ns4:solidFill><ns4:srgbClr val="1E2761"/></ns4:solidFill><ns4:latin typeface="Georgia"/><ns4:ea typeface="Georgia"/></ns4:defRPr></ns4:lvl1pPr><ns4:lvl2pPr algn="ctr"><ns4:buNone/><ns4:defRPr sz="6000" dirty="0" b="1"><ns4:solidFill><ns4:srgbClr val="1E2761"/></ns4:solidFill><ns4:latin typeface="Georgia"/><ns4:ea typeface="Georgia"/></ns4:defRPr></ns4:lvl2pPr><ns4:lvl3pPr algn="ctr"><ns4:buNone/><ns4:defRPr sz="6000" dirty="0" b="1"><ns4:solidFill><ns4:srgbClr val="1E2761"/></ns4:solidFill><ns4:latin typeface="Georgia"/><ns4:ea typeface="Georgia"/></ns4:defRPr></ns4:lvl3pPr><ns4:lvl4pPr algn="ctr"><ns4:buNone/><ns4:defRPr sz="6000" dirty="0" b="1"><ns4:solidFill><ns4:srgbClr val="1E2761"/></ns4:solidFill><ns4:latin typeface="Georgia"/><ns4:ea typeface="Georgia"/></ns4:defRPr></ns4:lvl4pPr><ns4:lvl5pPr algn="ctr"><ns4:buNone/><ns4:defRPr sz="6000" dirty="0" b="1"><ns4:solidFill><ns4:srgbClr val="1E2761"/></ns4:solidFill><ns4:latin typeface="Georgia"/><ns4:ea typeface="Georgia"/></ns4:defRPr></ns4:lvl5pPr><ns4:lvl6pPr algn="ctr"><ns4:buNone/><ns4:defRPr sz="6000" dirty="0" b="1"><ns4:solidFill><ns4:srgbClr val="1E2761"/></ns4:solidFill><ns4:latin typeface="Georgia"/><ns4:ea typeface="Georgia"/></ns4:defRPr></ns4:lvl6pPr><ns4:lvl7pPr algn="ctr"><ns4:buNone/><ns4:defRPr sz="6000" dirty="0" b="1"><ns4:solidFill><ns4:srgbClr val="1E2761"/></ns4:solidFill><ns4:latin typeface="Georgia"/><ns4:ea typeface="Georgia"/></ns4:defRPr></ns4:lvl7pPr><ns4:lvl8pPr algn="ctr"><ns4:buNone/><ns4:defRPr sz="6000" dirty="0" b="1"><ns4:solidFill><ns4:srgbClr val="1E2761"/></ns4:solidFill><ns4:latin typeface="Georgia"/><ns4:ea typeface="Georgia"/></ns4:defRPr></ns4:lvl8pPr><ns4:lvl9pPr algn="ctr"><ns4:buNone/><ns4:defRPr sz="6000" dirty="0" b="1"><ns4:solidFill><ns4:srgbClr val="1E2761"/></ns4:solidFill><ns4:latin typeface="Georgia"/><ns4:ea typeface="Georgia"/></ns4:defRPr></ns4:lvl9pPr></ns4:lstStyle/><ns5:p xmlns:ns5="http://schemas.openxmlformats.org/drawingml/2006/main"><ns5:pPr algn="ctr"><ns5:buNone/></ns5:pPr><ns5:r><ns5:rPr lang="ja-JP"/><ns5:t>指標名
-説明テキスト</ns5:t></ns5:r></ns5:p></ns0:txBody></ns0:sp><ns0:sp><ns0:nvSpPr><ns0:cNvPr id="30" name="SlideNum.Footer"/><ns0:cNvSpPr><ns1:spLocks xmlns:ns1="http://schemas.openxmlformats.org/drawingml/2006/main" noGrp="1"/></ns0:cNvSpPr><ns0:nvPr><ns0:ph idx="50" type="sldNum"/></ns0:nvPr></ns0:nvSpPr><ns0:spPr><ns2:xfrm xmlns:ns2="http://schemas.openxmlformats.org/drawingml/2006/main"><ns2:off x="10972800" y="6446520"/><ns2:ext cx="1097280" cy="274320"/></ns2:xfrm></ns0:spPr><ns0:txBody><ns3:bodyPr xmlns:ns3="http://schemas.openxmlformats.org/drawingml/2006/main" wrap="square" anchor="t" anchorCtr="0"/><ns4:lstStyle xmlns:ns4="http://schemas.openxmlformats.org/drawingml/2006/main"><ns4:defPPr algn="r"><ns4:buNone/><ns4:defRPr sz="1000" dirty="0"><ns4:solidFill><ns4:srgbClr val="94A3B8"/></ns4:solidFill><ns4:latin typeface="Calibri"/><ns4:ea typeface="Calibri"/></ns4:defRPr></ns4:defPPr><ns4:lvl1pPr algn="r"><ns4:buNone/><ns4:defRPr sz="1000" dirty="0"><ns4:solidFill><ns4:srgbClr val="94A3B8"/></ns4:solidFill><ns4:latin typeface="Calibri"/><ns4:ea typeface="Calibri"/></ns4:defRPr></ns4:lvl1pPr><ns4:lvl2pPr algn="r"><ns4:buNone/><ns4:defRPr sz="1000" dirty="0"><ns4:solidFill><ns4:srgbClr val="94A3B8"/></ns4:solidFill><ns4:latin typeface="Calibri"/><ns4:ea typeface="Calibri"/></ns4:defRPr></ns4:lvl2pPr><ns4:lvl3pPr algn="r"><ns4:buNone/><ns4:defRPr sz="1000" dirty="0"><ns4:solidFill><ns4:srgbClr val="94A3B8"/></ns4:solidFill><ns4:latin typeface="Calibri"/><ns4:ea typeface="Calibri"/></ns4:defRPr></ns4:lvl3pPr><ns4:lvl4pPr algn="r"><ns4:buNone/><ns4:defRPr sz="1000" dirty="0"><ns4:solidFill><ns4:srgbClr val="94A3B8"/></ns4:solidFill><ns4:latin typeface="Calibri"/><ns4:ea typeface="Calibri"/></ns4:defRPr></ns4:lvl4pPr><ns4:lvl5pPr algn="r"><ns4:buNone/><ns4:defRPr sz="1000" dirty="0"><ns4:solidFill><ns4:srgbClr val="94A3B8"/></ns4:solidFill><ns4:latin typeface="Calibri"/><ns4:ea typeface="Calibri"/></ns4:defRPr></ns4:lvl5pPr><ns4:lvl6pPr algn="r"><ns4:buNone/><ns4:defRPr sz="1000" dirty="0"><ns4:solidFill><ns4:srgbClr val="94A3B8"/></ns4:solidFill><ns4:latin typeface="Calibri"/><ns4:ea typeface="Calibri"/></ns4:defRPr></ns4:lvl6pPr><ns4:lvl7pPr algn="r"><ns4:buNone/><ns4:defRPr sz="1000" dirty="0"><ns4:solidFill><ns4:srgbClr val="94A3B8"/></ns4:solidFill><ns4:latin typeface="Calibri"/><ns4:ea typeface="Calibri"/></ns4:defRPr></ns4:lvl7pPr><ns4:lvl8pPr algn="r"><ns4:buNone/><ns4:defRPr sz="1000" dirty="0"><ns4:solidFill><ns4:srgbClr val="94A3B8"/></ns4:solidFill><ns4:latin typeface="Calibri"/><ns4:ea typeface="Calibri"/></ns4:defRPr></ns4:lvl8pPr><ns4:lvl9pPr algn="r"><ns4:buNone/><ns4:defRPr sz="1000" dirty="0"><ns4:solidFill><ns4:srgbClr val="94A3B8"/></ns4:solidFill><ns4:latin typeface="Calibri"/><ns4:ea typeface="Calibri"/></ns4:defRPr></ns4:lvl9pPr></ns4:lstStyle><ns5:p xmlns:ns5="http://schemas.openxmlformats.org/drawingml/2006/main"><ns5:pPr algn="r"><ns5:buNone/></ns5:pPr><ns5:r><ns5:rPr lang="ja-JP"/><ns5:t>&lt;#&gt;</ns5:t></ns5:r></ns5:p></ns0:txBody></ns0:sp></ns0:spTree></ns0:cSld><ns0:clrMapOvr/></ns0:sldLayout>
+<ns0:sldLayout xmlns:ns0="http://schemas.openxmlformats.org/presentationml/2006/main" type="blank" preserve="1"><ns0:cSld name="KPI.2Value.Equal"><ns0:spTree><ns0:nvGrpSpPr><ns0:cNvPr id="1" name=""/><ns0:cNvGrpSpPr/><ns0:nvPr/></ns0:nvGrpSpPr><ns0:grpSpPr><ns1:xfrm xmlns:ns1="http://schemas.openxmlformats.org/drawingml/2006/main"><ns1:off x="0" y="0"/><ns1:ext cx="0" cy="0"/><ns1:chOff x="0" y="0"/><ns1:chExt cx="0" cy="0"/></ns1:xfrm></ns0:grpSpPr><ns0:sp><ns0:nvSpPr><ns0:cNvPr id="2" name="HeaderBar"/><ns0:cNvSpPr><ns1:spLocks xmlns:ns1="http://schemas.openxmlformats.org/drawingml/2006/main" noGrp="1" noSelect="0" noRot="1" noMove="1"/></ns0:cNvSpPr><ns0:nvPr/></ns0:nvSpPr><ns0:spPr><ns2:xfrm xmlns:ns2="http://schemas.openxmlformats.org/drawingml/2006/main"><ns2:off x="0" y="0"/><ns2:ext cx="12192000" cy="1051560"/></ns2:xfrm><ns3:prstGeom xmlns:ns3="http://schemas.openxmlformats.org/drawingml/2006/main" prst="rect"/><ns4:solidFill xmlns:ns4="http://schemas.openxmlformats.org/drawingml/2006/main"><ns4:srgbClr val="1E2761"/></ns4:solidFill><ns5:ln xmlns:ns5="http://schemas.openxmlformats.org/drawingml/2006/main"><ns5:noFill/></ns5:ln></ns0:spPr></ns0:sp><ns0:sp><ns0:nvSpPr><ns0:cNvPr id="10" name="SlideTitle.Header"/><ns0:cNvSpPr><ns1:spLocks xmlns:ns1="http://schemas.openxmlformats.org/drawingml/2006/main" noGrp="1"/></ns0:cNvSpPr><ns0:nvPr><ns0:ph idx="15" type="body"/></ns0:nvPr></ns0:nvSpPr><ns0:spPr><ns2:xfrm xmlns:ns2="http://schemas.openxmlformats.org/drawingml/2006/main"><ns2:off x="731520" y="91440"/><ns2:ext cx="9144000" cy="475488"/></ns2:xfrm></ns0:spPr><ns0:txBody><ns3:bodyPr xmlns:ns3="http://schemas.openxmlformats.org/drawingml/2006/main" wrap="square" anchor="t" anchorCtr="0"/><ns4:lstStyle><ns4:defPPr><ns4:defRPr sz="2800" b="1"><ns4:solidFill><ns4:srgbClr val="FFFFFF"/></ns4:solidFill></ns4:defRPr></ns4:defPPr></ns4:lstStyle><ns4:defPPr algn="l"><ns4:buNone/><ns4:defRPr sz="2800" dirty="0" b="1"><ns4:solidFill><ns4:srgbClr val="FFFFFF"/></ns4:solidFill><ns4:latin typeface="Georgia"/><ns4:ea typeface="Georgia"/></ns4:defRPr></ns4:defPPr><ns4:lvl1pPr algn="l"><ns4:buNone/><ns4:defRPr sz="2800" dirty="0" b="1"><ns4:solidFill><ns4:srgbClr val="FFFFFF"/></ns4:solidFill><ns4:latin typeface="Georgia"/><ns4:ea typeface="Georgia"/></ns4:defRPr></ns4:lvl1pPr><ns4:lvl2pPr algn="l"><ns4:buNone/><ns4:defRPr sz="2800" dirty="0" b="1"><ns4:solidFill><ns4:srgbClr val="FFFFFF"/></ns4:solidFill><ns4:latin typeface="Georgia"/><ns4:ea typeface="Georgia"/></ns4:defRPr></ns4:lvl2pPr><ns4:lvl3pPr algn="l"><ns4:buNone/><ns4:defRPr sz="2800" dirty="0" b="1"><ns4:solidFill><ns4:srgbClr val="FFFFFF"/></ns4:solidFill><ns4:latin typeface="Georgia"/><ns4:ea typeface="Georgia"/></ns4:defRPr></ns4:lvl3pPr><ns4:lvl4pPr algn="l"><ns4:buNone/><ns4:defRPr sz="2800" dirty="0" b="1"><ns4:solidFill><ns4:srgbClr val="FFFFFF"/></ns4:solidFill><ns4:latin typeface="Georgia"/><ns4:ea typeface="Georgia"/></ns4:defRPr></ns4:lvl4pPr><ns4:lvl5pPr algn="l"><ns4:buNone/><ns4:defRPr sz="2800" dirty="0" b="1"><ns4:solidFill><ns4:srgbClr val="FFFFFF"/></ns4:solidFill><ns4:latin typeface="Georgia"/><ns4:ea typeface="Georgia"/></ns4:defRPr></ns4:lvl5pPr><ns4:lvl6pPr algn="l"><ns4:buNone/><ns4:defRPr sz="2800" dirty="0" b="1"><ns4:solidFill><ns4:srgbClr val="FFFFFF"/></ns4:solidFill><ns4:latin typeface="Georgia"/><ns4:ea typeface="Georgia"/></ns4:defRPr></ns4:lvl6pPr><ns4:lvl7pPr algn="l"><ns4:buNone/><ns4:defRPr sz="2800" dirty="0" b="1"><ns4:solidFill><ns4:srgbClr val="FFFFFF"/></ns4:solidFill><ns4:latin typeface="Georgia"/><ns4:ea typeface="Georgia"/></ns4:defRPr></ns4:lvl7pPr><ns4:lvl8pPr algn="l"><ns4:buNone/><ns4:defRPr sz="2800" dirty="0" b="1"><ns4:solidFill><ns4:srgbClr val="FFFFFF"/></ns4:solidFill><ns4:latin typeface="Georgia"/><ns4:ea typeface="Georgia"/></ns4:defRPr></ns4:lvl8pPr><ns4:lvl9pPr algn="l"><ns4:buNone/><ns4:defRPr sz="2800" dirty="0" b="1"><ns4:solidFill><ns4:srgbClr val="FFFFFF"/></ns4:solidFill><ns4:latin typeface="Georgia"/><ns4:ea typeface="Georgia"/></ns4:defRPr></ns4:lvl9pPr></ns4:lstStyle/><ns5:p xmlns:ns5="http://schemas.openxmlformats.org/drawingml/2006/main"><ns5:pPr algn="l"><ns5:buNone/></ns5:pPr><ns5:r><ns5:rPr lang="ja-JP"/><ns5:t>サブタイトル</ns5:t></ns5:r></ns5:p></ns0:txBody></ns0:sp><ns0:sp><ns0:nvSpPr><ns0:cNvPr id="5" name="Card1"/><ns0:cNvSpPr><ns1:spLocks xmlns:ns1="http://schemas.openxmlformats.org/drawingml/2006/main" noGrp="1" noSelect="0" noRot="1" noMove="1"/></ns0:cNvSpPr><ns0:nvPr/></ns0:nvSpPr><ns0:spPr><ns2:xfrm xmlns:ns2="http://schemas.openxmlformats.org/drawingml/2006/main"><ns2:off x="640080" y="1371600"/><ns2:ext cx="5120640" cy="4754880"/></ns2:xfrm><ns3:prstGeom xmlns:ns3="http://schemas.openxmlformats.org/drawingml/2006/main" prst="roundRect"><ns3:avLst><ns3:gd name="adj" fmla="val 10000"/></ns3:avLst></ns3:prstGeom><ns4:solidFill xmlns:ns4="http://schemas.openxmlformats.org/drawingml/2006/main"><ns4:srgbClr val="EDF0F7"/></ns4:solidFill><ns5:ln xmlns:ns5="http://schemas.openxmlformats.org/drawingml/2006/main"><ns5:noFill/></ns5:ln></ns0:spPr></ns0:sp><ns0:sp><ns0:nvSpPr><ns0:cNvPr id="6" name="Card2"/><ns0:cNvSpPr><ns1:spLocks xmlns:ns1="http://schemas.openxmlformats.org/drawingml/2006/main" noGrp="1" noSelect="0" noRot="1" noMove="1"/></ns0:cNvSpPr><ns0:nvPr/></ns0:nvSpPr><ns0:spPr><ns2:xfrm xmlns:ns2="http://schemas.openxmlformats.org/drawingml/2006/main"><ns2:off x="6126480" y="1371600"/><ns2:ext cx="5303520" cy="4754880"/></ns2:xfrm><ns3:prstGeom xmlns:ns3="http://schemas.openxmlformats.org/drawingml/2006/main" prst="roundRect"><ns3:avLst><ns3:gd name="adj" fmla="val 10000"/></ns3:avLst></ns3:prstGeom><ns4:solidFill xmlns:ns4="http://schemas.openxmlformats.org/drawingml/2006/main"><ns4:srgbClr val="EDF0F7"/></ns4:solidFill><ns5:ln xmlns:ns5="http://schemas.openxmlformats.org/drawingml/2006/main"><ns5:noFill/></ns5:ln></ns0:spPr></ns0:sp><ns0:sp><ns0:nvSpPr><ns0:cNvPr id="7" name="Accent1"/><ns0:cNvSpPr><ns1:spLocks xmlns:ns1="http://schemas.openxmlformats.org/drawingml/2006/main" noGrp="1" noSelect="0" noRot="1" noMove="1"/></ns0:cNvSpPr><ns0:nvPr/></ns0:nvSpPr><ns0:spPr><ns2:xfrm xmlns:ns2="http://schemas.openxmlformats.org/drawingml/2006/main"><ns2:off x="640080" y="1371600"/><ns2:ext cx="5120640" cy="73152"/></ns2:xfrm><ns3:prstGeom xmlns:ns3="http://schemas.openxmlformats.org/drawingml/2006/main" prst="rect"/><ns4:solidFill xmlns:ns4="http://schemas.openxmlformats.org/drawingml/2006/main"><ns4:srgbClr val="3B82F6"/></ns4:solidFill><ns5:ln xmlns:ns5="http://schemas.openxmlformats.org/drawingml/2006/main"><ns5:noFill/></ns5:ln></ns0:spPr></ns0:sp><ns0:sp><ns0:nvSpPr><ns0:cNvPr id="8" name="Accent2"/><ns0:cNvSpPr><ns1:spLocks xmlns:ns1="http://schemas.openxmlformats.org/drawingml/2006/main" noGrp="1" noSelect="0" noRot="1" noMove="1"/></ns0:cNvSpPr><ns0:nvPr/></ns0:nvSpPr><ns0:spPr><ns2:xfrm xmlns:ns2="http://schemas.openxmlformats.org/drawingml/2006/main"><ns2:off x="6126480" y="1371600"/><ns2:ext cx="5303520" cy="73152"/></ns2:xfrm><ns3:prstGeom xmlns:ns3="http://schemas.openxmlformats.org/drawingml/2006/main" prst="rect"/><ns4:solidFill xmlns:ns4="http://schemas.openxmlformats.org/drawingml/2006/main"><ns4:srgbClr val="06B6D4"/></ns4:solidFill><ns5:ln xmlns:ns5="http://schemas.openxmlformats.org/drawingml/2006/main"><ns5:noFill/></ns5:ln></ns0:spPr></ns0:sp><ns0:sp><ns0:nvSpPr><ns0:cNvPr id="20" name="Value1.Left"/><ns0:cNvSpPr><ns1:spLocks xmlns:ns1="http://schemas.openxmlformats.org/drawingml/2006/main" noGrp="1"/></ns0:cNvSpPr><ns0:nvPr><ns0:ph idx="1" type="body"/></ns0:nvPr></ns0:nvSpPr><ns0:spPr><ns2:xfrm xmlns:ns2="http://schemas.openxmlformats.org/drawingml/2006/main"><ns2:off x="1097280" y="1828800"/><ns2:ext cx="4206240" cy="1645920"/></ns2:xfrm></ns0:spPr><ns0:txBody><ns3:bodyPr xmlns:ns3="http://schemas.openxmlformats.org/drawingml/2006/main" wrap="square" anchor="t" anchorCtr="0"/><ns4:lstStyle><ns4:defPPr algn="ctr"><ns4:defRPr sz="6000" b="1"><ns4:solidFill><ns4:srgbClr val="1E2761"/></ns4:solidFill></ns4:defRPr></ns4:defPPr></ns4:lstStyle><ns4:defPPr algn="ctr"><ns4:buNone/><ns4:defRPr sz="6000" dirty="0" b="1"><ns4:solidFill><ns4:srgbClr val="1E2761"/></ns4:solidFill><ns4:latin typeface="Georgia"/><ns4:ea typeface="Georgia"/></ns4:defRPr></ns4:defPPr><ns4:lvl1pPr algn="ctr"><ns4:buNone/><ns4:defRPr sz="6000" dirty="0" b="1"><ns4:solidFill><ns4:srgbClr val="1E2761"/></ns4:solidFill><ns4:latin typeface="Georgia"/><ns4:ea typeface="Georgia"/></ns4:defRPr></ns4:lvl1pPr><ns4:lvl2pPr algn="ctr"><ns4:buNone/><ns4:defRPr sz="6000" dirty="0" b="1"><ns4:solidFill><ns4:srgbClr val="1E2761"/></ns4:solidFill><ns4:latin typeface="Georgia"/><ns4:ea typeface="Georgia"/></ns4:defRPr></ns4:lvl2pPr><ns4:lvl3pPr algn="ctr"><ns4:buNone/><ns4:defRPr sz="6000" dirty="0" b="1"><ns4:solidFill><ns4:srgbClr val="1E2761"/></ns4:solidFill><ns4:latin typeface="Georgia"/><ns4:ea typeface="Georgia"/></ns4:defRPr></ns4:lvl3pPr><ns4:lvl4pPr algn="ctr"><ns4:buNone/><ns4:defRPr sz="6000" dirty="0" b="1"><ns4:solidFill><ns4:srgbClr val="1E2761"/></ns4:solidFill><ns4:latin typeface="Georgia"/><ns4:ea typeface="Georgia"/></ns4:defRPr></ns4:lvl4pPr><ns4:lvl5pPr algn="ctr"><ns4:buNone/><ns4:defRPr sz="6000" dirty="0" b="1"><ns4:solidFill><ns4:srgbClr val="1E2761"/></ns4:solidFill><ns4:latin typeface="Georgia"/><ns4:ea typeface="Georgia"/></ns4:defRPr></ns4:lvl5pPr><ns4:lvl6pPr algn="ctr"><ns4:buNone/><ns4:defRPr sz="6000" dirty="0" b="1"><ns4:solidFill><ns4:srgbClr val="1E2761"/></ns4:solidFill><ns4:latin typeface="Georgia"/><ns4:ea typeface="Georgia"/></ns4:defRPr></ns4:lvl6pPr><ns4:lvl7pPr algn="ctr"><ns4:buNone/><ns4:defRPr sz="6000" dirty="0" b="1"><ns4:solidFill><ns4:srgbClr val="1E2761"/></ns4:solidFill><ns4:latin typeface="Georgia"/><ns4:ea typeface="Georgia"/></ns4:defRPr></ns4:lvl7pPr><ns4:lvl8pPr algn="ctr"><ns4:buNone/><ns4:defRPr sz="6000" dirty="0" b="1"><ns4:solidFill><ns4:srgbClr val="1E2761"/></ns4:solidFill><ns4:latin typeface="Georgia"/><ns4:ea typeface="Georgia"/></ns4:defRPr></ns4:lvl8pPr><ns4:lvl9pPr algn="ctr"><ns4:buNone/><ns4:defRPr sz="6000" dirty="0" b="1"><ns4:solidFill><ns4:srgbClr val="1E2761"/></ns4:solidFill><ns4:latin typeface="Georgia"/><ns4:ea typeface="Georgia"/></ns4:defRPr></ns4:lvl9pPr></ns4:lstStyle/><ns5:p xmlns:ns5="http://schemas.openxmlformats.org/drawingml/2006/main"><ns5:pPr algn="ctr"><ns5:buNone/></ns5:pPr><ns5:r><ns5:rPr lang="ja-JP"/><ns5:t>指標名
+説明テキスト</ns5:t></ns5:r></ns5:p></ns0:txBody></ns0:sp><ns0:sp><ns0:nvSpPr><ns0:cNvPr id="22" name="Value2.Right"/><ns0:cNvSpPr><ns1:spLocks xmlns:ns1="http://schemas.openxmlformats.org/drawingml/2006/main" noGrp="1"/></ns0:cNvSpPr><ns0:nvPr><ns0:ph idx="3" type="body"/></ns0:nvPr></ns0:nvSpPr><ns0:spPr><ns2:xfrm xmlns:ns2="http://schemas.openxmlformats.org/drawingml/2006/main"><ns2:off x="6583680" y="1828800"/><ns2:ext cx="4389120" cy="1645920"/></ns2:xfrm></ns0:spPr><ns0:txBody><ns3:bodyPr xmlns:ns3="http://schemas.openxmlformats.org/drawingml/2006/main" wrap="square" anchor="t" anchorCtr="0"/><ns4:lstStyle><ns4:defPPr algn="ctr"><ns4:defRPr sz="6000" b="1"><ns4:solidFill><ns4:srgbClr val="1E2761"/></ns4:solidFill></ns4:defRPr></ns4:defPPr></ns4:lstStyle><ns4:defPPr algn="ctr"><ns4:buNone/><ns4:defRPr sz="6000" dirty="0" b="1"><ns4:solidFill><ns4:srgbClr val="1E2761"/></ns4:solidFill><ns4:latin typeface="Georgia"/><ns4:ea typeface="Georgia"/></ns4:defRPr></ns4:defPPr><ns4:lvl1pPr algn="ctr"><ns4:buNone/><ns4:defRPr sz="6000" dirty="0" b="1"><ns4:solidFill><ns4:srgbClr val="1E2761"/></ns4:solidFill><ns4:latin typeface="Georgia"/><ns4:ea typeface="Georgia"/></ns4:defRPr></ns4:lvl1pPr><ns4:lvl2pPr algn="ctr"><ns4:buNone/><ns4:defRPr sz="6000" dirty="0" b="1"><ns4:solidFill><ns4:srgbClr val="1E2761"/></ns4:solidFill><ns4:latin typeface="Georgia"/><ns4:ea typeface="Georgia"/></ns4:defRPr></ns4:lvl2pPr><ns4:lvl3pPr algn="ctr"><ns4:buNone/><ns4:defRPr sz="6000" dirty="0" b="1"><ns4:solidFill><ns4:srgbClr val="1E2761"/></ns4:solidFill><ns4:latin typeface="Georgia"/><ns4:ea typeface="Georgia"/></ns4:defRPr></ns4:lvl3pPr><ns4:lvl4pPr algn="ctr"><ns4:buNone/><ns4:defRPr sz="6000" dirty="0" b="1"><ns4:solidFill><ns4:srgbClr val="1E2761"/></ns4:solidFill><ns4:latin typeface="Georgia"/><ns4:ea typeface="Georgia"/></ns4:defRPr></ns4:lvl4pPr><ns4:lvl5pPr algn="ctr"><ns4:buNone/><ns4:defRPr sz="6000" dirty="0" b="1"><ns4:solidFill><ns4:srgbClr val="1E2761"/></ns4:solidFill><ns4:latin typeface="Georgia"/><ns4:ea typeface="Georgia"/></ns4:defRPr></ns4:lvl5pPr><ns4:lvl6pPr algn="ctr"><ns4:buNone/><ns4:defRPr sz="6000" dirty="0" b="1"><ns4:solidFill><ns4:srgbClr val="1E2761"/></ns4:solidFill><ns4:latin typeface="Georgia"/><ns4:ea typeface="Georgia"/></ns4:defRPr></ns4:lvl6pPr><ns4:lvl7pPr algn="ctr"><ns4:buNone/><ns4:defRPr sz="6000" dirty="0" b="1"><ns4:solidFill><ns4:srgbClr val="1E2761"/></ns4:solidFill><ns4:latin typeface="Georgia"/><ns4:ea typeface="Georgia"/></ns4:defRPr></ns4:lvl7pPr><ns4:lvl8pPr algn="ctr"><ns4:buNone/><ns4:defRPr sz="6000" dirty="0" b="1"><ns4:solidFill><ns4:srgbClr val="1E2761"/></ns4:solidFill><ns4:latin typeface="Georgia"/><ns4:ea typeface="Georgia"/></ns4:defRPr></ns4:lvl8pPr><ns4:lvl9pPr algn="ctr"><ns4:buNone/><ns4:defRPr sz="6000" dirty="0" b="1"><ns4:solidFill><ns4:srgbClr val="1E2761"/></ns4:solidFill><ns4:latin typeface="Georgia"/><ns4:ea typeface="Georgia"/></ns4:defRPr></ns4:lvl9pPr></ns4:lstStyle/><ns5:p xmlns:ns5="http://schemas.openxmlformats.org/drawingml/2006/main"><ns5:pPr algn="ctr"><ns5:buNone/></ns5:pPr><ns5:r><ns5:rPr lang="ja-JP"/><ns5:t>指標名
+説明テキスト</ns5:t></ns5:r></ns5:p></ns0:txBody></ns0:sp><ns0:sp><ns0:nvSpPr><ns0:cNvPr id="30" name="SlideNum.Footer"/><ns0:cNvSpPr><ns1:spLocks xmlns:ns1="http://schemas.openxmlformats.org/drawingml/2006/main" noGrp="1"/></ns0:cNvSpPr><ns0:nvPr><ns0:ph idx="50" type="sldNum"/></ns0:nvPr></ns0:nvSpPr><ns0:spPr><ns2:xfrm xmlns:ns2="http://schemas.openxmlformats.org/drawingml/2006/main"><ns2:off x="10972800" y="6446520"/><ns2:ext cx="1097280" cy="274320"/></ns2:xfrm></ns0:spPr><ns0:txBody><ns3:bodyPr xmlns:ns3="http://schemas.openxmlformats.org/drawingml/2006/main" wrap="square" anchor="t" anchorCtr="0"/><ns4:lstStyle><ns4:defPPr algn="r"><ns4:defRPr sz="1000"><ns4:solidFill><ns4:srgbClr val="94A3B8"/></ns4:solidFill></ns4:defRPr></ns4:defPPr></ns4:lstStyle><ns4:defPPr algn="r"><ns4:buNone/><ns4:defRPr sz="1000" dirty="0"><ns4:solidFill><ns4:srgbClr val="94A3B8"/></ns4:solidFill><ns4:latin typeface="Calibri"/><ns4:ea typeface="Calibri"/></ns4:defRPr></ns4:defPPr><ns4:lvl1pPr algn="r"><ns4:buNone/><ns4:defRPr sz="1000" dirty="0"><ns4:solidFill><ns4:srgbClr val="94A3B8"/></ns4:solidFill><ns4:latin typeface="Calibri"/><ns4:ea typeface="Calibri"/></ns4:defRPr></ns4:lvl1pPr><ns4:lvl2pPr algn="r"><ns4:buNone/><ns4:defRPr sz="1000" dirty="0"><ns4:solidFill><ns4:srgbClr val="94A3B8"/></ns4:solidFill><ns4:latin typeface="Calibri"/><ns4:ea typeface="Calibri"/></ns4:defRPr></ns4:lvl2pPr><ns4:lvl3pPr algn="r"><ns4:buNone/><ns4:defRPr sz="1000" dirty="0"><ns4:solidFill><ns4:srgbClr val="94A3B8"/></ns4:solidFill><ns4:latin typeface="Calibri"/><ns4:ea typeface="Calibri"/></ns4:defRPr></ns4:lvl3pPr><ns4:lvl4pPr algn="r"><ns4:buNone/><ns4:defRPr sz="1000" dirty="0"><ns4:solidFill><ns4:srgbClr val="94A3B8"/></ns4:solidFill><ns4:latin typeface="Calibri"/><ns4:ea typeface="Calibri"/></ns4:defRPr></ns4:lvl4pPr><ns4:lvl5pPr algn="r"><ns4:buNone/><ns4:defRPr sz="1000" dirty="0"><ns4:solidFill><ns4:srgbClr val="94A3B8"/></ns4:solidFill><ns4:latin typeface="Calibri"/><ns4:ea typeface="Calibri"/></ns4:defRPr></ns4:lvl5pPr><ns4:lvl6pPr algn="r"><ns4:buNone/><ns4:defRPr sz="1000" dirty="0"><ns4:solidFill><ns4:srgbClr val="94A3B8"/></ns4:solidFill><ns4:latin typeface="Calibri"/><ns4:ea typeface="Calibri"/></ns4:defRPr></ns4:lvl6pPr><ns4:lvl7pPr algn="r"><ns4:buNone/><ns4:defRPr sz="1000" dirty="0"><ns4:solidFill><ns4:srgbClr val="94A3B8"/></ns4:solidFill><ns4:latin typeface="Calibri"/><ns4:ea typeface="Calibri"/></ns4:defRPr></ns4:lvl7pPr><ns4:lvl8pPr algn="r"><ns4:buNone/><ns4:defRPr sz="1000" dirty="0"><ns4:solidFill><ns4:srgbClr val="94A3B8"/></ns4:solidFill><ns4:latin typeface="Calibri"/><ns4:ea typeface="Calibri"/></ns4:defRPr></ns4:lvl8pPr><ns4:lvl9pPr algn="r"><ns4:buNone/><ns4:defRPr sz="1000" dirty="0"><ns4:solidFill><ns4:srgbClr val="94A3B8"/></ns4:solidFill><ns4:latin typeface="Calibri"/><ns4:ea typeface="Calibri"/></ns4:defRPr></ns4:lvl9pPr></ns4:lstStyle><ns5:p xmlns:ns5="http://schemas.openxmlformats.org/drawingml/2006/main"><ns5:pPr algn="r"><ns5:buNone/></ns5:pPr><ns5:r><ns5:rPr lang="ja-JP"/><ns5:t>&lt;#&gt;</ns5:t></ns5:r></ns5:p></ns0:txBody></ns0:sp></ns0:spTree></ns0:cSld><ns0:clrMapOvr/></ns0:sldLayout>
 </file>
 
 <file path=ppt/slideLayouts/slideLayout16.xml><?xml version='1.0' encoding='UTF-8' standalone='yes'?>
-<ns0:sldLayout xmlns:ns0="http://schemas.openxmlformats.org/presentationml/2006/main" type="blank" preserve="1"><ns0:cSld name="KPI.3Value.Equal"><ns0:spTree><ns0:nvGrpSpPr><ns0:cNvPr id="1" name=""/><ns0:cNvGrpSpPr/><ns0:nvPr/></ns0:nvGrpSpPr><ns0:grpSpPr><ns1:xfrm xmlns:ns1="http://schemas.openxmlformats.org/drawingml/2006/main"><ns1:off x="0" y="0"/><ns1:ext cx="0" cy="0"/><ns1:chOff x="0" y="0"/><ns1:chExt cx="0" cy="0"/></ns1:xfrm></ns0:grpSpPr><ns0:sp><ns0:nvSpPr><ns0:cNvPr id="2" name="HeaderBar"/><ns0:cNvSpPr><ns1:spLocks xmlns:ns1="http://schemas.openxmlformats.org/drawingml/2006/main" noGrp="1" noSelect="0" noRot="1" noMove="1"/></ns0:cNvSpPr><ns0:nvPr/></ns0:nvSpPr><ns0:spPr><ns2:xfrm xmlns:ns2="http://schemas.openxmlformats.org/drawingml/2006/main"><ns2:off x="0" y="0"/><ns2:ext cx="12192000" cy="1051560"/></ns2:xfrm><ns3:prstGeom xmlns:ns3="http://schemas.openxmlformats.org/drawingml/2006/main" prst="rect"/><ns4:solidFill xmlns:ns4="http://schemas.openxmlformats.org/drawingml/2006/main"><ns4:srgbClr val="1E2761"/></ns4:solidFill><ns5:ln xmlns:ns5="http://schemas.openxmlformats.org/drawingml/2006/main"><ns5:noFill/></ns5:ln></ns0:spPr></ns0:sp><ns0:sp><ns0:nvSpPr><ns0:cNvPr id="10" name="SlideTitle.Header"/><ns0:cNvSpPr><ns1:spLocks xmlns:ns1="http://schemas.openxmlformats.org/drawingml/2006/main" noGrp="1"/></ns0:cNvSpPr><ns0:nvPr><ns0:ph idx="15" type="body"/></ns0:nvPr></ns0:nvSpPr><ns0:spPr><ns2:xfrm xmlns:ns2="http://schemas.openxmlformats.org/drawingml/2006/main"><ns2:off x="731520" y="91440"/><ns2:ext cx="9144000" cy="475488"/></ns2:xfrm></ns0:spPr><ns0:txBody><ns3:bodyPr xmlns:ns3="http://schemas.openxmlformats.org/drawingml/2006/main" wrap="square" anchor="t" anchorCtr="0"/><ns4:lstStyle xmlns:ns4="http://schemas.openxmlformats.org/drawingml/2006/main"><ns4:defPPr algn="l"><ns4:buNone/><ns4:defRPr sz="2800" dirty="0" b="1"><ns4:solidFill><ns4:srgbClr val="FFFFFF"/></ns4:solidFill><ns4:latin typeface="Georgia"/><ns4:ea typeface="Georgia"/></ns4:defRPr></ns4:defPPr><ns4:lvl1pPr algn="l"><ns4:buNone/><ns4:defRPr sz="2800" dirty="0" b="1"><ns4:solidFill><ns4:srgbClr val="FFFFFF"/></ns4:solidFill><ns4:latin typeface="Georgia"/><ns4:ea typeface="Georgia"/></ns4:defRPr></ns4:lvl1pPr><ns4:lvl2pPr algn="l"><ns4:buNone/><ns4:defRPr sz="2800" dirty="0" b="1"><ns4:solidFill><ns4:srgbClr val="FFFFFF"/></ns4:solidFill><ns4:latin typeface="Georgia"/><ns4:ea typeface="Georgia"/></ns4:defRPr></ns4:lvl2pPr><ns4:lvl3pPr algn="l"><ns4:buNone/><ns4:defRPr sz="2800" dirty="0" b="1"><ns4:solidFill><ns4:srgbClr val="FFFFFF"/></ns4:solidFill><ns4:latin typeface="Georgia"/><ns4:ea typeface="Georgia"/></ns4:defRPr></ns4:lvl3pPr><ns4:lvl4pPr algn="l"><ns4:buNone/><ns4:defRPr sz="2800" dirty="0" b="1"><ns4:solidFill><ns4:srgbClr val="FFFFFF"/></ns4:solidFill><ns4:latin typeface="Georgia"/><ns4:ea typeface="Georgia"/></ns4:defRPr></ns4:lvl4pPr><ns4:lvl5pPr algn="l"><ns4:buNone/><ns4:defRPr sz="2800" dirty="0" b="1"><ns4:solidFill><ns4:srgbClr val="FFFFFF"/></ns4:solidFill><ns4:latin typeface="Georgia"/><ns4:ea typeface="Georgia"/></ns4:defRPr></ns4:lvl5pPr><ns4:lvl6pPr algn="l"><ns4:buNone/><ns4:defRPr sz="2800" dirty="0" b="1"><ns4:solidFill><ns4:srgbClr val="FFFFFF"/></ns4:solidFill><ns4:latin typeface="Georgia"/><ns4:ea typeface="Georgia"/></ns4:defRPr></ns4:lvl6pPr><ns4:lvl7pPr algn="l"><ns4:buNone/><ns4:defRPr sz="2800" dirty="0" b="1"><ns4:solidFill><ns4:srgbClr val="FFFFFF"/></ns4:solidFill><ns4:latin typeface="Georgia"/><ns4:ea typeface="Georgia"/></ns4:defRPr></ns4:lvl7pPr><ns4:lvl8pPr algn="l"><ns4:buNone/><ns4:defRPr sz="2800" dirty="0" b="1"><ns4:solidFill><ns4:srgbClr val="FFFFFF"/></ns4:solidFill><ns4:latin typeface="Georgia"/><ns4:ea typeface="Georgia"/></ns4:defRPr></ns4:lvl8pPr><ns4:lvl9pPr algn="l"><ns4:buNone/><ns4:defRPr sz="2800" dirty="0" b="1"><ns4:solidFill><ns4:srgbClr val="FFFFFF"/></ns4:solidFill><ns4:latin typeface="Georgia"/><ns4:ea typeface="Georgia"/></ns4:defRPr></ns4:lvl9pPr></ns4:lstStyle/><ns5:p xmlns:ns5="http://schemas.openxmlformats.org/drawingml/2006/main"><ns5:pPr algn="l"><ns5:buNone/></ns5:pPr><ns5:r><ns5:rPr lang="ja-JP"/><ns5:t>サブタイトル</ns5:t></ns5:r></ns5:p></ns0:txBody></ns0:sp><ns0:sp><ns0:nvSpPr><ns0:cNvPr id="5" name="Card1"/><ns0:cNvSpPr><ns1:spLocks xmlns:ns1="http://schemas.openxmlformats.org/drawingml/2006/main" noGrp="1" noSelect="0" noRot="1" noMove="1"/></ns0:cNvSpPr><ns0:nvPr/></ns0:nvSpPr><ns0:spPr><ns2:xfrm xmlns:ns2="http://schemas.openxmlformats.org/drawingml/2006/main"><ns2:off x="457200" y="1371600"/><ns2:ext cx="3474720" cy="4754880"/></ns2:xfrm><ns3:prstGeom xmlns:ns3="http://schemas.openxmlformats.org/drawingml/2006/main" prst="roundRect"><ns3:avLst><ns3:gd name="adj" fmla="val 10000"/></ns3:avLst></ns3:prstGeom><ns4:solidFill xmlns:ns4="http://schemas.openxmlformats.org/drawingml/2006/main"><ns4:srgbClr val="EDF0F7"/></ns4:solidFill><ns5:ln xmlns:ns5="http://schemas.openxmlformats.org/drawingml/2006/main"><ns5:noFill/></ns5:ln></ns0:spPr></ns0:sp><ns0:sp><ns0:nvSpPr><ns0:cNvPr id="6" name="Card2"/><ns0:cNvSpPr><ns1:spLocks xmlns:ns1="http://schemas.openxmlformats.org/drawingml/2006/main" noGrp="1" noSelect="0" noRot="1" noMove="1"/></ns0:cNvSpPr><ns0:nvPr/></ns0:nvSpPr><ns0:spPr><ns2:xfrm xmlns:ns2="http://schemas.openxmlformats.org/drawingml/2006/main"><ns2:off x="4206240" y="1371600"/><ns2:ext cx="3657600" cy="4754880"/></ns2:xfrm><ns3:prstGeom xmlns:ns3="http://schemas.openxmlformats.org/drawingml/2006/main" prst="roundRect"><ns3:avLst><ns3:gd name="adj" fmla="val 10000"/></ns3:avLst></ns3:prstGeom><ns4:solidFill xmlns:ns4="http://schemas.openxmlformats.org/drawingml/2006/main"><ns4:srgbClr val="EDF0F7"/></ns4:solidFill><ns5:ln xmlns:ns5="http://schemas.openxmlformats.org/drawingml/2006/main"><ns5:noFill/></ns5:ln></ns0:spPr></ns0:sp><ns0:sp><ns0:nvSpPr><ns0:cNvPr id="7" name="Card3"/><ns0:cNvSpPr><ns1:spLocks xmlns:ns1="http://schemas.openxmlformats.org/drawingml/2006/main" noGrp="1" noSelect="0" noRot="1" noMove="1"/></ns0:cNvSpPr><ns0:nvPr/></ns0:nvSpPr><ns0:spPr><ns2:xfrm xmlns:ns2="http://schemas.openxmlformats.org/drawingml/2006/main"><ns2:off x="8138160" y="1371600"/><ns2:ext cx="3566160" cy="4754880"/></ns2:xfrm><ns3:prstGeom xmlns:ns3="http://schemas.openxmlformats.org/drawingml/2006/main" prst="roundRect"><ns3:avLst><ns3:gd name="adj" fmla="val 10000"/></ns3:avLst></ns3:prstGeom><ns4:solidFill xmlns:ns4="http://schemas.openxmlformats.org/drawingml/2006/main"><ns4:srgbClr val="EDF0F7"/></ns4:solidFill><ns5:ln xmlns:ns5="http://schemas.openxmlformats.org/drawingml/2006/main"><ns5:noFill/></ns5:ln></ns0:spPr></ns0:sp><ns0:sp><ns0:nvSpPr><ns0:cNvPr id="8" name="A1"/><ns0:cNvSpPr><ns1:spLocks xmlns:ns1="http://schemas.openxmlformats.org/drawingml/2006/main" noGrp="1" noSelect="0" noRot="1" noMove="1"/></ns0:cNvSpPr><ns0:nvPr/></ns0:nvSpPr><ns0:spPr><ns2:xfrm xmlns:ns2="http://schemas.openxmlformats.org/drawingml/2006/main"><ns2:off x="457200" y="1371600"/><ns2:ext cx="3474720" cy="54864"/></ns2:xfrm><ns3:prstGeom xmlns:ns3="http://schemas.openxmlformats.org/drawingml/2006/main" prst="rect"/><ns4:solidFill xmlns:ns4="http://schemas.openxmlformats.org/drawingml/2006/main"><ns4:srgbClr val="3B82F6"/></ns4:solidFill><ns5:ln xmlns:ns5="http://schemas.openxmlformats.org/drawingml/2006/main"><ns5:noFill/></ns5:ln></ns0:spPr></ns0:sp><ns0:sp><ns0:nvSpPr><ns0:cNvPr id="9" name="A2"/><ns0:cNvSpPr><ns1:spLocks xmlns:ns1="http://schemas.openxmlformats.org/drawingml/2006/main" noGrp="1" noSelect="0" noRot="1" noMove="1"/></ns0:cNvSpPr><ns0:nvPr/></ns0:nvSpPr><ns0:spPr><ns2:xfrm xmlns:ns2="http://schemas.openxmlformats.org/drawingml/2006/main"><ns2:off x="4206240" y="1371600"/><ns2:ext cx="3657600" cy="54864"/></ns2:xfrm><ns3:prstGeom xmlns:ns3="http://schemas.openxmlformats.org/drawingml/2006/main" prst="rect"/><ns4:solidFill xmlns:ns4="http://schemas.openxmlformats.org/drawingml/2006/main"><ns4:srgbClr val="06B6D4"/></ns4:solidFill><ns5:ln xmlns:ns5="http://schemas.openxmlformats.org/drawingml/2006/main"><ns5:noFill/></ns5:ln></ns0:spPr></ns0:sp><ns0:sp><ns0:nvSpPr><ns0:cNvPr id="10" name="A3"/><ns0:cNvSpPr><ns1:spLocks xmlns:ns1="http://schemas.openxmlformats.org/drawingml/2006/main" noGrp="1" noSelect="0" noRot="1" noMove="1"/></ns0:cNvSpPr><ns0:nvPr/></ns0:nvSpPr><ns0:spPr><ns2:xfrm xmlns:ns2="http://schemas.openxmlformats.org/drawingml/2006/main"><ns2:off x="8138160" y="1371600"/><ns2:ext cx="3566160" cy="54864"/></ns2:xfrm><ns3:prstGeom xmlns:ns3="http://schemas.openxmlformats.org/drawingml/2006/main" prst="rect"/><ns4:solidFill xmlns:ns4="http://schemas.openxmlformats.org/drawingml/2006/main"><ns4:srgbClr val="F59E0B"/></ns4:solidFill><ns5:ln xmlns:ns5="http://schemas.openxmlformats.org/drawingml/2006/main"><ns5:noFill/></ns5:ln></ns0:spPr></ns0:sp><ns0:sp><ns0:nvSpPr><ns0:cNvPr id="20" name="Value1.Left"/><ns0:cNvSpPr><ns1:spLocks xmlns:ns1="http://schemas.openxmlformats.org/drawingml/2006/main" noGrp="1"/></ns0:cNvSpPr><ns0:nvPr><ns0:ph idx="1" type="body"/></ns0:nvPr></ns0:nvSpPr><ns0:spPr><ns2:xfrm xmlns:ns2="http://schemas.openxmlformats.org/drawingml/2006/main"><ns2:off x="731520" y="1828800"/><ns2:ext cx="2926080" cy="1371600"/></ns2:xfrm></ns0:spPr><ns0:txBody><ns3:bodyPr xmlns:ns3="http://schemas.openxmlformats.org/drawingml/2006/main" wrap="square" anchor="t" anchorCtr="0"/><ns4:lstStyle xmlns:ns4="http://schemas.openxmlformats.org/drawingml/2006/main"><ns4:defPPr algn="ctr"><ns4:buNone/><ns4:defRPr sz="5200" dirty="0" b="1"><ns4:solidFill><ns4:srgbClr val="1E2761"/></ns4:solidFill><ns4:latin typeface="Georgia"/><ns4:ea typeface="Georgia"/></ns4:defRPr></ns4:defPPr><ns4:lvl1pPr algn="ctr"><ns4:buNone/><ns4:defRPr sz="5200" dirty="0" b="1"><ns4:solidFill><ns4:srgbClr val="1E2761"/></ns4:solidFill><ns4:latin typeface="Georgia"/><ns4:ea typeface="Georgia"/></ns4:defRPr></ns4:lvl1pPr><ns4:lvl2pPr algn="ctr"><ns4:buNone/><ns4:defRPr sz="5200" dirty="0" b="1"><ns4:solidFill><ns4:srgbClr val="1E2761"/></ns4:solidFill><ns4:latin typeface="Georgia"/><ns4:ea typeface="Georgia"/></ns4:defRPr></ns4:lvl2pPr><ns4:lvl3pPr algn="ctr"><ns4:buNone/><ns4:defRPr sz="5200" dirty="0" b="1"><ns4:solidFill><ns4:srgbClr val="1E2761"/></ns4:solidFill><ns4:latin typeface="Georgia"/><ns4:ea typeface="Georgia"/></ns4:defRPr></ns4:lvl3pPr><ns4:lvl4pPr algn="ctr"><ns4:buNone/><ns4:defRPr sz="5200" dirty="0" b="1"><ns4:solidFill><ns4:srgbClr val="1E2761"/></ns4:solidFill><ns4:latin typeface="Georgia"/><ns4:ea typeface="Georgia"/></ns4:defRPr></ns4:lvl4pPr><ns4:lvl5pPr algn="ctr"><ns4:buNone/><ns4:defRPr sz="5200" dirty="0" b="1"><ns4:solidFill><ns4:srgbClr val="1E2761"/></ns4:solidFill><ns4:latin typeface="Georgia"/><ns4:ea typeface="Georgia"/></ns4:defRPr></ns4:lvl5pPr><ns4:lvl6pPr algn="ctr"><ns4:buNone/><ns4:defRPr sz="5200" dirty="0" b="1"><ns4:solidFill><ns4:srgbClr val="1E2761"/></ns4:solidFill><ns4:latin typeface="Georgia"/><ns4:ea typeface="Georgia"/></ns4:defRPr></ns4:lvl6pPr><ns4:lvl7pPr algn="ctr"><ns4:buNone/><ns4:defRPr sz="5200" dirty="0" b="1"><ns4:solidFill><ns4:srgbClr val="1E2761"/></ns4:solidFill><ns4:latin typeface="Georgia"/><ns4:ea typeface="Georgia"/></ns4:defRPr></ns4:lvl7pPr><ns4:lvl8pPr algn="ctr"><ns4:buNone/><ns4:defRPr sz="5200" dirty="0" b="1"><ns4:solidFill><ns4:srgbClr val="1E2761"/></ns4:solidFill><ns4:latin typeface="Georgia"/><ns4:ea typeface="Georgia"/></ns4:defRPr></ns4:lvl8pPr><ns4:lvl9pPr algn="ctr"><ns4:buNone/><ns4:defRPr sz="5200" dirty="0" b="1"><ns4:solidFill><ns4:srgbClr val="1E2761"/></ns4:solidFill><ns4:latin typeface="Georgia"/><ns4:ea typeface="Georgia"/></ns4:defRPr></ns4:lvl9pPr></ns4:lstStyle/><ns5:p xmlns:ns5="http://schemas.openxmlformats.org/drawingml/2006/main"><ns5:pPr algn="ctr"><ns5:buNone/></ns5:pPr><ns5:r><ns5:rPr lang="ja-JP"/><ns5:t>指標名
-説明</ns5:t></ns5:r></ns5:p></ns0:txBody></ns0:sp><ns0:sp><ns0:nvSpPr><ns0:cNvPr id="22" name="Value2.Center"/><ns0:cNvSpPr><ns1:spLocks xmlns:ns1="http://schemas.openxmlformats.org/drawingml/2006/main" noGrp="1"/></ns0:cNvSpPr><ns0:nvPr><ns0:ph idx="3" type="body"/></ns0:nvPr></ns0:nvSpPr><ns0:spPr><ns2:xfrm xmlns:ns2="http://schemas.openxmlformats.org/drawingml/2006/main"><ns2:off x="4480560" y="1828800"/><ns2:ext cx="3108960" cy="1371600"/></ns2:xfrm></ns0:spPr><ns0:txBody><ns3:bodyPr xmlns:ns3="http://schemas.openxmlformats.org/drawingml/2006/main" wrap="square" anchor="t" anchorCtr="0"/><ns4:lstStyle xmlns:ns4="http://schemas.openxmlformats.org/drawingml/2006/main"><ns4:defPPr algn="ctr"><ns4:buNone/><ns4:defRPr sz="5200" dirty="0" b="1"><ns4:solidFill><ns4:srgbClr val="1E2761"/></ns4:solidFill><ns4:latin typeface="Georgia"/><ns4:ea typeface="Georgia"/></ns4:defRPr></ns4:defPPr><ns4:lvl1pPr algn="ctr"><ns4:buNone/><ns4:defRPr sz="5200" dirty="0" b="1"><ns4:solidFill><ns4:srgbClr val="1E2761"/></ns4:solidFill><ns4:latin typeface="Georgia"/><ns4:ea typeface="Georgia"/></ns4:defRPr></ns4:lvl1pPr><ns4:lvl2pPr algn="ctr"><ns4:buNone/><ns4:defRPr sz="5200" dirty="0" b="1"><ns4:solidFill><ns4:srgbClr val="1E2761"/></ns4:solidFill><ns4:latin typeface="Georgia"/><ns4:ea typeface="Georgia"/></ns4:defRPr></ns4:lvl2pPr><ns4:lvl3pPr algn="ctr"><ns4:buNone/><ns4:defRPr sz="5200" dirty="0" b="1"><ns4:solidFill><ns4:srgbClr val="1E2761"/></ns4:solidFill><ns4:latin typeface="Georgia"/><ns4:ea typeface="Georgia"/></ns4:defRPr></ns4:lvl3pPr><ns4:lvl4pPr algn="ctr"><ns4:buNone/><ns4:defRPr sz="5200" dirty="0" b="1"><ns4:solidFill><ns4:srgbClr val="1E2761"/></ns4:solidFill><ns4:latin typeface="Georgia"/><ns4:ea typeface="Georgia"/></ns4:defRPr></ns4:lvl4pPr><ns4:lvl5pPr algn="ctr"><ns4:buNone/><ns4:defRPr sz="5200" dirty="0" b="1"><ns4:solidFill><ns4:srgbClr val="1E2761"/></ns4:solidFill><ns4:latin typeface="Georgia"/><ns4:ea typeface="Georgia"/></ns4:defRPr></ns4:lvl5pPr><ns4:lvl6pPr algn="ctr"><ns4:buNone/><ns4:defRPr sz="5200" dirty="0" b="1"><ns4:solidFill><ns4:srgbClr val="1E2761"/></ns4:solidFill><ns4:latin typeface="Georgia"/><ns4:ea typeface="Georgia"/></ns4:defRPr></ns4:lvl6pPr><ns4:lvl7pPr algn="ctr"><ns4:buNone/><ns4:defRPr sz="5200" dirty="0" b="1"><ns4:solidFill><ns4:srgbClr val="1E2761"/></ns4:solidFill><ns4:latin typeface="Georgia"/><ns4:ea typeface="Georgia"/></ns4:defRPr></ns4:lvl7pPr><ns4:lvl8pPr algn="ctr"><ns4:buNone/><ns4:defRPr sz="5200" dirty="0" b="1"><ns4:solidFill><ns4:srgbClr val="1E2761"/></ns4:solidFill><ns4:latin typeface="Georgia"/><ns4:ea typeface="Georgia"/></ns4:defRPr></ns4:lvl8pPr><ns4:lvl9pPr algn="ctr"><ns4:buNone/><ns4:defRPr sz="5200" dirty="0" b="1"><ns4:solidFill><ns4:srgbClr val="1E2761"/></ns4:solidFill><ns4:latin typeface="Georgia"/><ns4:ea typeface="Georgia"/></ns4:defRPr></ns4:lvl9pPr></ns4:lstStyle/><ns5:p xmlns:ns5="http://schemas.openxmlformats.org/drawingml/2006/main"><ns5:pPr algn="ctr"><ns5:buNone/></ns5:pPr><ns5:r><ns5:rPr lang="ja-JP"/><ns5:t>指標名
-説明</ns5:t></ns5:r></ns5:p></ns0:txBody></ns0:sp><ns0:sp><ns0:nvSpPr><ns0:cNvPr id="24" name="Value3.Right"/><ns0:cNvSpPr><ns1:spLocks xmlns:ns1="http://schemas.openxmlformats.org/drawingml/2006/main" noGrp="1"/></ns0:cNvSpPr><ns0:nvPr><ns0:ph idx="5" type="body"/></ns0:nvPr></ns0:nvSpPr><ns0:spPr><ns2:xfrm xmlns:ns2="http://schemas.openxmlformats.org/drawingml/2006/main"><ns2:off x="8412480" y="1828800"/><ns2:ext cx="3017520" cy="1371600"/></ns2:xfrm></ns0:spPr><ns0:txBody><ns3:bodyPr xmlns:ns3="http://schemas.openxmlformats.org/drawingml/2006/main" wrap="square" anchor="t" anchorCtr="0"/><ns4:lstStyle xmlns:ns4="http://schemas.openxmlformats.org/drawingml/2006/main"><ns4:defPPr algn="ctr"><ns4:buNone/><ns4:defRPr sz="5200" dirty="0" b="1"><ns4:solidFill><ns4:srgbClr val="1E2761"/></ns4:solidFill><ns4:latin typeface="Georgia"/><ns4:ea typeface="Georgia"/></ns4:defRPr></ns4:defPPr><ns4:lvl1pPr algn="ctr"><ns4:buNone/><ns4:defRPr sz="5200" dirty="0" b="1"><ns4:solidFill><ns4:srgbClr val="1E2761"/></ns4:solidFill><ns4:latin typeface="Georgia"/><ns4:ea typeface="Georgia"/></ns4:defRPr></ns4:lvl1pPr><ns4:lvl2pPr algn="ctr"><ns4:buNone/><ns4:defRPr sz="5200" dirty="0" b="1"><ns4:solidFill><ns4:srgbClr val="1E2761"/></ns4:solidFill><ns4:latin typeface="Georgia"/><ns4:ea typeface="Georgia"/></ns4:defRPr></ns4:lvl2pPr><ns4:lvl3pPr algn="ctr"><ns4:buNone/><ns4:defRPr sz="5200" dirty="0" b="1"><ns4:solidFill><ns4:srgbClr val="1E2761"/></ns4:solidFill><ns4:latin typeface="Georgia"/><ns4:ea typeface="Georgia"/></ns4:defRPr></ns4:lvl3pPr><ns4:lvl4pPr algn="ctr"><ns4:buNone/><ns4:defRPr sz="5200" dirty="0" b="1"><ns4:solidFill><ns4:srgbClr val="1E2761"/></ns4:solidFill><ns4:latin typeface="Georgia"/><ns4:ea typeface="Georgia"/></ns4:defRPr></ns4:lvl4pPr><ns4:lvl5pPr algn="ctr"><ns4:buNone/><ns4:defRPr sz="5200" dirty="0" b="1"><ns4:solidFill><ns4:srgbClr val="1E2761"/></ns4:solidFill><ns4:latin typeface="Georgia"/><ns4:ea typeface="Georgia"/></ns4:defRPr></ns4:lvl5pPr><ns4:lvl6pPr algn="ctr"><ns4:buNone/><ns4:defRPr sz="5200" dirty="0" b="1"><ns4:solidFill><ns4:srgbClr val="1E2761"/></ns4:solidFill><ns4:latin typeface="Georgia"/><ns4:ea typeface="Georgia"/></ns4:defRPr></ns4:lvl6pPr><ns4:lvl7pPr algn="ctr"><ns4:buNone/><ns4:defRPr sz="5200" dirty="0" b="1"><ns4:solidFill><ns4:srgbClr val="1E2761"/></ns4:solidFill><ns4:latin typeface="Georgia"/><ns4:ea typeface="Georgia"/></ns4:defRPr></ns4:lvl7pPr><ns4:lvl8pPr algn="ctr"><ns4:buNone/><ns4:defRPr sz="5200" dirty="0" b="1"><ns4:solidFill><ns4:srgbClr val="1E2761"/></ns4:solidFill><ns4:latin typeface="Georgia"/><ns4:ea typeface="Georgia"/></ns4:defRPr></ns4:lvl8pPr><ns4:lvl9pPr algn="ctr"><ns4:buNone/><ns4:defRPr sz="5200" dirty="0" b="1"><ns4:solidFill><ns4:srgbClr val="1E2761"/></ns4:solidFill><ns4:latin typeface="Georgia"/><ns4:ea typeface="Georgia"/></ns4:defRPr></ns4:lvl9pPr></ns4:lstStyle/><ns5:p xmlns:ns5="http://schemas.openxmlformats.org/drawingml/2006/main"><ns5:pPr algn="ctr"><ns5:buNone/></ns5:pPr><ns5:r><ns5:rPr lang="ja-JP"/><ns5:t>指標名
-説明</ns5:t></ns5:r></ns5:p></ns0:txBody></ns0:sp><ns0:sp><ns0:nvSpPr><ns0:cNvPr id="31" name="SlideNum.Footer"/><ns0:cNvSpPr><ns1:spLocks xmlns:ns1="http://schemas.openxmlformats.org/drawingml/2006/main" noGrp="1"/></ns0:cNvSpPr><ns0:nvPr><ns0:ph idx="50" type="sldNum"/></ns0:nvPr></ns0:nvSpPr><ns0:spPr><ns2:xfrm xmlns:ns2="http://schemas.openxmlformats.org/drawingml/2006/main"><ns2:off x="10972800" y="6446520"/><ns2:ext cx="1097280" cy="274320"/></ns2:xfrm></ns0:spPr><ns0:txBody><ns3:bodyPr xmlns:ns3="http://schemas.openxmlformats.org/drawingml/2006/main" wrap="square" anchor="t" anchorCtr="0"/><ns4:lstStyle xmlns:ns4="http://schemas.openxmlformats.org/drawingml/2006/main"><ns4:defPPr algn="r"><ns4:buNone/><ns4:defRPr sz="1000" dirty="0"><ns4:solidFill><ns4:srgbClr val="94A3B8"/></ns4:solidFill><ns4:latin typeface="Calibri"/><ns4:ea typeface="Calibri"/></ns4:defRPr></ns4:defPPr><ns4:lvl1pPr algn="r"><ns4:buNone/><ns4:defRPr sz="1000" dirty="0"><ns4:solidFill><ns4:srgbClr val="94A3B8"/></ns4:solidFill><ns4:latin typeface="Calibri"/><ns4:ea typeface="Calibri"/></ns4:defRPr></ns4:lvl1pPr><ns4:lvl2pPr algn="r"><ns4:buNone/><ns4:defRPr sz="1000" dirty="0"><ns4:solidFill><ns4:srgbClr val="94A3B8"/></ns4:solidFill><ns4:latin typeface="Calibri"/><ns4:ea typeface="Calibri"/></ns4:defRPr></ns4:lvl2pPr><ns4:lvl3pPr algn="r"><ns4:buNone/><ns4:defRPr sz="1000" dirty="0"><ns4:solidFill><ns4:srgbClr val="94A3B8"/></ns4:solidFill><ns4:latin typeface="Calibri"/><ns4:ea typeface="Calibri"/></ns4:defRPr></ns4:lvl3pPr><ns4:lvl4pPr algn="r"><ns4:buNone/><ns4:defRPr sz="1000" dirty="0"><ns4:solidFill><ns4:srgbClr val="94A3B8"/></ns4:solidFill><ns4:latin typeface="Calibri"/><ns4:ea typeface="Calibri"/></ns4:defRPr></ns4:lvl4pPr><ns4:lvl5pPr algn="r"><ns4:buNone/><ns4:defRPr sz="1000" dirty="0"><ns4:solidFill><ns4:srgbClr val="94A3B8"/></ns4:solidFill><ns4:latin typeface="Calibri"/><ns4:ea typeface="Calibri"/></ns4:defRPr></ns4:lvl5pPr><ns4:lvl6pPr algn="r"><ns4:buNone/><ns4:defRPr sz="1000" dirty="0"><ns4:solidFill><ns4:srgbClr val="94A3B8"/></ns4:solidFill><ns4:latin typeface="Calibri"/><ns4:ea typeface="Calibri"/></ns4:defRPr></ns4:lvl6pPr><ns4:lvl7pPr algn="r"><ns4:buNone/><ns4:defRPr sz="1000" dirty="0"><ns4:solidFill><ns4:srgbClr val="94A3B8"/></ns4:solidFill><ns4:latin typeface="Calibri"/><ns4:ea typeface="Calibri"/></ns4:defRPr></ns4:lvl7pPr><ns4:lvl8pPr algn="r"><ns4:buNone/><ns4:defRPr sz="1000" dirty="0"><ns4:solidFill><ns4:srgbClr val="94A3B8"/></ns4:solidFill><ns4:latin typeface="Calibri"/><ns4:ea typeface="Calibri"/></ns4:defRPr></ns4:lvl8pPr><ns4:lvl9pPr algn="r"><ns4:buNone/><ns4:defRPr sz="1000" dirty="0"><ns4:solidFill><ns4:srgbClr val="94A3B8"/></ns4:solidFill><ns4:latin typeface="Calibri"/><ns4:ea typeface="Calibri"/></ns4:defRPr></ns4:lvl9pPr></ns4:lstStyle><ns5:p xmlns:ns5="http://schemas.openxmlformats.org/drawingml/2006/main"><ns5:pPr algn="r"><ns5:buNone/></ns5:pPr><ns5:r><ns5:rPr lang="ja-JP"/><ns5:t>&lt;#&gt;</ns5:t></ns5:r></ns5:p></ns0:txBody></ns0:sp></ns0:spTree></ns0:cSld><ns0:clrMapOvr/></ns0:sldLayout>
+<ns0:sldLayout xmlns:ns0="http://schemas.openxmlformats.org/presentationml/2006/main" type="blank" preserve="1"><ns0:cSld name="KPI.3Value.Equal"><ns0:spTree><ns0:nvGrpSpPr><ns0:cNvPr id="1" name=""/><ns0:cNvGrpSpPr/><ns0:nvPr/></ns0:nvGrpSpPr><ns0:grpSpPr><ns1:xfrm xmlns:ns1="http://schemas.openxmlformats.org/drawingml/2006/main"><ns1:off x="0" y="0"/><ns1:ext cx="0" cy="0"/><ns1:chOff x="0" y="0"/><ns1:chExt cx="0" cy="0"/></ns1:xfrm></ns0:grpSpPr><ns0:sp><ns0:nvSpPr><ns0:cNvPr id="2" name="HeaderBar"/><ns0:cNvSpPr><ns1:spLocks xmlns:ns1="http://schemas.openxmlformats.org/drawingml/2006/main" noGrp="1" noSelect="0" noRot="1" noMove="1"/></ns0:cNvSpPr><ns0:nvPr/></ns0:nvSpPr><ns0:spPr><ns2:xfrm xmlns:ns2="http://schemas.openxmlformats.org/drawingml/2006/main"><ns2:off x="0" y="0"/><ns2:ext cx="12192000" cy="1051560"/></ns2:xfrm><ns3:prstGeom xmlns:ns3="http://schemas.openxmlformats.org/drawingml/2006/main" prst="rect"/><ns4:solidFill xmlns:ns4="http://schemas.openxmlformats.org/drawingml/2006/main"><ns4:srgbClr val="1E2761"/></ns4:solidFill><ns5:ln xmlns:ns5="http://schemas.openxmlformats.org/drawingml/2006/main"><ns5:noFill/></ns5:ln></ns0:spPr></ns0:sp><ns0:sp><ns0:nvSpPr><ns0:cNvPr id="10" name="SlideTitle.Header"/><ns0:cNvSpPr><ns1:spLocks xmlns:ns1="http://schemas.openxmlformats.org/drawingml/2006/main" noGrp="1"/></ns0:cNvSpPr><ns0:nvPr><ns0:ph idx="15" type="body"/></ns0:nvPr></ns0:nvSpPr><ns0:spPr><ns2:xfrm xmlns:ns2="http://schemas.openxmlformats.org/drawingml/2006/main"><ns2:off x="731520" y="91440"/><ns2:ext cx="9144000" cy="475488"/></ns2:xfrm></ns0:spPr><ns0:txBody><ns3:bodyPr xmlns:ns3="http://schemas.openxmlformats.org/drawingml/2006/main" wrap="square" anchor="t" anchorCtr="0"/><ns4:lstStyle><ns4:defPPr><ns4:defRPr sz="2800" b="1"><ns4:solidFill><ns4:srgbClr val="FFFFFF"/></ns4:solidFill></ns4:defRPr></ns4:defPPr></ns4:lstStyle><ns4:defPPr algn="l"><ns4:buNone/><ns4:defRPr sz="2800" dirty="0" b="1"><ns4:solidFill><ns4:srgbClr val="FFFFFF"/></ns4:solidFill><ns4:latin typeface="Georgia"/><ns4:ea typeface="Georgia"/></ns4:defRPr></ns4:defPPr><ns4:lvl1pPr algn="l"><ns4:buNone/><ns4:defRPr sz="2800" dirty="0" b="1"><ns4:solidFill><ns4:srgbClr val="FFFFFF"/></ns4:solidFill><ns4:latin typeface="Georgia"/><ns4:ea typeface="Georgia"/></ns4:defRPr></ns4:lvl1pPr><ns4:lvl2pPr algn="l"><ns4:buNone/><ns4:defRPr sz="2800" dirty="0" b="1"><ns4:solidFill><ns4:srgbClr val="FFFFFF"/></ns4:solidFill><ns4:latin typeface="Georgia"/><ns4:ea typeface="Georgia"/></ns4:defRPr></ns4:lvl2pPr><ns4:lvl3pPr algn="l"><ns4:buNone/><ns4:defRPr sz="2800" dirty="0" b="1"><ns4:solidFill><ns4:srgbClr val="FFFFFF"/></ns4:solidFill><ns4:latin typeface="Georgia"/><ns4:ea typeface="Georgia"/></ns4:defRPr></ns4:lvl3pPr><ns4:lvl4pPr algn="l"><ns4:buNone/><ns4:defRPr sz="2800" dirty="0" b="1"><ns4:solidFill><ns4:srgbClr val="FFFFFF"/></ns4:solidFill><ns4:latin typeface="Georgia"/><ns4:ea typeface="Georgia"/></ns4:defRPr></ns4:lvl4pPr><ns4:lvl5pPr algn="l"><ns4:buNone/><ns4:defRPr sz="2800" dirty="0" b="1"><ns4:solidFill><ns4:srgbClr val="FFFFFF"/></ns4:solidFill><ns4:latin typeface="Georgia"/><ns4:ea typeface="Georgia"/></ns4:defRPr></ns4:lvl5pPr><ns4:lvl6pPr algn="l"><ns4:buNone/><ns4:defRPr sz="2800" dirty="0" b="1"><ns4:solidFill><ns4:srgbClr val="FFFFFF"/></ns4:solidFill><ns4:latin typeface="Georgia"/><ns4:ea typeface="Georgia"/></ns4:defRPr></ns4:lvl6pPr><ns4:lvl7pPr algn="l"><ns4:buNone/><ns4:defRPr sz="2800" dirty="0" b="1"><ns4:solidFill><ns4:srgbClr val="FFFFFF"/></ns4:solidFill><ns4:latin typeface="Georgia"/><ns4:ea typeface="Georgia"/></ns4:defRPr></ns4:lvl7pPr><ns4:lvl8pPr algn="l"><ns4:buNone/><ns4:defRPr sz="2800" dirty="0" b="1"><ns4:solidFill><ns4:srgbClr val="FFFFFF"/></ns4:solidFill><ns4:latin typeface="Georgia"/><ns4:ea typeface="Georgia"/></ns4:defRPr></ns4:lvl8pPr><ns4:lvl9pPr algn="l"><ns4:buNone/><ns4:defRPr sz="2800" dirty="0" b="1"><ns4:solidFill><ns4:srgbClr val="FFFFFF"/></ns4:solidFill><ns4:latin typeface="Georgia"/><ns4:ea typeface="Georgia"/></ns4:defRPr></ns4:lvl9pPr></ns4:lstStyle/><ns5:p xmlns:ns5="http://schemas.openxmlformats.org/drawingml/2006/main"><ns5:pPr algn="l"><ns5:buNone/></ns5:pPr><ns5:r><ns5:rPr lang="ja-JP"/><ns5:t>サブタイトル</ns5:t></ns5:r></ns5:p></ns0:txBody></ns0:sp><ns0:sp><ns0:nvSpPr><ns0:cNvPr id="5" name="Card1"/><ns0:cNvSpPr><ns1:spLocks xmlns:ns1="http://schemas.openxmlformats.org/drawingml/2006/main" noGrp="1" noSelect="0" noRot="1" noMove="1"/></ns0:cNvSpPr><ns0:nvPr/></ns0:nvSpPr><ns0:spPr><ns2:xfrm xmlns:ns2="http://schemas.openxmlformats.org/drawingml/2006/main"><ns2:off x="457200" y="1371600"/><ns2:ext cx="3474720" cy="4754880"/></ns2:xfrm><ns3:prstGeom xmlns:ns3="http://schemas.openxmlformats.org/drawingml/2006/main" prst="roundRect"><ns3:avLst><ns3:gd name="adj" fmla="val 10000"/></ns3:avLst></ns3:prstGeom><ns4:solidFill xmlns:ns4="http://schemas.openxmlformats.org/drawingml/2006/main"><ns4:srgbClr val="EDF0F7"/></ns4:solidFill><ns5:ln xmlns:ns5="http://schemas.openxmlformats.org/drawingml/2006/main"><ns5:noFill/></ns5:ln></ns0:spPr></ns0:sp><ns0:sp><ns0:nvSpPr><ns0:cNvPr id="6" name="Card2"/><ns0:cNvSpPr><ns1:spLocks xmlns:ns1="http://schemas.openxmlformats.org/drawingml/2006/main" noGrp="1" noSelect="0" noRot="1" noMove="1"/></ns0:cNvSpPr><ns0:nvPr/></ns0:nvSpPr><ns0:spPr><ns2:xfrm xmlns:ns2="http://schemas.openxmlformats.org/drawingml/2006/main"><ns2:off x="4206240" y="1371600"/><ns2:ext cx="3657600" cy="4754880"/></ns2:xfrm><ns3:prstGeom xmlns:ns3="http://schemas.openxmlformats.org/drawingml/2006/main" prst="roundRect"><ns3:avLst><ns3:gd name="adj" fmla="val 10000"/></ns3:avLst></ns3:prstGeom><ns4:solidFill xmlns:ns4="http://schemas.openxmlformats.org/drawingml/2006/main"><ns4:srgbClr val="EDF0F7"/></ns4:solidFill><ns5:ln xmlns:ns5="http://schemas.openxmlformats.org/drawingml/2006/main"><ns5:noFill/></ns5:ln></ns0:spPr></ns0:sp><ns0:sp><ns0:nvSpPr><ns0:cNvPr id="7" name="Card3"/><ns0:cNvSpPr><ns1:spLocks xmlns:ns1="http://schemas.openxmlformats.org/drawingml/2006/main" noGrp="1" noSelect="0" noRot="1" noMove="1"/></ns0:cNvSpPr><ns0:nvPr/></ns0:nvSpPr><ns0:spPr><ns2:xfrm xmlns:ns2="http://schemas.openxmlformats.org/drawingml/2006/main"><ns2:off x="8138160" y="1371600"/><ns2:ext cx="3566160" cy="4754880"/></ns2:xfrm><ns3:prstGeom xmlns:ns3="http://schemas.openxmlformats.org/drawingml/2006/main" prst="roundRect"><ns3:avLst><ns3:gd name="adj" fmla="val 10000"/></ns3:avLst></ns3:prstGeom><ns4:solidFill xmlns:ns4="http://schemas.openxmlformats.org/drawingml/2006/main"><ns4:srgbClr val="EDF0F7"/></ns4:solidFill><ns5:ln xmlns:ns5="http://schemas.openxmlformats.org/drawingml/2006/main"><ns5:noFill/></ns5:ln></ns0:spPr></ns0:sp><ns0:sp><ns0:nvSpPr><ns0:cNvPr id="8" name="A1"/><ns0:cNvSpPr><ns1:spLocks xmlns:ns1="http://schemas.openxmlformats.org/drawingml/2006/main" noGrp="1" noSelect="0" noRot="1" noMove="1"/></ns0:cNvSpPr><ns0:nvPr/></ns0:nvSpPr><ns0:spPr><ns2:xfrm xmlns:ns2="http://schemas.openxmlformats.org/drawingml/2006/main"><ns2:off x="457200" y="1371600"/><ns2:ext cx="3474720" cy="54864"/></ns2:xfrm><ns3:prstGeom xmlns:ns3="http://schemas.openxmlformats.org/drawingml/2006/main" prst="rect"/><ns4:solidFill xmlns:ns4="http://schemas.openxmlformats.org/drawingml/2006/main"><ns4:srgbClr val="3B82F6"/></ns4:solidFill><ns5:ln xmlns:ns5="http://schemas.openxmlformats.org/drawingml/2006/main"><ns5:noFill/></ns5:ln></ns0:spPr></ns0:sp><ns0:sp><ns0:nvSpPr><ns0:cNvPr id="9" name="A2"/><ns0:cNvSpPr><ns1:spLocks xmlns:ns1="http://schemas.openxmlformats.org/drawingml/2006/main" noGrp="1" noSelect="0" noRot="1" noMove="1"/></ns0:cNvSpPr><ns0:nvPr/></ns0:nvSpPr><ns0:spPr><ns2:xfrm xmlns:ns2="http://schemas.openxmlformats.org/drawingml/2006/main"><ns2:off x="4206240" y="1371600"/><ns2:ext cx="3657600" cy="54864"/></ns2:xfrm><ns3:prstGeom xmlns:ns3="http://schemas.openxmlformats.org/drawingml/2006/main" prst="rect"/><ns4:solidFill xmlns:ns4="http://schemas.openxmlformats.org/drawingml/2006/main"><ns4:srgbClr val="06B6D4"/></ns4:solidFill><ns5:ln xmlns:ns5="http://schemas.openxmlformats.org/drawingml/2006/main"><ns5:noFill/></ns5:ln></ns0:spPr></ns0:sp><ns0:sp><ns0:nvSpPr><ns0:cNvPr id="10" name="A3"/><ns0:cNvSpPr><ns1:spLocks xmlns:ns1="http://schemas.openxmlformats.org/drawingml/2006/main" noGrp="1" noSelect="0" noRot="1" noMove="1"/></ns0:cNvSpPr><ns0:nvPr/></ns0:nvSpPr><ns0:spPr><ns2:xfrm xmlns:ns2="http://schemas.openxmlformats.org/drawingml/2006/main"><ns2:off x="8138160" y="1371600"/><ns2:ext cx="3566160" cy="54864"/></ns2:xfrm><ns3:prstGeom xmlns:ns3="http://schemas.openxmlformats.org/drawingml/2006/main" prst="rect"/><ns4:solidFill xmlns:ns4="http://schemas.openxmlformats.org/drawingml/2006/main"><ns4:srgbClr val="F59E0B"/></ns4:solidFill><ns5:ln xmlns:ns5="http://schemas.openxmlformats.org/drawingml/2006/main"><ns5:noFill/></ns5:ln></ns0:spPr></ns0:sp><ns0:sp><ns0:nvSpPr><ns0:cNvPr id="20" name="Value1.Left"/><ns0:cNvSpPr><ns1:spLocks xmlns:ns1="http://schemas.openxmlformats.org/drawingml/2006/main" noGrp="1"/></ns0:cNvSpPr><ns0:nvPr><ns0:ph idx="1" type="body"/></ns0:nvPr></ns0:nvSpPr><ns0:spPr><ns2:xfrm xmlns:ns2="http://schemas.openxmlformats.org/drawingml/2006/main"><ns2:off x="731520" y="1828800"/><ns2:ext cx="2926080" cy="1371600"/></ns2:xfrm></ns0:spPr><ns0:txBody><ns3:bodyPr xmlns:ns3="http://schemas.openxmlformats.org/drawingml/2006/main" wrap="square" anchor="t" anchorCtr="0"/><ns4:lstStyle><ns4:defPPr algn="ctr"><ns4:defRPr sz="5200" b="1"><ns4:solidFill><ns4:srgbClr val="1E2761"/></ns4:solidFill></ns4:defRPr></ns4:defPPr></ns4:lstStyle><ns4:defPPr algn="ctr"><ns4:buNone/><ns4:defRPr sz="5200" dirty="0" b="1"><ns4:solidFill><ns4:srgbClr val="1E2761"/></ns4:solidFill><ns4:latin typeface="Georgia"/><ns4:ea typeface="Georgia"/></ns4:defRPr></ns4:defPPr><ns4:lvl1pPr algn="ctr"><ns4:buNone/><ns4:defRPr sz="5200" dirty="0" b="1"><ns4:solidFill><ns4:srgbClr val="1E2761"/></ns4:solidFill><ns4:latin typeface="Georgia"/><ns4:ea typeface="Georgia"/></ns4:defRPr></ns4:lvl1pPr><ns4:lvl2pPr algn="ctr"><ns4:buNone/><ns4:defRPr sz="5200" dirty="0" b="1"><ns4:solidFill><ns4:srgbClr val="1E2761"/></ns4:solidFill><ns4:latin typeface="Georgia"/><ns4:ea typeface="Georgia"/></ns4:defRPr></ns4:lvl2pPr><ns4:lvl3pPr algn="ctr"><ns4:buNone/><ns4:defRPr sz="5200" dirty="0" b="1"><ns4:solidFill><ns4:srgbClr val="1E2761"/></ns4:solidFill><ns4:latin typeface="Georgia"/><ns4:ea typeface="Georgia"/></ns4:defRPr></ns4:lvl3pPr><ns4:lvl4pPr algn="ctr"><ns4:buNone/><ns4:defRPr sz="5200" dirty="0" b="1"><ns4:solidFill><ns4:srgbClr val="1E2761"/></ns4:solidFill><ns4:latin typeface="Georgia"/><ns4:ea typeface="Georgia"/></ns4:defRPr></ns4:lvl4pPr><ns4:lvl5pPr algn="ctr"><ns4:buNone/><ns4:defRPr sz="5200" dirty="0" b="1"><ns4:solidFill><ns4:srgbClr val="1E2761"/></ns4:solidFill><ns4:latin typeface="Georgia"/><ns4:ea typeface="Georgia"/></ns4:defRPr></ns4:lvl5pPr><ns4:lvl6pPr algn="ctr"><ns4:buNone/><ns4:defRPr sz="5200" dirty="0" b="1"><ns4:solidFill><ns4:srgbClr val="1E2761"/></ns4:solidFill><ns4:latin typeface="Georgia"/><ns4:ea typeface="Georgia"/></ns4:defRPr></ns4:lvl6pPr><ns4:lvl7pPr algn="ctr"><ns4:buNone/><ns4:defRPr sz="5200" dirty="0" b="1"><ns4:solidFill><ns4:srgbClr val="1E2761"/></ns4:solidFill><ns4:latin typeface="Georgia"/><ns4:ea typeface="Georgia"/></ns4:defRPr></ns4:lvl7pPr><ns4:lvl8pPr algn="ctr"><ns4:buNone/><ns4:defRPr sz="5200" dirty="0" b="1"><ns4:solidFill><ns4:srgbClr val="1E2761"/></ns4:solidFill><ns4:latin typeface="Georgia"/><ns4:ea typeface="Georgia"/></ns4:defRPr></ns4:lvl8pPr><ns4:lvl9pPr algn="ctr"><ns4:buNone/><ns4:defRPr sz="5200" dirty="0" b="1"><ns4:solidFill><ns4:srgbClr val="1E2761"/></ns4:solidFill><ns4:latin typeface="Georgia"/><ns4:ea typeface="Georgia"/></ns4:defRPr></ns4:lvl9pPr></ns4:lstStyle/><ns5:p xmlns:ns5="http://schemas.openxmlformats.org/drawingml/2006/main"><ns5:pPr algn="ctr"><ns5:buNone/></ns5:pPr><ns5:r><ns5:rPr lang="ja-JP"/><ns5:t>指標名
+説明</ns5:t></ns5:r></ns5:p></ns0:txBody></ns0:sp><ns0:sp><ns0:nvSpPr><ns0:cNvPr id="22" name="Value2.Center"/><ns0:cNvSpPr><ns1:spLocks xmlns:ns1="http://schemas.openxmlformats.org/drawingml/2006/main" noGrp="1"/></ns0:cNvSpPr><ns0:nvPr><ns0:ph idx="3" type="body"/></ns0:nvPr></ns0:nvSpPr><ns0:spPr><ns2:xfrm xmlns:ns2="http://schemas.openxmlformats.org/drawingml/2006/main"><ns2:off x="4480560" y="1828800"/><ns2:ext cx="3108960" cy="1371600"/></ns2:xfrm></ns0:spPr><ns0:txBody><ns3:bodyPr xmlns:ns3="http://schemas.openxmlformats.org/drawingml/2006/main" wrap="square" anchor="t" anchorCtr="0"/><ns4:lstStyle><ns4:defPPr algn="ctr"><ns4:defRPr sz="5200" b="1"><ns4:solidFill><ns4:srgbClr val="1E2761"/></ns4:solidFill></ns4:defRPr></ns4:defPPr></ns4:lstStyle><ns4:defPPr algn="ctr"><ns4:buNone/><ns4:defRPr sz="5200" dirty="0" b="1"><ns4:solidFill><ns4:srgbClr val="1E2761"/></ns4:solidFill><ns4:latin typeface="Georgia"/><ns4:ea typeface="Georgia"/></ns4:defRPr></ns4:defPPr><ns4:lvl1pPr algn="ctr"><ns4:buNone/><ns4:defRPr sz="5200" dirty="0" b="1"><ns4:solidFill><ns4:srgbClr val="1E2761"/></ns4:solidFill><ns4:latin typeface="Georgia"/><ns4:ea typeface="Georgia"/></ns4:defRPr></ns4:lvl1pPr><ns4:lvl2pPr algn="ctr"><ns4:buNone/><ns4:defRPr sz="5200" dirty="0" b="1"><ns4:solidFill><ns4:srgbClr val="1E2761"/></ns4:solidFill><ns4:latin typeface="Georgia"/><ns4:ea typeface="Georgia"/></ns4:defRPr></ns4:lvl2pPr><ns4:lvl3pPr algn="ctr"><ns4:buNone/><ns4:defRPr sz="5200" dirty="0" b="1"><ns4:solidFill><ns4:srgbClr val="1E2761"/></ns4:solidFill><ns4:latin typeface="Georgia"/><ns4:ea typeface="Georgia"/></ns4:defRPr></ns4:lvl3pPr><ns4:lvl4pPr algn="ctr"><ns4:buNone/><ns4:defRPr sz="5200" dirty="0" b="1"><ns4:solidFill><ns4:srgbClr val="1E2761"/></ns4:solidFill><ns4:latin typeface="Georgia"/><ns4:ea typeface="Georgia"/></ns4:defRPr></ns4:lvl4pPr><ns4:lvl5pPr algn="ctr"><ns4:buNone/><ns4:defRPr sz="5200" dirty="0" b="1"><ns4:solidFill><ns4:srgbClr val="1E2761"/></ns4:solidFill><ns4:latin typeface="Georgia"/><ns4:ea typeface="Georgia"/></ns4:defRPr></ns4:lvl5pPr><ns4:lvl6pPr algn="ctr"><ns4:buNone/><ns4:defRPr sz="5200" dirty="0" b="1"><ns4:solidFill><ns4:srgbClr val="1E2761"/></ns4:solidFill><ns4:latin typeface="Georgia"/><ns4:ea typeface="Georgia"/></ns4:defRPr></ns4:lvl6pPr><ns4:lvl7pPr algn="ctr"><ns4:buNone/><ns4:defRPr sz="5200" dirty="0" b="1"><ns4:solidFill><ns4:srgbClr val="1E2761"/></ns4:solidFill><ns4:latin typeface="Georgia"/><ns4:ea typeface="Georgia"/></ns4:defRPr></ns4:lvl7pPr><ns4:lvl8pPr algn="ctr"><ns4:buNone/><ns4:defRPr sz="5200" dirty="0" b="1"><ns4:solidFill><ns4:srgbClr val="1E2761"/></ns4:solidFill><ns4:latin typeface="Georgia"/><ns4:ea typeface="Georgia"/></ns4:defRPr></ns4:lvl8pPr><ns4:lvl9pPr algn="ctr"><ns4:buNone/><ns4:defRPr sz="5200" dirty="0" b="1"><ns4:solidFill><ns4:srgbClr val="1E2761"/></ns4:solidFill><ns4:latin typeface="Georgia"/><ns4:ea typeface="Georgia"/></ns4:defRPr></ns4:lvl9pPr></ns4:lstStyle/><ns5:p xmlns:ns5="http://schemas.openxmlformats.org/drawingml/2006/main"><ns5:pPr algn="ctr"><ns5:buNone/></ns5:pPr><ns5:r><ns5:rPr lang="ja-JP"/><ns5:t>指標名
+説明</ns5:t></ns5:r></ns5:p></ns0:txBody></ns0:sp><ns0:sp><ns0:nvSpPr><ns0:cNvPr id="24" name="Value3.Right"/><ns0:cNvSpPr><ns1:spLocks xmlns:ns1="http://schemas.openxmlformats.org/drawingml/2006/main" noGrp="1"/></ns0:cNvSpPr><ns0:nvPr><ns0:ph idx="5" type="body"/></ns0:nvPr></ns0:nvSpPr><ns0:spPr><ns2:xfrm xmlns:ns2="http://schemas.openxmlformats.org/drawingml/2006/main"><ns2:off x="8412480" y="1828800"/><ns2:ext cx="3017520" cy="1371600"/></ns2:xfrm></ns0:spPr><ns0:txBody><ns3:bodyPr xmlns:ns3="http://schemas.openxmlformats.org/drawingml/2006/main" wrap="square" anchor="t" anchorCtr="0"/><ns4:lstStyle><ns4:defPPr algn="ctr"><ns4:defRPr sz="5200" b="1"><ns4:solidFill><ns4:srgbClr val="1E2761"/></ns4:solidFill></ns4:defRPr></ns4:defPPr></ns4:lstStyle><ns4:defPPr algn="ctr"><ns4:buNone/><ns4:defRPr sz="5200" dirty="0" b="1"><ns4:solidFill><ns4:srgbClr val="1E2761"/></ns4:solidFill><ns4:latin typeface="Georgia"/><ns4:ea typeface="Georgia"/></ns4:defRPr></ns4:defPPr><ns4:lvl1pPr algn="ctr"><ns4:buNone/><ns4:defRPr sz="5200" dirty="0" b="1"><ns4:solidFill><ns4:srgbClr val="1E2761"/></ns4:solidFill><ns4:latin typeface="Georgia"/><ns4:ea typeface="Georgia"/></ns4:defRPr></ns4:lvl1pPr><ns4:lvl2pPr algn="ctr"><ns4:buNone/><ns4:defRPr sz="5200" dirty="0" b="1"><ns4:solidFill><ns4:srgbClr val="1E2761"/></ns4:solidFill><ns4:latin typeface="Georgia"/><ns4:ea typeface="Georgia"/></ns4:defRPr></ns4:lvl2pPr><ns4:lvl3pPr algn="ctr"><ns4:buNone/><ns4:defRPr sz="5200" dirty="0" b="1"><ns4:solidFill><ns4:srgbClr val="1E2761"/></ns4:solidFill><ns4:latin typeface="Georgia"/><ns4:ea typeface="Georgia"/></ns4:defRPr></ns4:lvl3pPr><ns4:lvl4pPr algn="ctr"><ns4:buNone/><ns4:defRPr sz="5200" dirty="0" b="1"><ns4:solidFill><ns4:srgbClr val="1E2761"/></ns4:solidFill><ns4:latin typeface="Georgia"/><ns4:ea typeface="Georgia"/></ns4:defRPr></ns4:lvl4pPr><ns4:lvl5pPr algn="ctr"><ns4:buNone/><ns4:defRPr sz="5200" dirty="0" b="1"><ns4:solidFill><ns4:srgbClr val="1E2761"/></ns4:solidFill><ns4:latin typeface="Georgia"/><ns4:ea typeface="Georgia"/></ns4:defRPr></ns4:lvl5pPr><ns4:lvl6pPr algn="ctr"><ns4:buNone/><ns4:defRPr sz="5200" dirty="0" b="1"><ns4:solidFill><ns4:srgbClr val="1E2761"/></ns4:solidFill><ns4:latin typeface="Georgia"/><ns4:ea typeface="Georgia"/></ns4:defRPr></ns4:lvl6pPr><ns4:lvl7pPr algn="ctr"><ns4:buNone/><ns4:defRPr sz="5200" dirty="0" b="1"><ns4:solidFill><ns4:srgbClr val="1E2761"/></ns4:solidFill><ns4:latin typeface="Georgia"/><ns4:ea typeface="Georgia"/></ns4:defRPr></ns4:lvl7pPr><ns4:lvl8pPr algn="ctr"><ns4:buNone/><ns4:defRPr sz="5200" dirty="0" b="1"><ns4:solidFill><ns4:srgbClr val="1E2761"/></ns4:solidFill><ns4:latin typeface="Georgia"/><ns4:ea typeface="Georgia"/></ns4:defRPr></ns4:lvl8pPr><ns4:lvl9pPr algn="ctr"><ns4:buNone/><ns4:defRPr sz="5200" dirty="0" b="1"><ns4:solidFill><ns4:srgbClr val="1E2761"/></ns4:solidFill><ns4:latin typeface="Georgia"/><ns4:ea typeface="Georgia"/></ns4:defRPr></ns4:lvl9pPr></ns4:lstStyle/><ns5:p xmlns:ns5="http://schemas.openxmlformats.org/drawingml/2006/main"><ns5:pPr algn="ctr"><ns5:buNone/></ns5:pPr><ns5:r><ns5:rPr lang="ja-JP"/><ns5:t>指標名
+説明</ns5:t></ns5:r></ns5:p></ns0:txBody></ns0:sp><ns0:sp><ns0:nvSpPr><ns0:cNvPr id="31" name="SlideNum.Footer"/><ns0:cNvSpPr><ns1:spLocks xmlns:ns1="http://schemas.openxmlformats.org/drawingml/2006/main" noGrp="1"/></ns0:cNvSpPr><ns0:nvPr><ns0:ph idx="50" type="sldNum"/></ns0:nvPr></ns0:nvSpPr><ns0:spPr><ns2:xfrm xmlns:ns2="http://schemas.openxmlformats.org/drawingml/2006/main"><ns2:off x="10972800" y="6446520"/><ns2:ext cx="1097280" cy="274320"/></ns2:xfrm></ns0:spPr><ns0:txBody><ns3:bodyPr xmlns:ns3="http://schemas.openxmlformats.org/drawingml/2006/main" wrap="square" anchor="t" anchorCtr="0"/><ns4:lstStyle><ns4:defPPr algn="r"><ns4:defRPr sz="1000"><ns4:solidFill><ns4:srgbClr val="94A3B8"/></ns4:solidFill></ns4:defRPr></ns4:defPPr></ns4:lstStyle><ns4:defPPr algn="r"><ns4:buNone/><ns4:defRPr sz="1000" dirty="0"><ns4:solidFill><ns4:srgbClr val="94A3B8"/></ns4:solidFill><ns4:latin typeface="Calibri"/><ns4:ea typeface="Calibri"/></ns4:defRPr></ns4:defPPr><ns4:lvl1pPr algn="r"><ns4:buNone/><ns4:defRPr sz="1000" dirty="0"><ns4:solidFill><ns4:srgbClr val="94A3B8"/></ns4:solidFill><ns4:latin typeface="Calibri"/><ns4:ea typeface="Calibri"/></ns4:defRPr></ns4:lvl1pPr><ns4:lvl2pPr algn="r"><ns4:buNone/><ns4:defRPr sz="1000" dirty="0"><ns4:solidFill><ns4:srgbClr val="94A3B8"/></ns4:solidFill><ns4:latin typeface="Calibri"/><ns4:ea typeface="Calibri"/></ns4:defRPr></ns4:lvl2pPr><ns4:lvl3pPr algn="r"><ns4:buNone/><ns4:defRPr sz="1000" dirty="0"><ns4:solidFill><ns4:srgbClr val="94A3B8"/></ns4:solidFill><ns4:latin typeface="Calibri"/><ns4:ea typeface="Calibri"/></ns4:defRPr></ns4:lvl3pPr><ns4:lvl4pPr algn="r"><ns4:buNone/><ns4:defRPr sz="1000" dirty="0"><ns4:solidFill><ns4:srgbClr val="94A3B8"/></ns4:solidFill><ns4:latin typeface="Calibri"/><ns4:ea typeface="Calibri"/></ns4:defRPr></ns4:lvl4pPr><ns4:lvl5pPr algn="r"><ns4:buNone/><ns4:defRPr sz="1000" dirty="0"><ns4:solidFill><ns4:srgbClr val="94A3B8"/></ns4:solidFill><ns4:latin typeface="Calibri"/><ns4:ea typeface="Calibri"/></ns4:defRPr></ns4:lvl5pPr><ns4:lvl6pPr algn="r"><ns4:buNone/><ns4:defRPr sz="1000" dirty="0"><ns4:solidFill><ns4:srgbClr val="94A3B8"/></ns4:solidFill><ns4:latin typeface="Calibri"/><ns4:ea typeface="Calibri"/></ns4:defRPr></ns4:lvl6pPr><ns4:lvl7pPr algn="r"><ns4:buNone/><ns4:defRPr sz="1000" dirty="0"><ns4:solidFill><ns4:srgbClr val="94A3B8"/></ns4:solidFill><ns4:latin typeface="Calibri"/><ns4:ea typeface="Calibri"/></ns4:defRPr></ns4:lvl7pPr><ns4:lvl8pPr algn="r"><ns4:buNone/><ns4:defRPr sz="1000" dirty="0"><ns4:solidFill><ns4:srgbClr val="94A3B8"/></ns4:solidFill><ns4:latin typeface="Calibri"/><ns4:ea typeface="Calibri"/></ns4:defRPr></ns4:lvl8pPr><ns4:lvl9pPr algn="r"><ns4:buNone/><ns4:defRPr sz="1000" dirty="0"><ns4:solidFill><ns4:srgbClr val="94A3B8"/></ns4:solidFill><ns4:latin typeface="Calibri"/><ns4:ea typeface="Calibri"/></ns4:defRPr></ns4:lvl9pPr></ns4:lstStyle><ns5:p xmlns:ns5="http://schemas.openxmlformats.org/drawingml/2006/main"><ns5:pPr algn="r"><ns5:buNone/></ns5:pPr><ns5:r><ns5:rPr lang="ja-JP"/><ns5:t>&lt;#&gt;</ns5:t></ns5:r></ns5:p></ns0:txBody></ns0:sp></ns0:spTree></ns0:cSld><ns0:clrMapOvr/></ns0:sldLayout>
 </file>
 
 <file path=ppt/slideLayouts/slideLayout17.xml><?xml version='1.0' encoding='UTF-8' standalone='yes'?>
-<ns0:sldLayout xmlns:ns0="http://schemas.openxmlformats.org/presentationml/2006/main" type="blank" preserve="1"><ns0:cSld name="KPI.4Value.Grid"><ns0:spTree><ns0:nvGrpSpPr><ns0:cNvPr id="1" name=""/><ns0:cNvGrpSpPr/><ns0:nvPr/></ns0:nvGrpSpPr><ns0:grpSpPr><ns1:xfrm xmlns:ns1="http://schemas.openxmlformats.org/drawingml/2006/main"><ns1:off x="0" y="0"/><ns1:ext cx="0" cy="0"/><ns1:chOff x="0" y="0"/><ns1:chExt cx="0" cy="0"/></ns1:xfrm></ns0:grpSpPr><ns0:sp><ns0:nvSpPr><ns0:cNvPr id="2" name="HeaderBar"/><ns0:cNvSpPr><ns1:spLocks xmlns:ns1="http://schemas.openxmlformats.org/drawingml/2006/main" noGrp="1" noSelect="0" noRot="1" noMove="1"/></ns0:cNvSpPr><ns0:nvPr/></ns0:nvSpPr><ns0:spPr><ns2:xfrm xmlns:ns2="http://schemas.openxmlformats.org/drawingml/2006/main"><ns2:off x="0" y="0"/><ns2:ext cx="12192000" cy="1051560"/></ns2:xfrm><ns3:prstGeom xmlns:ns3="http://schemas.openxmlformats.org/drawingml/2006/main" prst="rect"/><ns4:solidFill xmlns:ns4="http://schemas.openxmlformats.org/drawingml/2006/main"><ns4:srgbClr val="1E2761"/></ns4:solidFill><ns5:ln xmlns:ns5="http://schemas.openxmlformats.org/drawingml/2006/main"><ns5:noFill/></ns5:ln></ns0:spPr></ns0:sp><ns0:sp><ns0:nvSpPr><ns0:cNvPr id="10" name="SlideTitle.Header"/><ns0:cNvSpPr><ns1:spLocks xmlns:ns1="http://schemas.openxmlformats.org/drawingml/2006/main" noGrp="1"/></ns0:cNvSpPr><ns0:nvPr><ns0:ph idx="15" type="body"/></ns0:nvPr></ns0:nvSpPr><ns0:spPr><ns2:xfrm xmlns:ns2="http://schemas.openxmlformats.org/drawingml/2006/main"><ns2:off x="731520" y="91440"/><ns2:ext cx="9144000" cy="475488"/></ns2:xfrm></ns0:spPr><ns0:txBody><ns3:bodyPr xmlns:ns3="http://schemas.openxmlformats.org/drawingml/2006/main" wrap="square" anchor="t" anchorCtr="0"/><ns4:lstStyle xmlns:ns4="http://schemas.openxmlformats.org/drawingml/2006/main"><ns4:defPPr algn="l"><ns4:buNone/><ns4:defRPr sz="2800" dirty="0" b="1"><ns4:solidFill><ns4:srgbClr val="FFFFFF"/></ns4:solidFill><ns4:latin typeface="Georgia"/><ns4:ea typeface="Georgia"/></ns4:defRPr></ns4:defPPr><ns4:lvl1pPr algn="l"><ns4:buNone/><ns4:defRPr sz="2800" dirty="0" b="1"><ns4:solidFill><ns4:srgbClr val="FFFFFF"/></ns4:solidFill><ns4:latin typeface="Georgia"/><ns4:ea typeface="Georgia"/></ns4:defRPr></ns4:lvl1pPr><ns4:lvl2pPr algn="l"><ns4:buNone/><ns4:defRPr sz="2800" dirty="0" b="1"><ns4:solidFill><ns4:srgbClr val="FFFFFF"/></ns4:solidFill><ns4:latin typeface="Georgia"/><ns4:ea typeface="Georgia"/></ns4:defRPr></ns4:lvl2pPr><ns4:lvl3pPr algn="l"><ns4:buNone/><ns4:defRPr sz="2800" dirty="0" b="1"><ns4:solidFill><ns4:srgbClr val="FFFFFF"/></ns4:solidFill><ns4:latin typeface="Georgia"/><ns4:ea typeface="Georgia"/></ns4:defRPr></ns4:lvl3pPr><ns4:lvl4pPr algn="l"><ns4:buNone/><ns4:defRPr sz="2800" dirty="0" b="1"><ns4:solidFill><ns4:srgbClr val="FFFFFF"/></ns4:solidFill><ns4:latin typeface="Georgia"/><ns4:ea typeface="Georgia"/></ns4:defRPr></ns4:lvl4pPr><ns4:lvl5pPr algn="l"><ns4:buNone/><ns4:defRPr sz="2800" dirty="0" b="1"><ns4:solidFill><ns4:srgbClr val="FFFFFF"/></ns4:solidFill><ns4:latin typeface="Georgia"/><ns4:ea typeface="Georgia"/></ns4:defRPr></ns4:lvl5pPr><ns4:lvl6pPr algn="l"><ns4:buNone/><ns4:defRPr sz="2800" dirty="0" b="1"><ns4:solidFill><ns4:srgbClr val="FFFFFF"/></ns4:solidFill><ns4:latin typeface="Georgia"/><ns4:ea typeface="Georgia"/></ns4:defRPr></ns4:lvl6pPr><ns4:lvl7pPr algn="l"><ns4:buNone/><ns4:defRPr sz="2800" dirty="0" b="1"><ns4:solidFill><ns4:srgbClr val="FFFFFF"/></ns4:solidFill><ns4:latin typeface="Georgia"/><ns4:ea typeface="Georgia"/></ns4:defRPr></ns4:lvl7pPr><ns4:lvl8pPr algn="l"><ns4:buNone/><ns4:defRPr sz="2800" dirty="0" b="1"><ns4:solidFill><ns4:srgbClr val="FFFFFF"/></ns4:solidFill><ns4:latin typeface="Georgia"/><ns4:ea typeface="Georgia"/></ns4:defRPr></ns4:lvl8pPr><ns4:lvl9pPr algn="l"><ns4:buNone/><ns4:defRPr sz="2800" dirty="0" b="1"><ns4:solidFill><ns4:srgbClr val="FFFFFF"/></ns4:solidFill><ns4:latin typeface="Georgia"/><ns4:ea typeface="Georgia"/></ns4:defRPr></ns4:lvl9pPr></ns4:lstStyle/><ns5:p xmlns:ns5="http://schemas.openxmlformats.org/drawingml/2006/main"><ns5:pPr algn="l"><ns5:buNone/></ns5:pPr><ns5:r><ns5:rPr lang="ja-JP"/><ns5:t>サブタイトル</ns5:t></ns5:r></ns5:p></ns0:txBody></ns0:sp><ns0:sp><ns0:nvSpPr><ns0:cNvPr id="5" name="TL"/><ns0:cNvSpPr><ns1:spLocks xmlns:ns1="http://schemas.openxmlformats.org/drawingml/2006/main" noGrp="1" noSelect="0" noRot="1" noMove="1"/></ns0:cNvSpPr><ns0:nvPr/></ns0:nvSpPr><ns0:spPr><ns2:xfrm xmlns:ns2="http://schemas.openxmlformats.org/drawingml/2006/main"><ns2:off x="457200" y="1280160"/><ns2:ext cx="5303520" cy="2286000"/></ns2:xfrm><ns3:prstGeom xmlns:ns3="http://schemas.openxmlformats.org/drawingml/2006/main" prst="roundRect"><ns3:avLst><ns3:gd name="adj" fmla="val 8000"/></ns3:avLst></ns3:prstGeom><ns4:solidFill xmlns:ns4="http://schemas.openxmlformats.org/drawingml/2006/main"><ns4:srgbClr val="EDF0F7"/></ns4:solidFill><ns5:ln xmlns:ns5="http://schemas.openxmlformats.org/drawingml/2006/main"><ns5:noFill/></ns5:ln></ns0:spPr></ns0:sp><ns0:sp><ns0:nvSpPr><ns0:cNvPr id="6" name="TR"/><ns0:cNvSpPr><ns1:spLocks xmlns:ns1="http://schemas.openxmlformats.org/drawingml/2006/main" noGrp="1" noSelect="0" noRot="1" noMove="1"/></ns0:cNvSpPr><ns0:nvPr/></ns0:nvSpPr><ns0:spPr><ns2:xfrm xmlns:ns2="http://schemas.openxmlformats.org/drawingml/2006/main"><ns2:off x="6126480" y="1280160"/><ns2:ext cx="5394960" cy="2286000"/></ns2:xfrm><ns3:prstGeom xmlns:ns3="http://schemas.openxmlformats.org/drawingml/2006/main" prst="roundRect"><ns3:avLst><ns3:gd name="adj" fmla="val 8000"/></ns3:avLst></ns3:prstGeom><ns4:solidFill xmlns:ns4="http://schemas.openxmlformats.org/drawingml/2006/main"><ns4:srgbClr val="EDF0F7"/></ns4:solidFill><ns5:ln xmlns:ns5="http://schemas.openxmlformats.org/drawingml/2006/main"><ns5:noFill/></ns5:ln></ns0:spPr></ns0:sp><ns0:sp><ns0:nvSpPr><ns0:cNvPr id="7" name="BL"/><ns0:cNvSpPr><ns1:spLocks xmlns:ns1="http://schemas.openxmlformats.org/drawingml/2006/main" noGrp="1" noSelect="0" noRot="1" noMove="1"/></ns0:cNvSpPr><ns0:nvPr/></ns0:nvSpPr><ns0:spPr><ns2:xfrm xmlns:ns2="http://schemas.openxmlformats.org/drawingml/2006/main"><ns2:off x="457200" y="3840480"/><ns2:ext cx="5303520" cy="2286000"/></ns2:xfrm><ns3:prstGeom xmlns:ns3="http://schemas.openxmlformats.org/drawingml/2006/main" prst="roundRect"><ns3:avLst><ns3:gd name="adj" fmla="val 8000"/></ns3:avLst></ns3:prstGeom><ns4:solidFill xmlns:ns4="http://schemas.openxmlformats.org/drawingml/2006/main"><ns4:srgbClr val="EDF0F7"/></ns4:solidFill><ns5:ln xmlns:ns5="http://schemas.openxmlformats.org/drawingml/2006/main"><ns5:noFill/></ns5:ln></ns0:spPr></ns0:sp><ns0:sp><ns0:nvSpPr><ns0:cNvPr id="8" name="BR"/><ns0:cNvSpPr><ns1:spLocks xmlns:ns1="http://schemas.openxmlformats.org/drawingml/2006/main" noGrp="1" noSelect="0" noRot="1" noMove="1"/></ns0:cNvSpPr><ns0:nvPr/></ns0:nvSpPr><ns0:spPr><ns2:xfrm xmlns:ns2="http://schemas.openxmlformats.org/drawingml/2006/main"><ns2:off x="6126480" y="3840480"/><ns2:ext cx="5394960" cy="2286000"/></ns2:xfrm><ns3:prstGeom xmlns:ns3="http://schemas.openxmlformats.org/drawingml/2006/main" prst="roundRect"><ns3:avLst><ns3:gd name="adj" fmla="val 8000"/></ns3:avLst></ns3:prstGeom><ns4:solidFill xmlns:ns4="http://schemas.openxmlformats.org/drawingml/2006/main"><ns4:srgbClr val="EDF0F7"/></ns4:solidFill><ns5:ln xmlns:ns5="http://schemas.openxmlformats.org/drawingml/2006/main"><ns5:noFill/></ns5:ln></ns0:spPr></ns0:sp><ns0:sp><ns0:nvSpPr><ns0:cNvPr id="9" name="A1"/><ns0:cNvSpPr><ns1:spLocks xmlns:ns1="http://schemas.openxmlformats.org/drawingml/2006/main" noGrp="1" noSelect="0" noRot="1" noMove="1"/></ns0:cNvSpPr><ns0:nvPr/></ns0:nvSpPr><ns0:spPr><ns2:xfrm xmlns:ns2="http://schemas.openxmlformats.org/drawingml/2006/main"><ns2:off x="457200" y="1280160"/><ns2:ext cx="54864" cy="2286000"/></ns2:xfrm><ns3:prstGeom xmlns:ns3="http://schemas.openxmlformats.org/drawingml/2006/main" prst="rect"/><ns4:solidFill xmlns:ns4="http://schemas.openxmlformats.org/drawingml/2006/main"><ns4:srgbClr val="3B82F6"/></ns4:solidFill><ns5:ln xmlns:ns5="http://schemas.openxmlformats.org/drawingml/2006/main"><ns5:noFill/></ns5:ln></ns0:spPr></ns0:sp><ns0:sp><ns0:nvSpPr><ns0:cNvPr id="10" name="A2"/><ns0:cNvSpPr><ns1:spLocks xmlns:ns1="http://schemas.openxmlformats.org/drawingml/2006/main" noGrp="1" noSelect="0" noRot="1" noMove="1"/></ns0:cNvSpPr><ns0:nvPr/></ns0:nvSpPr><ns0:spPr><ns2:xfrm xmlns:ns2="http://schemas.openxmlformats.org/drawingml/2006/main"><ns2:off x="6126480" y="1280160"/><ns2:ext cx="54864" cy="2286000"/></ns2:xfrm><ns3:prstGeom xmlns:ns3="http://schemas.openxmlformats.org/drawingml/2006/main" prst="rect"/><ns4:solidFill xmlns:ns4="http://schemas.openxmlformats.org/drawingml/2006/main"><ns4:srgbClr val="06B6D4"/></ns4:solidFill><ns5:ln xmlns:ns5="http://schemas.openxmlformats.org/drawingml/2006/main"><ns5:noFill/></ns5:ln></ns0:spPr></ns0:sp><ns0:sp><ns0:nvSpPr><ns0:cNvPr id="11" name="A3"/><ns0:cNvSpPr><ns1:spLocks xmlns:ns1="http://schemas.openxmlformats.org/drawingml/2006/main" noGrp="1" noSelect="0" noRot="1" noMove="1"/></ns0:cNvSpPr><ns0:nvPr/></ns0:nvSpPr><ns0:spPr><ns2:xfrm xmlns:ns2="http://schemas.openxmlformats.org/drawingml/2006/main"><ns2:off x="457200" y="3840480"/><ns2:ext cx="54864" cy="2286000"/></ns2:xfrm><ns3:prstGeom xmlns:ns3="http://schemas.openxmlformats.org/drawingml/2006/main" prst="rect"/><ns4:solidFill xmlns:ns4="http://schemas.openxmlformats.org/drawingml/2006/main"><ns4:srgbClr val="F59E0B"/></ns4:solidFill><ns5:ln xmlns:ns5="http://schemas.openxmlformats.org/drawingml/2006/main"><ns5:noFill/></ns5:ln></ns0:spPr></ns0:sp><ns0:sp><ns0:nvSpPr><ns0:cNvPr id="12" name="A4"/><ns0:cNvSpPr><ns1:spLocks xmlns:ns1="http://schemas.openxmlformats.org/drawingml/2006/main" noGrp="1" noSelect="0" noRot="1" noMove="1"/></ns0:cNvSpPr><ns0:nvPr/></ns0:nvSpPr><ns0:spPr><ns2:xfrm xmlns:ns2="http://schemas.openxmlformats.org/drawingml/2006/main"><ns2:off x="6126480" y="3840480"/><ns2:ext cx="54864" cy="2286000"/></ns2:xfrm><ns3:prstGeom xmlns:ns3="http://schemas.openxmlformats.org/drawingml/2006/main" prst="rect"/><ns4:solidFill xmlns:ns4="http://schemas.openxmlformats.org/drawingml/2006/main"><ns4:srgbClr val="2563EB"/></ns4:solidFill><ns5:ln xmlns:ns5="http://schemas.openxmlformats.org/drawingml/2006/main"><ns5:noFill/></ns5:ln></ns0:spPr></ns0:sp><ns0:sp><ns0:nvSpPr><ns0:cNvPr id="20" name="Value1.TopLeft"/><ns0:cNvSpPr><ns1:spLocks xmlns:ns1="http://schemas.openxmlformats.org/drawingml/2006/main" noGrp="1"/></ns0:cNvSpPr><ns0:nvPr><ns0:ph idx="1" type="body"/></ns0:nvPr></ns0:nvSpPr><ns0:spPr><ns2:xfrm xmlns:ns2="http://schemas.openxmlformats.org/drawingml/2006/main"><ns2:off x="914400" y="1463040"/><ns2:ext cx="4389120" cy="1828800"/></ns2:xfrm></ns0:spPr><ns0:txBody><ns3:bodyPr xmlns:ns3="http://schemas.openxmlformats.org/drawingml/2006/main" wrap="square" anchor="t" anchorCtr="0"/><ns4:lstStyle xmlns:ns4="http://schemas.openxmlformats.org/drawingml/2006/main"><ns4:defPPr algn="l"><ns4:buNone/><ns4:defRPr sz="1400" dirty="0"><ns4:solidFill><ns4:srgbClr val="1E293B"/></ns4:solidFill><ns4:latin typeface="Calibri"/><ns4:ea typeface="Calibri"/></ns4:defRPr></ns4:defPPr><ns4:lvl1pPr algn="l"><ns4:buNone/><ns4:defRPr sz="1400" dirty="0"><ns4:solidFill><ns4:srgbClr val="1E293B"/></ns4:solidFill><ns4:latin typeface="Calibri"/><ns4:ea typeface="Calibri"/></ns4:defRPr></ns4:lvl1pPr><ns4:lvl2pPr algn="l"><ns4:buNone/><ns4:defRPr sz="1400" dirty="0"><ns4:solidFill><ns4:srgbClr val="1E293B"/></ns4:solidFill><ns4:latin typeface="Calibri"/><ns4:ea typeface="Calibri"/></ns4:defRPr></ns4:lvl2pPr><ns4:lvl3pPr algn="l"><ns4:buNone/><ns4:defRPr sz="1400" dirty="0"><ns4:solidFill><ns4:srgbClr val="1E293B"/></ns4:solidFill><ns4:latin typeface="Calibri"/><ns4:ea typeface="Calibri"/></ns4:defRPr></ns4:lvl3pPr><ns4:lvl4pPr algn="l"><ns4:buNone/><ns4:defRPr sz="1400" dirty="0"><ns4:solidFill><ns4:srgbClr val="1E293B"/></ns4:solidFill><ns4:latin typeface="Calibri"/><ns4:ea typeface="Calibri"/></ns4:defRPr></ns4:lvl4pPr><ns4:lvl5pPr algn="l"><ns4:buNone/><ns4:defRPr sz="1400" dirty="0"><ns4:solidFill><ns4:srgbClr val="1E293B"/></ns4:solidFill><ns4:latin typeface="Calibri"/><ns4:ea typeface="Calibri"/></ns4:defRPr></ns4:lvl5pPr><ns4:lvl6pPr algn="l"><ns4:buNone/><ns4:defRPr sz="1400" dirty="0"><ns4:solidFill><ns4:srgbClr val="1E293B"/></ns4:solidFill><ns4:latin typeface="Calibri"/><ns4:ea typeface="Calibri"/></ns4:defRPr></ns4:lvl6pPr><ns4:lvl7pPr algn="l"><ns4:buNone/><ns4:defRPr sz="1400" dirty="0"><ns4:solidFill><ns4:srgbClr val="1E293B"/></ns4:solidFill><ns4:latin typeface="Calibri"/><ns4:ea typeface="Calibri"/></ns4:defRPr></ns4:lvl7pPr><ns4:lvl8pPr algn="l"><ns4:buNone/><ns4:defRPr sz="1400" dirty="0"><ns4:solidFill><ns4:srgbClr val="1E293B"/></ns4:solidFill><ns4:latin typeface="Calibri"/><ns4:ea typeface="Calibri"/></ns4:defRPr></ns4:lvl8pPr><ns4:lvl9pPr algn="l"><ns4:buNone/><ns4:defRPr sz="1400" dirty="0"><ns4:solidFill><ns4:srgbClr val="1E293B"/></ns4:solidFill><ns4:latin typeface="Calibri"/><ns4:ea typeface="Calibri"/></ns4:defRPr></ns4:lvl9pPr></ns4:lstStyle/><ns5:p xmlns:ns5="http://schemas.openxmlformats.org/drawingml/2006/main"><ns5:pPr algn="l"><ns5:buNone/></ns5:pPr><ns5:r><ns5:rPr lang="ja-JP"/><ns5:t>指標 2
-値・説明</ns5:t></ns5:r></ns5:p></ns0:txBody></ns0:sp><ns0:sp><ns0:nvSpPr><ns0:cNvPr id="22" name="Value3.BottomLeft"/><ns0:cNvSpPr><ns1:spLocks xmlns:ns1="http://schemas.openxmlformats.org/drawingml/2006/main" noGrp="1"/></ns0:cNvSpPr><ns0:nvPr><ns0:ph idx="3" type="body"/></ns0:nvPr></ns0:nvSpPr><ns0:spPr><ns2:xfrm xmlns:ns2="http://schemas.openxmlformats.org/drawingml/2006/main"><ns2:off x="914400" y="4023360"/><ns2:ext cx="4389120" cy="1828800"/></ns2:xfrm></ns0:spPr><ns0:txBody><ns3:bodyPr xmlns:ns3="http://schemas.openxmlformats.org/drawingml/2006/main" wrap="square" anchor="t" anchorCtr="0"/><ns4:lstStyle xmlns:ns4="http://schemas.openxmlformats.org/drawingml/2006/main"><ns4:defPPr algn="l"><ns4:buNone/><ns4:defRPr sz="1400" dirty="0"><ns4:solidFill><ns4:srgbClr val="1E293B"/></ns4:solidFill><ns4:latin typeface="Calibri"/><ns4:ea typeface="Calibri"/></ns4:defRPr></ns4:defPPr><ns4:lvl1pPr algn="l"><ns4:buNone/><ns4:defRPr sz="1400" dirty="0"><ns4:solidFill><ns4:srgbClr val="1E293B"/></ns4:solidFill><ns4:latin typeface="Calibri"/><ns4:ea typeface="Calibri"/></ns4:defRPr></ns4:lvl1pPr><ns4:lvl2pPr algn="l"><ns4:buNone/><ns4:defRPr sz="1400" dirty="0"><ns4:solidFill><ns4:srgbClr val="1E293B"/></ns4:solidFill><ns4:latin typeface="Calibri"/><ns4:ea typeface="Calibri"/></ns4:defRPr></ns4:lvl2pPr><ns4:lvl3pPr algn="l"><ns4:buNone/><ns4:defRPr sz="1400" dirty="0"><ns4:solidFill><ns4:srgbClr val="1E293B"/></ns4:solidFill><ns4:latin typeface="Calibri"/><ns4:ea typeface="Calibri"/></ns4:defRPr></ns4:lvl3pPr><ns4:lvl4pPr algn="l"><ns4:buNone/><ns4:defRPr sz="1400" dirty="0"><ns4:solidFill><ns4:srgbClr val="1E293B"/></ns4:solidFill><ns4:latin typeface="Calibri"/><ns4:ea typeface="Calibri"/></ns4:defRPr></ns4:lvl4pPr><ns4:lvl5pPr algn="l"><ns4:buNone/><ns4:defRPr sz="1400" dirty="0"><ns4:solidFill><ns4:srgbClr val="1E293B"/></ns4:solidFill><ns4:latin typeface="Calibri"/><ns4:ea typeface="Calibri"/></ns4:defRPr></ns4:lvl5pPr><ns4:lvl6pPr algn="l"><ns4:buNone/><ns4:defRPr sz="1400" dirty="0"><ns4:solidFill><ns4:srgbClr val="1E293B"/></ns4:solidFill><ns4:latin typeface="Calibri"/><ns4:ea typeface="Calibri"/></ns4:defRPr></ns4:lvl6pPr><ns4:lvl7pPr algn="l"><ns4:buNone/><ns4:defRPr sz="1400" dirty="0"><ns4:solidFill><ns4:srgbClr val="1E293B"/></ns4:solidFill><ns4:latin typeface="Calibri"/><ns4:ea typeface="Calibri"/></ns4:defRPr></ns4:lvl7pPr><ns4:lvl8pPr algn="l"><ns4:buNone/><ns4:defRPr sz="1400" dirty="0"><ns4:solidFill><ns4:srgbClr val="1E293B"/></ns4:solidFill><ns4:latin typeface="Calibri"/><ns4:ea typeface="Calibri"/></ns4:defRPr></ns4:lvl8pPr><ns4:lvl9pPr algn="l"><ns4:buNone/><ns4:defRPr sz="1400" dirty="0"><ns4:solidFill><ns4:srgbClr val="1E293B"/></ns4:solidFill><ns4:latin typeface="Calibri"/><ns4:ea typeface="Calibri"/></ns4:defRPr></ns4:lvl9pPr></ns4:lstStyle/><ns5:p xmlns:ns5="http://schemas.openxmlformats.org/drawingml/2006/main"><ns5:pPr algn="l"><ns5:buNone/></ns5:pPr><ns5:r><ns5:rPr lang="ja-JP"/><ns5:t>指標 4
-値・説明</ns5:t></ns5:r></ns5:p></ns0:txBody></ns0:sp><ns0:sp><ns0:nvSpPr><ns0:cNvPr id="31" name="SlideNum.Footer"/><ns0:cNvSpPr><ns1:spLocks xmlns:ns1="http://schemas.openxmlformats.org/drawingml/2006/main" noGrp="1"/></ns0:cNvSpPr><ns0:nvPr><ns0:ph idx="50" type="sldNum"/></ns0:nvPr></ns0:nvSpPr><ns0:spPr><ns2:xfrm xmlns:ns2="http://schemas.openxmlformats.org/drawingml/2006/main"><ns2:off x="10972800" y="6446520"/><ns2:ext cx="1097280" cy="274320"/></ns2:xfrm></ns0:spPr><ns0:txBody><ns3:bodyPr xmlns:ns3="http://schemas.openxmlformats.org/drawingml/2006/main" wrap="square" anchor="t" anchorCtr="0"/><ns4:lstStyle xmlns:ns4="http://schemas.openxmlformats.org/drawingml/2006/main"><ns4:defPPr algn="r"><ns4:buNone/><ns4:defRPr sz="1000" dirty="0"><ns4:solidFill><ns4:srgbClr val="94A3B8"/></ns4:solidFill><ns4:latin typeface="Calibri"/><ns4:ea typeface="Calibri"/></ns4:defRPr></ns4:defPPr><ns4:lvl1pPr algn="r"><ns4:buNone/><ns4:defRPr sz="1000" dirty="0"><ns4:solidFill><ns4:srgbClr val="94A3B8"/></ns4:solidFill><ns4:latin typeface="Calibri"/><ns4:ea typeface="Calibri"/></ns4:defRPr></ns4:lvl1pPr><ns4:lvl2pPr algn="r"><ns4:buNone/><ns4:defRPr sz="1000" dirty="0"><ns4:solidFill><ns4:srgbClr val="94A3B8"/></ns4:solidFill><ns4:latin typeface="Calibri"/><ns4:ea typeface="Calibri"/></ns4:defRPr></ns4:lvl2pPr><ns4:lvl3pPr algn="r"><ns4:buNone/><ns4:defRPr sz="1000" dirty="0"><ns4:solidFill><ns4:srgbClr val="94A3B8"/></ns4:solidFill><ns4:latin typeface="Calibri"/><ns4:ea typeface="Calibri"/></ns4:defRPr></ns4:lvl3pPr><ns4:lvl4pPr algn="r"><ns4:buNone/><ns4:defRPr sz="1000" dirty="0"><ns4:solidFill><ns4:srgbClr val="94A3B8"/></ns4:solidFill><ns4:latin typeface="Calibri"/><ns4:ea typeface="Calibri"/></ns4:defRPr></ns4:lvl4pPr><ns4:lvl5pPr algn="r"><ns4:buNone/><ns4:defRPr sz="1000" dirty="0"><ns4:solidFill><ns4:srgbClr val="94A3B8"/></ns4:solidFill><ns4:latin typeface="Calibri"/><ns4:ea typeface="Calibri"/></ns4:defRPr></ns4:lvl5pPr><ns4:lvl6pPr algn="r"><ns4:buNone/><ns4:defRPr sz="1000" dirty="0"><ns4:solidFill><ns4:srgbClr val="94A3B8"/></ns4:solidFill><ns4:latin typeface="Calibri"/><ns4:ea typeface="Calibri"/></ns4:defRPr></ns4:lvl6pPr><ns4:lvl7pPr algn="r"><ns4:buNone/><ns4:defRPr sz="1000" dirty="0"><ns4:solidFill><ns4:srgbClr val="94A3B8"/></ns4:solidFill><ns4:latin typeface="Calibri"/><ns4:ea typeface="Calibri"/></ns4:defRPr></ns4:lvl7pPr><ns4:lvl8pPr algn="r"><ns4:buNone/><ns4:defRPr sz="1000" dirty="0"><ns4:solidFill><ns4:srgbClr val="94A3B8"/></ns4:solidFill><ns4:latin typeface="Calibri"/><ns4:ea typeface="Calibri"/></ns4:defRPr></ns4:lvl8pPr><ns4:lvl9pPr algn="r"><ns4:buNone/><ns4:defRPr sz="1000" dirty="0"><ns4:solidFill><ns4:srgbClr val="94A3B8"/></ns4:solidFill><ns4:latin typeface="Calibri"/><ns4:ea typeface="Calibri"/></ns4:defRPr></ns4:lvl9pPr></ns4:lstStyle><ns5:p xmlns:ns5="http://schemas.openxmlformats.org/drawingml/2006/main"><ns5:pPr algn="r"><ns5:buNone/></ns5:pPr><ns5:r><ns5:rPr lang="ja-JP"/><ns5:t>&lt;#&gt;</ns5:t></ns5:r></ns5:p></ns0:txBody></ns0:sp></ns0:spTree></ns0:cSld><ns0:clrMapOvr/></ns0:sldLayout>
+<ns0:sldLayout xmlns:ns0="http://schemas.openxmlformats.org/presentationml/2006/main" type="blank" preserve="1"><ns0:cSld name="KPI.4Value.Grid"><ns0:spTree><ns0:nvGrpSpPr><ns0:cNvPr id="1" name=""/><ns0:cNvGrpSpPr/><ns0:nvPr/></ns0:nvGrpSpPr><ns0:grpSpPr><ns1:xfrm xmlns:ns1="http://schemas.openxmlformats.org/drawingml/2006/main"><ns1:off x="0" y="0"/><ns1:ext cx="0" cy="0"/><ns1:chOff x="0" y="0"/><ns1:chExt cx="0" cy="0"/></ns1:xfrm></ns0:grpSpPr><ns0:sp><ns0:nvSpPr><ns0:cNvPr id="2" name="HeaderBar"/><ns0:cNvSpPr><ns1:spLocks xmlns:ns1="http://schemas.openxmlformats.org/drawingml/2006/main" noGrp="1" noSelect="0" noRot="1" noMove="1"/></ns0:cNvSpPr><ns0:nvPr/></ns0:nvSpPr><ns0:spPr><ns2:xfrm xmlns:ns2="http://schemas.openxmlformats.org/drawingml/2006/main"><ns2:off x="0" y="0"/><ns2:ext cx="12192000" cy="1051560"/></ns2:xfrm><ns3:prstGeom xmlns:ns3="http://schemas.openxmlformats.org/drawingml/2006/main" prst="rect"/><ns4:solidFill xmlns:ns4="http://schemas.openxmlformats.org/drawingml/2006/main"><ns4:srgbClr val="1E2761"/></ns4:solidFill><ns5:ln xmlns:ns5="http://schemas.openxmlformats.org/drawingml/2006/main"><ns5:noFill/></ns5:ln></ns0:spPr></ns0:sp><ns0:sp><ns0:nvSpPr><ns0:cNvPr id="10" name="SlideTitle.Header"/><ns0:cNvSpPr><ns1:spLocks xmlns:ns1="http://schemas.openxmlformats.org/drawingml/2006/main" noGrp="1"/></ns0:cNvSpPr><ns0:nvPr><ns0:ph idx="15" type="body"/></ns0:nvPr></ns0:nvSpPr><ns0:spPr><ns2:xfrm xmlns:ns2="http://schemas.openxmlformats.org/drawingml/2006/main"><ns2:off x="731520" y="91440"/><ns2:ext cx="9144000" cy="475488"/></ns2:xfrm></ns0:spPr><ns0:txBody><ns3:bodyPr xmlns:ns3="http://schemas.openxmlformats.org/drawingml/2006/main" wrap="square" anchor="t" anchorCtr="0"/><ns4:lstStyle><ns4:defPPr><ns4:defRPr sz="2800" b="1"><ns4:solidFill><ns4:srgbClr val="FFFFFF"/></ns4:solidFill></ns4:defRPr></ns4:defPPr></ns4:lstStyle><ns4:defPPr algn="l"><ns4:buNone/><ns4:defRPr sz="2800" dirty="0" b="1"><ns4:solidFill><ns4:srgbClr val="FFFFFF"/></ns4:solidFill><ns4:latin typeface="Georgia"/><ns4:ea typeface="Georgia"/></ns4:defRPr></ns4:defPPr><ns4:lvl1pPr algn="l"><ns4:buNone/><ns4:defRPr sz="2800" dirty="0" b="1"><ns4:solidFill><ns4:srgbClr val="FFFFFF"/></ns4:solidFill><ns4:latin typeface="Georgia"/><ns4:ea typeface="Georgia"/></ns4:defRPr></ns4:lvl1pPr><ns4:lvl2pPr algn="l"><ns4:buNone/><ns4:defRPr sz="2800" dirty="0" b="1"><ns4:solidFill><ns4:srgbClr val="FFFFFF"/></ns4:solidFill><ns4:latin typeface="Georgia"/><ns4:ea typeface="Georgia"/></ns4:defRPr></ns4:lvl2pPr><ns4:lvl3pPr algn="l"><ns4:buNone/><ns4:defRPr sz="2800" dirty="0" b="1"><ns4:solidFill><ns4:srgbClr val="FFFFFF"/></ns4:solidFill><ns4:latin typeface="Georgia"/><ns4:ea typeface="Georgia"/></ns4:defRPr></ns4:lvl3pPr><ns4:lvl4pPr algn="l"><ns4:buNone/><ns4:defRPr sz="2800" dirty="0" b="1"><ns4:solidFill><ns4:srgbClr val="FFFFFF"/></ns4:solidFill><ns4:latin typeface="Georgia"/><ns4:ea typeface="Georgia"/></ns4:defRPr></ns4:lvl4pPr><ns4:lvl5pPr algn="l"><ns4:buNone/><ns4:defRPr sz="2800" dirty="0" b="1"><ns4:solidFill><ns4:srgbClr val="FFFFFF"/></ns4:solidFill><ns4:latin typeface="Georgia"/><ns4:ea typeface="Georgia"/></ns4:defRPr></ns4:lvl5pPr><ns4:lvl6pPr algn="l"><ns4:buNone/><ns4:defRPr sz="2800" dirty="0" b="1"><ns4:solidFill><ns4:srgbClr val="FFFFFF"/></ns4:solidFill><ns4:latin typeface="Georgia"/><ns4:ea typeface="Georgia"/></ns4:defRPr></ns4:lvl6pPr><ns4:lvl7pPr algn="l"><ns4:buNone/><ns4:defRPr sz="2800" dirty="0" b="1"><ns4:solidFill><ns4:srgbClr val="FFFFFF"/></ns4:solidFill><ns4:latin typeface="Georgia"/><ns4:ea typeface="Georgia"/></ns4:defRPr></ns4:lvl7pPr><ns4:lvl8pPr algn="l"><ns4:buNone/><ns4:defRPr sz="2800" dirty="0" b="1"><ns4:solidFill><ns4:srgbClr val="FFFFFF"/></ns4:solidFill><ns4:latin typeface="Georgia"/><ns4:ea typeface="Georgia"/></ns4:defRPr></ns4:lvl8pPr><ns4:lvl9pPr algn="l"><ns4:buNone/><ns4:defRPr sz="2800" dirty="0" b="1"><ns4:solidFill><ns4:srgbClr val="FFFFFF"/></ns4:solidFill><ns4:latin typeface="Georgia"/><ns4:ea typeface="Georgia"/></ns4:defRPr></ns4:lvl9pPr></ns4:lstStyle/><ns5:p xmlns:ns5="http://schemas.openxmlformats.org/drawingml/2006/main"><ns5:pPr algn="l"><ns5:buNone/></ns5:pPr><ns5:r><ns5:rPr lang="ja-JP"/><ns5:t>サブタイトル</ns5:t></ns5:r></ns5:p></ns0:txBody></ns0:sp><ns0:sp><ns0:nvSpPr><ns0:cNvPr id="5" name="TL"/><ns0:cNvSpPr><ns1:spLocks xmlns:ns1="http://schemas.openxmlformats.org/drawingml/2006/main" noGrp="1" noSelect="0" noRot="1" noMove="1"/></ns0:cNvSpPr><ns0:nvPr/></ns0:nvSpPr><ns0:spPr><ns2:xfrm xmlns:ns2="http://schemas.openxmlformats.org/drawingml/2006/main"><ns2:off x="457200" y="1280160"/><ns2:ext cx="5303520" cy="2286000"/></ns2:xfrm><ns3:prstGeom xmlns:ns3="http://schemas.openxmlformats.org/drawingml/2006/main" prst="roundRect"><ns3:avLst><ns3:gd name="adj" fmla="val 8000"/></ns3:avLst></ns3:prstGeom><ns4:solidFill xmlns:ns4="http://schemas.openxmlformats.org/drawingml/2006/main"><ns4:srgbClr val="EDF0F7"/></ns4:solidFill><ns5:ln xmlns:ns5="http://schemas.openxmlformats.org/drawingml/2006/main"><ns5:noFill/></ns5:ln></ns0:spPr></ns0:sp><ns0:sp><ns0:nvSpPr><ns0:cNvPr id="6" name="TR"/><ns0:cNvSpPr><ns1:spLocks xmlns:ns1="http://schemas.openxmlformats.org/drawingml/2006/main" noGrp="1" noSelect="0" noRot="1" noMove="1"/></ns0:cNvSpPr><ns0:nvPr/></ns0:nvSpPr><ns0:spPr><ns2:xfrm xmlns:ns2="http://schemas.openxmlformats.org/drawingml/2006/main"><ns2:off x="6126480" y="1280160"/><ns2:ext cx="5394960" cy="2286000"/></ns2:xfrm><ns3:prstGeom xmlns:ns3="http://schemas.openxmlformats.org/drawingml/2006/main" prst="roundRect"><ns3:avLst><ns3:gd name="adj" fmla="val 8000"/></ns3:avLst></ns3:prstGeom><ns4:solidFill xmlns:ns4="http://schemas.openxmlformats.org/drawingml/2006/main"><ns4:srgbClr val="EDF0F7"/></ns4:solidFill><ns5:ln xmlns:ns5="http://schemas.openxmlformats.org/drawingml/2006/main"><ns5:noFill/></ns5:ln></ns0:spPr></ns0:sp><ns0:sp><ns0:nvSpPr><ns0:cNvPr id="7" name="BL"/><ns0:cNvSpPr><ns1:spLocks xmlns:ns1="http://schemas.openxmlformats.org/drawingml/2006/main" noGrp="1" noSelect="0" noRot="1" noMove="1"/></ns0:cNvSpPr><ns0:nvPr/></ns0:nvSpPr><ns0:spPr><ns2:xfrm xmlns:ns2="http://schemas.openxmlformats.org/drawingml/2006/main"><ns2:off x="457200" y="3840480"/><ns2:ext cx="5303520" cy="2286000"/></ns2:xfrm><ns3:prstGeom xmlns:ns3="http://schemas.openxmlformats.org/drawingml/2006/main" prst="roundRect"><ns3:avLst><ns3:gd name="adj" fmla="val 8000"/></ns3:avLst></ns3:prstGeom><ns4:solidFill xmlns:ns4="http://schemas.openxmlformats.org/drawingml/2006/main"><ns4:srgbClr val="EDF0F7"/></ns4:solidFill><ns5:ln xmlns:ns5="http://schemas.openxmlformats.org/drawingml/2006/main"><ns5:noFill/></ns5:ln></ns0:spPr></ns0:sp><ns0:sp><ns0:nvSpPr><ns0:cNvPr id="8" name="BR"/><ns0:cNvSpPr><ns1:spLocks xmlns:ns1="http://schemas.openxmlformats.org/drawingml/2006/main" noGrp="1" noSelect="0" noRot="1" noMove="1"/></ns0:cNvSpPr><ns0:nvPr/></ns0:nvSpPr><ns0:spPr><ns2:xfrm xmlns:ns2="http://schemas.openxmlformats.org/drawingml/2006/main"><ns2:off x="6126480" y="3840480"/><ns2:ext cx="5394960" cy="2286000"/></ns2:xfrm><ns3:prstGeom xmlns:ns3="http://schemas.openxmlformats.org/drawingml/2006/main" prst="roundRect"><ns3:avLst><ns3:gd name="adj" fmla="val 8000"/></ns3:avLst></ns3:prstGeom><ns4:solidFill xmlns:ns4="http://schemas.openxmlformats.org/drawingml/2006/main"><ns4:srgbClr val="EDF0F7"/></ns4:solidFill><ns5:ln xmlns:ns5="http://schemas.openxmlformats.org/drawingml/2006/main"><ns5:noFill/></ns5:ln></ns0:spPr></ns0:sp><ns0:sp><ns0:nvSpPr><ns0:cNvPr id="9" name="A1"/><ns0:cNvSpPr><ns1:spLocks xmlns:ns1="http://schemas.openxmlformats.org/drawingml/2006/main" noGrp="1" noSelect="0" noRot="1" noMove="1"/></ns0:cNvSpPr><ns0:nvPr/></ns0:nvSpPr><ns0:spPr><ns2:xfrm xmlns:ns2="http://schemas.openxmlformats.org/drawingml/2006/main"><ns2:off x="457200" y="1280160"/><ns2:ext cx="54864" cy="2286000"/></ns2:xfrm><ns3:prstGeom xmlns:ns3="http://schemas.openxmlformats.org/drawingml/2006/main" prst="rect"/><ns4:solidFill xmlns:ns4="http://schemas.openxmlformats.org/drawingml/2006/main"><ns4:srgbClr val="3B82F6"/></ns4:solidFill><ns5:ln xmlns:ns5="http://schemas.openxmlformats.org/drawingml/2006/main"><ns5:noFill/></ns5:ln></ns0:spPr></ns0:sp><ns0:sp><ns0:nvSpPr><ns0:cNvPr id="10" name="A2"/><ns0:cNvSpPr><ns1:spLocks xmlns:ns1="http://schemas.openxmlformats.org/drawingml/2006/main" noGrp="1" noSelect="0" noRot="1" noMove="1"/></ns0:cNvSpPr><ns0:nvPr/></ns0:nvSpPr><ns0:spPr><ns2:xfrm xmlns:ns2="http://schemas.openxmlformats.org/drawingml/2006/main"><ns2:off x="6126480" y="1280160"/><ns2:ext cx="54864" cy="2286000"/></ns2:xfrm><ns3:prstGeom xmlns:ns3="http://schemas.openxmlformats.org/drawingml/2006/main" prst="rect"/><ns4:solidFill xmlns:ns4="http://schemas.openxmlformats.org/drawingml/2006/main"><ns4:srgbClr val="06B6D4"/></ns4:solidFill><ns5:ln xmlns:ns5="http://schemas.openxmlformats.org/drawingml/2006/main"><ns5:noFill/></ns5:ln></ns0:spPr></ns0:sp><ns0:sp><ns0:nvSpPr><ns0:cNvPr id="11" name="A3"/><ns0:cNvSpPr><ns1:spLocks xmlns:ns1="http://schemas.openxmlformats.org/drawingml/2006/main" noGrp="1" noSelect="0" noRot="1" noMove="1"/></ns0:cNvSpPr><ns0:nvPr/></ns0:nvSpPr><ns0:spPr><ns2:xfrm xmlns:ns2="http://schemas.openxmlformats.org/drawingml/2006/main"><ns2:off x="457200" y="3840480"/><ns2:ext cx="54864" cy="2286000"/></ns2:xfrm><ns3:prstGeom xmlns:ns3="http://schemas.openxmlformats.org/drawingml/2006/main" prst="rect"/><ns4:solidFill xmlns:ns4="http://schemas.openxmlformats.org/drawingml/2006/main"><ns4:srgbClr val="F59E0B"/></ns4:solidFill><ns5:ln xmlns:ns5="http://schemas.openxmlformats.org/drawingml/2006/main"><ns5:noFill/></ns5:ln></ns0:spPr></ns0:sp><ns0:sp><ns0:nvSpPr><ns0:cNvPr id="12" name="A4"/><ns0:cNvSpPr><ns1:spLocks xmlns:ns1="http://schemas.openxmlformats.org/drawingml/2006/main" noGrp="1" noSelect="0" noRot="1" noMove="1"/></ns0:cNvSpPr><ns0:nvPr/></ns0:nvSpPr><ns0:spPr><ns2:xfrm xmlns:ns2="http://schemas.openxmlformats.org/drawingml/2006/main"><ns2:off x="6126480" y="3840480"/><ns2:ext cx="54864" cy="2286000"/></ns2:xfrm><ns3:prstGeom xmlns:ns3="http://schemas.openxmlformats.org/drawingml/2006/main" prst="rect"/><ns4:solidFill xmlns:ns4="http://schemas.openxmlformats.org/drawingml/2006/main"><ns4:srgbClr val="2563EB"/></ns4:solidFill><ns5:ln xmlns:ns5="http://schemas.openxmlformats.org/drawingml/2006/main"><ns5:noFill/></ns5:ln></ns0:spPr></ns0:sp><ns0:sp><ns0:nvSpPr><ns0:cNvPr id="20" name="Value1.TopLeft"/><ns0:cNvSpPr><ns1:spLocks xmlns:ns1="http://schemas.openxmlformats.org/drawingml/2006/main" noGrp="1"/></ns0:cNvSpPr><ns0:nvPr><ns0:ph idx="1" type="body"/></ns0:nvPr></ns0:nvSpPr><ns0:spPr><ns2:xfrm xmlns:ns2="http://schemas.openxmlformats.org/drawingml/2006/main"><ns2:off x="914400" y="1463040"/><ns2:ext cx="4389120" cy="1828800"/></ns2:xfrm></ns0:spPr><ns0:txBody><ns3:bodyPr xmlns:ns3="http://schemas.openxmlformats.org/drawingml/2006/main" wrap="square" anchor="t" anchorCtr="0"/><ns4:lstStyle/><ns4:defPPr algn="l"><ns4:buNone/><ns4:defRPr sz="1400" dirty="0"><ns4:solidFill><ns4:srgbClr val="1E293B"/></ns4:solidFill><ns4:latin typeface="Calibri"/><ns4:ea typeface="Calibri"/></ns4:defRPr></ns4:defPPr><ns4:lvl1pPr algn="l"><ns4:buNone/><ns4:defRPr sz="1400" dirty="0"><ns4:solidFill><ns4:srgbClr val="1E293B"/></ns4:solidFill><ns4:latin typeface="Calibri"/><ns4:ea typeface="Calibri"/></ns4:defRPr></ns4:lvl1pPr><ns4:lvl2pPr algn="l"><ns4:buNone/><ns4:defRPr sz="1400" dirty="0"><ns4:solidFill><ns4:srgbClr val="1E293B"/></ns4:solidFill><ns4:latin typeface="Calibri"/><ns4:ea typeface="Calibri"/></ns4:defRPr></ns4:lvl2pPr><ns4:lvl3pPr algn="l"><ns4:buNone/><ns4:defRPr sz="1400" dirty="0"><ns4:solidFill><ns4:srgbClr val="1E293B"/></ns4:solidFill><ns4:latin typeface="Calibri"/><ns4:ea typeface="Calibri"/></ns4:defRPr></ns4:lvl3pPr><ns4:lvl4pPr algn="l"><ns4:buNone/><ns4:defRPr sz="1400" dirty="0"><ns4:solidFill><ns4:srgbClr val="1E293B"/></ns4:solidFill><ns4:latin typeface="Calibri"/><ns4:ea typeface="Calibri"/></ns4:defRPr></ns4:lvl4pPr><ns4:lvl5pPr algn="l"><ns4:buNone/><ns4:defRPr sz="1400" dirty="0"><ns4:solidFill><ns4:srgbClr val="1E293B"/></ns4:solidFill><ns4:latin typeface="Calibri"/><ns4:ea typeface="Calibri"/></ns4:defRPr></ns4:lvl5pPr><ns4:lvl6pPr algn="l"><ns4:buNone/><ns4:defRPr sz="1400" dirty="0"><ns4:solidFill><ns4:srgbClr val="1E293B"/></ns4:solidFill><ns4:latin typeface="Calibri"/><ns4:ea typeface="Calibri"/></ns4:defRPr></ns4:lvl6pPr><ns4:lvl7pPr algn="l"><ns4:buNone/><ns4:defRPr sz="1400" dirty="0"><ns4:solidFill><ns4:srgbClr val="1E293B"/></ns4:solidFill><ns4:latin typeface="Calibri"/><ns4:ea typeface="Calibri"/></ns4:defRPr></ns4:lvl7pPr><ns4:lvl8pPr algn="l"><ns4:buNone/><ns4:defRPr sz="1400" dirty="0"><ns4:solidFill><ns4:srgbClr val="1E293B"/></ns4:solidFill><ns4:latin typeface="Calibri"/><ns4:ea typeface="Calibri"/></ns4:defRPr></ns4:lvl8pPr><ns4:lvl9pPr algn="l"><ns4:buNone/><ns4:defRPr sz="1400" dirty="0"><ns4:solidFill><ns4:srgbClr val="1E293B"/></ns4:solidFill><ns4:latin typeface="Calibri"/><ns4:ea typeface="Calibri"/></ns4:defRPr></ns4:lvl9pPr></ns4:lstStyle/><ns5:p xmlns:ns5="http://schemas.openxmlformats.org/drawingml/2006/main"><ns5:pPr algn="l"><ns5:buNone/></ns5:pPr><ns5:r><ns5:rPr lang="ja-JP"/><ns5:t>指標 2
+値・説明</ns5:t></ns5:r></ns5:p></ns0:txBody></ns0:sp><ns0:sp><ns0:nvSpPr><ns0:cNvPr id="22" name="Value3.BottomLeft"/><ns0:cNvSpPr><ns1:spLocks xmlns:ns1="http://schemas.openxmlformats.org/drawingml/2006/main" noGrp="1"/></ns0:cNvSpPr><ns0:nvPr><ns0:ph idx="3" type="body"/></ns0:nvPr></ns0:nvSpPr><ns0:spPr><ns2:xfrm xmlns:ns2="http://schemas.openxmlformats.org/drawingml/2006/main"><ns2:off x="914400" y="4023360"/><ns2:ext cx="4389120" cy="1828800"/></ns2:xfrm></ns0:spPr><ns0:txBody><ns3:bodyPr xmlns:ns3="http://schemas.openxmlformats.org/drawingml/2006/main" wrap="square" anchor="t" anchorCtr="0"/><ns4:lstStyle/><ns4:defPPr algn="l"><ns4:buNone/><ns4:defRPr sz="1400" dirty="0"><ns4:solidFill><ns4:srgbClr val="1E293B"/></ns4:solidFill><ns4:latin typeface="Calibri"/><ns4:ea typeface="Calibri"/></ns4:defRPr></ns4:defPPr><ns4:lvl1pPr algn="l"><ns4:buNone/><ns4:defRPr sz="1400" dirty="0"><ns4:solidFill><ns4:srgbClr val="1E293B"/></ns4:solidFill><ns4:latin typeface="Calibri"/><ns4:ea typeface="Calibri"/></ns4:defRPr></ns4:lvl1pPr><ns4:lvl2pPr algn="l"><ns4:buNone/><ns4:defRPr sz="1400" dirty="0"><ns4:solidFill><ns4:srgbClr val="1E293B"/></ns4:solidFill><ns4:latin typeface="Calibri"/><ns4:ea typeface="Calibri"/></ns4:defRPr></ns4:lvl2pPr><ns4:lvl3pPr algn="l"><ns4:buNone/><ns4:defRPr sz="1400" dirty="0"><ns4:solidFill><ns4:srgbClr val="1E293B"/></ns4:solidFill><ns4:latin typeface="Calibri"/><ns4:ea typeface="Calibri"/></ns4:defRPr></ns4:lvl3pPr><ns4:lvl4pPr algn="l"><ns4:buNone/><ns4:defRPr sz="1400" dirty="0"><ns4:solidFill><ns4:srgbClr val="1E293B"/></ns4:solidFill><ns4:latin typeface="Calibri"/><ns4:ea typeface="Calibri"/></ns4:defRPr></ns4:lvl4pPr><ns4:lvl5pPr algn="l"><ns4:buNone/><ns4:defRPr sz="1400" dirty="0"><ns4:solidFill><ns4:srgbClr val="1E293B"/></ns4:solidFill><ns4:latin typeface="Calibri"/><ns4:ea typeface="Calibri"/></ns4:defRPr></ns4:lvl5pPr><ns4:lvl6pPr algn="l"><ns4:buNone/><ns4:defRPr sz="1400" dirty="0"><ns4:solidFill><ns4:srgbClr val="1E293B"/></ns4:solidFill><ns4:latin typeface="Calibri"/><ns4:ea typeface="Calibri"/></ns4:defRPr></ns4:lvl6pPr><ns4:lvl7pPr algn="l"><ns4:buNone/><ns4:defRPr sz="1400" dirty="0"><ns4:solidFill><ns4:srgbClr val="1E293B"/></ns4:solidFill><ns4:latin typeface="Calibri"/><ns4:ea typeface="Calibri"/></ns4:defRPr></ns4:lvl7pPr><ns4:lvl8pPr algn="l"><ns4:buNone/><ns4:defRPr sz="1400" dirty="0"><ns4:solidFill><ns4:srgbClr val="1E293B"/></ns4:solidFill><ns4:latin typeface="Calibri"/><ns4:ea typeface="Calibri"/></ns4:defRPr></ns4:lvl8pPr><ns4:lvl9pPr algn="l"><ns4:buNone/><ns4:defRPr sz="1400" dirty="0"><ns4:solidFill><ns4:srgbClr val="1E293B"/></ns4:solidFill><ns4:latin typeface="Calibri"/><ns4:ea typeface="Calibri"/></ns4:defRPr></ns4:lvl9pPr></ns4:lstStyle/><ns5:p xmlns:ns5="http://schemas.openxmlformats.org/drawingml/2006/main"><ns5:pPr algn="l"><ns5:buNone/></ns5:pPr><ns5:r><ns5:rPr lang="ja-JP"/><ns5:t>指標 4
+値・説明</ns5:t></ns5:r></ns5:p></ns0:txBody></ns0:sp><ns0:sp><ns0:nvSpPr><ns0:cNvPr id="31" name="SlideNum.Footer"/><ns0:cNvSpPr><ns1:spLocks xmlns:ns1="http://schemas.openxmlformats.org/drawingml/2006/main" noGrp="1"/></ns0:cNvSpPr><ns0:nvPr><ns0:ph idx="50" type="sldNum"/></ns0:nvPr></ns0:nvSpPr><ns0:spPr><ns2:xfrm xmlns:ns2="http://schemas.openxmlformats.org/drawingml/2006/main"><ns2:off x="10972800" y="6446520"/><ns2:ext cx="1097280" cy="274320"/></ns2:xfrm></ns0:spPr><ns0:txBody><ns3:bodyPr xmlns:ns3="http://schemas.openxmlformats.org/drawingml/2006/main" wrap="square" anchor="t" anchorCtr="0"/><ns4:lstStyle><ns4:defPPr algn="r"><ns4:defRPr sz="1000"><ns4:solidFill><ns4:srgbClr val="94A3B8"/></ns4:solidFill></ns4:defRPr></ns4:defPPr></ns4:lstStyle><ns4:defPPr algn="r"><ns4:buNone/><ns4:defRPr sz="1000" dirty="0"><ns4:solidFill><ns4:srgbClr val="94A3B8"/></ns4:solidFill><ns4:latin typeface="Calibri"/><ns4:ea typeface="Calibri"/></ns4:defRPr></ns4:defPPr><ns4:lvl1pPr algn="r"><ns4:buNone/><ns4:defRPr sz="1000" dirty="0"><ns4:solidFill><ns4:srgbClr val="94A3B8"/></ns4:solidFill><ns4:latin typeface="Calibri"/><ns4:ea typeface="Calibri"/></ns4:defRPr></ns4:lvl1pPr><ns4:lvl2pPr algn="r"><ns4:buNone/><ns4:defRPr sz="1000" dirty="0"><ns4:solidFill><ns4:srgbClr val="94A3B8"/></ns4:solidFill><ns4:latin typeface="Calibri"/><ns4:ea typeface="Calibri"/></ns4:defRPr></ns4:lvl2pPr><ns4:lvl3pPr algn="r"><ns4:buNone/><ns4:defRPr sz="1000" dirty="0"><ns4:solidFill><ns4:srgbClr val="94A3B8"/></ns4:solidFill><ns4:latin typeface="Calibri"/><ns4:ea typeface="Calibri"/></ns4:defRPr></ns4:lvl3pPr><ns4:lvl4pPr algn="r"><ns4:buNone/><ns4:defRPr sz="1000" dirty="0"><ns4:solidFill><ns4:srgbClr val="94A3B8"/></ns4:solidFill><ns4:latin typeface="Calibri"/><ns4:ea typeface="Calibri"/></ns4:defRPr></ns4:lvl4pPr><ns4:lvl5pPr algn="r"><ns4:buNone/><ns4:defRPr sz="1000" dirty="0"><ns4:solidFill><ns4:srgbClr val="94A3B8"/></ns4:solidFill><ns4:latin typeface="Calibri"/><ns4:ea typeface="Calibri"/></ns4:defRPr></ns4:lvl5pPr><ns4:lvl6pPr algn="r"><ns4:buNone/><ns4:defRPr sz="1000" dirty="0"><ns4:solidFill><ns4:srgbClr val="94A3B8"/></ns4:solidFill><ns4:latin typeface="Calibri"/><ns4:ea typeface="Calibri"/></ns4:defRPr></ns4:lvl6pPr><ns4:lvl7pPr algn="r"><ns4:buNone/><ns4:defRPr sz="1000" dirty="0"><ns4:solidFill><ns4:srgbClr val="94A3B8"/></ns4:solidFill><ns4:latin typeface="Calibri"/><ns4:ea typeface="Calibri"/></ns4:defRPr></ns4:lvl7pPr><ns4:lvl8pPr algn="r"><ns4:buNone/><ns4:defRPr sz="1000" dirty="0"><ns4:solidFill><ns4:srgbClr val="94A3B8"/></ns4:solidFill><ns4:latin typeface="Calibri"/><ns4:ea typeface="Calibri"/></ns4:defRPr></ns4:lvl8pPr><ns4:lvl9pPr algn="r"><ns4:buNone/><ns4:defRPr sz="1000" dirty="0"><ns4:solidFill><ns4:srgbClr val="94A3B8"/></ns4:solidFill><ns4:latin typeface="Calibri"/><ns4:ea typeface="Calibri"/></ns4:defRPr></ns4:lvl9pPr></ns4:lstStyle><ns5:p xmlns:ns5="http://schemas.openxmlformats.org/drawingml/2006/main"><ns5:pPr algn="r"><ns5:buNone/></ns5:pPr><ns5:r><ns5:rPr lang="ja-JP"/><ns5:t>&lt;#&gt;</ns5:t></ns5:r></ns5:p></ns0:txBody></ns0:sp></ns0:spTree></ns0:cSld><ns0:clrMapOvr/></ns0:sldLayout>
 </file>
 
 <file path=ppt/slideLayouts/slideLayout18.xml><?xml version='1.0' encoding='UTF-8' standalone='yes'?>
-<ns0:sldLayout xmlns:ns0="http://schemas.openxmlformats.org/presentationml/2006/main" type="blank" preserve="1"><ns0:cSld name="Chart.1Chart.Single"><ns0:spTree><ns0:nvGrpSpPr><ns0:cNvPr id="1" name=""/><ns0:cNvGrpSpPr/><ns0:nvPr/></ns0:nvGrpSpPr><ns0:grpSpPr><ns1:xfrm xmlns:ns1="http://schemas.openxmlformats.org/drawingml/2006/main"><ns1:off x="0" y="0"/><ns1:ext cx="0" cy="0"/><ns1:chOff x="0" y="0"/><ns1:chExt cx="0" cy="0"/></ns1:xfrm></ns0:grpSpPr><ns0:sp><ns0:nvSpPr><ns0:cNvPr id="2" name="HeaderBar"/><ns0:cNvSpPr><ns1:spLocks xmlns:ns1="http://schemas.openxmlformats.org/drawingml/2006/main" noGrp="1" noSelect="0" noRot="1" noMove="1"/></ns0:cNvSpPr><ns0:nvPr/></ns0:nvSpPr><ns0:spPr><ns2:xfrm xmlns:ns2="http://schemas.openxmlformats.org/drawingml/2006/main"><ns2:off x="0" y="0"/><ns2:ext cx="12192000" cy="1051560"/></ns2:xfrm><ns3:prstGeom xmlns:ns3="http://schemas.openxmlformats.org/drawingml/2006/main" prst="rect"/><ns4:solidFill xmlns:ns4="http://schemas.openxmlformats.org/drawingml/2006/main"><ns4:srgbClr val="1E2761"/></ns4:solidFill><ns5:ln xmlns:ns5="http://schemas.openxmlformats.org/drawingml/2006/main"><ns5:noFill/></ns5:ln></ns0:spPr></ns0:sp><ns0:sp><ns0:nvSpPr><ns0:cNvPr id="10" name="SlideTitle.Header"/><ns0:cNvSpPr><ns1:spLocks xmlns:ns1="http://schemas.openxmlformats.org/drawingml/2006/main" noGrp="1"/></ns0:cNvSpPr><ns0:nvPr><ns0:ph idx="15" type="body"/></ns0:nvPr></ns0:nvSpPr><ns0:spPr><ns2:xfrm xmlns:ns2="http://schemas.openxmlformats.org/drawingml/2006/main"><ns2:off x="731520" y="91440"/><ns2:ext cx="9144000" cy="475488"/></ns2:xfrm></ns0:spPr><ns0:txBody><ns3:bodyPr xmlns:ns3="http://schemas.openxmlformats.org/drawingml/2006/main" wrap="square" anchor="t" anchorCtr="0"/><ns4:lstStyle xmlns:ns4="http://schemas.openxmlformats.org/drawingml/2006/main"><ns4:defPPr algn="l"><ns4:buNone/><ns4:defRPr sz="2800" dirty="0" b="1"><ns4:solidFill><ns4:srgbClr val="FFFFFF"/></ns4:solidFill><ns4:latin typeface="Georgia"/><ns4:ea typeface="Georgia"/></ns4:defRPr></ns4:defPPr><ns4:lvl1pPr algn="l"><ns4:buNone/><ns4:defRPr sz="2800" dirty="0" b="1"><ns4:solidFill><ns4:srgbClr val="FFFFFF"/></ns4:solidFill><ns4:latin typeface="Georgia"/><ns4:ea typeface="Georgia"/></ns4:defRPr></ns4:lvl1pPr><ns4:lvl2pPr algn="l"><ns4:buNone/><ns4:defRPr sz="2800" dirty="0" b="1"><ns4:solidFill><ns4:srgbClr val="FFFFFF"/></ns4:solidFill><ns4:latin typeface="Georgia"/><ns4:ea typeface="Georgia"/></ns4:defRPr></ns4:lvl2pPr><ns4:lvl3pPr algn="l"><ns4:buNone/><ns4:defRPr sz="2800" dirty="0" b="1"><ns4:solidFill><ns4:srgbClr val="FFFFFF"/></ns4:solidFill><ns4:latin typeface="Georgia"/><ns4:ea typeface="Georgia"/></ns4:defRPr></ns4:lvl3pPr><ns4:lvl4pPr algn="l"><ns4:buNone/><ns4:defRPr sz="2800" dirty="0" b="1"><ns4:solidFill><ns4:srgbClr val="FFFFFF"/></ns4:solidFill><ns4:latin typeface="Georgia"/><ns4:ea typeface="Georgia"/></ns4:defRPr></ns4:lvl4pPr><ns4:lvl5pPr algn="l"><ns4:buNone/><ns4:defRPr sz="2800" dirty="0" b="1"><ns4:solidFill><ns4:srgbClr val="FFFFFF"/></ns4:solidFill><ns4:latin typeface="Georgia"/><ns4:ea typeface="Georgia"/></ns4:defRPr></ns4:lvl5pPr><ns4:lvl6pPr algn="l"><ns4:buNone/><ns4:defRPr sz="2800" dirty="0" b="1"><ns4:solidFill><ns4:srgbClr val="FFFFFF"/></ns4:solidFill><ns4:latin typeface="Georgia"/><ns4:ea typeface="Georgia"/></ns4:defRPr></ns4:lvl6pPr><ns4:lvl7pPr algn="l"><ns4:buNone/><ns4:defRPr sz="2800" dirty="0" b="1"><ns4:solidFill><ns4:srgbClr val="FFFFFF"/></ns4:solidFill><ns4:latin typeface="Georgia"/><ns4:ea typeface="Georgia"/></ns4:defRPr></ns4:lvl7pPr><ns4:lvl8pPr algn="l"><ns4:buNone/><ns4:defRPr sz="2800" dirty="0" b="1"><ns4:solidFill><ns4:srgbClr val="FFFFFF"/></ns4:solidFill><ns4:latin typeface="Georgia"/><ns4:ea typeface="Georgia"/></ns4:defRPr></ns4:lvl8pPr><ns4:lvl9pPr algn="l"><ns4:buNone/><ns4:defRPr sz="2800" dirty="0" b="1"><ns4:solidFill><ns4:srgbClr val="FFFFFF"/></ns4:solidFill><ns4:latin typeface="Georgia"/><ns4:ea typeface="Georgia"/></ns4:defRPr></ns4:lvl9pPr></ns4:lstStyle/><ns5:p xmlns:ns5="http://schemas.openxmlformats.org/drawingml/2006/main"><ns5:pPr algn="l"><ns5:buNone/></ns5:pPr><ns5:r><ns5:rPr lang="ja-JP"/><ns5:t>サブタイトル</ns5:t></ns5:r></ns5:p></ns0:txBody></ns0:sp><ns0:sp><ns0:nvSpPr><ns0:cNvPr id="5" name="ChartArea"/><ns0:cNvSpPr><ns1:spLocks xmlns:ns1="http://schemas.openxmlformats.org/drawingml/2006/main" noGrp="1" noSelect="0" noRot="1" noMove="1"/></ns0:cNvSpPr><ns0:nvPr/></ns0:nvSpPr><ns0:spPr><ns2:xfrm xmlns:ns2="http://schemas.openxmlformats.org/drawingml/2006/main"><ns2:off x="457200" y="1280160"/><ns2:ext cx="11247120" cy="4937760"/></ns2:xfrm><ns3:prstGeom xmlns:ns3="http://schemas.openxmlformats.org/drawingml/2006/main" prst="roundRect"><ns3:avLst><ns3:gd name="adj" fmla="val 6000"/></ns3:avLst></ns3:prstGeom><ns4:solidFill xmlns:ns4="http://schemas.openxmlformats.org/drawingml/2006/main"><ns4:srgbClr val="EDF0F7"/></ns4:solidFill><ns5:ln xmlns:ns5="http://schemas.openxmlformats.org/drawingml/2006/main"><ns5:noFill/></ns5:ln></ns0:spPr></ns0:sp><ns0:sp><ns0:nvSpPr><ns0:cNvPr id="20" name="Body.Center"/><ns0:cNvSpPr><ns1:spLocks xmlns:ns1="http://schemas.openxmlformats.org/drawingml/2006/main" noGrp="1"/></ns0:cNvSpPr><ns0:nvPr><ns0:ph idx="1" type="body"/></ns0:nvPr></ns0:nvSpPr><ns0:spPr><ns2:xfrm xmlns:ns2="http://schemas.openxmlformats.org/drawingml/2006/main"><ns2:off x="731520" y="1463040"/><ns2:ext cx="10698480" cy="4572000"/></ns2:xfrm></ns0:spPr><ns0:txBody><ns3:bodyPr xmlns:ns3="http://schemas.openxmlformats.org/drawingml/2006/main" wrap="square" anchor="t" anchorCtr="0"/><ns4:lstStyle xmlns:ns4="http://schemas.openxmlformats.org/drawingml/2006/main"><ns4:defPPr algn="ctr"><ns4:buNone/><ns4:defRPr sz="1400" dirty="0"><ns4:solidFill><ns4:srgbClr val="94A3B8"/></ns4:solidFill><ns4:latin typeface="Calibri"/><ns4:ea typeface="Calibri"/></ns4:defRPr></ns4:defPPr><ns4:lvl1pPr algn="ctr"><ns4:buNone/><ns4:defRPr sz="1400" dirty="0"><ns4:solidFill><ns4:srgbClr val="94A3B8"/></ns4:solidFill><ns4:latin typeface="Calibri"/><ns4:ea typeface="Calibri"/></ns4:defRPr></ns4:lvl1pPr><ns4:lvl2pPr algn="ctr"><ns4:buNone/><ns4:defRPr sz="1400" dirty="0"><ns4:solidFill><ns4:srgbClr val="94A3B8"/></ns4:solidFill><ns4:latin typeface="Calibri"/><ns4:ea typeface="Calibri"/></ns4:defRPr></ns4:lvl2pPr><ns4:lvl3pPr algn="ctr"><ns4:buNone/><ns4:defRPr sz="1400" dirty="0"><ns4:solidFill><ns4:srgbClr val="94A3B8"/></ns4:solidFill><ns4:latin typeface="Calibri"/><ns4:ea typeface="Calibri"/></ns4:defRPr></ns4:lvl3pPr><ns4:lvl4pPr algn="ctr"><ns4:buNone/><ns4:defRPr sz="1400" dirty="0"><ns4:solidFill><ns4:srgbClr val="94A3B8"/></ns4:solidFill><ns4:latin typeface="Calibri"/><ns4:ea typeface="Calibri"/></ns4:defRPr></ns4:lvl4pPr><ns4:lvl5pPr algn="ctr"><ns4:buNone/><ns4:defRPr sz="1400" dirty="0"><ns4:solidFill><ns4:srgbClr val="94A3B8"/></ns4:solidFill><ns4:latin typeface="Calibri"/><ns4:ea typeface="Calibri"/></ns4:defRPr></ns4:lvl5pPr><ns4:lvl6pPr algn="ctr"><ns4:buNone/><ns4:defRPr sz="1400" dirty="0"><ns4:solidFill><ns4:srgbClr val="94A3B8"/></ns4:solidFill><ns4:latin typeface="Calibri"/><ns4:ea typeface="Calibri"/></ns4:defRPr></ns4:lvl6pPr><ns4:lvl7pPr algn="ctr"><ns4:buNone/><ns4:defRPr sz="1400" dirty="0"><ns4:solidFill><ns4:srgbClr val="94A3B8"/></ns4:solidFill><ns4:latin typeface="Calibri"/><ns4:ea typeface="Calibri"/></ns4:defRPr></ns4:lvl7pPr><ns4:lvl8pPr algn="ctr"><ns4:buNone/><ns4:defRPr sz="1400" dirty="0"><ns4:solidFill><ns4:srgbClr val="94A3B8"/></ns4:solidFill><ns4:latin typeface="Calibri"/><ns4:ea typeface="Calibri"/></ns4:defRPr></ns4:lvl8pPr><ns4:lvl9pPr algn="ctr"><ns4:buNone/><ns4:defRPr sz="1400" dirty="0"><ns4:solidFill><ns4:srgbClr val="94A3B8"/></ns4:solidFill><ns4:latin typeface="Calibri"/><ns4:ea typeface="Calibri"/></ns4:defRPr></ns4:lvl9pPr></ns4:lstStyle/><ns5:p xmlns:ns5="http://schemas.openxmlformats.org/drawingml/2006/main"><ns5:pPr algn="r"><ns5:buNone/></ns5:pPr><ns5:r><ns5:rPr lang="ja-JP"/><ns5:t>&lt;#&gt;</ns5:t></ns5:r></ns5:p></ns0:txBody></ns0:sp></ns0:spTree></ns0:cSld><ns0:clrMapOvr/></ns0:sldLayout>
+<ns0:sldLayout xmlns:ns0="http://schemas.openxmlformats.org/presentationml/2006/main" type="blank" preserve="1"><ns0:cSld name="Chart.1Chart.Single"><ns0:spTree><ns0:nvGrpSpPr><ns0:cNvPr id="1" name=""/><ns0:cNvGrpSpPr/><ns0:nvPr/></ns0:nvGrpSpPr><ns0:grpSpPr><ns1:xfrm xmlns:ns1="http://schemas.openxmlformats.org/drawingml/2006/main"><ns1:off x="0" y="0"/><ns1:ext cx="0" cy="0"/><ns1:chOff x="0" y="0"/><ns1:chExt cx="0" cy="0"/></ns1:xfrm></ns0:grpSpPr><ns0:sp><ns0:nvSpPr><ns0:cNvPr id="2" name="HeaderBar"/><ns0:cNvSpPr><ns1:spLocks xmlns:ns1="http://schemas.openxmlformats.org/drawingml/2006/main" noGrp="1" noSelect="0" noRot="1" noMove="1"/></ns0:cNvSpPr><ns0:nvPr/></ns0:nvSpPr><ns0:spPr><ns2:xfrm xmlns:ns2="http://schemas.openxmlformats.org/drawingml/2006/main"><ns2:off x="0" y="0"/><ns2:ext cx="12192000" cy="1051560"/></ns2:xfrm><ns3:prstGeom xmlns:ns3="http://schemas.openxmlformats.org/drawingml/2006/main" prst="rect"/><ns4:solidFill xmlns:ns4="http://schemas.openxmlformats.org/drawingml/2006/main"><ns4:srgbClr val="1E2761"/></ns4:solidFill><ns5:ln xmlns:ns5="http://schemas.openxmlformats.org/drawingml/2006/main"><ns5:noFill/></ns5:ln></ns0:spPr></ns0:sp><ns0:sp><ns0:nvSpPr><ns0:cNvPr id="10" name="SlideTitle.Header"/><ns0:cNvSpPr><ns1:spLocks xmlns:ns1="http://schemas.openxmlformats.org/drawingml/2006/main" noGrp="1"/></ns0:cNvSpPr><ns0:nvPr><ns0:ph idx="15" type="body"/></ns0:nvPr></ns0:nvSpPr><ns0:spPr><ns2:xfrm xmlns:ns2="http://schemas.openxmlformats.org/drawingml/2006/main"><ns2:off x="731520" y="91440"/><ns2:ext cx="9144000" cy="475488"/></ns2:xfrm></ns0:spPr><ns0:txBody><ns3:bodyPr xmlns:ns3="http://schemas.openxmlformats.org/drawingml/2006/main" wrap="square" anchor="t" anchorCtr="0"/><ns4:lstStyle><ns4:defPPr><ns4:defRPr sz="2800" b="1"><ns4:solidFill><ns4:srgbClr val="FFFFFF"/></ns4:solidFill></ns4:defRPr></ns4:defPPr></ns4:lstStyle><ns4:defPPr algn="l"><ns4:buNone/><ns4:defRPr sz="2800" dirty="0" b="1"><ns4:solidFill><ns4:srgbClr val="FFFFFF"/></ns4:solidFill><ns4:latin typeface="Georgia"/><ns4:ea typeface="Georgia"/></ns4:defRPr></ns4:defPPr><ns4:lvl1pPr algn="l"><ns4:buNone/><ns4:defRPr sz="2800" dirty="0" b="1"><ns4:solidFill><ns4:srgbClr val="FFFFFF"/></ns4:solidFill><ns4:latin typeface="Georgia"/><ns4:ea typeface="Georgia"/></ns4:defRPr></ns4:lvl1pPr><ns4:lvl2pPr algn="l"><ns4:buNone/><ns4:defRPr sz="2800" dirty="0" b="1"><ns4:solidFill><ns4:srgbClr val="FFFFFF"/></ns4:solidFill><ns4:latin typeface="Georgia"/><ns4:ea typeface="Georgia"/></ns4:defRPr></ns4:lvl2pPr><ns4:lvl3pPr algn="l"><ns4:buNone/><ns4:defRPr sz="2800" dirty="0" b="1"><ns4:solidFill><ns4:srgbClr val="FFFFFF"/></ns4:solidFill><ns4:latin typeface="Georgia"/><ns4:ea typeface="Georgia"/></ns4:defRPr></ns4:lvl3pPr><ns4:lvl4pPr algn="l"><ns4:buNone/><ns4:defRPr sz="2800" dirty="0" b="1"><ns4:solidFill><ns4:srgbClr val="FFFFFF"/></ns4:solidFill><ns4:latin typeface="Georgia"/><ns4:ea typeface="Georgia"/></ns4:defRPr></ns4:lvl4pPr><ns4:lvl5pPr algn="l"><ns4:buNone/><ns4:defRPr sz="2800" dirty="0" b="1"><ns4:solidFill><ns4:srgbClr val="FFFFFF"/></ns4:solidFill><ns4:latin typeface="Georgia"/><ns4:ea typeface="Georgia"/></ns4:defRPr></ns4:lvl5pPr><ns4:lvl6pPr algn="l"><ns4:buNone/><ns4:defRPr sz="2800" dirty="0" b="1"><ns4:solidFill><ns4:srgbClr val="FFFFFF"/></ns4:solidFill><ns4:latin typeface="Georgia"/><ns4:ea typeface="Georgia"/></ns4:defRPr></ns4:lvl6pPr><ns4:lvl7pPr algn="l"><ns4:buNone/><ns4:defRPr sz="2800" dirty="0" b="1"><ns4:solidFill><ns4:srgbClr val="FFFFFF"/></ns4:solidFill><ns4:latin typeface="Georgia"/><ns4:ea typeface="Georgia"/></ns4:defRPr></ns4:lvl7pPr><ns4:lvl8pPr algn="l"><ns4:buNone/><ns4:defRPr sz="2800" dirty="0" b="1"><ns4:solidFill><ns4:srgbClr val="FFFFFF"/></ns4:solidFill><ns4:latin typeface="Georgia"/><ns4:ea typeface="Georgia"/></ns4:defRPr></ns4:lvl8pPr><ns4:lvl9pPr algn="l"><ns4:buNone/><ns4:defRPr sz="2800" dirty="0" b="1"><ns4:solidFill><ns4:srgbClr val="FFFFFF"/></ns4:solidFill><ns4:latin typeface="Georgia"/><ns4:ea typeface="Georgia"/></ns4:defRPr></ns4:lvl9pPr></ns4:lstStyle/><ns5:p xmlns:ns5="http://schemas.openxmlformats.org/drawingml/2006/main"><ns5:pPr algn="l"><ns5:buNone/></ns5:pPr><ns5:r><ns5:rPr lang="ja-JP"/><ns5:t>サブタイトル</ns5:t></ns5:r></ns5:p></ns0:txBody></ns0:sp><ns0:sp><ns0:nvSpPr><ns0:cNvPr id="5" name="ChartArea"/><ns0:cNvSpPr><ns1:spLocks xmlns:ns1="http://schemas.openxmlformats.org/drawingml/2006/main" noGrp="1" noSelect="0" noRot="1" noMove="1"/></ns0:cNvSpPr><ns0:nvPr/></ns0:nvSpPr><ns0:spPr><ns2:xfrm xmlns:ns2="http://schemas.openxmlformats.org/drawingml/2006/main"><ns2:off x="457200" y="1280160"/><ns2:ext cx="11247120" cy="4937760"/></ns2:xfrm><ns3:prstGeom xmlns:ns3="http://schemas.openxmlformats.org/drawingml/2006/main" prst="roundRect"><ns3:avLst><ns3:gd name="adj" fmla="val 6000"/></ns3:avLst></ns3:prstGeom><ns4:solidFill xmlns:ns4="http://schemas.openxmlformats.org/drawingml/2006/main"><ns4:srgbClr val="EDF0F7"/></ns4:solidFill><ns5:ln xmlns:ns5="http://schemas.openxmlformats.org/drawingml/2006/main"><ns5:noFill/></ns5:ln></ns0:spPr></ns0:sp><ns0:sp><ns0:nvSpPr><ns0:cNvPr id="20" name="Body.Center"/><ns0:cNvSpPr><ns1:spLocks xmlns:ns1="http://schemas.openxmlformats.org/drawingml/2006/main" noGrp="1"/></ns0:cNvSpPr><ns0:nvPr><ns0:ph idx="1" type="body"/></ns0:nvPr></ns0:nvSpPr><ns0:spPr><ns2:xfrm xmlns:ns2="http://schemas.openxmlformats.org/drawingml/2006/main"><ns2:off x="731520" y="1463040"/><ns2:ext cx="10698480" cy="4572000"/></ns2:xfrm></ns0:spPr><ns0:txBody><ns3:bodyPr xmlns:ns3="http://schemas.openxmlformats.org/drawingml/2006/main" wrap="square" anchor="t" anchorCtr="0"/><ns4:lstStyle><ns4:defPPr algn="ctr"><ns4:defRPr><ns4:solidFill><ns4:srgbClr val="94A3B8"/></ns4:solidFill></ns4:defRPr></ns4:defPPr></ns4:lstStyle><ns4:defPPr algn="ctr"><ns4:buNone/><ns4:defRPr sz="1400" dirty="0"><ns4:solidFill><ns4:srgbClr val="94A3B8"/></ns4:solidFill><ns4:latin typeface="Calibri"/><ns4:ea typeface="Calibri"/></ns4:defRPr></ns4:defPPr><ns4:lvl1pPr algn="ctr"><ns4:buNone/><ns4:defRPr sz="1400" dirty="0"><ns4:solidFill><ns4:srgbClr val="94A3B8"/></ns4:solidFill><ns4:latin typeface="Calibri"/><ns4:ea typeface="Calibri"/></ns4:defRPr></ns4:lvl1pPr><ns4:lvl2pPr algn="ctr"><ns4:buNone/><ns4:defRPr sz="1400" dirty="0"><ns4:solidFill><ns4:srgbClr val="94A3B8"/></ns4:solidFill><ns4:latin typeface="Calibri"/><ns4:ea typeface="Calibri"/></ns4:defRPr></ns4:lvl2pPr><ns4:lvl3pPr algn="ctr"><ns4:buNone/><ns4:defRPr sz="1400" dirty="0"><ns4:solidFill><ns4:srgbClr val="94A3B8"/></ns4:solidFill><ns4:latin typeface="Calibri"/><ns4:ea typeface="Calibri"/></ns4:defRPr></ns4:lvl3pPr><ns4:lvl4pPr algn="ctr"><ns4:buNone/><ns4:defRPr sz="1400" dirty="0"><ns4:solidFill><ns4:srgbClr val="94A3B8"/></ns4:solidFill><ns4:latin typeface="Calibri"/><ns4:ea typeface="Calibri"/></ns4:defRPr></ns4:lvl4pPr><ns4:lvl5pPr algn="ctr"><ns4:buNone/><ns4:defRPr sz="1400" dirty="0"><ns4:solidFill><ns4:srgbClr val="94A3B8"/></ns4:solidFill><ns4:latin typeface="Calibri"/><ns4:ea typeface="Calibri"/></ns4:defRPr></ns4:lvl5pPr><ns4:lvl6pPr algn="ctr"><ns4:buNone/><ns4:defRPr sz="1400" dirty="0"><ns4:solidFill><ns4:srgbClr val="94A3B8"/></ns4:solidFill><ns4:latin typeface="Calibri"/><ns4:ea typeface="Calibri"/></ns4:defRPr></ns4:lvl6pPr><ns4:lvl7pPr algn="ctr"><ns4:buNone/><ns4:defRPr sz="1400" dirty="0"><ns4:solidFill><ns4:srgbClr val="94A3B8"/></ns4:solidFill><ns4:latin typeface="Calibri"/><ns4:ea typeface="Calibri"/></ns4:defRPr></ns4:lvl7pPr><ns4:lvl8pPr algn="ctr"><ns4:buNone/><ns4:defRPr sz="1400" dirty="0"><ns4:solidFill><ns4:srgbClr val="94A3B8"/></ns4:solidFill><ns4:latin typeface="Calibri"/><ns4:ea typeface="Calibri"/></ns4:defRPr></ns4:lvl8pPr><ns4:lvl9pPr algn="ctr"><ns4:buNone/><ns4:defRPr sz="1400" dirty="0"><ns4:solidFill><ns4:srgbClr val="94A3B8"/></ns4:solidFill><ns4:latin typeface="Calibri"/><ns4:ea typeface="Calibri"/></ns4:defRPr></ns4:lvl9pPr></ns4:lstStyle/><ns5:p xmlns:ns5="http://schemas.openxmlformats.org/drawingml/2006/main"><ns5:pPr algn="r"><ns5:buNone/></ns5:pPr><ns5:r><ns5:rPr lang="ja-JP"/><ns5:t>&lt;#&gt;</ns5:t></ns5:r></ns5:p></ns0:txBody></ns0:sp></ns0:spTree></ns0:cSld><ns0:clrMapOvr/></ns0:sldLayout>
 </file>
 
 <file path=ppt/slideLayouts/slideLayout19.xml><?xml version='1.0' encoding='UTF-8' standalone='yes'?>
-<ns0:sldLayout xmlns:ns0="http://schemas.openxmlformats.org/presentationml/2006/main" type="blank" preserve="1"><ns0:cSld name="Chart.1Chart.Single+1Analysis"><ns0:spTree><ns0:nvGrpSpPr><ns0:cNvPr id="1" name=""/><ns0:cNvGrpSpPr/><ns0:nvPr/></ns0:nvGrpSpPr><ns0:grpSpPr><ns1:xfrm xmlns:ns1="http://schemas.openxmlformats.org/drawingml/2006/main"><ns1:off x="0" y="0"/><ns1:ext cx="0" cy="0"/><ns1:chOff x="0" y="0"/><ns1:chExt cx="0" cy="0"/></ns1:xfrm></ns0:grpSpPr><ns0:sp><ns0:nvSpPr><ns0:cNvPr id="2" name="HeaderBar"/><ns0:cNvSpPr><ns1:spLocks xmlns:ns1="http://schemas.openxmlformats.org/drawingml/2006/main" noGrp="1" noSelect="0" noRot="1" noMove="1"/></ns0:cNvSpPr><ns0:nvPr/></ns0:nvSpPr><ns0:spPr><ns2:xfrm xmlns:ns2="http://schemas.openxmlformats.org/drawingml/2006/main"><ns2:off x="0" y="0"/><ns2:ext cx="12192000" cy="1051560"/></ns2:xfrm><ns3:prstGeom xmlns:ns3="http://schemas.openxmlformats.org/drawingml/2006/main" prst="rect"/><ns4:solidFill xmlns:ns4="http://schemas.openxmlformats.org/drawingml/2006/main"><ns4:srgbClr val="1E2761"/></ns4:solidFill><ns5:ln xmlns:ns5="http://schemas.openxmlformats.org/drawingml/2006/main"><ns5:noFill/></ns5:ln></ns0:spPr></ns0:sp><ns0:sp><ns0:nvSpPr><ns0:cNvPr id="10" name="SlideTitle.Header"/><ns0:cNvSpPr><ns1:spLocks xmlns:ns1="http://schemas.openxmlformats.org/drawingml/2006/main" noGrp="1"/></ns0:cNvSpPr><ns0:nvPr><ns0:ph idx="15" type="body"/></ns0:nvPr></ns0:nvSpPr><ns0:spPr><ns2:xfrm xmlns:ns2="http://schemas.openxmlformats.org/drawingml/2006/main"><ns2:off x="731520" y="91440"/><ns2:ext cx="9144000" cy="475488"/></ns2:xfrm></ns0:spPr><ns0:txBody><ns3:bodyPr xmlns:ns3="http://schemas.openxmlformats.org/drawingml/2006/main" wrap="square" anchor="t" anchorCtr="0"/><ns4:lstStyle xmlns:ns4="http://schemas.openxmlformats.org/drawingml/2006/main"><ns4:defPPr algn="l"><ns4:buNone/><ns4:defRPr sz="2800" dirty="0" b="1"><ns4:solidFill><ns4:srgbClr val="FFFFFF"/></ns4:solidFill><ns4:latin typeface="Georgia"/><ns4:ea typeface="Georgia"/></ns4:defRPr></ns4:defPPr><ns4:lvl1pPr algn="l"><ns4:buNone/><ns4:defRPr sz="2800" dirty="0" b="1"><ns4:solidFill><ns4:srgbClr val="FFFFFF"/></ns4:solidFill><ns4:latin typeface="Georgia"/><ns4:ea typeface="Georgia"/></ns4:defRPr></ns4:lvl1pPr><ns4:lvl2pPr algn="l"><ns4:buNone/><ns4:defRPr sz="2800" dirty="0" b="1"><ns4:solidFill><ns4:srgbClr val="FFFFFF"/></ns4:solidFill><ns4:latin typeface="Georgia"/><ns4:ea typeface="Georgia"/></ns4:defRPr></ns4:lvl2pPr><ns4:lvl3pPr algn="l"><ns4:buNone/><ns4:defRPr sz="2800" dirty="0" b="1"><ns4:solidFill><ns4:srgbClr val="FFFFFF"/></ns4:solidFill><ns4:latin typeface="Georgia"/><ns4:ea typeface="Georgia"/></ns4:defRPr></ns4:lvl3pPr><ns4:lvl4pPr algn="l"><ns4:buNone/><ns4:defRPr sz="2800" dirty="0" b="1"><ns4:solidFill><ns4:srgbClr val="FFFFFF"/></ns4:solidFill><ns4:latin typeface="Georgia"/><ns4:ea typeface="Georgia"/></ns4:defRPr></ns4:lvl4pPr><ns4:lvl5pPr algn="l"><ns4:buNone/><ns4:defRPr sz="2800" dirty="0" b="1"><ns4:solidFill><ns4:srgbClr val="FFFFFF"/></ns4:solidFill><ns4:latin typeface="Georgia"/><ns4:ea typeface="Georgia"/></ns4:defRPr></ns4:lvl5pPr><ns4:lvl6pPr algn="l"><ns4:buNone/><ns4:defRPr sz="2800" dirty="0" b="1"><ns4:solidFill><ns4:srgbClr val="FFFFFF"/></ns4:solidFill><ns4:latin typeface="Georgia"/><ns4:ea typeface="Georgia"/></ns4:defRPr></ns4:lvl6pPr><ns4:lvl7pPr algn="l"><ns4:buNone/><ns4:defRPr sz="2800" dirty="0" b="1"><ns4:solidFill><ns4:srgbClr val="FFFFFF"/></ns4:solidFill><ns4:latin typeface="Georgia"/><ns4:ea typeface="Georgia"/></ns4:defRPr></ns4:lvl7pPr><ns4:lvl8pPr algn="l"><ns4:buNone/><ns4:defRPr sz="2800" dirty="0" b="1"><ns4:solidFill><ns4:srgbClr val="FFFFFF"/></ns4:solidFill><ns4:latin typeface="Georgia"/><ns4:ea typeface="Georgia"/></ns4:defRPr></ns4:lvl8pPr><ns4:lvl9pPr algn="l"><ns4:buNone/><ns4:defRPr sz="2800" dirty="0" b="1"><ns4:solidFill><ns4:srgbClr val="FFFFFF"/></ns4:solidFill><ns4:latin typeface="Georgia"/><ns4:ea typeface="Georgia"/></ns4:defRPr></ns4:lvl9pPr></ns4:lstStyle/><ns5:p xmlns:ns5="http://schemas.openxmlformats.org/drawingml/2006/main"><ns5:pPr algn="l"><ns5:buNone/></ns5:pPr><ns5:r><ns5:rPr lang="ja-JP"/><ns5:t>サブタイトル</ns5:t></ns5:r></ns5:p></ns0:txBody></ns0:sp><ns0:sp><ns0:nvSpPr><ns0:cNvPr id="5" name="ChartArea"/><ns0:cNvSpPr><ns1:spLocks xmlns:ns1="http://schemas.openxmlformats.org/drawingml/2006/main" noGrp="1" noSelect="0" noRot="1" noMove="1"/></ns0:cNvSpPr><ns0:nvPr/></ns0:nvSpPr><ns0:spPr><ns2:xfrm xmlns:ns2="http://schemas.openxmlformats.org/drawingml/2006/main"><ns2:off x="457200" y="1280160"/><ns2:ext cx="6858000" cy="4937760"/></ns2:xfrm><ns3:prstGeom xmlns:ns3="http://schemas.openxmlformats.org/drawingml/2006/main" prst="roundRect"><ns3:avLst><ns3:gd name="adj" fmla="val 6000"/></ns3:avLst></ns3:prstGeom><ns4:solidFill xmlns:ns4="http://schemas.openxmlformats.org/drawingml/2006/main"><ns4:srgbClr val="EDF0F7"/></ns4:solidFill><ns5:ln xmlns:ns5="http://schemas.openxmlformats.org/drawingml/2006/main"><ns5:noFill/></ns5:ln></ns0:spPr></ns0:sp><ns0:sp><ns0:nvSpPr><ns0:cNvPr id="20" name="Body.Left"/><ns0:cNvSpPr><ns1:spLocks xmlns:ns1="http://schemas.openxmlformats.org/drawingml/2006/main" noGrp="1"/></ns0:cNvSpPr><ns0:nvPr><ns0:ph idx="1" type="body"/></ns0:nvPr></ns0:nvSpPr><ns0:spPr><ns2:xfrm xmlns:ns2="http://schemas.openxmlformats.org/drawingml/2006/main"><ns2:off x="731520" y="1463040"/><ns2:ext cx="6309360" cy="4572000"/></ns2:xfrm></ns0:spPr><ns0:txBody><ns3:bodyPr xmlns:ns3="http://schemas.openxmlformats.org/drawingml/2006/main" wrap="square" anchor="t" anchorCtr="0"/><ns4:lstStyle xmlns:ns4="http://schemas.openxmlformats.org/drawingml/2006/main"><ns4:defPPr algn="ctr"><ns4:buNone/><ns4:defRPr sz="1400" dirty="0"><ns4:solidFill><ns4:srgbClr val="94A3B8"/></ns4:solidFill><ns4:latin typeface="Calibri"/><ns4:ea typeface="Calibri"/></ns4:defRPr></ns4:defPPr><ns4:lvl1pPr algn="ctr"><ns4:buNone/><ns4:defRPr sz="1400" dirty="0"><ns4:solidFill><ns4:srgbClr val="94A3B8"/></ns4:solidFill><ns4:latin typeface="Calibri"/><ns4:ea typeface="Calibri"/></ns4:defRPr></ns4:lvl1pPr><ns4:lvl2pPr algn="ctr"><ns4:buNone/><ns4:defRPr sz="1400" dirty="0"><ns4:solidFill><ns4:srgbClr val="94A3B8"/></ns4:solidFill><ns4:latin typeface="Calibri"/><ns4:ea typeface="Calibri"/></ns4:defRPr></ns4:lvl2pPr><ns4:lvl3pPr algn="ctr"><ns4:buNone/><ns4:defRPr sz="1400" dirty="0"><ns4:solidFill><ns4:srgbClr val="94A3B8"/></ns4:solidFill><ns4:latin typeface="Calibri"/><ns4:ea typeface="Calibri"/></ns4:defRPr></ns4:lvl3pPr><ns4:lvl4pPr algn="ctr"><ns4:buNone/><ns4:defRPr sz="1400" dirty="0"><ns4:solidFill><ns4:srgbClr val="94A3B8"/></ns4:solidFill><ns4:latin typeface="Calibri"/><ns4:ea typeface="Calibri"/></ns4:defRPr></ns4:lvl4pPr><ns4:lvl5pPr algn="ctr"><ns4:buNone/><ns4:defRPr sz="1400" dirty="0"><ns4:solidFill><ns4:srgbClr val="94A3B8"/></ns4:solidFill><ns4:latin typeface="Calibri"/><ns4:ea typeface="Calibri"/></ns4:defRPr></ns4:lvl5pPr><ns4:lvl6pPr algn="ctr"><ns4:buNone/><ns4:defRPr sz="1400" dirty="0"><ns4:solidFill><ns4:srgbClr val="94A3B8"/></ns4:solidFill><ns4:latin typeface="Calibri"/><ns4:ea typeface="Calibri"/></ns4:defRPr></ns4:lvl6pPr><ns4:lvl7pPr algn="ctr"><ns4:buNone/><ns4:defRPr sz="1400" dirty="0"><ns4:solidFill><ns4:srgbClr val="94A3B8"/></ns4:solidFill><ns4:latin typeface="Calibri"/><ns4:ea typeface="Calibri"/></ns4:defRPr></ns4:lvl7pPr><ns4:lvl8pPr algn="ctr"><ns4:buNone/><ns4:defRPr sz="1400" dirty="0"><ns4:solidFill><ns4:srgbClr val="94A3B8"/></ns4:solidFill><ns4:latin typeface="Calibri"/><ns4:ea typeface="Calibri"/></ns4:defRPr></ns4:lvl8pPr><ns4:lvl9pPr algn="ctr"><ns4:buNone/><ns4:defRPr sz="1400" dirty="0"><ns4:solidFill><ns4:srgbClr val="94A3B8"/></ns4:solidFill><ns4:latin typeface="Calibri"/><ns4:ea typeface="Calibri"/></ns4:defRPr></ns4:lvl9pPr></ns4:lstStyle/><ns5:p xmlns:ns5="http://schemas.openxmlformats.org/drawingml/2006/main"><ns5:pPr algn="l"><ns5:buNone/></ns5:pPr><ns5:r><ns5:rPr lang="ja-JP"/><ns5:t>分析テキスト
+<ns0:sldLayout xmlns:ns0="http://schemas.openxmlformats.org/presentationml/2006/main" type="blank" preserve="1"><ns0:cSld name="Chart.1Chart.Single+1Analysis"><ns0:spTree><ns0:nvGrpSpPr><ns0:cNvPr id="1" name=""/><ns0:cNvGrpSpPr/><ns0:nvPr/></ns0:nvGrpSpPr><ns0:grpSpPr><ns1:xfrm xmlns:ns1="http://schemas.openxmlformats.org/drawingml/2006/main"><ns1:off x="0" y="0"/><ns1:ext cx="0" cy="0"/><ns1:chOff x="0" y="0"/><ns1:chExt cx="0" cy="0"/></ns1:xfrm></ns0:grpSpPr><ns0:sp><ns0:nvSpPr><ns0:cNvPr id="2" name="HeaderBar"/><ns0:cNvSpPr><ns1:spLocks xmlns:ns1="http://schemas.openxmlformats.org/drawingml/2006/main" noGrp="1" noSelect="0" noRot="1" noMove="1"/></ns0:cNvSpPr><ns0:nvPr/></ns0:nvSpPr><ns0:spPr><ns2:xfrm xmlns:ns2="http://schemas.openxmlformats.org/drawingml/2006/main"><ns2:off x="0" y="0"/><ns2:ext cx="12192000" cy="1051560"/></ns2:xfrm><ns3:prstGeom xmlns:ns3="http://schemas.openxmlformats.org/drawingml/2006/main" prst="rect"/><ns4:solidFill xmlns:ns4="http://schemas.openxmlformats.org/drawingml/2006/main"><ns4:srgbClr val="1E2761"/></ns4:solidFill><ns5:ln xmlns:ns5="http://schemas.openxmlformats.org/drawingml/2006/main"><ns5:noFill/></ns5:ln></ns0:spPr></ns0:sp><ns0:sp><ns0:nvSpPr><ns0:cNvPr id="10" name="SlideTitle.Header"/><ns0:cNvSpPr><ns1:spLocks xmlns:ns1="http://schemas.openxmlformats.org/drawingml/2006/main" noGrp="1"/></ns0:cNvSpPr><ns0:nvPr><ns0:ph idx="15" type="body"/></ns0:nvPr></ns0:nvSpPr><ns0:spPr><ns2:xfrm xmlns:ns2="http://schemas.openxmlformats.org/drawingml/2006/main"><ns2:off x="731520" y="91440"/><ns2:ext cx="9144000" cy="475488"/></ns2:xfrm></ns0:spPr><ns0:txBody><ns3:bodyPr xmlns:ns3="http://schemas.openxmlformats.org/drawingml/2006/main" wrap="square" anchor="t" anchorCtr="0"/><ns4:lstStyle><ns4:defPPr><ns4:defRPr sz="2800" b="1"><ns4:solidFill><ns4:srgbClr val="FFFFFF"/></ns4:solidFill></ns4:defRPr></ns4:defPPr></ns4:lstStyle><ns4:defPPr algn="l"><ns4:buNone/><ns4:defRPr sz="2800" dirty="0" b="1"><ns4:solidFill><ns4:srgbClr val="FFFFFF"/></ns4:solidFill><ns4:latin typeface="Georgia"/><ns4:ea typeface="Georgia"/></ns4:defRPr></ns4:defPPr><ns4:lvl1pPr algn="l"><ns4:buNone/><ns4:defRPr sz="2800" dirty="0" b="1"><ns4:solidFill><ns4:srgbClr val="FFFFFF"/></ns4:solidFill><ns4:latin typeface="Georgia"/><ns4:ea typeface="Georgia"/></ns4:defRPr></ns4:lvl1pPr><ns4:lvl2pPr algn="l"><ns4:buNone/><ns4:defRPr sz="2800" dirty="0" b="1"><ns4:solidFill><ns4:srgbClr val="FFFFFF"/></ns4:solidFill><ns4:latin typeface="Georgia"/><ns4:ea typeface="Georgia"/></ns4:defRPr></ns4:lvl2pPr><ns4:lvl3pPr algn="l"><ns4:buNone/><ns4:defRPr sz="2800" dirty="0" b="1"><ns4:solidFill><ns4:srgbClr val="FFFFFF"/></ns4:solidFill><ns4:latin typeface="Georgia"/><ns4:ea typeface="Georgia"/></ns4:defRPr></ns4:lvl3pPr><ns4:lvl4pPr algn="l"><ns4:buNone/><ns4:defRPr sz="2800" dirty="0" b="1"><ns4:solidFill><ns4:srgbClr val="FFFFFF"/></ns4:solidFill><ns4:latin typeface="Georgia"/><ns4:ea typeface="Georgia"/></ns4:defRPr></ns4:lvl4pPr><ns4:lvl5pPr algn="l"><ns4:buNone/><ns4:defRPr sz="2800" dirty="0" b="1"><ns4:solidFill><ns4:srgbClr val="FFFFFF"/></ns4:solidFill><ns4:latin typeface="Georgia"/><ns4:ea typeface="Georgia"/></ns4:defRPr></ns4:lvl5pPr><ns4:lvl6pPr algn="l"><ns4:buNone/><ns4:defRPr sz="2800" dirty="0" b="1"><ns4:solidFill><ns4:srgbClr val="FFFFFF"/></ns4:solidFill><ns4:latin typeface="Georgia"/><ns4:ea typeface="Georgia"/></ns4:defRPr></ns4:lvl6pPr><ns4:lvl7pPr algn="l"><ns4:buNone/><ns4:defRPr sz="2800" dirty="0" b="1"><ns4:solidFill><ns4:srgbClr val="FFFFFF"/></ns4:solidFill><ns4:latin typeface="Georgia"/><ns4:ea typeface="Georgia"/></ns4:defRPr></ns4:lvl7pPr><ns4:lvl8pPr algn="l"><ns4:buNone/><ns4:defRPr sz="2800" dirty="0" b="1"><ns4:solidFill><ns4:srgbClr val="FFFFFF"/></ns4:solidFill><ns4:latin typeface="Georgia"/><ns4:ea typeface="Georgia"/></ns4:defRPr></ns4:lvl8pPr><ns4:lvl9pPr algn="l"><ns4:buNone/><ns4:defRPr sz="2800" dirty="0" b="1"><ns4:solidFill><ns4:srgbClr val="FFFFFF"/></ns4:solidFill><ns4:latin typeface="Georgia"/><ns4:ea typeface="Georgia"/></ns4:defRPr></ns4:lvl9pPr></ns4:lstStyle/><ns5:p xmlns:ns5="http://schemas.openxmlformats.org/drawingml/2006/main"><ns5:pPr algn="l"><ns5:buNone/></ns5:pPr><ns5:r><ns5:rPr lang="ja-JP"/><ns5:t>サブタイトル</ns5:t></ns5:r></ns5:p></ns0:txBody></ns0:sp><ns0:sp><ns0:nvSpPr><ns0:cNvPr id="5" name="ChartArea"/><ns0:cNvSpPr><ns1:spLocks xmlns:ns1="http://schemas.openxmlformats.org/drawingml/2006/main" noGrp="1" noSelect="0" noRot="1" noMove="1"/></ns0:cNvSpPr><ns0:nvPr/></ns0:nvSpPr><ns0:spPr><ns2:xfrm xmlns:ns2="http://schemas.openxmlformats.org/drawingml/2006/main"><ns2:off x="457200" y="1280160"/><ns2:ext cx="6858000" cy="4937760"/></ns2:xfrm><ns3:prstGeom xmlns:ns3="http://schemas.openxmlformats.org/drawingml/2006/main" prst="roundRect"><ns3:avLst><ns3:gd name="adj" fmla="val 6000"/></ns3:avLst></ns3:prstGeom><ns4:solidFill xmlns:ns4="http://schemas.openxmlformats.org/drawingml/2006/main"><ns4:srgbClr val="EDF0F7"/></ns4:solidFill><ns5:ln xmlns:ns5="http://schemas.openxmlformats.org/drawingml/2006/main"><ns5:noFill/></ns5:ln></ns0:spPr></ns0:sp><ns0:sp><ns0:nvSpPr><ns0:cNvPr id="20" name="Body.Left"/><ns0:cNvSpPr><ns1:spLocks xmlns:ns1="http://schemas.openxmlformats.org/drawingml/2006/main" noGrp="1"/></ns0:cNvSpPr><ns0:nvPr><ns0:ph idx="1" type="body"/></ns0:nvPr></ns0:nvSpPr><ns0:spPr><ns2:xfrm xmlns:ns2="http://schemas.openxmlformats.org/drawingml/2006/main"><ns2:off x="731520" y="1463040"/><ns2:ext cx="6309360" cy="4572000"/></ns2:xfrm></ns0:spPr><ns0:txBody><ns3:bodyPr xmlns:ns3="http://schemas.openxmlformats.org/drawingml/2006/main" wrap="square" anchor="t" anchorCtr="0"/><ns4:lstStyle><ns4:defPPr algn="ctr"><ns4:defRPr><ns4:solidFill><ns4:srgbClr val="94A3B8"/></ns4:solidFill></ns4:defRPr></ns4:defPPr></ns4:lstStyle><ns4:defPPr algn="ctr"><ns4:buNone/><ns4:defRPr sz="1400" dirty="0"><ns4:solidFill><ns4:srgbClr val="94A3B8"/></ns4:solidFill><ns4:latin typeface="Calibri"/><ns4:ea typeface="Calibri"/></ns4:defRPr></ns4:defPPr><ns4:lvl1pPr algn="ctr"><ns4:buNone/><ns4:defRPr sz="1400" dirty="0"><ns4:solidFill><ns4:srgbClr val="94A3B8"/></ns4:solidFill><ns4:latin typeface="Calibri"/><ns4:ea typeface="Calibri"/></ns4:defRPr></ns4:lvl1pPr><ns4:lvl2pPr algn="ctr"><ns4:buNone/><ns4:defRPr sz="1400" dirty="0"><ns4:solidFill><ns4:srgbClr val="94A3B8"/></ns4:solidFill><ns4:latin typeface="Calibri"/><ns4:ea typeface="Calibri"/></ns4:defRPr></ns4:lvl2pPr><ns4:lvl3pPr algn="ctr"><ns4:buNone/><ns4:defRPr sz="1400" dirty="0"><ns4:solidFill><ns4:srgbClr val="94A3B8"/></ns4:solidFill><ns4:latin typeface="Calibri"/><ns4:ea typeface="Calibri"/></ns4:defRPr></ns4:lvl3pPr><ns4:lvl4pPr algn="ctr"><ns4:buNone/><ns4:defRPr sz="1400" dirty="0"><ns4:solidFill><ns4:srgbClr val="94A3B8"/></ns4:solidFill><ns4:latin typeface="Calibri"/><ns4:ea typeface="Calibri"/></ns4:defRPr></ns4:lvl4pPr><ns4:lvl5pPr algn="ctr"><ns4:buNone/><ns4:defRPr sz="1400" dirty="0"><ns4:solidFill><ns4:srgbClr val="94A3B8"/></ns4:solidFill><ns4:latin typeface="Calibri"/><ns4:ea typeface="Calibri"/></ns4:defRPr></ns4:lvl5pPr><ns4:lvl6pPr algn="ctr"><ns4:buNone/><ns4:defRPr sz="1400" dirty="0"><ns4:solidFill><ns4:srgbClr val="94A3B8"/></ns4:solidFill><ns4:latin typeface="Calibri"/><ns4:ea typeface="Calibri"/></ns4:defRPr></ns4:lvl6pPr><ns4:lvl7pPr algn="ctr"><ns4:buNone/><ns4:defRPr sz="1400" dirty="0"><ns4:solidFill><ns4:srgbClr val="94A3B8"/></ns4:solidFill><ns4:latin typeface="Calibri"/><ns4:ea typeface="Calibri"/></ns4:defRPr></ns4:lvl7pPr><ns4:lvl8pPr algn="ctr"><ns4:buNone/><ns4:defRPr sz="1400" dirty="0"><ns4:solidFill><ns4:srgbClr val="94A3B8"/></ns4:solidFill><ns4:latin typeface="Calibri"/><ns4:ea typeface="Calibri"/></ns4:defRPr></ns4:lvl8pPr><ns4:lvl9pPr algn="ctr"><ns4:buNone/><ns4:defRPr sz="1400" dirty="0"><ns4:solidFill><ns4:srgbClr val="94A3B8"/></ns4:solidFill><ns4:latin typeface="Calibri"/><ns4:ea typeface="Calibri"/></ns4:defRPr></ns4:lvl9pPr></ns4:lstStyle/><ns5:p xmlns:ns5="http://schemas.openxmlformats.org/drawingml/2006/main"><ns5:pPr algn="l"><ns5:buNone/></ns5:pPr><ns5:r><ns5:rPr lang="ja-JP"/><ns5:t>分析テキスト
 
 主要な発見事項や
-考察を記入</ns5:t></ns5:r></ns5:p></ns0:txBody></ns0:sp><ns0:sp><ns0:nvSpPr><ns0:cNvPr id="30" name="SlideNum.Footer"/><ns0:cNvSpPr><ns1:spLocks xmlns:ns1="http://schemas.openxmlformats.org/drawingml/2006/main" noGrp="1"/></ns0:cNvSpPr><ns0:nvPr><ns0:ph idx="50" type="sldNum"/></ns0:nvPr></ns0:nvSpPr><ns0:spPr><ns2:xfrm xmlns:ns2="http://schemas.openxmlformats.org/drawingml/2006/main"><ns2:off x="10972800" y="6446520"/><ns2:ext cx="1097280" cy="274320"/></ns2:xfrm></ns0:spPr><ns0:txBody><ns3:bodyPr xmlns:ns3="http://schemas.openxmlformats.org/drawingml/2006/main" wrap="square" anchor="t" anchorCtr="0"/><ns4:lstStyle xmlns:ns4="http://schemas.openxmlformats.org/drawingml/2006/main"><ns4:defPPr algn="r"><ns4:buNone/><ns4:defRPr sz="1000" dirty="0"><ns4:solidFill><ns4:srgbClr val="94A3B8"/></ns4:solidFill><ns4:latin typeface="Calibri"/><ns4:ea typeface="Calibri"/></ns4:defRPr></ns4:defPPr><ns4:lvl1pPr algn="r"><ns4:buNone/><ns4:defRPr sz="1000" dirty="0"><ns4:solidFill><ns4:srgbClr val="94A3B8"/></ns4:solidFill><ns4:latin typeface="Calibri"/><ns4:ea typeface="Calibri"/></ns4:defRPr></ns4:lvl1pPr><ns4:lvl2pPr algn="r"><ns4:buNone/><ns4:defRPr sz="1000" dirty="0"><ns4:solidFill><ns4:srgbClr val="94A3B8"/></ns4:solidFill><ns4:latin typeface="Calibri"/><ns4:ea typeface="Calibri"/></ns4:defRPr></ns4:lvl2pPr><ns4:lvl3pPr algn="r"><ns4:buNone/><ns4:defRPr sz="1000" dirty="0"><ns4:solidFill><ns4:srgbClr val="94A3B8"/></ns4:solidFill><ns4:latin typeface="Calibri"/><ns4:ea typeface="Calibri"/></ns4:defRPr></ns4:lvl3pPr><ns4:lvl4pPr algn="r"><ns4:buNone/><ns4:defRPr sz="1000" dirty="0"><ns4:solidFill><ns4:srgbClr val="94A3B8"/></ns4:solidFill><ns4:latin typeface="Calibri"/><ns4:ea typeface="Calibri"/></ns4:defRPr></ns4:lvl4pPr><ns4:lvl5pPr algn="r"><ns4:buNone/><ns4:defRPr sz="1000" dirty="0"><ns4:solidFill><ns4:srgbClr val="94A3B8"/></ns4:solidFill><ns4:latin typeface="Calibri"/><ns4:ea typeface="Calibri"/></ns4:defRPr></ns4:lvl5pPr><ns4:lvl6pPr algn="r"><ns4:buNone/><ns4:defRPr sz="1000" dirty="0"><ns4:solidFill><ns4:srgbClr val="94A3B8"/></ns4:solidFill><ns4:latin typeface="Calibri"/><ns4:ea typeface="Calibri"/></ns4:defRPr></ns4:lvl6pPr><ns4:lvl7pPr algn="r"><ns4:buNone/><ns4:defRPr sz="1000" dirty="0"><ns4:solidFill><ns4:srgbClr val="94A3B8"/></ns4:solidFill><ns4:latin typeface="Calibri"/><ns4:ea typeface="Calibri"/></ns4:defRPr></ns4:lvl7pPr><ns4:lvl8pPr algn="r"><ns4:buNone/><ns4:defRPr sz="1000" dirty="0"><ns4:solidFill><ns4:srgbClr val="94A3B8"/></ns4:solidFill><ns4:latin typeface="Calibri"/><ns4:ea typeface="Calibri"/></ns4:defRPr></ns4:lvl8pPr><ns4:lvl9pPr algn="r"><ns4:buNone/><ns4:defRPr sz="1000" dirty="0"><ns4:solidFill><ns4:srgbClr val="94A3B8"/></ns4:solidFill><ns4:latin typeface="Calibri"/><ns4:ea typeface="Calibri"/></ns4:defRPr></ns4:lvl9pPr></ns4:lstStyle><ns5:p xmlns:ns5="http://schemas.openxmlformats.org/drawingml/2006/main"><ns5:pPr algn="r"><ns5:buNone/></ns5:pPr><ns5:r><ns5:rPr lang="ja-JP"/><ns5:t>&lt;#&gt;</ns5:t></ns5:r></ns5:p></ns0:txBody></ns0:sp></ns0:spTree></ns0:cSld><ns0:clrMapOvr/></ns0:sldLayout>
+考察を記入</ns5:t></ns5:r></ns5:p></ns0:txBody></ns0:sp><ns0:sp><ns0:nvSpPr><ns0:cNvPr id="30" name="SlideNum.Footer"/><ns0:cNvSpPr><ns1:spLocks xmlns:ns1="http://schemas.openxmlformats.org/drawingml/2006/main" noGrp="1"/></ns0:cNvSpPr><ns0:nvPr><ns0:ph idx="50" type="sldNum"/></ns0:nvPr></ns0:nvSpPr><ns0:spPr><ns2:xfrm xmlns:ns2="http://schemas.openxmlformats.org/drawingml/2006/main"><ns2:off x="10972800" y="6446520"/><ns2:ext cx="1097280" cy="274320"/></ns2:xfrm></ns0:spPr><ns0:txBody><ns3:bodyPr xmlns:ns3="http://schemas.openxmlformats.org/drawingml/2006/main" wrap="square" anchor="t" anchorCtr="0"/><ns4:lstStyle><ns4:defPPr algn="r"><ns4:defRPr sz="1000"><ns4:solidFill><ns4:srgbClr val="94A3B8"/></ns4:solidFill></ns4:defRPr></ns4:defPPr></ns4:lstStyle><ns4:defPPr algn="r"><ns4:buNone/><ns4:defRPr sz="1000" dirty="0"><ns4:solidFill><ns4:srgbClr val="94A3B8"/></ns4:solidFill><ns4:latin typeface="Calibri"/><ns4:ea typeface="Calibri"/></ns4:defRPr></ns4:defPPr><ns4:lvl1pPr algn="r"><ns4:buNone/><ns4:defRPr sz="1000" dirty="0"><ns4:solidFill><ns4:srgbClr val="94A3B8"/></ns4:solidFill><ns4:latin typeface="Calibri"/><ns4:ea typeface="Calibri"/></ns4:defRPr></ns4:lvl1pPr><ns4:lvl2pPr algn="r"><ns4:buNone/><ns4:defRPr sz="1000" dirty="0"><ns4:solidFill><ns4:srgbClr val="94A3B8"/></ns4:solidFill><ns4:latin typeface="Calibri"/><ns4:ea typeface="Calibri"/></ns4:defRPr></ns4:lvl2pPr><ns4:lvl3pPr algn="r"><ns4:buNone/><ns4:defRPr sz="1000" dirty="0"><ns4:solidFill><ns4:srgbClr val="94A3B8"/></ns4:solidFill><ns4:latin typeface="Calibri"/><ns4:ea typeface="Calibri"/></ns4:defRPr></ns4:lvl3pPr><ns4:lvl4pPr algn="r"><ns4:buNone/><ns4:defRPr sz="1000" dirty="0"><ns4:solidFill><ns4:srgbClr val="94A3B8"/></ns4:solidFill><ns4:latin typeface="Calibri"/><ns4:ea typeface="Calibri"/></ns4:defRPr></ns4:lvl4pPr><ns4:lvl5pPr algn="r"><ns4:buNone/><ns4:defRPr sz="1000" dirty="0"><ns4:solidFill><ns4:srgbClr val="94A3B8"/></ns4:solidFill><ns4:latin typeface="Calibri"/><ns4:ea typeface="Calibri"/></ns4:defRPr></ns4:lvl5pPr><ns4:lvl6pPr algn="r"><ns4:buNone/><ns4:defRPr sz="1000" dirty="0"><ns4:solidFill><ns4:srgbClr val="94A3B8"/></ns4:solidFill><ns4:latin typeface="Calibri"/><ns4:ea typeface="Calibri"/></ns4:defRPr></ns4:lvl6pPr><ns4:lvl7pPr algn="r"><ns4:buNone/><ns4:defRPr sz="1000" dirty="0"><ns4:solidFill><ns4:srgbClr val="94A3B8"/></ns4:solidFill><ns4:latin typeface="Calibri"/><ns4:ea typeface="Calibri"/></ns4:defRPr></ns4:lvl7pPr><ns4:lvl8pPr algn="r"><ns4:buNone/><ns4:defRPr sz="1000" dirty="0"><ns4:solidFill><ns4:srgbClr val="94A3B8"/></ns4:solidFill><ns4:latin typeface="Calibri"/><ns4:ea typeface="Calibri"/></ns4:defRPr></ns4:lvl8pPr><ns4:lvl9pPr algn="r"><ns4:buNone/><ns4:defRPr sz="1000" dirty="0"><ns4:solidFill><ns4:srgbClr val="94A3B8"/></ns4:solidFill><ns4:latin typeface="Calibri"/><ns4:ea typeface="Calibri"/></ns4:defRPr></ns4:lvl9pPr></ns4:lstStyle><ns5:p xmlns:ns5="http://schemas.openxmlformats.org/drawingml/2006/main"><ns5:pPr algn="r"><ns5:buNone/></ns5:pPr><ns5:r><ns5:rPr lang="ja-JP"/><ns5:t>&lt;#&gt;</ns5:t></ns5:r></ns5:p></ns0:txBody></ns0:sp></ns0:spTree></ns0:cSld><ns0:clrMapOvr/></ns0:sldLayout>
 </file>
 
 <file path=ppt/slideLayouts/slideLayout2.xml><?xml version="1.0" encoding="utf-8"?>
@@ -1051,9 +1023,9 @@
           <a:bodyPr wrap="square" anchor="t" anchorCtr="0"/>
           <a:lstStyle>
             <a:defPPr>
-              <a:defRPr>
-                <a:solidFill>
-                  <a:srgbClr val="FFFFFF"/>
+              <a:defRPr sz="1400" b="1">
+                <a:solidFill>
+                  <a:srgbClr val="3B82F6"/>
                 </a:solidFill>
               </a:defRPr>
             </a:defPPr>
@@ -1089,11 +1061,7 @@
           <a:bodyPr wrap="square" anchor="t" anchorCtr="0"/>
           <a:lstStyle>
             <a:defPPr>
-              <a:defRPr>
-                <a:solidFill>
-                  <a:srgbClr val="FFFFFF"/>
-                </a:solidFill>
-              </a:defRPr>
+              <a:defRPr sz="4400"/>
             </a:defPPr>
           </a:lstStyle>
           <a:p>
@@ -1127,7 +1095,7 @@
           <a:bodyPr wrap="square" anchor="t" anchorCtr="0"/>
           <a:lstStyle>
             <a:defPPr>
-              <a:defRPr>
+              <a:defRPr sz="1800">
                 <a:solidFill>
                   <a:srgbClr val="CADCFC"/>
                 </a:solidFill>
@@ -1165,7 +1133,7 @@
           <a:bodyPr wrap="square" anchor="t" anchorCtr="0"/>
           <a:lstStyle>
             <a:defPPr>
-              <a:defRPr>
+              <a:defRPr sz="1300">
                 <a:solidFill>
                   <a:srgbClr val="CADCFC"/>
                 </a:solidFill>
@@ -1207,7 +1175,7 @@
           <a:bodyPr wrap="square" anchor="t" anchorCtr="0"/>
           <a:lstStyle>
             <a:defPPr>
-              <a:defRPr>
+              <a:defRPr sz="1100">
                 <a:solidFill>
                   <a:srgbClr val="CADCFC"/>
                 </a:solidFill>
@@ -1232,44 +1200,44 @@
 </file>
 
 <file path=ppt/slideLayouts/slideLayout20.xml><?xml version='1.0' encoding='UTF-8' standalone='yes'?>
-<ns0:sldLayout xmlns:ns0="http://schemas.openxmlformats.org/presentationml/2006/main" type="blank" preserve="1"><ns0:cSld name="Chart.2Chart.Equal"><ns0:spTree><ns0:nvGrpSpPr><ns0:cNvPr id="1" name=""/><ns0:cNvGrpSpPr/><ns0:nvPr/></ns0:nvGrpSpPr><ns0:grpSpPr><ns1:xfrm xmlns:ns1="http://schemas.openxmlformats.org/drawingml/2006/main"><ns1:off x="0" y="0"/><ns1:ext cx="0" cy="0"/><ns1:chOff x="0" y="0"/><ns1:chExt cx="0" cy="0"/></ns1:xfrm></ns0:grpSpPr><ns0:sp><ns0:nvSpPr><ns0:cNvPr id="2" name="HeaderBar"/><ns0:cNvSpPr><ns1:spLocks xmlns:ns1="http://schemas.openxmlformats.org/drawingml/2006/main" noGrp="1" noSelect="0" noRot="1" noMove="1"/></ns0:cNvSpPr><ns0:nvPr/></ns0:nvSpPr><ns0:spPr><ns2:xfrm xmlns:ns2="http://schemas.openxmlformats.org/drawingml/2006/main"><ns2:off x="0" y="0"/><ns2:ext cx="12192000" cy="1051560"/></ns2:xfrm><ns3:prstGeom xmlns:ns3="http://schemas.openxmlformats.org/drawingml/2006/main" prst="rect"/><ns4:solidFill xmlns:ns4="http://schemas.openxmlformats.org/drawingml/2006/main"><ns4:srgbClr val="1E2761"/></ns4:solidFill><ns5:ln xmlns:ns5="http://schemas.openxmlformats.org/drawingml/2006/main"><ns5:noFill/></ns5:ln></ns0:spPr></ns0:sp><ns0:sp><ns0:nvSpPr><ns0:cNvPr id="10" name="SlideTitle.Header"/><ns0:cNvSpPr><ns1:spLocks xmlns:ns1="http://schemas.openxmlformats.org/drawingml/2006/main" noGrp="1"/></ns0:cNvSpPr><ns0:nvPr><ns0:ph idx="15" type="body"/></ns0:nvPr></ns0:nvSpPr><ns0:spPr><ns2:xfrm xmlns:ns2="http://schemas.openxmlformats.org/drawingml/2006/main"><ns2:off x="731520" y="91440"/><ns2:ext cx="9144000" cy="475488"/></ns2:xfrm></ns0:spPr><ns0:txBody><ns3:bodyPr xmlns:ns3="http://schemas.openxmlformats.org/drawingml/2006/main" wrap="square" anchor="t" anchorCtr="0"/><ns4:lstStyle xmlns:ns4="http://schemas.openxmlformats.org/drawingml/2006/main"><ns4:defPPr algn="l"><ns4:buNone/><ns4:defRPr sz="2800" dirty="0" b="1"><ns4:solidFill><ns4:srgbClr val="FFFFFF"/></ns4:solidFill><ns4:latin typeface="Georgia"/><ns4:ea typeface="Georgia"/></ns4:defRPr></ns4:defPPr><ns4:lvl1pPr algn="l"><ns4:buNone/><ns4:defRPr sz="2800" dirty="0" b="1"><ns4:solidFill><ns4:srgbClr val="FFFFFF"/></ns4:solidFill><ns4:latin typeface="Georgia"/><ns4:ea typeface="Georgia"/></ns4:defRPr></ns4:lvl1pPr><ns4:lvl2pPr algn="l"><ns4:buNone/><ns4:defRPr sz="2800" dirty="0" b="1"><ns4:solidFill><ns4:srgbClr val="FFFFFF"/></ns4:solidFill><ns4:latin typeface="Georgia"/><ns4:ea typeface="Georgia"/></ns4:defRPr></ns4:lvl2pPr><ns4:lvl3pPr algn="l"><ns4:buNone/><ns4:defRPr sz="2800" dirty="0" b="1"><ns4:solidFill><ns4:srgbClr val="FFFFFF"/></ns4:solidFill><ns4:latin typeface="Georgia"/><ns4:ea typeface="Georgia"/></ns4:defRPr></ns4:lvl3pPr><ns4:lvl4pPr algn="l"><ns4:buNone/><ns4:defRPr sz="2800" dirty="0" b="1"><ns4:solidFill><ns4:srgbClr val="FFFFFF"/></ns4:solidFill><ns4:latin typeface="Georgia"/><ns4:ea typeface="Georgia"/></ns4:defRPr></ns4:lvl4pPr><ns4:lvl5pPr algn="l"><ns4:buNone/><ns4:defRPr sz="2800" dirty="0" b="1"><ns4:solidFill><ns4:srgbClr val="FFFFFF"/></ns4:solidFill><ns4:latin typeface="Georgia"/><ns4:ea typeface="Georgia"/></ns4:defRPr></ns4:lvl5pPr><ns4:lvl6pPr algn="l"><ns4:buNone/><ns4:defRPr sz="2800" dirty="0" b="1"><ns4:solidFill><ns4:srgbClr val="FFFFFF"/></ns4:solidFill><ns4:latin typeface="Georgia"/><ns4:ea typeface="Georgia"/></ns4:defRPr></ns4:lvl6pPr><ns4:lvl7pPr algn="l"><ns4:buNone/><ns4:defRPr sz="2800" dirty="0" b="1"><ns4:solidFill><ns4:srgbClr val="FFFFFF"/></ns4:solidFill><ns4:latin typeface="Georgia"/><ns4:ea typeface="Georgia"/></ns4:defRPr></ns4:lvl7pPr><ns4:lvl8pPr algn="l"><ns4:buNone/><ns4:defRPr sz="2800" dirty="0" b="1"><ns4:solidFill><ns4:srgbClr val="FFFFFF"/></ns4:solidFill><ns4:latin typeface="Georgia"/><ns4:ea typeface="Georgia"/></ns4:defRPr></ns4:lvl8pPr><ns4:lvl9pPr algn="l"><ns4:buNone/><ns4:defRPr sz="2800" dirty="0" b="1"><ns4:solidFill><ns4:srgbClr val="FFFFFF"/></ns4:solidFill><ns4:latin typeface="Georgia"/><ns4:ea typeface="Georgia"/></ns4:defRPr></ns4:lvl9pPr></ns4:lstStyle/><ns5:p xmlns:ns5="http://schemas.openxmlformats.org/drawingml/2006/main"><ns5:pPr algn="l"><ns5:buNone/></ns5:pPr><ns5:r><ns5:rPr lang="ja-JP"/><ns5:t>サブタイトル</ns5:t></ns5:r></ns5:p></ns0:txBody></ns0:sp><ns0:sp><ns0:nvSpPr><ns0:cNvPr id="5" name="ChartL"/><ns0:cNvSpPr><ns1:spLocks xmlns:ns1="http://schemas.openxmlformats.org/drawingml/2006/main" noGrp="1" noSelect="0" noRot="1" noMove="1"/></ns0:cNvSpPr><ns0:nvPr/></ns0:nvSpPr><ns0:spPr><ns2:xfrm xmlns:ns2="http://schemas.openxmlformats.org/drawingml/2006/main"><ns2:off x="457200" y="1280160"/><ns2:ext cx="5394960" cy="4937760"/></ns2:xfrm><ns3:prstGeom xmlns:ns3="http://schemas.openxmlformats.org/drawingml/2006/main" prst="roundRect"><ns3:avLst><ns3:gd name="adj" fmla="val 6000"/></ns3:avLst></ns3:prstGeom><ns4:solidFill xmlns:ns4="http://schemas.openxmlformats.org/drawingml/2006/main"><ns4:srgbClr val="EDF0F7"/></ns4:solidFill><ns5:ln xmlns:ns5="http://schemas.openxmlformats.org/drawingml/2006/main"><ns5:noFill/></ns5:ln></ns0:spPr></ns0:sp><ns0:sp><ns0:nvSpPr><ns0:cNvPr id="6" name="ChartR"/><ns0:cNvSpPr><ns1:spLocks xmlns:ns1="http://schemas.openxmlformats.org/drawingml/2006/main" noGrp="1" noSelect="0" noRot="1" noMove="1"/></ns0:cNvSpPr><ns0:nvPr/></ns0:nvSpPr><ns0:spPr><ns2:xfrm xmlns:ns2="http://schemas.openxmlformats.org/drawingml/2006/main"><ns2:off x="6126480" y="1280160"/><ns2:ext cx="5394960" cy="4937760"/></ns2:xfrm><ns3:prstGeom xmlns:ns3="http://schemas.openxmlformats.org/drawingml/2006/main" prst="roundRect"><ns3:avLst><ns3:gd name="adj" fmla="val 6000"/></ns3:avLst></ns3:prstGeom><ns4:solidFill xmlns:ns4="http://schemas.openxmlformats.org/drawingml/2006/main"><ns4:srgbClr val="EDF0F7"/></ns4:solidFill><ns5:ln xmlns:ns5="http://schemas.openxmlformats.org/drawingml/2006/main"><ns5:noFill/></ns5:ln></ns0:spPr></ns0:sp><ns0:sp><ns0:nvSpPr><ns0:cNvPr id="20" name="Body1.Left"/><ns0:cNvSpPr><ns1:spLocks xmlns:ns1="http://schemas.openxmlformats.org/drawingml/2006/main" noGrp="1"/></ns0:cNvSpPr><ns0:nvPr><ns0:ph idx="1" type="body"/></ns0:nvPr></ns0:nvSpPr><ns0:spPr><ns2:xfrm xmlns:ns2="http://schemas.openxmlformats.org/drawingml/2006/main"><ns2:off x="731520" y="1463040"/><ns2:ext cx="4846320" cy="4572000"/></ns2:xfrm></ns0:spPr><ns0:txBody><ns3:bodyPr xmlns:ns3="http://schemas.openxmlformats.org/drawingml/2006/main" wrap="square" anchor="t" anchorCtr="0"/><ns4:lstStyle xmlns:ns4="http://schemas.openxmlformats.org/drawingml/2006/main"><ns4:defPPr algn="ctr"><ns4:buNone/><ns4:defRPr sz="1400" dirty="0"><ns4:solidFill><ns4:srgbClr val="94A3B8"/></ns4:solidFill><ns4:latin typeface="Calibri"/><ns4:ea typeface="Calibri"/></ns4:defRPr></ns4:defPPr><ns4:lvl1pPr algn="ctr"><ns4:buNone/><ns4:defRPr sz="1400" dirty="0"><ns4:solidFill><ns4:srgbClr val="94A3B8"/></ns4:solidFill><ns4:latin typeface="Calibri"/><ns4:ea typeface="Calibri"/></ns4:defRPr></ns4:lvl1pPr><ns4:lvl2pPr algn="ctr"><ns4:buNone/><ns4:defRPr sz="1400" dirty="0"><ns4:solidFill><ns4:srgbClr val="94A3B8"/></ns4:solidFill><ns4:latin typeface="Calibri"/><ns4:ea typeface="Calibri"/></ns4:defRPr></ns4:lvl2pPr><ns4:lvl3pPr algn="ctr"><ns4:buNone/><ns4:defRPr sz="1400" dirty="0"><ns4:solidFill><ns4:srgbClr val="94A3B8"/></ns4:solidFill><ns4:latin typeface="Calibri"/><ns4:ea typeface="Calibri"/></ns4:defRPr></ns4:lvl3pPr><ns4:lvl4pPr algn="ctr"><ns4:buNone/><ns4:defRPr sz="1400" dirty="0"><ns4:solidFill><ns4:srgbClr val="94A3B8"/></ns4:solidFill><ns4:latin typeface="Calibri"/><ns4:ea typeface="Calibri"/></ns4:defRPr></ns4:lvl4pPr><ns4:lvl5pPr algn="ctr"><ns4:buNone/><ns4:defRPr sz="1400" dirty="0"><ns4:solidFill><ns4:srgbClr val="94A3B8"/></ns4:solidFill><ns4:latin typeface="Calibri"/><ns4:ea typeface="Calibri"/></ns4:defRPr></ns4:lvl5pPr><ns4:lvl6pPr algn="ctr"><ns4:buNone/><ns4:defRPr sz="1400" dirty="0"><ns4:solidFill><ns4:srgbClr val="94A3B8"/></ns4:solidFill><ns4:latin typeface="Calibri"/><ns4:ea typeface="Calibri"/></ns4:defRPr></ns4:lvl6pPr><ns4:lvl7pPr algn="ctr"><ns4:buNone/><ns4:defRPr sz="1400" dirty="0"><ns4:solidFill><ns4:srgbClr val="94A3B8"/></ns4:solidFill><ns4:latin typeface="Calibri"/><ns4:ea typeface="Calibri"/></ns4:defRPr></ns4:lvl7pPr><ns4:lvl8pPr algn="ctr"><ns4:buNone/><ns4:defRPr sz="1400" dirty="0"><ns4:solidFill><ns4:srgbClr val="94A3B8"/></ns4:solidFill><ns4:latin typeface="Calibri"/><ns4:ea typeface="Calibri"/></ns4:defRPr></ns4:lvl8pPr><ns4:lvl9pPr algn="ctr"><ns4:buNone/><ns4:defRPr sz="1400" dirty="0"><ns4:solidFill><ns4:srgbClr val="94A3B8"/></ns4:solidFill><ns4:latin typeface="Calibri"/><ns4:ea typeface="Calibri"/></ns4:defRPr></ns4:lvl9pPr></ns4:lstStyle/><ns5:p xmlns:ns5="http://schemas.openxmlformats.org/drawingml/2006/main"><ns5:pPr algn="ctr"><ns5:buNone/></ns5:pPr><ns5:r><ns5:rPr lang="ja-JP"/><ns5:t>チャート 2</ns5:t></ns5:r></ns5:p></ns0:txBody></ns0:sp><ns0:sp><ns0:nvSpPr><ns0:cNvPr id="30" name="SlideNum.Footer"/><ns0:cNvSpPr><ns1:spLocks xmlns:ns1="http://schemas.openxmlformats.org/drawingml/2006/main" noGrp="1"/></ns0:cNvSpPr><ns0:nvPr><ns0:ph idx="50" type="sldNum"/></ns0:nvPr></ns0:nvSpPr><ns0:spPr><ns2:xfrm xmlns:ns2="http://schemas.openxmlformats.org/drawingml/2006/main"><ns2:off x="10972800" y="6446520"/><ns2:ext cx="1097280" cy="274320"/></ns2:xfrm></ns0:spPr><ns0:txBody><ns3:bodyPr xmlns:ns3="http://schemas.openxmlformats.org/drawingml/2006/main" wrap="square" anchor="t" anchorCtr="0"/><ns4:lstStyle xmlns:ns4="http://schemas.openxmlformats.org/drawingml/2006/main"><ns4:defPPr algn="r"><ns4:buNone/><ns4:defRPr sz="1000" dirty="0"><ns4:solidFill><ns4:srgbClr val="94A3B8"/></ns4:solidFill><ns4:latin typeface="Calibri"/><ns4:ea typeface="Calibri"/></ns4:defRPr></ns4:defPPr><ns4:lvl1pPr algn="r"><ns4:buNone/><ns4:defRPr sz="1000" dirty="0"><ns4:solidFill><ns4:srgbClr val="94A3B8"/></ns4:solidFill><ns4:latin typeface="Calibri"/><ns4:ea typeface="Calibri"/></ns4:defRPr></ns4:lvl1pPr><ns4:lvl2pPr algn="r"><ns4:buNone/><ns4:defRPr sz="1000" dirty="0"><ns4:solidFill><ns4:srgbClr val="94A3B8"/></ns4:solidFill><ns4:latin typeface="Calibri"/><ns4:ea typeface="Calibri"/></ns4:defRPr></ns4:lvl2pPr><ns4:lvl3pPr algn="r"><ns4:buNone/><ns4:defRPr sz="1000" dirty="0"><ns4:solidFill><ns4:srgbClr val="94A3B8"/></ns4:solidFill><ns4:latin typeface="Calibri"/><ns4:ea typeface="Calibri"/></ns4:defRPr></ns4:lvl3pPr><ns4:lvl4pPr algn="r"><ns4:buNone/><ns4:defRPr sz="1000" dirty="0"><ns4:solidFill><ns4:srgbClr val="94A3B8"/></ns4:solidFill><ns4:latin typeface="Calibri"/><ns4:ea typeface="Calibri"/></ns4:defRPr></ns4:lvl4pPr><ns4:lvl5pPr algn="r"><ns4:buNone/><ns4:defRPr sz="1000" dirty="0"><ns4:solidFill><ns4:srgbClr val="94A3B8"/></ns4:solidFill><ns4:latin typeface="Calibri"/><ns4:ea typeface="Calibri"/></ns4:defRPr></ns4:lvl5pPr><ns4:lvl6pPr algn="r"><ns4:buNone/><ns4:defRPr sz="1000" dirty="0"><ns4:solidFill><ns4:srgbClr val="94A3B8"/></ns4:solidFill><ns4:latin typeface="Calibri"/><ns4:ea typeface="Calibri"/></ns4:defRPr></ns4:lvl6pPr><ns4:lvl7pPr algn="r"><ns4:buNone/><ns4:defRPr sz="1000" dirty="0"><ns4:solidFill><ns4:srgbClr val="94A3B8"/></ns4:solidFill><ns4:latin typeface="Calibri"/><ns4:ea typeface="Calibri"/></ns4:defRPr></ns4:lvl7pPr><ns4:lvl8pPr algn="r"><ns4:buNone/><ns4:defRPr sz="1000" dirty="0"><ns4:solidFill><ns4:srgbClr val="94A3B8"/></ns4:solidFill><ns4:latin typeface="Calibri"/><ns4:ea typeface="Calibri"/></ns4:defRPr></ns4:lvl8pPr><ns4:lvl9pPr algn="r"><ns4:buNone/><ns4:defRPr sz="1000" dirty="0"><ns4:solidFill><ns4:srgbClr val="94A3B8"/></ns4:solidFill><ns4:latin typeface="Calibri"/><ns4:ea typeface="Calibri"/></ns4:defRPr></ns4:lvl9pPr></ns4:lstStyle><ns5:p xmlns:ns5="http://schemas.openxmlformats.org/drawingml/2006/main"><ns5:pPr algn="r"><ns5:buNone/></ns5:pPr><ns5:r><ns5:rPr lang="ja-JP"/><ns5:t>&lt;#&gt;</ns5:t></ns5:r></ns5:p></ns0:txBody></ns0:sp></ns0:spTree></ns0:cSld><ns0:clrMapOvr/></ns0:sldLayout>
+<ns0:sldLayout xmlns:ns0="http://schemas.openxmlformats.org/presentationml/2006/main" type="blank" preserve="1"><ns0:cSld name="Chart.2Chart.Equal"><ns0:spTree><ns0:nvGrpSpPr><ns0:cNvPr id="1" name=""/><ns0:cNvGrpSpPr/><ns0:nvPr/></ns0:nvGrpSpPr><ns0:grpSpPr><ns1:xfrm xmlns:ns1="http://schemas.openxmlformats.org/drawingml/2006/main"><ns1:off x="0" y="0"/><ns1:ext cx="0" cy="0"/><ns1:chOff x="0" y="0"/><ns1:chExt cx="0" cy="0"/></ns1:xfrm></ns0:grpSpPr><ns0:sp><ns0:nvSpPr><ns0:cNvPr id="2" name="HeaderBar"/><ns0:cNvSpPr><ns1:spLocks xmlns:ns1="http://schemas.openxmlformats.org/drawingml/2006/main" noGrp="1" noSelect="0" noRot="1" noMove="1"/></ns0:cNvSpPr><ns0:nvPr/></ns0:nvSpPr><ns0:spPr><ns2:xfrm xmlns:ns2="http://schemas.openxmlformats.org/drawingml/2006/main"><ns2:off x="0" y="0"/><ns2:ext cx="12192000" cy="1051560"/></ns2:xfrm><ns3:prstGeom xmlns:ns3="http://schemas.openxmlformats.org/drawingml/2006/main" prst="rect"/><ns4:solidFill xmlns:ns4="http://schemas.openxmlformats.org/drawingml/2006/main"><ns4:srgbClr val="1E2761"/></ns4:solidFill><ns5:ln xmlns:ns5="http://schemas.openxmlformats.org/drawingml/2006/main"><ns5:noFill/></ns5:ln></ns0:spPr></ns0:sp><ns0:sp><ns0:nvSpPr><ns0:cNvPr id="10" name="SlideTitle.Header"/><ns0:cNvSpPr><ns1:spLocks xmlns:ns1="http://schemas.openxmlformats.org/drawingml/2006/main" noGrp="1"/></ns0:cNvSpPr><ns0:nvPr><ns0:ph idx="15" type="body"/></ns0:nvPr></ns0:nvSpPr><ns0:spPr><ns2:xfrm xmlns:ns2="http://schemas.openxmlformats.org/drawingml/2006/main"><ns2:off x="731520" y="91440"/><ns2:ext cx="9144000" cy="475488"/></ns2:xfrm></ns0:spPr><ns0:txBody><ns3:bodyPr xmlns:ns3="http://schemas.openxmlformats.org/drawingml/2006/main" wrap="square" anchor="t" anchorCtr="0"/><ns4:lstStyle><ns4:defPPr><ns4:defRPr sz="2800" b="1"><ns4:solidFill><ns4:srgbClr val="FFFFFF"/></ns4:solidFill></ns4:defRPr></ns4:defPPr></ns4:lstStyle><ns4:defPPr algn="l"><ns4:buNone/><ns4:defRPr sz="2800" dirty="0" b="1"><ns4:solidFill><ns4:srgbClr val="FFFFFF"/></ns4:solidFill><ns4:latin typeface="Georgia"/><ns4:ea typeface="Georgia"/></ns4:defRPr></ns4:defPPr><ns4:lvl1pPr algn="l"><ns4:buNone/><ns4:defRPr sz="2800" dirty="0" b="1"><ns4:solidFill><ns4:srgbClr val="FFFFFF"/></ns4:solidFill><ns4:latin typeface="Georgia"/><ns4:ea typeface="Georgia"/></ns4:defRPr></ns4:lvl1pPr><ns4:lvl2pPr algn="l"><ns4:buNone/><ns4:defRPr sz="2800" dirty="0" b="1"><ns4:solidFill><ns4:srgbClr val="FFFFFF"/></ns4:solidFill><ns4:latin typeface="Georgia"/><ns4:ea typeface="Georgia"/></ns4:defRPr></ns4:lvl2pPr><ns4:lvl3pPr algn="l"><ns4:buNone/><ns4:defRPr sz="2800" dirty="0" b="1"><ns4:solidFill><ns4:srgbClr val="FFFFFF"/></ns4:solidFill><ns4:latin typeface="Georgia"/><ns4:ea typeface="Georgia"/></ns4:defRPr></ns4:lvl3pPr><ns4:lvl4pPr algn="l"><ns4:buNone/><ns4:defRPr sz="2800" dirty="0" b="1"><ns4:solidFill><ns4:srgbClr val="FFFFFF"/></ns4:solidFill><ns4:latin typeface="Georgia"/><ns4:ea typeface="Georgia"/></ns4:defRPr></ns4:lvl4pPr><ns4:lvl5pPr algn="l"><ns4:buNone/><ns4:defRPr sz="2800" dirty="0" b="1"><ns4:solidFill><ns4:srgbClr val="FFFFFF"/></ns4:solidFill><ns4:latin typeface="Georgia"/><ns4:ea typeface="Georgia"/></ns4:defRPr></ns4:lvl5pPr><ns4:lvl6pPr algn="l"><ns4:buNone/><ns4:defRPr sz="2800" dirty="0" b="1"><ns4:solidFill><ns4:srgbClr val="FFFFFF"/></ns4:solidFill><ns4:latin typeface="Georgia"/><ns4:ea typeface="Georgia"/></ns4:defRPr></ns4:lvl6pPr><ns4:lvl7pPr algn="l"><ns4:buNone/><ns4:defRPr sz="2800" dirty="0" b="1"><ns4:solidFill><ns4:srgbClr val="FFFFFF"/></ns4:solidFill><ns4:latin typeface="Georgia"/><ns4:ea typeface="Georgia"/></ns4:defRPr></ns4:lvl7pPr><ns4:lvl8pPr algn="l"><ns4:buNone/><ns4:defRPr sz="2800" dirty="0" b="1"><ns4:solidFill><ns4:srgbClr val="FFFFFF"/></ns4:solidFill><ns4:latin typeface="Georgia"/><ns4:ea typeface="Georgia"/></ns4:defRPr></ns4:lvl8pPr><ns4:lvl9pPr algn="l"><ns4:buNone/><ns4:defRPr sz="2800" dirty="0" b="1"><ns4:solidFill><ns4:srgbClr val="FFFFFF"/></ns4:solidFill><ns4:latin typeface="Georgia"/><ns4:ea typeface="Georgia"/></ns4:defRPr></ns4:lvl9pPr></ns4:lstStyle/><ns5:p xmlns:ns5="http://schemas.openxmlformats.org/drawingml/2006/main"><ns5:pPr algn="l"><ns5:buNone/></ns5:pPr><ns5:r><ns5:rPr lang="ja-JP"/><ns5:t>サブタイトル</ns5:t></ns5:r></ns5:p></ns0:txBody></ns0:sp><ns0:sp><ns0:nvSpPr><ns0:cNvPr id="5" name="ChartL"/><ns0:cNvSpPr><ns1:spLocks xmlns:ns1="http://schemas.openxmlformats.org/drawingml/2006/main" noGrp="1" noSelect="0" noRot="1" noMove="1"/></ns0:cNvSpPr><ns0:nvPr/></ns0:nvSpPr><ns0:spPr><ns2:xfrm xmlns:ns2="http://schemas.openxmlformats.org/drawingml/2006/main"><ns2:off x="457200" y="1280160"/><ns2:ext cx="5394960" cy="4937760"/></ns2:xfrm><ns3:prstGeom xmlns:ns3="http://schemas.openxmlformats.org/drawingml/2006/main" prst="roundRect"><ns3:avLst><ns3:gd name="adj" fmla="val 6000"/></ns3:avLst></ns3:prstGeom><ns4:solidFill xmlns:ns4="http://schemas.openxmlformats.org/drawingml/2006/main"><ns4:srgbClr val="EDF0F7"/></ns4:solidFill><ns5:ln xmlns:ns5="http://schemas.openxmlformats.org/drawingml/2006/main"><ns5:noFill/></ns5:ln></ns0:spPr></ns0:sp><ns0:sp><ns0:nvSpPr><ns0:cNvPr id="6" name="ChartR"/><ns0:cNvSpPr><ns1:spLocks xmlns:ns1="http://schemas.openxmlformats.org/drawingml/2006/main" noGrp="1" noSelect="0" noRot="1" noMove="1"/></ns0:cNvSpPr><ns0:nvPr/></ns0:nvSpPr><ns0:spPr><ns2:xfrm xmlns:ns2="http://schemas.openxmlformats.org/drawingml/2006/main"><ns2:off x="6126480" y="1280160"/><ns2:ext cx="5394960" cy="4937760"/></ns2:xfrm><ns3:prstGeom xmlns:ns3="http://schemas.openxmlformats.org/drawingml/2006/main" prst="roundRect"><ns3:avLst><ns3:gd name="adj" fmla="val 6000"/></ns3:avLst></ns3:prstGeom><ns4:solidFill xmlns:ns4="http://schemas.openxmlformats.org/drawingml/2006/main"><ns4:srgbClr val="EDF0F7"/></ns4:solidFill><ns5:ln xmlns:ns5="http://schemas.openxmlformats.org/drawingml/2006/main"><ns5:noFill/></ns5:ln></ns0:spPr></ns0:sp><ns0:sp><ns0:nvSpPr><ns0:cNvPr id="20" name="Body1.Left"/><ns0:cNvSpPr><ns1:spLocks xmlns:ns1="http://schemas.openxmlformats.org/drawingml/2006/main" noGrp="1"/></ns0:cNvSpPr><ns0:nvPr><ns0:ph idx="1" type="body"/></ns0:nvPr></ns0:nvSpPr><ns0:spPr><ns2:xfrm xmlns:ns2="http://schemas.openxmlformats.org/drawingml/2006/main"><ns2:off x="731520" y="1463040"/><ns2:ext cx="4846320" cy="4572000"/></ns2:xfrm></ns0:spPr><ns0:txBody><ns3:bodyPr xmlns:ns3="http://schemas.openxmlformats.org/drawingml/2006/main" wrap="square" anchor="t" anchorCtr="0"/><ns4:lstStyle><ns4:defPPr algn="ctr"><ns4:defRPr><ns4:solidFill><ns4:srgbClr val="94A3B8"/></ns4:solidFill></ns4:defRPr></ns4:defPPr></ns4:lstStyle><ns4:defPPr algn="ctr"><ns4:buNone/><ns4:defRPr sz="1400" dirty="0"><ns4:solidFill><ns4:srgbClr val="94A3B8"/></ns4:solidFill><ns4:latin typeface="Calibri"/><ns4:ea typeface="Calibri"/></ns4:defRPr></ns4:defPPr><ns4:lvl1pPr algn="ctr"><ns4:buNone/><ns4:defRPr sz="1400" dirty="0"><ns4:solidFill><ns4:srgbClr val="94A3B8"/></ns4:solidFill><ns4:latin typeface="Calibri"/><ns4:ea typeface="Calibri"/></ns4:defRPr></ns4:lvl1pPr><ns4:lvl2pPr algn="ctr"><ns4:buNone/><ns4:defRPr sz="1400" dirty="0"><ns4:solidFill><ns4:srgbClr val="94A3B8"/></ns4:solidFill><ns4:latin typeface="Calibri"/><ns4:ea typeface="Calibri"/></ns4:defRPr></ns4:lvl2pPr><ns4:lvl3pPr algn="ctr"><ns4:buNone/><ns4:defRPr sz="1400" dirty="0"><ns4:solidFill><ns4:srgbClr val="94A3B8"/></ns4:solidFill><ns4:latin typeface="Calibri"/><ns4:ea typeface="Calibri"/></ns4:defRPr></ns4:lvl3pPr><ns4:lvl4pPr algn="ctr"><ns4:buNone/><ns4:defRPr sz="1400" dirty="0"><ns4:solidFill><ns4:srgbClr val="94A3B8"/></ns4:solidFill><ns4:latin typeface="Calibri"/><ns4:ea typeface="Calibri"/></ns4:defRPr></ns4:lvl4pPr><ns4:lvl5pPr algn="ctr"><ns4:buNone/><ns4:defRPr sz="1400" dirty="0"><ns4:solidFill><ns4:srgbClr val="94A3B8"/></ns4:solidFill><ns4:latin typeface="Calibri"/><ns4:ea typeface="Calibri"/></ns4:defRPr></ns4:lvl5pPr><ns4:lvl6pPr algn="ctr"><ns4:buNone/><ns4:defRPr sz="1400" dirty="0"><ns4:solidFill><ns4:srgbClr val="94A3B8"/></ns4:solidFill><ns4:latin typeface="Calibri"/><ns4:ea typeface="Calibri"/></ns4:defRPr></ns4:lvl6pPr><ns4:lvl7pPr algn="ctr"><ns4:buNone/><ns4:defRPr sz="1400" dirty="0"><ns4:solidFill><ns4:srgbClr val="94A3B8"/></ns4:solidFill><ns4:latin typeface="Calibri"/><ns4:ea typeface="Calibri"/></ns4:defRPr></ns4:lvl7pPr><ns4:lvl8pPr algn="ctr"><ns4:buNone/><ns4:defRPr sz="1400" dirty="0"><ns4:solidFill><ns4:srgbClr val="94A3B8"/></ns4:solidFill><ns4:latin typeface="Calibri"/><ns4:ea typeface="Calibri"/></ns4:defRPr></ns4:lvl8pPr><ns4:lvl9pPr algn="ctr"><ns4:buNone/><ns4:defRPr sz="1400" dirty="0"><ns4:solidFill><ns4:srgbClr val="94A3B8"/></ns4:solidFill><ns4:latin typeface="Calibri"/><ns4:ea typeface="Calibri"/></ns4:defRPr></ns4:lvl9pPr></ns4:lstStyle/><ns5:p xmlns:ns5="http://schemas.openxmlformats.org/drawingml/2006/main"><ns5:pPr algn="ctr"><ns5:buNone/></ns5:pPr><ns5:r><ns5:rPr lang="ja-JP"/><ns5:t>チャート 2</ns5:t></ns5:r></ns5:p></ns0:txBody></ns0:sp><ns0:sp><ns0:nvSpPr><ns0:cNvPr id="30" name="SlideNum.Footer"/><ns0:cNvSpPr><ns1:spLocks xmlns:ns1="http://schemas.openxmlformats.org/drawingml/2006/main" noGrp="1"/></ns0:cNvSpPr><ns0:nvPr><ns0:ph idx="50" type="sldNum"/></ns0:nvPr></ns0:nvSpPr><ns0:spPr><ns2:xfrm xmlns:ns2="http://schemas.openxmlformats.org/drawingml/2006/main"><ns2:off x="10972800" y="6446520"/><ns2:ext cx="1097280" cy="274320"/></ns2:xfrm></ns0:spPr><ns0:txBody><ns3:bodyPr xmlns:ns3="http://schemas.openxmlformats.org/drawingml/2006/main" wrap="square" anchor="t" anchorCtr="0"/><ns4:lstStyle><ns4:defPPr algn="r"><ns4:defRPr sz="1000"><ns4:solidFill><ns4:srgbClr val="94A3B8"/></ns4:solidFill></ns4:defRPr></ns4:defPPr></ns4:lstStyle><ns4:defPPr algn="r"><ns4:buNone/><ns4:defRPr sz="1000" dirty="0"><ns4:solidFill><ns4:srgbClr val="94A3B8"/></ns4:solidFill><ns4:latin typeface="Calibri"/><ns4:ea typeface="Calibri"/></ns4:defRPr></ns4:defPPr><ns4:lvl1pPr algn="r"><ns4:buNone/><ns4:defRPr sz="1000" dirty="0"><ns4:solidFill><ns4:srgbClr val="94A3B8"/></ns4:solidFill><ns4:latin typeface="Calibri"/><ns4:ea typeface="Calibri"/></ns4:defRPr></ns4:lvl1pPr><ns4:lvl2pPr algn="r"><ns4:buNone/><ns4:defRPr sz="1000" dirty="0"><ns4:solidFill><ns4:srgbClr val="94A3B8"/></ns4:solidFill><ns4:latin typeface="Calibri"/><ns4:ea typeface="Calibri"/></ns4:defRPr></ns4:lvl2pPr><ns4:lvl3pPr algn="r"><ns4:buNone/><ns4:defRPr sz="1000" dirty="0"><ns4:solidFill><ns4:srgbClr val="94A3B8"/></ns4:solidFill><ns4:latin typeface="Calibri"/><ns4:ea typeface="Calibri"/></ns4:defRPr></ns4:lvl3pPr><ns4:lvl4pPr algn="r"><ns4:buNone/><ns4:defRPr sz="1000" dirty="0"><ns4:solidFill><ns4:srgbClr val="94A3B8"/></ns4:solidFill><ns4:latin typeface="Calibri"/><ns4:ea typeface="Calibri"/></ns4:defRPr></ns4:lvl4pPr><ns4:lvl5pPr algn="r"><ns4:buNone/><ns4:defRPr sz="1000" dirty="0"><ns4:solidFill><ns4:srgbClr val="94A3B8"/></ns4:solidFill><ns4:latin typeface="Calibri"/><ns4:ea typeface="Calibri"/></ns4:defRPr></ns4:lvl5pPr><ns4:lvl6pPr algn="r"><ns4:buNone/><ns4:defRPr sz="1000" dirty="0"><ns4:solidFill><ns4:srgbClr val="94A3B8"/></ns4:solidFill><ns4:latin typeface="Calibri"/><ns4:ea typeface="Calibri"/></ns4:defRPr></ns4:lvl6pPr><ns4:lvl7pPr algn="r"><ns4:buNone/><ns4:defRPr sz="1000" dirty="0"><ns4:solidFill><ns4:srgbClr val="94A3B8"/></ns4:solidFill><ns4:latin typeface="Calibri"/><ns4:ea typeface="Calibri"/></ns4:defRPr></ns4:lvl7pPr><ns4:lvl8pPr algn="r"><ns4:buNone/><ns4:defRPr sz="1000" dirty="0"><ns4:solidFill><ns4:srgbClr val="94A3B8"/></ns4:solidFill><ns4:latin typeface="Calibri"/><ns4:ea typeface="Calibri"/></ns4:defRPr></ns4:lvl8pPr><ns4:lvl9pPr algn="r"><ns4:buNone/><ns4:defRPr sz="1000" dirty="0"><ns4:solidFill><ns4:srgbClr val="94A3B8"/></ns4:solidFill><ns4:latin typeface="Calibri"/><ns4:ea typeface="Calibri"/></ns4:defRPr></ns4:lvl9pPr></ns4:lstStyle><ns5:p xmlns:ns5="http://schemas.openxmlformats.org/drawingml/2006/main"><ns5:pPr algn="r"><ns5:buNone/></ns5:pPr><ns5:r><ns5:rPr lang="ja-JP"/><ns5:t>&lt;#&gt;</ns5:t></ns5:r></ns5:p></ns0:txBody></ns0:sp></ns0:spTree></ns0:cSld><ns0:clrMapOvr/></ns0:sldLayout>
 </file>
 
 <file path=ppt/slideLayouts/slideLayout21.xml><?xml version='1.0' encoding='UTF-8' standalone='yes'?>
-<ns0:sldLayout xmlns:ns0="http://schemas.openxmlformats.org/presentationml/2006/main" type="blank" preserve="1"><ns0:cSld name="Table.1Table.Single+1Source"><ns0:spTree><ns0:nvGrpSpPr><ns0:cNvPr id="1" name=""/><ns0:cNvGrpSpPr/><ns0:nvPr/></ns0:nvGrpSpPr><ns0:grpSpPr><ns1:xfrm xmlns:ns1="http://schemas.openxmlformats.org/drawingml/2006/main"><ns1:off x="0" y="0"/><ns1:ext cx="0" cy="0"/><ns1:chOff x="0" y="0"/><ns1:chExt cx="0" cy="0"/></ns1:xfrm></ns0:grpSpPr><ns0:sp><ns0:nvSpPr><ns0:cNvPr id="2" name="HeaderBar"/><ns0:cNvSpPr><ns1:spLocks xmlns:ns1="http://schemas.openxmlformats.org/drawingml/2006/main" noGrp="1" noSelect="0" noRot="1" noMove="1"/></ns0:cNvSpPr><ns0:nvPr/></ns0:nvSpPr><ns0:spPr><ns2:xfrm xmlns:ns2="http://schemas.openxmlformats.org/drawingml/2006/main"><ns2:off x="0" y="0"/><ns2:ext cx="12192000" cy="1051560"/></ns2:xfrm><ns3:prstGeom xmlns:ns3="http://schemas.openxmlformats.org/drawingml/2006/main" prst="rect"/><ns4:solidFill xmlns:ns4="http://schemas.openxmlformats.org/drawingml/2006/main"><ns4:srgbClr val="1E2761"/></ns4:solidFill><ns5:ln xmlns:ns5="http://schemas.openxmlformats.org/drawingml/2006/main"><ns5:noFill/></ns5:ln></ns0:spPr></ns0:sp><ns0:sp><ns0:nvSpPr><ns0:cNvPr id="10" name="SlideTitle.Header"/><ns0:cNvSpPr><ns1:spLocks xmlns:ns1="http://schemas.openxmlformats.org/drawingml/2006/main" noGrp="1"/></ns0:cNvSpPr><ns0:nvPr><ns0:ph idx="15" type="body"/></ns0:nvPr></ns0:nvSpPr><ns0:spPr><ns2:xfrm xmlns:ns2="http://schemas.openxmlformats.org/drawingml/2006/main"><ns2:off x="731520" y="91440"/><ns2:ext cx="9144000" cy="475488"/></ns2:xfrm></ns0:spPr><ns0:txBody><ns3:bodyPr xmlns:ns3="http://schemas.openxmlformats.org/drawingml/2006/main" wrap="square" anchor="t" anchorCtr="0"/><ns4:lstStyle xmlns:ns4="http://schemas.openxmlformats.org/drawingml/2006/main"><ns4:defPPr algn="l"><ns4:buNone/><ns4:defRPr sz="2800" dirty="0" b="1"><ns4:solidFill><ns4:srgbClr val="FFFFFF"/></ns4:solidFill><ns4:latin typeface="Georgia"/><ns4:ea typeface="Georgia"/></ns4:defRPr></ns4:defPPr><ns4:lvl1pPr algn="l"><ns4:buNone/><ns4:defRPr sz="2800" dirty="0" b="1"><ns4:solidFill><ns4:srgbClr val="FFFFFF"/></ns4:solidFill><ns4:latin typeface="Georgia"/><ns4:ea typeface="Georgia"/></ns4:defRPr></ns4:lvl1pPr><ns4:lvl2pPr algn="l"><ns4:buNone/><ns4:defRPr sz="2800" dirty="0" b="1"><ns4:solidFill><ns4:srgbClr val="FFFFFF"/></ns4:solidFill><ns4:latin typeface="Georgia"/><ns4:ea typeface="Georgia"/></ns4:defRPr></ns4:lvl2pPr><ns4:lvl3pPr algn="l"><ns4:buNone/><ns4:defRPr sz="2800" dirty="0" b="1"><ns4:solidFill><ns4:srgbClr val="FFFFFF"/></ns4:solidFill><ns4:latin typeface="Georgia"/><ns4:ea typeface="Georgia"/></ns4:defRPr></ns4:lvl3pPr><ns4:lvl4pPr algn="l"><ns4:buNone/><ns4:defRPr sz="2800" dirty="0" b="1"><ns4:solidFill><ns4:srgbClr val="FFFFFF"/></ns4:solidFill><ns4:latin typeface="Georgia"/><ns4:ea typeface="Georgia"/></ns4:defRPr></ns4:lvl4pPr><ns4:lvl5pPr algn="l"><ns4:buNone/><ns4:defRPr sz="2800" dirty="0" b="1"><ns4:solidFill><ns4:srgbClr val="FFFFFF"/></ns4:solidFill><ns4:latin typeface="Georgia"/><ns4:ea typeface="Georgia"/></ns4:defRPr></ns4:lvl5pPr><ns4:lvl6pPr algn="l"><ns4:buNone/><ns4:defRPr sz="2800" dirty="0" b="1"><ns4:solidFill><ns4:srgbClr val="FFFFFF"/></ns4:solidFill><ns4:latin typeface="Georgia"/><ns4:ea typeface="Georgia"/></ns4:defRPr></ns4:lvl6pPr><ns4:lvl7pPr algn="l"><ns4:buNone/><ns4:defRPr sz="2800" dirty="0" b="1"><ns4:solidFill><ns4:srgbClr val="FFFFFF"/></ns4:solidFill><ns4:latin typeface="Georgia"/><ns4:ea typeface="Georgia"/></ns4:defRPr></ns4:lvl7pPr><ns4:lvl8pPr algn="l"><ns4:buNone/><ns4:defRPr sz="2800" dirty="0" b="1"><ns4:solidFill><ns4:srgbClr val="FFFFFF"/></ns4:solidFill><ns4:latin typeface="Georgia"/><ns4:ea typeface="Georgia"/></ns4:defRPr></ns4:lvl8pPr><ns4:lvl9pPr algn="l"><ns4:buNone/><ns4:defRPr sz="2800" dirty="0" b="1"><ns4:solidFill><ns4:srgbClr val="FFFFFF"/></ns4:solidFill><ns4:latin typeface="Georgia"/><ns4:ea typeface="Georgia"/></ns4:defRPr></ns4:lvl9pPr></ns4:lstStyle/><ns5:p xmlns:ns5="http://schemas.openxmlformats.org/drawingml/2006/main"><ns5:pPr algn="l"><ns5:buNone/></ns5:pPr><ns5:r><ns5:rPr lang="ja-JP"/><ns5:t>サブタイトル</ns5:t></ns5:r></ns5:p></ns0:txBody></ns0:sp><ns0:sp><ns0:nvSpPr><ns0:cNvPr id="20" name="Body.Center"/><ns0:cNvSpPr><ns1:spLocks xmlns:ns1="http://schemas.openxmlformats.org/drawingml/2006/main" noGrp="1"/></ns0:cNvSpPr><ns0:nvPr><ns0:ph idx="1" type="body"/></ns0:nvPr></ns0:nvSpPr><ns0:spPr><ns2:xfrm xmlns:ns2="http://schemas.openxmlformats.org/drawingml/2006/main"><ns2:off x="457200" y="1325880"/><ns2:ext cx="11247120" cy="4572000"/></ns2:xfrm></ns0:spPr><ns0:txBody><ns3:bodyPr xmlns:ns3="http://schemas.openxmlformats.org/drawingml/2006/main" wrap="square" anchor="t" anchorCtr="0"/><ns4:lstStyle xmlns:ns4="http://schemas.openxmlformats.org/drawingml/2006/main"><ns4:defPPr algn="l"><ns4:buNone/><ns4:defRPr sz="1400" dirty="0"><ns4:solidFill><ns4:srgbClr val="1E293B"/></ns4:solidFill><ns4:latin typeface="Calibri"/><ns4:ea typeface="Calibri"/></ns4:defRPr></ns4:defPPr><ns4:lvl1pPr algn="l"><ns4:buNone/><ns4:defRPr sz="1400" dirty="0"><ns4:solidFill><ns4:srgbClr val="1E293B"/></ns4:solidFill><ns4:latin typeface="Calibri"/><ns4:ea typeface="Calibri"/></ns4:defRPr></ns4:lvl1pPr><ns4:lvl2pPr algn="l"><ns4:buNone/><ns4:defRPr sz="1400" dirty="0"><ns4:solidFill><ns4:srgbClr val="1E293B"/></ns4:solidFill><ns4:latin typeface="Calibri"/><ns4:ea typeface="Calibri"/></ns4:defRPr></ns4:lvl2pPr><ns4:lvl3pPr algn="l"><ns4:buNone/><ns4:defRPr sz="1400" dirty="0"><ns4:solidFill><ns4:srgbClr val="1E293B"/></ns4:solidFill><ns4:latin typeface="Calibri"/><ns4:ea typeface="Calibri"/></ns4:defRPr></ns4:lvl3pPr><ns4:lvl4pPr algn="l"><ns4:buNone/><ns4:defRPr sz="1400" dirty="0"><ns4:solidFill><ns4:srgbClr val="1E293B"/></ns4:solidFill><ns4:latin typeface="Calibri"/><ns4:ea typeface="Calibri"/></ns4:defRPr></ns4:lvl4pPr><ns4:lvl5pPr algn="l"><ns4:buNone/><ns4:defRPr sz="1400" dirty="0"><ns4:solidFill><ns4:srgbClr val="1E293B"/></ns4:solidFill><ns4:latin typeface="Calibri"/><ns4:ea typeface="Calibri"/></ns4:defRPr></ns4:lvl5pPr><ns4:lvl6pPr algn="l"><ns4:buNone/><ns4:defRPr sz="1400" dirty="0"><ns4:solidFill><ns4:srgbClr val="1E293B"/></ns4:solidFill><ns4:latin typeface="Calibri"/><ns4:ea typeface="Calibri"/></ns4:defRPr></ns4:lvl6pPr><ns4:lvl7pPr algn="l"><ns4:buNone/><ns4:defRPr sz="1400" dirty="0"><ns4:solidFill><ns4:srgbClr val="1E293B"/></ns4:solidFill><ns4:latin typeface="Calibri"/><ns4:ea typeface="Calibri"/></ns4:defRPr></ns4:lvl7pPr><ns4:lvl8pPr algn="l"><ns4:buNone/><ns4:defRPr sz="1400" dirty="0"><ns4:solidFill><ns4:srgbClr val="1E293B"/></ns4:solidFill><ns4:latin typeface="Calibri"/><ns4:ea typeface="Calibri"/></ns4:defRPr></ns4:lvl8pPr><ns4:lvl9pPr algn="l"><ns4:buNone/><ns4:defRPr sz="1400" dirty="0"><ns4:solidFill><ns4:srgbClr val="1E293B"/></ns4:solidFill><ns4:latin typeface="Calibri"/><ns4:ea typeface="Calibri"/></ns4:defRPr></ns4:lvl9pPr></ns4:lstStyle/><ns5:p xmlns:ns5="http://schemas.openxmlformats.org/drawingml/2006/main"><ns5:pPr algn="l"><ns5:buNone/></ns5:pPr><ns5:r><ns5:rPr lang="ja-JP"/><ns5:t>出典：</ns5:t></ns5:r></ns5:p></ns0:txBody></ns0:sp><ns0:sp><ns0:nvSpPr><ns0:cNvPr id="30" name="SlideNum.Footer"/><ns0:cNvSpPr><ns1:spLocks xmlns:ns1="http://schemas.openxmlformats.org/drawingml/2006/main" noGrp="1"/></ns0:cNvSpPr><ns0:nvPr><ns0:ph idx="50" type="sldNum"/></ns0:nvPr></ns0:nvSpPr><ns0:spPr><ns2:xfrm xmlns:ns2="http://schemas.openxmlformats.org/drawingml/2006/main"><ns2:off x="10972800" y="6446520"/><ns2:ext cx="1097280" cy="274320"/></ns2:xfrm></ns0:spPr><ns0:txBody><ns3:bodyPr xmlns:ns3="http://schemas.openxmlformats.org/drawingml/2006/main" wrap="square" anchor="t" anchorCtr="0"/><ns4:lstStyle xmlns:ns4="http://schemas.openxmlformats.org/drawingml/2006/main"><ns4:defPPr algn="r"><ns4:buNone/><ns4:defRPr sz="1000" dirty="0"><ns4:solidFill><ns4:srgbClr val="94A3B8"/></ns4:solidFill><ns4:latin typeface="Calibri"/><ns4:ea typeface="Calibri"/></ns4:defRPr></ns4:defPPr><ns4:lvl1pPr algn="r"><ns4:buNone/><ns4:defRPr sz="1000" dirty="0"><ns4:solidFill><ns4:srgbClr val="94A3B8"/></ns4:solidFill><ns4:latin typeface="Calibri"/><ns4:ea typeface="Calibri"/></ns4:defRPr></ns4:lvl1pPr><ns4:lvl2pPr algn="r"><ns4:buNone/><ns4:defRPr sz="1000" dirty="0"><ns4:solidFill><ns4:srgbClr val="94A3B8"/></ns4:solidFill><ns4:latin typeface="Calibri"/><ns4:ea typeface="Calibri"/></ns4:defRPr></ns4:lvl2pPr><ns4:lvl3pPr algn="r"><ns4:buNone/><ns4:defRPr sz="1000" dirty="0"><ns4:solidFill><ns4:srgbClr val="94A3B8"/></ns4:solidFill><ns4:latin typeface="Calibri"/><ns4:ea typeface="Calibri"/></ns4:defRPr></ns4:lvl3pPr><ns4:lvl4pPr algn="r"><ns4:buNone/><ns4:defRPr sz="1000" dirty="0"><ns4:solidFill><ns4:srgbClr val="94A3B8"/></ns4:solidFill><ns4:latin typeface="Calibri"/><ns4:ea typeface="Calibri"/></ns4:defRPr></ns4:lvl4pPr><ns4:lvl5pPr algn="r"><ns4:buNone/><ns4:defRPr sz="1000" dirty="0"><ns4:solidFill><ns4:srgbClr val="94A3B8"/></ns4:solidFill><ns4:latin typeface="Calibri"/><ns4:ea typeface="Calibri"/></ns4:defRPr></ns4:lvl5pPr><ns4:lvl6pPr algn="r"><ns4:buNone/><ns4:defRPr sz="1000" dirty="0"><ns4:solidFill><ns4:srgbClr val="94A3B8"/></ns4:solidFill><ns4:latin typeface="Calibri"/><ns4:ea typeface="Calibri"/></ns4:defRPr></ns4:lvl6pPr><ns4:lvl7pPr algn="r"><ns4:buNone/><ns4:defRPr sz="1000" dirty="0"><ns4:solidFill><ns4:srgbClr val="94A3B8"/></ns4:solidFill><ns4:latin typeface="Calibri"/><ns4:ea typeface="Calibri"/></ns4:defRPr></ns4:lvl7pPr><ns4:lvl8pPr algn="r"><ns4:buNone/><ns4:defRPr sz="1000" dirty="0"><ns4:solidFill><ns4:srgbClr val="94A3B8"/></ns4:solidFill><ns4:latin typeface="Calibri"/><ns4:ea typeface="Calibri"/></ns4:defRPr></ns4:lvl8pPr><ns4:lvl9pPr algn="r"><ns4:buNone/><ns4:defRPr sz="1000" dirty="0"><ns4:solidFill><ns4:srgbClr val="94A3B8"/></ns4:solidFill><ns4:latin typeface="Calibri"/><ns4:ea typeface="Calibri"/></ns4:defRPr></ns4:lvl9pPr></ns4:lstStyle><ns5:p xmlns:ns5="http://schemas.openxmlformats.org/drawingml/2006/main"><ns5:pPr algn="r"><ns5:buNone/></ns5:pPr><ns5:r><ns5:rPr lang="ja-JP"/><ns5:t>&lt;#&gt;</ns5:t></ns5:r></ns5:p></ns0:txBody></ns0:sp></ns0:spTree></ns0:cSld><ns0:clrMapOvr/></ns0:sldLayout>
+<ns0:sldLayout xmlns:ns0="http://schemas.openxmlformats.org/presentationml/2006/main" type="blank" preserve="1"><ns0:cSld name="Table.1Table.Single+1Source"><ns0:spTree><ns0:nvGrpSpPr><ns0:cNvPr id="1" name=""/><ns0:cNvGrpSpPr/><ns0:nvPr/></ns0:nvGrpSpPr><ns0:grpSpPr><ns1:xfrm xmlns:ns1="http://schemas.openxmlformats.org/drawingml/2006/main"><ns1:off x="0" y="0"/><ns1:ext cx="0" cy="0"/><ns1:chOff x="0" y="0"/><ns1:chExt cx="0" cy="0"/></ns1:xfrm></ns0:grpSpPr><ns0:sp><ns0:nvSpPr><ns0:cNvPr id="2" name="HeaderBar"/><ns0:cNvSpPr><ns1:spLocks xmlns:ns1="http://schemas.openxmlformats.org/drawingml/2006/main" noGrp="1" noSelect="0" noRot="1" noMove="1"/></ns0:cNvSpPr><ns0:nvPr/></ns0:nvSpPr><ns0:spPr><ns2:xfrm xmlns:ns2="http://schemas.openxmlformats.org/drawingml/2006/main"><ns2:off x="0" y="0"/><ns2:ext cx="12192000" cy="1051560"/></ns2:xfrm><ns3:prstGeom xmlns:ns3="http://schemas.openxmlformats.org/drawingml/2006/main" prst="rect"/><ns4:solidFill xmlns:ns4="http://schemas.openxmlformats.org/drawingml/2006/main"><ns4:srgbClr val="1E2761"/></ns4:solidFill><ns5:ln xmlns:ns5="http://schemas.openxmlformats.org/drawingml/2006/main"><ns5:noFill/></ns5:ln></ns0:spPr></ns0:sp><ns0:sp><ns0:nvSpPr><ns0:cNvPr id="10" name="SlideTitle.Header"/><ns0:cNvSpPr><ns1:spLocks xmlns:ns1="http://schemas.openxmlformats.org/drawingml/2006/main" noGrp="1"/></ns0:cNvSpPr><ns0:nvPr><ns0:ph idx="15" type="body"/></ns0:nvPr></ns0:nvSpPr><ns0:spPr><ns2:xfrm xmlns:ns2="http://schemas.openxmlformats.org/drawingml/2006/main"><ns2:off x="731520" y="91440"/><ns2:ext cx="9144000" cy="475488"/></ns2:xfrm></ns0:spPr><ns0:txBody><ns3:bodyPr xmlns:ns3="http://schemas.openxmlformats.org/drawingml/2006/main" wrap="square" anchor="t" anchorCtr="0"/><ns4:lstStyle><ns4:defPPr><ns4:defRPr sz="2800" b="1"><ns4:solidFill><ns4:srgbClr val="FFFFFF"/></ns4:solidFill></ns4:defRPr></ns4:defPPr></ns4:lstStyle><ns4:defPPr algn="l"><ns4:buNone/><ns4:defRPr sz="2800" dirty="0" b="1"><ns4:solidFill><ns4:srgbClr val="FFFFFF"/></ns4:solidFill><ns4:latin typeface="Georgia"/><ns4:ea typeface="Georgia"/></ns4:defRPr></ns4:defPPr><ns4:lvl1pPr algn="l"><ns4:buNone/><ns4:defRPr sz="2800" dirty="0" b="1"><ns4:solidFill><ns4:srgbClr val="FFFFFF"/></ns4:solidFill><ns4:latin typeface="Georgia"/><ns4:ea typeface="Georgia"/></ns4:defRPr></ns4:lvl1pPr><ns4:lvl2pPr algn="l"><ns4:buNone/><ns4:defRPr sz="2800" dirty="0" b="1"><ns4:solidFill><ns4:srgbClr val="FFFFFF"/></ns4:solidFill><ns4:latin typeface="Georgia"/><ns4:ea typeface="Georgia"/></ns4:defRPr></ns4:lvl2pPr><ns4:lvl3pPr algn="l"><ns4:buNone/><ns4:defRPr sz="2800" dirty="0" b="1"><ns4:solidFill><ns4:srgbClr val="FFFFFF"/></ns4:solidFill><ns4:latin typeface="Georgia"/><ns4:ea typeface="Georgia"/></ns4:defRPr></ns4:lvl3pPr><ns4:lvl4pPr algn="l"><ns4:buNone/><ns4:defRPr sz="2800" dirty="0" b="1"><ns4:solidFill><ns4:srgbClr val="FFFFFF"/></ns4:solidFill><ns4:latin typeface="Georgia"/><ns4:ea typeface="Georgia"/></ns4:defRPr></ns4:lvl4pPr><ns4:lvl5pPr algn="l"><ns4:buNone/><ns4:defRPr sz="2800" dirty="0" b="1"><ns4:solidFill><ns4:srgbClr val="FFFFFF"/></ns4:solidFill><ns4:latin typeface="Georgia"/><ns4:ea typeface="Georgia"/></ns4:defRPr></ns4:lvl5pPr><ns4:lvl6pPr algn="l"><ns4:buNone/><ns4:defRPr sz="2800" dirty="0" b="1"><ns4:solidFill><ns4:srgbClr val="FFFFFF"/></ns4:solidFill><ns4:latin typeface="Georgia"/><ns4:ea typeface="Georgia"/></ns4:defRPr></ns4:lvl6pPr><ns4:lvl7pPr algn="l"><ns4:buNone/><ns4:defRPr sz="2800" dirty="0" b="1"><ns4:solidFill><ns4:srgbClr val="FFFFFF"/></ns4:solidFill><ns4:latin typeface="Georgia"/><ns4:ea typeface="Georgia"/></ns4:defRPr></ns4:lvl7pPr><ns4:lvl8pPr algn="l"><ns4:buNone/><ns4:defRPr sz="2800" dirty="0" b="1"><ns4:solidFill><ns4:srgbClr val="FFFFFF"/></ns4:solidFill><ns4:latin typeface="Georgia"/><ns4:ea typeface="Georgia"/></ns4:defRPr></ns4:lvl8pPr><ns4:lvl9pPr algn="l"><ns4:buNone/><ns4:defRPr sz="2800" dirty="0" b="1"><ns4:solidFill><ns4:srgbClr val="FFFFFF"/></ns4:solidFill><ns4:latin typeface="Georgia"/><ns4:ea typeface="Georgia"/></ns4:defRPr></ns4:lvl9pPr></ns4:lstStyle/><ns5:p xmlns:ns5="http://schemas.openxmlformats.org/drawingml/2006/main"><ns5:pPr algn="l"><ns5:buNone/></ns5:pPr><ns5:r><ns5:rPr lang="ja-JP"/><ns5:t>サブタイトル</ns5:t></ns5:r></ns5:p></ns0:txBody></ns0:sp><ns0:sp><ns0:nvSpPr><ns0:cNvPr id="20" name="Body.Center"/><ns0:cNvSpPr><ns1:spLocks xmlns:ns1="http://schemas.openxmlformats.org/drawingml/2006/main" noGrp="1"/></ns0:cNvSpPr><ns0:nvPr><ns0:ph idx="1" type="body"/></ns0:nvPr></ns0:nvSpPr><ns0:spPr><ns2:xfrm xmlns:ns2="http://schemas.openxmlformats.org/drawingml/2006/main"><ns2:off x="457200" y="1325880"/><ns2:ext cx="11247120" cy="4572000"/></ns2:xfrm></ns0:spPr><ns0:txBody><ns3:bodyPr xmlns:ns3="http://schemas.openxmlformats.org/drawingml/2006/main" wrap="square" anchor="t" anchorCtr="0"/><ns4:lstStyle/><ns4:defPPr algn="l"><ns4:buNone/><ns4:defRPr sz="1400" dirty="0"><ns4:solidFill><ns4:srgbClr val="1E293B"/></ns4:solidFill><ns4:latin typeface="Calibri"/><ns4:ea typeface="Calibri"/></ns4:defRPr></ns4:defPPr><ns4:lvl1pPr algn="l"><ns4:buNone/><ns4:defRPr sz="1400" dirty="0"><ns4:solidFill><ns4:srgbClr val="1E293B"/></ns4:solidFill><ns4:latin typeface="Calibri"/><ns4:ea typeface="Calibri"/></ns4:defRPr></ns4:lvl1pPr><ns4:lvl2pPr algn="l"><ns4:buNone/><ns4:defRPr sz="1400" dirty="0"><ns4:solidFill><ns4:srgbClr val="1E293B"/></ns4:solidFill><ns4:latin typeface="Calibri"/><ns4:ea typeface="Calibri"/></ns4:defRPr></ns4:lvl2pPr><ns4:lvl3pPr algn="l"><ns4:buNone/><ns4:defRPr sz="1400" dirty="0"><ns4:solidFill><ns4:srgbClr val="1E293B"/></ns4:solidFill><ns4:latin typeface="Calibri"/><ns4:ea typeface="Calibri"/></ns4:defRPr></ns4:lvl3pPr><ns4:lvl4pPr algn="l"><ns4:buNone/><ns4:defRPr sz="1400" dirty="0"><ns4:solidFill><ns4:srgbClr val="1E293B"/></ns4:solidFill><ns4:latin typeface="Calibri"/><ns4:ea typeface="Calibri"/></ns4:defRPr></ns4:lvl4pPr><ns4:lvl5pPr algn="l"><ns4:buNone/><ns4:defRPr sz="1400" dirty="0"><ns4:solidFill><ns4:srgbClr val="1E293B"/></ns4:solidFill><ns4:latin typeface="Calibri"/><ns4:ea typeface="Calibri"/></ns4:defRPr></ns4:lvl5pPr><ns4:lvl6pPr algn="l"><ns4:buNone/><ns4:defRPr sz="1400" dirty="0"><ns4:solidFill><ns4:srgbClr val="1E293B"/></ns4:solidFill><ns4:latin typeface="Calibri"/><ns4:ea typeface="Calibri"/></ns4:defRPr></ns4:lvl6pPr><ns4:lvl7pPr algn="l"><ns4:buNone/><ns4:defRPr sz="1400" dirty="0"><ns4:solidFill><ns4:srgbClr val="1E293B"/></ns4:solidFill><ns4:latin typeface="Calibri"/><ns4:ea typeface="Calibri"/></ns4:defRPr></ns4:lvl7pPr><ns4:lvl8pPr algn="l"><ns4:buNone/><ns4:defRPr sz="1400" dirty="0"><ns4:solidFill><ns4:srgbClr val="1E293B"/></ns4:solidFill><ns4:latin typeface="Calibri"/><ns4:ea typeface="Calibri"/></ns4:defRPr></ns4:lvl8pPr><ns4:lvl9pPr algn="l"><ns4:buNone/><ns4:defRPr sz="1400" dirty="0"><ns4:solidFill><ns4:srgbClr val="1E293B"/></ns4:solidFill><ns4:latin typeface="Calibri"/><ns4:ea typeface="Calibri"/></ns4:defRPr></ns4:lvl9pPr></ns4:lstStyle/><ns5:p xmlns:ns5="http://schemas.openxmlformats.org/drawingml/2006/main"><ns5:pPr algn="l"><ns5:buNone/></ns5:pPr><ns5:r><ns5:rPr lang="ja-JP"/><ns5:t>出典：</ns5:t></ns5:r></ns5:p></ns0:txBody></ns0:sp><ns0:sp><ns0:nvSpPr><ns0:cNvPr id="30" name="SlideNum.Footer"/><ns0:cNvSpPr><ns1:spLocks xmlns:ns1="http://schemas.openxmlformats.org/drawingml/2006/main" noGrp="1"/></ns0:cNvSpPr><ns0:nvPr><ns0:ph idx="50" type="sldNum"/></ns0:nvPr></ns0:nvSpPr><ns0:spPr><ns2:xfrm xmlns:ns2="http://schemas.openxmlformats.org/drawingml/2006/main"><ns2:off x="10972800" y="6446520"/><ns2:ext cx="1097280" cy="274320"/></ns2:xfrm></ns0:spPr><ns0:txBody><ns3:bodyPr xmlns:ns3="http://schemas.openxmlformats.org/drawingml/2006/main" wrap="square" anchor="t" anchorCtr="0"/><ns4:lstStyle><ns4:defPPr algn="r"><ns4:defRPr sz="1000"><ns4:solidFill><ns4:srgbClr val="94A3B8"/></ns4:solidFill></ns4:defRPr></ns4:defPPr></ns4:lstStyle><ns4:defPPr algn="r"><ns4:buNone/><ns4:defRPr sz="1000" dirty="0"><ns4:solidFill><ns4:srgbClr val="94A3B8"/></ns4:solidFill><ns4:latin typeface="Calibri"/><ns4:ea typeface="Calibri"/></ns4:defRPr></ns4:defPPr><ns4:lvl1pPr algn="r"><ns4:buNone/><ns4:defRPr sz="1000" dirty="0"><ns4:solidFill><ns4:srgbClr val="94A3B8"/></ns4:solidFill><ns4:latin typeface="Calibri"/><ns4:ea typeface="Calibri"/></ns4:defRPr></ns4:lvl1pPr><ns4:lvl2pPr algn="r"><ns4:buNone/><ns4:defRPr sz="1000" dirty="0"><ns4:solidFill><ns4:srgbClr val="94A3B8"/></ns4:solidFill><ns4:latin typeface="Calibri"/><ns4:ea typeface="Calibri"/></ns4:defRPr></ns4:lvl2pPr><ns4:lvl3pPr algn="r"><ns4:buNone/><ns4:defRPr sz="1000" dirty="0"><ns4:solidFill><ns4:srgbClr val="94A3B8"/></ns4:solidFill><ns4:latin typeface="Calibri"/><ns4:ea typeface="Calibri"/></ns4:defRPr></ns4:lvl3pPr><ns4:lvl4pPr algn="r"><ns4:buNone/><ns4:defRPr sz="1000" dirty="0"><ns4:solidFill><ns4:srgbClr val="94A3B8"/></ns4:solidFill><ns4:latin typeface="Calibri"/><ns4:ea typeface="Calibri"/></ns4:defRPr></ns4:lvl4pPr><ns4:lvl5pPr algn="r"><ns4:buNone/><ns4:defRPr sz="1000" dirty="0"><ns4:solidFill><ns4:srgbClr val="94A3B8"/></ns4:solidFill><ns4:latin typeface="Calibri"/><ns4:ea typeface="Calibri"/></ns4:defRPr></ns4:lvl5pPr><ns4:lvl6pPr algn="r"><ns4:buNone/><ns4:defRPr sz="1000" dirty="0"><ns4:solidFill><ns4:srgbClr val="94A3B8"/></ns4:solidFill><ns4:latin typeface="Calibri"/><ns4:ea typeface="Calibri"/></ns4:defRPr></ns4:lvl6pPr><ns4:lvl7pPr algn="r"><ns4:buNone/><ns4:defRPr sz="1000" dirty="0"><ns4:solidFill><ns4:srgbClr val="94A3B8"/></ns4:solidFill><ns4:latin typeface="Calibri"/><ns4:ea typeface="Calibri"/></ns4:defRPr></ns4:lvl7pPr><ns4:lvl8pPr algn="r"><ns4:buNone/><ns4:defRPr sz="1000" dirty="0"><ns4:solidFill><ns4:srgbClr val="94A3B8"/></ns4:solidFill><ns4:latin typeface="Calibri"/><ns4:ea typeface="Calibri"/></ns4:defRPr></ns4:lvl8pPr><ns4:lvl9pPr algn="r"><ns4:buNone/><ns4:defRPr sz="1000" dirty="0"><ns4:solidFill><ns4:srgbClr val="94A3B8"/></ns4:solidFill><ns4:latin typeface="Calibri"/><ns4:ea typeface="Calibri"/></ns4:defRPr></ns4:lvl9pPr></ns4:lstStyle><ns5:p xmlns:ns5="http://schemas.openxmlformats.org/drawingml/2006/main"><ns5:pPr algn="r"><ns5:buNone/></ns5:pPr><ns5:r><ns5:rPr lang="ja-JP"/><ns5:t>&lt;#&gt;</ns5:t></ns5:r></ns5:p></ns0:txBody></ns0:sp></ns0:spTree></ns0:cSld><ns0:clrMapOvr/></ns0:sldLayout>
 </file>
 
 <file path=ppt/slideLayouts/slideLayout22.xml><?xml version='1.0' encoding='UTF-8' standalone='yes'?>
-<ns0:sldLayout xmlns:ns0="http://schemas.openxmlformats.org/presentationml/2006/main" type="blank" preserve="1"><ns0:cSld name="Table.1Table.Single+1Notes"><ns0:spTree><ns0:nvGrpSpPr><ns0:cNvPr id="1" name=""/><ns0:cNvGrpSpPr/><ns0:nvPr/></ns0:nvGrpSpPr><ns0:grpSpPr><ns1:xfrm xmlns:ns1="http://schemas.openxmlformats.org/drawingml/2006/main"><ns1:off x="0" y="0"/><ns1:ext cx="0" cy="0"/><ns1:chOff x="0" y="0"/><ns1:chExt cx="0" cy="0"/></ns1:xfrm></ns0:grpSpPr><ns0:sp><ns0:nvSpPr><ns0:cNvPr id="2" name="HeaderBar"/><ns0:cNvSpPr><ns1:spLocks xmlns:ns1="http://schemas.openxmlformats.org/drawingml/2006/main" noGrp="1" noSelect="0" noRot="1" noMove="1"/></ns0:cNvSpPr><ns0:nvPr/></ns0:nvSpPr><ns0:spPr><ns2:xfrm xmlns:ns2="http://schemas.openxmlformats.org/drawingml/2006/main"><ns2:off x="0" y="0"/><ns2:ext cx="12192000" cy="1051560"/></ns2:xfrm><ns3:prstGeom xmlns:ns3="http://schemas.openxmlformats.org/drawingml/2006/main" prst="rect"/><ns4:solidFill xmlns:ns4="http://schemas.openxmlformats.org/drawingml/2006/main"><ns4:srgbClr val="1E2761"/></ns4:solidFill><ns5:ln xmlns:ns5="http://schemas.openxmlformats.org/drawingml/2006/main"><ns5:noFill/></ns5:ln></ns0:spPr></ns0:sp><ns0:sp><ns0:nvSpPr><ns0:cNvPr id="10" name="SlideTitle.Header"/><ns0:cNvSpPr><ns1:spLocks xmlns:ns1="http://schemas.openxmlformats.org/drawingml/2006/main" noGrp="1"/></ns0:cNvSpPr><ns0:nvPr><ns0:ph idx="15" type="body"/></ns0:nvPr></ns0:nvSpPr><ns0:spPr><ns2:xfrm xmlns:ns2="http://schemas.openxmlformats.org/drawingml/2006/main"><ns2:off x="731520" y="91440"/><ns2:ext cx="9144000" cy="475488"/></ns2:xfrm></ns0:spPr><ns0:txBody><ns3:bodyPr xmlns:ns3="http://schemas.openxmlformats.org/drawingml/2006/main" wrap="square" anchor="t" anchorCtr="0"/><ns4:lstStyle xmlns:ns4="http://schemas.openxmlformats.org/drawingml/2006/main"><ns4:defPPr algn="l"><ns4:buNone/><ns4:defRPr sz="2800" dirty="0" b="1"><ns4:solidFill><ns4:srgbClr val="FFFFFF"/></ns4:solidFill><ns4:latin typeface="Georgia"/><ns4:ea typeface="Georgia"/></ns4:defRPr></ns4:defPPr><ns4:lvl1pPr algn="l"><ns4:buNone/><ns4:defRPr sz="2800" dirty="0" b="1"><ns4:solidFill><ns4:srgbClr val="FFFFFF"/></ns4:solidFill><ns4:latin typeface="Georgia"/><ns4:ea typeface="Georgia"/></ns4:defRPr></ns4:lvl1pPr><ns4:lvl2pPr algn="l"><ns4:buNone/><ns4:defRPr sz="2800" dirty="0" b="1"><ns4:solidFill><ns4:srgbClr val="FFFFFF"/></ns4:solidFill><ns4:latin typeface="Georgia"/><ns4:ea typeface="Georgia"/></ns4:defRPr></ns4:lvl2pPr><ns4:lvl3pPr algn="l"><ns4:buNone/><ns4:defRPr sz="2800" dirty="0" b="1"><ns4:solidFill><ns4:srgbClr val="FFFFFF"/></ns4:solidFill><ns4:latin typeface="Georgia"/><ns4:ea typeface="Georgia"/></ns4:defRPr></ns4:lvl3pPr><ns4:lvl4pPr algn="l"><ns4:buNone/><ns4:defRPr sz="2800" dirty="0" b="1"><ns4:solidFill><ns4:srgbClr val="FFFFFF"/></ns4:solidFill><ns4:latin typeface="Georgia"/><ns4:ea typeface="Georgia"/></ns4:defRPr></ns4:lvl4pPr><ns4:lvl5pPr algn="l"><ns4:buNone/><ns4:defRPr sz="2800" dirty="0" b="1"><ns4:solidFill><ns4:srgbClr val="FFFFFF"/></ns4:solidFill><ns4:latin typeface="Georgia"/><ns4:ea typeface="Georgia"/></ns4:defRPr></ns4:lvl5pPr><ns4:lvl6pPr algn="l"><ns4:buNone/><ns4:defRPr sz="2800" dirty="0" b="1"><ns4:solidFill><ns4:srgbClr val="FFFFFF"/></ns4:solidFill><ns4:latin typeface="Georgia"/><ns4:ea typeface="Georgia"/></ns4:defRPr></ns4:lvl6pPr><ns4:lvl7pPr algn="l"><ns4:buNone/><ns4:defRPr sz="2800" dirty="0" b="1"><ns4:solidFill><ns4:srgbClr val="FFFFFF"/></ns4:solidFill><ns4:latin typeface="Georgia"/><ns4:ea typeface="Georgia"/></ns4:defRPr></ns4:lvl7pPr><ns4:lvl8pPr algn="l"><ns4:buNone/><ns4:defRPr sz="2800" dirty="0" b="1"><ns4:solidFill><ns4:srgbClr val="FFFFFF"/></ns4:solidFill><ns4:latin typeface="Georgia"/><ns4:ea typeface="Georgia"/></ns4:defRPr></ns4:lvl8pPr><ns4:lvl9pPr algn="l"><ns4:buNone/><ns4:defRPr sz="2800" dirty="0" b="1"><ns4:solidFill><ns4:srgbClr val="FFFFFF"/></ns4:solidFill><ns4:latin typeface="Georgia"/><ns4:ea typeface="Georgia"/></ns4:defRPr></ns4:lvl9pPr></ns4:lstStyle/><ns5:p xmlns:ns5="http://schemas.openxmlformats.org/drawingml/2006/main"><ns5:pPr algn="l"><ns5:buNone/></ns5:pPr><ns5:r><ns5:rPr lang="ja-JP"/><ns5:t>サブタイトル</ns5:t></ns5:r></ns5:p></ns0:txBody></ns0:sp><ns0:sp><ns0:nvSpPr><ns0:cNvPr id="20" name="Body.Left"/><ns0:cNvSpPr><ns1:spLocks xmlns:ns1="http://schemas.openxmlformats.org/drawingml/2006/main" noGrp="1"/></ns0:cNvSpPr><ns0:nvPr><ns0:ph idx="1" type="body"/></ns0:nvPr></ns0:nvSpPr><ns0:spPr><ns2:xfrm xmlns:ns2="http://schemas.openxmlformats.org/drawingml/2006/main"><ns2:off x="457200" y="1325880"/><ns2:ext cx="7772400" cy="4937760"/></ns2:xfrm></ns0:spPr><ns0:txBody><ns3:bodyPr xmlns:ns3="http://schemas.openxmlformats.org/drawingml/2006/main" wrap="square" anchor="t" anchorCtr="0"/><ns4:lstStyle xmlns:ns4="http://schemas.openxmlformats.org/drawingml/2006/main"><ns4:defPPr algn="l"><ns4:buNone/><ns4:defRPr sz="1400" dirty="0"><ns4:solidFill><ns4:srgbClr val="1E293B"/></ns4:solidFill><ns4:latin typeface="Calibri"/><ns4:ea typeface="Calibri"/></ns4:defRPr></ns4:defPPr><ns4:lvl1pPr algn="l"><ns4:buNone/><ns4:defRPr sz="1400" dirty="0"><ns4:solidFill><ns4:srgbClr val="1E293B"/></ns4:solidFill><ns4:latin typeface="Calibri"/><ns4:ea typeface="Calibri"/></ns4:defRPr></ns4:lvl1pPr><ns4:lvl2pPr algn="l"><ns4:buNone/><ns4:defRPr sz="1400" dirty="0"><ns4:solidFill><ns4:srgbClr val="1E293B"/></ns4:solidFill><ns4:latin typeface="Calibri"/><ns4:ea typeface="Calibri"/></ns4:defRPr></ns4:lvl2pPr><ns4:lvl3pPr algn="l"><ns4:buNone/><ns4:defRPr sz="1400" dirty="0"><ns4:solidFill><ns4:srgbClr val="1E293B"/></ns4:solidFill><ns4:latin typeface="Calibri"/><ns4:ea typeface="Calibri"/></ns4:defRPr></ns4:lvl3pPr><ns4:lvl4pPr algn="l"><ns4:buNone/><ns4:defRPr sz="1400" dirty="0"><ns4:solidFill><ns4:srgbClr val="1E293B"/></ns4:solidFill><ns4:latin typeface="Calibri"/><ns4:ea typeface="Calibri"/></ns4:defRPr></ns4:lvl4pPr><ns4:lvl5pPr algn="l"><ns4:buNone/><ns4:defRPr sz="1400" dirty="0"><ns4:solidFill><ns4:srgbClr val="1E293B"/></ns4:solidFill><ns4:latin typeface="Calibri"/><ns4:ea typeface="Calibri"/></ns4:defRPr></ns4:lvl5pPr><ns4:lvl6pPr algn="l"><ns4:buNone/><ns4:defRPr sz="1400" dirty="0"><ns4:solidFill><ns4:srgbClr val="1E293B"/></ns4:solidFill><ns4:latin typeface="Calibri"/><ns4:ea typeface="Calibri"/></ns4:defRPr></ns4:lvl6pPr><ns4:lvl7pPr algn="l"><ns4:buNone/><ns4:defRPr sz="1400" dirty="0"><ns4:solidFill><ns4:srgbClr val="1E293B"/></ns4:solidFill><ns4:latin typeface="Calibri"/><ns4:ea typeface="Calibri"/></ns4:defRPr></ns4:lvl7pPr><ns4:lvl8pPr algn="l"><ns4:buNone/><ns4:defRPr sz="1400" dirty="0"><ns4:solidFill><ns4:srgbClr val="1E293B"/></ns4:solidFill><ns4:latin typeface="Calibri"/><ns4:ea typeface="Calibri"/></ns4:defRPr></ns4:lvl8pPr><ns4:lvl9pPr algn="l"><ns4:buNone/><ns4:defRPr sz="1400" dirty="0"><ns4:solidFill><ns4:srgbClr val="1E293B"/></ns4:solidFill><ns4:latin typeface="Calibri"/><ns4:ea typeface="Calibri"/></ns4:defRPr></ns4:lvl9pPr></ns4:lstStyle/><ns5:p xmlns:ns5="http://schemas.openxmlformats.org/drawingml/2006/main"><ns5:pPr algn="l"><ns5:buNone/></ns5:pPr><ns5:r><ns5:rPr lang="ja-JP"/><ns5:t>コメント・注記
-
-テーブルの補足情報</ns5:t></ns5:r></ns5:p></ns0:txBody></ns0:sp><ns0:sp><ns0:nvSpPr><ns0:cNvPr id="30" name="SlideNum.Footer"/><ns0:cNvSpPr><ns1:spLocks xmlns:ns1="http://schemas.openxmlformats.org/drawingml/2006/main" noGrp="1"/></ns0:cNvSpPr><ns0:nvPr><ns0:ph idx="50" type="sldNum"/></ns0:nvPr></ns0:nvSpPr><ns0:spPr><ns2:xfrm xmlns:ns2="http://schemas.openxmlformats.org/drawingml/2006/main"><ns2:off x="10972800" y="6446520"/><ns2:ext cx="1097280" cy="274320"/></ns2:xfrm></ns0:spPr><ns0:txBody><ns3:bodyPr xmlns:ns3="http://schemas.openxmlformats.org/drawingml/2006/main" wrap="square" anchor="t" anchorCtr="0"/><ns4:lstStyle xmlns:ns4="http://schemas.openxmlformats.org/drawingml/2006/main"><ns4:defPPr algn="r"><ns4:buNone/><ns4:defRPr sz="1000" dirty="0"><ns4:solidFill><ns4:srgbClr val="94A3B8"/></ns4:solidFill><ns4:latin typeface="Calibri"/><ns4:ea typeface="Calibri"/></ns4:defRPr></ns4:defPPr><ns4:lvl1pPr algn="r"><ns4:buNone/><ns4:defRPr sz="1000" dirty="0"><ns4:solidFill><ns4:srgbClr val="94A3B8"/></ns4:solidFill><ns4:latin typeface="Calibri"/><ns4:ea typeface="Calibri"/></ns4:defRPr></ns4:lvl1pPr><ns4:lvl2pPr algn="r"><ns4:buNone/><ns4:defRPr sz="1000" dirty="0"><ns4:solidFill><ns4:srgbClr val="94A3B8"/></ns4:solidFill><ns4:latin typeface="Calibri"/><ns4:ea typeface="Calibri"/></ns4:defRPr></ns4:lvl2pPr><ns4:lvl3pPr algn="r"><ns4:buNone/><ns4:defRPr sz="1000" dirty="0"><ns4:solidFill><ns4:srgbClr val="94A3B8"/></ns4:solidFill><ns4:latin typeface="Calibri"/><ns4:ea typeface="Calibri"/></ns4:defRPr></ns4:lvl3pPr><ns4:lvl4pPr algn="r"><ns4:buNone/><ns4:defRPr sz="1000" dirty="0"><ns4:solidFill><ns4:srgbClr val="94A3B8"/></ns4:solidFill><ns4:latin typeface="Calibri"/><ns4:ea typeface="Calibri"/></ns4:defRPr></ns4:lvl4pPr><ns4:lvl5pPr algn="r"><ns4:buNone/><ns4:defRPr sz="1000" dirty="0"><ns4:solidFill><ns4:srgbClr val="94A3B8"/></ns4:solidFill><ns4:latin typeface="Calibri"/><ns4:ea typeface="Calibri"/></ns4:defRPr></ns4:lvl5pPr><ns4:lvl6pPr algn="r"><ns4:buNone/><ns4:defRPr sz="1000" dirty="0"><ns4:solidFill><ns4:srgbClr val="94A3B8"/></ns4:solidFill><ns4:latin typeface="Calibri"/><ns4:ea typeface="Calibri"/></ns4:defRPr></ns4:lvl6pPr><ns4:lvl7pPr algn="r"><ns4:buNone/><ns4:defRPr sz="1000" dirty="0"><ns4:solidFill><ns4:srgbClr val="94A3B8"/></ns4:solidFill><ns4:latin typeface="Calibri"/><ns4:ea typeface="Calibri"/></ns4:defRPr></ns4:lvl7pPr><ns4:lvl8pPr algn="r"><ns4:buNone/><ns4:defRPr sz="1000" dirty="0"><ns4:solidFill><ns4:srgbClr val="94A3B8"/></ns4:solidFill><ns4:latin typeface="Calibri"/><ns4:ea typeface="Calibri"/></ns4:defRPr></ns4:lvl8pPr><ns4:lvl9pPr algn="r"><ns4:buNone/><ns4:defRPr sz="1000" dirty="0"><ns4:solidFill><ns4:srgbClr val="94A3B8"/></ns4:solidFill><ns4:latin typeface="Calibri"/><ns4:ea typeface="Calibri"/></ns4:defRPr></ns4:lvl9pPr></ns4:lstStyle><ns5:p xmlns:ns5="http://schemas.openxmlformats.org/drawingml/2006/main"><ns5:pPr algn="r"><ns5:buNone/></ns5:pPr><ns5:r><ns5:rPr lang="ja-JP"/><ns5:t>&lt;#&gt;</ns5:t></ns5:r></ns5:p></ns0:txBody></ns0:sp></ns0:spTree></ns0:cSld><ns0:clrMapOvr/></ns0:sldLayout>
+<ns0:sldLayout xmlns:ns0="http://schemas.openxmlformats.org/presentationml/2006/main" type="blank" preserve="1"><ns0:cSld name="Table.1Table.Single+1Notes"><ns0:spTree><ns0:nvGrpSpPr><ns0:cNvPr id="1" name=""/><ns0:cNvGrpSpPr/><ns0:nvPr/></ns0:nvGrpSpPr><ns0:grpSpPr><ns1:xfrm xmlns:ns1="http://schemas.openxmlformats.org/drawingml/2006/main"><ns1:off x="0" y="0"/><ns1:ext cx="0" cy="0"/><ns1:chOff x="0" y="0"/><ns1:chExt cx="0" cy="0"/></ns1:xfrm></ns0:grpSpPr><ns0:sp><ns0:nvSpPr><ns0:cNvPr id="2" name="HeaderBar"/><ns0:cNvSpPr><ns1:spLocks xmlns:ns1="http://schemas.openxmlformats.org/drawingml/2006/main" noGrp="1" noSelect="0" noRot="1" noMove="1"/></ns0:cNvSpPr><ns0:nvPr/></ns0:nvSpPr><ns0:spPr><ns2:xfrm xmlns:ns2="http://schemas.openxmlformats.org/drawingml/2006/main"><ns2:off x="0" y="0"/><ns2:ext cx="12192000" cy="1051560"/></ns2:xfrm><ns3:prstGeom xmlns:ns3="http://schemas.openxmlformats.org/drawingml/2006/main" prst="rect"/><ns4:solidFill xmlns:ns4="http://schemas.openxmlformats.org/drawingml/2006/main"><ns4:srgbClr val="1E2761"/></ns4:solidFill><ns5:ln xmlns:ns5="http://schemas.openxmlformats.org/drawingml/2006/main"><ns5:noFill/></ns5:ln></ns0:spPr></ns0:sp><ns0:sp><ns0:nvSpPr><ns0:cNvPr id="10" name="SlideTitle.Header"/><ns0:cNvSpPr><ns1:spLocks xmlns:ns1="http://schemas.openxmlformats.org/drawingml/2006/main" noGrp="1"/></ns0:cNvSpPr><ns0:nvPr><ns0:ph idx="15" type="body"/></ns0:nvPr></ns0:nvSpPr><ns0:spPr><ns2:xfrm xmlns:ns2="http://schemas.openxmlformats.org/drawingml/2006/main"><ns2:off x="731520" y="91440"/><ns2:ext cx="9144000" cy="475488"/></ns2:xfrm></ns0:spPr><ns0:txBody><ns3:bodyPr xmlns:ns3="http://schemas.openxmlformats.org/drawingml/2006/main" wrap="square" anchor="t" anchorCtr="0"/><ns4:lstStyle><ns4:defPPr><ns4:defRPr sz="2800" b="1"><ns4:solidFill><ns4:srgbClr val="FFFFFF"/></ns4:solidFill></ns4:defRPr></ns4:defPPr></ns4:lstStyle><ns4:defPPr algn="l"><ns4:buNone/><ns4:defRPr sz="2800" dirty="0" b="1"><ns4:solidFill><ns4:srgbClr val="FFFFFF"/></ns4:solidFill><ns4:latin typeface="Georgia"/><ns4:ea typeface="Georgia"/></ns4:defRPr></ns4:defPPr><ns4:lvl1pPr algn="l"><ns4:buNone/><ns4:defRPr sz="2800" dirty="0" b="1"><ns4:solidFill><ns4:srgbClr val="FFFFFF"/></ns4:solidFill><ns4:latin typeface="Georgia"/><ns4:ea typeface="Georgia"/></ns4:defRPr></ns4:lvl1pPr><ns4:lvl2pPr algn="l"><ns4:buNone/><ns4:defRPr sz="2800" dirty="0" b="1"><ns4:solidFill><ns4:srgbClr val="FFFFFF"/></ns4:solidFill><ns4:latin typeface="Georgia"/><ns4:ea typeface="Georgia"/></ns4:defRPr></ns4:lvl2pPr><ns4:lvl3pPr algn="l"><ns4:buNone/><ns4:defRPr sz="2800" dirty="0" b="1"><ns4:solidFill><ns4:srgbClr val="FFFFFF"/></ns4:solidFill><ns4:latin typeface="Georgia"/><ns4:ea typeface="Georgia"/></ns4:defRPr></ns4:lvl3pPr><ns4:lvl4pPr algn="l"><ns4:buNone/><ns4:defRPr sz="2800" dirty="0" b="1"><ns4:solidFill><ns4:srgbClr val="FFFFFF"/></ns4:solidFill><ns4:latin typeface="Georgia"/><ns4:ea typeface="Georgia"/></ns4:defRPr></ns4:lvl4pPr><ns4:lvl5pPr algn="l"><ns4:buNone/><ns4:defRPr sz="2800" dirty="0" b="1"><ns4:solidFill><ns4:srgbClr val="FFFFFF"/></ns4:solidFill><ns4:latin typeface="Georgia"/><ns4:ea typeface="Georgia"/></ns4:defRPr></ns4:lvl5pPr><ns4:lvl6pPr algn="l"><ns4:buNone/><ns4:defRPr sz="2800" dirty="0" b="1"><ns4:solidFill><ns4:srgbClr val="FFFFFF"/></ns4:solidFill><ns4:latin typeface="Georgia"/><ns4:ea typeface="Georgia"/></ns4:defRPr></ns4:lvl6pPr><ns4:lvl7pPr algn="l"><ns4:buNone/><ns4:defRPr sz="2800" dirty="0" b="1"><ns4:solidFill><ns4:srgbClr val="FFFFFF"/></ns4:solidFill><ns4:latin typeface="Georgia"/><ns4:ea typeface="Georgia"/></ns4:defRPr></ns4:lvl7pPr><ns4:lvl8pPr algn="l"><ns4:buNone/><ns4:defRPr sz="2800" dirty="0" b="1"><ns4:solidFill><ns4:srgbClr val="FFFFFF"/></ns4:solidFill><ns4:latin typeface="Georgia"/><ns4:ea typeface="Georgia"/></ns4:defRPr></ns4:lvl8pPr><ns4:lvl9pPr algn="l"><ns4:buNone/><ns4:defRPr sz="2800" dirty="0" b="1"><ns4:solidFill><ns4:srgbClr val="FFFFFF"/></ns4:solidFill><ns4:latin typeface="Georgia"/><ns4:ea typeface="Georgia"/></ns4:defRPr></ns4:lvl9pPr></ns4:lstStyle/><ns5:p xmlns:ns5="http://schemas.openxmlformats.org/drawingml/2006/main"><ns5:pPr algn="l"><ns5:buNone/></ns5:pPr><ns5:r><ns5:rPr lang="ja-JP"/><ns5:t>サブタイトル</ns5:t></ns5:r></ns5:p></ns0:txBody></ns0:sp><ns0:sp><ns0:nvSpPr><ns0:cNvPr id="20" name="Body.Left"/><ns0:cNvSpPr><ns1:spLocks xmlns:ns1="http://schemas.openxmlformats.org/drawingml/2006/main" noGrp="1"/></ns0:cNvSpPr><ns0:nvPr><ns0:ph idx="1" type="body"/></ns0:nvPr></ns0:nvSpPr><ns0:spPr><ns2:xfrm xmlns:ns2="http://schemas.openxmlformats.org/drawingml/2006/main"><ns2:off x="457200" y="1325880"/><ns2:ext cx="7772400" cy="4937760"/></ns2:xfrm></ns0:spPr><ns0:txBody><ns3:bodyPr xmlns:ns3="http://schemas.openxmlformats.org/drawingml/2006/main" wrap="square" anchor="t" anchorCtr="0"/><ns4:lstStyle/><ns4:defPPr algn="l"><ns4:buNone/><ns4:defRPr sz="1400" dirty="0"><ns4:solidFill><ns4:srgbClr val="1E293B"/></ns4:solidFill><ns4:latin typeface="Calibri"/><ns4:ea typeface="Calibri"/></ns4:defRPr></ns4:defPPr><ns4:lvl1pPr algn="l"><ns4:buNone/><ns4:defRPr sz="1400" dirty="0"><ns4:solidFill><ns4:srgbClr val="1E293B"/></ns4:solidFill><ns4:latin typeface="Calibri"/><ns4:ea typeface="Calibri"/></ns4:defRPr></ns4:lvl1pPr><ns4:lvl2pPr algn="l"><ns4:buNone/><ns4:defRPr sz="1400" dirty="0"><ns4:solidFill><ns4:srgbClr val="1E293B"/></ns4:solidFill><ns4:latin typeface="Calibri"/><ns4:ea typeface="Calibri"/></ns4:defRPr></ns4:lvl2pPr><ns4:lvl3pPr algn="l"><ns4:buNone/><ns4:defRPr sz="1400" dirty="0"><ns4:solidFill><ns4:srgbClr val="1E293B"/></ns4:solidFill><ns4:latin typeface="Calibri"/><ns4:ea typeface="Calibri"/></ns4:defRPr></ns4:lvl3pPr><ns4:lvl4pPr algn="l"><ns4:buNone/><ns4:defRPr sz="1400" dirty="0"><ns4:solidFill><ns4:srgbClr val="1E293B"/></ns4:solidFill><ns4:latin typeface="Calibri"/><ns4:ea typeface="Calibri"/></ns4:defRPr></ns4:lvl4pPr><ns4:lvl5pPr algn="l"><ns4:buNone/><ns4:defRPr sz="1400" dirty="0"><ns4:solidFill><ns4:srgbClr val="1E293B"/></ns4:solidFill><ns4:latin typeface="Calibri"/><ns4:ea typeface="Calibri"/></ns4:defRPr></ns4:lvl5pPr><ns4:lvl6pPr algn="l"><ns4:buNone/><ns4:defRPr sz="1400" dirty="0"><ns4:solidFill><ns4:srgbClr val="1E293B"/></ns4:solidFill><ns4:latin typeface="Calibri"/><ns4:ea typeface="Calibri"/></ns4:defRPr></ns4:lvl6pPr><ns4:lvl7pPr algn="l"><ns4:buNone/><ns4:defRPr sz="1400" dirty="0"><ns4:solidFill><ns4:srgbClr val="1E293B"/></ns4:solidFill><ns4:latin typeface="Calibri"/><ns4:ea typeface="Calibri"/></ns4:defRPr></ns4:lvl7pPr><ns4:lvl8pPr algn="l"><ns4:buNone/><ns4:defRPr sz="1400" dirty="0"><ns4:solidFill><ns4:srgbClr val="1E293B"/></ns4:solidFill><ns4:latin typeface="Calibri"/><ns4:ea typeface="Calibri"/></ns4:defRPr></ns4:lvl8pPr><ns4:lvl9pPr algn="l"><ns4:buNone/><ns4:defRPr sz="1400" dirty="0"><ns4:solidFill><ns4:srgbClr val="1E293B"/></ns4:solidFill><ns4:latin typeface="Calibri"/><ns4:ea typeface="Calibri"/></ns4:defRPr></ns4:lvl9pPr></ns4:lstStyle/><ns5:p xmlns:ns5="http://schemas.openxmlformats.org/drawingml/2006/main"><ns5:pPr algn="l"><ns5:buNone/></ns5:pPr><ns5:r><ns5:rPr lang="ja-JP"/><ns5:t>コメント・注記
+
+テーブルの補足情報</ns5:t></ns5:r></ns5:p></ns0:txBody></ns0:sp><ns0:sp><ns0:nvSpPr><ns0:cNvPr id="30" name="SlideNum.Footer"/><ns0:cNvSpPr><ns1:spLocks xmlns:ns1="http://schemas.openxmlformats.org/drawingml/2006/main" noGrp="1"/></ns0:cNvSpPr><ns0:nvPr><ns0:ph idx="50" type="sldNum"/></ns0:nvPr></ns0:nvSpPr><ns0:spPr><ns2:xfrm xmlns:ns2="http://schemas.openxmlformats.org/drawingml/2006/main"><ns2:off x="10972800" y="6446520"/><ns2:ext cx="1097280" cy="274320"/></ns2:xfrm></ns0:spPr><ns0:txBody><ns3:bodyPr xmlns:ns3="http://schemas.openxmlformats.org/drawingml/2006/main" wrap="square" anchor="t" anchorCtr="0"/><ns4:lstStyle><ns4:defPPr algn="r"><ns4:defRPr sz="1000"><ns4:solidFill><ns4:srgbClr val="94A3B8"/></ns4:solidFill></ns4:defRPr></ns4:defPPr></ns4:lstStyle><ns4:defPPr algn="r"><ns4:buNone/><ns4:defRPr sz="1000" dirty="0"><ns4:solidFill><ns4:srgbClr val="94A3B8"/></ns4:solidFill><ns4:latin typeface="Calibri"/><ns4:ea typeface="Calibri"/></ns4:defRPr></ns4:defPPr><ns4:lvl1pPr algn="r"><ns4:buNone/><ns4:defRPr sz="1000" dirty="0"><ns4:solidFill><ns4:srgbClr val="94A3B8"/></ns4:solidFill><ns4:latin typeface="Calibri"/><ns4:ea typeface="Calibri"/></ns4:defRPr></ns4:lvl1pPr><ns4:lvl2pPr algn="r"><ns4:buNone/><ns4:defRPr sz="1000" dirty="0"><ns4:solidFill><ns4:srgbClr val="94A3B8"/></ns4:solidFill><ns4:latin typeface="Calibri"/><ns4:ea typeface="Calibri"/></ns4:defRPr></ns4:lvl2pPr><ns4:lvl3pPr algn="r"><ns4:buNone/><ns4:defRPr sz="1000" dirty="0"><ns4:solidFill><ns4:srgbClr val="94A3B8"/></ns4:solidFill><ns4:latin typeface="Calibri"/><ns4:ea typeface="Calibri"/></ns4:defRPr></ns4:lvl3pPr><ns4:lvl4pPr algn="r"><ns4:buNone/><ns4:defRPr sz="1000" dirty="0"><ns4:solidFill><ns4:srgbClr val="94A3B8"/></ns4:solidFill><ns4:latin typeface="Calibri"/><ns4:ea typeface="Calibri"/></ns4:defRPr></ns4:lvl4pPr><ns4:lvl5pPr algn="r"><ns4:buNone/><ns4:defRPr sz="1000" dirty="0"><ns4:solidFill><ns4:srgbClr val="94A3B8"/></ns4:solidFill><ns4:latin typeface="Calibri"/><ns4:ea typeface="Calibri"/></ns4:defRPr></ns4:lvl5pPr><ns4:lvl6pPr algn="r"><ns4:buNone/><ns4:defRPr sz="1000" dirty="0"><ns4:solidFill><ns4:srgbClr val="94A3B8"/></ns4:solidFill><ns4:latin typeface="Calibri"/><ns4:ea typeface="Calibri"/></ns4:defRPr></ns4:lvl6pPr><ns4:lvl7pPr algn="r"><ns4:buNone/><ns4:defRPr sz="1000" dirty="0"><ns4:solidFill><ns4:srgbClr val="94A3B8"/></ns4:solidFill><ns4:latin typeface="Calibri"/><ns4:ea typeface="Calibri"/></ns4:defRPr></ns4:lvl7pPr><ns4:lvl8pPr algn="r"><ns4:buNone/><ns4:defRPr sz="1000" dirty="0"><ns4:solidFill><ns4:srgbClr val="94A3B8"/></ns4:solidFill><ns4:latin typeface="Calibri"/><ns4:ea typeface="Calibri"/></ns4:defRPr></ns4:lvl8pPr><ns4:lvl9pPr algn="r"><ns4:buNone/><ns4:defRPr sz="1000" dirty="0"><ns4:solidFill><ns4:srgbClr val="94A3B8"/></ns4:solidFill><ns4:latin typeface="Calibri"/><ns4:ea typeface="Calibri"/></ns4:defRPr></ns4:lvl9pPr></ns4:lstStyle><ns5:p xmlns:ns5="http://schemas.openxmlformats.org/drawingml/2006/main"><ns5:pPr algn="r"><ns5:buNone/></ns5:pPr><ns5:r><ns5:rPr lang="ja-JP"/><ns5:t>&lt;#&gt;</ns5:t></ns5:r></ns5:p></ns0:txBody></ns0:sp></ns0:spTree></ns0:cSld><ns0:clrMapOvr/></ns0:sldLayout>
 </file>
 
 <file path=ppt/slideLayouts/slideLayout23.xml><?xml version='1.0' encoding='UTF-8' standalone='yes'?>
-<ns0:sldLayout xmlns:ns0="http://schemas.openxmlformats.org/presentationml/2006/main" type="blank" preserve="1"><ns0:cSld name="Compare.2Option.Versus"><ns0:spTree><ns0:nvGrpSpPr><ns0:cNvPr id="1" name=""/><ns0:cNvGrpSpPr/><ns0:nvPr/></ns0:nvGrpSpPr><ns0:grpSpPr><ns1:xfrm xmlns:ns1="http://schemas.openxmlformats.org/drawingml/2006/main"><ns1:off x="0" y="0"/><ns1:ext cx="0" cy="0"/><ns1:chOff x="0" y="0"/><ns1:chExt cx="0" cy="0"/></ns1:xfrm></ns0:grpSpPr><ns0:sp><ns0:nvSpPr><ns0:cNvPr id="2" name="HeaderBar"/><ns0:cNvSpPr><ns1:spLocks xmlns:ns1="http://schemas.openxmlformats.org/drawingml/2006/main" noGrp="1" noSelect="0" noRot="1" noMove="1"/></ns0:cNvSpPr><ns0:nvPr/></ns0:nvSpPr><ns0:spPr><ns2:xfrm xmlns:ns2="http://schemas.openxmlformats.org/drawingml/2006/main"><ns2:off x="0" y="0"/><ns2:ext cx="12192000" cy="1051560"/></ns2:xfrm><ns3:prstGeom xmlns:ns3="http://schemas.openxmlformats.org/drawingml/2006/main" prst="rect"/><ns4:solidFill xmlns:ns4="http://schemas.openxmlformats.org/drawingml/2006/main"><ns4:srgbClr val="1E2761"/></ns4:solidFill><ns5:ln xmlns:ns5="http://schemas.openxmlformats.org/drawingml/2006/main"><ns5:noFill/></ns5:ln></ns0:spPr></ns0:sp><ns0:sp><ns0:nvSpPr><ns0:cNvPr id="10" name="SlideTitle.Header"/><ns0:cNvSpPr><ns1:spLocks xmlns:ns1="http://schemas.openxmlformats.org/drawingml/2006/main" noGrp="1"/></ns0:cNvSpPr><ns0:nvPr><ns0:ph idx="15" type="body"/></ns0:nvPr></ns0:nvSpPr><ns0:spPr><ns2:xfrm xmlns:ns2="http://schemas.openxmlformats.org/drawingml/2006/main"><ns2:off x="731520" y="91440"/><ns2:ext cx="9144000" cy="475488"/></ns2:xfrm></ns0:spPr><ns0:txBody><ns3:bodyPr xmlns:ns3="http://schemas.openxmlformats.org/drawingml/2006/main" wrap="square" anchor="t" anchorCtr="0"/><ns4:lstStyle xmlns:ns4="http://schemas.openxmlformats.org/drawingml/2006/main"><ns4:defPPr algn="l"><ns4:buNone/><ns4:defRPr sz="2800" dirty="0" b="1"><ns4:solidFill><ns4:srgbClr val="FFFFFF"/></ns4:solidFill><ns4:latin typeface="Georgia"/><ns4:ea typeface="Georgia"/></ns4:defRPr></ns4:defPPr><ns4:lvl1pPr algn="l"><ns4:buNone/><ns4:defRPr sz="2800" dirty="0" b="1"><ns4:solidFill><ns4:srgbClr val="FFFFFF"/></ns4:solidFill><ns4:latin typeface="Georgia"/><ns4:ea typeface="Georgia"/></ns4:defRPr></ns4:lvl1pPr><ns4:lvl2pPr algn="l"><ns4:buNone/><ns4:defRPr sz="2800" dirty="0" b="1"><ns4:solidFill><ns4:srgbClr val="FFFFFF"/></ns4:solidFill><ns4:latin typeface="Georgia"/><ns4:ea typeface="Georgia"/></ns4:defRPr></ns4:lvl2pPr><ns4:lvl3pPr algn="l"><ns4:buNone/><ns4:defRPr sz="2800" dirty="0" b="1"><ns4:solidFill><ns4:srgbClr val="FFFFFF"/></ns4:solidFill><ns4:latin typeface="Georgia"/><ns4:ea typeface="Georgia"/></ns4:defRPr></ns4:lvl3pPr><ns4:lvl4pPr algn="l"><ns4:buNone/><ns4:defRPr sz="2800" dirty="0" b="1"><ns4:solidFill><ns4:srgbClr val="FFFFFF"/></ns4:solidFill><ns4:latin typeface="Georgia"/><ns4:ea typeface="Georgia"/></ns4:defRPr></ns4:lvl4pPr><ns4:lvl5pPr algn="l"><ns4:buNone/><ns4:defRPr sz="2800" dirty="0" b="1"><ns4:solidFill><ns4:srgbClr val="FFFFFF"/></ns4:solidFill><ns4:latin typeface="Georgia"/><ns4:ea typeface="Georgia"/></ns4:defRPr></ns4:lvl5pPr><ns4:lvl6pPr algn="l"><ns4:buNone/><ns4:defRPr sz="2800" dirty="0" b="1"><ns4:solidFill><ns4:srgbClr val="FFFFFF"/></ns4:solidFill><ns4:latin typeface="Georgia"/><ns4:ea typeface="Georgia"/></ns4:defRPr></ns4:lvl6pPr><ns4:lvl7pPr algn="l"><ns4:buNone/><ns4:defRPr sz="2800" dirty="0" b="1"><ns4:solidFill><ns4:srgbClr val="FFFFFF"/></ns4:solidFill><ns4:latin typeface="Georgia"/><ns4:ea typeface="Georgia"/></ns4:defRPr></ns4:lvl7pPr><ns4:lvl8pPr algn="l"><ns4:buNone/><ns4:defRPr sz="2800" dirty="0" b="1"><ns4:solidFill><ns4:srgbClr val="FFFFFF"/></ns4:solidFill><ns4:latin typeface="Georgia"/><ns4:ea typeface="Georgia"/></ns4:defRPr></ns4:lvl8pPr><ns4:lvl9pPr algn="l"><ns4:buNone/><ns4:defRPr sz="2800" dirty="0" b="1"><ns4:solidFill><ns4:srgbClr val="FFFFFF"/></ns4:solidFill><ns4:latin typeface="Georgia"/><ns4:ea typeface="Georgia"/></ns4:defRPr></ns4:lvl9pPr></ns4:lstStyle/><ns5:p xmlns:ns5="http://schemas.openxmlformats.org/drawingml/2006/main"><ns5:pPr algn="l"><ns5:buNone/></ns5:pPr><ns5:r><ns5:rPr lang="ja-JP"/><ns5:t>サブタイトル</ns5:t></ns5:r></ns5:p></ns0:txBody></ns0:sp><ns0:sp><ns0:nvSpPr><ns0:cNvPr id="5" name="PanelL"/><ns0:cNvSpPr><ns1:spLocks xmlns:ns1="http://schemas.openxmlformats.org/drawingml/2006/main" noGrp="1" noSelect="0" noRot="1" noMove="1"/></ns0:cNvSpPr><ns0:nvPr/></ns0:nvSpPr><ns0:spPr><ns2:xfrm xmlns:ns2="http://schemas.openxmlformats.org/drawingml/2006/main"><ns2:off x="457200" y="1280160"/><ns2:ext cx="5303520" cy="4937760"/></ns2:xfrm><ns3:prstGeom xmlns:ns3="http://schemas.openxmlformats.org/drawingml/2006/main" prst="roundRect"><ns3:avLst><ns3:gd name="adj" fmla="val 8000"/></ns3:avLst></ns3:prstGeom><ns4:solidFill xmlns:ns4="http://schemas.openxmlformats.org/drawingml/2006/main"><ns4:srgbClr val="EDF0F7"/></ns4:solidFill><ns5:ln xmlns:ns5="http://schemas.openxmlformats.org/drawingml/2006/main"><ns5:noFill/></ns5:ln></ns0:spPr></ns0:sp><ns0:sp><ns0:nvSpPr><ns0:cNvPr id="6" name="PanelR"/><ns0:cNvSpPr><ns1:spLocks xmlns:ns1="http://schemas.openxmlformats.org/drawingml/2006/main" noGrp="1" noSelect="0" noRot="1" noMove="1"/></ns0:cNvSpPr><ns0:nvPr/></ns0:nvSpPr><ns0:spPr><ns2:xfrm xmlns:ns2="http://schemas.openxmlformats.org/drawingml/2006/main"><ns2:off x="6126480" y="1280160"/><ns2:ext cx="5394960" cy="4937760"/></ns2:xfrm><ns3:prstGeom xmlns:ns3="http://schemas.openxmlformats.org/drawingml/2006/main" prst="roundRect"><ns3:avLst><ns3:gd name="adj" fmla="val 8000"/></ns3:avLst></ns3:prstGeom><ns4:solidFill xmlns:ns4="http://schemas.openxmlformats.org/drawingml/2006/main"><ns4:srgbClr val="EDF0F7"/></ns4:solidFill><ns5:ln xmlns:ns5="http://schemas.openxmlformats.org/drawingml/2006/main"><ns5:noFill/></ns5:ln></ns0:spPr></ns0:sp><ns0:sp><ns0:nvSpPr><ns0:cNvPr id="7" name="AccentL"/><ns0:cNvSpPr><ns1:spLocks xmlns:ns1="http://schemas.openxmlformats.org/drawingml/2006/main" noGrp="1" noSelect="0" noRot="1" noMove="1"/></ns0:cNvSpPr><ns0:nvPr/></ns0:nvSpPr><ns0:spPr><ns2:xfrm xmlns:ns2="http://schemas.openxmlformats.org/drawingml/2006/main"><ns2:off x="457200" y="1280160"/><ns2:ext cx="5303520" cy="54864"/></ns2:xfrm><ns3:prstGeom xmlns:ns3="http://schemas.openxmlformats.org/drawingml/2006/main" prst="rect"/><ns4:solidFill xmlns:ns4="http://schemas.openxmlformats.org/drawingml/2006/main"><ns4:srgbClr val="3B82F6"/></ns4:solidFill><ns5:ln xmlns:ns5="http://schemas.openxmlformats.org/drawingml/2006/main"><ns5:noFill/></ns5:ln></ns0:spPr></ns0:sp><ns0:sp><ns0:nvSpPr><ns0:cNvPr id="8" name="AccentR"/><ns0:cNvSpPr><ns1:spLocks xmlns:ns1="http://schemas.openxmlformats.org/drawingml/2006/main" noGrp="1" noSelect="0" noRot="1" noMove="1"/></ns0:cNvSpPr><ns0:nvPr/></ns0:nvSpPr><ns0:spPr><ns2:xfrm xmlns:ns2="http://schemas.openxmlformats.org/drawingml/2006/main"><ns2:off x="6126480" y="1280160"/><ns2:ext cx="5394960" cy="54864"/></ns2:xfrm><ns3:prstGeom xmlns:ns3="http://schemas.openxmlformats.org/drawingml/2006/main" prst="rect"/><ns4:solidFill xmlns:ns4="http://schemas.openxmlformats.org/drawingml/2006/main"><ns4:srgbClr val="06B6D4"/></ns4:solidFill><ns5:ln xmlns:ns5="http://schemas.openxmlformats.org/drawingml/2006/main"><ns5:noFill/></ns5:ln></ns0:spPr></ns0:sp><ns0:sp><ns0:nvSpPr><ns0:cNvPr id="9" name="VS"/><ns0:cNvSpPr><ns1:spLocks xmlns:ns1="http://schemas.openxmlformats.org/drawingml/2006/main" noGrp="1"/></ns0:cNvSpPr><ns0:nvPr/></ns0:nvSpPr><ns0:spPr><ns2:xfrm xmlns:ns2="http://schemas.openxmlformats.org/drawingml/2006/main"><ns2:off x="5309408461680" y="3428121901679"/><ns2:ext cx="548640" cy="548640"/></ns2:xfrm><ns3:prstGeom xmlns:ns3="http://schemas.openxmlformats.org/drawingml/2006/main" prst="ellipse"/><ns4:solidFill xmlns:ns4="http://schemas.openxmlformats.org/drawingml/2006/main"><ns4:srgbClr val="1E2761"/></ns4:solidFill><ns5:ln xmlns:ns5="http://schemas.openxmlformats.org/drawingml/2006/main"><ns5:noFill/></ns5:ln></ns0:spPr></ns0:sp><ns0:sp><ns0:nvSpPr><ns0:cNvPr id="20" name="OptionLabel1.Left"/><ns0:cNvSpPr><ns1:spLocks xmlns:ns1="http://schemas.openxmlformats.org/drawingml/2006/main" noGrp="1"/></ns0:cNvSpPr><ns0:nvPr><ns0:ph idx="1" type="body"/></ns0:nvPr></ns0:nvSpPr><ns0:spPr><ns2:xfrm xmlns:ns2="http://schemas.openxmlformats.org/drawingml/2006/main"><ns2:off x="731520" y="1554480"/><ns2:ext cx="4754880" cy="457200"/></ns2:xfrm></ns0:spPr><ns0:txBody><ns3:bodyPr xmlns:ns3="http://schemas.openxmlformats.org/drawingml/2006/main" wrap="square" anchor="t" anchorCtr="0"/><ns4:lstStyle xmlns:ns4="http://schemas.openxmlformats.org/drawingml/2006/main"><ns4:defPPr algn="l"><ns4:buNone/><ns4:defRPr sz="1600" dirty="0" b="1"><ns4:solidFill><ns4:srgbClr val="3B82F6"/></ns4:solidFill><ns4:latin typeface="Calibri"/><ns4:ea typeface="Calibri"/></ns4:defRPr></ns4:defPPr><ns4:lvl1pPr algn="l"><ns4:buNone/><ns4:defRPr sz="1600" dirty="0" b="1"><ns4:solidFill><ns4:srgbClr val="3B82F6"/></ns4:solidFill><ns4:latin typeface="Calibri"/><ns4:ea typeface="Calibri"/></ns4:defRPr></ns4:lvl1pPr><ns4:lvl2pPr algn="l"><ns4:buNone/><ns4:defRPr sz="1600" dirty="0" b="1"><ns4:solidFill><ns4:srgbClr val="3B82F6"/></ns4:solidFill><ns4:latin typeface="Calibri"/><ns4:ea typeface="Calibri"/></ns4:defRPr></ns4:lvl2pPr><ns4:lvl3pPr algn="l"><ns4:buNone/><ns4:defRPr sz="1600" dirty="0" b="1"><ns4:solidFill><ns4:srgbClr val="3B82F6"/></ns4:solidFill><ns4:latin typeface="Calibri"/><ns4:ea typeface="Calibri"/></ns4:defRPr></ns4:lvl3pPr><ns4:lvl4pPr algn="l"><ns4:buNone/><ns4:defRPr sz="1600" dirty="0" b="1"><ns4:solidFill><ns4:srgbClr val="3B82F6"/></ns4:solidFill><ns4:latin typeface="Calibri"/><ns4:ea typeface="Calibri"/></ns4:defRPr></ns4:lvl4pPr><ns4:lvl5pPr algn="l"><ns4:buNone/><ns4:defRPr sz="1600" dirty="0" b="1"><ns4:solidFill><ns4:srgbClr val="3B82F6"/></ns4:solidFill><ns4:latin typeface="Calibri"/><ns4:ea typeface="Calibri"/></ns4:defRPr></ns4:lvl5pPr><ns4:lvl6pPr algn="l"><ns4:buNone/><ns4:defRPr sz="1600" dirty="0" b="1"><ns4:solidFill><ns4:srgbClr val="3B82F6"/></ns4:solidFill><ns4:latin typeface="Calibri"/><ns4:ea typeface="Calibri"/></ns4:defRPr></ns4:lvl6pPr><ns4:lvl7pPr algn="l"><ns4:buNone/><ns4:defRPr sz="1600" dirty="0" b="1"><ns4:solidFill><ns4:srgbClr val="3B82F6"/></ns4:solidFill><ns4:latin typeface="Calibri"/><ns4:ea typeface="Calibri"/></ns4:defRPr></ns4:lvl7pPr><ns4:lvl8pPr algn="l"><ns4:buNone/><ns4:defRPr sz="1600" dirty="0" b="1"><ns4:solidFill><ns4:srgbClr val="3B82F6"/></ns4:solidFill><ns4:latin typeface="Calibri"/><ns4:ea typeface="Calibri"/></ns4:defRPr></ns4:lvl8pPr><ns4:lvl9pPr algn="l"><ns4:buNone/><ns4:defRPr sz="1600" dirty="0" b="1"><ns4:solidFill><ns4:srgbClr val="3B82F6"/></ns4:solidFill><ns4:latin typeface="Calibri"/><ns4:ea typeface="Calibri"/></ns4:defRPr></ns4:lvl9pPr></ns4:lstStyle/><ns5:p xmlns:ns5="http://schemas.openxmlformats.org/drawingml/2006/main"><ns5:pPr algn="l"><ns5:buNone/></ns5:pPr><ns5:r><ns5:rPr lang="ja-JP"/><ns5:t>内容を入力</ns5:t></ns5:r></ns5:p></ns0:txBody></ns0:sp><ns0:sp><ns0:nvSpPr><ns0:cNvPr id="22" name="OptionLabel2.Right"/><ns0:cNvSpPr><ns1:spLocks xmlns:ns1="http://schemas.openxmlformats.org/drawingml/2006/main" noGrp="1"/></ns0:cNvSpPr><ns0:nvPr><ns0:ph idx="3" type="body"/></ns0:nvPr></ns0:nvSpPr><ns0:spPr><ns2:xfrm xmlns:ns2="http://schemas.openxmlformats.org/drawingml/2006/main"><ns2:off x="6400800" y="1554480"/><ns2:ext cx="4846320" cy="457200"/></ns2:xfrm></ns0:spPr><ns0:txBody><ns3:bodyPr xmlns:ns3="http://schemas.openxmlformats.org/drawingml/2006/main" wrap="square" anchor="t" anchorCtr="0"/><ns4:lstStyle xmlns:ns4="http://schemas.openxmlformats.org/drawingml/2006/main"><ns4:defPPr algn="l"><ns4:buNone/><ns4:defRPr sz="1600" dirty="0" b="1"><ns4:solidFill><ns4:srgbClr val="06B6D4"/></ns4:solidFill><ns4:latin typeface="Calibri"/><ns4:ea typeface="Calibri"/></ns4:defRPr></ns4:defPPr><ns4:lvl1pPr algn="l"><ns4:buNone/><ns4:defRPr sz="1600" dirty="0" b="1"><ns4:solidFill><ns4:srgbClr val="06B6D4"/></ns4:solidFill><ns4:latin typeface="Calibri"/><ns4:ea typeface="Calibri"/></ns4:defRPr></ns4:lvl1pPr><ns4:lvl2pPr algn="l"><ns4:buNone/><ns4:defRPr sz="1600" dirty="0" b="1"><ns4:solidFill><ns4:srgbClr val="06B6D4"/></ns4:solidFill><ns4:latin typeface="Calibri"/><ns4:ea typeface="Calibri"/></ns4:defRPr></ns4:lvl2pPr><ns4:lvl3pPr algn="l"><ns4:buNone/><ns4:defRPr sz="1600" dirty="0" b="1"><ns4:solidFill><ns4:srgbClr val="06B6D4"/></ns4:solidFill><ns4:latin typeface="Calibri"/><ns4:ea typeface="Calibri"/></ns4:defRPr></ns4:lvl3pPr><ns4:lvl4pPr algn="l"><ns4:buNone/><ns4:defRPr sz="1600" dirty="0" b="1"><ns4:solidFill><ns4:srgbClr val="06B6D4"/></ns4:solidFill><ns4:latin typeface="Calibri"/><ns4:ea typeface="Calibri"/></ns4:defRPr></ns4:lvl4pPr><ns4:lvl5pPr algn="l"><ns4:buNone/><ns4:defRPr sz="1600" dirty="0" b="1"><ns4:solidFill><ns4:srgbClr val="06B6D4"/></ns4:solidFill><ns4:latin typeface="Calibri"/><ns4:ea typeface="Calibri"/></ns4:defRPr></ns4:lvl5pPr><ns4:lvl6pPr algn="l"><ns4:buNone/><ns4:defRPr sz="1600" dirty="0" b="1"><ns4:solidFill><ns4:srgbClr val="06B6D4"/></ns4:solidFill><ns4:latin typeface="Calibri"/><ns4:ea typeface="Calibri"/></ns4:defRPr></ns4:lvl6pPr><ns4:lvl7pPr algn="l"><ns4:buNone/><ns4:defRPr sz="1600" dirty="0" b="1"><ns4:solidFill><ns4:srgbClr val="06B6D4"/></ns4:solidFill><ns4:latin typeface="Calibri"/><ns4:ea typeface="Calibri"/></ns4:defRPr></ns4:lvl7pPr><ns4:lvl8pPr algn="l"><ns4:buNone/><ns4:defRPr sz="1600" dirty="0" b="1"><ns4:solidFill><ns4:srgbClr val="06B6D4"/></ns4:solidFill><ns4:latin typeface="Calibri"/><ns4:ea typeface="Calibri"/></ns4:defRPr></ns4:lvl8pPr><ns4:lvl9pPr algn="l"><ns4:buNone/><ns4:defRPr sz="1600" dirty="0" b="1"><ns4:solidFill><ns4:srgbClr val="06B6D4"/></ns4:solidFill><ns4:latin typeface="Calibri"/><ns4:ea typeface="Calibri"/></ns4:defRPr></ns4:lvl9pPr></ns4:lstStyle/><ns5:p xmlns:ns5="http://schemas.openxmlformats.org/drawingml/2006/main"><ns5:pPr algn="l"><ns5:buNone/></ns5:pPr><ns5:r><ns5:rPr lang="ja-JP"/><ns5:t>内容を入力</ns5:t></ns5:r></ns5:p></ns0:txBody></ns0:sp><ns0:sp><ns0:nvSpPr><ns0:cNvPr id="30" name="SlideNum.Footer"/><ns0:cNvSpPr><ns1:spLocks xmlns:ns1="http://schemas.openxmlformats.org/drawingml/2006/main" noGrp="1"/></ns0:cNvSpPr><ns0:nvPr><ns0:ph idx="50" type="sldNum"/></ns0:nvPr></ns0:nvSpPr><ns0:spPr><ns2:xfrm xmlns:ns2="http://schemas.openxmlformats.org/drawingml/2006/main"><ns2:off x="10972800" y="6446520"/><ns2:ext cx="1097280" cy="274320"/></ns2:xfrm></ns0:spPr><ns0:txBody><ns3:bodyPr xmlns:ns3="http://schemas.openxmlformats.org/drawingml/2006/main" wrap="square" anchor="t" anchorCtr="0"/><ns4:lstStyle xmlns:ns4="http://schemas.openxmlformats.org/drawingml/2006/main"><ns4:defPPr algn="r"><ns4:buNone/><ns4:defRPr sz="1000" dirty="0"><ns4:solidFill><ns4:srgbClr val="94A3B8"/></ns4:solidFill><ns4:latin typeface="Calibri"/><ns4:ea typeface="Calibri"/></ns4:defRPr></ns4:defPPr><ns4:lvl1pPr algn="r"><ns4:buNone/><ns4:defRPr sz="1000" dirty="0"><ns4:solidFill><ns4:srgbClr val="94A3B8"/></ns4:solidFill><ns4:latin typeface="Calibri"/><ns4:ea typeface="Calibri"/></ns4:defRPr></ns4:lvl1pPr><ns4:lvl2pPr algn="r"><ns4:buNone/><ns4:defRPr sz="1000" dirty="0"><ns4:solidFill><ns4:srgbClr val="94A3B8"/></ns4:solidFill><ns4:latin typeface="Calibri"/><ns4:ea typeface="Calibri"/></ns4:defRPr></ns4:lvl2pPr><ns4:lvl3pPr algn="r"><ns4:buNone/><ns4:defRPr sz="1000" dirty="0"><ns4:solidFill><ns4:srgbClr val="94A3B8"/></ns4:solidFill><ns4:latin typeface="Calibri"/><ns4:ea typeface="Calibri"/></ns4:defRPr></ns4:lvl3pPr><ns4:lvl4pPr algn="r"><ns4:buNone/><ns4:defRPr sz="1000" dirty="0"><ns4:solidFill><ns4:srgbClr val="94A3B8"/></ns4:solidFill><ns4:latin typeface="Calibri"/><ns4:ea typeface="Calibri"/></ns4:defRPr></ns4:lvl4pPr><ns4:lvl5pPr algn="r"><ns4:buNone/><ns4:defRPr sz="1000" dirty="0"><ns4:solidFill><ns4:srgbClr val="94A3B8"/></ns4:solidFill><ns4:latin typeface="Calibri"/><ns4:ea typeface="Calibri"/></ns4:defRPr></ns4:lvl5pPr><ns4:lvl6pPr algn="r"><ns4:buNone/><ns4:defRPr sz="1000" dirty="0"><ns4:solidFill><ns4:srgbClr val="94A3B8"/></ns4:solidFill><ns4:latin typeface="Calibri"/><ns4:ea typeface="Calibri"/></ns4:defRPr></ns4:lvl6pPr><ns4:lvl7pPr algn="r"><ns4:buNone/><ns4:defRPr sz="1000" dirty="0"><ns4:solidFill><ns4:srgbClr val="94A3B8"/></ns4:solidFill><ns4:latin typeface="Calibri"/><ns4:ea typeface="Calibri"/></ns4:defRPr></ns4:lvl7pPr><ns4:lvl8pPr algn="r"><ns4:buNone/><ns4:defRPr sz="1000" dirty="0"><ns4:solidFill><ns4:srgbClr val="94A3B8"/></ns4:solidFill><ns4:latin typeface="Calibri"/><ns4:ea typeface="Calibri"/></ns4:defRPr></ns4:lvl8pPr><ns4:lvl9pPr algn="r"><ns4:buNone/><ns4:defRPr sz="1000" dirty="0"><ns4:solidFill><ns4:srgbClr val="94A3B8"/></ns4:solidFill><ns4:latin typeface="Calibri"/><ns4:ea typeface="Calibri"/></ns4:defRPr></ns4:lvl9pPr></ns4:lstStyle><ns5:p xmlns:ns5="http://schemas.openxmlformats.org/drawingml/2006/main"><ns5:pPr algn="r"><ns5:buNone/></ns5:pPr><ns5:r><ns5:rPr lang="ja-JP"/><ns5:t>&lt;#&gt;</ns5:t></ns5:r></ns5:p></ns0:txBody></ns0:sp></ns0:spTree></ns0:cSld><ns0:clrMapOvr/></ns0:sldLayout>
+<ns0:sldLayout xmlns:ns0="http://schemas.openxmlformats.org/presentationml/2006/main" type="blank" preserve="1"><ns0:cSld name="Compare.2Option.Versus"><ns0:spTree><ns0:nvGrpSpPr><ns0:cNvPr id="1" name=""/><ns0:cNvGrpSpPr/><ns0:nvPr/></ns0:nvGrpSpPr><ns0:grpSpPr><ns1:xfrm xmlns:ns1="http://schemas.openxmlformats.org/drawingml/2006/main"><ns1:off x="0" y="0"/><ns1:ext cx="0" cy="0"/><ns1:chOff x="0" y="0"/><ns1:chExt cx="0" cy="0"/></ns1:xfrm></ns0:grpSpPr><ns0:sp><ns0:nvSpPr><ns0:cNvPr id="2" name="HeaderBar"/><ns0:cNvSpPr><ns1:spLocks xmlns:ns1="http://schemas.openxmlformats.org/drawingml/2006/main" noGrp="1" noSelect="0" noRot="1" noMove="1"/></ns0:cNvSpPr><ns0:nvPr/></ns0:nvSpPr><ns0:spPr><ns2:xfrm xmlns:ns2="http://schemas.openxmlformats.org/drawingml/2006/main"><ns2:off x="0" y="0"/><ns2:ext cx="12192000" cy="1051560"/></ns2:xfrm><ns3:prstGeom xmlns:ns3="http://schemas.openxmlformats.org/drawingml/2006/main" prst="rect"/><ns4:solidFill xmlns:ns4="http://schemas.openxmlformats.org/drawingml/2006/main"><ns4:srgbClr val="1E2761"/></ns4:solidFill><ns5:ln xmlns:ns5="http://schemas.openxmlformats.org/drawingml/2006/main"><ns5:noFill/></ns5:ln></ns0:spPr></ns0:sp><ns0:sp><ns0:nvSpPr><ns0:cNvPr id="10" name="SlideTitle.Header"/><ns0:cNvSpPr><ns1:spLocks xmlns:ns1="http://schemas.openxmlformats.org/drawingml/2006/main" noGrp="1"/></ns0:cNvSpPr><ns0:nvPr><ns0:ph idx="15" type="body"/></ns0:nvPr></ns0:nvSpPr><ns0:spPr><ns2:xfrm xmlns:ns2="http://schemas.openxmlformats.org/drawingml/2006/main"><ns2:off x="731520" y="91440"/><ns2:ext cx="9144000" cy="475488"/></ns2:xfrm></ns0:spPr><ns0:txBody><ns3:bodyPr xmlns:ns3="http://schemas.openxmlformats.org/drawingml/2006/main" wrap="square" anchor="t" anchorCtr="0"/><ns4:lstStyle><ns4:defPPr><ns4:defRPr sz="2800" b="1"><ns4:solidFill><ns4:srgbClr val="FFFFFF"/></ns4:solidFill></ns4:defRPr></ns4:defPPr></ns4:lstStyle><ns4:defPPr algn="l"><ns4:buNone/><ns4:defRPr sz="2800" dirty="0" b="1"><ns4:solidFill><ns4:srgbClr val="FFFFFF"/></ns4:solidFill><ns4:latin typeface="Georgia"/><ns4:ea typeface="Georgia"/></ns4:defRPr></ns4:defPPr><ns4:lvl1pPr algn="l"><ns4:buNone/><ns4:defRPr sz="2800" dirty="0" b="1"><ns4:solidFill><ns4:srgbClr val="FFFFFF"/></ns4:solidFill><ns4:latin typeface="Georgia"/><ns4:ea typeface="Georgia"/></ns4:defRPr></ns4:lvl1pPr><ns4:lvl2pPr algn="l"><ns4:buNone/><ns4:defRPr sz="2800" dirty="0" b="1"><ns4:solidFill><ns4:srgbClr val="FFFFFF"/></ns4:solidFill><ns4:latin typeface="Georgia"/><ns4:ea typeface="Georgia"/></ns4:defRPr></ns4:lvl2pPr><ns4:lvl3pPr algn="l"><ns4:buNone/><ns4:defRPr sz="2800" dirty="0" b="1"><ns4:solidFill><ns4:srgbClr val="FFFFFF"/></ns4:solidFill><ns4:latin typeface="Georgia"/><ns4:ea typeface="Georgia"/></ns4:defRPr></ns4:lvl3pPr><ns4:lvl4pPr algn="l"><ns4:buNone/><ns4:defRPr sz="2800" dirty="0" b="1"><ns4:solidFill><ns4:srgbClr val="FFFFFF"/></ns4:solidFill><ns4:latin typeface="Georgia"/><ns4:ea typeface="Georgia"/></ns4:defRPr></ns4:lvl4pPr><ns4:lvl5pPr algn="l"><ns4:buNone/><ns4:defRPr sz="2800" dirty="0" b="1"><ns4:solidFill><ns4:srgbClr val="FFFFFF"/></ns4:solidFill><ns4:latin typeface="Georgia"/><ns4:ea typeface="Georgia"/></ns4:defRPr></ns4:lvl5pPr><ns4:lvl6pPr algn="l"><ns4:buNone/><ns4:defRPr sz="2800" dirty="0" b="1"><ns4:solidFill><ns4:srgbClr val="FFFFFF"/></ns4:solidFill><ns4:latin typeface="Georgia"/><ns4:ea typeface="Georgia"/></ns4:defRPr></ns4:lvl6pPr><ns4:lvl7pPr algn="l"><ns4:buNone/><ns4:defRPr sz="2800" dirty="0" b="1"><ns4:solidFill><ns4:srgbClr val="FFFFFF"/></ns4:solidFill><ns4:latin typeface="Georgia"/><ns4:ea typeface="Georgia"/></ns4:defRPr></ns4:lvl7pPr><ns4:lvl8pPr algn="l"><ns4:buNone/><ns4:defRPr sz="2800" dirty="0" b="1"><ns4:solidFill><ns4:srgbClr val="FFFFFF"/></ns4:solidFill><ns4:latin typeface="Georgia"/><ns4:ea typeface="Georgia"/></ns4:defRPr></ns4:lvl8pPr><ns4:lvl9pPr algn="l"><ns4:buNone/><ns4:defRPr sz="2800" dirty="0" b="1"><ns4:solidFill><ns4:srgbClr val="FFFFFF"/></ns4:solidFill><ns4:latin typeface="Georgia"/><ns4:ea typeface="Georgia"/></ns4:defRPr></ns4:lvl9pPr></ns4:lstStyle/><ns5:p xmlns:ns5="http://schemas.openxmlformats.org/drawingml/2006/main"><ns5:pPr algn="l"><ns5:buNone/></ns5:pPr><ns5:r><ns5:rPr lang="ja-JP"/><ns5:t>サブタイトル</ns5:t></ns5:r></ns5:p></ns0:txBody></ns0:sp><ns0:sp><ns0:nvSpPr><ns0:cNvPr id="5" name="PanelL"/><ns0:cNvSpPr><ns1:spLocks xmlns:ns1="http://schemas.openxmlformats.org/drawingml/2006/main" noGrp="1" noSelect="0" noRot="1" noMove="1"/></ns0:cNvSpPr><ns0:nvPr/></ns0:nvSpPr><ns0:spPr><ns2:xfrm xmlns:ns2="http://schemas.openxmlformats.org/drawingml/2006/main"><ns2:off x="457200" y="1280160"/><ns2:ext cx="5303520" cy="4937760"/></ns2:xfrm><ns3:prstGeom xmlns:ns3="http://schemas.openxmlformats.org/drawingml/2006/main" prst="roundRect"><ns3:avLst><ns3:gd name="adj" fmla="val 8000"/></ns3:avLst></ns3:prstGeom><ns4:solidFill xmlns:ns4="http://schemas.openxmlformats.org/drawingml/2006/main"><ns4:srgbClr val="EDF0F7"/></ns4:solidFill><ns5:ln xmlns:ns5="http://schemas.openxmlformats.org/drawingml/2006/main"><ns5:noFill/></ns5:ln></ns0:spPr></ns0:sp><ns0:sp><ns0:nvSpPr><ns0:cNvPr id="6" name="PanelR"/><ns0:cNvSpPr><ns1:spLocks xmlns:ns1="http://schemas.openxmlformats.org/drawingml/2006/main" noGrp="1" noSelect="0" noRot="1" noMove="1"/></ns0:cNvSpPr><ns0:nvPr/></ns0:nvSpPr><ns0:spPr><ns2:xfrm xmlns:ns2="http://schemas.openxmlformats.org/drawingml/2006/main"><ns2:off x="6126480" y="1280160"/><ns2:ext cx="5394960" cy="4937760"/></ns2:xfrm><ns3:prstGeom xmlns:ns3="http://schemas.openxmlformats.org/drawingml/2006/main" prst="roundRect"><ns3:avLst><ns3:gd name="adj" fmla="val 8000"/></ns3:avLst></ns3:prstGeom><ns4:solidFill xmlns:ns4="http://schemas.openxmlformats.org/drawingml/2006/main"><ns4:srgbClr val="EDF0F7"/></ns4:solidFill><ns5:ln xmlns:ns5="http://schemas.openxmlformats.org/drawingml/2006/main"><ns5:noFill/></ns5:ln></ns0:spPr></ns0:sp><ns0:sp><ns0:nvSpPr><ns0:cNvPr id="7" name="AccentL"/><ns0:cNvSpPr><ns1:spLocks xmlns:ns1="http://schemas.openxmlformats.org/drawingml/2006/main" noGrp="1" noSelect="0" noRot="1" noMove="1"/></ns0:cNvSpPr><ns0:nvPr/></ns0:nvSpPr><ns0:spPr><ns2:xfrm xmlns:ns2="http://schemas.openxmlformats.org/drawingml/2006/main"><ns2:off x="457200" y="1280160"/><ns2:ext cx="5303520" cy="54864"/></ns2:xfrm><ns3:prstGeom xmlns:ns3="http://schemas.openxmlformats.org/drawingml/2006/main" prst="rect"/><ns4:solidFill xmlns:ns4="http://schemas.openxmlformats.org/drawingml/2006/main"><ns4:srgbClr val="3B82F6"/></ns4:solidFill><ns5:ln xmlns:ns5="http://schemas.openxmlformats.org/drawingml/2006/main"><ns5:noFill/></ns5:ln></ns0:spPr></ns0:sp><ns0:sp><ns0:nvSpPr><ns0:cNvPr id="8" name="AccentR"/><ns0:cNvSpPr><ns1:spLocks xmlns:ns1="http://schemas.openxmlformats.org/drawingml/2006/main" noGrp="1" noSelect="0" noRot="1" noMove="1"/></ns0:cNvSpPr><ns0:nvPr/></ns0:nvSpPr><ns0:spPr><ns2:xfrm xmlns:ns2="http://schemas.openxmlformats.org/drawingml/2006/main"><ns2:off x="6126480" y="1280160"/><ns2:ext cx="5394960" cy="54864"/></ns2:xfrm><ns3:prstGeom xmlns:ns3="http://schemas.openxmlformats.org/drawingml/2006/main" prst="rect"/><ns4:solidFill xmlns:ns4="http://schemas.openxmlformats.org/drawingml/2006/main"><ns4:srgbClr val="06B6D4"/></ns4:solidFill><ns5:ln xmlns:ns5="http://schemas.openxmlformats.org/drawingml/2006/main"><ns5:noFill/></ns5:ln></ns0:spPr></ns0:sp><ns0:sp><ns0:nvSpPr><ns0:cNvPr id="9" name="VS"/><ns0:cNvSpPr><ns1:spLocks xmlns:ns1="http://schemas.openxmlformats.org/drawingml/2006/main" noGrp="1"/></ns0:cNvSpPr><ns0:nvPr/></ns0:nvSpPr><ns0:spPr><ns2:xfrm xmlns:ns2="http://schemas.openxmlformats.org/drawingml/2006/main"><ns2:off x="5309408461680" y="3428121901679"/><ns2:ext cx="548640" cy="548640"/></ns2:xfrm><ns3:prstGeom xmlns:ns3="http://schemas.openxmlformats.org/drawingml/2006/main" prst="ellipse"/><ns4:solidFill xmlns:ns4="http://schemas.openxmlformats.org/drawingml/2006/main"><ns4:srgbClr val="1E2761"/></ns4:solidFill><ns5:ln xmlns:ns5="http://schemas.openxmlformats.org/drawingml/2006/main"><ns5:noFill/></ns5:ln></ns0:spPr></ns0:sp><ns0:sp><ns0:nvSpPr><ns0:cNvPr id="20" name="OptionLabel1.Left"/><ns0:cNvSpPr><ns1:spLocks xmlns:ns1="http://schemas.openxmlformats.org/drawingml/2006/main" noGrp="1"/></ns0:cNvSpPr><ns0:nvPr><ns0:ph idx="1" type="body"/></ns0:nvPr></ns0:nvSpPr><ns0:spPr><ns2:xfrm xmlns:ns2="http://schemas.openxmlformats.org/drawingml/2006/main"><ns2:off x="731520" y="1554480"/><ns2:ext cx="4754880" cy="457200"/></ns2:xfrm></ns0:spPr><ns0:txBody><ns3:bodyPr xmlns:ns3="http://schemas.openxmlformats.org/drawingml/2006/main" wrap="square" anchor="t" anchorCtr="0"/><ns4:lstStyle><ns4:defPPr><ns4:defRPr sz="1600" b="1"><ns4:solidFill><ns4:srgbClr val="3B82F6"/></ns4:solidFill></ns4:defRPr></ns4:defPPr></ns4:lstStyle><ns4:defPPr algn="l"><ns4:buNone/><ns4:defRPr sz="1600" dirty="0" b="1"><ns4:solidFill><ns4:srgbClr val="3B82F6"/></ns4:solidFill><ns4:latin typeface="Calibri"/><ns4:ea typeface="Calibri"/></ns4:defRPr></ns4:defPPr><ns4:lvl1pPr algn="l"><ns4:buNone/><ns4:defRPr sz="1600" dirty="0" b="1"><ns4:solidFill><ns4:srgbClr val="3B82F6"/></ns4:solidFill><ns4:latin typeface="Calibri"/><ns4:ea typeface="Calibri"/></ns4:defRPr></ns4:lvl1pPr><ns4:lvl2pPr algn="l"><ns4:buNone/><ns4:defRPr sz="1600" dirty="0" b="1"><ns4:solidFill><ns4:srgbClr val="3B82F6"/></ns4:solidFill><ns4:latin typeface="Calibri"/><ns4:ea typeface="Calibri"/></ns4:defRPr></ns4:lvl2pPr><ns4:lvl3pPr algn="l"><ns4:buNone/><ns4:defRPr sz="1600" dirty="0" b="1"><ns4:solidFill><ns4:srgbClr val="3B82F6"/></ns4:solidFill><ns4:latin typeface="Calibri"/><ns4:ea typeface="Calibri"/></ns4:defRPr></ns4:lvl3pPr><ns4:lvl4pPr algn="l"><ns4:buNone/><ns4:defRPr sz="1600" dirty="0" b="1"><ns4:solidFill><ns4:srgbClr val="3B82F6"/></ns4:solidFill><ns4:latin typeface="Calibri"/><ns4:ea typeface="Calibri"/></ns4:defRPr></ns4:lvl4pPr><ns4:lvl5pPr algn="l"><ns4:buNone/><ns4:defRPr sz="1600" dirty="0" b="1"><ns4:solidFill><ns4:srgbClr val="3B82F6"/></ns4:solidFill><ns4:latin typeface="Calibri"/><ns4:ea typeface="Calibri"/></ns4:defRPr></ns4:lvl5pPr><ns4:lvl6pPr algn="l"><ns4:buNone/><ns4:defRPr sz="1600" dirty="0" b="1"><ns4:solidFill><ns4:srgbClr val="3B82F6"/></ns4:solidFill><ns4:latin typeface="Calibri"/><ns4:ea typeface="Calibri"/></ns4:defRPr></ns4:lvl6pPr><ns4:lvl7pPr algn="l"><ns4:buNone/><ns4:defRPr sz="1600" dirty="0" b="1"><ns4:solidFill><ns4:srgbClr val="3B82F6"/></ns4:solidFill><ns4:latin typeface="Calibri"/><ns4:ea typeface="Calibri"/></ns4:defRPr></ns4:lvl7pPr><ns4:lvl8pPr algn="l"><ns4:buNone/><ns4:defRPr sz="1600" dirty="0" b="1"><ns4:solidFill><ns4:srgbClr val="3B82F6"/></ns4:solidFill><ns4:latin typeface="Calibri"/><ns4:ea typeface="Calibri"/></ns4:defRPr></ns4:lvl8pPr><ns4:lvl9pPr algn="l"><ns4:buNone/><ns4:defRPr sz="1600" dirty="0" b="1"><ns4:solidFill><ns4:srgbClr val="3B82F6"/></ns4:solidFill><ns4:latin typeface="Calibri"/><ns4:ea typeface="Calibri"/></ns4:defRPr></ns4:lvl9pPr></ns4:lstStyle/><ns5:p xmlns:ns5="http://schemas.openxmlformats.org/drawingml/2006/main"><ns5:pPr algn="l"><ns5:buNone/></ns5:pPr><ns5:r><ns5:rPr lang="ja-JP"/><ns5:t>内容を入力</ns5:t></ns5:r></ns5:p></ns0:txBody></ns0:sp><ns0:sp><ns0:nvSpPr><ns0:cNvPr id="22" name="OptionLabel2.Right"/><ns0:cNvSpPr><ns1:spLocks xmlns:ns1="http://schemas.openxmlformats.org/drawingml/2006/main" noGrp="1"/></ns0:cNvSpPr><ns0:nvPr><ns0:ph idx="3" type="body"/></ns0:nvPr></ns0:nvSpPr><ns0:spPr><ns2:xfrm xmlns:ns2="http://schemas.openxmlformats.org/drawingml/2006/main"><ns2:off x="6400800" y="1554480"/><ns2:ext cx="4846320" cy="457200"/></ns2:xfrm></ns0:spPr><ns0:txBody><ns3:bodyPr xmlns:ns3="http://schemas.openxmlformats.org/drawingml/2006/main" wrap="square" anchor="t" anchorCtr="0"/><ns4:lstStyle><ns4:defPPr><ns4:defRPr sz="1600" b="1"><ns4:solidFill><ns4:srgbClr val="06B6D4"/></ns4:solidFill></ns4:defRPr></ns4:defPPr></ns4:lstStyle><ns4:defPPr algn="l"><ns4:buNone/><ns4:defRPr sz="1600" dirty="0" b="1"><ns4:solidFill><ns4:srgbClr val="06B6D4"/></ns4:solidFill><ns4:latin typeface="Calibri"/><ns4:ea typeface="Calibri"/></ns4:defRPr></ns4:defPPr><ns4:lvl1pPr algn="l"><ns4:buNone/><ns4:defRPr sz="1600" dirty="0" b="1"><ns4:solidFill><ns4:srgbClr val="06B6D4"/></ns4:solidFill><ns4:latin typeface="Calibri"/><ns4:ea typeface="Calibri"/></ns4:defRPr></ns4:lvl1pPr><ns4:lvl2pPr algn="l"><ns4:buNone/><ns4:defRPr sz="1600" dirty="0" b="1"><ns4:solidFill><ns4:srgbClr val="06B6D4"/></ns4:solidFill><ns4:latin typeface="Calibri"/><ns4:ea typeface="Calibri"/></ns4:defRPr></ns4:lvl2pPr><ns4:lvl3pPr algn="l"><ns4:buNone/><ns4:defRPr sz="1600" dirty="0" b="1"><ns4:solidFill><ns4:srgbClr val="06B6D4"/></ns4:solidFill><ns4:latin typeface="Calibri"/><ns4:ea typeface="Calibri"/></ns4:defRPr></ns4:lvl3pPr><ns4:lvl4pPr algn="l"><ns4:buNone/><ns4:defRPr sz="1600" dirty="0" b="1"><ns4:solidFill><ns4:srgbClr val="06B6D4"/></ns4:solidFill><ns4:latin typeface="Calibri"/><ns4:ea typeface="Calibri"/></ns4:defRPr></ns4:lvl4pPr><ns4:lvl5pPr algn="l"><ns4:buNone/><ns4:defRPr sz="1600" dirty="0" b="1"><ns4:solidFill><ns4:srgbClr val="06B6D4"/></ns4:solidFill><ns4:latin typeface="Calibri"/><ns4:ea typeface="Calibri"/></ns4:defRPr></ns4:lvl5pPr><ns4:lvl6pPr algn="l"><ns4:buNone/><ns4:defRPr sz="1600" dirty="0" b="1"><ns4:solidFill><ns4:srgbClr val="06B6D4"/></ns4:solidFill><ns4:latin typeface="Calibri"/><ns4:ea typeface="Calibri"/></ns4:defRPr></ns4:lvl6pPr><ns4:lvl7pPr algn="l"><ns4:buNone/><ns4:defRPr sz="1600" dirty="0" b="1"><ns4:solidFill><ns4:srgbClr val="06B6D4"/></ns4:solidFill><ns4:latin typeface="Calibri"/><ns4:ea typeface="Calibri"/></ns4:defRPr></ns4:lvl7pPr><ns4:lvl8pPr algn="l"><ns4:buNone/><ns4:defRPr sz="1600" dirty="0" b="1"><ns4:solidFill><ns4:srgbClr val="06B6D4"/></ns4:solidFill><ns4:latin typeface="Calibri"/><ns4:ea typeface="Calibri"/></ns4:defRPr></ns4:lvl8pPr><ns4:lvl9pPr algn="l"><ns4:buNone/><ns4:defRPr sz="1600" dirty="0" b="1"><ns4:solidFill><ns4:srgbClr val="06B6D4"/></ns4:solidFill><ns4:latin typeface="Calibri"/><ns4:ea typeface="Calibri"/></ns4:defRPr></ns4:lvl9pPr></ns4:lstStyle/><ns5:p xmlns:ns5="http://schemas.openxmlformats.org/drawingml/2006/main"><ns5:pPr algn="l"><ns5:buNone/></ns5:pPr><ns5:r><ns5:rPr lang="ja-JP"/><ns5:t>内容を入力</ns5:t></ns5:r></ns5:p></ns0:txBody></ns0:sp><ns0:sp><ns0:nvSpPr><ns0:cNvPr id="30" name="SlideNum.Footer"/><ns0:cNvSpPr><ns1:spLocks xmlns:ns1="http://schemas.openxmlformats.org/drawingml/2006/main" noGrp="1"/></ns0:cNvSpPr><ns0:nvPr><ns0:ph idx="50" type="sldNum"/></ns0:nvPr></ns0:nvSpPr><ns0:spPr><ns2:xfrm xmlns:ns2="http://schemas.openxmlformats.org/drawingml/2006/main"><ns2:off x="10972800" y="6446520"/><ns2:ext cx="1097280" cy="274320"/></ns2:xfrm></ns0:spPr><ns0:txBody><ns3:bodyPr xmlns:ns3="http://schemas.openxmlformats.org/drawingml/2006/main" wrap="square" anchor="t" anchorCtr="0"/><ns4:lstStyle><ns4:defPPr algn="r"><ns4:defRPr sz="1000"><ns4:solidFill><ns4:srgbClr val="94A3B8"/></ns4:solidFill></ns4:defRPr></ns4:defPPr></ns4:lstStyle><ns4:defPPr algn="r"><ns4:buNone/><ns4:defRPr sz="1000" dirty="0"><ns4:solidFill><ns4:srgbClr val="94A3B8"/></ns4:solidFill><ns4:latin typeface="Calibri"/><ns4:ea typeface="Calibri"/></ns4:defRPr></ns4:defPPr><ns4:lvl1pPr algn="r"><ns4:buNone/><ns4:defRPr sz="1000" dirty="0"><ns4:solidFill><ns4:srgbClr val="94A3B8"/></ns4:solidFill><ns4:latin typeface="Calibri"/><ns4:ea typeface="Calibri"/></ns4:defRPr></ns4:lvl1pPr><ns4:lvl2pPr algn="r"><ns4:buNone/><ns4:defRPr sz="1000" dirty="0"><ns4:solidFill><ns4:srgbClr val="94A3B8"/></ns4:solidFill><ns4:latin typeface="Calibri"/><ns4:ea typeface="Calibri"/></ns4:defRPr></ns4:lvl2pPr><ns4:lvl3pPr algn="r"><ns4:buNone/><ns4:defRPr sz="1000" dirty="0"><ns4:solidFill><ns4:srgbClr val="94A3B8"/></ns4:solidFill><ns4:latin typeface="Calibri"/><ns4:ea typeface="Calibri"/></ns4:defRPr></ns4:lvl3pPr><ns4:lvl4pPr algn="r"><ns4:buNone/><ns4:defRPr sz="1000" dirty="0"><ns4:solidFill><ns4:srgbClr val="94A3B8"/></ns4:solidFill><ns4:latin typeface="Calibri"/><ns4:ea typeface="Calibri"/></ns4:defRPr></ns4:lvl4pPr><ns4:lvl5pPr algn="r"><ns4:buNone/><ns4:defRPr sz="1000" dirty="0"><ns4:solidFill><ns4:srgbClr val="94A3B8"/></ns4:solidFill><ns4:latin typeface="Calibri"/><ns4:ea typeface="Calibri"/></ns4:defRPr></ns4:lvl5pPr><ns4:lvl6pPr algn="r"><ns4:buNone/><ns4:defRPr sz="1000" dirty="0"><ns4:solidFill><ns4:srgbClr val="94A3B8"/></ns4:solidFill><ns4:latin typeface="Calibri"/><ns4:ea typeface="Calibri"/></ns4:defRPr></ns4:lvl6pPr><ns4:lvl7pPr algn="r"><ns4:buNone/><ns4:defRPr sz="1000" dirty="0"><ns4:solidFill><ns4:srgbClr val="94A3B8"/></ns4:solidFill><ns4:latin typeface="Calibri"/><ns4:ea typeface="Calibri"/></ns4:defRPr></ns4:lvl7pPr><ns4:lvl8pPr algn="r"><ns4:buNone/><ns4:defRPr sz="1000" dirty="0"><ns4:solidFill><ns4:srgbClr val="94A3B8"/></ns4:solidFill><ns4:latin typeface="Calibri"/><ns4:ea typeface="Calibri"/></ns4:defRPr></ns4:lvl8pPr><ns4:lvl9pPr algn="r"><ns4:buNone/><ns4:defRPr sz="1000" dirty="0"><ns4:solidFill><ns4:srgbClr val="94A3B8"/></ns4:solidFill><ns4:latin typeface="Calibri"/><ns4:ea typeface="Calibri"/></ns4:defRPr></ns4:lvl9pPr></ns4:lstStyle><ns5:p xmlns:ns5="http://schemas.openxmlformats.org/drawingml/2006/main"><ns5:pPr algn="r"><ns5:buNone/></ns5:pPr><ns5:r><ns5:rPr lang="ja-JP"/><ns5:t>&lt;#&gt;</ns5:t></ns5:r></ns5:p></ns0:txBody></ns0:sp></ns0:spTree></ns0:cSld><ns0:clrMapOvr/></ns0:sldLayout>
 </file>
 
 <file path=ppt/slideLayouts/slideLayout24.xml><?xml version='1.0' encoding='UTF-8' standalone='yes'?>
-<ns0:sldLayout xmlns:ns0="http://schemas.openxmlformats.org/presentationml/2006/main" type="blank" preserve="1"><ns0:cSld name="Compare.1Matrix.Single"><ns0:spTree><ns0:nvGrpSpPr><ns0:cNvPr id="1" name=""/><ns0:cNvGrpSpPr/><ns0:nvPr/></ns0:nvGrpSpPr><ns0:grpSpPr><ns1:xfrm xmlns:ns1="http://schemas.openxmlformats.org/drawingml/2006/main"><ns1:off x="0" y="0"/><ns1:ext cx="0" cy="0"/><ns1:chOff x="0" y="0"/><ns1:chExt cx="0" cy="0"/></ns1:xfrm></ns0:grpSpPr><ns0:sp><ns0:nvSpPr><ns0:cNvPr id="2" name="HeaderBar"/><ns0:cNvSpPr><ns1:spLocks xmlns:ns1="http://schemas.openxmlformats.org/drawingml/2006/main" noGrp="1" noSelect="0" noRot="1" noMove="1"/></ns0:cNvSpPr><ns0:nvPr/></ns0:nvSpPr><ns0:spPr><ns2:xfrm xmlns:ns2="http://schemas.openxmlformats.org/drawingml/2006/main"><ns2:off x="0" y="0"/><ns2:ext cx="12192000" cy="1051560"/></ns2:xfrm><ns3:prstGeom xmlns:ns3="http://schemas.openxmlformats.org/drawingml/2006/main" prst="rect"/><ns4:solidFill xmlns:ns4="http://schemas.openxmlformats.org/drawingml/2006/main"><ns4:srgbClr val="1E2761"/></ns4:solidFill><ns5:ln xmlns:ns5="http://schemas.openxmlformats.org/drawingml/2006/main"><ns5:noFill/></ns5:ln></ns0:spPr></ns0:sp><ns0:sp><ns0:nvSpPr><ns0:cNvPr id="10" name="SlideTitle.Header"/><ns0:cNvSpPr><ns1:spLocks xmlns:ns1="http://schemas.openxmlformats.org/drawingml/2006/main" noGrp="1"/></ns0:cNvSpPr><ns0:nvPr><ns0:ph idx="15" type="body"/></ns0:nvPr></ns0:nvSpPr><ns0:spPr><ns2:xfrm xmlns:ns2="http://schemas.openxmlformats.org/drawingml/2006/main"><ns2:off x="731520" y="91440"/><ns2:ext cx="9144000" cy="475488"/></ns2:xfrm></ns0:spPr><ns0:txBody><ns3:bodyPr xmlns:ns3="http://schemas.openxmlformats.org/drawingml/2006/main" wrap="square" anchor="t" anchorCtr="0"/><ns4:lstStyle xmlns:ns4="http://schemas.openxmlformats.org/drawingml/2006/main"><ns4:defPPr algn="l"><ns4:buNone/><ns4:defRPr sz="2800" dirty="0" b="1"><ns4:solidFill><ns4:srgbClr val="FFFFFF"/></ns4:solidFill><ns4:latin typeface="Georgia"/><ns4:ea typeface="Georgia"/></ns4:defRPr></ns4:defPPr><ns4:lvl1pPr algn="l"><ns4:buNone/><ns4:defRPr sz="2800" dirty="0" b="1"><ns4:solidFill><ns4:srgbClr val="FFFFFF"/></ns4:solidFill><ns4:latin typeface="Georgia"/><ns4:ea typeface="Georgia"/></ns4:defRPr></ns4:lvl1pPr><ns4:lvl2pPr algn="l"><ns4:buNone/><ns4:defRPr sz="2800" dirty="0" b="1"><ns4:solidFill><ns4:srgbClr val="FFFFFF"/></ns4:solidFill><ns4:latin typeface="Georgia"/><ns4:ea typeface="Georgia"/></ns4:defRPr></ns4:lvl2pPr><ns4:lvl3pPr algn="l"><ns4:buNone/><ns4:defRPr sz="2800" dirty="0" b="1"><ns4:solidFill><ns4:srgbClr val="FFFFFF"/></ns4:solidFill><ns4:latin typeface="Georgia"/><ns4:ea typeface="Georgia"/></ns4:defRPr></ns4:lvl3pPr><ns4:lvl4pPr algn="l"><ns4:buNone/><ns4:defRPr sz="2800" dirty="0" b="1"><ns4:solidFill><ns4:srgbClr val="FFFFFF"/></ns4:solidFill><ns4:latin typeface="Georgia"/><ns4:ea typeface="Georgia"/></ns4:defRPr></ns4:lvl4pPr><ns4:lvl5pPr algn="l"><ns4:buNone/><ns4:defRPr sz="2800" dirty="0" b="1"><ns4:solidFill><ns4:srgbClr val="FFFFFF"/></ns4:solidFill><ns4:latin typeface="Georgia"/><ns4:ea typeface="Georgia"/></ns4:defRPr></ns4:lvl5pPr><ns4:lvl6pPr algn="l"><ns4:buNone/><ns4:defRPr sz="2800" dirty="0" b="1"><ns4:solidFill><ns4:srgbClr val="FFFFFF"/></ns4:solidFill><ns4:latin typeface="Georgia"/><ns4:ea typeface="Georgia"/></ns4:defRPr></ns4:lvl6pPr><ns4:lvl7pPr algn="l"><ns4:buNone/><ns4:defRPr sz="2800" dirty="0" b="1"><ns4:solidFill><ns4:srgbClr val="FFFFFF"/></ns4:solidFill><ns4:latin typeface="Georgia"/><ns4:ea typeface="Georgia"/></ns4:defRPr></ns4:lvl7pPr><ns4:lvl8pPr algn="l"><ns4:buNone/><ns4:defRPr sz="2800" dirty="0" b="1"><ns4:solidFill><ns4:srgbClr val="FFFFFF"/></ns4:solidFill><ns4:latin typeface="Georgia"/><ns4:ea typeface="Georgia"/></ns4:defRPr></ns4:lvl8pPr><ns4:lvl9pPr algn="l"><ns4:buNone/><ns4:defRPr sz="2800" dirty="0" b="1"><ns4:solidFill><ns4:srgbClr val="FFFFFF"/></ns4:solidFill><ns4:latin typeface="Georgia"/><ns4:ea typeface="Georgia"/></ns4:defRPr></ns4:lvl9pPr></ns4:lstStyle/><ns5:p xmlns:ns5="http://schemas.openxmlformats.org/drawingml/2006/main"><ns5:pPr algn="l"><ns5:buNone/></ns5:pPr><ns5:r><ns5:rPr lang="ja-JP"/><ns5:t>サブタイトル</ns5:t></ns5:r></ns5:p></ns0:txBody></ns0:sp><ns0:sp><ns0:nvSpPr><ns0:cNvPr id="5" name="ContentBG"/><ns0:cNvSpPr><ns1:spLocks xmlns:ns1="http://schemas.openxmlformats.org/drawingml/2006/main" noGrp="1" noSelect="0" noRot="1" noMove="1"/></ns0:cNvSpPr><ns0:nvPr/></ns0:nvSpPr><ns0:spPr><ns2:xfrm xmlns:ns2="http://schemas.openxmlformats.org/drawingml/2006/main"><ns2:off x="457200" y="1280160"/><ns2:ext cx="11247120" cy="5029200"/></ns2:xfrm><ns3:prstGeom xmlns:ns3="http://schemas.openxmlformats.org/drawingml/2006/main" prst="rect"/><ns4:solidFill xmlns:ns4="http://schemas.openxmlformats.org/drawingml/2006/main"><ns4:srgbClr val="FFFFFF"/></ns4:solidFill><ns5:ln xmlns:ns5="http://schemas.openxmlformats.org/drawingml/2006/main"><ns5:noFill/></ns5:ln></ns0:spPr></ns0:sp><ns0:sp><ns0:nvSpPr><ns0:cNvPr id="30" name="SlideNum.Footer"/><ns0:cNvSpPr><ns1:spLocks xmlns:ns1="http://schemas.openxmlformats.org/drawingml/2006/main" noGrp="1"/></ns0:cNvSpPr><ns0:nvPr><ns0:ph idx="50" type="sldNum"/></ns0:nvPr></ns0:nvSpPr><ns0:spPr><ns2:xfrm xmlns:ns2="http://schemas.openxmlformats.org/drawingml/2006/main"><ns2:off x="10972800" y="6446520"/><ns2:ext cx="1097280" cy="274320"/></ns2:xfrm></ns0:spPr><ns0:txBody><ns3:bodyPr xmlns:ns3="http://schemas.openxmlformats.org/drawingml/2006/main" wrap="square" anchor="t" anchorCtr="0"/><ns4:lstStyle xmlns:ns4="http://schemas.openxmlformats.org/drawingml/2006/main"><ns4:defPPr algn="r"><ns4:buNone/><ns4:defRPr sz="1000" dirty="0"><ns4:solidFill><ns4:srgbClr val="94A3B8"/></ns4:solidFill><ns4:latin typeface="Calibri"/><ns4:ea typeface="Calibri"/></ns4:defRPr></ns4:defPPr><ns4:lvl1pPr algn="r"><ns4:buNone/><ns4:defRPr sz="1000" dirty="0"><ns4:solidFill><ns4:srgbClr val="94A3B8"/></ns4:solidFill><ns4:latin typeface="Calibri"/><ns4:ea typeface="Calibri"/></ns4:defRPr></ns4:lvl1pPr><ns4:lvl2pPr algn="r"><ns4:buNone/><ns4:defRPr sz="1000" dirty="0"><ns4:solidFill><ns4:srgbClr val="94A3B8"/></ns4:solidFill><ns4:latin typeface="Calibri"/><ns4:ea typeface="Calibri"/></ns4:defRPr></ns4:lvl2pPr><ns4:lvl3pPr algn="r"><ns4:buNone/><ns4:defRPr sz="1000" dirty="0"><ns4:solidFill><ns4:srgbClr val="94A3B8"/></ns4:solidFill><ns4:latin typeface="Calibri"/><ns4:ea typeface="Calibri"/></ns4:defRPr></ns4:lvl3pPr><ns4:lvl4pPr algn="r"><ns4:buNone/><ns4:defRPr sz="1000" dirty="0"><ns4:solidFill><ns4:srgbClr val="94A3B8"/></ns4:solidFill><ns4:latin typeface="Calibri"/><ns4:ea typeface="Calibri"/></ns4:defRPr></ns4:lvl4pPr><ns4:lvl5pPr algn="r"><ns4:buNone/><ns4:defRPr sz="1000" dirty="0"><ns4:solidFill><ns4:srgbClr val="94A3B8"/></ns4:solidFill><ns4:latin typeface="Calibri"/><ns4:ea typeface="Calibri"/></ns4:defRPr></ns4:lvl5pPr><ns4:lvl6pPr algn="r"><ns4:buNone/><ns4:defRPr sz="1000" dirty="0"><ns4:solidFill><ns4:srgbClr val="94A3B8"/></ns4:solidFill><ns4:latin typeface="Calibri"/><ns4:ea typeface="Calibri"/></ns4:defRPr></ns4:lvl6pPr><ns4:lvl7pPr algn="r"><ns4:buNone/><ns4:defRPr sz="1000" dirty="0"><ns4:solidFill><ns4:srgbClr val="94A3B8"/></ns4:solidFill><ns4:latin typeface="Calibri"/><ns4:ea typeface="Calibri"/></ns4:defRPr></ns4:lvl7pPr><ns4:lvl8pPr algn="r"><ns4:buNone/><ns4:defRPr sz="1000" dirty="0"><ns4:solidFill><ns4:srgbClr val="94A3B8"/></ns4:solidFill><ns4:latin typeface="Calibri"/><ns4:ea typeface="Calibri"/></ns4:defRPr></ns4:lvl8pPr><ns4:lvl9pPr algn="r"><ns4:buNone/><ns4:defRPr sz="1000" dirty="0"><ns4:solidFill><ns4:srgbClr val="94A3B8"/></ns4:solidFill><ns4:latin typeface="Calibri"/><ns4:ea typeface="Calibri"/></ns4:defRPr></ns4:lvl9pPr></ns4:lstStyle><ns5:p xmlns:ns5="http://schemas.openxmlformats.org/drawingml/2006/main"><ns5:pPr algn="r"><ns5:buNone/></ns5:pPr><ns5:r><ns5:rPr lang="ja-JP"/><ns5:t>&lt;#&gt;</ns5:t></ns5:r></ns5:p></ns0:txBody></ns0:sp></ns0:spTree></ns0:cSld><ns0:clrMapOvr/></ns0:sldLayout>
+<ns0:sldLayout xmlns:ns0="http://schemas.openxmlformats.org/presentationml/2006/main" type="blank" preserve="1"><ns0:cSld name="Compare.1Matrix.Single"><ns0:spTree><ns0:nvGrpSpPr><ns0:cNvPr id="1" name=""/><ns0:cNvGrpSpPr/><ns0:nvPr/></ns0:nvGrpSpPr><ns0:grpSpPr><ns1:xfrm xmlns:ns1="http://schemas.openxmlformats.org/drawingml/2006/main"><ns1:off x="0" y="0"/><ns1:ext cx="0" cy="0"/><ns1:chOff x="0" y="0"/><ns1:chExt cx="0" cy="0"/></ns1:xfrm></ns0:grpSpPr><ns0:sp><ns0:nvSpPr><ns0:cNvPr id="2" name="HeaderBar"/><ns0:cNvSpPr><ns1:spLocks xmlns:ns1="http://schemas.openxmlformats.org/drawingml/2006/main" noGrp="1" noSelect="0" noRot="1" noMove="1"/></ns0:cNvSpPr><ns0:nvPr/></ns0:nvSpPr><ns0:spPr><ns2:xfrm xmlns:ns2="http://schemas.openxmlformats.org/drawingml/2006/main"><ns2:off x="0" y="0"/><ns2:ext cx="12192000" cy="1051560"/></ns2:xfrm><ns3:prstGeom xmlns:ns3="http://schemas.openxmlformats.org/drawingml/2006/main" prst="rect"/><ns4:solidFill xmlns:ns4="http://schemas.openxmlformats.org/drawingml/2006/main"><ns4:srgbClr val="1E2761"/></ns4:solidFill><ns5:ln xmlns:ns5="http://schemas.openxmlformats.org/drawingml/2006/main"><ns5:noFill/></ns5:ln></ns0:spPr></ns0:sp><ns0:sp><ns0:nvSpPr><ns0:cNvPr id="10" name="SlideTitle.Header"/><ns0:cNvSpPr><ns1:spLocks xmlns:ns1="http://schemas.openxmlformats.org/drawingml/2006/main" noGrp="1"/></ns0:cNvSpPr><ns0:nvPr><ns0:ph idx="15" type="body"/></ns0:nvPr></ns0:nvSpPr><ns0:spPr><ns2:xfrm xmlns:ns2="http://schemas.openxmlformats.org/drawingml/2006/main"><ns2:off x="731520" y="91440"/><ns2:ext cx="9144000" cy="475488"/></ns2:xfrm></ns0:spPr><ns0:txBody><ns3:bodyPr xmlns:ns3="http://schemas.openxmlformats.org/drawingml/2006/main" wrap="square" anchor="t" anchorCtr="0"/><ns4:lstStyle><ns4:defPPr><ns4:defRPr sz="2800" b="1"><ns4:solidFill><ns4:srgbClr val="FFFFFF"/></ns4:solidFill></ns4:defRPr></ns4:defPPr></ns4:lstStyle><ns4:defPPr algn="l"><ns4:buNone/><ns4:defRPr sz="2800" dirty="0" b="1"><ns4:solidFill><ns4:srgbClr val="FFFFFF"/></ns4:solidFill><ns4:latin typeface="Georgia"/><ns4:ea typeface="Georgia"/></ns4:defRPr></ns4:defPPr><ns4:lvl1pPr algn="l"><ns4:buNone/><ns4:defRPr sz="2800" dirty="0" b="1"><ns4:solidFill><ns4:srgbClr val="FFFFFF"/></ns4:solidFill><ns4:latin typeface="Georgia"/><ns4:ea typeface="Georgia"/></ns4:defRPr></ns4:lvl1pPr><ns4:lvl2pPr algn="l"><ns4:buNone/><ns4:defRPr sz="2800" dirty="0" b="1"><ns4:solidFill><ns4:srgbClr val="FFFFFF"/></ns4:solidFill><ns4:latin typeface="Georgia"/><ns4:ea typeface="Georgia"/></ns4:defRPr></ns4:lvl2pPr><ns4:lvl3pPr algn="l"><ns4:buNone/><ns4:defRPr sz="2800" dirty="0" b="1"><ns4:solidFill><ns4:srgbClr val="FFFFFF"/></ns4:solidFill><ns4:latin typeface="Georgia"/><ns4:ea typeface="Georgia"/></ns4:defRPr></ns4:lvl3pPr><ns4:lvl4pPr algn="l"><ns4:buNone/><ns4:defRPr sz="2800" dirty="0" b="1"><ns4:solidFill><ns4:srgbClr val="FFFFFF"/></ns4:solidFill><ns4:latin typeface="Georgia"/><ns4:ea typeface="Georgia"/></ns4:defRPr></ns4:lvl4pPr><ns4:lvl5pPr algn="l"><ns4:buNone/><ns4:defRPr sz="2800" dirty="0" b="1"><ns4:solidFill><ns4:srgbClr val="FFFFFF"/></ns4:solidFill><ns4:latin typeface="Georgia"/><ns4:ea typeface="Georgia"/></ns4:defRPr></ns4:lvl5pPr><ns4:lvl6pPr algn="l"><ns4:buNone/><ns4:defRPr sz="2800" dirty="0" b="1"><ns4:solidFill><ns4:srgbClr val="FFFFFF"/></ns4:solidFill><ns4:latin typeface="Georgia"/><ns4:ea typeface="Georgia"/></ns4:defRPr></ns4:lvl6pPr><ns4:lvl7pPr algn="l"><ns4:buNone/><ns4:defRPr sz="2800" dirty="0" b="1"><ns4:solidFill><ns4:srgbClr val="FFFFFF"/></ns4:solidFill><ns4:latin typeface="Georgia"/><ns4:ea typeface="Georgia"/></ns4:defRPr></ns4:lvl7pPr><ns4:lvl8pPr algn="l"><ns4:buNone/><ns4:defRPr sz="2800" dirty="0" b="1"><ns4:solidFill><ns4:srgbClr val="FFFFFF"/></ns4:solidFill><ns4:latin typeface="Georgia"/><ns4:ea typeface="Georgia"/></ns4:defRPr></ns4:lvl8pPr><ns4:lvl9pPr algn="l"><ns4:buNone/><ns4:defRPr sz="2800" dirty="0" b="1"><ns4:solidFill><ns4:srgbClr val="FFFFFF"/></ns4:solidFill><ns4:latin typeface="Georgia"/><ns4:ea typeface="Georgia"/></ns4:defRPr></ns4:lvl9pPr></ns4:lstStyle/><ns5:p xmlns:ns5="http://schemas.openxmlformats.org/drawingml/2006/main"><ns5:pPr algn="l"><ns5:buNone/></ns5:pPr><ns5:r><ns5:rPr lang="ja-JP"/><ns5:t>サブタイトル</ns5:t></ns5:r></ns5:p></ns0:txBody></ns0:sp><ns0:sp><ns0:nvSpPr><ns0:cNvPr id="5" name="ContentBG"/><ns0:cNvSpPr><ns1:spLocks xmlns:ns1="http://schemas.openxmlformats.org/drawingml/2006/main" noGrp="1" noSelect="0" noRot="1" noMove="1"/></ns0:cNvSpPr><ns0:nvPr/></ns0:nvSpPr><ns0:spPr><ns2:xfrm xmlns:ns2="http://schemas.openxmlformats.org/drawingml/2006/main"><ns2:off x="457200" y="1280160"/><ns2:ext cx="11247120" cy="5029200"/></ns2:xfrm><ns3:prstGeom xmlns:ns3="http://schemas.openxmlformats.org/drawingml/2006/main" prst="rect"/><ns4:solidFill xmlns:ns4="http://schemas.openxmlformats.org/drawingml/2006/main"><ns4:srgbClr val="FFFFFF"/></ns4:solidFill><ns5:ln xmlns:ns5="http://schemas.openxmlformats.org/drawingml/2006/main"><ns5:noFill/></ns5:ln></ns0:spPr></ns0:sp><ns0:sp><ns0:nvSpPr><ns0:cNvPr id="30" name="SlideNum.Footer"/><ns0:cNvSpPr><ns1:spLocks xmlns:ns1="http://schemas.openxmlformats.org/drawingml/2006/main" noGrp="1"/></ns0:cNvSpPr><ns0:nvPr><ns0:ph idx="50" type="sldNum"/></ns0:nvPr></ns0:nvSpPr><ns0:spPr><ns2:xfrm xmlns:ns2="http://schemas.openxmlformats.org/drawingml/2006/main"><ns2:off x="10972800" y="6446520"/><ns2:ext cx="1097280" cy="274320"/></ns2:xfrm></ns0:spPr><ns0:txBody><ns3:bodyPr xmlns:ns3="http://schemas.openxmlformats.org/drawingml/2006/main" wrap="square" anchor="t" anchorCtr="0"/><ns4:lstStyle><ns4:defPPr algn="r"><ns4:defRPr sz="1000"><ns4:solidFill><ns4:srgbClr val="94A3B8"/></ns4:solidFill></ns4:defRPr></ns4:defPPr></ns4:lstStyle><ns4:defPPr algn="r"><ns4:buNone/><ns4:defRPr sz="1000" dirty="0"><ns4:solidFill><ns4:srgbClr val="94A3B8"/></ns4:solidFill><ns4:latin typeface="Calibri"/><ns4:ea typeface="Calibri"/></ns4:defRPr></ns4:defPPr><ns4:lvl1pPr algn="r"><ns4:buNone/><ns4:defRPr sz="1000" dirty="0"><ns4:solidFill><ns4:srgbClr val="94A3B8"/></ns4:solidFill><ns4:latin typeface="Calibri"/><ns4:ea typeface="Calibri"/></ns4:defRPr></ns4:lvl1pPr><ns4:lvl2pPr algn="r"><ns4:buNone/><ns4:defRPr sz="1000" dirty="0"><ns4:solidFill><ns4:srgbClr val="94A3B8"/></ns4:solidFill><ns4:latin typeface="Calibri"/><ns4:ea typeface="Calibri"/></ns4:defRPr></ns4:lvl2pPr><ns4:lvl3pPr algn="r"><ns4:buNone/><ns4:defRPr sz="1000" dirty="0"><ns4:solidFill><ns4:srgbClr val="94A3B8"/></ns4:solidFill><ns4:latin typeface="Calibri"/><ns4:ea typeface="Calibri"/></ns4:defRPr></ns4:lvl3pPr><ns4:lvl4pPr algn="r"><ns4:buNone/><ns4:defRPr sz="1000" dirty="0"><ns4:solidFill><ns4:srgbClr val="94A3B8"/></ns4:solidFill><ns4:latin typeface="Calibri"/><ns4:ea typeface="Calibri"/></ns4:defRPr></ns4:lvl4pPr><ns4:lvl5pPr algn="r"><ns4:buNone/><ns4:defRPr sz="1000" dirty="0"><ns4:solidFill><ns4:srgbClr val="94A3B8"/></ns4:solidFill><ns4:latin typeface="Calibri"/><ns4:ea typeface="Calibri"/></ns4:defRPr></ns4:lvl5pPr><ns4:lvl6pPr algn="r"><ns4:buNone/><ns4:defRPr sz="1000" dirty="0"><ns4:solidFill><ns4:srgbClr val="94A3B8"/></ns4:solidFill><ns4:latin typeface="Calibri"/><ns4:ea typeface="Calibri"/></ns4:defRPr></ns4:lvl6pPr><ns4:lvl7pPr algn="r"><ns4:buNone/><ns4:defRPr sz="1000" dirty="0"><ns4:solidFill><ns4:srgbClr val="94A3B8"/></ns4:solidFill><ns4:latin typeface="Calibri"/><ns4:ea typeface="Calibri"/></ns4:defRPr></ns4:lvl7pPr><ns4:lvl8pPr algn="r"><ns4:buNone/><ns4:defRPr sz="1000" dirty="0"><ns4:solidFill><ns4:srgbClr val="94A3B8"/></ns4:solidFill><ns4:latin typeface="Calibri"/><ns4:ea typeface="Calibri"/></ns4:defRPr></ns4:lvl8pPr><ns4:lvl9pPr algn="r"><ns4:buNone/><ns4:defRPr sz="1000" dirty="0"><ns4:solidFill><ns4:srgbClr val="94A3B8"/></ns4:solidFill><ns4:latin typeface="Calibri"/><ns4:ea typeface="Calibri"/></ns4:defRPr></ns4:lvl9pPr></ns4:lstStyle><ns5:p xmlns:ns5="http://schemas.openxmlformats.org/drawingml/2006/main"><ns5:pPr algn="r"><ns5:buNone/></ns5:pPr><ns5:r><ns5:rPr lang="ja-JP"/><ns5:t>&lt;#&gt;</ns5:t></ns5:r></ns5:p></ns0:txBody></ns0:sp></ns0:spTree></ns0:cSld><ns0:clrMapOvr/></ns0:sldLayout>
 </file>
 
 <file path=ppt/slideLayouts/slideLayout25.xml><?xml version='1.0' encoding='UTF-8' standalone='yes'?>
-<ns0:sldLayout xmlns:ns0="http://schemas.openxmlformats.org/presentationml/2006/main" type="blank" preserve="1"><ns0:cSld name="Process.4Step.Sequential"><ns0:spTree><ns0:nvGrpSpPr><ns0:cNvPr id="1" name=""/><ns0:cNvGrpSpPr/><ns0:nvPr/></ns0:nvGrpSpPr><ns0:grpSpPr><ns1:xfrm xmlns:ns1="http://schemas.openxmlformats.org/drawingml/2006/main"><ns1:off x="0" y="0"/><ns1:ext cx="0" cy="0"/><ns1:chOff x="0" y="0"/><ns1:chExt cx="0" cy="0"/></ns1:xfrm></ns0:grpSpPr><ns0:sp><ns0:nvSpPr><ns0:cNvPr id="2" name="HeaderBar"/><ns0:cNvSpPr><ns1:spLocks xmlns:ns1="http://schemas.openxmlformats.org/drawingml/2006/main" noGrp="1" noSelect="0" noRot="1" noMove="1"/></ns0:cNvSpPr><ns0:nvPr/></ns0:nvSpPr><ns0:spPr><ns2:xfrm xmlns:ns2="http://schemas.openxmlformats.org/drawingml/2006/main"><ns2:off x="0" y="0"/><ns2:ext cx="12192000" cy="1051560"/></ns2:xfrm><ns3:prstGeom xmlns:ns3="http://schemas.openxmlformats.org/drawingml/2006/main" prst="rect"/><ns4:solidFill xmlns:ns4="http://schemas.openxmlformats.org/drawingml/2006/main"><ns4:srgbClr val="1E2761"/></ns4:solidFill><ns5:ln xmlns:ns5="http://schemas.openxmlformats.org/drawingml/2006/main"><ns5:noFill/></ns5:ln></ns0:spPr></ns0:sp><ns0:sp><ns0:nvSpPr><ns0:cNvPr id="10" name="SlideTitle.Header"/><ns0:cNvSpPr><ns1:spLocks xmlns:ns1="http://schemas.openxmlformats.org/drawingml/2006/main" noGrp="1"/></ns0:cNvSpPr><ns0:nvPr><ns0:ph idx="15" type="body"/></ns0:nvPr></ns0:nvSpPr><ns0:spPr><ns2:xfrm xmlns:ns2="http://schemas.openxmlformats.org/drawingml/2006/main"><ns2:off x="731520" y="91440"/><ns2:ext cx="9144000" cy="475488"/></ns2:xfrm></ns0:spPr><ns0:txBody><ns3:bodyPr xmlns:ns3="http://schemas.openxmlformats.org/drawingml/2006/main" wrap="square" anchor="t" anchorCtr="0"/><ns4:lstStyle xmlns:ns4="http://schemas.openxmlformats.org/drawingml/2006/main"><ns4:defPPr algn="l"><ns4:buNone/><ns4:defRPr sz="2800" dirty="0" b="1"><ns4:solidFill><ns4:srgbClr val="FFFFFF"/></ns4:solidFill><ns4:latin typeface="Georgia"/><ns4:ea typeface="Georgia"/></ns4:defRPr></ns4:defPPr><ns4:lvl1pPr algn="l"><ns4:buNone/><ns4:defRPr sz="2800" dirty="0" b="1"><ns4:solidFill><ns4:srgbClr val="FFFFFF"/></ns4:solidFill><ns4:latin typeface="Georgia"/><ns4:ea typeface="Georgia"/></ns4:defRPr></ns4:lvl1pPr><ns4:lvl2pPr algn="l"><ns4:buNone/><ns4:defRPr sz="2800" dirty="0" b="1"><ns4:solidFill><ns4:srgbClr val="FFFFFF"/></ns4:solidFill><ns4:latin typeface="Georgia"/><ns4:ea typeface="Georgia"/></ns4:defRPr></ns4:lvl2pPr><ns4:lvl3pPr algn="l"><ns4:buNone/><ns4:defRPr sz="2800" dirty="0" b="1"><ns4:solidFill><ns4:srgbClr val="FFFFFF"/></ns4:solidFill><ns4:latin typeface="Georgia"/><ns4:ea typeface="Georgia"/></ns4:defRPr></ns4:lvl3pPr><ns4:lvl4pPr algn="l"><ns4:buNone/><ns4:defRPr sz="2800" dirty="0" b="1"><ns4:solidFill><ns4:srgbClr val="FFFFFF"/></ns4:solidFill><ns4:latin typeface="Georgia"/><ns4:ea typeface="Georgia"/></ns4:defRPr></ns4:lvl4pPr><ns4:lvl5pPr algn="l"><ns4:buNone/><ns4:defRPr sz="2800" dirty="0" b="1"><ns4:solidFill><ns4:srgbClr val="FFFFFF"/></ns4:solidFill><ns4:latin typeface="Georgia"/><ns4:ea typeface="Georgia"/></ns4:defRPr></ns4:lvl5pPr><ns4:lvl6pPr algn="l"><ns4:buNone/><ns4:defRPr sz="2800" dirty="0" b="1"><ns4:solidFill><ns4:srgbClr val="FFFFFF"/></ns4:solidFill><ns4:latin typeface="Georgia"/><ns4:ea typeface="Georgia"/></ns4:defRPr></ns4:lvl6pPr><ns4:lvl7pPr algn="l"><ns4:buNone/><ns4:defRPr sz="2800" dirty="0" b="1"><ns4:solidFill><ns4:srgbClr val="FFFFFF"/></ns4:solidFill><ns4:latin typeface="Georgia"/><ns4:ea typeface="Georgia"/></ns4:defRPr></ns4:lvl7pPr><ns4:lvl8pPr algn="l"><ns4:buNone/><ns4:defRPr sz="2800" dirty="0" b="1"><ns4:solidFill><ns4:srgbClr val="FFFFFF"/></ns4:solidFill><ns4:latin typeface="Georgia"/><ns4:ea typeface="Georgia"/></ns4:defRPr></ns4:lvl8pPr><ns4:lvl9pPr algn="l"><ns4:buNone/><ns4:defRPr sz="2800" dirty="0" b="1"><ns4:solidFill><ns4:srgbClr val="FFFFFF"/></ns4:solidFill><ns4:latin typeface="Georgia"/><ns4:ea typeface="Georgia"/></ns4:defRPr></ns4:lvl9pPr></ns4:lstStyle/><ns5:p xmlns:ns5="http://schemas.openxmlformats.org/drawingml/2006/main"><ns5:pPr algn="l"><ns5:buNone/></ns5:pPr><ns5:r><ns5:rPr lang="ja-JP"/><ns5:t>サブタイトル</ns5:t></ns5:r></ns5:p></ns0:txBody></ns0:sp><ns0:sp><ns0:nvSpPr><ns0:cNvPr id="5" name="ConnLine"/><ns0:cNvSpPr><ns1:spLocks xmlns:ns1="http://schemas.openxmlformats.org/drawingml/2006/main" noGrp="1" noSelect="0" noRot="1" noMove="1"/></ns0:cNvSpPr><ns0:nvPr/></ns0:nvSpPr><ns0:spPr><ns2:xfrm xmlns:ns2="http://schemas.openxmlformats.org/drawingml/2006/main"><ns2:off x="1645920" y="2651760"/><ns2:ext cx="8869680" cy="36576"/></ns2:xfrm><ns3:prstGeom xmlns:ns3="http://schemas.openxmlformats.org/drawingml/2006/main" prst="rect"/><ns4:solidFill xmlns:ns4="http://schemas.openxmlformats.org/drawingml/2006/main"><ns4:srgbClr val="CADCFC"/></ns4:solidFill><ns5:ln xmlns:ns5="http://schemas.openxmlformats.org/drawingml/2006/main"><ns5:noFill/></ns5:ln></ns0:spPr></ns0:sp><ns0:sp><ns0:nvSpPr><ns0:cNvPr id="6" name="C1"/><ns0:cNvSpPr><ns1:spLocks xmlns:ns1="http://schemas.openxmlformats.org/drawingml/2006/main" noGrp="1"/></ns0:cNvSpPr><ns0:nvPr/></ns0:nvSpPr><ns0:spPr><ns2:xfrm xmlns:ns2="http://schemas.openxmlformats.org/drawingml/2006/main"><ns2:off x="1672254463968" y="2466575455968"/><ns2:ext cx="512064" cy="512064"/></ns2:xfrm><ns3:prstGeom xmlns:ns3="http://schemas.openxmlformats.org/drawingml/2006/main" prst="ellipse"/><ns4:solidFill xmlns:ns4="http://schemas.openxmlformats.org/drawingml/2006/main"><ns4:srgbClr val="3B82F6"/></ns4:solidFill><ns5:ln xmlns:ns5="http://schemas.openxmlformats.org/drawingml/2006/main"><ns5:noFill/></ns5:ln></ns0:spPr></ns0:sp><ns0:sp><ns0:nvSpPr><ns0:cNvPr id="7" name="C2"/><ns0:cNvSpPr><ns1:spLocks xmlns:ns1="http://schemas.openxmlformats.org/drawingml/2006/main" noGrp="1"/></ns0:cNvSpPr><ns0:nvPr/></ns0:nvSpPr><ns0:spPr><ns2:xfrm xmlns:ns2="http://schemas.openxmlformats.org/drawingml/2006/main"><ns2:off x="4347862015968" y="2466575455968"/><ns2:ext cx="512064" cy="512064"/></ns2:xfrm><ns3:prstGeom xmlns:ns3="http://schemas.openxmlformats.org/drawingml/2006/main" prst="ellipse"/><ns4:solidFill xmlns:ns4="http://schemas.openxmlformats.org/drawingml/2006/main"><ns4:srgbClr val="3B82F6"/></ns4:solidFill><ns5:ln xmlns:ns5="http://schemas.openxmlformats.org/drawingml/2006/main"><ns5:noFill/></ns5:ln></ns0:spPr></ns0:sp><ns0:sp><ns0:nvSpPr><ns0:cNvPr id="8" name="C3"/><ns0:cNvSpPr><ns1:spLocks xmlns:ns1="http://schemas.openxmlformats.org/drawingml/2006/main" noGrp="1"/></ns0:cNvSpPr><ns0:nvPr/></ns0:nvSpPr><ns0:spPr><ns2:xfrm xmlns:ns2="http://schemas.openxmlformats.org/drawingml/2006/main"><ns2:off x="7023469567968" y="2466575455968"/><ns2:ext cx="512064" cy="512064"/></ns2:xfrm><ns3:prstGeom xmlns:ns3="http://schemas.openxmlformats.org/drawingml/2006/main" prst="ellipse"/><ns4:solidFill xmlns:ns4="http://schemas.openxmlformats.org/drawingml/2006/main"><ns4:srgbClr val="3B82F6"/></ns4:solidFill><ns5:ln xmlns:ns5="http://schemas.openxmlformats.org/drawingml/2006/main"><ns5:noFill/></ns5:ln></ns0:spPr></ns0:sp><ns0:sp><ns0:nvSpPr><ns0:cNvPr id="9" name="C4"/><ns0:cNvSpPr><ns1:spLocks xmlns:ns1="http://schemas.openxmlformats.org/drawingml/2006/main" noGrp="1"/></ns0:cNvSpPr><ns0:nvPr/></ns0:nvSpPr><ns0:spPr><ns2:xfrm xmlns:ns2="http://schemas.openxmlformats.org/drawingml/2006/main"><ns2:off x="9615464383968" y="2466575455968"/><ns2:ext cx="512064" cy="512064"/></ns2:xfrm><ns3:prstGeom xmlns:ns3="http://schemas.openxmlformats.org/drawingml/2006/main" prst="ellipse"/><ns4:solidFill xmlns:ns4="http://schemas.openxmlformats.org/drawingml/2006/main"><ns4:srgbClr val="3B82F6"/></ns4:solidFill><ns5:ln xmlns:ns5="http://schemas.openxmlformats.org/drawingml/2006/main"><ns5:noFill/></ns5:ln></ns0:spPr></ns0:sp><ns0:sp><ns0:nvSpPr><ns0:cNvPr id="20" name="Step1.Left"/><ns0:cNvSpPr><ns1:spLocks xmlns:ns1="http://schemas.openxmlformats.org/drawingml/2006/main" noGrp="1"/></ns0:cNvSpPr><ns0:nvPr><ns0:ph idx="1" type="body"/></ns0:nvPr></ns0:nvSpPr><ns0:spPr><ns2:xfrm xmlns:ns2="http://schemas.openxmlformats.org/drawingml/2006/main"><ns2:off x="457200" y="3291840"/><ns2:ext cx="2560320" cy="2743200"/></ns2:xfrm></ns0:spPr><ns0:txBody><ns3:bodyPr xmlns:ns3="http://schemas.openxmlformats.org/drawingml/2006/main" wrap="square" anchor="t" anchorCtr="0"/><ns4:lstStyle xmlns:ns4="http://schemas.openxmlformats.org/drawingml/2006/main"><ns4:defPPr algn="ctr"><ns4:buNone/><ns4:defRPr sz="1300" dirty="0"><ns4:solidFill><ns4:srgbClr val="1E293B"/></ns4:solidFill><ns4:latin typeface="Calibri"/><ns4:ea typeface="Calibri"/></ns4:defRPr></ns4:defPPr><ns4:lvl1pPr algn="ctr"><ns4:buNone/><ns4:defRPr sz="1300" dirty="0"><ns4:solidFill><ns4:srgbClr val="1E293B"/></ns4:solidFill><ns4:latin typeface="Calibri"/><ns4:ea typeface="Calibri"/></ns4:defRPr></ns4:lvl1pPr><ns4:lvl2pPr algn="ctr"><ns4:buNone/><ns4:defRPr sz="1300" dirty="0"><ns4:solidFill><ns4:srgbClr val="1E293B"/></ns4:solidFill><ns4:latin typeface="Calibri"/><ns4:ea typeface="Calibri"/></ns4:defRPr></ns4:lvl2pPr><ns4:lvl3pPr algn="ctr"><ns4:buNone/><ns4:defRPr sz="1300" dirty="0"><ns4:solidFill><ns4:srgbClr val="1E293B"/></ns4:solidFill><ns4:latin typeface="Calibri"/><ns4:ea typeface="Calibri"/></ns4:defRPr></ns4:lvl3pPr><ns4:lvl4pPr algn="ctr"><ns4:buNone/><ns4:defRPr sz="1300" dirty="0"><ns4:solidFill><ns4:srgbClr val="1E293B"/></ns4:solidFill><ns4:latin typeface="Calibri"/><ns4:ea typeface="Calibri"/></ns4:defRPr></ns4:lvl4pPr><ns4:lvl5pPr algn="ctr"><ns4:buNone/><ns4:defRPr sz="1300" dirty="0"><ns4:solidFill><ns4:srgbClr val="1E293B"/></ns4:solidFill><ns4:latin typeface="Calibri"/><ns4:ea typeface="Calibri"/></ns4:defRPr></ns4:lvl5pPr><ns4:lvl6pPr algn="ctr"><ns4:buNone/><ns4:defRPr sz="1300" dirty="0"><ns4:solidFill><ns4:srgbClr val="1E293B"/></ns4:solidFill><ns4:latin typeface="Calibri"/><ns4:ea typeface="Calibri"/></ns4:defRPr></ns4:lvl6pPr><ns4:lvl7pPr algn="ctr"><ns4:buNone/><ns4:defRPr sz="1300" dirty="0"><ns4:solidFill><ns4:srgbClr val="1E293B"/></ns4:solidFill><ns4:latin typeface="Calibri"/><ns4:ea typeface="Calibri"/></ns4:defRPr></ns4:lvl7pPr><ns4:lvl8pPr algn="ctr"><ns4:buNone/><ns4:defRPr sz="1300" dirty="0"><ns4:solidFill><ns4:srgbClr val="1E293B"/></ns4:solidFill><ns4:latin typeface="Calibri"/><ns4:ea typeface="Calibri"/></ns4:defRPr></ns4:lvl8pPr><ns4:lvl9pPr algn="ctr"><ns4:buNone/><ns4:defRPr sz="1300" dirty="0"><ns4:solidFill><ns4:srgbClr val="1E293B"/></ns4:solidFill><ns4:latin typeface="Calibri"/><ns4:ea typeface="Calibri"/></ns4:defRPr></ns4:lvl9pPr></ns4:lstStyle/><ns5:p xmlns:ns5="http://schemas.openxmlformats.org/drawingml/2006/main"><ns5:pPr algn="ctr"><ns5:buNone/></ns5:pPr><ns5:r><ns5:rPr lang="ja-JP"/><ns5:t>STEP 2
+<ns0:sldLayout xmlns:ns0="http://schemas.openxmlformats.org/presentationml/2006/main" type="blank" preserve="1"><ns0:cSld name="Process.4Step.Sequential"><ns0:spTree><ns0:nvGrpSpPr><ns0:cNvPr id="1" name=""/><ns0:cNvGrpSpPr/><ns0:nvPr/></ns0:nvGrpSpPr><ns0:grpSpPr><ns1:xfrm xmlns:ns1="http://schemas.openxmlformats.org/drawingml/2006/main"><ns1:off x="0" y="0"/><ns1:ext cx="0" cy="0"/><ns1:chOff x="0" y="0"/><ns1:chExt cx="0" cy="0"/></ns1:xfrm></ns0:grpSpPr><ns0:sp><ns0:nvSpPr><ns0:cNvPr id="2" name="HeaderBar"/><ns0:cNvSpPr><ns1:spLocks xmlns:ns1="http://schemas.openxmlformats.org/drawingml/2006/main" noGrp="1" noSelect="0" noRot="1" noMove="1"/></ns0:cNvSpPr><ns0:nvPr/></ns0:nvSpPr><ns0:spPr><ns2:xfrm xmlns:ns2="http://schemas.openxmlformats.org/drawingml/2006/main"><ns2:off x="0" y="0"/><ns2:ext cx="12192000" cy="1051560"/></ns2:xfrm><ns3:prstGeom xmlns:ns3="http://schemas.openxmlformats.org/drawingml/2006/main" prst="rect"/><ns4:solidFill xmlns:ns4="http://schemas.openxmlformats.org/drawingml/2006/main"><ns4:srgbClr val="1E2761"/></ns4:solidFill><ns5:ln xmlns:ns5="http://schemas.openxmlformats.org/drawingml/2006/main"><ns5:noFill/></ns5:ln></ns0:spPr></ns0:sp><ns0:sp><ns0:nvSpPr><ns0:cNvPr id="10" name="SlideTitle.Header"/><ns0:cNvSpPr><ns1:spLocks xmlns:ns1="http://schemas.openxmlformats.org/drawingml/2006/main" noGrp="1"/></ns0:cNvSpPr><ns0:nvPr><ns0:ph idx="15" type="body"/></ns0:nvPr></ns0:nvSpPr><ns0:spPr><ns2:xfrm xmlns:ns2="http://schemas.openxmlformats.org/drawingml/2006/main"><ns2:off x="731520" y="91440"/><ns2:ext cx="9144000" cy="475488"/></ns2:xfrm></ns0:spPr><ns0:txBody><ns3:bodyPr xmlns:ns3="http://schemas.openxmlformats.org/drawingml/2006/main" wrap="square" anchor="t" anchorCtr="0"/><ns4:lstStyle><ns4:defPPr><ns4:defRPr sz="2800" b="1"><ns4:solidFill><ns4:srgbClr val="FFFFFF"/></ns4:solidFill></ns4:defRPr></ns4:defPPr></ns4:lstStyle><ns4:defPPr algn="l"><ns4:buNone/><ns4:defRPr sz="2800" dirty="0" b="1"><ns4:solidFill><ns4:srgbClr val="FFFFFF"/></ns4:solidFill><ns4:latin typeface="Georgia"/><ns4:ea typeface="Georgia"/></ns4:defRPr></ns4:defPPr><ns4:lvl1pPr algn="l"><ns4:buNone/><ns4:defRPr sz="2800" dirty="0" b="1"><ns4:solidFill><ns4:srgbClr val="FFFFFF"/></ns4:solidFill><ns4:latin typeface="Georgia"/><ns4:ea typeface="Georgia"/></ns4:defRPr></ns4:lvl1pPr><ns4:lvl2pPr algn="l"><ns4:buNone/><ns4:defRPr sz="2800" dirty="0" b="1"><ns4:solidFill><ns4:srgbClr val="FFFFFF"/></ns4:solidFill><ns4:latin typeface="Georgia"/><ns4:ea typeface="Georgia"/></ns4:defRPr></ns4:lvl2pPr><ns4:lvl3pPr algn="l"><ns4:buNone/><ns4:defRPr sz="2800" dirty="0" b="1"><ns4:solidFill><ns4:srgbClr val="FFFFFF"/></ns4:solidFill><ns4:latin typeface="Georgia"/><ns4:ea typeface="Georgia"/></ns4:defRPr></ns4:lvl3pPr><ns4:lvl4pPr algn="l"><ns4:buNone/><ns4:defRPr sz="2800" dirty="0" b="1"><ns4:solidFill><ns4:srgbClr val="FFFFFF"/></ns4:solidFill><ns4:latin typeface="Georgia"/><ns4:ea typeface="Georgia"/></ns4:defRPr></ns4:lvl4pPr><ns4:lvl5pPr algn="l"><ns4:buNone/><ns4:defRPr sz="2800" dirty="0" b="1"><ns4:solidFill><ns4:srgbClr val="FFFFFF"/></ns4:solidFill><ns4:latin typeface="Georgia"/><ns4:ea typeface="Georgia"/></ns4:defRPr></ns4:lvl5pPr><ns4:lvl6pPr algn="l"><ns4:buNone/><ns4:defRPr sz="2800" dirty="0" b="1"><ns4:solidFill><ns4:srgbClr val="FFFFFF"/></ns4:solidFill><ns4:latin typeface="Georgia"/><ns4:ea typeface="Georgia"/></ns4:defRPr></ns4:lvl6pPr><ns4:lvl7pPr algn="l"><ns4:buNone/><ns4:defRPr sz="2800" dirty="0" b="1"><ns4:solidFill><ns4:srgbClr val="FFFFFF"/></ns4:solidFill><ns4:latin typeface="Georgia"/><ns4:ea typeface="Georgia"/></ns4:defRPr></ns4:lvl7pPr><ns4:lvl8pPr algn="l"><ns4:buNone/><ns4:defRPr sz="2800" dirty="0" b="1"><ns4:solidFill><ns4:srgbClr val="FFFFFF"/></ns4:solidFill><ns4:latin typeface="Georgia"/><ns4:ea typeface="Georgia"/></ns4:defRPr></ns4:lvl8pPr><ns4:lvl9pPr algn="l"><ns4:buNone/><ns4:defRPr sz="2800" dirty="0" b="1"><ns4:solidFill><ns4:srgbClr val="FFFFFF"/></ns4:solidFill><ns4:latin typeface="Georgia"/><ns4:ea typeface="Georgia"/></ns4:defRPr></ns4:lvl9pPr></ns4:lstStyle/><ns5:p xmlns:ns5="http://schemas.openxmlformats.org/drawingml/2006/main"><ns5:pPr algn="l"><ns5:buNone/></ns5:pPr><ns5:r><ns5:rPr lang="ja-JP"/><ns5:t>サブタイトル</ns5:t></ns5:r></ns5:p></ns0:txBody></ns0:sp><ns0:sp><ns0:nvSpPr><ns0:cNvPr id="5" name="ConnLine"/><ns0:cNvSpPr><ns1:spLocks xmlns:ns1="http://schemas.openxmlformats.org/drawingml/2006/main" noGrp="1" noSelect="0" noRot="1" noMove="1"/></ns0:cNvSpPr><ns0:nvPr/></ns0:nvSpPr><ns0:spPr><ns2:xfrm xmlns:ns2="http://schemas.openxmlformats.org/drawingml/2006/main"><ns2:off x="1645920" y="2651760"/><ns2:ext cx="8869680" cy="36576"/></ns2:xfrm><ns3:prstGeom xmlns:ns3="http://schemas.openxmlformats.org/drawingml/2006/main" prst="rect"/><ns4:solidFill xmlns:ns4="http://schemas.openxmlformats.org/drawingml/2006/main"><ns4:srgbClr val="CADCFC"/></ns4:solidFill><ns5:ln xmlns:ns5="http://schemas.openxmlformats.org/drawingml/2006/main"><ns5:noFill/></ns5:ln></ns0:spPr></ns0:sp><ns0:sp><ns0:nvSpPr><ns0:cNvPr id="6" name="C1"/><ns0:cNvSpPr><ns1:spLocks xmlns:ns1="http://schemas.openxmlformats.org/drawingml/2006/main" noGrp="1"/></ns0:cNvSpPr><ns0:nvPr/></ns0:nvSpPr><ns0:spPr><ns2:xfrm xmlns:ns2="http://schemas.openxmlformats.org/drawingml/2006/main"><ns2:off x="1672254463968" y="2466575455968"/><ns2:ext cx="512064" cy="512064"/></ns2:xfrm><ns3:prstGeom xmlns:ns3="http://schemas.openxmlformats.org/drawingml/2006/main" prst="ellipse"/><ns4:solidFill xmlns:ns4="http://schemas.openxmlformats.org/drawingml/2006/main"><ns4:srgbClr val="3B82F6"/></ns4:solidFill><ns5:ln xmlns:ns5="http://schemas.openxmlformats.org/drawingml/2006/main"><ns5:noFill/></ns5:ln></ns0:spPr></ns0:sp><ns0:sp><ns0:nvSpPr><ns0:cNvPr id="7" name="C2"/><ns0:cNvSpPr><ns1:spLocks xmlns:ns1="http://schemas.openxmlformats.org/drawingml/2006/main" noGrp="1"/></ns0:cNvSpPr><ns0:nvPr/></ns0:nvSpPr><ns0:spPr><ns2:xfrm xmlns:ns2="http://schemas.openxmlformats.org/drawingml/2006/main"><ns2:off x="4347862015968" y="2466575455968"/><ns2:ext cx="512064" cy="512064"/></ns2:xfrm><ns3:prstGeom xmlns:ns3="http://schemas.openxmlformats.org/drawingml/2006/main" prst="ellipse"/><ns4:solidFill xmlns:ns4="http://schemas.openxmlformats.org/drawingml/2006/main"><ns4:srgbClr val="3B82F6"/></ns4:solidFill><ns5:ln xmlns:ns5="http://schemas.openxmlformats.org/drawingml/2006/main"><ns5:noFill/></ns5:ln></ns0:spPr></ns0:sp><ns0:sp><ns0:nvSpPr><ns0:cNvPr id="8" name="C3"/><ns0:cNvSpPr><ns1:spLocks xmlns:ns1="http://schemas.openxmlformats.org/drawingml/2006/main" noGrp="1"/></ns0:cNvSpPr><ns0:nvPr/></ns0:nvSpPr><ns0:spPr><ns2:xfrm xmlns:ns2="http://schemas.openxmlformats.org/drawingml/2006/main"><ns2:off x="7023469567968" y="2466575455968"/><ns2:ext cx="512064" cy="512064"/></ns2:xfrm><ns3:prstGeom xmlns:ns3="http://schemas.openxmlformats.org/drawingml/2006/main" prst="ellipse"/><ns4:solidFill xmlns:ns4="http://schemas.openxmlformats.org/drawingml/2006/main"><ns4:srgbClr val="3B82F6"/></ns4:solidFill><ns5:ln xmlns:ns5="http://schemas.openxmlformats.org/drawingml/2006/main"><ns5:noFill/></ns5:ln></ns0:spPr></ns0:sp><ns0:sp><ns0:nvSpPr><ns0:cNvPr id="9" name="C4"/><ns0:cNvSpPr><ns1:spLocks xmlns:ns1="http://schemas.openxmlformats.org/drawingml/2006/main" noGrp="1"/></ns0:cNvSpPr><ns0:nvPr/></ns0:nvSpPr><ns0:spPr><ns2:xfrm xmlns:ns2="http://schemas.openxmlformats.org/drawingml/2006/main"><ns2:off x="9615464383968" y="2466575455968"/><ns2:ext cx="512064" cy="512064"/></ns2:xfrm><ns3:prstGeom xmlns:ns3="http://schemas.openxmlformats.org/drawingml/2006/main" prst="ellipse"/><ns4:solidFill xmlns:ns4="http://schemas.openxmlformats.org/drawingml/2006/main"><ns4:srgbClr val="3B82F6"/></ns4:solidFill><ns5:ln xmlns:ns5="http://schemas.openxmlformats.org/drawingml/2006/main"><ns5:noFill/></ns5:ln></ns0:spPr></ns0:sp><ns0:sp><ns0:nvSpPr><ns0:cNvPr id="20" name="Step1.Left"/><ns0:cNvSpPr><ns1:spLocks xmlns:ns1="http://schemas.openxmlformats.org/drawingml/2006/main" noGrp="1"/></ns0:cNvSpPr><ns0:nvPr><ns0:ph idx="1" type="body"/></ns0:nvPr></ns0:nvSpPr><ns0:spPr><ns2:xfrm xmlns:ns2="http://schemas.openxmlformats.org/drawingml/2006/main"><ns2:off x="457200" y="3291840"/><ns2:ext cx="2560320" cy="2743200"/></ns2:xfrm></ns0:spPr><ns0:txBody><ns3:bodyPr xmlns:ns3="http://schemas.openxmlformats.org/drawingml/2006/main" wrap="square" anchor="t" anchorCtr="0"/><ns4:lstStyle><ns4:defPPr algn="ctr"><ns4:defRPr sz="1300"></ns4:defRPr></ns4:defPPr></ns4:lstStyle><ns4:defPPr algn="ctr"><ns4:buNone/><ns4:defRPr sz="1300" dirty="0"><ns4:solidFill><ns4:srgbClr val="1E293B"/></ns4:solidFill><ns4:latin typeface="Calibri"/><ns4:ea typeface="Calibri"/></ns4:defRPr></ns4:defPPr><ns4:lvl1pPr algn="ctr"><ns4:buNone/><ns4:defRPr sz="1300" dirty="0"><ns4:solidFill><ns4:srgbClr val="1E293B"/></ns4:solidFill><ns4:latin typeface="Calibri"/><ns4:ea typeface="Calibri"/></ns4:defRPr></ns4:lvl1pPr><ns4:lvl2pPr algn="ctr"><ns4:buNone/><ns4:defRPr sz="1300" dirty="0"><ns4:solidFill><ns4:srgbClr val="1E293B"/></ns4:solidFill><ns4:latin typeface="Calibri"/><ns4:ea typeface="Calibri"/></ns4:defRPr></ns4:lvl2pPr><ns4:lvl3pPr algn="ctr"><ns4:buNone/><ns4:defRPr sz="1300" dirty="0"><ns4:solidFill><ns4:srgbClr val="1E293B"/></ns4:solidFill><ns4:latin typeface="Calibri"/><ns4:ea typeface="Calibri"/></ns4:defRPr></ns4:lvl3pPr><ns4:lvl4pPr algn="ctr"><ns4:buNone/><ns4:defRPr sz="1300" dirty="0"><ns4:solidFill><ns4:srgbClr val="1E293B"/></ns4:solidFill><ns4:latin typeface="Calibri"/><ns4:ea typeface="Calibri"/></ns4:defRPr></ns4:lvl4pPr><ns4:lvl5pPr algn="ctr"><ns4:buNone/><ns4:defRPr sz="1300" dirty="0"><ns4:solidFill><ns4:srgbClr val="1E293B"/></ns4:solidFill><ns4:latin typeface="Calibri"/><ns4:ea typeface="Calibri"/></ns4:defRPr></ns4:lvl5pPr><ns4:lvl6pPr algn="ctr"><ns4:buNone/><ns4:defRPr sz="1300" dirty="0"><ns4:solidFill><ns4:srgbClr val="1E293B"/></ns4:solidFill><ns4:latin typeface="Calibri"/><ns4:ea typeface="Calibri"/></ns4:defRPr></ns4:lvl6pPr><ns4:lvl7pPr algn="ctr"><ns4:buNone/><ns4:defRPr sz="1300" dirty="0"><ns4:solidFill><ns4:srgbClr val="1E293B"/></ns4:solidFill><ns4:latin typeface="Calibri"/><ns4:ea typeface="Calibri"/></ns4:defRPr></ns4:lvl7pPr><ns4:lvl8pPr algn="ctr"><ns4:buNone/><ns4:defRPr sz="1300" dirty="0"><ns4:solidFill><ns4:srgbClr val="1E293B"/></ns4:solidFill><ns4:latin typeface="Calibri"/><ns4:ea typeface="Calibri"/></ns4:defRPr></ns4:lvl8pPr><ns4:lvl9pPr algn="ctr"><ns4:buNone/><ns4:defRPr sz="1300" dirty="0"><ns4:solidFill><ns4:srgbClr val="1E293B"/></ns4:solidFill><ns4:latin typeface="Calibri"/><ns4:ea typeface="Calibri"/></ns4:defRPr></ns4:lvl9pPr></ns4:lstStyle/><ns5:p xmlns:ns5="http://schemas.openxmlformats.org/drawingml/2006/main"><ns5:pPr algn="ctr"><ns5:buNone/></ns5:pPr><ns5:r><ns5:rPr lang="ja-JP"/><ns5:t>STEP 2
 タイトル
-説明テキスト</ns5:t></ns5:r></ns5:p></ns0:txBody></ns0:sp><ns0:sp><ns0:nvSpPr><ns0:cNvPr id="22" name="Step3.CenterRight"/><ns0:cNvSpPr><ns1:spLocks xmlns:ns1="http://schemas.openxmlformats.org/drawingml/2006/main" noGrp="1"/></ns0:cNvSpPr><ns0:nvPr><ns0:ph idx="3" type="body"/></ns0:nvPr></ns0:nvSpPr><ns0:spPr><ns2:xfrm xmlns:ns2="http://schemas.openxmlformats.org/drawingml/2006/main"><ns2:off x="6309360" y="3291840"/><ns2:ext cx="2560320" cy="2743200"/></ns2:xfrm></ns0:spPr><ns0:txBody><ns3:bodyPr xmlns:ns3="http://schemas.openxmlformats.org/drawingml/2006/main" wrap="square" anchor="t" anchorCtr="0"/><ns4:lstStyle xmlns:ns4="http://schemas.openxmlformats.org/drawingml/2006/main"><ns4:defPPr algn="ctr"><ns4:buNone/><ns4:defRPr sz="1300" dirty="0"><ns4:solidFill><ns4:srgbClr val="1E293B"/></ns4:solidFill><ns4:latin typeface="Calibri"/><ns4:ea typeface="Calibri"/></ns4:defRPr></ns4:defPPr><ns4:lvl1pPr algn="ctr"><ns4:buNone/><ns4:defRPr sz="1300" dirty="0"><ns4:solidFill><ns4:srgbClr val="1E293B"/></ns4:solidFill><ns4:latin typeface="Calibri"/><ns4:ea typeface="Calibri"/></ns4:defRPr></ns4:lvl1pPr><ns4:lvl2pPr algn="ctr"><ns4:buNone/><ns4:defRPr sz="1300" dirty="0"><ns4:solidFill><ns4:srgbClr val="1E293B"/></ns4:solidFill><ns4:latin typeface="Calibri"/><ns4:ea typeface="Calibri"/></ns4:defRPr></ns4:lvl2pPr><ns4:lvl3pPr algn="ctr"><ns4:buNone/><ns4:defRPr sz="1300" dirty="0"><ns4:solidFill><ns4:srgbClr val="1E293B"/></ns4:solidFill><ns4:latin typeface="Calibri"/><ns4:ea typeface="Calibri"/></ns4:defRPr></ns4:lvl3pPr><ns4:lvl4pPr algn="ctr"><ns4:buNone/><ns4:defRPr sz="1300" dirty="0"><ns4:solidFill><ns4:srgbClr val="1E293B"/></ns4:solidFill><ns4:latin typeface="Calibri"/><ns4:ea typeface="Calibri"/></ns4:defRPr></ns4:lvl4pPr><ns4:lvl5pPr algn="ctr"><ns4:buNone/><ns4:defRPr sz="1300" dirty="0"><ns4:solidFill><ns4:srgbClr val="1E293B"/></ns4:solidFill><ns4:latin typeface="Calibri"/><ns4:ea typeface="Calibri"/></ns4:defRPr></ns4:lvl5pPr><ns4:lvl6pPr algn="ctr"><ns4:buNone/><ns4:defRPr sz="1300" dirty="0"><ns4:solidFill><ns4:srgbClr val="1E293B"/></ns4:solidFill><ns4:latin typeface="Calibri"/><ns4:ea typeface="Calibri"/></ns4:defRPr></ns4:lvl6pPr><ns4:lvl7pPr algn="ctr"><ns4:buNone/><ns4:defRPr sz="1300" dirty="0"><ns4:solidFill><ns4:srgbClr val="1E293B"/></ns4:solidFill><ns4:latin typeface="Calibri"/><ns4:ea typeface="Calibri"/></ns4:defRPr></ns4:lvl7pPr><ns4:lvl8pPr algn="ctr"><ns4:buNone/><ns4:defRPr sz="1300" dirty="0"><ns4:solidFill><ns4:srgbClr val="1E293B"/></ns4:solidFill><ns4:latin typeface="Calibri"/><ns4:ea typeface="Calibri"/></ns4:defRPr></ns4:lvl8pPr><ns4:lvl9pPr algn="ctr"><ns4:buNone/><ns4:defRPr sz="1300" dirty="0"><ns4:solidFill><ns4:srgbClr val="1E293B"/></ns4:solidFill><ns4:latin typeface="Calibri"/><ns4:ea typeface="Calibri"/></ns4:defRPr></ns4:lvl9pPr></ns4:lstStyle/><ns5:p xmlns:ns5="http://schemas.openxmlformats.org/drawingml/2006/main"><ns5:pPr algn="ctr"><ns5:buNone/></ns5:pPr><ns5:r><ns5:rPr lang="ja-JP"/><ns5:t>STEP 4
+説明テキスト</ns5:t></ns5:r></ns5:p></ns0:txBody></ns0:sp><ns0:sp><ns0:nvSpPr><ns0:cNvPr id="22" name="Step3.CenterRight"/><ns0:cNvSpPr><ns1:spLocks xmlns:ns1="http://schemas.openxmlformats.org/drawingml/2006/main" noGrp="1"/></ns0:cNvSpPr><ns0:nvPr><ns0:ph idx="3" type="body"/></ns0:nvPr></ns0:nvSpPr><ns0:spPr><ns2:xfrm xmlns:ns2="http://schemas.openxmlformats.org/drawingml/2006/main"><ns2:off x="6309360" y="3291840"/><ns2:ext cx="2560320" cy="2743200"/></ns2:xfrm></ns0:spPr><ns0:txBody><ns3:bodyPr xmlns:ns3="http://schemas.openxmlformats.org/drawingml/2006/main" wrap="square" anchor="t" anchorCtr="0"/><ns4:lstStyle><ns4:defPPr algn="ctr"><ns4:defRPr sz="1300"></ns4:defRPr></ns4:defPPr></ns4:lstStyle><ns4:defPPr algn="ctr"><ns4:buNone/><ns4:defRPr sz="1300" dirty="0"><ns4:solidFill><ns4:srgbClr val="1E293B"/></ns4:solidFill><ns4:latin typeface="Calibri"/><ns4:ea typeface="Calibri"/></ns4:defRPr></ns4:defPPr><ns4:lvl1pPr algn="ctr"><ns4:buNone/><ns4:defRPr sz="1300" dirty="0"><ns4:solidFill><ns4:srgbClr val="1E293B"/></ns4:solidFill><ns4:latin typeface="Calibri"/><ns4:ea typeface="Calibri"/></ns4:defRPr></ns4:lvl1pPr><ns4:lvl2pPr algn="ctr"><ns4:buNone/><ns4:defRPr sz="1300" dirty="0"><ns4:solidFill><ns4:srgbClr val="1E293B"/></ns4:solidFill><ns4:latin typeface="Calibri"/><ns4:ea typeface="Calibri"/></ns4:defRPr></ns4:lvl2pPr><ns4:lvl3pPr algn="ctr"><ns4:buNone/><ns4:defRPr sz="1300" dirty="0"><ns4:solidFill><ns4:srgbClr val="1E293B"/></ns4:solidFill><ns4:latin typeface="Calibri"/><ns4:ea typeface="Calibri"/></ns4:defRPr></ns4:lvl3pPr><ns4:lvl4pPr algn="ctr"><ns4:buNone/><ns4:defRPr sz="1300" dirty="0"><ns4:solidFill><ns4:srgbClr val="1E293B"/></ns4:solidFill><ns4:latin typeface="Calibri"/><ns4:ea typeface="Calibri"/></ns4:defRPr></ns4:lvl4pPr><ns4:lvl5pPr algn="ctr"><ns4:buNone/><ns4:defRPr sz="1300" dirty="0"><ns4:solidFill><ns4:srgbClr val="1E293B"/></ns4:solidFill><ns4:latin typeface="Calibri"/><ns4:ea typeface="Calibri"/></ns4:defRPr></ns4:lvl5pPr><ns4:lvl6pPr algn="ctr"><ns4:buNone/><ns4:defRPr sz="1300" dirty="0"><ns4:solidFill><ns4:srgbClr val="1E293B"/></ns4:solidFill><ns4:latin typeface="Calibri"/><ns4:ea typeface="Calibri"/></ns4:defRPr></ns4:lvl6pPr><ns4:lvl7pPr algn="ctr"><ns4:buNone/><ns4:defRPr sz="1300" dirty="0"><ns4:solidFill><ns4:srgbClr val="1E293B"/></ns4:solidFill><ns4:latin typeface="Calibri"/><ns4:ea typeface="Calibri"/></ns4:defRPr></ns4:lvl7pPr><ns4:lvl8pPr algn="ctr"><ns4:buNone/><ns4:defRPr sz="1300" dirty="0"><ns4:solidFill><ns4:srgbClr val="1E293B"/></ns4:solidFill><ns4:latin typeface="Calibri"/><ns4:ea typeface="Calibri"/></ns4:defRPr></ns4:lvl8pPr><ns4:lvl9pPr algn="ctr"><ns4:buNone/><ns4:defRPr sz="1300" dirty="0"><ns4:solidFill><ns4:srgbClr val="1E293B"/></ns4:solidFill><ns4:latin typeface="Calibri"/><ns4:ea typeface="Calibri"/></ns4:defRPr></ns4:lvl9pPr></ns4:lstStyle/><ns5:p xmlns:ns5="http://schemas.openxmlformats.org/drawingml/2006/main"><ns5:pPr algn="ctr"><ns5:buNone/></ns5:pPr><ns5:r><ns5:rPr lang="ja-JP"/><ns5:t>STEP 4
 タイトル
-説明テキスト</ns5:t></ns5:r></ns5:p></ns0:txBody></ns0:sp><ns0:sp><ns0:nvSpPr><ns0:cNvPr id="30" name="SlideNum.Footer"/><ns0:cNvSpPr><ns1:spLocks xmlns:ns1="http://schemas.openxmlformats.org/drawingml/2006/main" noGrp="1"/></ns0:cNvSpPr><ns0:nvPr><ns0:ph idx="50" type="sldNum"/></ns0:nvPr></ns0:nvSpPr><ns0:spPr><ns2:xfrm xmlns:ns2="http://schemas.openxmlformats.org/drawingml/2006/main"><ns2:off x="10972800" y="6446520"/><ns2:ext cx="1097280" cy="274320"/></ns2:xfrm></ns0:spPr><ns0:txBody><ns3:bodyPr xmlns:ns3="http://schemas.openxmlformats.org/drawingml/2006/main" wrap="square" anchor="t" anchorCtr="0"/><ns4:lstStyle xmlns:ns4="http://schemas.openxmlformats.org/drawingml/2006/main"><ns4:defPPr algn="r"><ns4:buNone/><ns4:defRPr sz="1000" dirty="0"><ns4:solidFill><ns4:srgbClr val="94A3B8"/></ns4:solidFill><ns4:latin typeface="Calibri"/><ns4:ea typeface="Calibri"/></ns4:defRPr></ns4:defPPr><ns4:lvl1pPr algn="r"><ns4:buNone/><ns4:defRPr sz="1000" dirty="0"><ns4:solidFill><ns4:srgbClr val="94A3B8"/></ns4:solidFill><ns4:latin typeface="Calibri"/><ns4:ea typeface="Calibri"/></ns4:defRPr></ns4:lvl1pPr><ns4:lvl2pPr algn="r"><ns4:buNone/><ns4:defRPr sz="1000" dirty="0"><ns4:solidFill><ns4:srgbClr val="94A3B8"/></ns4:solidFill><ns4:latin typeface="Calibri"/><ns4:ea typeface="Calibri"/></ns4:defRPr></ns4:lvl2pPr><ns4:lvl3pPr algn="r"><ns4:buNone/><ns4:defRPr sz="1000" dirty="0"><ns4:solidFill><ns4:srgbClr val="94A3B8"/></ns4:solidFill><ns4:latin typeface="Calibri"/><ns4:ea typeface="Calibri"/></ns4:defRPr></ns4:lvl3pPr><ns4:lvl4pPr algn="r"><ns4:buNone/><ns4:defRPr sz="1000" dirty="0"><ns4:solidFill><ns4:srgbClr val="94A3B8"/></ns4:solidFill><ns4:latin typeface="Calibri"/><ns4:ea typeface="Calibri"/></ns4:defRPr></ns4:lvl4pPr><ns4:lvl5pPr algn="r"><ns4:buNone/><ns4:defRPr sz="1000" dirty="0"><ns4:solidFill><ns4:srgbClr val="94A3B8"/></ns4:solidFill><ns4:latin typeface="Calibri"/><ns4:ea typeface="Calibri"/></ns4:defRPr></ns4:lvl5pPr><ns4:lvl6pPr algn="r"><ns4:buNone/><ns4:defRPr sz="1000" dirty="0"><ns4:solidFill><ns4:srgbClr val="94A3B8"/></ns4:solidFill><ns4:latin typeface="Calibri"/><ns4:ea typeface="Calibri"/></ns4:defRPr></ns4:lvl6pPr><ns4:lvl7pPr algn="r"><ns4:buNone/><ns4:defRPr sz="1000" dirty="0"><ns4:solidFill><ns4:srgbClr val="94A3B8"/></ns4:solidFill><ns4:latin typeface="Calibri"/><ns4:ea typeface="Calibri"/></ns4:defRPr></ns4:lvl7pPr><ns4:lvl8pPr algn="r"><ns4:buNone/><ns4:defRPr sz="1000" dirty="0"><ns4:solidFill><ns4:srgbClr val="94A3B8"/></ns4:solidFill><ns4:latin typeface="Calibri"/><ns4:ea typeface="Calibri"/></ns4:defRPr></ns4:lvl8pPr><ns4:lvl9pPr algn="r"><ns4:buNone/><ns4:defRPr sz="1000" dirty="0"><ns4:solidFill><ns4:srgbClr val="94A3B8"/></ns4:solidFill><ns4:latin typeface="Calibri"/><ns4:ea typeface="Calibri"/></ns4:defRPr></ns4:lvl9pPr></ns4:lstStyle><ns5:p xmlns:ns5="http://schemas.openxmlformats.org/drawingml/2006/main"><ns5:pPr algn="r"><ns5:buNone/></ns5:pPr><ns5:r><ns5:rPr lang="ja-JP"/><ns5:t>&lt;#&gt;</ns5:t></ns5:r></ns5:p></ns0:txBody></ns0:sp></ns0:spTree></ns0:cSld><ns0:clrMapOvr/></ns0:sldLayout>
+説明テキスト</ns5:t></ns5:r></ns5:p></ns0:txBody></ns0:sp><ns0:sp><ns0:nvSpPr><ns0:cNvPr id="30" name="SlideNum.Footer"/><ns0:cNvSpPr><ns1:spLocks xmlns:ns1="http://schemas.openxmlformats.org/drawingml/2006/main" noGrp="1"/></ns0:cNvSpPr><ns0:nvPr><ns0:ph idx="50" type="sldNum"/></ns0:nvPr></ns0:nvSpPr><ns0:spPr><ns2:xfrm xmlns:ns2="http://schemas.openxmlformats.org/drawingml/2006/main"><ns2:off x="10972800" y="6446520"/><ns2:ext cx="1097280" cy="274320"/></ns2:xfrm></ns0:spPr><ns0:txBody><ns3:bodyPr xmlns:ns3="http://schemas.openxmlformats.org/drawingml/2006/main" wrap="square" anchor="t" anchorCtr="0"/><ns4:lstStyle><ns4:defPPr algn="r"><ns4:defRPr sz="1000"><ns4:solidFill><ns4:srgbClr val="94A3B8"/></ns4:solidFill></ns4:defRPr></ns4:defPPr></ns4:lstStyle><ns4:defPPr algn="r"><ns4:buNone/><ns4:defRPr sz="1000" dirty="0"><ns4:solidFill><ns4:srgbClr val="94A3B8"/></ns4:solidFill><ns4:latin typeface="Calibri"/><ns4:ea typeface="Calibri"/></ns4:defRPr></ns4:defPPr><ns4:lvl1pPr algn="r"><ns4:buNone/><ns4:defRPr sz="1000" dirty="0"><ns4:solidFill><ns4:srgbClr val="94A3B8"/></ns4:solidFill><ns4:latin typeface="Calibri"/><ns4:ea typeface="Calibri"/></ns4:defRPr></ns4:lvl1pPr><ns4:lvl2pPr algn="r"><ns4:buNone/><ns4:defRPr sz="1000" dirty="0"><ns4:solidFill><ns4:srgbClr val="94A3B8"/></ns4:solidFill><ns4:latin typeface="Calibri"/><ns4:ea typeface="Calibri"/></ns4:defRPr></ns4:lvl2pPr><ns4:lvl3pPr algn="r"><ns4:buNone/><ns4:defRPr sz="1000" dirty="0"><ns4:solidFill><ns4:srgbClr val="94A3B8"/></ns4:solidFill><ns4:latin typeface="Calibri"/><ns4:ea typeface="Calibri"/></ns4:defRPr></ns4:lvl3pPr><ns4:lvl4pPr algn="r"><ns4:buNone/><ns4:defRPr sz="1000" dirty="0"><ns4:solidFill><ns4:srgbClr val="94A3B8"/></ns4:solidFill><ns4:latin typeface="Calibri"/><ns4:ea typeface="Calibri"/></ns4:defRPr></ns4:lvl4pPr><ns4:lvl5pPr algn="r"><ns4:buNone/><ns4:defRPr sz="1000" dirty="0"><ns4:solidFill><ns4:srgbClr val="94A3B8"/></ns4:solidFill><ns4:latin typeface="Calibri"/><ns4:ea typeface="Calibri"/></ns4:defRPr></ns4:lvl5pPr><ns4:lvl6pPr algn="r"><ns4:buNone/><ns4:defRPr sz="1000" dirty="0"><ns4:solidFill><ns4:srgbClr val="94A3B8"/></ns4:solidFill><ns4:latin typeface="Calibri"/><ns4:ea typeface="Calibri"/></ns4:defRPr></ns4:lvl6pPr><ns4:lvl7pPr algn="r"><ns4:buNone/><ns4:defRPr sz="1000" dirty="0"><ns4:solidFill><ns4:srgbClr val="94A3B8"/></ns4:solidFill><ns4:latin typeface="Calibri"/><ns4:ea typeface="Calibri"/></ns4:defRPr></ns4:lvl7pPr><ns4:lvl8pPr algn="r"><ns4:buNone/><ns4:defRPr sz="1000" dirty="0"><ns4:solidFill><ns4:srgbClr val="94A3B8"/></ns4:solidFill><ns4:latin typeface="Calibri"/><ns4:ea typeface="Calibri"/></ns4:defRPr></ns4:lvl8pPr><ns4:lvl9pPr algn="r"><ns4:buNone/><ns4:defRPr sz="1000" dirty="0"><ns4:solidFill><ns4:srgbClr val="94A3B8"/></ns4:solidFill><ns4:latin typeface="Calibri"/><ns4:ea typeface="Calibri"/></ns4:defRPr></ns4:lvl9pPr></ns4:lstStyle><ns5:p xmlns:ns5="http://schemas.openxmlformats.org/drawingml/2006/main"><ns5:pPr algn="r"><ns5:buNone/></ns5:pPr><ns5:r><ns5:rPr lang="ja-JP"/><ns5:t>&lt;#&gt;</ns5:t></ns5:r></ns5:p></ns0:txBody></ns0:sp></ns0:spTree></ns0:cSld><ns0:clrMapOvr/></ns0:sldLayout>
 </file>
 
 <file path=ppt/slideLayouts/slideLayout26.xml><?xml version='1.0' encoding='UTF-8' standalone='yes'?>
-<ns0:sldLayout xmlns:ns0="http://schemas.openxmlformats.org/presentationml/2006/main" type="blank" preserve="1"><ns0:cSld name="Process.3Step.Sequential"><ns0:spTree><ns0:nvGrpSpPr><ns0:cNvPr id="1" name=""/><ns0:cNvGrpSpPr/><ns0:nvPr/></ns0:nvGrpSpPr><ns0:grpSpPr><ns1:xfrm xmlns:ns1="http://schemas.openxmlformats.org/drawingml/2006/main"><ns1:off x="0" y="0"/><ns1:ext cx="0" cy="0"/><ns1:chOff x="0" y="0"/><ns1:chExt cx="0" cy="0"/></ns1:xfrm></ns0:grpSpPr><ns0:sp><ns0:nvSpPr><ns0:cNvPr id="2" name="HeaderBar"/><ns0:cNvSpPr><ns1:spLocks xmlns:ns1="http://schemas.openxmlformats.org/drawingml/2006/main" noGrp="1" noSelect="0" noRot="1" noMove="1"/></ns0:cNvSpPr><ns0:nvPr/></ns0:nvSpPr><ns0:spPr><ns2:xfrm xmlns:ns2="http://schemas.openxmlformats.org/drawingml/2006/main"><ns2:off x="0" y="0"/><ns2:ext cx="12192000" cy="1051560"/></ns2:xfrm><ns3:prstGeom xmlns:ns3="http://schemas.openxmlformats.org/drawingml/2006/main" prst="rect"/><ns4:solidFill xmlns:ns4="http://schemas.openxmlformats.org/drawingml/2006/main"><ns4:srgbClr val="1E2761"/></ns4:solidFill><ns5:ln xmlns:ns5="http://schemas.openxmlformats.org/drawingml/2006/main"><ns5:noFill/></ns5:ln></ns0:spPr></ns0:sp><ns0:sp><ns0:nvSpPr><ns0:cNvPr id="10" name="SlideTitle.Header"/><ns0:cNvSpPr><ns1:spLocks xmlns:ns1="http://schemas.openxmlformats.org/drawingml/2006/main" noGrp="1"/></ns0:cNvSpPr><ns0:nvPr><ns0:ph idx="15" type="body"/></ns0:nvPr></ns0:nvSpPr><ns0:spPr><ns2:xfrm xmlns:ns2="http://schemas.openxmlformats.org/drawingml/2006/main"><ns2:off x="731520" y="91440"/><ns2:ext cx="9144000" cy="475488"/></ns2:xfrm></ns0:spPr><ns0:txBody><ns3:bodyPr xmlns:ns3="http://schemas.openxmlformats.org/drawingml/2006/main" wrap="square" anchor="t" anchorCtr="0"/><ns4:lstStyle xmlns:ns4="http://schemas.openxmlformats.org/drawingml/2006/main"><ns4:defPPr algn="l"><ns4:buNone/><ns4:defRPr sz="2800" dirty="0" b="1"><ns4:solidFill><ns4:srgbClr val="FFFFFF"/></ns4:solidFill><ns4:latin typeface="Georgia"/><ns4:ea typeface="Georgia"/></ns4:defRPr></ns4:defPPr><ns4:lvl1pPr algn="l"><ns4:buNone/><ns4:defRPr sz="2800" dirty="0" b="1"><ns4:solidFill><ns4:srgbClr val="FFFFFF"/></ns4:solidFill><ns4:latin typeface="Georgia"/><ns4:ea typeface="Georgia"/></ns4:defRPr></ns4:lvl1pPr><ns4:lvl2pPr algn="l"><ns4:buNone/><ns4:defRPr sz="2800" dirty="0" b="1"><ns4:solidFill><ns4:srgbClr val="FFFFFF"/></ns4:solidFill><ns4:latin typeface="Georgia"/><ns4:ea typeface="Georgia"/></ns4:defRPr></ns4:lvl2pPr><ns4:lvl3pPr algn="l"><ns4:buNone/><ns4:defRPr sz="2800" dirty="0" b="1"><ns4:solidFill><ns4:srgbClr val="FFFFFF"/></ns4:solidFill><ns4:latin typeface="Georgia"/><ns4:ea typeface="Georgia"/></ns4:defRPr></ns4:lvl3pPr><ns4:lvl4pPr algn="l"><ns4:buNone/><ns4:defRPr sz="2800" dirty="0" b="1"><ns4:solidFill><ns4:srgbClr val="FFFFFF"/></ns4:solidFill><ns4:latin typeface="Georgia"/><ns4:ea typeface="Georgia"/></ns4:defRPr></ns4:lvl4pPr><ns4:lvl5pPr algn="l"><ns4:buNone/><ns4:defRPr sz="2800" dirty="0" b="1"><ns4:solidFill><ns4:srgbClr val="FFFFFF"/></ns4:solidFill><ns4:latin typeface="Georgia"/><ns4:ea typeface="Georgia"/></ns4:defRPr></ns4:lvl5pPr><ns4:lvl6pPr algn="l"><ns4:buNone/><ns4:defRPr sz="2800" dirty="0" b="1"><ns4:solidFill><ns4:srgbClr val="FFFFFF"/></ns4:solidFill><ns4:latin typeface="Georgia"/><ns4:ea typeface="Georgia"/></ns4:defRPr></ns4:lvl6pPr><ns4:lvl7pPr algn="l"><ns4:buNone/><ns4:defRPr sz="2800" dirty="0" b="1"><ns4:solidFill><ns4:srgbClr val="FFFFFF"/></ns4:solidFill><ns4:latin typeface="Georgia"/><ns4:ea typeface="Georgia"/></ns4:defRPr></ns4:lvl7pPr><ns4:lvl8pPr algn="l"><ns4:buNone/><ns4:defRPr sz="2800" dirty="0" b="1"><ns4:solidFill><ns4:srgbClr val="FFFFFF"/></ns4:solidFill><ns4:latin typeface="Georgia"/><ns4:ea typeface="Georgia"/></ns4:defRPr></ns4:lvl8pPr><ns4:lvl9pPr algn="l"><ns4:buNone/><ns4:defRPr sz="2800" dirty="0" b="1"><ns4:solidFill><ns4:srgbClr val="FFFFFF"/></ns4:solidFill><ns4:latin typeface="Georgia"/><ns4:ea typeface="Georgia"/></ns4:defRPr></ns4:lvl9pPr></ns4:lstStyle/><ns5:p xmlns:ns5="http://schemas.openxmlformats.org/drawingml/2006/main"><ns5:pPr algn="l"><ns5:buNone/></ns5:pPr><ns5:r><ns5:rPr lang="ja-JP"/><ns5:t>サブタイトル</ns5:t></ns5:r></ns5:p></ns0:txBody></ns0:sp><ns0:sp><ns0:nvSpPr><ns0:cNvPr id="5" name="VLine"/><ns0:cNvSpPr><ns1:spLocks xmlns:ns1="http://schemas.openxmlformats.org/drawingml/2006/main" noGrp="1" noSelect="0" noRot="1" noMove="1"/></ns0:cNvSpPr><ns0:nvPr/></ns0:nvSpPr><ns0:spPr><ns2:xfrm xmlns:ns2="http://schemas.openxmlformats.org/drawingml/2006/main"><ns2:off x="1828800" y="1645920"/><ns2:ext cx="36576" cy="4389120"/></ns2:xfrm><ns3:prstGeom xmlns:ns3="http://schemas.openxmlformats.org/drawingml/2006/main" prst="rect"/><ns4:solidFill xmlns:ns4="http://schemas.openxmlformats.org/drawingml/2006/main"><ns4:srgbClr val="CADCFC"/></ns4:solidFill><ns5:ln xmlns:ns5="http://schemas.openxmlformats.org/drawingml/2006/main"><ns5:noFill/></ns5:ln></ns0:spPr></ns0:sp><ns0:sp><ns0:nvSpPr><ns0:cNvPr id="6" name="S1"/><ns0:cNvSpPr><ns1:spLocks xmlns:ns1="http://schemas.openxmlformats.org/drawingml/2006/main" noGrp="1"/></ns0:cNvSpPr><ns0:nvPr/></ns0:nvSpPr><ns0:spPr><ns2:xfrm xmlns:ns2="http://schemas.openxmlformats.org/drawingml/2006/main"><ns2:off x="1688977066032" y="1839479990832"/><ns2:ext cx="402336" cy="402336"/></ns2:xfrm><ns3:prstGeom xmlns:ns3="http://schemas.openxmlformats.org/drawingml/2006/main" prst="ellipse"/><ns4:solidFill xmlns:ns4="http://schemas.openxmlformats.org/drawingml/2006/main"><ns4:srgbClr val="3B82F6"/></ns4:solidFill><ns5:ln xmlns:ns5="http://schemas.openxmlformats.org/drawingml/2006/main"><ns5:noFill/></ns5:ln></ns0:spPr></ns0:sp><ns0:sp><ns0:nvSpPr><ns0:cNvPr id="7" name="S2"/><ns0:cNvSpPr><ns1:spLocks xmlns:ns1="http://schemas.openxmlformats.org/drawingml/2006/main" noGrp="1"/></ns0:cNvSpPr><ns0:nvPr/></ns0:nvSpPr><ns0:spPr><ns2:xfrm xmlns:ns2="http://schemas.openxmlformats.org/drawingml/2006/main"><ns2:off x="1688977066032" y="3177283766832"/><ns2:ext cx="402336" cy="402336"/></ns2:xfrm><ns3:prstGeom xmlns:ns3="http://schemas.openxmlformats.org/drawingml/2006/main" prst="ellipse"/><ns4:solidFill xmlns:ns4="http://schemas.openxmlformats.org/drawingml/2006/main"><ns4:srgbClr val="3B82F6"/></ns4:solidFill><ns5:ln xmlns:ns5="http://schemas.openxmlformats.org/drawingml/2006/main"><ns5:noFill/></ns5:ln></ns0:spPr></ns0:sp><ns0:sp><ns0:nvSpPr><ns0:cNvPr id="8" name="S3"/><ns0:cNvSpPr><ns1:spLocks xmlns:ns1="http://schemas.openxmlformats.org/drawingml/2006/main" noGrp="1"/></ns0:cNvSpPr><ns0:nvPr/></ns0:nvSpPr><ns0:spPr><ns2:xfrm xmlns:ns2="http://schemas.openxmlformats.org/drawingml/2006/main"><ns2:off x="1688977066032" y="4515087542832"/><ns2:ext cx="402336" cy="402336"/></ns2:xfrm><ns3:prstGeom xmlns:ns3="http://schemas.openxmlformats.org/drawingml/2006/main" prst="ellipse"/><ns4:solidFill xmlns:ns4="http://schemas.openxmlformats.org/drawingml/2006/main"><ns4:srgbClr val="3B82F6"/></ns4:solidFill><ns5:ln xmlns:ns5="http://schemas.openxmlformats.org/drawingml/2006/main"><ns5:noFill/></ns5:ln></ns0:spPr></ns0:sp><ns0:sp><ns0:nvSpPr><ns0:cNvPr id="20" name="Step1.Top"/><ns0:cNvSpPr><ns1:spLocks xmlns:ns1="http://schemas.openxmlformats.org/drawingml/2006/main" noGrp="1"/></ns0:cNvSpPr><ns0:nvPr><ns0:ph idx="1" type="body"/></ns0:nvPr></ns0:nvSpPr><ns0:spPr><ns2:xfrm xmlns:ns2="http://schemas.openxmlformats.org/drawingml/2006/main"><ns2:off x="2560320" y="1554480"/><ns2:ext cx="8686800" cy="1097280"/></ns2:xfrm></ns0:spPr><ns0:txBody><ns3:bodyPr xmlns:ns3="http://schemas.openxmlformats.org/drawingml/2006/main" wrap="square" anchor="t" anchorCtr="0"/><ns4:lstStyle xmlns:ns4="http://schemas.openxmlformats.org/drawingml/2006/main"><ns4:defPPr algn="l"><ns4:buNone/><ns4:defRPr sz="1400" dirty="0"><ns4:solidFill><ns4:srgbClr val="1E293B"/></ns4:solidFill><ns4:latin typeface="Calibri"/><ns4:ea typeface="Calibri"/></ns4:defRPr></ns4:defPPr><ns4:lvl1pPr algn="l"><ns4:buNone/><ns4:defRPr sz="1400" dirty="0"><ns4:solidFill><ns4:srgbClr val="1E293B"/></ns4:solidFill><ns4:latin typeface="Calibri"/><ns4:ea typeface="Calibri"/></ns4:defRPr></ns4:lvl1pPr><ns4:lvl2pPr algn="l"><ns4:buNone/><ns4:defRPr sz="1400" dirty="0"><ns4:solidFill><ns4:srgbClr val="1E293B"/></ns4:solidFill><ns4:latin typeface="Calibri"/><ns4:ea typeface="Calibri"/></ns4:defRPr></ns4:lvl2pPr><ns4:lvl3pPr algn="l"><ns4:buNone/><ns4:defRPr sz="1400" dirty="0"><ns4:solidFill><ns4:srgbClr val="1E293B"/></ns4:solidFill><ns4:latin typeface="Calibri"/><ns4:ea typeface="Calibri"/></ns4:defRPr></ns4:lvl3pPr><ns4:lvl4pPr algn="l"><ns4:buNone/><ns4:defRPr sz="1400" dirty="0"><ns4:solidFill><ns4:srgbClr val="1E293B"/></ns4:solidFill><ns4:latin typeface="Calibri"/><ns4:ea typeface="Calibri"/></ns4:defRPr></ns4:lvl4pPr><ns4:lvl5pPr algn="l"><ns4:buNone/><ns4:defRPr sz="1400" dirty="0"><ns4:solidFill><ns4:srgbClr val="1E293B"/></ns4:solidFill><ns4:latin typeface="Calibri"/><ns4:ea typeface="Calibri"/></ns4:defRPr></ns4:lvl5pPr><ns4:lvl6pPr algn="l"><ns4:buNone/><ns4:defRPr sz="1400" dirty="0"><ns4:solidFill><ns4:srgbClr val="1E293B"/></ns4:solidFill><ns4:latin typeface="Calibri"/><ns4:ea typeface="Calibri"/></ns4:defRPr></ns4:lvl6pPr><ns4:lvl7pPr algn="l"><ns4:buNone/><ns4:defRPr sz="1400" dirty="0"><ns4:solidFill><ns4:srgbClr val="1E293B"/></ns4:solidFill><ns4:latin typeface="Calibri"/><ns4:ea typeface="Calibri"/></ns4:defRPr></ns4:lvl7pPr><ns4:lvl8pPr algn="l"><ns4:buNone/><ns4:defRPr sz="1400" dirty="0"><ns4:solidFill><ns4:srgbClr val="1E293B"/></ns4:solidFill><ns4:latin typeface="Calibri"/><ns4:ea typeface="Calibri"/></ns4:defRPr></ns4:lvl8pPr><ns4:lvl9pPr algn="l"><ns4:buNone/><ns4:defRPr sz="1400" dirty="0"><ns4:solidFill><ns4:srgbClr val="1E293B"/></ns4:solidFill><ns4:latin typeface="Calibri"/><ns4:ea typeface="Calibri"/></ns4:defRPr></ns4:lvl9pPr></ns4:lstStyle/><ns5:p xmlns:ns5="http://schemas.openxmlformats.org/drawingml/2006/main"><ns5:pPr algn="l"><ns5:buNone/></ns5:pPr><ns5:r><ns5:rPr lang="ja-JP"/><ns5:t>ステップ 2：タイトル
-説明テキスト</ns5:t></ns5:r></ns5:p></ns0:txBody></ns0:sp><ns0:sp><ns0:nvSpPr><ns0:cNvPr id="22" name="Step3.Bottom"/><ns0:cNvSpPr><ns1:spLocks xmlns:ns1="http://schemas.openxmlformats.org/drawingml/2006/main" noGrp="1"/></ns0:cNvSpPr><ns0:nvPr><ns0:ph idx="3" type="body"/></ns0:nvPr></ns0:nvSpPr><ns0:spPr><ns2:xfrm xmlns:ns2="http://schemas.openxmlformats.org/drawingml/2006/main"><ns2:off x="2560320" y="4480560"/><ns2:ext cx="8686800" cy="1097280"/></ns2:xfrm></ns0:spPr><ns0:txBody><ns3:bodyPr xmlns:ns3="http://schemas.openxmlformats.org/drawingml/2006/main" wrap="square" anchor="t" anchorCtr="0"/><ns4:lstStyle xmlns:ns4="http://schemas.openxmlformats.org/drawingml/2006/main"><ns4:defPPr algn="l"><ns4:buNone/><ns4:defRPr sz="1400" dirty="0"><ns4:solidFill><ns4:srgbClr val="1E293B"/></ns4:solidFill><ns4:latin typeface="Calibri"/><ns4:ea typeface="Calibri"/></ns4:defRPr></ns4:defPPr><ns4:lvl1pPr algn="l"><ns4:buNone/><ns4:defRPr sz="1400" dirty="0"><ns4:solidFill><ns4:srgbClr val="1E293B"/></ns4:solidFill><ns4:latin typeface="Calibri"/><ns4:ea typeface="Calibri"/></ns4:defRPr></ns4:lvl1pPr><ns4:lvl2pPr algn="l"><ns4:buNone/><ns4:defRPr sz="1400" dirty="0"><ns4:solidFill><ns4:srgbClr val="1E293B"/></ns4:solidFill><ns4:latin typeface="Calibri"/><ns4:ea typeface="Calibri"/></ns4:defRPr></ns4:lvl2pPr><ns4:lvl3pPr algn="l"><ns4:buNone/><ns4:defRPr sz="1400" dirty="0"><ns4:solidFill><ns4:srgbClr val="1E293B"/></ns4:solidFill><ns4:latin typeface="Calibri"/><ns4:ea typeface="Calibri"/></ns4:defRPr></ns4:lvl3pPr><ns4:lvl4pPr algn="l"><ns4:buNone/><ns4:defRPr sz="1400" dirty="0"><ns4:solidFill><ns4:srgbClr val="1E293B"/></ns4:solidFill><ns4:latin typeface="Calibri"/><ns4:ea typeface="Calibri"/></ns4:defRPr></ns4:lvl4pPr><ns4:lvl5pPr algn="l"><ns4:buNone/><ns4:defRPr sz="1400" dirty="0"><ns4:solidFill><ns4:srgbClr val="1E293B"/></ns4:solidFill><ns4:latin typeface="Calibri"/><ns4:ea typeface="Calibri"/></ns4:defRPr></ns4:lvl5pPr><ns4:lvl6pPr algn="l"><ns4:buNone/><ns4:defRPr sz="1400" dirty="0"><ns4:solidFill><ns4:srgbClr val="1E293B"/></ns4:solidFill><ns4:latin typeface="Calibri"/><ns4:ea typeface="Calibri"/></ns4:defRPr></ns4:lvl6pPr><ns4:lvl7pPr algn="l"><ns4:buNone/><ns4:defRPr sz="1400" dirty="0"><ns4:solidFill><ns4:srgbClr val="1E293B"/></ns4:solidFill><ns4:latin typeface="Calibri"/><ns4:ea typeface="Calibri"/></ns4:defRPr></ns4:lvl7pPr><ns4:lvl8pPr algn="l"><ns4:buNone/><ns4:defRPr sz="1400" dirty="0"><ns4:solidFill><ns4:srgbClr val="1E293B"/></ns4:solidFill><ns4:latin typeface="Calibri"/><ns4:ea typeface="Calibri"/></ns4:defRPr></ns4:lvl8pPr><ns4:lvl9pPr algn="l"><ns4:buNone/><ns4:defRPr sz="1400" dirty="0"><ns4:solidFill><ns4:srgbClr val="1E293B"/></ns4:solidFill><ns4:latin typeface="Calibri"/><ns4:ea typeface="Calibri"/></ns4:defRPr></ns4:lvl9pPr></ns4:lstStyle/><ns5:p xmlns:ns5="http://schemas.openxmlformats.org/drawingml/2006/main"><ns5:pPr algn="r"><ns5:buNone/></ns5:pPr><ns5:r><ns5:rPr lang="ja-JP"/><ns5:t>&lt;#&gt;</ns5:t></ns5:r></ns5:p></ns0:txBody></ns0:sp></ns0:spTree></ns0:cSld><ns0:clrMapOvr/></ns0:sldLayout>
+<ns0:sldLayout xmlns:ns0="http://schemas.openxmlformats.org/presentationml/2006/main" type="blank" preserve="1"><ns0:cSld name="Process.3Step.Sequential"><ns0:spTree><ns0:nvGrpSpPr><ns0:cNvPr id="1" name=""/><ns0:cNvGrpSpPr/><ns0:nvPr/></ns0:nvGrpSpPr><ns0:grpSpPr><ns1:xfrm xmlns:ns1="http://schemas.openxmlformats.org/drawingml/2006/main"><ns1:off x="0" y="0"/><ns1:ext cx="0" cy="0"/><ns1:chOff x="0" y="0"/><ns1:chExt cx="0" cy="0"/></ns1:xfrm></ns0:grpSpPr><ns0:sp><ns0:nvSpPr><ns0:cNvPr id="2" name="HeaderBar"/><ns0:cNvSpPr><ns1:spLocks xmlns:ns1="http://schemas.openxmlformats.org/drawingml/2006/main" noGrp="1" noSelect="0" noRot="1" noMove="1"/></ns0:cNvSpPr><ns0:nvPr/></ns0:nvSpPr><ns0:spPr><ns2:xfrm xmlns:ns2="http://schemas.openxmlformats.org/drawingml/2006/main"><ns2:off x="0" y="0"/><ns2:ext cx="12192000" cy="1051560"/></ns2:xfrm><ns3:prstGeom xmlns:ns3="http://schemas.openxmlformats.org/drawingml/2006/main" prst="rect"/><ns4:solidFill xmlns:ns4="http://schemas.openxmlformats.org/drawingml/2006/main"><ns4:srgbClr val="1E2761"/></ns4:solidFill><ns5:ln xmlns:ns5="http://schemas.openxmlformats.org/drawingml/2006/main"><ns5:noFill/></ns5:ln></ns0:spPr></ns0:sp><ns0:sp><ns0:nvSpPr><ns0:cNvPr id="10" name="SlideTitle.Header"/><ns0:cNvSpPr><ns1:spLocks xmlns:ns1="http://schemas.openxmlformats.org/drawingml/2006/main" noGrp="1"/></ns0:cNvSpPr><ns0:nvPr><ns0:ph idx="15" type="body"/></ns0:nvPr></ns0:nvSpPr><ns0:spPr><ns2:xfrm xmlns:ns2="http://schemas.openxmlformats.org/drawingml/2006/main"><ns2:off x="731520" y="91440"/><ns2:ext cx="9144000" cy="475488"/></ns2:xfrm></ns0:spPr><ns0:txBody><ns3:bodyPr xmlns:ns3="http://schemas.openxmlformats.org/drawingml/2006/main" wrap="square" anchor="t" anchorCtr="0"/><ns4:lstStyle><ns4:defPPr><ns4:defRPr sz="2800" b="1"><ns4:solidFill><ns4:srgbClr val="FFFFFF"/></ns4:solidFill></ns4:defRPr></ns4:defPPr></ns4:lstStyle><ns4:defPPr algn="l"><ns4:buNone/><ns4:defRPr sz="2800" dirty="0" b="1"><ns4:solidFill><ns4:srgbClr val="FFFFFF"/></ns4:solidFill><ns4:latin typeface="Georgia"/><ns4:ea typeface="Georgia"/></ns4:defRPr></ns4:defPPr><ns4:lvl1pPr algn="l"><ns4:buNone/><ns4:defRPr sz="2800" dirty="0" b="1"><ns4:solidFill><ns4:srgbClr val="FFFFFF"/></ns4:solidFill><ns4:latin typeface="Georgia"/><ns4:ea typeface="Georgia"/></ns4:defRPr></ns4:lvl1pPr><ns4:lvl2pPr algn="l"><ns4:buNone/><ns4:defRPr sz="2800" dirty="0" b="1"><ns4:solidFill><ns4:srgbClr val="FFFFFF"/></ns4:solidFill><ns4:latin typeface="Georgia"/><ns4:ea typeface="Georgia"/></ns4:defRPr></ns4:lvl2pPr><ns4:lvl3pPr algn="l"><ns4:buNone/><ns4:defRPr sz="2800" dirty="0" b="1"><ns4:solidFill><ns4:srgbClr val="FFFFFF"/></ns4:solidFill><ns4:latin typeface="Georgia"/><ns4:ea typeface="Georgia"/></ns4:defRPr></ns4:lvl3pPr><ns4:lvl4pPr algn="l"><ns4:buNone/><ns4:defRPr sz="2800" dirty="0" b="1"><ns4:solidFill><ns4:srgbClr val="FFFFFF"/></ns4:solidFill><ns4:latin typeface="Georgia"/><ns4:ea typeface="Georgia"/></ns4:defRPr></ns4:lvl4pPr><ns4:lvl5pPr algn="l"><ns4:buNone/><ns4:defRPr sz="2800" dirty="0" b="1"><ns4:solidFill><ns4:srgbClr val="FFFFFF"/></ns4:solidFill><ns4:latin typeface="Georgia"/><ns4:ea typeface="Georgia"/></ns4:defRPr></ns4:lvl5pPr><ns4:lvl6pPr algn="l"><ns4:buNone/><ns4:defRPr sz="2800" dirty="0" b="1"><ns4:solidFill><ns4:srgbClr val="FFFFFF"/></ns4:solidFill><ns4:latin typeface="Georgia"/><ns4:ea typeface="Georgia"/></ns4:defRPr></ns4:lvl6pPr><ns4:lvl7pPr algn="l"><ns4:buNone/><ns4:defRPr sz="2800" dirty="0" b="1"><ns4:solidFill><ns4:srgbClr val="FFFFFF"/></ns4:solidFill><ns4:latin typeface="Georgia"/><ns4:ea typeface="Georgia"/></ns4:defRPr></ns4:lvl7pPr><ns4:lvl8pPr algn="l"><ns4:buNone/><ns4:defRPr sz="2800" dirty="0" b="1"><ns4:solidFill><ns4:srgbClr val="FFFFFF"/></ns4:solidFill><ns4:latin typeface="Georgia"/><ns4:ea typeface="Georgia"/></ns4:defRPr></ns4:lvl8pPr><ns4:lvl9pPr algn="l"><ns4:buNone/><ns4:defRPr sz="2800" dirty="0" b="1"><ns4:solidFill><ns4:srgbClr val="FFFFFF"/></ns4:solidFill><ns4:latin typeface="Georgia"/><ns4:ea typeface="Georgia"/></ns4:defRPr></ns4:lvl9pPr></ns4:lstStyle/><ns5:p xmlns:ns5="http://schemas.openxmlformats.org/drawingml/2006/main"><ns5:pPr algn="l"><ns5:buNone/></ns5:pPr><ns5:r><ns5:rPr lang="ja-JP"/><ns5:t>サブタイトル</ns5:t></ns5:r></ns5:p></ns0:txBody></ns0:sp><ns0:sp><ns0:nvSpPr><ns0:cNvPr id="5" name="VLine"/><ns0:cNvSpPr><ns1:spLocks xmlns:ns1="http://schemas.openxmlformats.org/drawingml/2006/main" noGrp="1" noSelect="0" noRot="1" noMove="1"/></ns0:cNvSpPr><ns0:nvPr/></ns0:nvSpPr><ns0:spPr><ns2:xfrm xmlns:ns2="http://schemas.openxmlformats.org/drawingml/2006/main"><ns2:off x="1828800" y="1645920"/><ns2:ext cx="36576" cy="4389120"/></ns2:xfrm><ns3:prstGeom xmlns:ns3="http://schemas.openxmlformats.org/drawingml/2006/main" prst="rect"/><ns4:solidFill xmlns:ns4="http://schemas.openxmlformats.org/drawingml/2006/main"><ns4:srgbClr val="CADCFC"/></ns4:solidFill><ns5:ln xmlns:ns5="http://schemas.openxmlformats.org/drawingml/2006/main"><ns5:noFill/></ns5:ln></ns0:spPr></ns0:sp><ns0:sp><ns0:nvSpPr><ns0:cNvPr id="6" name="S1"/><ns0:cNvSpPr><ns1:spLocks xmlns:ns1="http://schemas.openxmlformats.org/drawingml/2006/main" noGrp="1"/></ns0:cNvSpPr><ns0:nvPr/></ns0:nvSpPr><ns0:spPr><ns2:xfrm xmlns:ns2="http://schemas.openxmlformats.org/drawingml/2006/main"><ns2:off x="1688977066032" y="1839479990832"/><ns2:ext cx="402336" cy="402336"/></ns2:xfrm><ns3:prstGeom xmlns:ns3="http://schemas.openxmlformats.org/drawingml/2006/main" prst="ellipse"/><ns4:solidFill xmlns:ns4="http://schemas.openxmlformats.org/drawingml/2006/main"><ns4:srgbClr val="3B82F6"/></ns4:solidFill><ns5:ln xmlns:ns5="http://schemas.openxmlformats.org/drawingml/2006/main"><ns5:noFill/></ns5:ln></ns0:spPr></ns0:sp><ns0:sp><ns0:nvSpPr><ns0:cNvPr id="7" name="S2"/><ns0:cNvSpPr><ns1:spLocks xmlns:ns1="http://schemas.openxmlformats.org/drawingml/2006/main" noGrp="1"/></ns0:cNvSpPr><ns0:nvPr/></ns0:nvSpPr><ns0:spPr><ns2:xfrm xmlns:ns2="http://schemas.openxmlformats.org/drawingml/2006/main"><ns2:off x="1688977066032" y="3177283766832"/><ns2:ext cx="402336" cy="402336"/></ns2:xfrm><ns3:prstGeom xmlns:ns3="http://schemas.openxmlformats.org/drawingml/2006/main" prst="ellipse"/><ns4:solidFill xmlns:ns4="http://schemas.openxmlformats.org/drawingml/2006/main"><ns4:srgbClr val="3B82F6"/></ns4:solidFill><ns5:ln xmlns:ns5="http://schemas.openxmlformats.org/drawingml/2006/main"><ns5:noFill/></ns5:ln></ns0:spPr></ns0:sp><ns0:sp><ns0:nvSpPr><ns0:cNvPr id="8" name="S3"/><ns0:cNvSpPr><ns1:spLocks xmlns:ns1="http://schemas.openxmlformats.org/drawingml/2006/main" noGrp="1"/></ns0:cNvSpPr><ns0:nvPr/></ns0:nvSpPr><ns0:spPr><ns2:xfrm xmlns:ns2="http://schemas.openxmlformats.org/drawingml/2006/main"><ns2:off x="1688977066032" y="4515087542832"/><ns2:ext cx="402336" cy="402336"/></ns2:xfrm><ns3:prstGeom xmlns:ns3="http://schemas.openxmlformats.org/drawingml/2006/main" prst="ellipse"/><ns4:solidFill xmlns:ns4="http://schemas.openxmlformats.org/drawingml/2006/main"><ns4:srgbClr val="3B82F6"/></ns4:solidFill><ns5:ln xmlns:ns5="http://schemas.openxmlformats.org/drawingml/2006/main"><ns5:noFill/></ns5:ln></ns0:spPr></ns0:sp><ns0:sp><ns0:nvSpPr><ns0:cNvPr id="20" name="Step1.Top"/><ns0:cNvSpPr><ns1:spLocks xmlns:ns1="http://schemas.openxmlformats.org/drawingml/2006/main" noGrp="1"/></ns0:cNvSpPr><ns0:nvPr><ns0:ph idx="1" type="body"/></ns0:nvPr></ns0:nvSpPr><ns0:spPr><ns2:xfrm xmlns:ns2="http://schemas.openxmlformats.org/drawingml/2006/main"><ns2:off x="2560320" y="1554480"/><ns2:ext cx="8686800" cy="1097280"/></ns2:xfrm></ns0:spPr><ns0:txBody><ns3:bodyPr xmlns:ns3="http://schemas.openxmlformats.org/drawingml/2006/main" wrap="square" anchor="t" anchorCtr="0"/><ns4:lstStyle/><ns4:defPPr algn="l"><ns4:buNone/><ns4:defRPr sz="1400" dirty="0"><ns4:solidFill><ns4:srgbClr val="1E293B"/></ns4:solidFill><ns4:latin typeface="Calibri"/><ns4:ea typeface="Calibri"/></ns4:defRPr></ns4:defPPr><ns4:lvl1pPr algn="l"><ns4:buNone/><ns4:defRPr sz="1400" dirty="0"><ns4:solidFill><ns4:srgbClr val="1E293B"/></ns4:solidFill><ns4:latin typeface="Calibri"/><ns4:ea typeface="Calibri"/></ns4:defRPr></ns4:lvl1pPr><ns4:lvl2pPr algn="l"><ns4:buNone/><ns4:defRPr sz="1400" dirty="0"><ns4:solidFill><ns4:srgbClr val="1E293B"/></ns4:solidFill><ns4:latin typeface="Calibri"/><ns4:ea typeface="Calibri"/></ns4:defRPr></ns4:lvl2pPr><ns4:lvl3pPr algn="l"><ns4:buNone/><ns4:defRPr sz="1400" dirty="0"><ns4:solidFill><ns4:srgbClr val="1E293B"/></ns4:solidFill><ns4:latin typeface="Calibri"/><ns4:ea typeface="Calibri"/></ns4:defRPr></ns4:lvl3pPr><ns4:lvl4pPr algn="l"><ns4:buNone/><ns4:defRPr sz="1400" dirty="0"><ns4:solidFill><ns4:srgbClr val="1E293B"/></ns4:solidFill><ns4:latin typeface="Calibri"/><ns4:ea typeface="Calibri"/></ns4:defRPr></ns4:lvl4pPr><ns4:lvl5pPr algn="l"><ns4:buNone/><ns4:defRPr sz="1400" dirty="0"><ns4:solidFill><ns4:srgbClr val="1E293B"/></ns4:solidFill><ns4:latin typeface="Calibri"/><ns4:ea typeface="Calibri"/></ns4:defRPr></ns4:lvl5pPr><ns4:lvl6pPr algn="l"><ns4:buNone/><ns4:defRPr sz="1400" dirty="0"><ns4:solidFill><ns4:srgbClr val="1E293B"/></ns4:solidFill><ns4:latin typeface="Calibri"/><ns4:ea typeface="Calibri"/></ns4:defRPr></ns4:lvl6pPr><ns4:lvl7pPr algn="l"><ns4:buNone/><ns4:defRPr sz="1400" dirty="0"><ns4:solidFill><ns4:srgbClr val="1E293B"/></ns4:solidFill><ns4:latin typeface="Calibri"/><ns4:ea typeface="Calibri"/></ns4:defRPr></ns4:lvl7pPr><ns4:lvl8pPr algn="l"><ns4:buNone/><ns4:defRPr sz="1400" dirty="0"><ns4:solidFill><ns4:srgbClr val="1E293B"/></ns4:solidFill><ns4:latin typeface="Calibri"/><ns4:ea typeface="Calibri"/></ns4:defRPr></ns4:lvl8pPr><ns4:lvl9pPr algn="l"><ns4:buNone/><ns4:defRPr sz="1400" dirty="0"><ns4:solidFill><ns4:srgbClr val="1E293B"/></ns4:solidFill><ns4:latin typeface="Calibri"/><ns4:ea typeface="Calibri"/></ns4:defRPr></ns4:lvl9pPr></ns4:lstStyle/><ns5:p xmlns:ns5="http://schemas.openxmlformats.org/drawingml/2006/main"><ns5:pPr algn="l"><ns5:buNone/></ns5:pPr><ns5:r><ns5:rPr lang="ja-JP"/><ns5:t>ステップ 2：タイトル
+説明テキスト</ns5:t></ns5:r></ns5:p></ns0:txBody></ns0:sp><ns0:sp><ns0:nvSpPr><ns0:cNvPr id="22" name="Step3.Bottom"/><ns0:cNvSpPr><ns1:spLocks xmlns:ns1="http://schemas.openxmlformats.org/drawingml/2006/main" noGrp="1"/></ns0:cNvSpPr><ns0:nvPr><ns0:ph idx="3" type="body"/></ns0:nvPr></ns0:nvSpPr><ns0:spPr><ns2:xfrm xmlns:ns2="http://schemas.openxmlformats.org/drawingml/2006/main"><ns2:off x="2560320" y="4480560"/><ns2:ext cx="8686800" cy="1097280"/></ns2:xfrm></ns0:spPr><ns0:txBody><ns3:bodyPr xmlns:ns3="http://schemas.openxmlformats.org/drawingml/2006/main" wrap="square" anchor="t" anchorCtr="0"/><ns4:lstStyle/><ns4:defPPr algn="l"><ns4:buNone/><ns4:defRPr sz="1400" dirty="0"><ns4:solidFill><ns4:srgbClr val="1E293B"/></ns4:solidFill><ns4:latin typeface="Calibri"/><ns4:ea typeface="Calibri"/></ns4:defRPr></ns4:defPPr><ns4:lvl1pPr algn="l"><ns4:buNone/><ns4:defRPr sz="1400" dirty="0"><ns4:solidFill><ns4:srgbClr val="1E293B"/></ns4:solidFill><ns4:latin typeface="Calibri"/><ns4:ea typeface="Calibri"/></ns4:defRPr></ns4:lvl1pPr><ns4:lvl2pPr algn="l"><ns4:buNone/><ns4:defRPr sz="1400" dirty="0"><ns4:solidFill><ns4:srgbClr val="1E293B"/></ns4:solidFill><ns4:latin typeface="Calibri"/><ns4:ea typeface="Calibri"/></ns4:defRPr></ns4:lvl2pPr><ns4:lvl3pPr algn="l"><ns4:buNone/><ns4:defRPr sz="1400" dirty="0"><ns4:solidFill><ns4:srgbClr val="1E293B"/></ns4:solidFill><ns4:latin typeface="Calibri"/><ns4:ea typeface="Calibri"/></ns4:defRPr></ns4:lvl3pPr><ns4:lvl4pPr algn="l"><ns4:buNone/><ns4:defRPr sz="1400" dirty="0"><ns4:solidFill><ns4:srgbClr val="1E293B"/></ns4:solidFill><ns4:latin typeface="Calibri"/><ns4:ea typeface="Calibri"/></ns4:defRPr></ns4:lvl4pPr><ns4:lvl5pPr algn="l"><ns4:buNone/><ns4:defRPr sz="1400" dirty="0"><ns4:solidFill><ns4:srgbClr val="1E293B"/></ns4:solidFill><ns4:latin typeface="Calibri"/><ns4:ea typeface="Calibri"/></ns4:defRPr></ns4:lvl5pPr><ns4:lvl6pPr algn="l"><ns4:buNone/><ns4:defRPr sz="1400" dirty="0"><ns4:solidFill><ns4:srgbClr val="1E293B"/></ns4:solidFill><ns4:latin typeface="Calibri"/><ns4:ea typeface="Calibri"/></ns4:defRPr></ns4:lvl6pPr><ns4:lvl7pPr algn="l"><ns4:buNone/><ns4:defRPr sz="1400" dirty="0"><ns4:solidFill><ns4:srgbClr val="1E293B"/></ns4:solidFill><ns4:latin typeface="Calibri"/><ns4:ea typeface="Calibri"/></ns4:defRPr></ns4:lvl7pPr><ns4:lvl8pPr algn="l"><ns4:buNone/><ns4:defRPr sz="1400" dirty="0"><ns4:solidFill><ns4:srgbClr val="1E293B"/></ns4:solidFill><ns4:latin typeface="Calibri"/><ns4:ea typeface="Calibri"/></ns4:defRPr></ns4:lvl8pPr><ns4:lvl9pPr algn="l"><ns4:buNone/><ns4:defRPr sz="1400" dirty="0"><ns4:solidFill><ns4:srgbClr val="1E293B"/></ns4:solidFill><ns4:latin typeface="Calibri"/><ns4:ea typeface="Calibri"/></ns4:defRPr></ns4:lvl9pPr></ns4:lstStyle/><ns5:p xmlns:ns5="http://schemas.openxmlformats.org/drawingml/2006/main"><ns5:pPr algn="r"><ns5:buNone/></ns5:pPr><ns5:r><ns5:rPr lang="ja-JP"/><ns5:t>&lt;#&gt;</ns5:t></ns5:r></ns5:p></ns0:txBody></ns0:sp></ns0:spTree></ns0:cSld><ns0:clrMapOvr/></ns0:sldLayout>
 </file>
 
 <file path=ppt/slideLayouts/slideLayout27.xml><?xml version='1.0' encoding='UTF-8' standalone='yes'?>
-<ns0:sldLayout xmlns:ns0="http://schemas.openxmlformats.org/presentationml/2006/main" type="blank" preserve="1"><ns0:cSld name="Summary.1Agenda.Single"><ns0:spTree><ns0:nvGrpSpPr><ns0:cNvPr id="1" name=""/><ns0:cNvGrpSpPr/><ns0:nvPr/></ns0:nvGrpSpPr><ns0:grpSpPr><ns1:xfrm xmlns:ns1="http://schemas.openxmlformats.org/drawingml/2006/main"><ns1:off x="0" y="0"/><ns1:ext cx="0" cy="0"/><ns1:chOff x="0" y="0"/><ns1:chExt cx="0" cy="0"/></ns1:xfrm></ns0:grpSpPr><ns0:sp><ns0:nvSpPr><ns0:cNvPr id="2" name="BG"/><ns0:cNvSpPr><ns1:spLocks xmlns:ns1="http://schemas.openxmlformats.org/drawingml/2006/main" noGrp="1" noSelect="0" noRot="1" noMove="1"/></ns0:cNvSpPr><ns0:nvPr/></ns0:nvSpPr><ns0:spPr><ns2:xfrm xmlns:ns2="http://schemas.openxmlformats.org/drawingml/2006/main"><ns2:off x="0" y="0"/><ns2:ext cx="12192000" cy="6858000"/></ns2:xfrm><ns3:prstGeom xmlns:ns3="http://schemas.openxmlformats.org/drawingml/2006/main" prst="rect"/><ns4:solidFill xmlns:ns4="http://schemas.openxmlformats.org/drawingml/2006/main"><ns4:srgbClr val="FFFFFF"/></ns4:solidFill><ns5:ln xmlns:ns5="http://schemas.openxmlformats.org/drawingml/2006/main"><ns5:noFill/></ns5:ln></ns0:spPr></ns0:sp><ns0:sp><ns0:nvSpPr><ns0:cNvPr id="3" name="LeftPanel"/><ns0:cNvSpPr><ns1:spLocks xmlns:ns1="http://schemas.openxmlformats.org/drawingml/2006/main" noGrp="1" noSelect="0" noRot="1" noMove="1"/></ns0:cNvSpPr><ns0:nvPr/></ns0:nvSpPr><ns0:spPr><ns2:xfrm xmlns:ns2="http://schemas.openxmlformats.org/drawingml/2006/main"><ns2:off x="0" y="0"/><ns2:ext cx="4114800" cy="6858000"/></ns2:xfrm><ns3:prstGeom xmlns:ns3="http://schemas.openxmlformats.org/drawingml/2006/main" prst="rect"/><ns4:solidFill xmlns:ns4="http://schemas.openxmlformats.org/drawingml/2006/main"><ns4:srgbClr val="1E2761"/></ns4:solidFill><ns5:ln xmlns:ns5="http://schemas.openxmlformats.org/drawingml/2006/main"><ns5:noFill/></ns5:ln></ns0:spPr></ns0:sp><ns0:sp><ns0:nvSpPr><ns0:cNvPr id="4" name="AccentBar"/><ns0:cNvSpPr><ns1:spLocks xmlns:ns1="http://schemas.openxmlformats.org/drawingml/2006/main" noGrp="1" noSelect="0" noRot="1" noMove="1"/></ns0:cNvSpPr><ns0:nvPr/></ns0:nvSpPr><ns0:spPr><ns2:xfrm xmlns:ns2="http://schemas.openxmlformats.org/drawingml/2006/main"><ns2:off x="0" y="0"/><ns2:ext cx="164592" cy="6858000"/></ns2:xfrm><ns3:prstGeom xmlns:ns3="http://schemas.openxmlformats.org/drawingml/2006/main" prst="rect"/><ns4:solidFill xmlns:ns4="http://schemas.openxmlformats.org/drawingml/2006/main"><ns4:srgbClr val="3B82F6"/></ns4:solidFill><ns5:ln xmlns:ns5="http://schemas.openxmlformats.org/drawingml/2006/main"><ns5:noFill/></ns5:ln></ns0:spPr></ns0:sp><ns0:sp><ns0:nvSpPr><ns0:cNvPr id="10" name="Title.Left"/><ns0:cNvSpPr><ns1:spLocks xmlns:ns1="http://schemas.openxmlformats.org/drawingml/2006/main" noGrp="1"/></ns0:cNvSpPr><ns0:nvPr><ns0:ph idx="15" type="body"/></ns0:nvPr></ns0:nvSpPr><ns0:spPr><ns2:xfrm xmlns:ns2="http://schemas.openxmlformats.org/drawingml/2006/main"><ns2:off x="548640" y="914400"/><ns2:ext cx="3200400" cy="1371600"/></ns2:xfrm></ns0:spPr><ns0:txBody><ns3:bodyPr xmlns:ns3="http://schemas.openxmlformats.org/drawingml/2006/main" wrap="square" anchor="t" anchorCtr="0"/><ns4:lstStyle xmlns:ns4="http://schemas.openxmlformats.org/drawingml/2006/main"><ns4:defPPr algn="l"><ns4:buNone/><ns4:defRPr sz="3600" dirty="0" b="1"><ns4:solidFill><ns4:srgbClr val="FFFFFF"/></ns4:solidFill><ns4:latin typeface="Georgia"/><ns4:ea typeface="Georgia"/></ns4:defRPr></ns4:defPPr><ns4:lvl1pPr algn="l"><ns4:buNone/><ns4:defRPr sz="3600" dirty="0" b="1"><ns4:solidFill><ns4:srgbClr val="FFFFFF"/></ns4:solidFill><ns4:latin typeface="Georgia"/><ns4:ea typeface="Georgia"/></ns4:defRPr></ns4:lvl1pPr><ns4:lvl2pPr algn="l"><ns4:buNone/><ns4:defRPr sz="3600" dirty="0" b="1"><ns4:solidFill><ns4:srgbClr val="FFFFFF"/></ns4:solidFill><ns4:latin typeface="Georgia"/><ns4:ea typeface="Georgia"/></ns4:defRPr></ns4:lvl2pPr><ns4:lvl3pPr algn="l"><ns4:buNone/><ns4:defRPr sz="3600" dirty="0" b="1"><ns4:solidFill><ns4:srgbClr val="FFFFFF"/></ns4:solidFill><ns4:latin typeface="Georgia"/><ns4:ea typeface="Georgia"/></ns4:defRPr></ns4:lvl3pPr><ns4:lvl4pPr algn="l"><ns4:buNone/><ns4:defRPr sz="3600" dirty="0" b="1"><ns4:solidFill><ns4:srgbClr val="FFFFFF"/></ns4:solidFill><ns4:latin typeface="Georgia"/><ns4:ea typeface="Georgia"/></ns4:defRPr></ns4:lvl4pPr><ns4:lvl5pPr algn="l"><ns4:buNone/><ns4:defRPr sz="3600" dirty="0" b="1"><ns4:solidFill><ns4:srgbClr val="FFFFFF"/></ns4:solidFill><ns4:latin typeface="Georgia"/><ns4:ea typeface="Georgia"/></ns4:defRPr></ns4:lvl5pPr><ns4:lvl6pPr algn="l"><ns4:buNone/><ns4:defRPr sz="3600" dirty="0" b="1"><ns4:solidFill><ns4:srgbClr val="FFFFFF"/></ns4:solidFill><ns4:latin typeface="Georgia"/><ns4:ea typeface="Georgia"/></ns4:defRPr></ns4:lvl6pPr><ns4:lvl7pPr algn="l"><ns4:buNone/><ns4:defRPr sz="3600" dirty="0" b="1"><ns4:solidFill><ns4:srgbClr val="FFFFFF"/></ns4:solidFill><ns4:latin typeface="Georgia"/><ns4:ea typeface="Georgia"/></ns4:defRPr></ns4:lvl7pPr><ns4:lvl8pPr algn="l"><ns4:buNone/><ns4:defRPr sz="3600" dirty="0" b="1"><ns4:solidFill><ns4:srgbClr val="FFFFFF"/></ns4:solidFill><ns4:latin typeface="Georgia"/><ns4:ea typeface="Georgia"/></ns4:defRPr></ns4:lvl8pPr><ns4:lvl9pPr algn="l"><ns4:buNone/><ns4:defRPr sz="3600" dirty="0" b="1"><ns4:solidFill><ns4:srgbClr val="FFFFFF"/></ns4:solidFill><ns4:latin typeface="Georgia"/><ns4:ea typeface="Georgia"/></ns4:defRPr></ns4:lvl9pPr></ns4:lstStyle/><ns5:p xmlns:ns5="http://schemas.openxmlformats.org/drawingml/2006/main"><ns5:pPr algn="l"><ns5:buNone/></ns5:pPr><ns5:r><ns5:rPr lang="ja-JP"/><ns5:t>日時：
+<ns0:sldLayout xmlns:ns0="http://schemas.openxmlformats.org/presentationml/2006/main" type="blank" preserve="1"><ns0:cSld name="Summary.1Agenda.Single"><ns0:spTree><ns0:nvGrpSpPr><ns0:cNvPr id="1" name=""/><ns0:cNvGrpSpPr/><ns0:nvPr/></ns0:nvGrpSpPr><ns0:grpSpPr><ns1:xfrm xmlns:ns1="http://schemas.openxmlformats.org/drawingml/2006/main"><ns1:off x="0" y="0"/><ns1:ext cx="0" cy="0"/><ns1:chOff x="0" y="0"/><ns1:chExt cx="0" cy="0"/></ns1:xfrm></ns0:grpSpPr><ns0:sp><ns0:nvSpPr><ns0:cNvPr id="2" name="BG"/><ns0:cNvSpPr><ns1:spLocks xmlns:ns1="http://schemas.openxmlformats.org/drawingml/2006/main" noGrp="1" noSelect="0" noRot="1" noMove="1"/></ns0:cNvSpPr><ns0:nvPr/></ns0:nvSpPr><ns0:spPr><ns2:xfrm xmlns:ns2="http://schemas.openxmlformats.org/drawingml/2006/main"><ns2:off x="0" y="0"/><ns2:ext cx="12192000" cy="6858000"/></ns2:xfrm><ns3:prstGeom xmlns:ns3="http://schemas.openxmlformats.org/drawingml/2006/main" prst="rect"/><ns4:solidFill xmlns:ns4="http://schemas.openxmlformats.org/drawingml/2006/main"><ns4:srgbClr val="FFFFFF"/></ns4:solidFill><ns5:ln xmlns:ns5="http://schemas.openxmlformats.org/drawingml/2006/main"><ns5:noFill/></ns5:ln></ns0:spPr></ns0:sp><ns0:sp><ns0:nvSpPr><ns0:cNvPr id="3" name="LeftPanel"/><ns0:cNvSpPr><ns1:spLocks xmlns:ns1="http://schemas.openxmlformats.org/drawingml/2006/main" noGrp="1" noSelect="0" noRot="1" noMove="1"/></ns0:cNvSpPr><ns0:nvPr/></ns0:nvSpPr><ns0:spPr><ns2:xfrm xmlns:ns2="http://schemas.openxmlformats.org/drawingml/2006/main"><ns2:off x="0" y="0"/><ns2:ext cx="4114800" cy="6858000"/></ns2:xfrm><ns3:prstGeom xmlns:ns3="http://schemas.openxmlformats.org/drawingml/2006/main" prst="rect"/><ns4:solidFill xmlns:ns4="http://schemas.openxmlformats.org/drawingml/2006/main"><ns4:srgbClr val="1E2761"/></ns4:solidFill><ns5:ln xmlns:ns5="http://schemas.openxmlformats.org/drawingml/2006/main"><ns5:noFill/></ns5:ln></ns0:spPr></ns0:sp><ns0:sp><ns0:nvSpPr><ns0:cNvPr id="4" name="AccentBar"/><ns0:cNvSpPr><ns1:spLocks xmlns:ns1="http://schemas.openxmlformats.org/drawingml/2006/main" noGrp="1" noSelect="0" noRot="1" noMove="1"/></ns0:cNvSpPr><ns0:nvPr/></ns0:nvSpPr><ns0:spPr><ns2:xfrm xmlns:ns2="http://schemas.openxmlformats.org/drawingml/2006/main"><ns2:off x="0" y="0"/><ns2:ext cx="164592" cy="6858000"/></ns2:xfrm><ns3:prstGeom xmlns:ns3="http://schemas.openxmlformats.org/drawingml/2006/main" prst="rect"/><ns4:solidFill xmlns:ns4="http://schemas.openxmlformats.org/drawingml/2006/main"><ns4:srgbClr val="3B82F6"/></ns4:solidFill><ns5:ln xmlns:ns5="http://schemas.openxmlformats.org/drawingml/2006/main"><ns5:noFill/></ns5:ln></ns0:spPr></ns0:sp><ns0:sp><ns0:nvSpPr><ns0:cNvPr id="10" name="Title.Left"/><ns0:cNvSpPr><ns1:spLocks xmlns:ns1="http://schemas.openxmlformats.org/drawingml/2006/main" noGrp="1"/></ns0:cNvSpPr><ns0:nvPr><ns0:ph idx="15" type="body"/></ns0:nvPr></ns0:nvSpPr><ns0:spPr><ns2:xfrm xmlns:ns2="http://schemas.openxmlformats.org/drawingml/2006/main"><ns2:off x="548640" y="914400"/><ns2:ext cx="3200400" cy="1371600"/></ns2:xfrm></ns0:spPr><ns0:txBody><ns3:bodyPr xmlns:ns3="http://schemas.openxmlformats.org/drawingml/2006/main" wrap="square" anchor="t" anchorCtr="0"/><ns4:lstStyle><ns4:defPPr><ns4:defRPr sz="3600" b="1"><ns4:solidFill><ns4:srgbClr val="FFFFFF"/></ns4:solidFill></ns4:defRPr></ns4:defPPr></ns4:lstStyle><ns4:defPPr algn="l"><ns4:buNone/><ns4:defRPr sz="3600" dirty="0" b="1"><ns4:solidFill><ns4:srgbClr val="FFFFFF"/></ns4:solidFill><ns4:latin typeface="Georgia"/><ns4:ea typeface="Georgia"/></ns4:defRPr></ns4:defPPr><ns4:lvl1pPr algn="l"><ns4:buNone/><ns4:defRPr sz="3600" dirty="0" b="1"><ns4:solidFill><ns4:srgbClr val="FFFFFF"/></ns4:solidFill><ns4:latin typeface="Georgia"/><ns4:ea typeface="Georgia"/></ns4:defRPr></ns4:lvl1pPr><ns4:lvl2pPr algn="l"><ns4:buNone/><ns4:defRPr sz="3600" dirty="0" b="1"><ns4:solidFill><ns4:srgbClr val="FFFFFF"/></ns4:solidFill><ns4:latin typeface="Georgia"/><ns4:ea typeface="Georgia"/></ns4:defRPr></ns4:lvl2pPr><ns4:lvl3pPr algn="l"><ns4:buNone/><ns4:defRPr sz="3600" dirty="0" b="1"><ns4:solidFill><ns4:srgbClr val="FFFFFF"/></ns4:solidFill><ns4:latin typeface="Georgia"/><ns4:ea typeface="Georgia"/></ns4:defRPr></ns4:lvl3pPr><ns4:lvl4pPr algn="l"><ns4:buNone/><ns4:defRPr sz="3600" dirty="0" b="1"><ns4:solidFill><ns4:srgbClr val="FFFFFF"/></ns4:solidFill><ns4:latin typeface="Georgia"/><ns4:ea typeface="Georgia"/></ns4:defRPr></ns4:lvl4pPr><ns4:lvl5pPr algn="l"><ns4:buNone/><ns4:defRPr sz="3600" dirty="0" b="1"><ns4:solidFill><ns4:srgbClr val="FFFFFF"/></ns4:solidFill><ns4:latin typeface="Georgia"/><ns4:ea typeface="Georgia"/></ns4:defRPr></ns4:lvl5pPr><ns4:lvl6pPr algn="l"><ns4:buNone/><ns4:defRPr sz="3600" dirty="0" b="1"><ns4:solidFill><ns4:srgbClr val="FFFFFF"/></ns4:solidFill><ns4:latin typeface="Georgia"/><ns4:ea typeface="Georgia"/></ns4:defRPr></ns4:lvl6pPr><ns4:lvl7pPr algn="l"><ns4:buNone/><ns4:defRPr sz="3600" dirty="0" b="1"><ns4:solidFill><ns4:srgbClr val="FFFFFF"/></ns4:solidFill><ns4:latin typeface="Georgia"/><ns4:ea typeface="Georgia"/></ns4:defRPr></ns4:lvl7pPr><ns4:lvl8pPr algn="l"><ns4:buNone/><ns4:defRPr sz="3600" dirty="0" b="1"><ns4:solidFill><ns4:srgbClr val="FFFFFF"/></ns4:solidFill><ns4:latin typeface="Georgia"/><ns4:ea typeface="Georgia"/></ns4:defRPr></ns4:lvl8pPr><ns4:lvl9pPr algn="l"><ns4:buNone/><ns4:defRPr sz="3600" dirty="0" b="1"><ns4:solidFill><ns4:srgbClr val="FFFFFF"/></ns4:solidFill><ns4:latin typeface="Georgia"/><ns4:ea typeface="Georgia"/></ns4:defRPr></ns4:lvl9pPr></ns4:lstStyle/><ns5:p xmlns:ns5="http://schemas.openxmlformats.org/drawingml/2006/main"><ns5:pPr algn="l"><ns5:buNone/></ns5:pPr><ns5:r><ns5:rPr lang="ja-JP"/><ns5:t>日時：
 場所：
-所要時間：</ns5:t></ns5:r></ns5:p></ns0:txBody></ns0:sp><ns0:sp><ns0:nvSpPr><ns0:cNvPr id="20" name="AgendaItems.Right"/><ns0:cNvSpPr><ns1:spLocks xmlns:ns1="http://schemas.openxmlformats.org/drawingml/2006/main" noGrp="1"/></ns0:cNvSpPr><ns0:nvPr><ns0:ph idx="1" type="body"/></ns0:nvPr></ns0:nvSpPr><ns0:spPr><ns2:xfrm xmlns:ns2="http://schemas.openxmlformats.org/drawingml/2006/main"><ns2:off x="4572000" y="731520"/><ns2:ext cx="6858000" cy="5486400"/></ns2:xfrm></ns0:spPr><ns0:txBody><ns3:bodyPr xmlns:ns3="http://schemas.openxmlformats.org/drawingml/2006/main" wrap="square" anchor="t" anchorCtr="0"/><ns4:lstStyle xmlns:ns4="http://schemas.openxmlformats.org/drawingml/2006/main"><ns4:defPPr algn="l"><ns4:buNone/><ns4:defRPr sz="1500" dirty="0"><ns4:solidFill><ns4:srgbClr val="1E293B"/></ns4:solidFill><ns4:latin typeface="Calibri"/><ns4:ea typeface="Calibri"/></ns4:defRPr></ns4:defPPr><ns4:lvl1pPr algn="l"><ns4:buNone/><ns4:defRPr sz="1500" dirty="0"><ns4:solidFill><ns4:srgbClr val="1E293B"/></ns4:solidFill><ns4:latin typeface="Calibri"/><ns4:ea typeface="Calibri"/></ns4:defRPr></ns4:lvl1pPr><ns4:lvl2pPr algn="l"><ns4:buNone/><ns4:defRPr sz="1500" dirty="0"><ns4:solidFill><ns4:srgbClr val="1E293B"/></ns4:solidFill><ns4:latin typeface="Calibri"/><ns4:ea typeface="Calibri"/></ns4:defRPr></ns4:lvl2pPr><ns4:lvl3pPr algn="l"><ns4:buNone/><ns4:defRPr sz="1500" dirty="0"><ns4:solidFill><ns4:srgbClr val="1E293B"/></ns4:solidFill><ns4:latin typeface="Calibri"/><ns4:ea typeface="Calibri"/></ns4:defRPr></ns4:lvl3pPr><ns4:lvl4pPr algn="l"><ns4:buNone/><ns4:defRPr sz="1500" dirty="0"><ns4:solidFill><ns4:srgbClr val="1E293B"/></ns4:solidFill><ns4:latin typeface="Calibri"/><ns4:ea typeface="Calibri"/></ns4:defRPr></ns4:lvl4pPr><ns4:lvl5pPr algn="l"><ns4:buNone/><ns4:defRPr sz="1500" dirty="0"><ns4:solidFill><ns4:srgbClr val="1E293B"/></ns4:solidFill><ns4:latin typeface="Calibri"/><ns4:ea typeface="Calibri"/></ns4:defRPr></ns4:lvl5pPr><ns4:lvl6pPr algn="l"><ns4:buNone/><ns4:defRPr sz="1500" dirty="0"><ns4:solidFill><ns4:srgbClr val="1E293B"/></ns4:solidFill><ns4:latin typeface="Calibri"/><ns4:ea typeface="Calibri"/></ns4:defRPr></ns4:lvl6pPr><ns4:lvl7pPr algn="l"><ns4:buNone/><ns4:defRPr sz="1500" dirty="0"><ns4:solidFill><ns4:srgbClr val="1E293B"/></ns4:solidFill><ns4:latin typeface="Calibri"/><ns4:ea typeface="Calibri"/></ns4:defRPr></ns4:lvl7pPr><ns4:lvl8pPr algn="l"><ns4:buNone/><ns4:defRPr sz="1500" dirty="0"><ns4:solidFill><ns4:srgbClr val="1E293B"/></ns4:solidFill><ns4:latin typeface="Calibri"/><ns4:ea typeface="Calibri"/></ns4:defRPr></ns4:lvl8pPr><ns4:lvl9pPr algn="l"><ns4:buNone/><ns4:defRPr sz="1500" dirty="0"><ns4:solidFill><ns4:srgbClr val="1E293B"/></ns4:solidFill><ns4:latin typeface="Calibri"/><ns4:ea typeface="Calibri"/></ns4:defRPr></ns4:lvl9pPr></ns4:lstStyle><ns5:p xmlns:ns5="http://schemas.openxmlformats.org/drawingml/2006/main"><ns5:pPr algn="l"><ns5:buNone/></ns5:pPr><ns5:r><ns5:rPr lang="ja-JP"/><ns5:t>01  議題タイトル
+所要時間：</ns5:t></ns5:r></ns5:p></ns0:txBody></ns0:sp><ns0:sp><ns0:nvSpPr><ns0:cNvPr id="20" name="AgendaItems.Right"/><ns0:cNvSpPr><ns1:spLocks xmlns:ns1="http://schemas.openxmlformats.org/drawingml/2006/main" noGrp="1"/></ns0:cNvSpPr><ns0:nvPr><ns0:ph idx="1" type="body"/></ns0:nvPr></ns0:nvSpPr><ns0:spPr><ns2:xfrm xmlns:ns2="http://schemas.openxmlformats.org/drawingml/2006/main"><ns2:off x="4572000" y="731520"/><ns2:ext cx="6858000" cy="5486400"/></ns2:xfrm></ns0:spPr><ns0:txBody><ns3:bodyPr xmlns:ns3="http://schemas.openxmlformats.org/drawingml/2006/main" wrap="square" anchor="t" anchorCtr="0"/><ns4:lstStyle><ns4:defPPr><ns4:defRPr sz="1500"></ns4:defRPr></ns4:defPPr></ns4:lstStyle><ns4:defPPr algn="l"><ns4:buNone/><ns4:defRPr sz="1500" dirty="0"><ns4:solidFill><ns4:srgbClr val="1E293B"/></ns4:solidFill><ns4:latin typeface="Calibri"/><ns4:ea typeface="Calibri"/></ns4:defRPr></ns4:defPPr><ns4:lvl1pPr algn="l"><ns4:buNone/><ns4:defRPr sz="1500" dirty="0"><ns4:solidFill><ns4:srgbClr val="1E293B"/></ns4:solidFill><ns4:latin typeface="Calibri"/><ns4:ea typeface="Calibri"/></ns4:defRPr></ns4:lvl1pPr><ns4:lvl2pPr algn="l"><ns4:buNone/><ns4:defRPr sz="1500" dirty="0"><ns4:solidFill><ns4:srgbClr val="1E293B"/></ns4:solidFill><ns4:latin typeface="Calibri"/><ns4:ea typeface="Calibri"/></ns4:defRPr></ns4:lvl2pPr><ns4:lvl3pPr algn="l"><ns4:buNone/><ns4:defRPr sz="1500" dirty="0"><ns4:solidFill><ns4:srgbClr val="1E293B"/></ns4:solidFill><ns4:latin typeface="Calibri"/><ns4:ea typeface="Calibri"/></ns4:defRPr></ns4:lvl3pPr><ns4:lvl4pPr algn="l"><ns4:buNone/><ns4:defRPr sz="1500" dirty="0"><ns4:solidFill><ns4:srgbClr val="1E293B"/></ns4:solidFill><ns4:latin typeface="Calibri"/><ns4:ea typeface="Calibri"/></ns4:defRPr></ns4:lvl4pPr><ns4:lvl5pPr algn="l"><ns4:buNone/><ns4:defRPr sz="1500" dirty="0"><ns4:solidFill><ns4:srgbClr val="1E293B"/></ns4:solidFill><ns4:latin typeface="Calibri"/><ns4:ea typeface="Calibri"/></ns4:defRPr></ns4:lvl5pPr><ns4:lvl6pPr algn="l"><ns4:buNone/><ns4:defRPr sz="1500" dirty="0"><ns4:solidFill><ns4:srgbClr val="1E293B"/></ns4:solidFill><ns4:latin typeface="Calibri"/><ns4:ea typeface="Calibri"/></ns4:defRPr></ns4:lvl6pPr><ns4:lvl7pPr algn="l"><ns4:buNone/><ns4:defRPr sz="1500" dirty="0"><ns4:solidFill><ns4:srgbClr val="1E293B"/></ns4:solidFill><ns4:latin typeface="Calibri"/><ns4:ea typeface="Calibri"/></ns4:defRPr></ns4:lvl7pPr><ns4:lvl8pPr algn="l"><ns4:buNone/><ns4:defRPr sz="1500" dirty="0"><ns4:solidFill><ns4:srgbClr val="1E293B"/></ns4:solidFill><ns4:latin typeface="Calibri"/><ns4:ea typeface="Calibri"/></ns4:defRPr></ns4:lvl8pPr><ns4:lvl9pPr algn="l"><ns4:buNone/><ns4:defRPr sz="1500" dirty="0"><ns4:solidFill><ns4:srgbClr val="1E293B"/></ns4:solidFill><ns4:latin typeface="Calibri"/><ns4:ea typeface="Calibri"/></ns4:defRPr></ns4:lvl9pPr></ns4:lstStyle><ns5:p xmlns:ns5="http://schemas.openxmlformats.org/drawingml/2006/main"><ns5:pPr algn="l"><ns5:buNone/></ns5:pPr><ns5:r><ns5:rPr lang="ja-JP"/><ns5:t>01  議題タイトル
 
 02  議題タイトル
 
@@ -1281,15 +1249,15 @@
 </file>
 
 <file path=ppt/slideLayouts/slideLayout28.xml><?xml version='1.0' encoding='UTF-8' standalone='yes'?>
-<ns0:sldLayout xmlns:ns0="http://schemas.openxmlformats.org/presentationml/2006/main" type="blank" preserve="1"><ns0:cSld name="Summary.2Block.Equal"><ns0:spTree><ns0:nvGrpSpPr><ns0:cNvPr id="1" name=""/><ns0:cNvGrpSpPr/><ns0:nvPr/></ns0:nvGrpSpPr><ns0:grpSpPr><ns1:xfrm xmlns:ns1="http://schemas.openxmlformats.org/drawingml/2006/main"><ns1:off x="0" y="0"/><ns1:ext cx="0" cy="0"/><ns1:chOff x="0" y="0"/><ns1:chExt cx="0" cy="0"/></ns1:xfrm></ns0:grpSpPr><ns0:sp><ns0:nvSpPr><ns0:cNvPr id="2" name="HeaderBar"/><ns0:cNvSpPr><ns1:spLocks xmlns:ns1="http://schemas.openxmlformats.org/drawingml/2006/main" noGrp="1" noSelect="0" noRot="1" noMove="1"/></ns0:cNvSpPr><ns0:nvPr/></ns0:nvSpPr><ns0:spPr><ns2:xfrm xmlns:ns2="http://schemas.openxmlformats.org/drawingml/2006/main"><ns2:off x="0" y="0"/><ns2:ext cx="12192000" cy="1051560"/></ns2:xfrm><ns3:prstGeom xmlns:ns3="http://schemas.openxmlformats.org/drawingml/2006/main" prst="rect"/><ns4:solidFill xmlns:ns4="http://schemas.openxmlformats.org/drawingml/2006/main"><ns4:srgbClr val="1E2761"/></ns4:solidFill><ns5:ln xmlns:ns5="http://schemas.openxmlformats.org/drawingml/2006/main"><ns5:noFill/></ns5:ln></ns0:spPr></ns0:sp><ns0:sp><ns0:nvSpPr><ns0:cNvPr id="10" name="SlideTitle.Header"/><ns0:cNvSpPr><ns1:spLocks xmlns:ns1="http://schemas.openxmlformats.org/drawingml/2006/main" noGrp="1"/></ns0:cNvSpPr><ns0:nvPr><ns0:ph idx="15" type="body"/></ns0:nvPr></ns0:nvSpPr><ns0:spPr><ns2:xfrm xmlns:ns2="http://schemas.openxmlformats.org/drawingml/2006/main"><ns2:off x="731520" y="91440"/><ns2:ext cx="9144000" cy="475488"/></ns2:xfrm></ns0:spPr><ns0:txBody><ns3:bodyPr xmlns:ns3="http://schemas.openxmlformats.org/drawingml/2006/main" wrap="square" anchor="t" anchorCtr="0"/><ns4:lstStyle xmlns:ns4="http://schemas.openxmlformats.org/drawingml/2006/main"><ns4:defPPr algn="l"><ns4:buNone/><ns4:defRPr sz="2800" dirty="0" b="1"><ns4:solidFill><ns4:srgbClr val="FFFFFF"/></ns4:solidFill><ns4:latin typeface="Georgia"/><ns4:ea typeface="Georgia"/></ns4:defRPr></ns4:defPPr><ns4:lvl1pPr algn="l"><ns4:buNone/><ns4:defRPr sz="2800" dirty="0" b="1"><ns4:solidFill><ns4:srgbClr val="FFFFFF"/></ns4:solidFill><ns4:latin typeface="Georgia"/><ns4:ea typeface="Georgia"/></ns4:defRPr></ns4:lvl1pPr><ns4:lvl2pPr algn="l"><ns4:buNone/><ns4:defRPr sz="2800" dirty="0" b="1"><ns4:solidFill><ns4:srgbClr val="FFFFFF"/></ns4:solidFill><ns4:latin typeface="Georgia"/><ns4:ea typeface="Georgia"/></ns4:defRPr></ns4:lvl2pPr><ns4:lvl3pPr algn="l"><ns4:buNone/><ns4:defRPr sz="2800" dirty="0" b="1"><ns4:solidFill><ns4:srgbClr val="FFFFFF"/></ns4:solidFill><ns4:latin typeface="Georgia"/><ns4:ea typeface="Georgia"/></ns4:defRPr></ns4:lvl3pPr><ns4:lvl4pPr algn="l"><ns4:buNone/><ns4:defRPr sz="2800" dirty="0" b="1"><ns4:solidFill><ns4:srgbClr val="FFFFFF"/></ns4:solidFill><ns4:latin typeface="Georgia"/><ns4:ea typeface="Georgia"/></ns4:defRPr></ns4:lvl4pPr><ns4:lvl5pPr algn="l"><ns4:buNone/><ns4:defRPr sz="2800" dirty="0" b="1"><ns4:solidFill><ns4:srgbClr val="FFFFFF"/></ns4:solidFill><ns4:latin typeface="Georgia"/><ns4:ea typeface="Georgia"/></ns4:defRPr></ns4:lvl5pPr><ns4:lvl6pPr algn="l"><ns4:buNone/><ns4:defRPr sz="2800" dirty="0" b="1"><ns4:solidFill><ns4:srgbClr val="FFFFFF"/></ns4:solidFill><ns4:latin typeface="Georgia"/><ns4:ea typeface="Georgia"/></ns4:defRPr></ns4:lvl6pPr><ns4:lvl7pPr algn="l"><ns4:buNone/><ns4:defRPr sz="2800" dirty="0" b="1"><ns4:solidFill><ns4:srgbClr val="FFFFFF"/></ns4:solidFill><ns4:latin typeface="Georgia"/><ns4:ea typeface="Georgia"/></ns4:defRPr></ns4:lvl7pPr><ns4:lvl8pPr algn="l"><ns4:buNone/><ns4:defRPr sz="2800" dirty="0" b="1"><ns4:solidFill><ns4:srgbClr val="FFFFFF"/></ns4:solidFill><ns4:latin typeface="Georgia"/><ns4:ea typeface="Georgia"/></ns4:defRPr></ns4:lvl8pPr><ns4:lvl9pPr algn="l"><ns4:buNone/><ns4:defRPr sz="2800" dirty="0" b="1"><ns4:solidFill><ns4:srgbClr val="FFFFFF"/></ns4:solidFill><ns4:latin typeface="Georgia"/><ns4:ea typeface="Georgia"/></ns4:defRPr></ns4:lvl9pPr></ns4:lstStyle/><ns5:p xmlns:ns5="http://schemas.openxmlformats.org/drawingml/2006/main"><ns5:pPr algn="l"><ns5:buNone/></ns5:pPr><ns5:r><ns5:rPr lang="ja-JP"/><ns5:t>サブタイトル</ns5:t></ns5:r></ns5:p></ns0:txBody></ns0:sp><ns0:sp><ns0:nvSpPr><ns0:cNvPr id="5" name="FindingsPanel"/><ns0:cNvSpPr><ns1:spLocks xmlns:ns1="http://schemas.openxmlformats.org/drawingml/2006/main" noGrp="1" noSelect="0" noRot="1" noMove="1"/></ns0:cNvSpPr><ns0:nvPr/></ns0:nvSpPr><ns0:spPr><ns2:xfrm xmlns:ns2="http://schemas.openxmlformats.org/drawingml/2006/main"><ns2:off x="457200" y="1280160"/><ns2:ext cx="7132320" cy="5029200"/></ns2:xfrm><ns3:prstGeom xmlns:ns3="http://schemas.openxmlformats.org/drawingml/2006/main" prst="roundRect"><ns3:avLst><ns3:gd name="adj" fmla="val 8000"/></ns3:avLst></ns3:prstGeom><ns4:solidFill xmlns:ns4="http://schemas.openxmlformats.org/drawingml/2006/main"><ns4:srgbClr val="EDF0F7"/></ns4:solidFill><ns5:ln xmlns:ns5="http://schemas.openxmlformats.org/drawingml/2006/main"><ns5:noFill/></ns5:ln></ns0:spPr></ns0:sp><ns0:sp><ns0:nvSpPr><ns0:cNvPr id="6" name="RecPanel"/><ns0:cNvSpPr><ns1:spLocks xmlns:ns1="http://schemas.openxmlformats.org/drawingml/2006/main" noGrp="1" noSelect="0" noRot="1" noMove="1"/></ns0:cNvSpPr><ns0:nvPr/></ns0:nvSpPr><ns0:spPr><ns2:xfrm xmlns:ns2="http://schemas.openxmlformats.org/drawingml/2006/main"><ns2:off x="7863840" y="1280160"/><ns2:ext cx="3749039" cy="5029200"/></ns2:xfrm><ns3:prstGeom xmlns:ns3="http://schemas.openxmlformats.org/drawingml/2006/main" prst="roundRect"><ns3:avLst><ns3:gd name="adj" fmla="val 8000"/></ns3:avLst></ns3:prstGeom><ns4:solidFill xmlns:ns4="http://schemas.openxmlformats.org/drawingml/2006/main"><ns4:srgbClr val="F0F4FF"/></ns4:solidFill><ns5:ln xmlns:ns5="http://schemas.openxmlformats.org/drawingml/2006/main"><ns5:noFill/></ns5:ln></ns0:spPr></ns0:sp><ns0:sp><ns0:nvSpPr><ns0:cNvPr id="7" name="RecAccent"/><ns0:cNvSpPr><ns1:spLocks xmlns:ns1="http://schemas.openxmlformats.org/drawingml/2006/main" noGrp="1" noSelect="0" noRot="1" noMove="1"/></ns0:cNvSpPr><ns0:nvPr/></ns0:nvSpPr><ns0:spPr><ns2:xfrm xmlns:ns2="http://schemas.openxmlformats.org/drawingml/2006/main"><ns2:off x="7863840" y="1280160"/><ns2:ext cx="54864" cy="5029200"/></ns2:xfrm><ns3:prstGeom xmlns:ns3="http://schemas.openxmlformats.org/drawingml/2006/main" prst="rect"/><ns4:solidFill xmlns:ns4="http://schemas.openxmlformats.org/drawingml/2006/main"><ns4:srgbClr val="3B82F6"/></ns4:solidFill><ns5:ln xmlns:ns5="http://schemas.openxmlformats.org/drawingml/2006/main"><ns5:noFill/></ns5:ln></ns0:spPr></ns0:sp><ns0:sp><ns0:nvSpPr><ns0:cNvPr id="20" name="Body1.Left"/><ns0:cNvSpPr><ns1:spLocks xmlns:ns1="http://schemas.openxmlformats.org/drawingml/2006/main" noGrp="1"/></ns0:cNvSpPr><ns0:nvPr><ns0:ph idx="1" type="body"/></ns0:nvPr></ns0:nvSpPr><ns0:spPr><ns2:xfrm xmlns:ns2="http://schemas.openxmlformats.org/drawingml/2006/main"><ns2:off x="822960" y="1554480"/><ns2:ext cx="6400800" cy="4572000"/></ns2:xfrm></ns0:spPr><ns0:txBody><ns3:bodyPr xmlns:ns3="http://schemas.openxmlformats.org/drawingml/2006/main" wrap="square" anchor="t" anchorCtr="0"/><ns4:lstStyle xmlns:ns4="http://schemas.openxmlformats.org/drawingml/2006/main"><ns4:defPPr algn="l"><ns4:buNone/><ns4:defRPr sz="1400" dirty="0"><ns4:solidFill><ns4:srgbClr val="1E293B"/></ns4:solidFill><ns4:latin typeface="Calibri"/><ns4:ea typeface="Calibri"/></ns4:defRPr></ns4:defPPr><ns4:lvl1pPr algn="l"><ns4:buNone/><ns4:defRPr sz="1400" dirty="0"><ns4:solidFill><ns4:srgbClr val="1E293B"/></ns4:solidFill><ns4:latin typeface="Calibri"/><ns4:ea typeface="Calibri"/></ns4:defRPr></ns4:lvl1pPr><ns4:lvl2pPr algn="l"><ns4:buNone/><ns4:defRPr sz="1400" dirty="0"><ns4:solidFill><ns4:srgbClr val="1E293B"/></ns4:solidFill><ns4:latin typeface="Calibri"/><ns4:ea typeface="Calibri"/></ns4:defRPr></ns4:lvl2pPr><ns4:lvl3pPr algn="l"><ns4:buNone/><ns4:defRPr sz="1400" dirty="0"><ns4:solidFill><ns4:srgbClr val="1E293B"/></ns4:solidFill><ns4:latin typeface="Calibri"/><ns4:ea typeface="Calibri"/></ns4:defRPr></ns4:lvl3pPr><ns4:lvl4pPr algn="l"><ns4:buNone/><ns4:defRPr sz="1400" dirty="0"><ns4:solidFill><ns4:srgbClr val="1E293B"/></ns4:solidFill><ns4:latin typeface="Calibri"/><ns4:ea typeface="Calibri"/></ns4:defRPr></ns4:lvl4pPr><ns4:lvl5pPr algn="l"><ns4:buNone/><ns4:defRPr sz="1400" dirty="0"><ns4:solidFill><ns4:srgbClr val="1E293B"/></ns4:solidFill><ns4:latin typeface="Calibri"/><ns4:ea typeface="Calibri"/></ns4:defRPr></ns4:lvl5pPr><ns4:lvl6pPr algn="l"><ns4:buNone/><ns4:defRPr sz="1400" dirty="0"><ns4:solidFill><ns4:srgbClr val="1E293B"/></ns4:solidFill><ns4:latin typeface="Calibri"/><ns4:ea typeface="Calibri"/></ns4:defRPr></ns4:lvl6pPr><ns4:lvl7pPr algn="l"><ns4:buNone/><ns4:defRPr sz="1400" dirty="0"><ns4:solidFill><ns4:srgbClr val="1E293B"/></ns4:solidFill><ns4:latin typeface="Calibri"/><ns4:ea typeface="Calibri"/></ns4:defRPr></ns4:lvl7pPr><ns4:lvl8pPr algn="l"><ns4:buNone/><ns4:defRPr sz="1400" dirty="0"><ns4:solidFill><ns4:srgbClr val="1E293B"/></ns4:solidFill><ns4:latin typeface="Calibri"/><ns4:ea typeface="Calibri"/></ns4:defRPr></ns4:lvl8pPr><ns4:lvl9pPr algn="l"><ns4:buNone/><ns4:defRPr sz="1400" dirty="0"><ns4:solidFill><ns4:srgbClr val="1E293B"/></ns4:solidFill><ns4:latin typeface="Calibri"/><ns4:ea typeface="Calibri"/></ns4:defRPr></ns4:lvl9pPr></ns4:lstStyle/><ns5:p xmlns:ns5="http://schemas.openxmlformats.org/drawingml/2006/main"><ns5:pPr algn="l"><ns5:buNone/></ns5:pPr><ns5:r><ns5:rPr lang="ja-JP"/><ns5:t>推奨アクション
+<ns0:sldLayout xmlns:ns0="http://schemas.openxmlformats.org/presentationml/2006/main" type="blank" preserve="1"><ns0:cSld name="Summary.2Block.Equal"><ns0:spTree><ns0:nvGrpSpPr><ns0:cNvPr id="1" name=""/><ns0:cNvGrpSpPr/><ns0:nvPr/></ns0:nvGrpSpPr><ns0:grpSpPr><ns1:xfrm xmlns:ns1="http://schemas.openxmlformats.org/drawingml/2006/main"><ns1:off x="0" y="0"/><ns1:ext cx="0" cy="0"/><ns1:chOff x="0" y="0"/><ns1:chExt cx="0" cy="0"/></ns1:xfrm></ns0:grpSpPr><ns0:sp><ns0:nvSpPr><ns0:cNvPr id="2" name="HeaderBar"/><ns0:cNvSpPr><ns1:spLocks xmlns:ns1="http://schemas.openxmlformats.org/drawingml/2006/main" noGrp="1" noSelect="0" noRot="1" noMove="1"/></ns0:cNvSpPr><ns0:nvPr/></ns0:nvSpPr><ns0:spPr><ns2:xfrm xmlns:ns2="http://schemas.openxmlformats.org/drawingml/2006/main"><ns2:off x="0" y="0"/><ns2:ext cx="12192000" cy="1051560"/></ns2:xfrm><ns3:prstGeom xmlns:ns3="http://schemas.openxmlformats.org/drawingml/2006/main" prst="rect"/><ns4:solidFill xmlns:ns4="http://schemas.openxmlformats.org/drawingml/2006/main"><ns4:srgbClr val="1E2761"/></ns4:solidFill><ns5:ln xmlns:ns5="http://schemas.openxmlformats.org/drawingml/2006/main"><ns5:noFill/></ns5:ln></ns0:spPr></ns0:sp><ns0:sp><ns0:nvSpPr><ns0:cNvPr id="10" name="SlideTitle.Header"/><ns0:cNvSpPr><ns1:spLocks xmlns:ns1="http://schemas.openxmlformats.org/drawingml/2006/main" noGrp="1"/></ns0:cNvSpPr><ns0:nvPr><ns0:ph idx="15" type="body"/></ns0:nvPr></ns0:nvSpPr><ns0:spPr><ns2:xfrm xmlns:ns2="http://schemas.openxmlformats.org/drawingml/2006/main"><ns2:off x="731520" y="91440"/><ns2:ext cx="9144000" cy="475488"/></ns2:xfrm></ns0:spPr><ns0:txBody><ns3:bodyPr xmlns:ns3="http://schemas.openxmlformats.org/drawingml/2006/main" wrap="square" anchor="t" anchorCtr="0"/><ns4:lstStyle><ns4:defPPr><ns4:defRPr sz="2800" b="1"><ns4:solidFill><ns4:srgbClr val="FFFFFF"/></ns4:solidFill></ns4:defRPr></ns4:defPPr></ns4:lstStyle><ns4:defPPr algn="l"><ns4:buNone/><ns4:defRPr sz="2800" dirty="0" b="1"><ns4:solidFill><ns4:srgbClr val="FFFFFF"/></ns4:solidFill><ns4:latin typeface="Georgia"/><ns4:ea typeface="Georgia"/></ns4:defRPr></ns4:defPPr><ns4:lvl1pPr algn="l"><ns4:buNone/><ns4:defRPr sz="2800" dirty="0" b="1"><ns4:solidFill><ns4:srgbClr val="FFFFFF"/></ns4:solidFill><ns4:latin typeface="Georgia"/><ns4:ea typeface="Georgia"/></ns4:defRPr></ns4:lvl1pPr><ns4:lvl2pPr algn="l"><ns4:buNone/><ns4:defRPr sz="2800" dirty="0" b="1"><ns4:solidFill><ns4:srgbClr val="FFFFFF"/></ns4:solidFill><ns4:latin typeface="Georgia"/><ns4:ea typeface="Georgia"/></ns4:defRPr></ns4:lvl2pPr><ns4:lvl3pPr algn="l"><ns4:buNone/><ns4:defRPr sz="2800" dirty="0" b="1"><ns4:solidFill><ns4:srgbClr val="FFFFFF"/></ns4:solidFill><ns4:latin typeface="Georgia"/><ns4:ea typeface="Georgia"/></ns4:defRPr></ns4:lvl3pPr><ns4:lvl4pPr algn="l"><ns4:buNone/><ns4:defRPr sz="2800" dirty="0" b="1"><ns4:solidFill><ns4:srgbClr val="FFFFFF"/></ns4:solidFill><ns4:latin typeface="Georgia"/><ns4:ea typeface="Georgia"/></ns4:defRPr></ns4:lvl4pPr><ns4:lvl5pPr algn="l"><ns4:buNone/><ns4:defRPr sz="2800" dirty="0" b="1"><ns4:solidFill><ns4:srgbClr val="FFFFFF"/></ns4:solidFill><ns4:latin typeface="Georgia"/><ns4:ea typeface="Georgia"/></ns4:defRPr></ns4:lvl5pPr><ns4:lvl6pPr algn="l"><ns4:buNone/><ns4:defRPr sz="2800" dirty="0" b="1"><ns4:solidFill><ns4:srgbClr val="FFFFFF"/></ns4:solidFill><ns4:latin typeface="Georgia"/><ns4:ea typeface="Georgia"/></ns4:defRPr></ns4:lvl6pPr><ns4:lvl7pPr algn="l"><ns4:buNone/><ns4:defRPr sz="2800" dirty="0" b="1"><ns4:solidFill><ns4:srgbClr val="FFFFFF"/></ns4:solidFill><ns4:latin typeface="Georgia"/><ns4:ea typeface="Georgia"/></ns4:defRPr></ns4:lvl7pPr><ns4:lvl8pPr algn="l"><ns4:buNone/><ns4:defRPr sz="2800" dirty="0" b="1"><ns4:solidFill><ns4:srgbClr val="FFFFFF"/></ns4:solidFill><ns4:latin typeface="Georgia"/><ns4:ea typeface="Georgia"/></ns4:defRPr></ns4:lvl8pPr><ns4:lvl9pPr algn="l"><ns4:buNone/><ns4:defRPr sz="2800" dirty="0" b="1"><ns4:solidFill><ns4:srgbClr val="FFFFFF"/></ns4:solidFill><ns4:latin typeface="Georgia"/><ns4:ea typeface="Georgia"/></ns4:defRPr></ns4:lvl9pPr></ns4:lstStyle/><ns5:p xmlns:ns5="http://schemas.openxmlformats.org/drawingml/2006/main"><ns5:pPr algn="l"><ns5:buNone/></ns5:pPr><ns5:r><ns5:rPr lang="ja-JP"/><ns5:t>サブタイトル</ns5:t></ns5:r></ns5:p></ns0:txBody></ns0:sp><ns0:sp><ns0:nvSpPr><ns0:cNvPr id="5" name="FindingsPanel"/><ns0:cNvSpPr><ns1:spLocks xmlns:ns1="http://schemas.openxmlformats.org/drawingml/2006/main" noGrp="1" noSelect="0" noRot="1" noMove="1"/></ns0:cNvSpPr><ns0:nvPr/></ns0:nvSpPr><ns0:spPr><ns2:xfrm xmlns:ns2="http://schemas.openxmlformats.org/drawingml/2006/main"><ns2:off x="457200" y="1280160"/><ns2:ext cx="7132320" cy="5029200"/></ns2:xfrm><ns3:prstGeom xmlns:ns3="http://schemas.openxmlformats.org/drawingml/2006/main" prst="roundRect"><ns3:avLst><ns3:gd name="adj" fmla="val 8000"/></ns3:avLst></ns3:prstGeom><ns4:solidFill xmlns:ns4="http://schemas.openxmlformats.org/drawingml/2006/main"><ns4:srgbClr val="EDF0F7"/></ns4:solidFill><ns5:ln xmlns:ns5="http://schemas.openxmlformats.org/drawingml/2006/main"><ns5:noFill/></ns5:ln></ns0:spPr></ns0:sp><ns0:sp><ns0:nvSpPr><ns0:cNvPr id="6" name="RecPanel"/><ns0:cNvSpPr><ns1:spLocks xmlns:ns1="http://schemas.openxmlformats.org/drawingml/2006/main" noGrp="1" noSelect="0" noRot="1" noMove="1"/></ns0:cNvSpPr><ns0:nvPr/></ns0:nvSpPr><ns0:spPr><ns2:xfrm xmlns:ns2="http://schemas.openxmlformats.org/drawingml/2006/main"><ns2:off x="7863840" y="1280160"/><ns2:ext cx="3749039" cy="5029200"/></ns2:xfrm><ns3:prstGeom xmlns:ns3="http://schemas.openxmlformats.org/drawingml/2006/main" prst="roundRect"><ns3:avLst><ns3:gd name="adj" fmla="val 8000"/></ns3:avLst></ns3:prstGeom><ns4:solidFill xmlns:ns4="http://schemas.openxmlformats.org/drawingml/2006/main"><ns4:srgbClr val="F0F4FF"/></ns4:solidFill><ns5:ln xmlns:ns5="http://schemas.openxmlformats.org/drawingml/2006/main"><ns5:noFill/></ns5:ln></ns0:spPr></ns0:sp><ns0:sp><ns0:nvSpPr><ns0:cNvPr id="7" name="RecAccent"/><ns0:cNvSpPr><ns1:spLocks xmlns:ns1="http://schemas.openxmlformats.org/drawingml/2006/main" noGrp="1" noSelect="0" noRot="1" noMove="1"/></ns0:cNvSpPr><ns0:nvPr/></ns0:nvSpPr><ns0:spPr><ns2:xfrm xmlns:ns2="http://schemas.openxmlformats.org/drawingml/2006/main"><ns2:off x="7863840" y="1280160"/><ns2:ext cx="54864" cy="5029200"/></ns2:xfrm><ns3:prstGeom xmlns:ns3="http://schemas.openxmlformats.org/drawingml/2006/main" prst="rect"/><ns4:solidFill xmlns:ns4="http://schemas.openxmlformats.org/drawingml/2006/main"><ns4:srgbClr val="3B82F6"/></ns4:solidFill><ns5:ln xmlns:ns5="http://schemas.openxmlformats.org/drawingml/2006/main"><ns5:noFill/></ns5:ln></ns0:spPr></ns0:sp><ns0:sp><ns0:nvSpPr><ns0:cNvPr id="20" name="Body1.Left"/><ns0:cNvSpPr><ns1:spLocks xmlns:ns1="http://schemas.openxmlformats.org/drawingml/2006/main" noGrp="1"/></ns0:cNvSpPr><ns0:nvPr><ns0:ph idx="1" type="body"/></ns0:nvPr></ns0:nvSpPr><ns0:spPr><ns2:xfrm xmlns:ns2="http://schemas.openxmlformats.org/drawingml/2006/main"><ns2:off x="822960" y="1554480"/><ns2:ext cx="6400800" cy="4572000"/></ns2:xfrm></ns0:spPr><ns0:txBody><ns3:bodyPr xmlns:ns3="http://schemas.openxmlformats.org/drawingml/2006/main" wrap="square" anchor="t" anchorCtr="0"/><ns4:lstStyle/><ns4:defPPr algn="l"><ns4:buNone/><ns4:defRPr sz="1400" dirty="0"><ns4:solidFill><ns4:srgbClr val="1E293B"/></ns4:solidFill><ns4:latin typeface="Calibri"/><ns4:ea typeface="Calibri"/></ns4:defRPr></ns4:defPPr><ns4:lvl1pPr algn="l"><ns4:buNone/><ns4:defRPr sz="1400" dirty="0"><ns4:solidFill><ns4:srgbClr val="1E293B"/></ns4:solidFill><ns4:latin typeface="Calibri"/><ns4:ea typeface="Calibri"/></ns4:defRPr></ns4:lvl1pPr><ns4:lvl2pPr algn="l"><ns4:buNone/><ns4:defRPr sz="1400" dirty="0"><ns4:solidFill><ns4:srgbClr val="1E293B"/></ns4:solidFill><ns4:latin typeface="Calibri"/><ns4:ea typeface="Calibri"/></ns4:defRPr></ns4:lvl2pPr><ns4:lvl3pPr algn="l"><ns4:buNone/><ns4:defRPr sz="1400" dirty="0"><ns4:solidFill><ns4:srgbClr val="1E293B"/></ns4:solidFill><ns4:latin typeface="Calibri"/><ns4:ea typeface="Calibri"/></ns4:defRPr></ns4:lvl3pPr><ns4:lvl4pPr algn="l"><ns4:buNone/><ns4:defRPr sz="1400" dirty="0"><ns4:solidFill><ns4:srgbClr val="1E293B"/></ns4:solidFill><ns4:latin typeface="Calibri"/><ns4:ea typeface="Calibri"/></ns4:defRPr></ns4:lvl4pPr><ns4:lvl5pPr algn="l"><ns4:buNone/><ns4:defRPr sz="1400" dirty="0"><ns4:solidFill><ns4:srgbClr val="1E293B"/></ns4:solidFill><ns4:latin typeface="Calibri"/><ns4:ea typeface="Calibri"/></ns4:defRPr></ns4:lvl5pPr><ns4:lvl6pPr algn="l"><ns4:buNone/><ns4:defRPr sz="1400" dirty="0"><ns4:solidFill><ns4:srgbClr val="1E293B"/></ns4:solidFill><ns4:latin typeface="Calibri"/><ns4:ea typeface="Calibri"/></ns4:defRPr></ns4:lvl6pPr><ns4:lvl7pPr algn="l"><ns4:buNone/><ns4:defRPr sz="1400" dirty="0"><ns4:solidFill><ns4:srgbClr val="1E293B"/></ns4:solidFill><ns4:latin typeface="Calibri"/><ns4:ea typeface="Calibri"/></ns4:defRPr></ns4:lvl7pPr><ns4:lvl8pPr algn="l"><ns4:buNone/><ns4:defRPr sz="1400" dirty="0"><ns4:solidFill><ns4:srgbClr val="1E293B"/></ns4:solidFill><ns4:latin typeface="Calibri"/><ns4:ea typeface="Calibri"/></ns4:defRPr></ns4:lvl8pPr><ns4:lvl9pPr algn="l"><ns4:buNone/><ns4:defRPr sz="1400" dirty="0"><ns4:solidFill><ns4:srgbClr val="1E293B"/></ns4:solidFill><ns4:latin typeface="Calibri"/><ns4:ea typeface="Calibri"/></ns4:defRPr></ns4:lvl9pPr></ns4:lstStyle/><ns5:p xmlns:ns5="http://schemas.openxmlformats.org/drawingml/2006/main"><ns5:pPr algn="l"><ns5:buNone/></ns5:pPr><ns5:r><ns5:rPr lang="ja-JP"/><ns5:t>推奨アクション
 
 優先度：高
 
-対応策を記入</ns5:t></ns5:r></ns5:p></ns0:txBody></ns0:sp><ns0:sp><ns0:nvSpPr><ns0:cNvPr id="30" name="SlideNum.Footer"/><ns0:cNvSpPr><ns1:spLocks xmlns:ns1="http://schemas.openxmlformats.org/drawingml/2006/main" noGrp="1"/></ns0:cNvSpPr><ns0:nvPr><ns0:ph idx="50" type="sldNum"/></ns0:nvPr></ns0:nvSpPr><ns0:spPr><ns2:xfrm xmlns:ns2="http://schemas.openxmlformats.org/drawingml/2006/main"><ns2:off x="10972800" y="6446520"/><ns2:ext cx="1097280" cy="274320"/></ns2:xfrm></ns0:spPr><ns0:txBody><ns3:bodyPr xmlns:ns3="http://schemas.openxmlformats.org/drawingml/2006/main" wrap="square" anchor="t" anchorCtr="0"/><ns4:lstStyle xmlns:ns4="http://schemas.openxmlformats.org/drawingml/2006/main"><ns4:defPPr algn="r"><ns4:buNone/><ns4:defRPr sz="1000" dirty="0"><ns4:solidFill><ns4:srgbClr val="94A3B8"/></ns4:solidFill><ns4:latin typeface="Calibri"/><ns4:ea typeface="Calibri"/></ns4:defRPr></ns4:defPPr><ns4:lvl1pPr algn="r"><ns4:buNone/><ns4:defRPr sz="1000" dirty="0"><ns4:solidFill><ns4:srgbClr val="94A3B8"/></ns4:solidFill><ns4:latin typeface="Calibri"/><ns4:ea typeface="Calibri"/></ns4:defRPr></ns4:lvl1pPr><ns4:lvl2pPr algn="r"><ns4:buNone/><ns4:defRPr sz="1000" dirty="0"><ns4:solidFill><ns4:srgbClr val="94A3B8"/></ns4:solidFill><ns4:latin typeface="Calibri"/><ns4:ea typeface="Calibri"/></ns4:defRPr></ns4:lvl2pPr><ns4:lvl3pPr algn="r"><ns4:buNone/><ns4:defRPr sz="1000" dirty="0"><ns4:solidFill><ns4:srgbClr val="94A3B8"/></ns4:solidFill><ns4:latin typeface="Calibri"/><ns4:ea typeface="Calibri"/></ns4:defRPr></ns4:lvl3pPr><ns4:lvl4pPr algn="r"><ns4:buNone/><ns4:defRPr sz="1000" dirty="0"><ns4:solidFill><ns4:srgbClr val="94A3B8"/></ns4:solidFill><ns4:latin typeface="Calibri"/><ns4:ea typeface="Calibri"/></ns4:defRPr></ns4:lvl4pPr><ns4:lvl5pPr algn="r"><ns4:buNone/><ns4:defRPr sz="1000" dirty="0"><ns4:solidFill><ns4:srgbClr val="94A3B8"/></ns4:solidFill><ns4:latin typeface="Calibri"/><ns4:ea typeface="Calibri"/></ns4:defRPr></ns4:lvl5pPr><ns4:lvl6pPr algn="r"><ns4:buNone/><ns4:defRPr sz="1000" dirty="0"><ns4:solidFill><ns4:srgbClr val="94A3B8"/></ns4:solidFill><ns4:latin typeface="Calibri"/><ns4:ea typeface="Calibri"/></ns4:defRPr></ns4:lvl6pPr><ns4:lvl7pPr algn="r"><ns4:buNone/><ns4:defRPr sz="1000" dirty="0"><ns4:solidFill><ns4:srgbClr val="94A3B8"/></ns4:solidFill><ns4:latin typeface="Calibri"/><ns4:ea typeface="Calibri"/></ns4:defRPr></ns4:lvl7pPr><ns4:lvl8pPr algn="r"><ns4:buNone/><ns4:defRPr sz="1000" dirty="0"><ns4:solidFill><ns4:srgbClr val="94A3B8"/></ns4:solidFill><ns4:latin typeface="Calibri"/><ns4:ea typeface="Calibri"/></ns4:defRPr></ns4:lvl8pPr><ns4:lvl9pPr algn="r"><ns4:buNone/><ns4:defRPr sz="1000" dirty="0"><ns4:solidFill><ns4:srgbClr val="94A3B8"/></ns4:solidFill><ns4:latin typeface="Calibri"/><ns4:ea typeface="Calibri"/></ns4:defRPr></ns4:lvl9pPr></ns4:lstStyle><ns5:p xmlns:ns5="http://schemas.openxmlformats.org/drawingml/2006/main"><ns5:pPr algn="r"><ns5:buNone/></ns5:pPr><ns5:r><ns5:rPr lang="ja-JP"/><ns5:t>&lt;#&gt;</ns5:t></ns5:r></ns5:p></ns0:txBody></ns0:sp></ns0:spTree></ns0:cSld><ns0:clrMapOvr/></ns0:sldLayout>
+対応策を記入</ns5:t></ns5:r></ns5:p></ns0:txBody></ns0:sp><ns0:sp><ns0:nvSpPr><ns0:cNvPr id="30" name="SlideNum.Footer"/><ns0:cNvSpPr><ns1:spLocks xmlns:ns1="http://schemas.openxmlformats.org/drawingml/2006/main" noGrp="1"/></ns0:cNvSpPr><ns0:nvPr><ns0:ph idx="50" type="sldNum"/></ns0:nvPr></ns0:nvSpPr><ns0:spPr><ns2:xfrm xmlns:ns2="http://schemas.openxmlformats.org/drawingml/2006/main"><ns2:off x="10972800" y="6446520"/><ns2:ext cx="1097280" cy="274320"/></ns2:xfrm></ns0:spPr><ns0:txBody><ns3:bodyPr xmlns:ns3="http://schemas.openxmlformats.org/drawingml/2006/main" wrap="square" anchor="t" anchorCtr="0"/><ns4:lstStyle><ns4:defPPr algn="r"><ns4:defRPr sz="1000"><ns4:solidFill><ns4:srgbClr val="94A3B8"/></ns4:solidFill></ns4:defRPr></ns4:defPPr></ns4:lstStyle><ns4:defPPr algn="r"><ns4:buNone/><ns4:defRPr sz="1000" dirty="0"><ns4:solidFill><ns4:srgbClr val="94A3B8"/></ns4:solidFill><ns4:latin typeface="Calibri"/><ns4:ea typeface="Calibri"/></ns4:defRPr></ns4:defPPr><ns4:lvl1pPr algn="r"><ns4:buNone/><ns4:defRPr sz="1000" dirty="0"><ns4:solidFill><ns4:srgbClr val="94A3B8"/></ns4:solidFill><ns4:latin typeface="Calibri"/><ns4:ea typeface="Calibri"/></ns4:defRPr></ns4:lvl1pPr><ns4:lvl2pPr algn="r"><ns4:buNone/><ns4:defRPr sz="1000" dirty="0"><ns4:solidFill><ns4:srgbClr val="94A3B8"/></ns4:solidFill><ns4:latin typeface="Calibri"/><ns4:ea typeface="Calibri"/></ns4:defRPr></ns4:lvl2pPr><ns4:lvl3pPr algn="r"><ns4:buNone/><ns4:defRPr sz="1000" dirty="0"><ns4:solidFill><ns4:srgbClr val="94A3B8"/></ns4:solidFill><ns4:latin typeface="Calibri"/><ns4:ea typeface="Calibri"/></ns4:defRPr></ns4:lvl3pPr><ns4:lvl4pPr algn="r"><ns4:buNone/><ns4:defRPr sz="1000" dirty="0"><ns4:solidFill><ns4:srgbClr val="94A3B8"/></ns4:solidFill><ns4:latin typeface="Calibri"/><ns4:ea typeface="Calibri"/></ns4:defRPr></ns4:lvl4pPr><ns4:lvl5pPr algn="r"><ns4:buNone/><ns4:defRPr sz="1000" dirty="0"><ns4:solidFill><ns4:srgbClr val="94A3B8"/></ns4:solidFill><ns4:latin typeface="Calibri"/><ns4:ea typeface="Calibri"/></ns4:defRPr></ns4:lvl5pPr><ns4:lvl6pPr algn="r"><ns4:buNone/><ns4:defRPr sz="1000" dirty="0"><ns4:solidFill><ns4:srgbClr val="94A3B8"/></ns4:solidFill><ns4:latin typeface="Calibri"/><ns4:ea typeface="Calibri"/></ns4:defRPr></ns4:lvl6pPr><ns4:lvl7pPr algn="r"><ns4:buNone/><ns4:defRPr sz="1000" dirty="0"><ns4:solidFill><ns4:srgbClr val="94A3B8"/></ns4:solidFill><ns4:latin typeface="Calibri"/><ns4:ea typeface="Calibri"/></ns4:defRPr></ns4:lvl7pPr><ns4:lvl8pPr algn="r"><ns4:buNone/><ns4:defRPr sz="1000" dirty="0"><ns4:solidFill><ns4:srgbClr val="94A3B8"/></ns4:solidFill><ns4:latin typeface="Calibri"/><ns4:ea typeface="Calibri"/></ns4:defRPr></ns4:lvl8pPr><ns4:lvl9pPr algn="r"><ns4:buNone/><ns4:defRPr sz="1000" dirty="0"><ns4:solidFill><ns4:srgbClr val="94A3B8"/></ns4:solidFill><ns4:latin typeface="Calibri"/><ns4:ea typeface="Calibri"/></ns4:defRPr></ns4:lvl9pPr></ns4:lstStyle><ns5:p xmlns:ns5="http://schemas.openxmlformats.org/drawingml/2006/main"><ns5:pPr algn="r"><ns5:buNone/></ns5:pPr><ns5:r><ns5:rPr lang="ja-JP"/><ns5:t>&lt;#&gt;</ns5:t></ns5:r></ns5:p></ns0:txBody></ns0:sp></ns0:spTree></ns0:cSld><ns0:clrMapOvr/></ns0:sldLayout>
 </file>
 
 <file path=ppt/slideLayouts/slideLayout29.xml><?xml version='1.0' encoding='UTF-8' standalone='yes'?>
-<ns0:sldLayout xmlns:ns0="http://schemas.openxmlformats.org/presentationml/2006/main" type="blank" preserve="1"><ns0:cSld name="Closing.1Message.Single"><ns0:spTree><ns0:nvGrpSpPr><ns0:cNvPr id="1" name=""/><ns0:cNvGrpSpPr/><ns0:nvPr/></ns0:nvGrpSpPr><ns0:grpSpPr><ns1:xfrm xmlns:ns1="http://schemas.openxmlformats.org/drawingml/2006/main"><ns1:off x="0" y="0"/><ns1:ext cx="0" cy="0"/><ns1:chOff x="0" y="0"/><ns1:chExt cx="0" cy="0"/></ns1:xfrm></ns0:grpSpPr><ns0:sp><ns0:nvSpPr><ns0:cNvPr id="2" name="BG"/><ns0:cNvSpPr><ns1:spLocks xmlns:ns1="http://schemas.openxmlformats.org/drawingml/2006/main" noGrp="1" noSelect="0" noRot="1" noMove="1"/></ns0:cNvSpPr><ns0:nvPr/></ns0:nvSpPr><ns0:spPr><ns2:xfrm xmlns:ns2="http://schemas.openxmlformats.org/drawingml/2006/main"><ns2:off x="0" y="0"/><ns2:ext cx="12192000" cy="6858000"/></ns2:xfrm><ns3:prstGeom xmlns:ns3="http://schemas.openxmlformats.org/drawingml/2006/main" prst="rect"/><ns4:solidFill xmlns:ns4="http://schemas.openxmlformats.org/drawingml/2006/main"><ns4:srgbClr val="1E2761"/></ns4:solidFill><ns5:ln xmlns:ns5="http://schemas.openxmlformats.org/drawingml/2006/main"><ns5:noFill/></ns5:ln></ns0:spPr></ns0:sp><ns0:sp><ns0:nvSpPr><ns0:cNvPr id="3" name="AccentBar"/><ns0:cNvSpPr><ns1:spLocks xmlns:ns1="http://schemas.openxmlformats.org/drawingml/2006/main" noGrp="1" noSelect="0" noRot="1" noMove="1"/></ns0:cNvSpPr><ns0:nvPr/></ns0:nvSpPr><ns0:spPr><ns2:xfrm xmlns:ns2="http://schemas.openxmlformats.org/drawingml/2006/main"><ns2:off x="0" y="0"/><ns2:ext cx="164592" cy="6858000"/></ns2:xfrm><ns3:prstGeom xmlns:ns3="http://schemas.openxmlformats.org/drawingml/2006/main" prst="rect"/><ns4:solidFill xmlns:ns4="http://schemas.openxmlformats.org/drawingml/2006/main"><ns4:srgbClr val="3B82F6"/></ns4:solidFill><ns5:ln xmlns:ns5="http://schemas.openxmlformats.org/drawingml/2006/main"><ns5:noFill/></ns5:ln></ns0:spPr></ns0:sp><ns0:sp><ns0:nvSpPr><ns0:cNvPr id="4" name="BottomPanel"/><ns0:cNvSpPr><ns1:spLocks xmlns:ns1="http://schemas.openxmlformats.org/drawingml/2006/main" noGrp="1" noSelect="0" noRot="1" noMove="1"/></ns0:cNvSpPr><ns0:nvPr/></ns0:nvSpPr><ns0:spPr><ns2:xfrm xmlns:ns2="http://schemas.openxmlformats.org/drawingml/2006/main"><ns2:off x="0" y="4389120"/><ns2:ext cx="12192000" cy="2468880"/></ns2:xfrm><ns3:prstGeom xmlns:ns3="http://schemas.openxmlformats.org/drawingml/2006/main" prst="rect"/><ns4:solidFill xmlns:ns4="http://schemas.openxmlformats.org/drawingml/2006/main"><ns4:srgbClr val="141B41"/></ns4:solidFill><ns5:ln xmlns:ns5="http://schemas.openxmlformats.org/drawingml/2006/main"><ns5:noFill/></ns5:ln></ns0:spPr></ns0:sp><ns0:sp><ns0:nvSpPr><ns0:cNvPr id="10" name="CategoryLabel.Top"/><ns0:cNvSpPr><ns1:spLocks xmlns:ns1="http://schemas.openxmlformats.org/drawingml/2006/main" noGrp="1"/></ns0:cNvSpPr><ns0:nvPr><ns0:ph idx="10" type="body"/></ns0:nvPr></ns0:nvSpPr><ns0:spPr><ns2:xfrm xmlns:ns2="http://schemas.openxmlformats.org/drawingml/2006/main"><ns2:off x="1097280" y="1371600"/><ns2:ext cx="9144000" cy="457200"/></ns2:xfrm></ns0:spPr><ns0:txBody><ns3:bodyPr xmlns:ns3="http://schemas.openxmlformats.org/drawingml/2006/main" wrap="square" anchor="t" anchorCtr="0"/><ns4:lstStyle xmlns:ns4="http://schemas.openxmlformats.org/drawingml/2006/main"><ns4:defPPr algn="l"><ns4:buNone/><ns4:defRPr sz="1800" dirty="0" b="1"><ns4:solidFill><ns4:srgbClr val="3B82F6"/></ns4:solidFill><ns4:latin typeface="Calibri"/><ns4:ea typeface="Calibri"/></ns4:defRPr></ns4:defPPr><ns4:lvl1pPr algn="l"><ns4:buNone/><ns4:defRPr sz="1800" dirty="0" b="1"><ns4:solidFill><ns4:srgbClr val="3B82F6"/></ns4:solidFill><ns4:latin typeface="Calibri"/><ns4:ea typeface="Calibri"/></ns4:defRPr></ns4:lvl1pPr><ns4:lvl2pPr algn="l"><ns4:buNone/><ns4:defRPr sz="1800" dirty="0" b="1"><ns4:solidFill><ns4:srgbClr val="3B82F6"/></ns4:solidFill><ns4:latin typeface="Calibri"/><ns4:ea typeface="Calibri"/></ns4:defRPr></ns4:lvl2pPr><ns4:lvl3pPr algn="l"><ns4:buNone/><ns4:defRPr sz="1800" dirty="0" b="1"><ns4:solidFill><ns4:srgbClr val="3B82F6"/></ns4:solidFill><ns4:latin typeface="Calibri"/><ns4:ea typeface="Calibri"/></ns4:defRPr></ns4:lvl3pPr><ns4:lvl4pPr algn="l"><ns4:buNone/><ns4:defRPr sz="1800" dirty="0" b="1"><ns4:solidFill><ns4:srgbClr val="3B82F6"/></ns4:solidFill><ns4:latin typeface="Calibri"/><ns4:ea typeface="Calibri"/></ns4:defRPr></ns4:lvl4pPr><ns4:lvl5pPr algn="l"><ns4:buNone/><ns4:defRPr sz="1800" dirty="0" b="1"><ns4:solidFill><ns4:srgbClr val="3B82F6"/></ns4:solidFill><ns4:latin typeface="Calibri"/><ns4:ea typeface="Calibri"/></ns4:defRPr></ns4:lvl5pPr><ns4:lvl6pPr algn="l"><ns4:buNone/><ns4:defRPr sz="1800" dirty="0" b="1"><ns4:solidFill><ns4:srgbClr val="3B82F6"/></ns4:solidFill><ns4:latin typeface="Calibri"/><ns4:ea typeface="Calibri"/></ns4:defRPr></ns4:lvl6pPr><ns4:lvl7pPr algn="l"><ns4:buNone/><ns4:defRPr sz="1800" dirty="0" b="1"><ns4:solidFill><ns4:srgbClr val="3B82F6"/></ns4:solidFill><ns4:latin typeface="Calibri"/><ns4:ea typeface="Calibri"/></ns4:defRPr></ns4:lvl7pPr><ns4:lvl8pPr algn="l"><ns4:buNone/><ns4:defRPr sz="1800" dirty="0" b="1"><ns4:solidFill><ns4:srgbClr val="3B82F6"/></ns4:solidFill><ns4:latin typeface="Calibri"/><ns4:ea typeface="Calibri"/></ns4:defRPr></ns4:lvl8pPr><ns4:lvl9pPr algn="l"><ns4:buNone/><ns4:defRPr sz="1800" dirty="0" b="1"><ns4:solidFill><ns4:srgbClr val="3B82F6"/></ns4:solidFill><ns4:latin typeface="Calibri"/><ns4:ea typeface="Calibri"/></ns4:defRPr></ns4:lvl9pPr></ns4:lstStyle/><ns5:p xmlns:ns5="http://schemas.openxmlformats.org/drawingml/2006/main"><ns5:pPr algn="l"><ns5:buNone/></ns5:pPr><ns5:r><ns5:rPr lang="ja-JP"/><ns5:t>ご質問をお待ちしています</ns5:t></ns5:r></ns5:p></ns0:txBody></ns0:sp><ns0:sp><ns0:nvSpPr><ns0:cNvPr id="12" name="PresenterName.Bottom"/><ns0:cNvSpPr><ns1:spLocks xmlns:ns1="http://schemas.openxmlformats.org/drawingml/2006/main" noGrp="1"/></ns0:cNvSpPr><ns0:nvPr><ns0:ph idx="11" type="body"/></ns0:nvPr></ns0:nvSpPr><ns0:spPr><ns2:xfrm xmlns:ns2="http://schemas.openxmlformats.org/drawingml/2006/main"><ns2:off x="1097280" y="4754880"/><ns2:ext cx="7315200" cy="457200"/></ns2:xfrm></ns0:spPr><ns0:txBody><ns3:bodyPr xmlns:ns3="http://schemas.openxmlformats.org/drawingml/2006/main" wrap="square" anchor="t" anchorCtr="0"/><ns4:lstStyle xmlns:ns4="http://schemas.openxmlformats.org/drawingml/2006/main"><ns4:defPPr algn="l"><ns4:buNone/><ns4:defRPr sz="1600" dirty="0"><ns4:solidFill><ns4:srgbClr val="CADCFC"/></ns4:solidFill><ns4:latin typeface="Calibri"/><ns4:ea typeface="Calibri"/></ns4:defRPr></ns4:defPPr><ns4:lvl1pPr algn="l"><ns4:buNone/><ns4:defRPr sz="1600" dirty="0"><ns4:solidFill><ns4:srgbClr val="CADCFC"/></ns4:solidFill><ns4:latin typeface="Calibri"/><ns4:ea typeface="Calibri"/></ns4:defRPr></ns4:lvl1pPr><ns4:lvl2pPr algn="l"><ns4:buNone/><ns4:defRPr sz="1600" dirty="0"><ns4:solidFill><ns4:srgbClr val="CADCFC"/></ns4:solidFill><ns4:latin typeface="Calibri"/><ns4:ea typeface="Calibri"/></ns4:defRPr></ns4:lvl2pPr><ns4:lvl3pPr algn="l"><ns4:buNone/><ns4:defRPr sz="1600" dirty="0"><ns4:solidFill><ns4:srgbClr val="CADCFC"/></ns4:solidFill><ns4:latin typeface="Calibri"/><ns4:ea typeface="Calibri"/></ns4:defRPr></ns4:lvl3pPr><ns4:lvl4pPr algn="l"><ns4:buNone/><ns4:defRPr sz="1600" dirty="0"><ns4:solidFill><ns4:srgbClr val="CADCFC"/></ns4:solidFill><ns4:latin typeface="Calibri"/><ns4:ea typeface="Calibri"/></ns4:defRPr></ns4:lvl4pPr><ns4:lvl5pPr algn="l"><ns4:buNone/><ns4:defRPr sz="1600" dirty="0"><ns4:solidFill><ns4:srgbClr val="CADCFC"/></ns4:solidFill><ns4:latin typeface="Calibri"/><ns4:ea typeface="Calibri"/></ns4:defRPr></ns4:lvl5pPr><ns4:lvl6pPr algn="l"><ns4:buNone/><ns4:defRPr sz="1600" dirty="0"><ns4:solidFill><ns4:srgbClr val="CADCFC"/></ns4:solidFill><ns4:latin typeface="Calibri"/><ns4:ea typeface="Calibri"/></ns4:defRPr></ns4:lvl6pPr><ns4:lvl7pPr algn="l"><ns4:buNone/><ns4:defRPr sz="1600" dirty="0"><ns4:solidFill><ns4:srgbClr val="CADCFC"/></ns4:solidFill><ns4:latin typeface="Calibri"/><ns4:ea typeface="Calibri"/></ns4:defRPr></ns4:lvl7pPr><ns4:lvl8pPr algn="l"><ns4:buNone/><ns4:defRPr sz="1600" dirty="0"><ns4:solidFill><ns4:srgbClr val="CADCFC"/></ns4:solidFill><ns4:latin typeface="Calibri"/><ns4:ea typeface="Calibri"/></ns4:defRPr></ns4:lvl8pPr><ns4:lvl9pPr algn="l"><ns4:buNone/><ns4:defRPr sz="1600" dirty="0"><ns4:solidFill><ns4:srgbClr val="CADCFC"/></ns4:solidFill><ns4:latin typeface="Calibri"/><ns4:ea typeface="Calibri"/></ns4:defRPr></ns4:lvl9pPr></ns4:lstStyle/><ns5:p xmlns:ns5="http://schemas.openxmlformats.org/drawingml/2006/main"><ns5:pPr algn="l"><ns5:buNone/></ns5:pPr><ns5:r><ns5:rPr lang="ja-JP"/><ns5:t>email@example.com  |  内線: 0000
+<ns0:sldLayout xmlns:ns0="http://schemas.openxmlformats.org/presentationml/2006/main" type="blank" preserve="1"><ns0:cSld name="Closing.1Message.Single"><ns0:spTree><ns0:nvGrpSpPr><ns0:cNvPr id="1" name=""/><ns0:cNvGrpSpPr/><ns0:nvPr/></ns0:nvGrpSpPr><ns0:grpSpPr><ns1:xfrm xmlns:ns1="http://schemas.openxmlformats.org/drawingml/2006/main"><ns1:off x="0" y="0"/><ns1:ext cx="0" cy="0"/><ns1:chOff x="0" y="0"/><ns1:chExt cx="0" cy="0"/></ns1:xfrm></ns0:grpSpPr><ns0:sp><ns0:nvSpPr><ns0:cNvPr id="2" name="BG"/><ns0:cNvSpPr><ns1:spLocks xmlns:ns1="http://schemas.openxmlformats.org/drawingml/2006/main" noGrp="1" noSelect="0" noRot="1" noMove="1"/></ns0:cNvSpPr><ns0:nvPr/></ns0:nvSpPr><ns0:spPr><ns2:xfrm xmlns:ns2="http://schemas.openxmlformats.org/drawingml/2006/main"><ns2:off x="0" y="0"/><ns2:ext cx="12192000" cy="6858000"/></ns2:xfrm><ns3:prstGeom xmlns:ns3="http://schemas.openxmlformats.org/drawingml/2006/main" prst="rect"/><ns4:solidFill xmlns:ns4="http://schemas.openxmlformats.org/drawingml/2006/main"><ns4:srgbClr val="1E2761"/></ns4:solidFill><ns5:ln xmlns:ns5="http://schemas.openxmlformats.org/drawingml/2006/main"><ns5:noFill/></ns5:ln></ns0:spPr></ns0:sp><ns0:sp><ns0:nvSpPr><ns0:cNvPr id="3" name="AccentBar"/><ns0:cNvSpPr><ns1:spLocks xmlns:ns1="http://schemas.openxmlformats.org/drawingml/2006/main" noGrp="1" noSelect="0" noRot="1" noMove="1"/></ns0:cNvSpPr><ns0:nvPr/></ns0:nvSpPr><ns0:spPr><ns2:xfrm xmlns:ns2="http://schemas.openxmlformats.org/drawingml/2006/main"><ns2:off x="0" y="0"/><ns2:ext cx="164592" cy="6858000"/></ns2:xfrm><ns3:prstGeom xmlns:ns3="http://schemas.openxmlformats.org/drawingml/2006/main" prst="rect"/><ns4:solidFill xmlns:ns4="http://schemas.openxmlformats.org/drawingml/2006/main"><ns4:srgbClr val="3B82F6"/></ns4:solidFill><ns5:ln xmlns:ns5="http://schemas.openxmlformats.org/drawingml/2006/main"><ns5:noFill/></ns5:ln></ns0:spPr></ns0:sp><ns0:sp><ns0:nvSpPr><ns0:cNvPr id="4" name="BottomPanel"/><ns0:cNvSpPr><ns1:spLocks xmlns:ns1="http://schemas.openxmlformats.org/drawingml/2006/main" noGrp="1" noSelect="0" noRot="1" noMove="1"/></ns0:cNvSpPr><ns0:nvPr/></ns0:nvSpPr><ns0:spPr><ns2:xfrm xmlns:ns2="http://schemas.openxmlformats.org/drawingml/2006/main"><ns2:off x="0" y="4389120"/><ns2:ext cx="12192000" cy="2468880"/></ns2:xfrm><ns3:prstGeom xmlns:ns3="http://schemas.openxmlformats.org/drawingml/2006/main" prst="rect"/><ns4:solidFill xmlns:ns4="http://schemas.openxmlformats.org/drawingml/2006/main"><ns4:srgbClr val="141B41"/></ns4:solidFill><ns5:ln xmlns:ns5="http://schemas.openxmlformats.org/drawingml/2006/main"><ns5:noFill/></ns5:ln></ns0:spPr></ns0:sp><ns0:sp><ns0:nvSpPr><ns0:cNvPr id="10" name="CategoryLabel.Top"/><ns0:cNvSpPr><ns1:spLocks xmlns:ns1="http://schemas.openxmlformats.org/drawingml/2006/main" noGrp="1"/></ns0:cNvSpPr><ns0:nvPr><ns0:ph idx="10" type="body"/></ns0:nvPr></ns0:nvSpPr><ns0:spPr><ns2:xfrm xmlns:ns2="http://schemas.openxmlformats.org/drawingml/2006/main"><ns2:off x="1097280" y="1371600"/><ns2:ext cx="9144000" cy="457200"/></ns2:xfrm></ns0:spPr><ns0:txBody><ns3:bodyPr xmlns:ns3="http://schemas.openxmlformats.org/drawingml/2006/main" wrap="square" anchor="t" anchorCtr="0"/><ns4:lstStyle><ns4:defPPr><ns4:defRPr sz="1800" b="1"><ns4:solidFill><ns4:srgbClr val="3B82F6"/></ns4:solidFill></ns4:defRPr></ns4:defPPr></ns4:lstStyle><ns4:defPPr algn="l"><ns4:buNone/><ns4:defRPr sz="1800" dirty="0" b="1"><ns4:solidFill><ns4:srgbClr val="3B82F6"/></ns4:solidFill><ns4:latin typeface="Calibri"/><ns4:ea typeface="Calibri"/></ns4:defRPr></ns4:defPPr><ns4:lvl1pPr algn="l"><ns4:buNone/><ns4:defRPr sz="1800" dirty="0" b="1"><ns4:solidFill><ns4:srgbClr val="3B82F6"/></ns4:solidFill><ns4:latin typeface="Calibri"/><ns4:ea typeface="Calibri"/></ns4:defRPr></ns4:lvl1pPr><ns4:lvl2pPr algn="l"><ns4:buNone/><ns4:defRPr sz="1800" dirty="0" b="1"><ns4:solidFill><ns4:srgbClr val="3B82F6"/></ns4:solidFill><ns4:latin typeface="Calibri"/><ns4:ea typeface="Calibri"/></ns4:defRPr></ns4:lvl2pPr><ns4:lvl3pPr algn="l"><ns4:buNone/><ns4:defRPr sz="1800" dirty="0" b="1"><ns4:solidFill><ns4:srgbClr val="3B82F6"/></ns4:solidFill><ns4:latin typeface="Calibri"/><ns4:ea typeface="Calibri"/></ns4:defRPr></ns4:lvl3pPr><ns4:lvl4pPr algn="l"><ns4:buNone/><ns4:defRPr sz="1800" dirty="0" b="1"><ns4:solidFill><ns4:srgbClr val="3B82F6"/></ns4:solidFill><ns4:latin typeface="Calibri"/><ns4:ea typeface="Calibri"/></ns4:defRPr></ns4:lvl4pPr><ns4:lvl5pPr algn="l"><ns4:buNone/><ns4:defRPr sz="1800" dirty="0" b="1"><ns4:solidFill><ns4:srgbClr val="3B82F6"/></ns4:solidFill><ns4:latin typeface="Calibri"/><ns4:ea typeface="Calibri"/></ns4:defRPr></ns4:lvl5pPr><ns4:lvl6pPr algn="l"><ns4:buNone/><ns4:defRPr sz="1800" dirty="0" b="1"><ns4:solidFill><ns4:srgbClr val="3B82F6"/></ns4:solidFill><ns4:latin typeface="Calibri"/><ns4:ea typeface="Calibri"/></ns4:defRPr></ns4:lvl6pPr><ns4:lvl7pPr algn="l"><ns4:buNone/><ns4:defRPr sz="1800" dirty="0" b="1"><ns4:solidFill><ns4:srgbClr val="3B82F6"/></ns4:solidFill><ns4:latin typeface="Calibri"/><ns4:ea typeface="Calibri"/></ns4:defRPr></ns4:lvl7pPr><ns4:lvl8pPr algn="l"><ns4:buNone/><ns4:defRPr sz="1800" dirty="0" b="1"><ns4:solidFill><ns4:srgbClr val="3B82F6"/></ns4:solidFill><ns4:latin typeface="Calibri"/><ns4:ea typeface="Calibri"/></ns4:defRPr></ns4:lvl8pPr><ns4:lvl9pPr algn="l"><ns4:buNone/><ns4:defRPr sz="1800" dirty="0" b="1"><ns4:solidFill><ns4:srgbClr val="3B82F6"/></ns4:solidFill><ns4:latin typeface="Calibri"/><ns4:ea typeface="Calibri"/></ns4:defRPr></ns4:lvl9pPr></ns4:lstStyle/><ns5:p xmlns:ns5="http://schemas.openxmlformats.org/drawingml/2006/main"><ns5:pPr algn="l"><ns5:buNone/></ns5:pPr><ns5:r><ns5:rPr lang="ja-JP"/><ns5:t>ご質問をお待ちしています</ns5:t></ns5:r></ns5:p></ns0:txBody></ns0:sp><ns0:sp><ns0:nvSpPr><ns0:cNvPr id="12" name="PresenterName.Bottom"/><ns0:cNvSpPr><ns1:spLocks xmlns:ns1="http://schemas.openxmlformats.org/drawingml/2006/main" noGrp="1"/></ns0:cNvSpPr><ns0:nvPr><ns0:ph idx="11" type="body"/></ns0:nvPr></ns0:nvSpPr><ns0:spPr><ns2:xfrm xmlns:ns2="http://schemas.openxmlformats.org/drawingml/2006/main"><ns2:off x="1097280" y="4754880"/><ns2:ext cx="7315200" cy="457200"/></ns2:xfrm></ns0:spPr><ns0:txBody><ns3:bodyPr xmlns:ns3="http://schemas.openxmlformats.org/drawingml/2006/main" wrap="square" anchor="t" anchorCtr="0"/><ns4:lstStyle><ns4:defPPr><ns4:defRPr sz="1600"><ns4:solidFill><ns4:srgbClr val="CADCFC"/></ns4:solidFill></ns4:defRPr></ns4:defPPr></ns4:lstStyle><ns4:defPPr algn="l"><ns4:buNone/><ns4:defRPr sz="1600" dirty="0"><ns4:solidFill><ns4:srgbClr val="CADCFC"/></ns4:solidFill><ns4:latin typeface="Calibri"/><ns4:ea typeface="Calibri"/></ns4:defRPr></ns4:defPPr><ns4:lvl1pPr algn="l"><ns4:buNone/><ns4:defRPr sz="1600" dirty="0"><ns4:solidFill><ns4:srgbClr val="CADCFC"/></ns4:solidFill><ns4:latin typeface="Calibri"/><ns4:ea typeface="Calibri"/></ns4:defRPr></ns4:lvl1pPr><ns4:lvl2pPr algn="l"><ns4:buNone/><ns4:defRPr sz="1600" dirty="0"><ns4:solidFill><ns4:srgbClr val="CADCFC"/></ns4:solidFill><ns4:latin typeface="Calibri"/><ns4:ea typeface="Calibri"/></ns4:defRPr></ns4:lvl2pPr><ns4:lvl3pPr algn="l"><ns4:buNone/><ns4:defRPr sz="1600" dirty="0"><ns4:solidFill><ns4:srgbClr val="CADCFC"/></ns4:solidFill><ns4:latin typeface="Calibri"/><ns4:ea typeface="Calibri"/></ns4:defRPr></ns4:lvl3pPr><ns4:lvl4pPr algn="l"><ns4:buNone/><ns4:defRPr sz="1600" dirty="0"><ns4:solidFill><ns4:srgbClr val="CADCFC"/></ns4:solidFill><ns4:latin typeface="Calibri"/><ns4:ea typeface="Calibri"/></ns4:defRPr></ns4:lvl4pPr><ns4:lvl5pPr algn="l"><ns4:buNone/><ns4:defRPr sz="1600" dirty="0"><ns4:solidFill><ns4:srgbClr val="CADCFC"/></ns4:solidFill><ns4:latin typeface="Calibri"/><ns4:ea typeface="Calibri"/></ns4:defRPr></ns4:lvl5pPr><ns4:lvl6pPr algn="l"><ns4:buNone/><ns4:defRPr sz="1600" dirty="0"><ns4:solidFill><ns4:srgbClr val="CADCFC"/></ns4:solidFill><ns4:latin typeface="Calibri"/><ns4:ea typeface="Calibri"/></ns4:defRPr></ns4:lvl6pPr><ns4:lvl7pPr algn="l"><ns4:buNone/><ns4:defRPr sz="1600" dirty="0"><ns4:solidFill><ns4:srgbClr val="CADCFC"/></ns4:solidFill><ns4:latin typeface="Calibri"/><ns4:ea typeface="Calibri"/></ns4:defRPr></ns4:lvl7pPr><ns4:lvl8pPr algn="l"><ns4:buNone/><ns4:defRPr sz="1600" dirty="0"><ns4:solidFill><ns4:srgbClr val="CADCFC"/></ns4:solidFill><ns4:latin typeface="Calibri"/><ns4:ea typeface="Calibri"/></ns4:defRPr></ns4:lvl8pPr><ns4:lvl9pPr algn="l"><ns4:buNone/><ns4:defRPr sz="1600" dirty="0"><ns4:solidFill><ns4:srgbClr val="CADCFC"/></ns4:solidFill><ns4:latin typeface="Calibri"/><ns4:ea typeface="Calibri"/></ns4:defRPr></ns4:lvl9pPr></ns4:lstStyle/><ns5:p xmlns:ns5="http://schemas.openxmlformats.org/drawingml/2006/main"><ns5:pPr algn="l"><ns5:buNone/></ns5:pPr><ns5:r><ns5:rPr lang="ja-JP"/><ns5:t>email@example.com  |  内線: 0000
 Slack: #channel</ns5:t></ns5:r></ns5:p></ns0:txBody></ns0:sp></ns0:spTree></ns0:cSld><ns0:clrMapOvr/></ns0:sldLayout>
 </file>
 
@@ -1418,9 +1386,9 @@
           <a:bodyPr wrap="square" anchor="t" anchorCtr="0"/>
           <a:lstStyle>
             <a:defPPr>
-              <a:defRPr>
-                <a:solidFill>
-                  <a:srgbClr val="FFFFFF"/>
+              <a:defRPr sz="1400" b="1">
+                <a:solidFill>
+                  <a:srgbClr val="3B82F6"/>
                 </a:solidFill>
               </a:defRPr>
             </a:defPPr>
@@ -1456,11 +1424,7 @@
           <a:bodyPr wrap="square" anchor="t" anchorCtr="0"/>
           <a:lstStyle>
             <a:defPPr>
-              <a:defRPr>
-                <a:solidFill>
-                  <a:srgbClr val="FFFFFF"/>
-                </a:solidFill>
-              </a:defRPr>
+              <a:defRPr sz="4200"/>
             </a:defPPr>
           </a:lstStyle>
           <a:p>
@@ -1494,7 +1458,7 @@
           <a:bodyPr wrap="square" anchor="t" anchorCtr="0"/>
           <a:lstStyle>
             <a:defPPr>
-              <a:defRPr>
+              <a:defRPr sz="1600">
                 <a:solidFill>
                   <a:srgbClr val="CADCFC"/>
                 </a:solidFill>
@@ -1534,7 +1498,7 @@
             <a:defPPr>
               <a:defRPr>
                 <a:solidFill>
-                  <a:srgbClr val="CADCFC"/>
+                  <a:srgbClr val="1E293B"/>
                 </a:solidFill>
               </a:defRPr>
             </a:defPPr>
@@ -1571,7 +1535,7 @@
           <a:bodyPr wrap="square" anchor="t" anchorCtr="0"/>
           <a:lstStyle>
             <a:defPPr>
-              <a:defRPr>
+              <a:defRPr sz="1100">
                 <a:solidFill>
                   <a:srgbClr val="CADCFC"/>
                 </a:solidFill>
@@ -1596,11 +1560,11 @@
 </file>
 
 <file path=ppt/slideLayouts/slideLayout30.xml><?xml version='1.0' encoding='UTF-8' standalone='yes'?>
-<ns0:sldLayout xmlns:ns0="http://schemas.openxmlformats.org/presentationml/2006/main" type="blank" preserve="1"><ns0:cSld name="Closing.1Steps.Single+1Notes"><ns0:spTree><ns0:nvGrpSpPr><ns0:cNvPr id="1" name=""/><ns0:cNvGrpSpPr/><ns0:nvPr/></ns0:nvGrpSpPr><ns0:grpSpPr><ns1:xfrm xmlns:ns1="http://schemas.openxmlformats.org/drawingml/2006/main"><ns1:off x="0" y="0"/><ns1:ext cx="0" cy="0"/><ns1:chOff x="0" y="0"/><ns1:chExt cx="0" cy="0"/></ns1:xfrm></ns0:grpSpPr><ns0:sp><ns0:nvSpPr><ns0:cNvPr id="2" name="BG"/><ns0:cNvSpPr><ns1:spLocks xmlns:ns1="http://schemas.openxmlformats.org/drawingml/2006/main" noGrp="1" noSelect="0" noRot="1" noMove="1"/></ns0:cNvSpPr><ns0:nvPr/></ns0:nvSpPr><ns0:spPr><ns2:xfrm xmlns:ns2="http://schemas.openxmlformats.org/drawingml/2006/main"><ns2:off x="0" y="0"/><ns2:ext cx="12192000" cy="6858000"/></ns2:xfrm><ns3:prstGeom xmlns:ns3="http://schemas.openxmlformats.org/drawingml/2006/main" prst="rect"/><ns4:solidFill xmlns:ns4="http://schemas.openxmlformats.org/drawingml/2006/main"><ns4:srgbClr val="1E2761"/></ns4:solidFill><ns5:ln xmlns:ns5="http://schemas.openxmlformats.org/drawingml/2006/main"><ns5:noFill/></ns5:ln></ns0:spPr></ns0:sp><ns0:sp><ns0:nvSpPr><ns0:cNvPr id="3" name="AccentBar"/><ns0:cNvSpPr><ns1:spLocks xmlns:ns1="http://schemas.openxmlformats.org/drawingml/2006/main" noGrp="1" noSelect="0" noRot="1" noMove="1"/></ns0:cNvSpPr><ns0:nvPr/></ns0:nvSpPr><ns0:spPr><ns2:xfrm xmlns:ns2="http://schemas.openxmlformats.org/drawingml/2006/main"><ns2:off x="0" y="0"/><ns2:ext cx="164592" cy="6858000"/></ns2:xfrm><ns3:prstGeom xmlns:ns3="http://schemas.openxmlformats.org/drawingml/2006/main" prst="rect"/><ns4:solidFill xmlns:ns4="http://schemas.openxmlformats.org/drawingml/2006/main"><ns4:srgbClr val="3B82F6"/></ns4:solidFill><ns5:ln xmlns:ns5="http://schemas.openxmlformats.org/drawingml/2006/main"><ns5:noFill/></ns5:ln></ns0:spPr></ns0:sp><ns0:sp><ns0:nvSpPr><ns0:cNvPr id="4" name="StepsPanel"/><ns0:cNvSpPr><ns1:spLocks xmlns:ns1="http://schemas.openxmlformats.org/drawingml/2006/main" noGrp="1" noSelect="0" noRot="1" noMove="1"/></ns0:cNvSpPr><ns0:nvPr/></ns0:nvSpPr><ns0:spPr><ns2:xfrm xmlns:ns2="http://schemas.openxmlformats.org/drawingml/2006/main"><ns2:off x="731520" y="914400"/><ns2:ext cx="6858000" cy="5029200"/></ns2:xfrm><ns3:prstGeom xmlns:ns3="http://schemas.openxmlformats.org/drawingml/2006/main" prst="roundRect"><ns3:avLst><ns3:gd name="adj" fmla="val 10000"/></ns3:avLst></ns3:prstGeom><ns4:solidFill xmlns:ns4="http://schemas.openxmlformats.org/drawingml/2006/main"><ns4:srgbClr val="141B41"/></ns4:solidFill><ns5:ln xmlns:ns5="http://schemas.openxmlformats.org/drawingml/2006/main"><ns5:noFill/></ns5:ln></ns0:spPr></ns0:sp><ns0:sp><ns0:nvSpPr><ns0:cNvPr id="5" name="CTAPanel"/><ns0:cNvSpPr><ns1:spLocks xmlns:ns1="http://schemas.openxmlformats.org/drawingml/2006/main" noGrp="1" noSelect="0" noRot="1" noMove="1"/></ns0:cNvSpPr><ns0:nvPr/></ns0:nvSpPr><ns0:spPr><ns2:xfrm xmlns:ns2="http://schemas.openxmlformats.org/drawingml/2006/main"><ns2:off x="8046720" y="914400"/><ns2:ext cx="3657600" cy="5029200"/></ns2:xfrm><ns3:prstGeom xmlns:ns3="http://schemas.openxmlformats.org/drawingml/2006/main" prst="roundRect"><ns3:avLst><ns3:gd name="adj" fmla="val 10000"/></ns3:avLst></ns3:prstGeom><ns4:solidFill xmlns:ns4="http://schemas.openxmlformats.org/drawingml/2006/main"><ns4:srgbClr val="2D3A6E"/></ns4:solidFill><ns5:ln xmlns:ns5="http://schemas.openxmlformats.org/drawingml/2006/main"><ns5:noFill/></ns5:ln></ns0:spPr></ns0:sp><ns0:sp><ns0:nvSpPr><ns0:cNvPr id="10" name="Title.Left"/><ns0:cNvSpPr><ns1:spLocks xmlns:ns1="http://schemas.openxmlformats.org/drawingml/2006/main" noGrp="1"/></ns0:cNvSpPr><ns0:nvPr><ns0:ph idx="15" type="body"/></ns0:nvPr></ns0:nvSpPr><ns0:spPr><ns2:xfrm xmlns:ns2="http://schemas.openxmlformats.org/drawingml/2006/main"><ns2:off x="1097280" y="1188720"/><ns2:ext cx="6217920" cy="640080"/></ns2:xfrm></ns0:spPr><ns0:txBody><ns3:bodyPr xmlns:ns3="http://schemas.openxmlformats.org/drawingml/2006/main" wrap="square" anchor="t" anchorCtr="0"/><ns4:lstStyle xmlns:ns4="http://schemas.openxmlformats.org/drawingml/2006/main"><ns4:defPPr algn="l"><ns4:buNone/><ns4:defRPr sz="2800" dirty="0" b="1"><ns4:solidFill><ns4:srgbClr val="FFFFFF"/></ns4:solidFill><ns4:latin typeface="Georgia"/><ns4:ea typeface="Georgia"/></ns4:defRPr></ns4:defPPr><ns4:lvl1pPr algn="l"><ns4:buNone/><ns4:defRPr sz="2800" dirty="0" b="1"><ns4:solidFill><ns4:srgbClr val="FFFFFF"/></ns4:solidFill><ns4:latin typeface="Georgia"/><ns4:ea typeface="Georgia"/></ns4:defRPr></ns4:lvl1pPr><ns4:lvl2pPr algn="l"><ns4:buNone/><ns4:defRPr sz="2800" dirty="0" b="1"><ns4:solidFill><ns4:srgbClr val="FFFFFF"/></ns4:solidFill><ns4:latin typeface="Georgia"/><ns4:ea typeface="Georgia"/></ns4:defRPr></ns4:lvl2pPr><ns4:lvl3pPr algn="l"><ns4:buNone/><ns4:defRPr sz="2800" dirty="0" b="1"><ns4:solidFill><ns4:srgbClr val="FFFFFF"/></ns4:solidFill><ns4:latin typeface="Georgia"/><ns4:ea typeface="Georgia"/></ns4:defRPr></ns4:lvl3pPr><ns4:lvl4pPr algn="l"><ns4:buNone/><ns4:defRPr sz="2800" dirty="0" b="1"><ns4:solidFill><ns4:srgbClr val="FFFFFF"/></ns4:solidFill><ns4:latin typeface="Georgia"/><ns4:ea typeface="Georgia"/></ns4:defRPr></ns4:lvl4pPr><ns4:lvl5pPr algn="l"><ns4:buNone/><ns4:defRPr sz="2800" dirty="0" b="1"><ns4:solidFill><ns4:srgbClr val="FFFFFF"/></ns4:solidFill><ns4:latin typeface="Georgia"/><ns4:ea typeface="Georgia"/></ns4:defRPr></ns4:lvl5pPr><ns4:lvl6pPr algn="l"><ns4:buNone/><ns4:defRPr sz="2800" dirty="0" b="1"><ns4:solidFill><ns4:srgbClr val="FFFFFF"/></ns4:solidFill><ns4:latin typeface="Georgia"/><ns4:ea typeface="Georgia"/></ns4:defRPr></ns4:lvl6pPr><ns4:lvl7pPr algn="l"><ns4:buNone/><ns4:defRPr sz="2800" dirty="0" b="1"><ns4:solidFill><ns4:srgbClr val="FFFFFF"/></ns4:solidFill><ns4:latin typeface="Georgia"/><ns4:ea typeface="Georgia"/></ns4:defRPr></ns4:lvl7pPr><ns4:lvl8pPr algn="l"><ns4:buNone/><ns4:defRPr sz="2800" dirty="0" b="1"><ns4:solidFill><ns4:srgbClr val="FFFFFF"/></ns4:solidFill><ns4:latin typeface="Georgia"/><ns4:ea typeface="Georgia"/></ns4:defRPr></ns4:lvl8pPr><ns4:lvl9pPr algn="l"><ns4:buNone/><ns4:defRPr sz="2800" dirty="0" b="1"><ns4:solidFill><ns4:srgbClr val="FFFFFF"/></ns4:solidFill><ns4:latin typeface="Georgia"/><ns4:ea typeface="Georgia"/></ns4:defRPr></ns4:lvl9pPr></ns4:lstStyle/><ns5:p xmlns:ns5="http://schemas.openxmlformats.org/drawingml/2006/main"><ns5:pPr algn="l"><ns5:buNone/></ns5:pPr><ns5:r><ns5:rPr lang="ja-JP"/><ns5:t>1. アクション項目
+<ns0:sldLayout xmlns:ns0="http://schemas.openxmlformats.org/presentationml/2006/main" type="blank" preserve="1"><ns0:cSld name="Closing.1Steps.Single+1Notes"><ns0:spTree><ns0:nvGrpSpPr><ns0:cNvPr id="1" name=""/><ns0:cNvGrpSpPr/><ns0:nvPr/></ns0:nvGrpSpPr><ns0:grpSpPr><ns1:xfrm xmlns:ns1="http://schemas.openxmlformats.org/drawingml/2006/main"><ns1:off x="0" y="0"/><ns1:ext cx="0" cy="0"/><ns1:chOff x="0" y="0"/><ns1:chExt cx="0" cy="0"/></ns1:xfrm></ns0:grpSpPr><ns0:sp><ns0:nvSpPr><ns0:cNvPr id="2" name="BG"/><ns0:cNvSpPr><ns1:spLocks xmlns:ns1="http://schemas.openxmlformats.org/drawingml/2006/main" noGrp="1" noSelect="0" noRot="1" noMove="1"/></ns0:cNvSpPr><ns0:nvPr/></ns0:nvSpPr><ns0:spPr><ns2:xfrm xmlns:ns2="http://schemas.openxmlformats.org/drawingml/2006/main"><ns2:off x="0" y="0"/><ns2:ext cx="12192000" cy="6858000"/></ns2:xfrm><ns3:prstGeom xmlns:ns3="http://schemas.openxmlformats.org/drawingml/2006/main" prst="rect"/><ns4:solidFill xmlns:ns4="http://schemas.openxmlformats.org/drawingml/2006/main"><ns4:srgbClr val="1E2761"/></ns4:solidFill><ns5:ln xmlns:ns5="http://schemas.openxmlformats.org/drawingml/2006/main"><ns5:noFill/></ns5:ln></ns0:spPr></ns0:sp><ns0:sp><ns0:nvSpPr><ns0:cNvPr id="3" name="AccentBar"/><ns0:cNvSpPr><ns1:spLocks xmlns:ns1="http://schemas.openxmlformats.org/drawingml/2006/main" noGrp="1" noSelect="0" noRot="1" noMove="1"/></ns0:cNvSpPr><ns0:nvPr/></ns0:nvSpPr><ns0:spPr><ns2:xfrm xmlns:ns2="http://schemas.openxmlformats.org/drawingml/2006/main"><ns2:off x="0" y="0"/><ns2:ext cx="164592" cy="6858000"/></ns2:xfrm><ns3:prstGeom xmlns:ns3="http://schemas.openxmlformats.org/drawingml/2006/main" prst="rect"/><ns4:solidFill xmlns:ns4="http://schemas.openxmlformats.org/drawingml/2006/main"><ns4:srgbClr val="3B82F6"/></ns4:solidFill><ns5:ln xmlns:ns5="http://schemas.openxmlformats.org/drawingml/2006/main"><ns5:noFill/></ns5:ln></ns0:spPr></ns0:sp><ns0:sp><ns0:nvSpPr><ns0:cNvPr id="4" name="StepsPanel"/><ns0:cNvSpPr><ns1:spLocks xmlns:ns1="http://schemas.openxmlformats.org/drawingml/2006/main" noGrp="1" noSelect="0" noRot="1" noMove="1"/></ns0:cNvSpPr><ns0:nvPr/></ns0:nvSpPr><ns0:spPr><ns2:xfrm xmlns:ns2="http://schemas.openxmlformats.org/drawingml/2006/main"><ns2:off x="731520" y="914400"/><ns2:ext cx="6858000" cy="5029200"/></ns2:xfrm><ns3:prstGeom xmlns:ns3="http://schemas.openxmlformats.org/drawingml/2006/main" prst="roundRect"><ns3:avLst><ns3:gd name="adj" fmla="val 10000"/></ns3:avLst></ns3:prstGeom><ns4:solidFill xmlns:ns4="http://schemas.openxmlformats.org/drawingml/2006/main"><ns4:srgbClr val="141B41"/></ns4:solidFill><ns5:ln xmlns:ns5="http://schemas.openxmlformats.org/drawingml/2006/main"><ns5:noFill/></ns5:ln></ns0:spPr></ns0:sp><ns0:sp><ns0:nvSpPr><ns0:cNvPr id="5" name="CTAPanel"/><ns0:cNvSpPr><ns1:spLocks xmlns:ns1="http://schemas.openxmlformats.org/drawingml/2006/main" noGrp="1" noSelect="0" noRot="1" noMove="1"/></ns0:cNvSpPr><ns0:nvPr/></ns0:nvSpPr><ns0:spPr><ns2:xfrm xmlns:ns2="http://schemas.openxmlformats.org/drawingml/2006/main"><ns2:off x="8046720" y="914400"/><ns2:ext cx="3657600" cy="5029200"/></ns2:xfrm><ns3:prstGeom xmlns:ns3="http://schemas.openxmlformats.org/drawingml/2006/main" prst="roundRect"><ns3:avLst><ns3:gd name="adj" fmla="val 10000"/></ns3:avLst></ns3:prstGeom><ns4:solidFill xmlns:ns4="http://schemas.openxmlformats.org/drawingml/2006/main"><ns4:srgbClr val="2D3A6E"/></ns4:solidFill><ns5:ln xmlns:ns5="http://schemas.openxmlformats.org/drawingml/2006/main"><ns5:noFill/></ns5:ln></ns0:spPr></ns0:sp><ns0:sp><ns0:nvSpPr><ns0:cNvPr id="10" name="Title.Left"/><ns0:cNvSpPr><ns1:spLocks xmlns:ns1="http://schemas.openxmlformats.org/drawingml/2006/main" noGrp="1"/></ns0:cNvSpPr><ns0:nvPr><ns0:ph idx="15" type="body"/></ns0:nvPr></ns0:nvSpPr><ns0:spPr><ns2:xfrm xmlns:ns2="http://schemas.openxmlformats.org/drawingml/2006/main"><ns2:off x="1097280" y="1188720"/><ns2:ext cx="6217920" cy="640080"/></ns2:xfrm></ns0:spPr><ns0:txBody><ns3:bodyPr xmlns:ns3="http://schemas.openxmlformats.org/drawingml/2006/main" wrap="square" anchor="t" anchorCtr="0"/><ns4:lstStyle><ns4:defPPr><ns4:defRPr sz="2800" b="1"><ns4:solidFill><ns4:srgbClr val="FFFFFF"/></ns4:solidFill></ns4:defRPr></ns4:defPPr></ns4:lstStyle><ns4:defPPr algn="l"><ns4:buNone/><ns4:defRPr sz="2800" dirty="0" b="1"><ns4:solidFill><ns4:srgbClr val="FFFFFF"/></ns4:solidFill><ns4:latin typeface="Georgia"/><ns4:ea typeface="Georgia"/></ns4:defRPr></ns4:defPPr><ns4:lvl1pPr algn="l"><ns4:buNone/><ns4:defRPr sz="2800" dirty="0" b="1"><ns4:solidFill><ns4:srgbClr val="FFFFFF"/></ns4:solidFill><ns4:latin typeface="Georgia"/><ns4:ea typeface="Georgia"/></ns4:defRPr></ns4:lvl1pPr><ns4:lvl2pPr algn="l"><ns4:buNone/><ns4:defRPr sz="2800" dirty="0" b="1"><ns4:solidFill><ns4:srgbClr val="FFFFFF"/></ns4:solidFill><ns4:latin typeface="Georgia"/><ns4:ea typeface="Georgia"/></ns4:defRPr></ns4:lvl2pPr><ns4:lvl3pPr algn="l"><ns4:buNone/><ns4:defRPr sz="2800" dirty="0" b="1"><ns4:solidFill><ns4:srgbClr val="FFFFFF"/></ns4:solidFill><ns4:latin typeface="Georgia"/><ns4:ea typeface="Georgia"/></ns4:defRPr></ns4:lvl3pPr><ns4:lvl4pPr algn="l"><ns4:buNone/><ns4:defRPr sz="2800" dirty="0" b="1"><ns4:solidFill><ns4:srgbClr val="FFFFFF"/></ns4:solidFill><ns4:latin typeface="Georgia"/><ns4:ea typeface="Georgia"/></ns4:defRPr></ns4:lvl4pPr><ns4:lvl5pPr algn="l"><ns4:buNone/><ns4:defRPr sz="2800" dirty="0" b="1"><ns4:solidFill><ns4:srgbClr val="FFFFFF"/></ns4:solidFill><ns4:latin typeface="Georgia"/><ns4:ea typeface="Georgia"/></ns4:defRPr></ns4:lvl5pPr><ns4:lvl6pPr algn="l"><ns4:buNone/><ns4:defRPr sz="2800" dirty="0" b="1"><ns4:solidFill><ns4:srgbClr val="FFFFFF"/></ns4:solidFill><ns4:latin typeface="Georgia"/><ns4:ea typeface="Georgia"/></ns4:defRPr></ns4:lvl6pPr><ns4:lvl7pPr algn="l"><ns4:buNone/><ns4:defRPr sz="2800" dirty="0" b="1"><ns4:solidFill><ns4:srgbClr val="FFFFFF"/></ns4:solidFill><ns4:latin typeface="Georgia"/><ns4:ea typeface="Georgia"/></ns4:defRPr></ns4:lvl7pPr><ns4:lvl8pPr algn="l"><ns4:buNone/><ns4:defRPr sz="2800" dirty="0" b="1"><ns4:solidFill><ns4:srgbClr val="FFFFFF"/></ns4:solidFill><ns4:latin typeface="Georgia"/><ns4:ea typeface="Georgia"/></ns4:defRPr></ns4:lvl8pPr><ns4:lvl9pPr algn="l"><ns4:buNone/><ns4:defRPr sz="2800" dirty="0" b="1"><ns4:solidFill><ns4:srgbClr val="FFFFFF"/></ns4:solidFill><ns4:latin typeface="Georgia"/><ns4:ea typeface="Georgia"/></ns4:defRPr></ns4:lvl9pPr></ns4:lstStyle/><ns5:p xmlns:ns5="http://schemas.openxmlformats.org/drawingml/2006/main"><ns5:pPr algn="l"><ns5:buNone/></ns5:pPr><ns5:r><ns5:rPr lang="ja-JP"/><ns5:t>1. アクション項目
 
 2. アクション項目
 
-3. アクション項目</ns5:t></ns5:r></ns5:p></ns0:txBody></ns0:sp><ns0:sp><ns0:nvSpPr><ns0:cNvPr id="21" name="Notes.Right"/><ns0:cNvSpPr><ns1:spLocks xmlns:ns1="http://schemas.openxmlformats.org/drawingml/2006/main" noGrp="1"/></ns0:cNvSpPr><ns0:nvPr><ns0:ph idx="2" type="body"/></ns0:nvPr></ns0:nvSpPr><ns0:spPr><ns2:xfrm xmlns:ns2="http://schemas.openxmlformats.org/drawingml/2006/main"><ns2:off x="8321040" y="1188720"/><ns2:ext cx="3108960" cy="4572000"/></ns2:xfrm></ns0:spPr><ns0:txBody><ns3:bodyPr xmlns:ns3="http://schemas.openxmlformats.org/drawingml/2006/main" wrap="square" anchor="t" anchorCtr="0"/><ns4:lstStyle xmlns:ns4="http://schemas.openxmlformats.org/drawingml/2006/main"><ns4:defPPr algn="l"><ns4:buNone/><ns4:defRPr sz="1400" dirty="0"><ns4:solidFill><ns4:srgbClr val="FFFFFF"/></ns4:solidFill><ns4:latin typeface="Calibri"/><ns4:ea typeface="Calibri"/></ns4:defRPr></ns4:defPPr><ns4:lvl1pPr algn="l"><ns4:buNone/><ns4:defRPr sz="1400" dirty="0"><ns4:solidFill><ns4:srgbClr val="FFFFFF"/></ns4:solidFill><ns4:latin typeface="Calibri"/><ns4:ea typeface="Calibri"/></ns4:defRPr></ns4:lvl1pPr><ns4:lvl2pPr algn="l"><ns4:buNone/><ns4:defRPr sz="1400" dirty="0"><ns4:solidFill><ns4:srgbClr val="FFFFFF"/></ns4:solidFill><ns4:latin typeface="Calibri"/><ns4:ea typeface="Calibri"/></ns4:defRPr></ns4:lvl2pPr><ns4:lvl3pPr algn="l"><ns4:buNone/><ns4:defRPr sz="1400" dirty="0"><ns4:solidFill><ns4:srgbClr val="FFFFFF"/></ns4:solidFill><ns4:latin typeface="Calibri"/><ns4:ea typeface="Calibri"/></ns4:defRPr></ns4:lvl3pPr><ns4:lvl4pPr algn="l"><ns4:buNone/><ns4:defRPr sz="1400" dirty="0"><ns4:solidFill><ns4:srgbClr val="FFFFFF"/></ns4:solidFill><ns4:latin typeface="Calibri"/><ns4:ea typeface="Calibri"/></ns4:defRPr></ns4:lvl4pPr><ns4:lvl5pPr algn="l"><ns4:buNone/><ns4:defRPr sz="1400" dirty="0"><ns4:solidFill><ns4:srgbClr val="FFFFFF"/></ns4:solidFill><ns4:latin typeface="Calibri"/><ns4:ea typeface="Calibri"/></ns4:defRPr></ns4:lvl5pPr><ns4:lvl6pPr algn="l"><ns4:buNone/><ns4:defRPr sz="1400" dirty="0"><ns4:solidFill><ns4:srgbClr val="FFFFFF"/></ns4:solidFill><ns4:latin typeface="Calibri"/><ns4:ea typeface="Calibri"/></ns4:defRPr></ns4:lvl6pPr><ns4:lvl7pPr algn="l"><ns4:buNone/><ns4:defRPr sz="1400" dirty="0"><ns4:solidFill><ns4:srgbClr val="FFFFFF"/></ns4:solidFill><ns4:latin typeface="Calibri"/><ns4:ea typeface="Calibri"/></ns4:defRPr></ns4:lvl7pPr><ns4:lvl8pPr algn="l"><ns4:buNone/><ns4:defRPr sz="1400" dirty="0"><ns4:solidFill><ns4:srgbClr val="FFFFFF"/></ns4:solidFill><ns4:latin typeface="Calibri"/><ns4:ea typeface="Calibri"/></ns4:defRPr></ns4:lvl8pPr><ns4:lvl9pPr algn="l"><ns4:buNone/><ns4:defRPr sz="1400" dirty="0"><ns4:solidFill><ns4:srgbClr val="FFFFFF"/></ns4:solidFill><ns4:latin typeface="Calibri"/><ns4:ea typeface="Calibri"/></ns4:defRPr></ns4:lvl9pPr></ns4:lstStyle><ns5:p xmlns:ns5="http://schemas.openxmlformats.org/drawingml/2006/main"><ns5:pPr algn="l"><ns5:buNone/></ns5:pPr><ns5:r><ns5:rPr lang="ja-JP"/><ns5:t>期限
+3. アクション項目</ns5:t></ns5:r></ns5:p></ns0:txBody></ns0:sp><ns0:sp><ns0:nvSpPr><ns0:cNvPr id="21" name="Notes.Right"/><ns0:cNvSpPr><ns1:spLocks xmlns:ns1="http://schemas.openxmlformats.org/drawingml/2006/main" noGrp="1"/></ns0:cNvSpPr><ns0:nvPr><ns0:ph idx="2" type="body"/></ns0:nvPr></ns0:nvSpPr><ns0:spPr><ns2:xfrm xmlns:ns2="http://schemas.openxmlformats.org/drawingml/2006/main"><ns2:off x="8321040" y="1188720"/><ns2:ext cx="3108960" cy="4572000"/></ns2:xfrm></ns0:spPr><ns0:txBody><ns3:bodyPr xmlns:ns3="http://schemas.openxmlformats.org/drawingml/2006/main" wrap="square" anchor="t" anchorCtr="0"/><ns4:lstStyle><ns4:defPPr><ns4:defRPr><ns4:solidFill><ns4:srgbClr val="FFFFFF"/></ns4:solidFill></ns4:defRPr></ns4:defPPr></ns4:lstStyle><ns4:defPPr algn="l"><ns4:buNone/><ns4:defRPr sz="1400" dirty="0"><ns4:solidFill><ns4:srgbClr val="FFFFFF"/></ns4:solidFill><ns4:latin typeface="Calibri"/><ns4:ea typeface="Calibri"/></ns4:defRPr></ns4:defPPr><ns4:lvl1pPr algn="l"><ns4:buNone/><ns4:defRPr sz="1400" dirty="0"><ns4:solidFill><ns4:srgbClr val="FFFFFF"/></ns4:solidFill><ns4:latin typeface="Calibri"/><ns4:ea typeface="Calibri"/></ns4:defRPr></ns4:lvl1pPr><ns4:lvl2pPr algn="l"><ns4:buNone/><ns4:defRPr sz="1400" dirty="0"><ns4:solidFill><ns4:srgbClr val="FFFFFF"/></ns4:solidFill><ns4:latin typeface="Calibri"/><ns4:ea typeface="Calibri"/></ns4:defRPr></ns4:lvl2pPr><ns4:lvl3pPr algn="l"><ns4:buNone/><ns4:defRPr sz="1400" dirty="0"><ns4:solidFill><ns4:srgbClr val="FFFFFF"/></ns4:solidFill><ns4:latin typeface="Calibri"/><ns4:ea typeface="Calibri"/></ns4:defRPr></ns4:lvl3pPr><ns4:lvl4pPr algn="l"><ns4:buNone/><ns4:defRPr sz="1400" dirty="0"><ns4:solidFill><ns4:srgbClr val="FFFFFF"/></ns4:solidFill><ns4:latin typeface="Calibri"/><ns4:ea typeface="Calibri"/></ns4:defRPr></ns4:lvl4pPr><ns4:lvl5pPr algn="l"><ns4:buNone/><ns4:defRPr sz="1400" dirty="0"><ns4:solidFill><ns4:srgbClr val="FFFFFF"/></ns4:solidFill><ns4:latin typeface="Calibri"/><ns4:ea typeface="Calibri"/></ns4:defRPr></ns4:lvl5pPr><ns4:lvl6pPr algn="l"><ns4:buNone/><ns4:defRPr sz="1400" dirty="0"><ns4:solidFill><ns4:srgbClr val="FFFFFF"/></ns4:solidFill><ns4:latin typeface="Calibri"/><ns4:ea typeface="Calibri"/></ns4:defRPr></ns4:lvl6pPr><ns4:lvl7pPr algn="l"><ns4:buNone/><ns4:defRPr sz="1400" dirty="0"><ns4:solidFill><ns4:srgbClr val="FFFFFF"/></ns4:solidFill><ns4:latin typeface="Calibri"/><ns4:ea typeface="Calibri"/></ns4:defRPr></ns4:lvl7pPr><ns4:lvl8pPr algn="l"><ns4:buNone/><ns4:defRPr sz="1400" dirty="0"><ns4:solidFill><ns4:srgbClr val="FFFFFF"/></ns4:solidFill><ns4:latin typeface="Calibri"/><ns4:ea typeface="Calibri"/></ns4:defRPr></ns4:lvl8pPr><ns4:lvl9pPr algn="l"><ns4:buNone/><ns4:defRPr sz="1400" dirty="0"><ns4:solidFill><ns4:srgbClr val="FFFFFF"/></ns4:solidFill><ns4:latin typeface="Calibri"/><ns4:ea typeface="Calibri"/></ns4:defRPr></ns4:lvl9pPr></ns4:lstStyle><ns5:p xmlns:ns5="http://schemas.openxmlformats.org/drawingml/2006/main"><ns5:pPr algn="l"><ns5:buNone/></ns5:pPr><ns5:r><ns5:rPr lang="ja-JP"/><ns5:t>期限
 
 担当者
 
@@ -1712,7 +1676,7 @@
           <a:bodyPr wrap="square" anchor="t" anchorCtr="0"/>
           <a:lstStyle>
             <a:defPPr>
-              <a:defRPr>
+              <a:defRPr sz="1300" b="1">
                 <a:solidFill>
                   <a:srgbClr val="3B82F6"/>
                 </a:solidFill>
@@ -1750,7 +1714,7 @@
           <a:bodyPr wrap="square" anchor="t" anchorCtr="0"/>
           <a:lstStyle>
             <a:defPPr>
-              <a:defRPr>
+              <a:defRPr sz="4000" b="1">
                 <a:solidFill>
                   <a:srgbClr val="FFFFFF"/>
                 </a:solidFill>
@@ -1788,7 +1752,7 @@
           <a:bodyPr wrap="square" anchor="t" anchorCtr="0"/>
           <a:lstStyle>
             <a:defPPr>
-              <a:defRPr>
+              <a:defRPr sz="1600">
                 <a:solidFill>
                   <a:srgbClr val="CADCFC"/>
                 </a:solidFill>
@@ -1896,8 +1860,8 @@
         <p:txBody>
           <a:bodyPr wrap="square" anchor="t" anchorCtr="0"/>
           <a:lstStyle>
-            <a:defPPr>
-              <a:defRPr>
+            <a:defPPr algn="ctr">
+              <a:defRPr sz="8000" b="1">
                 <a:solidFill>
                   <a:srgbClr val="3B82F6"/>
                 </a:solidFill>
@@ -1934,8 +1898,8 @@
         <p:txBody>
           <a:bodyPr wrap="square" anchor="t" anchorCtr="0"/>
           <a:lstStyle>
-            <a:defPPr>
-              <a:defRPr>
+            <a:defPPr algn="ctr">
+              <a:defRPr sz="1200">
                 <a:solidFill>
                   <a:srgbClr val="CADCFC"/>
                 </a:solidFill>
@@ -1973,7 +1937,7 @@
           <a:bodyPr wrap="square" anchor="t" anchorCtr="0"/>
           <a:lstStyle>
             <a:defPPr>
-              <a:defRPr>
+              <a:defRPr sz="3800" b="1">
                 <a:solidFill>
                   <a:srgbClr val="FFFFFF"/>
                 </a:solidFill>
@@ -2011,7 +1975,7 @@
           <a:bodyPr wrap="square" anchor="t" anchorCtr="0"/>
           <a:lstStyle>
             <a:defPPr>
-              <a:defRPr>
+              <a:defRPr sz="1600">
                 <a:solidFill>
                   <a:srgbClr val="CADCFC"/>
                 </a:solidFill>
@@ -2182,7 +2146,7 @@
           <a:bodyPr wrap="square" anchor="t" anchorCtr="0"/>
           <a:lstStyle>
             <a:defPPr>
-              <a:defRPr>
+              <a:defRPr sz="1300" b="1">
                 <a:solidFill>
                   <a:srgbClr val="3B82F6"/>
                 </a:solidFill>
@@ -2220,7 +2184,7 @@
           <a:bodyPr wrap="square" anchor="t" anchorCtr="0"/>
           <a:lstStyle>
             <a:defPPr>
-              <a:defRPr>
+              <a:defRPr sz="4400" b="1">
                 <a:solidFill>
                   <a:srgbClr val="FFFFFF"/>
                 </a:solidFill>
@@ -2258,7 +2222,7 @@
           <a:bodyPr wrap="square" anchor="t" anchorCtr="0"/>
           <a:lstStyle>
             <a:defPPr>
-              <a:defRPr>
+              <a:defRPr sz="1500">
                 <a:solidFill>
                   <a:srgbClr val="CADCFC"/>
                 </a:solidFill>
@@ -2341,7 +2305,7 @@
           <a:bodyPr wrap="square" anchor="t" anchorCtr="0"/>
           <a:lstStyle>
             <a:defPPr>
-              <a:defRPr>
+              <a:defRPr sz="2800" b="1">
                 <a:solidFill>
                   <a:srgbClr val="FFFFFF"/>
                 </a:solidFill>
@@ -2379,7 +2343,7 @@
           <a:bodyPr wrap="square" anchor="t" anchorCtr="0"/>
           <a:lstStyle>
             <a:defPPr>
-              <a:defRPr>
+              <a:defRPr sz="1200">
                 <a:solidFill>
                   <a:srgbClr val="CADCFC"/>
                 </a:solidFill>
@@ -2415,15 +2379,7 @@
         </p:spPr>
         <p:txBody>
           <a:bodyPr wrap="square" anchor="t" anchorCtr="0"/>
-          <a:lstStyle>
-            <a:defPPr>
-              <a:defRPr>
-                <a:solidFill>
-                  <a:srgbClr val="1E293B"/>
-                </a:solidFill>
-              </a:defRPr>
-            </a:defPPr>
-          </a:lstStyle>
+          <a:lstStyle/>
           <a:p>
             <a:pPr algn="l">
               <a:buNone/>
@@ -2454,8 +2410,8 @@
         <p:txBody>
           <a:bodyPr wrap="square" anchor="t" anchorCtr="0"/>
           <a:lstStyle>
-            <a:defPPr>
-              <a:defRPr>
+            <a:defPPr algn="r">
+              <a:defRPr sz="1000">
                 <a:solidFill>
                   <a:srgbClr val="94A3B8"/>
                 </a:solidFill>
@@ -2538,7 +2494,7 @@
           <a:bodyPr wrap="square" anchor="t" anchorCtr="0"/>
           <a:lstStyle>
             <a:defPPr>
-              <a:defRPr>
+              <a:defRPr sz="2800" b="1">
                 <a:solidFill>
                   <a:srgbClr val="FFFFFF"/>
                 </a:solidFill>
@@ -2576,7 +2532,7 @@
           <a:bodyPr wrap="square" anchor="t" anchorCtr="0"/>
           <a:lstStyle>
             <a:defPPr>
-              <a:defRPr>
+              <a:defRPr sz="1200">
                 <a:solidFill>
                   <a:srgbClr val="CADCFC"/>
                 </a:solidFill>
@@ -2638,15 +2594,7 @@
         </p:spPr>
         <p:txBody>
           <a:bodyPr wrap="square" anchor="t" anchorCtr="0"/>
-          <a:lstStyle>
-            <a:defPPr>
-              <a:defRPr>
-                <a:solidFill>
-                  <a:srgbClr val="1E293B"/>
-                </a:solidFill>
-              </a:defRPr>
-            </a:defPPr>
-          </a:lstStyle>
+          <a:lstStyle/>
           <a:p>
             <a:pPr algn="l">
               <a:buNone/>
@@ -2678,11 +2626,7 @@
           <a:bodyPr wrap="square" anchor="t" anchorCtr="0"/>
           <a:lstStyle>
             <a:defPPr>
-              <a:defRPr>
-                <a:solidFill>
-                  <a:srgbClr val="1E293B"/>
-                </a:solidFill>
-              </a:defRPr>
+              <a:defRPr sz="1200"/>
             </a:defPPr>
           </a:lstStyle>
           <a:p>
@@ -2717,8 +2661,8 @@
         <p:txBody>
           <a:bodyPr wrap="square" anchor="t" anchorCtr="0"/>
           <a:lstStyle>
-            <a:defPPr>
-              <a:defRPr>
+            <a:defPPr algn="r">
+              <a:defRPr sz="1000">
                 <a:solidFill>
                   <a:srgbClr val="94A3B8"/>
                 </a:solidFill>
@@ -2801,7 +2745,7 @@
           <a:bodyPr wrap="square" anchor="t" anchorCtr="0"/>
           <a:lstStyle>
             <a:defPPr>
-              <a:defRPr>
+              <a:defRPr sz="2800" b="1">
                 <a:solidFill>
                   <a:srgbClr val="FFFFFF"/>
                 </a:solidFill>
@@ -2839,7 +2783,7 @@
           <a:bodyPr wrap="square" anchor="t" anchorCtr="0"/>
           <a:lstStyle>
             <a:defPPr>
-              <a:defRPr>
+              <a:defRPr sz="1200">
                 <a:solidFill>
                   <a:srgbClr val="CADCFC"/>
                 </a:solidFill>
@@ -2897,15 +2841,7 @@
         </p:spPr>
         <p:txBody>
           <a:bodyPr wrap="square" anchor="t" anchorCtr="0"/>
-          <a:lstStyle>
-            <a:defPPr>
-              <a:defRPr>
-                <a:solidFill>
-                  <a:srgbClr val="1E293B"/>
-                </a:solidFill>
-              </a:defRPr>
-            </a:defPPr>
-          </a:lstStyle>
+          <a:lstStyle/>
           <a:p>
             <a:pPr algn="l">
               <a:buNone/>
@@ -2937,9 +2873,9 @@
           <a:bodyPr wrap="square" anchor="t" anchorCtr="0"/>
           <a:lstStyle>
             <a:defPPr>
-              <a:defRPr>
-                <a:solidFill>
-                  <a:srgbClr val="1E293B"/>
+              <a:defRPr sz="1000">
+                <a:solidFill>
+                  <a:srgbClr val="94A3B8"/>
                 </a:solidFill>
               </a:defRPr>
             </a:defPPr>
@@ -2974,8 +2910,8 @@
         <p:txBody>
           <a:bodyPr wrap="square" anchor="t" anchorCtr="0"/>
           <a:lstStyle>
-            <a:defPPr>
-              <a:defRPr>
+            <a:defPPr algn="r">
+              <a:defRPr sz="1000">
                 <a:solidFill>
                   <a:srgbClr val="94A3B8"/>
                 </a:solidFill>
@@ -3277,34 +3213,26 @@
   </p:sldLayoutIdLst>
   <p:txStyles>
     <p:titleStyle>
-      <a:lvl1pPr algn="l" defTabSz="457200" rtl="0" eaLnBrk="1" latinLnBrk="0" hangingPunct="1">
-        <a:spcBef>
-          <a:spcPct val="0"/>
-        </a:spcBef>
+      <a:lvl1pPr algn="l">
         <a:buNone/>
-        <a:defRPr sz="4400" kern="1200" b="1">
+        <a:defRPr sz="4400" b="1">
           <a:solidFill>
             <a:srgbClr val="FFFFFF"/>
           </a:solidFill>
-          <a:latin typeface="Georgia"/>
-          <a:ea typeface="Georgia"/>
-          <a:cs typeface="Georgia"/>
+          <a:latin typeface="+mj-lt"/>
+          <a:ea typeface="+mj-ea"/>
         </a:defRPr>
       </a:lvl1pPr>
     </p:titleStyle>
     <p:bodyStyle>
-      <a:lvl1pPr marL="342900" indent="-342900" algn="l" defTabSz="457200" rtl="0" eaLnBrk="1" latinLnBrk="0" hangingPunct="1">
-        <a:spcBef>
-          <a:spcPct val="20000"/>
-        </a:spcBef>
+      <a:lvl1pPr algn="l">
         <a:buNone/>
-        <a:defRPr sz="1400" kern="1200">
+        <a:defRPr sz="1400">
           <a:solidFill>
             <a:srgbClr val="1E293B"/>
           </a:solidFill>
-          <a:latin typeface="Calibri"/>
-          <a:ea typeface="Calibri"/>
-          <a:cs typeface="Calibri"/>
+          <a:latin typeface="+mn-lt"/>
+          <a:ea typeface="+mn-ea"/>
         </a:defRPr>
       </a:lvl1pPr>
     </p:bodyStyle>
@@ -3450,7 +3378,7 @@
     </a:clrScheme>
     <a:fontScheme name="Office">
       <a:majorFont>
-        <a:latin typeface="Calibri"/>
+        <a:latin typeface="Georgia"/>
         <a:ea typeface=""/>
         <a:cs typeface=""/>
         <a:font script="Jpan" typeface="ＭＳ Ｐゴシック"/>

</xml_diff>

<commit_message>
feat: rebuild template with all 151 placeholders from design spec
- scripts/rebuild-template.ts: automated template rebuild from
  create_30_layouts.py placeholder definitions
- All 30 layouts rebuilt with correct placeholders (including
  ctrTitle idx=0 for Title/Closing layouts that were previously lost)
- lstStyle overrides are minimal diffs from master defaults only
- Decorative shapes preserved from original template
- ROADMAP updated with template rebuild task

Co-Authored-By: Claude Opus 4.6 (1M context) <noreply@anthropic.com>
</commit_message>
<xml_diff>
--- a/public/templates/slide/Midnight_Executive_30_TemplateOnly.pptx
+++ b/public/templates/slide/Midnight_Executive_30_TemplateOnly.pptx
@@ -106,7 +106,7 @@
 </file>
 
 <file path=ppt/slideLayouts/slideLayout1.xml><?xml version="1.0" encoding="utf-8"?>
-<p:sldLayout xmlns:a="http://schemas.openxmlformats.org/drawingml/2006/main" xmlns:r="http://schemas.openxmlformats.org/officeDocument/2006/relationships" xmlns:p="http://schemas.openxmlformats.org/presentationml/2006/main" type="title" preserve="1">
+<p:sldLayout xmlns:a="http://schemas.openxmlformats.org/drawingml/2006/main" xmlns:p="http://schemas.openxmlformats.org/presentationml/2006/main" xmlns:r="http://schemas.openxmlformats.org/officeDocument/2006/relationships" type="title" preserve="1">
   <p:cSld name="Title.1Title.Single">
     <p:spTree>
       <p:nvGrpSpPr>
@@ -190,12 +190,12 @@
       </p:sp>
       <p:sp>
         <p:nvSpPr>
-          <p:cNvPr id="10" name="CategoryLabel.Top"/>
-          <p:cNvSpPr>
-            <a:spLocks noGrp="1"/>
-          </p:cNvSpPr>
-          <p:nvPr>
-            <p:ph idx="10" type="body"/>
+          <p:cNvPr id="5" name="CategoryLabel.Top"/>
+          <p:cNvSpPr>
+            <a:spLocks noGrp="1"/>
+          </p:cNvSpPr>
+          <p:nvPr>
+            <p:ph type="body" idx="10"/>
           </p:nvPr>
         </p:nvSpPr>
         <p:spPr>
@@ -216,24 +216,21 @@
             </a:defPPr>
           </a:lstStyle>
           <a:p>
-            <a:pPr algn="l">
-              <a:buNone/>
-            </a:pPr>
-            <a:r>
-              <a:rPr lang="ja-JP"/>
-              <a:t>CATEGORY LABEL</a:t>
-            </a:r>
-          </a:p>
-        </p:txBody>
-      </p:sp>
-      <p:sp>
-        <p:nvSpPr>
-          <p:cNvPr id="11" name="Title.Center"/>
-          <p:cNvSpPr>
-            <a:spLocks noGrp="1"/>
-          </p:cNvSpPr>
-          <p:nvPr>
-            <p:ph idx="0" type="ctrTitle"/>
+            <a:r>
+              <a:rPr lang="ja-JP"/>
+              <a:t> </a:t>
+            </a:r>
+          </a:p>
+        </p:txBody>
+      </p:sp>
+      <p:sp>
+        <p:nvSpPr>
+          <p:cNvPr id="6" name="Title.Center"/>
+          <p:cNvSpPr>
+            <a:spLocks noGrp="1"/>
+          </p:cNvSpPr>
+          <p:nvPr>
+            <p:ph type="ctrTitle" idx="0"/>
           </p:nvPr>
         </p:nvSpPr>
         <p:spPr>
@@ -250,24 +247,21 @@
             </a:defPPr>
           </a:lstStyle>
           <a:p>
-            <a:pPr algn="l">
-              <a:buNone/>
-            </a:pPr>
-            <a:r>
-              <a:rPr lang="ja-JP"/>
-              <a:t>プレゼンテーションタイトル</a:t>
-            </a:r>
-          </a:p>
-        </p:txBody>
-      </p:sp>
-      <p:sp>
-        <p:nvSpPr>
-          <p:cNvPr id="12" name="Subtitle.Center"/>
-          <p:cNvSpPr>
-            <a:spLocks noGrp="1"/>
-          </p:cNvSpPr>
-          <p:nvPr>
-            <p:ph idx="1" type="subTitle"/>
+            <a:r>
+              <a:rPr lang="ja-JP"/>
+              <a:t> </a:t>
+            </a:r>
+          </a:p>
+        </p:txBody>
+      </p:sp>
+      <p:sp>
+        <p:nvSpPr>
+          <p:cNvPr id="7" name="Subtitle.Center"/>
+          <p:cNvSpPr>
+            <a:spLocks noGrp="1"/>
+          </p:cNvSpPr>
+          <p:nvPr>
+            <p:ph type="subTitle" idx="1"/>
           </p:nvPr>
         </p:nvSpPr>
         <p:spPr>
@@ -288,24 +282,21 @@
             </a:defPPr>
           </a:lstStyle>
           <a:p>
-            <a:pPr algn="l">
-              <a:buNone/>
-            </a:pPr>
-            <a:r>
-              <a:rPr lang="ja-JP"/>
-              <a:t>サブタイトル・説明文</a:t>
-            </a:r>
-          </a:p>
-        </p:txBody>
-      </p:sp>
-      <p:sp>
-        <p:nvSpPr>
-          <p:cNvPr id="13" name="Date.Bottom"/>
-          <p:cNvSpPr>
-            <a:spLocks noGrp="1"/>
-          </p:cNvSpPr>
-          <p:nvPr>
-            <p:ph idx="11" type="body"/>
+            <a:r>
+              <a:rPr lang="ja-JP"/>
+              <a:t> </a:t>
+            </a:r>
+          </a:p>
+        </p:txBody>
+      </p:sp>
+      <p:sp>
+        <p:nvSpPr>
+          <p:cNvPr id="8" name="Date.Bottom"/>
+          <p:cNvSpPr>
+            <a:spLocks noGrp="1"/>
+          </p:cNvSpPr>
+          <p:nvPr>
+            <p:ph type="body" idx="11"/>
           </p:nvPr>
         </p:nvSpPr>
         <p:spPr>
@@ -326,24 +317,21 @@
             </a:defPPr>
           </a:lstStyle>
           <a:p>
-            <a:pPr algn="l">
-              <a:buNone/>
-            </a:pPr>
-            <a:r>
-              <a:rPr lang="ja-JP"/>
-              <a:t>日付  |  組織名  |  部門名</a:t>
-            </a:r>
-          </a:p>
-        </p:txBody>
-      </p:sp>
-      <p:sp>
-        <p:nvSpPr>
-          <p:cNvPr id="14" name="Footer.Bottom"/>
-          <p:cNvSpPr>
-            <a:spLocks noGrp="1"/>
-          </p:cNvSpPr>
-          <p:nvPr>
-            <p:ph idx="12" type="body"/>
+            <a:r>
+              <a:rPr lang="ja-JP"/>
+              <a:t> </a:t>
+            </a:r>
+          </a:p>
+        </p:txBody>
+      </p:sp>
+      <p:sp>
+        <p:nvSpPr>
+          <p:cNvPr id="9" name="Footer.Bottom"/>
+          <p:cNvSpPr>
+            <a:spLocks noGrp="1"/>
+          </p:cNvSpPr>
+          <p:nvPr>
+            <p:ph type="body" idx="12"/>
           </p:nvPr>
         </p:nvSpPr>
         <p:spPr>
@@ -364,12 +352,9 @@
             </a:defPPr>
           </a:lstStyle>
           <a:p>
-            <a:pPr algn="l">
-              <a:buNone/>
-            </a:pPr>
-            <a:r>
-              <a:rPr lang="ja-JP"/>
-              <a:t>Confidential</a:t>
+            <a:r>
+              <a:rPr lang="ja-JP"/>
+              <a:t> </a:t>
             </a:r>
           </a:p>
         </p:txBody>
@@ -381,7 +366,7 @@
 </file>
 
 <file path=ppt/slideLayouts/slideLayout10.xml><?xml version="1.0" encoding="utf-8"?>
-<p:sldLayout xmlns:a="http://schemas.openxmlformats.org/drawingml/2006/main" xmlns:r="http://schemas.openxmlformats.org/officeDocument/2006/relationships" xmlns:p="http://schemas.openxmlformats.org/presentationml/2006/main" type="obj" preserve="1">
+<p:sldLayout xmlns:a="http://schemas.openxmlformats.org/drawingml/2006/main" xmlns:p="http://schemas.openxmlformats.org/presentationml/2006/main" xmlns:r="http://schemas.openxmlformats.org/officeDocument/2006/relationships" type="obj" preserve="1">
   <p:cSld name="Content.1Body.Single+1Callout">
     <p:spTree>
       <p:nvGrpSpPr>
@@ -421,83 +406,7 @@
       </p:sp>
       <p:sp>
         <p:nvSpPr>
-          <p:cNvPr id="10" name="SlideTitle.Header"/>
-          <p:cNvSpPr>
-            <a:spLocks noGrp="1"/>
-          </p:cNvSpPr>
-          <p:nvPr>
-            <p:ph idx="15" type="body"/>
-          </p:nvPr>
-        </p:nvSpPr>
-        <p:spPr>
-          <a:xfrm>
-            <a:off x="731520" y="91440"/>
-            <a:ext cx="9144000" cy="475488"/>
-          </a:xfrm>
-        </p:spPr>
-        <p:txBody>
-          <a:bodyPr wrap="square" anchor="t" anchorCtr="0"/>
-          <a:lstStyle>
-            <a:defPPr>
-              <a:defRPr sz="2800" b="1">
-                <a:solidFill>
-                  <a:srgbClr val="FFFFFF"/>
-                </a:solidFill>
-              </a:defRPr>
-            </a:defPPr>
-          </a:lstStyle>
-          <a:p>
-            <a:pPr algn="l">
-              <a:buNone/>
-            </a:pPr>
-            <a:r>
-              <a:rPr lang="ja-JP"/>
-              <a:t>スライドタイトル</a:t>
-            </a:r>
-          </a:p>
-        </p:txBody>
-      </p:sp>
-      <p:sp>
-        <p:nvSpPr>
-          <p:cNvPr id="11" name="SlideSubtitle.Header"/>
-          <p:cNvSpPr>
-            <a:spLocks noGrp="1"/>
-          </p:cNvSpPr>
-          <p:nvPr>
-            <p:ph idx="16" type="body"/>
-          </p:nvPr>
-        </p:nvSpPr>
-        <p:spPr>
-          <a:xfrm>
-            <a:off x="731520" y="658368"/>
-            <a:ext cx="9144000" cy="274320"/>
-          </a:xfrm>
-        </p:spPr>
-        <p:txBody>
-          <a:bodyPr wrap="square" anchor="t" anchorCtr="0"/>
-          <a:lstStyle>
-            <a:defPPr>
-              <a:defRPr sz="1200">
-                <a:solidFill>
-                  <a:srgbClr val="CADCFC"/>
-                </a:solidFill>
-              </a:defRPr>
-            </a:defPPr>
-          </a:lstStyle>
-          <a:p>
-            <a:pPr algn="l">
-              <a:buNone/>
-            </a:pPr>
-            <a:r>
-              <a:rPr lang="ja-JP"/>
-              <a:t>サブタイトル</a:t>
-            </a:r>
-          </a:p>
-        </p:txBody>
-      </p:sp>
-      <p:sp>
-        <p:nvSpPr>
-          <p:cNvPr id="5" name="Callout"/>
+          <p:cNvPr id="3" name="Callout"/>
           <p:cNvSpPr>
             <a:spLocks noGrp="1" noSelect="0" noRot="1" noMove="1"/>
           </p:cNvSpPr>
@@ -523,7 +432,7 @@
       </p:sp>
       <p:sp>
         <p:nvSpPr>
-          <p:cNvPr id="6" name="CalloutAccent"/>
+          <p:cNvPr id="4" name="CalloutAccent"/>
           <p:cNvSpPr>
             <a:spLocks noGrp="1" noSelect="0" noRot="1" noMove="1"/>
           </p:cNvSpPr>
@@ -545,12 +454,82 @@
       </p:sp>
       <p:sp>
         <p:nvSpPr>
-          <p:cNvPr id="20" name="Callout.Top"/>
-          <p:cNvSpPr>
-            <a:spLocks noGrp="1"/>
-          </p:cNvSpPr>
-          <p:nvPr>
-            <p:ph idx="2" type="body"/>
+          <p:cNvPr id="5" name="SlideTitle.Header"/>
+          <p:cNvSpPr>
+            <a:spLocks noGrp="1"/>
+          </p:cNvSpPr>
+          <p:nvPr>
+            <p:ph type="body" idx="15"/>
+          </p:nvPr>
+        </p:nvSpPr>
+        <p:spPr>
+          <a:xfrm>
+            <a:off x="731520" y="91440"/>
+            <a:ext cx="9144000" cy="475488"/>
+          </a:xfrm>
+        </p:spPr>
+        <p:txBody>
+          <a:bodyPr wrap="square" anchor="t" anchorCtr="0"/>
+          <a:lstStyle>
+            <a:defPPr>
+              <a:defRPr sz="2800" b="1">
+                <a:solidFill>
+                  <a:srgbClr val="FFFFFF"/>
+                </a:solidFill>
+              </a:defRPr>
+            </a:defPPr>
+          </a:lstStyle>
+          <a:p>
+            <a:r>
+              <a:rPr lang="ja-JP"/>
+              <a:t> </a:t>
+            </a:r>
+          </a:p>
+        </p:txBody>
+      </p:sp>
+      <p:sp>
+        <p:nvSpPr>
+          <p:cNvPr id="6" name="SlideSubtitle.Header"/>
+          <p:cNvSpPr>
+            <a:spLocks noGrp="1"/>
+          </p:cNvSpPr>
+          <p:nvPr>
+            <p:ph type="body" idx="16"/>
+          </p:nvPr>
+        </p:nvSpPr>
+        <p:spPr>
+          <a:xfrm>
+            <a:off x="731520" y="658368"/>
+            <a:ext cx="9144000" cy="274320"/>
+          </a:xfrm>
+        </p:spPr>
+        <p:txBody>
+          <a:bodyPr wrap="square" anchor="t" anchorCtr="0"/>
+          <a:lstStyle>
+            <a:defPPr>
+              <a:defRPr sz="1200">
+                <a:solidFill>
+                  <a:srgbClr val="CADCFC"/>
+                </a:solidFill>
+              </a:defRPr>
+            </a:defPPr>
+          </a:lstStyle>
+          <a:p>
+            <a:r>
+              <a:rPr lang="ja-JP"/>
+              <a:t> </a:t>
+            </a:r>
+          </a:p>
+        </p:txBody>
+      </p:sp>
+      <p:sp>
+        <p:nvSpPr>
+          <p:cNvPr id="7" name="Callout.Top"/>
+          <p:cNvSpPr>
+            <a:spLocks noGrp="1"/>
+          </p:cNvSpPr>
+          <p:nvPr>
+            <p:ph type="body" idx="2"/>
           </p:nvPr>
         </p:nvSpPr>
         <p:spPr>
@@ -571,54 +550,48 @@
             </a:defPPr>
           </a:lstStyle>
           <a:p>
-            <a:pPr algn="l">
-              <a:buNone/>
-            </a:pPr>
-            <a:r>
-              <a:rPr lang="ja-JP"/>
-              <a:t>キーメッセージ・要約を記入</a:t>
-            </a:r>
-          </a:p>
-        </p:txBody>
-      </p:sp>
-      <p:sp>
-        <p:nvSpPr>
-          <p:cNvPr id="21" name="Body.Center"/>
-          <p:cNvSpPr>
-            <a:spLocks noGrp="1"/>
-          </p:cNvSpPr>
-          <p:nvPr>
-            <p:ph idx="1" type="body"/>
+            <a:r>
+              <a:rPr lang="ja-JP"/>
+              <a:t> </a:t>
+            </a:r>
+          </a:p>
+        </p:txBody>
+      </p:sp>
+      <p:sp>
+        <p:nvSpPr>
+          <p:cNvPr id="8" name="Body.Center"/>
+          <p:cNvSpPr>
+            <a:spLocks noGrp="1"/>
+          </p:cNvSpPr>
+          <p:nvPr>
+            <p:ph type="body" idx="1"/>
           </p:nvPr>
         </p:nvSpPr>
         <p:spPr>
           <a:xfrm>
             <a:off x="731520" y="2560320"/>
-            <a:ext cx="10698480" cy="3749039"/>
+            <a:ext cx="10698480" cy="3749040"/>
           </a:xfrm>
         </p:spPr>
         <p:txBody>
           <a:bodyPr wrap="square" anchor="t" anchorCtr="0"/>
           <a:lstStyle/>
           <a:p>
-            <a:pPr algn="l">
-              <a:buNone/>
-            </a:pPr>
-            <a:r>
-              <a:rPr lang="ja-JP"/>
-              <a:t>コンテンツを入力</a:t>
-            </a:r>
-          </a:p>
-        </p:txBody>
-      </p:sp>
-      <p:sp>
-        <p:nvSpPr>
-          <p:cNvPr id="30" name="SlideNum.Footer"/>
-          <p:cNvSpPr>
-            <a:spLocks noGrp="1"/>
-          </p:cNvSpPr>
-          <p:nvPr>
-            <p:ph idx="50" type="sldNum"/>
+            <a:r>
+              <a:rPr lang="ja-JP"/>
+              <a:t> </a:t>
+            </a:r>
+          </a:p>
+        </p:txBody>
+      </p:sp>
+      <p:sp>
+        <p:nvSpPr>
+          <p:cNvPr id="9" name="SlideNum.Footer"/>
+          <p:cNvSpPr>
+            <a:spLocks noGrp="1"/>
+          </p:cNvSpPr>
+          <p:nvPr>
+            <p:ph type="sldNum" idx="50"/>
           </p:nvPr>
         </p:nvSpPr>
         <p:spPr>
@@ -639,12 +612,9 @@
             </a:defPPr>
           </a:lstStyle>
           <a:p>
-            <a:pPr algn="r">
-              <a:buNone/>
-            </a:pPr>
-            <a:r>
-              <a:rPr lang="ja-JP"/>
-              <a:t>&lt;#&gt;</a:t>
+            <a:r>
+              <a:rPr lang="ja-JP"/>
+              <a:t> </a:t>
             </a:r>
           </a:p>
         </p:txBody>
@@ -656,7 +626,7 @@
 </file>
 
 <file path=ppt/slideLayouts/slideLayout11.xml><?xml version="1.0" encoding="utf-8"?>
-<p:sldLayout xmlns:a="http://schemas.openxmlformats.org/drawingml/2006/main" xmlns:r="http://schemas.openxmlformats.org/officeDocument/2006/relationships" xmlns:p="http://schemas.openxmlformats.org/presentationml/2006/main" type="twoObj" preserve="1">
+<p:sldLayout xmlns:a="http://schemas.openxmlformats.org/drawingml/2006/main" xmlns:p="http://schemas.openxmlformats.org/presentationml/2006/main" xmlns:r="http://schemas.openxmlformats.org/officeDocument/2006/relationships" type="twoObj" preserve="1">
   <p:cSld name="Column.2Body.Equal">
     <p:spTree>
       <p:nvGrpSpPr>
@@ -696,12 +666,12 @@
       </p:sp>
       <p:sp>
         <p:nvSpPr>
-          <p:cNvPr id="10" name="SlideTitle.Header"/>
-          <p:cNvSpPr>
-            <a:spLocks noGrp="1"/>
-          </p:cNvSpPr>
-          <p:nvPr>
-            <p:ph idx="15" type="body"/>
+          <p:cNvPr id="3" name="SlideTitle.Header"/>
+          <p:cNvSpPr>
+            <a:spLocks noGrp="1"/>
+          </p:cNvSpPr>
+          <p:nvPr>
+            <p:ph type="body" idx="15"/>
           </p:nvPr>
         </p:nvSpPr>
         <p:spPr>
@@ -722,24 +692,21 @@
             </a:defPPr>
           </a:lstStyle>
           <a:p>
-            <a:pPr algn="l">
-              <a:buNone/>
-            </a:pPr>
-            <a:r>
-              <a:rPr lang="ja-JP"/>
-              <a:t>スライドタイトル</a:t>
-            </a:r>
-          </a:p>
-        </p:txBody>
-      </p:sp>
-      <p:sp>
-        <p:nvSpPr>
-          <p:cNvPr id="11" name="SlideSubtitle.Header"/>
-          <p:cNvSpPr>
-            <a:spLocks noGrp="1"/>
-          </p:cNvSpPr>
-          <p:nvPr>
-            <p:ph idx="16" type="body"/>
+            <a:r>
+              <a:rPr lang="ja-JP"/>
+              <a:t> </a:t>
+            </a:r>
+          </a:p>
+        </p:txBody>
+      </p:sp>
+      <p:sp>
+        <p:nvSpPr>
+          <p:cNvPr id="4" name="SlideSubtitle.Header"/>
+          <p:cNvSpPr>
+            <a:spLocks noGrp="1"/>
+          </p:cNvSpPr>
+          <p:nvPr>
+            <p:ph type="body" idx="16"/>
           </p:nvPr>
         </p:nvSpPr>
         <p:spPr>
@@ -760,24 +727,21 @@
             </a:defPPr>
           </a:lstStyle>
           <a:p>
-            <a:pPr algn="l">
-              <a:buNone/>
-            </a:pPr>
-            <a:r>
-              <a:rPr lang="ja-JP"/>
-              <a:t>サブタイトル</a:t>
-            </a:r>
-          </a:p>
-        </p:txBody>
-      </p:sp>
-      <p:sp>
-        <p:nvSpPr>
-          <p:cNvPr id="20" name="Body1.Left"/>
-          <p:cNvSpPr>
-            <a:spLocks noGrp="1"/>
-          </p:cNvSpPr>
-          <p:nvPr>
-            <p:ph idx="1" type="body"/>
+            <a:r>
+              <a:rPr lang="ja-JP"/>
+              <a:t> </a:t>
+            </a:r>
+          </a:p>
+        </p:txBody>
+      </p:sp>
+      <p:sp>
+        <p:nvSpPr>
+          <p:cNvPr id="5" name="Body1.Left"/>
+          <p:cNvSpPr>
+            <a:spLocks noGrp="1"/>
+          </p:cNvSpPr>
+          <p:nvPr>
+            <p:ph type="body" idx="1"/>
           </p:nvPr>
         </p:nvSpPr>
         <p:spPr>
@@ -790,24 +754,21 @@
           <a:bodyPr wrap="square" anchor="t" anchorCtr="0"/>
           <a:lstStyle/>
           <a:p>
-            <a:pPr algn="l">
-              <a:buNone/>
-            </a:pPr>
-            <a:r>
-              <a:rPr lang="ja-JP"/>
-              <a:t>左カラム</a:t>
-            </a:r>
-          </a:p>
-        </p:txBody>
-      </p:sp>
-      <p:sp>
-        <p:nvSpPr>
-          <p:cNvPr id="21" name="Body2.Right"/>
-          <p:cNvSpPr>
-            <a:spLocks noGrp="1"/>
-          </p:cNvSpPr>
-          <p:nvPr>
-            <p:ph idx="2" type="body"/>
+            <a:r>
+              <a:rPr lang="ja-JP"/>
+              <a:t> </a:t>
+            </a:r>
+          </a:p>
+        </p:txBody>
+      </p:sp>
+      <p:sp>
+        <p:nvSpPr>
+          <p:cNvPr id="6" name="Body2.Right"/>
+          <p:cNvSpPr>
+            <a:spLocks noGrp="1"/>
+          </p:cNvSpPr>
+          <p:nvPr>
+            <p:ph type="body" idx="2"/>
           </p:nvPr>
         </p:nvSpPr>
         <p:spPr>
@@ -820,24 +781,21 @@
           <a:bodyPr wrap="square" anchor="t" anchorCtr="0"/>
           <a:lstStyle/>
           <a:p>
-            <a:pPr algn="l">
-              <a:buNone/>
-            </a:pPr>
-            <a:r>
-              <a:rPr lang="ja-JP"/>
-              <a:t>右カラム</a:t>
-            </a:r>
-          </a:p>
-        </p:txBody>
-      </p:sp>
-      <p:sp>
-        <p:nvSpPr>
-          <p:cNvPr id="30" name="SlideNum.Footer"/>
-          <p:cNvSpPr>
-            <a:spLocks noGrp="1"/>
-          </p:cNvSpPr>
-          <p:nvPr>
-            <p:ph idx="50" type="sldNum"/>
+            <a:r>
+              <a:rPr lang="ja-JP"/>
+              <a:t> </a:t>
+            </a:r>
+          </a:p>
+        </p:txBody>
+      </p:sp>
+      <p:sp>
+        <p:nvSpPr>
+          <p:cNvPr id="7" name="SlideNum.Footer"/>
+          <p:cNvSpPr>
+            <a:spLocks noGrp="1"/>
+          </p:cNvSpPr>
+          <p:nvPr>
+            <p:ph type="sldNum" idx="50"/>
           </p:nvPr>
         </p:nvSpPr>
         <p:spPr>
@@ -858,12 +816,9 @@
             </a:defPPr>
           </a:lstStyle>
           <a:p>
-            <a:pPr algn="r">
-              <a:buNone/>
-            </a:pPr>
-            <a:r>
-              <a:rPr lang="ja-JP"/>
-              <a:t>&lt;#&gt;</a:t>
+            <a:r>
+              <a:rPr lang="ja-JP"/>
+              <a:t> </a:t>
             </a:r>
           </a:p>
         </p:txBody>
@@ -874,50 +829,461 @@
 </p:sldLayout>
 </file>
 
-<file path=ppt/slideLayouts/slideLayout12.xml><?xml version='1.0' encoding='UTF-8' standalone='yes'?>
-<ns0:sldLayout xmlns:ns0="http://schemas.openxmlformats.org/presentationml/2006/main" type="twoObj" preserve="1"><ns0:cSld name="Column.2Body.MainSub"><ns0:spTree><ns0:nvGrpSpPr><ns0:cNvPr id="1" name=""/><ns0:cNvGrpSpPr/><ns0:nvPr/></ns0:nvGrpSpPr><ns0:grpSpPr><ns1:xfrm xmlns:ns1="http://schemas.openxmlformats.org/drawingml/2006/main"><ns1:off x="0" y="0"/><ns1:ext cx="0" cy="0"/><ns1:chOff x="0" y="0"/><ns1:chExt cx="0" cy="0"/></ns1:xfrm></ns0:grpSpPr><ns0:sp><ns0:nvSpPr><ns0:cNvPr id="2" name="HeaderBar"/><ns0:cNvSpPr><ns1:spLocks xmlns:ns1="http://schemas.openxmlformats.org/drawingml/2006/main" noGrp="1" noSelect="0" noRot="1" noMove="1"/></ns0:cNvSpPr><ns0:nvPr/></ns0:nvSpPr><ns0:spPr><ns2:xfrm xmlns:ns2="http://schemas.openxmlformats.org/drawingml/2006/main"><ns2:off x="0" y="0"/><ns2:ext cx="12192000" cy="1051560"/></ns2:xfrm><ns3:prstGeom xmlns:ns3="http://schemas.openxmlformats.org/drawingml/2006/main" prst="rect"/><ns4:solidFill xmlns:ns4="http://schemas.openxmlformats.org/drawingml/2006/main"><ns4:srgbClr val="1E2761"/></ns4:solidFill><ns5:ln xmlns:ns5="http://schemas.openxmlformats.org/drawingml/2006/main"><ns5:noFill/></ns5:ln></ns0:spPr></ns0:sp><ns0:sp><ns0:nvSpPr><ns0:cNvPr id="10" name="SlideTitle.Header"/><ns0:cNvSpPr><ns1:spLocks xmlns:ns1="http://schemas.openxmlformats.org/drawingml/2006/main" noGrp="1"/></ns0:cNvSpPr><ns0:nvPr><ns0:ph idx="15" type="body"/></ns0:nvPr></ns0:nvSpPr><ns0:spPr><ns2:xfrm xmlns:ns2="http://schemas.openxmlformats.org/drawingml/2006/main"><ns2:off x="731520" y="91440"/><ns2:ext cx="9144000" cy="475488"/></ns2:xfrm></ns0:spPr><ns0:txBody><ns3:bodyPr xmlns:ns3="http://schemas.openxmlformats.org/drawingml/2006/main" wrap="square" anchor="t" anchorCtr="0"/><ns4:lstStyle><ns4:defPPr><ns4:defRPr sz="2800" b="1"><ns4:solidFill><ns4:srgbClr val="FFFFFF"/></ns4:solidFill></ns4:defRPr></ns4:defPPr></ns4:lstStyle><ns4:defPPr algn="l"><ns4:buNone/><ns4:defRPr sz="2800" dirty="0" b="1"><ns4:solidFill><ns4:srgbClr val="FFFFFF"/></ns4:solidFill><ns4:latin typeface="Georgia"/><ns4:ea typeface="Georgia"/></ns4:defRPr></ns4:defPPr><ns4:lvl1pPr algn="l"><ns4:buNone/><ns4:defRPr sz="2800" dirty="0" b="1"><ns4:solidFill><ns4:srgbClr val="FFFFFF"/></ns4:solidFill><ns4:latin typeface="Georgia"/><ns4:ea typeface="Georgia"/></ns4:defRPr></ns4:lvl1pPr><ns4:lvl2pPr algn="l"><ns4:buNone/><ns4:defRPr sz="2800" dirty="0" b="1"><ns4:solidFill><ns4:srgbClr val="FFFFFF"/></ns4:solidFill><ns4:latin typeface="Georgia"/><ns4:ea typeface="Georgia"/></ns4:defRPr></ns4:lvl2pPr><ns4:lvl3pPr algn="l"><ns4:buNone/><ns4:defRPr sz="2800" dirty="0" b="1"><ns4:solidFill><ns4:srgbClr val="FFFFFF"/></ns4:solidFill><ns4:latin typeface="Georgia"/><ns4:ea typeface="Georgia"/></ns4:defRPr></ns4:lvl3pPr><ns4:lvl4pPr algn="l"><ns4:buNone/><ns4:defRPr sz="2800" dirty="0" b="1"><ns4:solidFill><ns4:srgbClr val="FFFFFF"/></ns4:solidFill><ns4:latin typeface="Georgia"/><ns4:ea typeface="Georgia"/></ns4:defRPr></ns4:lvl4pPr><ns4:lvl5pPr algn="l"><ns4:buNone/><ns4:defRPr sz="2800" dirty="0" b="1"><ns4:solidFill><ns4:srgbClr val="FFFFFF"/></ns4:solidFill><ns4:latin typeface="Georgia"/><ns4:ea typeface="Georgia"/></ns4:defRPr></ns4:lvl5pPr><ns4:lvl6pPr algn="l"><ns4:buNone/><ns4:defRPr sz="2800" dirty="0" b="1"><ns4:solidFill><ns4:srgbClr val="FFFFFF"/></ns4:solidFill><ns4:latin typeface="Georgia"/><ns4:ea typeface="Georgia"/></ns4:defRPr></ns4:lvl6pPr><ns4:lvl7pPr algn="l"><ns4:buNone/><ns4:defRPr sz="2800" dirty="0" b="1"><ns4:solidFill><ns4:srgbClr val="FFFFFF"/></ns4:solidFill><ns4:latin typeface="Georgia"/><ns4:ea typeface="Georgia"/></ns4:defRPr></ns4:lvl7pPr><ns4:lvl8pPr algn="l"><ns4:buNone/><ns4:defRPr sz="2800" dirty="0" b="1"><ns4:solidFill><ns4:srgbClr val="FFFFFF"/></ns4:solidFill><ns4:latin typeface="Georgia"/><ns4:ea typeface="Georgia"/></ns4:defRPr></ns4:lvl8pPr><ns4:lvl9pPr algn="l"><ns4:buNone/><ns4:defRPr sz="2800" dirty="0" b="1"><ns4:solidFill><ns4:srgbClr val="FFFFFF"/></ns4:solidFill><ns4:latin typeface="Georgia"/><ns4:ea typeface="Georgia"/></ns4:defRPr></ns4:lvl9pPr></ns4:lstStyle/><ns5:p xmlns:ns5="http://schemas.openxmlformats.org/drawingml/2006/main"><ns5:pPr algn="l"><ns5:buNone/></ns5:pPr><ns5:r><ns5:rPr lang="ja-JP"/><ns5:t>サブタイトル</ns5:t></ns5:r></ns5:p></ns0:txBody></ns0:sp><ns0:sp><ns0:nvSpPr><ns0:cNvPr id="20" name="Body1.Left"/><ns0:cNvSpPr><ns1:spLocks xmlns:ns1="http://schemas.openxmlformats.org/drawingml/2006/main" noGrp="1"/></ns0:cNvSpPr><ns0:nvPr><ns0:ph idx="1" type="body"/></ns0:nvPr></ns0:nvSpPr><ns0:spPr><ns2:xfrm xmlns:ns2="http://schemas.openxmlformats.org/drawingml/2006/main"><ns2:off x="731520" y="1325880"/><ns2:ext cx="6766560" cy="4937760"/></ns2:xfrm></ns0:spPr><ns0:txBody><ns3:bodyPr xmlns:ns3="http://schemas.openxmlformats.org/drawingml/2006/main" wrap="square" anchor="t" anchorCtr="0"/><ns4:lstStyle/><ns4:defPPr algn="l"><ns4:buNone/><ns4:defRPr sz="1400" dirty="0"><ns4:solidFill><ns4:srgbClr val="1E293B"/></ns4:solidFill><ns4:latin typeface="Calibri"/><ns4:ea typeface="Calibri"/></ns4:defRPr></ns4:defPPr><ns4:lvl1pPr algn="l"><ns4:buNone/><ns4:defRPr sz="1400" dirty="0"><ns4:solidFill><ns4:srgbClr val="1E293B"/></ns4:solidFill><ns4:latin typeface="Calibri"/><ns4:ea typeface="Calibri"/></ns4:defRPr></ns4:lvl1pPr><ns4:lvl2pPr algn="l"><ns4:buNone/><ns4:defRPr sz="1400" dirty="0"><ns4:solidFill><ns4:srgbClr val="1E293B"/></ns4:solidFill><ns4:latin typeface="Calibri"/><ns4:ea typeface="Calibri"/></ns4:defRPr></ns4:lvl2pPr><ns4:lvl3pPr algn="l"><ns4:buNone/><ns4:defRPr sz="1400" dirty="0"><ns4:solidFill><ns4:srgbClr val="1E293B"/></ns4:solidFill><ns4:latin typeface="Calibri"/><ns4:ea typeface="Calibri"/></ns4:defRPr></ns4:lvl3pPr><ns4:lvl4pPr algn="l"><ns4:buNone/><ns4:defRPr sz="1400" dirty="0"><ns4:solidFill><ns4:srgbClr val="1E293B"/></ns4:solidFill><ns4:latin typeface="Calibri"/><ns4:ea typeface="Calibri"/></ns4:defRPr></ns4:lvl4pPr><ns4:lvl5pPr algn="l"><ns4:buNone/><ns4:defRPr sz="1400" dirty="0"><ns4:solidFill><ns4:srgbClr val="1E293B"/></ns4:solidFill><ns4:latin typeface="Calibri"/><ns4:ea typeface="Calibri"/></ns4:defRPr></ns4:lvl5pPr><ns4:lvl6pPr algn="l"><ns4:buNone/><ns4:defRPr sz="1400" dirty="0"><ns4:solidFill><ns4:srgbClr val="1E293B"/></ns4:solidFill><ns4:latin typeface="Calibri"/><ns4:ea typeface="Calibri"/></ns4:defRPr></ns4:lvl6pPr><ns4:lvl7pPr algn="l"><ns4:buNone/><ns4:defRPr sz="1400" dirty="0"><ns4:solidFill><ns4:srgbClr val="1E293B"/></ns4:solidFill><ns4:latin typeface="Calibri"/><ns4:ea typeface="Calibri"/></ns4:defRPr></ns4:lvl7pPr><ns4:lvl8pPr algn="l"><ns4:buNone/><ns4:defRPr sz="1400" dirty="0"><ns4:solidFill><ns4:srgbClr val="1E293B"/></ns4:solidFill><ns4:latin typeface="Calibri"/><ns4:ea typeface="Calibri"/></ns4:defRPr></ns4:lvl8pPr><ns4:lvl9pPr algn="l"><ns4:buNone/><ns4:defRPr sz="1400" dirty="0"><ns4:solidFill><ns4:srgbClr val="1E293B"/></ns4:solidFill><ns4:latin typeface="Calibri"/><ns4:ea typeface="Calibri"/></ns4:defRPr></ns4:lvl9pPr></ns4:lstStyle/><ns5:p xmlns:ns5="http://schemas.openxmlformats.org/drawingml/2006/main"><ns5:pPr algn="l"><ns5:buNone/></ns5:pPr><ns5:r><ns5:rPr lang="ja-JP"/><ns5:t>サブカラム</ns5:t></ns5:r></ns5:p></ns0:txBody></ns0:sp><ns0:sp><ns0:nvSpPr><ns0:cNvPr id="30" name="SlideNum.Footer"/><ns0:cNvSpPr><ns1:spLocks xmlns:ns1="http://schemas.openxmlformats.org/drawingml/2006/main" noGrp="1"/></ns0:cNvSpPr><ns0:nvPr><ns0:ph idx="50" type="sldNum"/></ns0:nvPr></ns0:nvSpPr><ns0:spPr><ns2:xfrm xmlns:ns2="http://schemas.openxmlformats.org/drawingml/2006/main"><ns2:off x="10972800" y="6446520"/><ns2:ext cx="1097280" cy="274320"/></ns2:xfrm></ns0:spPr><ns0:txBody><ns3:bodyPr xmlns:ns3="http://schemas.openxmlformats.org/drawingml/2006/main" wrap="square" anchor="t" anchorCtr="0"/><ns4:lstStyle><ns4:defPPr algn="r"><ns4:defRPr sz="1000"><ns4:solidFill><ns4:srgbClr val="94A3B8"/></ns4:solidFill></ns4:defRPr></ns4:defPPr></ns4:lstStyle><ns4:defPPr algn="r"><ns4:buNone/><ns4:defRPr sz="1000" dirty="0"><ns4:solidFill><ns4:srgbClr val="94A3B8"/></ns4:solidFill><ns4:latin typeface="Calibri"/><ns4:ea typeface="Calibri"/></ns4:defRPr></ns4:defPPr><ns4:lvl1pPr algn="r"><ns4:buNone/><ns4:defRPr sz="1000" dirty="0"><ns4:solidFill><ns4:srgbClr val="94A3B8"/></ns4:solidFill><ns4:latin typeface="Calibri"/><ns4:ea typeface="Calibri"/></ns4:defRPr></ns4:lvl1pPr><ns4:lvl2pPr algn="r"><ns4:buNone/><ns4:defRPr sz="1000" dirty="0"><ns4:solidFill><ns4:srgbClr val="94A3B8"/></ns4:solidFill><ns4:latin typeface="Calibri"/><ns4:ea typeface="Calibri"/></ns4:defRPr></ns4:lvl2pPr><ns4:lvl3pPr algn="r"><ns4:buNone/><ns4:defRPr sz="1000" dirty="0"><ns4:solidFill><ns4:srgbClr val="94A3B8"/></ns4:solidFill><ns4:latin typeface="Calibri"/><ns4:ea typeface="Calibri"/></ns4:defRPr></ns4:lvl3pPr><ns4:lvl4pPr algn="r"><ns4:buNone/><ns4:defRPr sz="1000" dirty="0"><ns4:solidFill><ns4:srgbClr val="94A3B8"/></ns4:solidFill><ns4:latin typeface="Calibri"/><ns4:ea typeface="Calibri"/></ns4:defRPr></ns4:lvl4pPr><ns4:lvl5pPr algn="r"><ns4:buNone/><ns4:defRPr sz="1000" dirty="0"><ns4:solidFill><ns4:srgbClr val="94A3B8"/></ns4:solidFill><ns4:latin typeface="Calibri"/><ns4:ea typeface="Calibri"/></ns4:defRPr></ns4:lvl5pPr><ns4:lvl6pPr algn="r"><ns4:buNone/><ns4:defRPr sz="1000" dirty="0"><ns4:solidFill><ns4:srgbClr val="94A3B8"/></ns4:solidFill><ns4:latin typeface="Calibri"/><ns4:ea typeface="Calibri"/></ns4:defRPr></ns4:lvl6pPr><ns4:lvl7pPr algn="r"><ns4:buNone/><ns4:defRPr sz="1000" dirty="0"><ns4:solidFill><ns4:srgbClr val="94A3B8"/></ns4:solidFill><ns4:latin typeface="Calibri"/><ns4:ea typeface="Calibri"/></ns4:defRPr></ns4:lvl7pPr><ns4:lvl8pPr algn="r"><ns4:buNone/><ns4:defRPr sz="1000" dirty="0"><ns4:solidFill><ns4:srgbClr val="94A3B8"/></ns4:solidFill><ns4:latin typeface="Calibri"/><ns4:ea typeface="Calibri"/></ns4:defRPr></ns4:lvl8pPr><ns4:lvl9pPr algn="r"><ns4:buNone/><ns4:defRPr sz="1000" dirty="0"><ns4:solidFill><ns4:srgbClr val="94A3B8"/></ns4:solidFill><ns4:latin typeface="Calibri"/><ns4:ea typeface="Calibri"/></ns4:defRPr></ns4:lvl9pPr></ns4:lstStyle><ns5:p xmlns:ns5="http://schemas.openxmlformats.org/drawingml/2006/main"><ns5:pPr algn="r"><ns5:buNone/></ns5:pPr><ns5:r><ns5:rPr lang="ja-JP"/><ns5:t>&lt;#&gt;</ns5:t></ns5:r></ns5:p></ns0:txBody></ns0:sp></ns0:spTree></ns0:cSld><ns0:clrMapOvr/></ns0:sldLayout>
+<file path=ppt/slideLayouts/slideLayout12.xml><?xml version="1.0" encoding="utf-8"?>
+<p:sldLayout xmlns:a="http://schemas.openxmlformats.org/drawingml/2006/main" xmlns:p="http://schemas.openxmlformats.org/presentationml/2006/main" xmlns:r="http://schemas.openxmlformats.org/officeDocument/2006/relationships" type="twoObj" preserve="1">
+  <p:cSld name="Column.2Body.MainSub">
+    <p:spTree>
+      <p:nvGrpSpPr>
+        <p:cNvPr id="1" name=""/>
+        <p:cNvGrpSpPr/>
+        <p:nvPr/>
+      </p:nvGrpSpPr>
+      <p:grpSpPr>
+        <a:xfrm>
+          <a:off x="0" y="0"/>
+          <a:ext cx="0" cy="0"/>
+          <a:chOff x="0" y="0"/>
+          <a:chExt cx="0" cy="0"/>
+        </a:xfrm>
+      </p:grpSpPr>
+      <p:sp>
+        <p:nvSpPr>
+          <p:cNvPr id="2" name="HeaderBar"/>
+          <p:cNvSpPr>
+            <a:spLocks xmlns:ns1="http://schemas.openxmlformats.org/drawingml/2006/main" noGrp="1" noSelect="0" noRot="1" noMove="1"/>
+          </p:cNvSpPr>
+          <p:nvPr/>
+        </p:nvSpPr>
+        <p:spPr>
+          <a:xfrm xmlns:ns2="http://schemas.openxmlformats.org/drawingml/2006/main">
+            <a:off x="0" y="0"/>
+            <a:ext cx="12192000" cy="1051560"/>
+          </a:xfrm>
+          <a:prstGeom xmlns:ns3="http://schemas.openxmlformats.org/drawingml/2006/main" prst="rect"/>
+          <a:solidFill xmlns:ns4="http://schemas.openxmlformats.org/drawingml/2006/main">
+            <a:srgbClr val="1E2761"/>
+          </a:solidFill>
+          <a:ln xmlns:ns5="http://schemas.openxmlformats.org/drawingml/2006/main">
+            <a:noFill/>
+          </a:ln>
+        </p:spPr>
+      </p:sp>
+      <p:sp>
+        <p:nvSpPr>
+          <p:cNvPr id="3" name="SlideTitle.Header"/>
+          <p:cNvSpPr>
+            <a:spLocks noGrp="1"/>
+          </p:cNvSpPr>
+          <p:nvPr>
+            <p:ph type="body" idx="15"/>
+          </p:nvPr>
+        </p:nvSpPr>
+        <p:spPr>
+          <a:xfrm>
+            <a:off x="731520" y="91440"/>
+            <a:ext cx="9144000" cy="475488"/>
+          </a:xfrm>
+        </p:spPr>
+        <p:txBody>
+          <a:bodyPr wrap="square" anchor="t" anchorCtr="0"/>
+          <a:lstStyle>
+            <a:defPPr>
+              <a:defRPr sz="2800" b="1">
+                <a:solidFill>
+                  <a:srgbClr val="FFFFFF"/>
+                </a:solidFill>
+              </a:defRPr>
+            </a:defPPr>
+          </a:lstStyle>
+          <a:p>
+            <a:r>
+              <a:rPr lang="ja-JP"/>
+              <a:t> </a:t>
+            </a:r>
+          </a:p>
+        </p:txBody>
+      </p:sp>
+      <p:sp>
+        <p:nvSpPr>
+          <p:cNvPr id="4" name="SlideSubtitle.Header"/>
+          <p:cNvSpPr>
+            <a:spLocks noGrp="1"/>
+          </p:cNvSpPr>
+          <p:nvPr>
+            <p:ph type="body" idx="16"/>
+          </p:nvPr>
+        </p:nvSpPr>
+        <p:spPr>
+          <a:xfrm>
+            <a:off x="731520" y="658368"/>
+            <a:ext cx="9144000" cy="274320"/>
+          </a:xfrm>
+        </p:spPr>
+        <p:txBody>
+          <a:bodyPr wrap="square" anchor="t" anchorCtr="0"/>
+          <a:lstStyle>
+            <a:defPPr>
+              <a:defRPr sz="1200">
+                <a:solidFill>
+                  <a:srgbClr val="CADCFC"/>
+                </a:solidFill>
+              </a:defRPr>
+            </a:defPPr>
+          </a:lstStyle>
+          <a:p>
+            <a:r>
+              <a:rPr lang="ja-JP"/>
+              <a:t> </a:t>
+            </a:r>
+          </a:p>
+        </p:txBody>
+      </p:sp>
+      <p:sp>
+        <p:nvSpPr>
+          <p:cNvPr id="5" name="Body1.Left"/>
+          <p:cNvSpPr>
+            <a:spLocks noGrp="1"/>
+          </p:cNvSpPr>
+          <p:nvPr>
+            <p:ph type="body" idx="1"/>
+          </p:nvPr>
+        </p:nvSpPr>
+        <p:spPr>
+          <a:xfrm>
+            <a:off x="731520" y="1325880"/>
+            <a:ext cx="6766560" cy="4937760"/>
+          </a:xfrm>
+        </p:spPr>
+        <p:txBody>
+          <a:bodyPr wrap="square" anchor="t" anchorCtr="0"/>
+          <a:lstStyle/>
+          <a:p>
+            <a:r>
+              <a:rPr lang="ja-JP"/>
+              <a:t> </a:t>
+            </a:r>
+          </a:p>
+        </p:txBody>
+      </p:sp>
+      <p:sp>
+        <p:nvSpPr>
+          <p:cNvPr id="6" name="Body2.Right"/>
+          <p:cNvSpPr>
+            <a:spLocks noGrp="1"/>
+          </p:cNvSpPr>
+          <p:nvPr>
+            <p:ph type="body" idx="2"/>
+          </p:nvPr>
+        </p:nvSpPr>
+        <p:spPr>
+          <a:xfrm>
+            <a:off x="8046720" y="1417320"/>
+            <a:ext cx="3474720" cy="4663440"/>
+          </a:xfrm>
+        </p:spPr>
+        <p:txBody>
+          <a:bodyPr wrap="square" anchor="t" anchorCtr="0"/>
+          <a:lstStyle/>
+          <a:p>
+            <a:r>
+              <a:rPr lang="ja-JP"/>
+              <a:t> </a:t>
+            </a:r>
+          </a:p>
+        </p:txBody>
+      </p:sp>
+      <p:sp>
+        <p:nvSpPr>
+          <p:cNvPr id="7" name="SlideNum.Footer"/>
+          <p:cNvSpPr>
+            <a:spLocks noGrp="1"/>
+          </p:cNvSpPr>
+          <p:nvPr>
+            <p:ph type="sldNum" idx="50"/>
+          </p:nvPr>
+        </p:nvSpPr>
+        <p:spPr>
+          <a:xfrm>
+            <a:off x="10972800" y="6446520"/>
+            <a:ext cx="1097280" cy="274320"/>
+          </a:xfrm>
+        </p:spPr>
+        <p:txBody>
+          <a:bodyPr wrap="square" anchor="t" anchorCtr="0"/>
+          <a:lstStyle>
+            <a:defPPr algn="r">
+              <a:defRPr sz="1000">
+                <a:solidFill>
+                  <a:srgbClr val="94A3B8"/>
+                </a:solidFill>
+              </a:defRPr>
+            </a:defPPr>
+          </a:lstStyle>
+          <a:p>
+            <a:r>
+              <a:rPr lang="ja-JP"/>
+              <a:t> </a:t>
+            </a:r>
+          </a:p>
+        </p:txBody>
+      </p:sp>
+    </p:spTree>
+  </p:cSld>
+  <p:clrMapOvr/>
+</p:sldLayout>
 </file>
 
-<file path=ppt/slideLayouts/slideLayout13.xml><?xml version='1.0' encoding='UTF-8' standalone='yes'?>
-<ns0:sldLayout xmlns:ns0="http://schemas.openxmlformats.org/presentationml/2006/main" type="threeObj" preserve="1"><ns0:cSld name="Column.3Body.Equal"><ns0:spTree><ns0:nvGrpSpPr><ns0:cNvPr id="1" name=""/><ns0:cNvGrpSpPr/><ns0:nvPr/></ns0:nvGrpSpPr><ns0:grpSpPr><ns1:xfrm xmlns:ns1="http://schemas.openxmlformats.org/drawingml/2006/main"><ns1:off x="0" y="0"/><ns1:ext cx="0" cy="0"/><ns1:chOff x="0" y="0"/><ns1:chExt cx="0" cy="0"/></ns1:xfrm></ns0:grpSpPr><ns0:sp><ns0:nvSpPr><ns0:cNvPr id="2" name="HeaderBar"/><ns0:cNvSpPr><ns1:spLocks xmlns:ns1="http://schemas.openxmlformats.org/drawingml/2006/main" noGrp="1" noSelect="0" noRot="1" noMove="1"/></ns0:cNvSpPr><ns0:nvPr/></ns0:nvSpPr><ns0:spPr><ns2:xfrm xmlns:ns2="http://schemas.openxmlformats.org/drawingml/2006/main"><ns2:off x="0" y="0"/><ns2:ext cx="12192000" cy="1051560"/></ns2:xfrm><ns3:prstGeom xmlns:ns3="http://schemas.openxmlformats.org/drawingml/2006/main" prst="rect"/><ns4:solidFill xmlns:ns4="http://schemas.openxmlformats.org/drawingml/2006/main"><ns4:srgbClr val="1E2761"/></ns4:solidFill><ns5:ln xmlns:ns5="http://schemas.openxmlformats.org/drawingml/2006/main"><ns5:noFill/></ns5:ln></ns0:spPr></ns0:sp><ns0:sp><ns0:nvSpPr><ns0:cNvPr id="10" name="SlideTitle.Header"/><ns0:cNvSpPr><ns1:spLocks xmlns:ns1="http://schemas.openxmlformats.org/drawingml/2006/main" noGrp="1"/></ns0:cNvSpPr><ns0:nvPr><ns0:ph idx="15" type="body"/></ns0:nvPr></ns0:nvSpPr><ns0:spPr><ns2:xfrm xmlns:ns2="http://schemas.openxmlformats.org/drawingml/2006/main"><ns2:off x="731520" y="91440"/><ns2:ext cx="9144000" cy="475488"/></ns2:xfrm></ns0:spPr><ns0:txBody><ns3:bodyPr xmlns:ns3="http://schemas.openxmlformats.org/drawingml/2006/main" wrap="square" anchor="t" anchorCtr="0"/><ns4:lstStyle><ns4:defPPr><ns4:defRPr sz="2800" b="1"><ns4:solidFill><ns4:srgbClr val="FFFFFF"/></ns4:solidFill></ns4:defRPr></ns4:defPPr></ns4:lstStyle><ns4:defPPr algn="l"><ns4:buNone/><ns4:defRPr sz="2800" dirty="0" b="1"><ns4:solidFill><ns4:srgbClr val="FFFFFF"/></ns4:solidFill><ns4:latin typeface="Georgia"/><ns4:ea typeface="Georgia"/></ns4:defRPr></ns4:defPPr><ns4:lvl1pPr algn="l"><ns4:buNone/><ns4:defRPr sz="2800" dirty="0" b="1"><ns4:solidFill><ns4:srgbClr val="FFFFFF"/></ns4:solidFill><ns4:latin typeface="Georgia"/><ns4:ea typeface="Georgia"/></ns4:defRPr></ns4:lvl1pPr><ns4:lvl2pPr algn="l"><ns4:buNone/><ns4:defRPr sz="2800" dirty="0" b="1"><ns4:solidFill><ns4:srgbClr val="FFFFFF"/></ns4:solidFill><ns4:latin typeface="Georgia"/><ns4:ea typeface="Georgia"/></ns4:defRPr></ns4:lvl2pPr><ns4:lvl3pPr algn="l"><ns4:buNone/><ns4:defRPr sz="2800" dirty="0" b="1"><ns4:solidFill><ns4:srgbClr val="FFFFFF"/></ns4:solidFill><ns4:latin typeface="Georgia"/><ns4:ea typeface="Georgia"/></ns4:defRPr></ns4:lvl3pPr><ns4:lvl4pPr algn="l"><ns4:buNone/><ns4:defRPr sz="2800" dirty="0" b="1"><ns4:solidFill><ns4:srgbClr val="FFFFFF"/></ns4:solidFill><ns4:latin typeface="Georgia"/><ns4:ea typeface="Georgia"/></ns4:defRPr></ns4:lvl4pPr><ns4:lvl5pPr algn="l"><ns4:buNone/><ns4:defRPr sz="2800" dirty="0" b="1"><ns4:solidFill><ns4:srgbClr val="FFFFFF"/></ns4:solidFill><ns4:latin typeface="Georgia"/><ns4:ea typeface="Georgia"/></ns4:defRPr></ns4:lvl5pPr><ns4:lvl6pPr algn="l"><ns4:buNone/><ns4:defRPr sz="2800" dirty="0" b="1"><ns4:solidFill><ns4:srgbClr val="FFFFFF"/></ns4:solidFill><ns4:latin typeface="Georgia"/><ns4:ea typeface="Georgia"/></ns4:defRPr></ns4:lvl6pPr><ns4:lvl7pPr algn="l"><ns4:buNone/><ns4:defRPr sz="2800" dirty="0" b="1"><ns4:solidFill><ns4:srgbClr val="FFFFFF"/></ns4:solidFill><ns4:latin typeface="Georgia"/><ns4:ea typeface="Georgia"/></ns4:defRPr></ns4:lvl7pPr><ns4:lvl8pPr algn="l"><ns4:buNone/><ns4:defRPr sz="2800" dirty="0" b="1"><ns4:solidFill><ns4:srgbClr val="FFFFFF"/></ns4:solidFill><ns4:latin typeface="Georgia"/><ns4:ea typeface="Georgia"/></ns4:defRPr></ns4:lvl8pPr><ns4:lvl9pPr algn="l"><ns4:buNone/><ns4:defRPr sz="2800" dirty="0" b="1"><ns4:solidFill><ns4:srgbClr val="FFFFFF"/></ns4:solidFill><ns4:latin typeface="Georgia"/><ns4:ea typeface="Georgia"/></ns4:defRPr></ns4:lvl9pPr></ns4:lstStyle/><ns5:p xmlns:ns5="http://schemas.openxmlformats.org/drawingml/2006/main"><ns5:pPr algn="l"><ns5:buNone/></ns5:pPr><ns5:r><ns5:rPr lang="ja-JP"/><ns5:t>サブタイトル</ns5:t></ns5:r></ns5:p></ns0:txBody></ns0:sp><ns0:sp><ns0:nvSpPr><ns0:cNvPr id="20" name="Body1.Left"/><ns0:cNvSpPr><ns1:spLocks xmlns:ns1="http://schemas.openxmlformats.org/drawingml/2006/main" noGrp="1"/></ns0:cNvSpPr><ns0:nvPr><ns0:ph idx="1" type="body"/></ns0:nvPr></ns0:nvSpPr><ns0:spPr><ns2:xfrm xmlns:ns2="http://schemas.openxmlformats.org/drawingml/2006/main"><ns2:off x="731520" y="1325880"/><ns2:ext cx="3200400" cy="4937760"/></ns2:xfrm></ns0:spPr><ns0:txBody><ns3:bodyPr xmlns:ns3="http://schemas.openxmlformats.org/drawingml/2006/main" wrap="square" anchor="t" anchorCtr="0"/><ns4:lstStyle/><ns4:defPPr algn="l"><ns4:buNone/><ns4:defRPr sz="1400" dirty="0"><ns4:solidFill><ns4:srgbClr val="1E293B"/></ns4:solidFill><ns4:latin typeface="Calibri"/><ns4:ea typeface="Calibri"/></ns4:defRPr></ns4:defPPr><ns4:lvl1pPr algn="l"><ns4:buNone/><ns4:defRPr sz="1400" dirty="0"><ns4:solidFill><ns4:srgbClr val="1E293B"/></ns4:solidFill><ns4:latin typeface="Calibri"/><ns4:ea typeface="Calibri"/></ns4:defRPr></ns4:lvl1pPr><ns4:lvl2pPr algn="l"><ns4:buNone/><ns4:defRPr sz="1400" dirty="0"><ns4:solidFill><ns4:srgbClr val="1E293B"/></ns4:solidFill><ns4:latin typeface="Calibri"/><ns4:ea typeface="Calibri"/></ns4:defRPr></ns4:lvl2pPr><ns4:lvl3pPr algn="l"><ns4:buNone/><ns4:defRPr sz="1400" dirty="0"><ns4:solidFill><ns4:srgbClr val="1E293B"/></ns4:solidFill><ns4:latin typeface="Calibri"/><ns4:ea typeface="Calibri"/></ns4:defRPr></ns4:lvl3pPr><ns4:lvl4pPr algn="l"><ns4:buNone/><ns4:defRPr sz="1400" dirty="0"><ns4:solidFill><ns4:srgbClr val="1E293B"/></ns4:solidFill><ns4:latin typeface="Calibri"/><ns4:ea typeface="Calibri"/></ns4:defRPr></ns4:lvl4pPr><ns4:lvl5pPr algn="l"><ns4:buNone/><ns4:defRPr sz="1400" dirty="0"><ns4:solidFill><ns4:srgbClr val="1E293B"/></ns4:solidFill><ns4:latin typeface="Calibri"/><ns4:ea typeface="Calibri"/></ns4:defRPr></ns4:lvl5pPr><ns4:lvl6pPr algn="l"><ns4:buNone/><ns4:defRPr sz="1400" dirty="0"><ns4:solidFill><ns4:srgbClr val="1E293B"/></ns4:solidFill><ns4:latin typeface="Calibri"/><ns4:ea typeface="Calibri"/></ns4:defRPr></ns4:lvl6pPr><ns4:lvl7pPr algn="l"><ns4:buNone/><ns4:defRPr sz="1400" dirty="0"><ns4:solidFill><ns4:srgbClr val="1E293B"/></ns4:solidFill><ns4:latin typeface="Calibri"/><ns4:ea typeface="Calibri"/></ns4:defRPr></ns4:lvl7pPr><ns4:lvl8pPr algn="l"><ns4:buNone/><ns4:defRPr sz="1400" dirty="0"><ns4:solidFill><ns4:srgbClr val="1E293B"/></ns4:solidFill><ns4:latin typeface="Calibri"/><ns4:ea typeface="Calibri"/></ns4:defRPr></ns4:lvl8pPr><ns4:lvl9pPr algn="l"><ns4:buNone/><ns4:defRPr sz="1400" dirty="0"><ns4:solidFill><ns4:srgbClr val="1E293B"/></ns4:solidFill><ns4:latin typeface="Calibri"/><ns4:ea typeface="Calibri"/></ns4:defRPr></ns4:lvl9pPr></ns4:lstStyle/><ns5:p xmlns:ns5="http://schemas.openxmlformats.org/drawingml/2006/main"><ns5:pPr algn="l"><ns5:buNone/></ns5:pPr><ns5:r><ns5:rPr lang="ja-JP"/><ns5:t>カラム 2</ns5:t></ns5:r></ns5:p></ns0:txBody></ns0:sp><ns0:sp><ns0:nvSpPr><ns0:cNvPr id="22" name="Body3.Right"/><ns0:cNvSpPr><ns1:spLocks xmlns:ns1="http://schemas.openxmlformats.org/drawingml/2006/main" noGrp="1"/></ns0:cNvSpPr><ns0:nvPr><ns0:ph idx="3" type="body"/></ns0:nvPr></ns0:nvSpPr><ns0:spPr><ns2:xfrm xmlns:ns2="http://schemas.openxmlformats.org/drawingml/2006/main"><ns2:off x="7863840" y="1325880"/><ns2:ext cx="3566160" cy="4937760"/></ns2:xfrm></ns0:spPr><ns0:txBody><ns3:bodyPr xmlns:ns3="http://schemas.openxmlformats.org/drawingml/2006/main" wrap="square" anchor="t" anchorCtr="0"/><ns4:lstStyle/><ns4:defPPr algn="l"><ns4:buNone/><ns4:defRPr sz="1400" dirty="0"><ns4:solidFill><ns4:srgbClr val="1E293B"/></ns4:solidFill><ns4:latin typeface="Calibri"/><ns4:ea typeface="Calibri"/></ns4:defRPr></ns4:defPPr><ns4:lvl1pPr algn="l"><ns4:buNone/><ns4:defRPr sz="1400" dirty="0"><ns4:solidFill><ns4:srgbClr val="1E293B"/></ns4:solidFill><ns4:latin typeface="Calibri"/><ns4:ea typeface="Calibri"/></ns4:defRPr></ns4:lvl1pPr><ns4:lvl2pPr algn="l"><ns4:buNone/><ns4:defRPr sz="1400" dirty="0"><ns4:solidFill><ns4:srgbClr val="1E293B"/></ns4:solidFill><ns4:latin typeface="Calibri"/><ns4:ea typeface="Calibri"/></ns4:defRPr></ns4:lvl2pPr><ns4:lvl3pPr algn="l"><ns4:buNone/><ns4:defRPr sz="1400" dirty="0"><ns4:solidFill><ns4:srgbClr val="1E293B"/></ns4:solidFill><ns4:latin typeface="Calibri"/><ns4:ea typeface="Calibri"/></ns4:defRPr></ns4:lvl3pPr><ns4:lvl4pPr algn="l"><ns4:buNone/><ns4:defRPr sz="1400" dirty="0"><ns4:solidFill><ns4:srgbClr val="1E293B"/></ns4:solidFill><ns4:latin typeface="Calibri"/><ns4:ea typeface="Calibri"/></ns4:defRPr></ns4:lvl4pPr><ns4:lvl5pPr algn="l"><ns4:buNone/><ns4:defRPr sz="1400" dirty="0"><ns4:solidFill><ns4:srgbClr val="1E293B"/></ns4:solidFill><ns4:latin typeface="Calibri"/><ns4:ea typeface="Calibri"/></ns4:defRPr></ns4:lvl5pPr><ns4:lvl6pPr algn="l"><ns4:buNone/><ns4:defRPr sz="1400" dirty="0"><ns4:solidFill><ns4:srgbClr val="1E293B"/></ns4:solidFill><ns4:latin typeface="Calibri"/><ns4:ea typeface="Calibri"/></ns4:defRPr></ns4:lvl6pPr><ns4:lvl7pPr algn="l"><ns4:buNone/><ns4:defRPr sz="1400" dirty="0"><ns4:solidFill><ns4:srgbClr val="1E293B"/></ns4:solidFill><ns4:latin typeface="Calibri"/><ns4:ea typeface="Calibri"/></ns4:defRPr></ns4:lvl7pPr><ns4:lvl8pPr algn="l"><ns4:buNone/><ns4:defRPr sz="1400" dirty="0"><ns4:solidFill><ns4:srgbClr val="1E293B"/></ns4:solidFill><ns4:latin typeface="Calibri"/><ns4:ea typeface="Calibri"/></ns4:defRPr></ns4:lvl8pPr><ns4:lvl9pPr algn="l"><ns4:buNone/><ns4:defRPr sz="1400" dirty="0"><ns4:solidFill><ns4:srgbClr val="1E293B"/></ns4:solidFill><ns4:latin typeface="Calibri"/><ns4:ea typeface="Calibri"/></ns4:defRPr></ns4:lvl9pPr></ns4:lstStyle/><ns5:p xmlns:ns5="http://schemas.openxmlformats.org/drawingml/2006/main"><ns5:pPr algn="r"><ns5:buNone/></ns5:pPr><ns5:r><ns5:rPr lang="ja-JP"/><ns5:t>&lt;#&gt;</ns5:t></ns5:r></ns5:p></ns0:txBody></ns0:sp></ns0:spTree></ns0:cSld><ns0:clrMapOvr/></ns0:sldLayout>
+<file path=ppt/slideLayouts/slideLayout13.xml><?xml version="1.0" encoding="utf-8"?>
+<p:sldLayout xmlns:a="http://schemas.openxmlformats.org/drawingml/2006/main" xmlns:p="http://schemas.openxmlformats.org/presentationml/2006/main" xmlns:r="http://schemas.openxmlformats.org/officeDocument/2006/relationships" type="threeObj" preserve="1">
+  <p:cSld name="Column.3Body.Equal">
+    <p:spTree>
+      <p:nvGrpSpPr>
+        <p:cNvPr id="1" name=""/>
+        <p:cNvGrpSpPr/>
+        <p:nvPr/>
+      </p:nvGrpSpPr>
+      <p:grpSpPr>
+        <a:xfrm>
+          <a:off x="0" y="0"/>
+          <a:ext cx="0" cy="0"/>
+          <a:chOff x="0" y="0"/>
+          <a:chExt cx="0" cy="0"/>
+        </a:xfrm>
+      </p:grpSpPr>
+      <p:sp>
+        <p:nvSpPr>
+          <p:cNvPr id="2" name="HeaderBar"/>
+          <p:cNvSpPr>
+            <a:spLocks xmlns:ns1="http://schemas.openxmlformats.org/drawingml/2006/main" noGrp="1" noSelect="0" noRot="1" noMove="1"/>
+          </p:cNvSpPr>
+          <p:nvPr/>
+        </p:nvSpPr>
+        <p:spPr>
+          <a:xfrm xmlns:ns2="http://schemas.openxmlformats.org/drawingml/2006/main">
+            <a:off x="0" y="0"/>
+            <a:ext cx="12192000" cy="1051560"/>
+          </a:xfrm>
+          <a:prstGeom xmlns:ns3="http://schemas.openxmlformats.org/drawingml/2006/main" prst="rect"/>
+          <a:solidFill xmlns:ns4="http://schemas.openxmlformats.org/drawingml/2006/main">
+            <a:srgbClr val="1E2761"/>
+          </a:solidFill>
+          <a:ln xmlns:ns5="http://schemas.openxmlformats.org/drawingml/2006/main">
+            <a:noFill/>
+          </a:ln>
+        </p:spPr>
+      </p:sp>
+      <p:sp>
+        <p:nvSpPr>
+          <p:cNvPr id="3" name="SlideTitle.Header"/>
+          <p:cNvSpPr>
+            <a:spLocks noGrp="1"/>
+          </p:cNvSpPr>
+          <p:nvPr>
+            <p:ph type="body" idx="15"/>
+          </p:nvPr>
+        </p:nvSpPr>
+        <p:spPr>
+          <a:xfrm>
+            <a:off x="731520" y="91440"/>
+            <a:ext cx="9144000" cy="475488"/>
+          </a:xfrm>
+        </p:spPr>
+        <p:txBody>
+          <a:bodyPr wrap="square" anchor="t" anchorCtr="0"/>
+          <a:lstStyle>
+            <a:defPPr>
+              <a:defRPr sz="2800" b="1">
+                <a:solidFill>
+                  <a:srgbClr val="FFFFFF"/>
+                </a:solidFill>
+              </a:defRPr>
+            </a:defPPr>
+          </a:lstStyle>
+          <a:p>
+            <a:r>
+              <a:rPr lang="ja-JP"/>
+              <a:t> </a:t>
+            </a:r>
+          </a:p>
+        </p:txBody>
+      </p:sp>
+      <p:sp>
+        <p:nvSpPr>
+          <p:cNvPr id="4" name="SlideSubtitle.Header"/>
+          <p:cNvSpPr>
+            <a:spLocks noGrp="1"/>
+          </p:cNvSpPr>
+          <p:nvPr>
+            <p:ph type="body" idx="16"/>
+          </p:nvPr>
+        </p:nvSpPr>
+        <p:spPr>
+          <a:xfrm>
+            <a:off x="731520" y="658368"/>
+            <a:ext cx="9144000" cy="274320"/>
+          </a:xfrm>
+        </p:spPr>
+        <p:txBody>
+          <a:bodyPr wrap="square" anchor="t" anchorCtr="0"/>
+          <a:lstStyle>
+            <a:defPPr>
+              <a:defRPr sz="1200">
+                <a:solidFill>
+                  <a:srgbClr val="CADCFC"/>
+                </a:solidFill>
+              </a:defRPr>
+            </a:defPPr>
+          </a:lstStyle>
+          <a:p>
+            <a:r>
+              <a:rPr lang="ja-JP"/>
+              <a:t> </a:t>
+            </a:r>
+          </a:p>
+        </p:txBody>
+      </p:sp>
+      <p:sp>
+        <p:nvSpPr>
+          <p:cNvPr id="5" name="Body1.Left"/>
+          <p:cNvSpPr>
+            <a:spLocks noGrp="1"/>
+          </p:cNvSpPr>
+          <p:nvPr>
+            <p:ph type="body" idx="1"/>
+          </p:nvPr>
+        </p:nvSpPr>
+        <p:spPr>
+          <a:xfrm>
+            <a:off x="731520" y="1325880"/>
+            <a:ext cx="3200400" cy="4937760"/>
+          </a:xfrm>
+        </p:spPr>
+        <p:txBody>
+          <a:bodyPr wrap="square" anchor="t" anchorCtr="0"/>
+          <a:lstStyle/>
+          <a:p>
+            <a:r>
+              <a:rPr lang="ja-JP"/>
+              <a:t> </a:t>
+            </a:r>
+          </a:p>
+        </p:txBody>
+      </p:sp>
+      <p:sp>
+        <p:nvSpPr>
+          <p:cNvPr id="6" name="Body2.Center"/>
+          <p:cNvSpPr>
+            <a:spLocks noGrp="1"/>
+          </p:cNvSpPr>
+          <p:nvPr>
+            <p:ph type="body" idx="2"/>
+          </p:nvPr>
+        </p:nvSpPr>
+        <p:spPr>
+          <a:xfrm>
+            <a:off x="4297680" y="1325880"/>
+            <a:ext cx="3200400" cy="4937760"/>
+          </a:xfrm>
+        </p:spPr>
+        <p:txBody>
+          <a:bodyPr wrap="square" anchor="t" anchorCtr="0"/>
+          <a:lstStyle/>
+          <a:p>
+            <a:r>
+              <a:rPr lang="ja-JP"/>
+              <a:t> </a:t>
+            </a:r>
+          </a:p>
+        </p:txBody>
+      </p:sp>
+      <p:sp>
+        <p:nvSpPr>
+          <p:cNvPr id="7" name="Body3.Right"/>
+          <p:cNvSpPr>
+            <a:spLocks noGrp="1"/>
+          </p:cNvSpPr>
+          <p:nvPr>
+            <p:ph type="body" idx="3"/>
+          </p:nvPr>
+        </p:nvSpPr>
+        <p:spPr>
+          <a:xfrm>
+            <a:off x="7863840" y="1325880"/>
+            <a:ext cx="3566160" cy="4937760"/>
+          </a:xfrm>
+        </p:spPr>
+        <p:txBody>
+          <a:bodyPr wrap="square" anchor="t" anchorCtr="0"/>
+          <a:lstStyle/>
+          <a:p>
+            <a:r>
+              <a:rPr lang="ja-JP"/>
+              <a:t> </a:t>
+            </a:r>
+          </a:p>
+        </p:txBody>
+      </p:sp>
+      <p:sp>
+        <p:nvSpPr>
+          <p:cNvPr id="8" name="SlideNum.Footer"/>
+          <p:cNvSpPr>
+            <a:spLocks noGrp="1"/>
+          </p:cNvSpPr>
+          <p:nvPr>
+            <p:ph type="sldNum" idx="50"/>
+          </p:nvPr>
+        </p:nvSpPr>
+        <p:spPr>
+          <a:xfrm>
+            <a:off x="10972800" y="6446520"/>
+            <a:ext cx="1097280" cy="274320"/>
+          </a:xfrm>
+        </p:spPr>
+        <p:txBody>
+          <a:bodyPr wrap="square" anchor="t" anchorCtr="0"/>
+          <a:lstStyle>
+            <a:defPPr algn="r">
+              <a:defRPr sz="1000">
+                <a:solidFill>
+                  <a:srgbClr val="94A3B8"/>
+                </a:solidFill>
+              </a:defRPr>
+            </a:defPPr>
+          </a:lstStyle>
+          <a:p>
+            <a:r>
+              <a:rPr lang="ja-JP"/>
+              <a:t> </a:t>
+            </a:r>
+          </a:p>
+        </p:txBody>
+      </p:sp>
+    </p:spTree>
+  </p:cSld>
+  <p:clrMapOvr/>
+</p:sldLayout>
 </file>
 
-<file path=ppt/slideLayouts/slideLayout14.xml><?xml version='1.0' encoding='UTF-8' standalone='yes'?>
-<ns0:sldLayout xmlns:ns0="http://schemas.openxmlformats.org/presentationml/2006/main" type="blank" preserve="1"><ns0:cSld name="KPI.1Value.Single"><ns0:spTree><ns0:nvGrpSpPr><ns0:cNvPr id="1" name=""/><ns0:cNvGrpSpPr/><ns0:nvPr/></ns0:nvGrpSpPr><ns0:grpSpPr><ns1:xfrm xmlns:ns1="http://schemas.openxmlformats.org/drawingml/2006/main"><ns1:off x="0" y="0"/><ns1:ext cx="0" cy="0"/><ns1:chOff x="0" y="0"/><ns1:chExt cx="0" cy="0"/></ns1:xfrm></ns0:grpSpPr><ns0:sp><ns0:nvSpPr><ns0:cNvPr id="2" name="HeaderBar"/><ns0:cNvSpPr><ns1:spLocks xmlns:ns1="http://schemas.openxmlformats.org/drawingml/2006/main" noGrp="1" noSelect="0" noRot="1" noMove="1"/></ns0:cNvSpPr><ns0:nvPr/></ns0:nvSpPr><ns0:spPr><ns2:xfrm xmlns:ns2="http://schemas.openxmlformats.org/drawingml/2006/main"><ns2:off x="0" y="0"/><ns2:ext cx="12192000" cy="1051560"/></ns2:xfrm><ns3:prstGeom xmlns:ns3="http://schemas.openxmlformats.org/drawingml/2006/main" prst="rect"/><ns4:solidFill xmlns:ns4="http://schemas.openxmlformats.org/drawingml/2006/main"><ns4:srgbClr val="1E2761"/></ns4:solidFill><ns5:ln xmlns:ns5="http://schemas.openxmlformats.org/drawingml/2006/main"><ns5:noFill/></ns5:ln></ns0:spPr></ns0:sp><ns0:sp><ns0:nvSpPr><ns0:cNvPr id="10" name="SlideTitle.Header"/><ns0:cNvSpPr><ns1:spLocks xmlns:ns1="http://schemas.openxmlformats.org/drawingml/2006/main" noGrp="1"/></ns0:cNvSpPr><ns0:nvPr><ns0:ph idx="15" type="body"/></ns0:nvPr></ns0:nvSpPr><ns0:spPr><ns2:xfrm xmlns:ns2="http://schemas.openxmlformats.org/drawingml/2006/main"><ns2:off x="731520" y="91440"/><ns2:ext cx="9144000" cy="475488"/></ns2:xfrm></ns0:spPr><ns0:txBody><ns3:bodyPr xmlns:ns3="http://schemas.openxmlformats.org/drawingml/2006/main" wrap="square" anchor="t" anchorCtr="0"/><ns4:lstStyle><ns4:defPPr><ns4:defRPr sz="2800" b="1"><ns4:solidFill><ns4:srgbClr val="FFFFFF"/></ns4:solidFill></ns4:defRPr></ns4:defPPr></ns4:lstStyle><ns4:defPPr algn="l"><ns4:buNone/><ns4:defRPr sz="2800" dirty="0" b="1"><ns4:solidFill><ns4:srgbClr val="FFFFFF"/></ns4:solidFill><ns4:latin typeface="Georgia"/><ns4:ea typeface="Georgia"/></ns4:defRPr></ns4:defPPr><ns4:lvl1pPr algn="l"><ns4:buNone/><ns4:defRPr sz="2800" dirty="0" b="1"><ns4:solidFill><ns4:srgbClr val="FFFFFF"/></ns4:solidFill><ns4:latin typeface="Georgia"/><ns4:ea typeface="Georgia"/></ns4:defRPr></ns4:lvl1pPr><ns4:lvl2pPr algn="l"><ns4:buNone/><ns4:defRPr sz="2800" dirty="0" b="1"><ns4:solidFill><ns4:srgbClr val="FFFFFF"/></ns4:solidFill><ns4:latin typeface="Georgia"/><ns4:ea typeface="Georgia"/></ns4:defRPr></ns4:lvl2pPr><ns4:lvl3pPr algn="l"><ns4:buNone/><ns4:defRPr sz="2800" dirty="0" b="1"><ns4:solidFill><ns4:srgbClr val="FFFFFF"/></ns4:solidFill><ns4:latin typeface="Georgia"/><ns4:ea typeface="Georgia"/></ns4:defRPr></ns4:lvl3pPr><ns4:lvl4pPr algn="l"><ns4:buNone/><ns4:defRPr sz="2800" dirty="0" b="1"><ns4:solidFill><ns4:srgbClr val="FFFFFF"/></ns4:solidFill><ns4:latin typeface="Georgia"/><ns4:ea typeface="Georgia"/></ns4:defRPr></ns4:lvl4pPr><ns4:lvl5pPr algn="l"><ns4:buNone/><ns4:defRPr sz="2800" dirty="0" b="1"><ns4:solidFill><ns4:srgbClr val="FFFFFF"/></ns4:solidFill><ns4:latin typeface="Georgia"/><ns4:ea typeface="Georgia"/></ns4:defRPr></ns4:lvl5pPr><ns4:lvl6pPr algn="l"><ns4:buNone/><ns4:defRPr sz="2800" dirty="0" b="1"><ns4:solidFill><ns4:srgbClr val="FFFFFF"/></ns4:solidFill><ns4:latin typeface="Georgia"/><ns4:ea typeface="Georgia"/></ns4:defRPr></ns4:lvl6pPr><ns4:lvl7pPr algn="l"><ns4:buNone/><ns4:defRPr sz="2800" dirty="0" b="1"><ns4:solidFill><ns4:srgbClr val="FFFFFF"/></ns4:solidFill><ns4:latin typeface="Georgia"/><ns4:ea typeface="Georgia"/></ns4:defRPr></ns4:lvl7pPr><ns4:lvl8pPr algn="l"><ns4:buNone/><ns4:defRPr sz="2800" dirty="0" b="1"><ns4:solidFill><ns4:srgbClr val="FFFFFF"/></ns4:solidFill><ns4:latin typeface="Georgia"/><ns4:ea typeface="Georgia"/></ns4:defRPr></ns4:lvl8pPr><ns4:lvl9pPr algn="l"><ns4:buNone/><ns4:defRPr sz="2800" dirty="0" b="1"><ns4:solidFill><ns4:srgbClr val="FFFFFF"/></ns4:solidFill><ns4:latin typeface="Georgia"/><ns4:ea typeface="Georgia"/></ns4:defRPr></ns4:lvl9pPr></ns4:lstStyle/><ns5:p xmlns:ns5="http://schemas.openxmlformats.org/drawingml/2006/main"><ns5:pPr algn="l"><ns5:buNone/></ns5:pPr><ns5:r><ns5:rPr lang="ja-JP"/><ns5:t>サブタイトル</ns5:t></ns5:r></ns5:p></ns0:txBody></ns0:sp><ns0:sp><ns0:nvSpPr><ns0:cNvPr id="5" name="StatPanel"/><ns0:cNvSpPr><ns1:spLocks xmlns:ns1="http://schemas.openxmlformats.org/drawingml/2006/main" noGrp="1" noSelect="0" noRot="1" noMove="1"/></ns0:cNvSpPr><ns0:nvPr/></ns0:nvSpPr><ns0:spPr><ns2:xfrm xmlns:ns2="http://schemas.openxmlformats.org/drawingml/2006/main"><ns2:off x="2743200" y="1645920"/><ns2:ext cx="6675120" cy="4114800"/></ns2:xfrm><ns3:prstGeom xmlns:ns3="http://schemas.openxmlformats.org/drawingml/2006/main" prst="roundRect"><ns3:avLst><ns3:gd name="adj" fmla="val 10000"/></ns3:avLst></ns3:prstGeom><ns4:solidFill xmlns:ns4="http://schemas.openxmlformats.org/drawingml/2006/main"><ns4:srgbClr val="EDF0F7"/></ns4:solidFill><ns5:ln xmlns:ns5="http://schemas.openxmlformats.org/drawingml/2006/main"><ns5:noFill/></ns5:ln></ns0:spPr></ns0:sp><ns0:sp><ns0:nvSpPr><ns0:cNvPr id="6" name="AccentDot"/><ns0:cNvSpPr><ns1:spLocks xmlns:ns1="http://schemas.openxmlformats.org/drawingml/2006/main" noGrp="1"/></ns0:cNvSpPr><ns0:nvPr/></ns0:nvSpPr><ns0:spPr><ns2:xfrm xmlns:ns2="http://schemas.openxmlformats.org/drawingml/2006/main"><ns2:off x="3154680" y="2057400"/><ns2:ext cx="274320" cy="274320"/></ns2:xfrm><ns3:prstGeom xmlns:ns3="http://schemas.openxmlformats.org/drawingml/2006/main" prst="ellipse"/><ns4:solidFill xmlns:ns4="http://schemas.openxmlformats.org/drawingml/2006/main"><ns4:srgbClr val="3B82F6"/></ns4:solidFill><ns5:ln xmlns:ns5="http://schemas.openxmlformats.org/drawingml/2006/main"><ns5:noFill/></ns5:ln></ns0:spPr></ns0:sp><ns0:sp><ns0:nvSpPr><ns0:cNvPr id="20" name="Value.Center"/><ns0:cNvSpPr><ns1:spLocks xmlns:ns1="http://schemas.openxmlformats.org/drawingml/2006/main" noGrp="1"/></ns0:cNvSpPr><ns0:nvPr><ns0:ph idx="1" type="body"/></ns0:nvPr></ns0:nvSpPr><ns0:spPr><ns2:xfrm xmlns:ns2="http://schemas.openxmlformats.org/drawingml/2006/main"><ns2:off x="3200400" y="2011680"/><ns2:ext cx="5943600" cy="1828800"/></ns2:xfrm></ns0:spPr><ns0:txBody><ns3:bodyPr xmlns:ns3="http://schemas.openxmlformats.org/drawingml/2006/main" wrap="square" anchor="t" anchorCtr="0"/><ns4:lstStyle><ns4:defPPr algn="ctr"><ns4:defRPr sz="7200" b="1"><ns4:solidFill><ns4:srgbClr val="1E2761"/></ns4:solidFill></ns4:defRPr></ns4:defPPr></ns4:lstStyle><ns4:defPPr algn="ctr"><ns4:buNone/><ns4:defRPr sz="7200" dirty="0" b="1"><ns4:solidFill><ns4:srgbClr val="1E2761"/></ns4:solidFill><ns4:latin typeface="Georgia"/><ns4:ea typeface="Georgia"/></ns4:defRPr></ns4:defPPr><ns4:lvl1pPr algn="ctr"><ns4:buNone/><ns4:defRPr sz="7200" dirty="0" b="1"><ns4:solidFill><ns4:srgbClr val="1E2761"/></ns4:solidFill><ns4:latin typeface="Georgia"/><ns4:ea typeface="Georgia"/></ns4:defRPr></ns4:lvl1pPr><ns4:lvl2pPr algn="ctr"><ns4:buNone/><ns4:defRPr sz="7200" dirty="0" b="1"><ns4:solidFill><ns4:srgbClr val="1E2761"/></ns4:solidFill><ns4:latin typeface="Georgia"/><ns4:ea typeface="Georgia"/></ns4:defRPr></ns4:lvl2pPr><ns4:lvl3pPr algn="ctr"><ns4:buNone/><ns4:defRPr sz="7200" dirty="0" b="1"><ns4:solidFill><ns4:srgbClr val="1E2761"/></ns4:solidFill><ns4:latin typeface="Georgia"/><ns4:ea typeface="Georgia"/></ns4:defRPr></ns4:lvl3pPr><ns4:lvl4pPr algn="ctr"><ns4:buNone/><ns4:defRPr sz="7200" dirty="0" b="1"><ns4:solidFill><ns4:srgbClr val="1E2761"/></ns4:solidFill><ns4:latin typeface="Georgia"/><ns4:ea typeface="Georgia"/></ns4:defRPr></ns4:lvl4pPr><ns4:lvl5pPr algn="ctr"><ns4:buNone/><ns4:defRPr sz="7200" dirty="0" b="1"><ns4:solidFill><ns4:srgbClr val="1E2761"/></ns4:solidFill><ns4:latin typeface="Georgia"/><ns4:ea typeface="Georgia"/></ns4:defRPr></ns4:lvl5pPr><ns4:lvl6pPr algn="ctr"><ns4:buNone/><ns4:defRPr sz="7200" dirty="0" b="1"><ns4:solidFill><ns4:srgbClr val="1E2761"/></ns4:solidFill><ns4:latin typeface="Georgia"/><ns4:ea typeface="Georgia"/></ns4:defRPr></ns4:lvl6pPr><ns4:lvl7pPr algn="ctr"><ns4:buNone/><ns4:defRPr sz="7200" dirty="0" b="1"><ns4:solidFill><ns4:srgbClr val="1E2761"/></ns4:solidFill><ns4:latin typeface="Georgia"/><ns4:ea typeface="Georgia"/></ns4:defRPr></ns4:lvl7pPr><ns4:lvl8pPr algn="ctr"><ns4:buNone/><ns4:defRPr sz="7200" dirty="0" b="1"><ns4:solidFill><ns4:srgbClr val="1E2761"/></ns4:solidFill><ns4:latin typeface="Georgia"/><ns4:ea typeface="Georgia"/></ns4:defRPr></ns4:lvl8pPr><ns4:lvl9pPr algn="ctr"><ns4:buNone/><ns4:defRPr sz="7200" dirty="0" b="1"><ns4:solidFill><ns4:srgbClr val="1E2761"/></ns4:solidFill><ns4:latin typeface="Georgia"/><ns4:ea typeface="Georgia"/></ns4:defRPr></ns4:lvl9pPr></ns4:lstStyle/><ns5:p xmlns:ns5="http://schemas.openxmlformats.org/drawingml/2006/main"><ns5:pPr algn="ctr"><ns5:buNone/></ns5:pPr><ns5:r><ns5:rPr lang="ja-JP"/><ns5:t>指標名</ns5:t></ns5:r></ns5:p></ns0:txBody></ns0:sp><ns0:sp><ns0:nvSpPr><ns0:cNvPr id="22" name="ValueDesc.Center"/><ns0:cNvSpPr><ns1:spLocks xmlns:ns1="http://schemas.openxmlformats.org/drawingml/2006/main" noGrp="1"/></ns0:cNvSpPr><ns0:nvPr><ns0:ph idx="3" type="body"/></ns0:nvPr></ns0:nvSpPr><ns0:spPr><ns2:xfrm xmlns:ns2="http://schemas.openxmlformats.org/drawingml/2006/main"><ns2:off x="3200400" y="4389120"/><ns2:ext cx="5943600" cy="914400"/></ns2:xfrm></ns0:spPr><ns0:txBody><ns3:bodyPr xmlns:ns3="http://schemas.openxmlformats.org/drawingml/2006/main" wrap="square" anchor="t" anchorCtr="0"/><ns4:lstStyle><ns4:defPPr algn="ctr"><ns4:defRPr sz="1300"><ns4:solidFill><ns4:srgbClr val="94A3B8"/></ns4:solidFill></ns4:defRPr></ns4:defPPr></ns4:lstStyle><ns4:defPPr algn="ctr"><ns4:buNone/><ns4:defRPr sz="1300" dirty="0"><ns4:solidFill><ns4:srgbClr val="94A3B8"/></ns4:solidFill><ns4:latin typeface="Calibri"/><ns4:ea typeface="Calibri"/></ns4:defRPr></ns4:defPPr><ns4:lvl1pPr algn="ctr"><ns4:buNone/><ns4:defRPr sz="1300" dirty="0"><ns4:solidFill><ns4:srgbClr val="94A3B8"/></ns4:solidFill><ns4:latin typeface="Calibri"/><ns4:ea typeface="Calibri"/></ns4:defRPr></ns4:lvl1pPr><ns4:lvl2pPr algn="ctr"><ns4:buNone/><ns4:defRPr sz="1300" dirty="0"><ns4:solidFill><ns4:srgbClr val="94A3B8"/></ns4:solidFill><ns4:latin typeface="Calibri"/><ns4:ea typeface="Calibri"/></ns4:defRPr></ns4:lvl2pPr><ns4:lvl3pPr algn="ctr"><ns4:buNone/><ns4:defRPr sz="1300" dirty="0"><ns4:solidFill><ns4:srgbClr val="94A3B8"/></ns4:solidFill><ns4:latin typeface="Calibri"/><ns4:ea typeface="Calibri"/></ns4:defRPr></ns4:lvl3pPr><ns4:lvl4pPr algn="ctr"><ns4:buNone/><ns4:defRPr sz="1300" dirty="0"><ns4:solidFill><ns4:srgbClr val="94A3B8"/></ns4:solidFill><ns4:latin typeface="Calibri"/><ns4:ea typeface="Calibri"/></ns4:defRPr></ns4:lvl4pPr><ns4:lvl5pPr algn="ctr"><ns4:buNone/><ns4:defRPr sz="1300" dirty="0"><ns4:solidFill><ns4:srgbClr val="94A3B8"/></ns4:solidFill><ns4:latin typeface="Calibri"/><ns4:ea typeface="Calibri"/></ns4:defRPr></ns4:lvl5pPr><ns4:lvl6pPr algn="ctr"><ns4:buNone/><ns4:defRPr sz="1300" dirty="0"><ns4:solidFill><ns4:srgbClr val="94A3B8"/></ns4:solidFill><ns4:latin typeface="Calibri"/><ns4:ea typeface="Calibri"/></ns4:defRPr></ns4:lvl6pPr><ns4:lvl7pPr algn="ctr"><ns4:buNone/><ns4:defRPr sz="1300" dirty="0"><ns4:solidFill><ns4:srgbClr val="94A3B8"/></ns4:solidFill><ns4:latin typeface="Calibri"/><ns4:ea typeface="Calibri"/></ns4:defRPr></ns4:lvl7pPr><ns4:lvl8pPr algn="ctr"><ns4:buNone/><ns4:defRPr sz="1300" dirty="0"><ns4:solidFill><ns4:srgbClr val="94A3B8"/></ns4:solidFill><ns4:latin typeface="Calibri"/><ns4:ea typeface="Calibri"/></ns4:defRPr></ns4:lvl8pPr><ns4:lvl9pPr algn="ctr"><ns4:buNone/><ns4:defRPr sz="1300" dirty="0"><ns4:solidFill><ns4:srgbClr val="94A3B8"/></ns4:solidFill><ns4:latin typeface="Calibri"/><ns4:ea typeface="Calibri"/></ns4:defRPr></ns4:lvl9pPr></ns4:lstStyle/><ns5:p xmlns:ns5="http://schemas.openxmlformats.org/drawingml/2006/main"><ns5:pPr algn="r"><ns5:buNone/></ns5:pPr><ns5:r><ns5:rPr lang="ja-JP"/><ns5:t>&lt;#&gt;</ns5:t></ns5:r></ns5:p></ns0:txBody></ns0:sp></ns0:spTree></ns0:cSld><ns0:clrMapOvr/></ns0:sldLayout>
+<file path=ppt/slideLayouts/slideLayout14.xml><?xml version='1.0' encoding='UTF-8' standalone='yes'?><p:sldLayout xmlns:a="http://schemas.openxmlformats.org/drawingml/2006/main" xmlns:p="http://schemas.openxmlformats.org/presentationml/2006/main" xmlns:r="http://schemas.openxmlformats.org/officeDocument/2006/relationships" type="blank" preserve="1"><p:cSld name="KPI.1Value.Single"><p:spTree><p:nvGrpSpPr><p:cNvPr id="1" name=""/><p:cNvGrpSpPr/><p:nvPr/></p:nvGrpSpPr><p:grpSpPr><a:xfrm><a:off x="0" y="0"/><a:ext cx="0" cy="0"/><a:chOff x="0" y="0"/><a:chExt cx="0" cy="0"/></a:xfrm></p:grpSpPr><p:sp><p:nvSpPr><p:cNvPr id="2" name="HeaderBar"/><p:cNvSpPr><a:spLocks xmlns:ns1="http://schemas.openxmlformats.org/drawingml/2006/main" noGrp="1" noSelect="0" noRot="1" noMove="1"/></p:cNvSpPr><p:nvPr/></p:nvSpPr><p:spPr><a:xfrm xmlns:ns2="http://schemas.openxmlformats.org/drawingml/2006/main"><a:off x="0" y="0"/><a:ext cx="12192000" cy="1051560"/></a:xfrm><a:prstGeom xmlns:ns3="http://schemas.openxmlformats.org/drawingml/2006/main" prst="rect"/><a:solidFill xmlns:ns4="http://schemas.openxmlformats.org/drawingml/2006/main"><a:srgbClr val="1E2761"/></a:solidFill><a:ln xmlns:ns5="http://schemas.openxmlformats.org/drawingml/2006/main"><a:noFill/></a:ln></p:spPr></p:sp><p:sp><p:nvSpPr><p:cNvPr id="3" name="StatPanel"/><p:cNvSpPr><a:spLocks xmlns:ns1="http://schemas.openxmlformats.org/drawingml/2006/main" noGrp="1" noSelect="0" noRot="1" noMove="1"/></p:cNvSpPr><p:nvPr/></p:nvSpPr><p:spPr><a:xfrm xmlns:ns2="http://schemas.openxmlformats.org/drawingml/2006/main"><a:off x="2743200" y="1645920"/><a:ext cx="6675120" cy="4114800"/></a:xfrm><a:prstGeom xmlns:ns3="http://schemas.openxmlformats.org/drawingml/2006/main" prst="roundRect"><a:avLst><a:gd name="adj" fmla="val 10000"/></a:avLst></p:prstGeom><a:solidFill xmlns:ns4="http://schemas.openxmlformats.org/drawingml/2006/main"><a:srgbClr val="EDF0F7"/></a:solidFill><a:ln xmlns:ns5="http://schemas.openxmlformats.org/drawingml/2006/main"><a:noFill/></a:ln></p:spPr></p:sp><p:sp><p:nvSpPr><p:cNvPr id="4" name="AccentDot"/><p:cNvSpPr><a:spLocks xmlns:ns1="http://schemas.openxmlformats.org/drawingml/2006/main" noGrp="1"/></p:cNvSpPr><p:nvPr/></p:nvSpPr><p:spPr><a:xfrm xmlns:ns2="http://schemas.openxmlformats.org/drawingml/2006/main"><a:off x="3154680" y="2057400"/><a:ext cx="274320" cy="274320"/></a:xfrm><a:prstGeom xmlns:ns3="http://schemas.openxmlformats.org/drawingml/2006/main" prst="ellipse"/><a:solidFill xmlns:ns4="http://schemas.openxmlformats.org/drawingml/2006/main"><a:srgbClr val="3B82F6"/></a:solidFill><a:ln xmlns:ns5="http://schemas.openxmlformats.org/drawingml/2006/main"><a:noFill/></a:ln></p:spPr></p:sp><p:sp><p:nvSpPr><p:cNvPr id="5" name="SlideTitle.Header"/><p:cNvSpPr><a:spLocks noGrp="1"/></p:cNvSpPr><p:nvPr><p:ph type="body" idx="15"/></p:nvPr></p:nvSpPr><p:spPr><a:xfrm><a:off x="731520" y="91440"/><a:ext cx="9144000" cy="475488"/></a:xfrm></p:spPr><p:txBody><a:bodyPr wrap="square" anchor="t" anchorCtr="0"/><a:lstStyle><a:defPPr><a:defRPr sz="2800" b="1"><a:solidFill><a:srgbClr val="FFFFFF"/></a:solidFill></a:defRPr></a:defPPr></a:lstStyle><a:p><a:r><a:rPr lang="ja-JP"/><a:t> </a:t></a:r></a:p></p:txBody></p:sp><p:sp><p:nvSpPr><p:cNvPr id="6" name="SlideSubtitle.Header"/><p:cNvSpPr><a:spLocks noGrp="1"/></p:cNvSpPr><p:nvPr><p:ph type="body" idx="16"/></p:nvPr></p:nvSpPr><p:spPr><a:xfrm><a:off x="731520" y="658368"/><a:ext cx="9144000" cy="274320"/></a:xfrm></p:spPr><p:txBody><a:bodyPr wrap="square" anchor="t" anchorCtr="0"/><a:lstStyle><a:defPPr><a:defRPr sz="1200"><a:solidFill><a:srgbClr val="CADCFC"/></a:solidFill></a:defRPr></a:defPPr></a:lstStyle><a:p><a:r><a:rPr lang="ja-JP"/><a:t> </a:t></a:r></a:p></p:txBody></p:sp><p:sp><p:nvSpPr><p:cNvPr id="7" name="Value.Center"/><p:cNvSpPr><a:spLocks noGrp="1"/></p:cNvSpPr><p:nvPr><p:ph type="body" idx="1"/></p:nvPr></p:nvSpPr><p:spPr><a:xfrm><a:off x="3200400" y="2011680"/><a:ext cx="5943600" cy="1828800"/></a:xfrm></p:spPr><p:txBody><a:bodyPr wrap="square" anchor="t" anchorCtr="0"/><a:lstStyle><a:defPPr algn="ctr"><a:defRPr sz="7200" b="1"><a:solidFill><a:srgbClr val="1E2761"/></a:solidFill></a:defRPr></a:defPPr></a:lstStyle><a:p><a:r><a:rPr lang="ja-JP"/><a:t> </a:t></a:r></a:p></p:txBody></p:sp><p:sp><p:nvSpPr><p:cNvPr id="8" name="ValueLabel.Center"/><p:cNvSpPr><a:spLocks noGrp="1"/></p:cNvSpPr><p:nvPr><p:ph type="body" idx="2"/></p:nvPr></p:nvSpPr><p:spPr><a:xfrm><a:off x="3200400" y="3840480"/><a:ext cx="5943600" cy="457200"/></a:xfrm></p:spPr><p:txBody><a:bodyPr wrap="square" anchor="t" anchorCtr="0"/><a:lstStyle><a:defPPr algn="ctr"><a:defRPr sz="1800" b="1"></a:defRPr></a:defPPr></a:lstStyle><a:p><a:r><a:rPr lang="ja-JP"/><a:t> </a:t></a:r></a:p></p:txBody></p:sp><p:sp><p:nvSpPr><p:cNvPr id="9" name="ValueDesc.Center"/><p:cNvSpPr><a:spLocks noGrp="1"/></p:cNvSpPr><p:nvPr><p:ph type="body" idx="3"/></p:nvPr></p:nvSpPr><p:spPr><a:xfrm><a:off x="3200400" y="4389120"/><a:ext cx="5943600" cy="914400"/></a:xfrm></p:spPr><p:txBody><a:bodyPr wrap="square" anchor="t" anchorCtr="0"/><a:lstStyle><a:defPPr algn="ctr"><a:defRPr sz="1300"><a:solidFill><a:srgbClr val="94A3B8"/></a:solidFill></a:defRPr></a:defPPr></a:lstStyle><a:p><a:r><a:rPr lang="ja-JP"/><a:t> </a:t></a:r></a:p></p:txBody></p:sp><p:sp><p:nvSpPr><p:cNvPr id="10" name="SlideNum.Footer"/><p:cNvSpPr><a:spLocks noGrp="1"/></p:cNvSpPr><p:nvPr><p:ph type="sldNum" idx="50"/></p:nvPr></p:nvSpPr><p:spPr><a:xfrm><a:off x="10972800" y="6446520"/><a:ext cx="1097280" cy="274320"/></a:xfrm></p:spPr><p:txBody><a:bodyPr wrap="square" anchor="t" anchorCtr="0"/><a:lstStyle><a:defPPr algn="r"><a:defRPr sz="1000"><a:solidFill><a:srgbClr val="94A3B8"/></a:solidFill></a:defRPr></a:defPPr></a:lstStyle><a:p><a:r><a:rPr lang="ja-JP"/><a:t> </a:t></a:r></a:p></p:txBody></p:sp></p:spTree></p:cSld><p:clrMapOvr/></p:sldLayout>
 </file>
 
-<file path=ppt/slideLayouts/slideLayout15.xml><?xml version='1.0' encoding='UTF-8' standalone='yes'?>
-<ns0:sldLayout xmlns:ns0="http://schemas.openxmlformats.org/presentationml/2006/main" type="blank" preserve="1"><ns0:cSld name="KPI.2Value.Equal"><ns0:spTree><ns0:nvGrpSpPr><ns0:cNvPr id="1" name=""/><ns0:cNvGrpSpPr/><ns0:nvPr/></ns0:nvGrpSpPr><ns0:grpSpPr><ns1:xfrm xmlns:ns1="http://schemas.openxmlformats.org/drawingml/2006/main"><ns1:off x="0" y="0"/><ns1:ext cx="0" cy="0"/><ns1:chOff x="0" y="0"/><ns1:chExt cx="0" cy="0"/></ns1:xfrm></ns0:grpSpPr><ns0:sp><ns0:nvSpPr><ns0:cNvPr id="2" name="HeaderBar"/><ns0:cNvSpPr><ns1:spLocks xmlns:ns1="http://schemas.openxmlformats.org/drawingml/2006/main" noGrp="1" noSelect="0" noRot="1" noMove="1"/></ns0:cNvSpPr><ns0:nvPr/></ns0:nvSpPr><ns0:spPr><ns2:xfrm xmlns:ns2="http://schemas.openxmlformats.org/drawingml/2006/main"><ns2:off x="0" y="0"/><ns2:ext cx="12192000" cy="1051560"/></ns2:xfrm><ns3:prstGeom xmlns:ns3="http://schemas.openxmlformats.org/drawingml/2006/main" prst="rect"/><ns4:solidFill xmlns:ns4="http://schemas.openxmlformats.org/drawingml/2006/main"><ns4:srgbClr val="1E2761"/></ns4:solidFill><ns5:ln xmlns:ns5="http://schemas.openxmlformats.org/drawingml/2006/main"><ns5:noFill/></ns5:ln></ns0:spPr></ns0:sp><ns0:sp><ns0:nvSpPr><ns0:cNvPr id="10" name="SlideTitle.Header"/><ns0:cNvSpPr><ns1:spLocks xmlns:ns1="http://schemas.openxmlformats.org/drawingml/2006/main" noGrp="1"/></ns0:cNvSpPr><ns0:nvPr><ns0:ph idx="15" type="body"/></ns0:nvPr></ns0:nvSpPr><ns0:spPr><ns2:xfrm xmlns:ns2="http://schemas.openxmlformats.org/drawingml/2006/main"><ns2:off x="731520" y="91440"/><ns2:ext cx="9144000" cy="475488"/></ns2:xfrm></ns0:spPr><ns0:txBody><ns3:bodyPr xmlns:ns3="http://schemas.openxmlformats.org/drawingml/2006/main" wrap="square" anchor="t" anchorCtr="0"/><ns4:lstStyle><ns4:defPPr><ns4:defRPr sz="2800" b="1"><ns4:solidFill><ns4:srgbClr val="FFFFFF"/></ns4:solidFill></ns4:defRPr></ns4:defPPr></ns4:lstStyle><ns4:defPPr algn="l"><ns4:buNone/><ns4:defRPr sz="2800" dirty="0" b="1"><ns4:solidFill><ns4:srgbClr val="FFFFFF"/></ns4:solidFill><ns4:latin typeface="Georgia"/><ns4:ea typeface="Georgia"/></ns4:defRPr></ns4:defPPr><ns4:lvl1pPr algn="l"><ns4:buNone/><ns4:defRPr sz="2800" dirty="0" b="1"><ns4:solidFill><ns4:srgbClr val="FFFFFF"/></ns4:solidFill><ns4:latin typeface="Georgia"/><ns4:ea typeface="Georgia"/></ns4:defRPr></ns4:lvl1pPr><ns4:lvl2pPr algn="l"><ns4:buNone/><ns4:defRPr sz="2800" dirty="0" b="1"><ns4:solidFill><ns4:srgbClr val="FFFFFF"/></ns4:solidFill><ns4:latin typeface="Georgia"/><ns4:ea typeface="Georgia"/></ns4:defRPr></ns4:lvl2pPr><ns4:lvl3pPr algn="l"><ns4:buNone/><ns4:defRPr sz="2800" dirty="0" b="1"><ns4:solidFill><ns4:srgbClr val="FFFFFF"/></ns4:solidFill><ns4:latin typeface="Georgia"/><ns4:ea typeface="Georgia"/></ns4:defRPr></ns4:lvl3pPr><ns4:lvl4pPr algn="l"><ns4:buNone/><ns4:defRPr sz="2800" dirty="0" b="1"><ns4:solidFill><ns4:srgbClr val="FFFFFF"/></ns4:solidFill><ns4:latin typeface="Georgia"/><ns4:ea typeface="Georgia"/></ns4:defRPr></ns4:lvl4pPr><ns4:lvl5pPr algn="l"><ns4:buNone/><ns4:defRPr sz="2800" dirty="0" b="1"><ns4:solidFill><ns4:srgbClr val="FFFFFF"/></ns4:solidFill><ns4:latin typeface="Georgia"/><ns4:ea typeface="Georgia"/></ns4:defRPr></ns4:lvl5pPr><ns4:lvl6pPr algn="l"><ns4:buNone/><ns4:defRPr sz="2800" dirty="0" b="1"><ns4:solidFill><ns4:srgbClr val="FFFFFF"/></ns4:solidFill><ns4:latin typeface="Georgia"/><ns4:ea typeface="Georgia"/></ns4:defRPr></ns4:lvl6pPr><ns4:lvl7pPr algn="l"><ns4:buNone/><ns4:defRPr sz="2800" dirty="0" b="1"><ns4:solidFill><ns4:srgbClr val="FFFFFF"/></ns4:solidFill><ns4:latin typeface="Georgia"/><ns4:ea typeface="Georgia"/></ns4:defRPr></ns4:lvl7pPr><ns4:lvl8pPr algn="l"><ns4:buNone/><ns4:defRPr sz="2800" dirty="0" b="1"><ns4:solidFill><ns4:srgbClr val="FFFFFF"/></ns4:solidFill><ns4:latin typeface="Georgia"/><ns4:ea typeface="Georgia"/></ns4:defRPr></ns4:lvl8pPr><ns4:lvl9pPr algn="l"><ns4:buNone/><ns4:defRPr sz="2800" dirty="0" b="1"><ns4:solidFill><ns4:srgbClr val="FFFFFF"/></ns4:solidFill><ns4:latin typeface="Georgia"/><ns4:ea typeface="Georgia"/></ns4:defRPr></ns4:lvl9pPr></ns4:lstStyle/><ns5:p xmlns:ns5="http://schemas.openxmlformats.org/drawingml/2006/main"><ns5:pPr algn="l"><ns5:buNone/></ns5:pPr><ns5:r><ns5:rPr lang="ja-JP"/><ns5:t>サブタイトル</ns5:t></ns5:r></ns5:p></ns0:txBody></ns0:sp><ns0:sp><ns0:nvSpPr><ns0:cNvPr id="5" name="Card1"/><ns0:cNvSpPr><ns1:spLocks xmlns:ns1="http://schemas.openxmlformats.org/drawingml/2006/main" noGrp="1" noSelect="0" noRot="1" noMove="1"/></ns0:cNvSpPr><ns0:nvPr/></ns0:nvSpPr><ns0:spPr><ns2:xfrm xmlns:ns2="http://schemas.openxmlformats.org/drawingml/2006/main"><ns2:off x="640080" y="1371600"/><ns2:ext cx="5120640" cy="4754880"/></ns2:xfrm><ns3:prstGeom xmlns:ns3="http://schemas.openxmlformats.org/drawingml/2006/main" prst="roundRect"><ns3:avLst><ns3:gd name="adj" fmla="val 10000"/></ns3:avLst></ns3:prstGeom><ns4:solidFill xmlns:ns4="http://schemas.openxmlformats.org/drawingml/2006/main"><ns4:srgbClr val="EDF0F7"/></ns4:solidFill><ns5:ln xmlns:ns5="http://schemas.openxmlformats.org/drawingml/2006/main"><ns5:noFill/></ns5:ln></ns0:spPr></ns0:sp><ns0:sp><ns0:nvSpPr><ns0:cNvPr id="6" name="Card2"/><ns0:cNvSpPr><ns1:spLocks xmlns:ns1="http://schemas.openxmlformats.org/drawingml/2006/main" noGrp="1" noSelect="0" noRot="1" noMove="1"/></ns0:cNvSpPr><ns0:nvPr/></ns0:nvSpPr><ns0:spPr><ns2:xfrm xmlns:ns2="http://schemas.openxmlformats.org/drawingml/2006/main"><ns2:off x="6126480" y="1371600"/><ns2:ext cx="5303520" cy="4754880"/></ns2:xfrm><ns3:prstGeom xmlns:ns3="http://schemas.openxmlformats.org/drawingml/2006/main" prst="roundRect"><ns3:avLst><ns3:gd name="adj" fmla="val 10000"/></ns3:avLst></ns3:prstGeom><ns4:solidFill xmlns:ns4="http://schemas.openxmlformats.org/drawingml/2006/main"><ns4:srgbClr val="EDF0F7"/></ns4:solidFill><ns5:ln xmlns:ns5="http://schemas.openxmlformats.org/drawingml/2006/main"><ns5:noFill/></ns5:ln></ns0:spPr></ns0:sp><ns0:sp><ns0:nvSpPr><ns0:cNvPr id="7" name="Accent1"/><ns0:cNvSpPr><ns1:spLocks xmlns:ns1="http://schemas.openxmlformats.org/drawingml/2006/main" noGrp="1" noSelect="0" noRot="1" noMove="1"/></ns0:cNvSpPr><ns0:nvPr/></ns0:nvSpPr><ns0:spPr><ns2:xfrm xmlns:ns2="http://schemas.openxmlformats.org/drawingml/2006/main"><ns2:off x="640080" y="1371600"/><ns2:ext cx="5120640" cy="73152"/></ns2:xfrm><ns3:prstGeom xmlns:ns3="http://schemas.openxmlformats.org/drawingml/2006/main" prst="rect"/><ns4:solidFill xmlns:ns4="http://schemas.openxmlformats.org/drawingml/2006/main"><ns4:srgbClr val="3B82F6"/></ns4:solidFill><ns5:ln xmlns:ns5="http://schemas.openxmlformats.org/drawingml/2006/main"><ns5:noFill/></ns5:ln></ns0:spPr></ns0:sp><ns0:sp><ns0:nvSpPr><ns0:cNvPr id="8" name="Accent2"/><ns0:cNvSpPr><ns1:spLocks xmlns:ns1="http://schemas.openxmlformats.org/drawingml/2006/main" noGrp="1" noSelect="0" noRot="1" noMove="1"/></ns0:cNvSpPr><ns0:nvPr/></ns0:nvSpPr><ns0:spPr><ns2:xfrm xmlns:ns2="http://schemas.openxmlformats.org/drawingml/2006/main"><ns2:off x="6126480" y="1371600"/><ns2:ext cx="5303520" cy="73152"/></ns2:xfrm><ns3:prstGeom xmlns:ns3="http://schemas.openxmlformats.org/drawingml/2006/main" prst="rect"/><ns4:solidFill xmlns:ns4="http://schemas.openxmlformats.org/drawingml/2006/main"><ns4:srgbClr val="06B6D4"/></ns4:solidFill><ns5:ln xmlns:ns5="http://schemas.openxmlformats.org/drawingml/2006/main"><ns5:noFill/></ns5:ln></ns0:spPr></ns0:sp><ns0:sp><ns0:nvSpPr><ns0:cNvPr id="20" name="Value1.Left"/><ns0:cNvSpPr><ns1:spLocks xmlns:ns1="http://schemas.openxmlformats.org/drawingml/2006/main" noGrp="1"/></ns0:cNvSpPr><ns0:nvPr><ns0:ph idx="1" type="body"/></ns0:nvPr></ns0:nvSpPr><ns0:spPr><ns2:xfrm xmlns:ns2="http://schemas.openxmlformats.org/drawingml/2006/main"><ns2:off x="1097280" y="1828800"/><ns2:ext cx="4206240" cy="1645920"/></ns2:xfrm></ns0:spPr><ns0:txBody><ns3:bodyPr xmlns:ns3="http://schemas.openxmlformats.org/drawingml/2006/main" wrap="square" anchor="t" anchorCtr="0"/><ns4:lstStyle><ns4:defPPr algn="ctr"><ns4:defRPr sz="6000" b="1"><ns4:solidFill><ns4:srgbClr val="1E2761"/></ns4:solidFill></ns4:defRPr></ns4:defPPr></ns4:lstStyle><ns4:defPPr algn="ctr"><ns4:buNone/><ns4:defRPr sz="6000" dirty="0" b="1"><ns4:solidFill><ns4:srgbClr val="1E2761"/></ns4:solidFill><ns4:latin typeface="Georgia"/><ns4:ea typeface="Georgia"/></ns4:defRPr></ns4:defPPr><ns4:lvl1pPr algn="ctr"><ns4:buNone/><ns4:defRPr sz="6000" dirty="0" b="1"><ns4:solidFill><ns4:srgbClr val="1E2761"/></ns4:solidFill><ns4:latin typeface="Georgia"/><ns4:ea typeface="Georgia"/></ns4:defRPr></ns4:lvl1pPr><ns4:lvl2pPr algn="ctr"><ns4:buNone/><ns4:defRPr sz="6000" dirty="0" b="1"><ns4:solidFill><ns4:srgbClr val="1E2761"/></ns4:solidFill><ns4:latin typeface="Georgia"/><ns4:ea typeface="Georgia"/></ns4:defRPr></ns4:lvl2pPr><ns4:lvl3pPr algn="ctr"><ns4:buNone/><ns4:defRPr sz="6000" dirty="0" b="1"><ns4:solidFill><ns4:srgbClr val="1E2761"/></ns4:solidFill><ns4:latin typeface="Georgia"/><ns4:ea typeface="Georgia"/></ns4:defRPr></ns4:lvl3pPr><ns4:lvl4pPr algn="ctr"><ns4:buNone/><ns4:defRPr sz="6000" dirty="0" b="1"><ns4:solidFill><ns4:srgbClr val="1E2761"/></ns4:solidFill><ns4:latin typeface="Georgia"/><ns4:ea typeface="Georgia"/></ns4:defRPr></ns4:lvl4pPr><ns4:lvl5pPr algn="ctr"><ns4:buNone/><ns4:defRPr sz="6000" dirty="0" b="1"><ns4:solidFill><ns4:srgbClr val="1E2761"/></ns4:solidFill><ns4:latin typeface="Georgia"/><ns4:ea typeface="Georgia"/></ns4:defRPr></ns4:lvl5pPr><ns4:lvl6pPr algn="ctr"><ns4:buNone/><ns4:defRPr sz="6000" dirty="0" b="1"><ns4:solidFill><ns4:srgbClr val="1E2761"/></ns4:solidFill><ns4:latin typeface="Georgia"/><ns4:ea typeface="Georgia"/></ns4:defRPr></ns4:lvl6pPr><ns4:lvl7pPr algn="ctr"><ns4:buNone/><ns4:defRPr sz="6000" dirty="0" b="1"><ns4:solidFill><ns4:srgbClr val="1E2761"/></ns4:solidFill><ns4:latin typeface="Georgia"/><ns4:ea typeface="Georgia"/></ns4:defRPr></ns4:lvl7pPr><ns4:lvl8pPr algn="ctr"><ns4:buNone/><ns4:defRPr sz="6000" dirty="0" b="1"><ns4:solidFill><ns4:srgbClr val="1E2761"/></ns4:solidFill><ns4:latin typeface="Georgia"/><ns4:ea typeface="Georgia"/></ns4:defRPr></ns4:lvl8pPr><ns4:lvl9pPr algn="ctr"><ns4:buNone/><ns4:defRPr sz="6000" dirty="0" b="1"><ns4:solidFill><ns4:srgbClr val="1E2761"/></ns4:solidFill><ns4:latin typeface="Georgia"/><ns4:ea typeface="Georgia"/></ns4:defRPr></ns4:lvl9pPr></ns4:lstStyle/><ns5:p xmlns:ns5="http://schemas.openxmlformats.org/drawingml/2006/main"><ns5:pPr algn="ctr"><ns5:buNone/></ns5:pPr><ns5:r><ns5:rPr lang="ja-JP"/><ns5:t>指標名
-説明テキスト</ns5:t></ns5:r></ns5:p></ns0:txBody></ns0:sp><ns0:sp><ns0:nvSpPr><ns0:cNvPr id="22" name="Value2.Right"/><ns0:cNvSpPr><ns1:spLocks xmlns:ns1="http://schemas.openxmlformats.org/drawingml/2006/main" noGrp="1"/></ns0:cNvSpPr><ns0:nvPr><ns0:ph idx="3" type="body"/></ns0:nvPr></ns0:nvSpPr><ns0:spPr><ns2:xfrm xmlns:ns2="http://schemas.openxmlformats.org/drawingml/2006/main"><ns2:off x="6583680" y="1828800"/><ns2:ext cx="4389120" cy="1645920"/></ns2:xfrm></ns0:spPr><ns0:txBody><ns3:bodyPr xmlns:ns3="http://schemas.openxmlformats.org/drawingml/2006/main" wrap="square" anchor="t" anchorCtr="0"/><ns4:lstStyle><ns4:defPPr algn="ctr"><ns4:defRPr sz="6000" b="1"><ns4:solidFill><ns4:srgbClr val="1E2761"/></ns4:solidFill></ns4:defRPr></ns4:defPPr></ns4:lstStyle><ns4:defPPr algn="ctr"><ns4:buNone/><ns4:defRPr sz="6000" dirty="0" b="1"><ns4:solidFill><ns4:srgbClr val="1E2761"/></ns4:solidFill><ns4:latin typeface="Georgia"/><ns4:ea typeface="Georgia"/></ns4:defRPr></ns4:defPPr><ns4:lvl1pPr algn="ctr"><ns4:buNone/><ns4:defRPr sz="6000" dirty="0" b="1"><ns4:solidFill><ns4:srgbClr val="1E2761"/></ns4:solidFill><ns4:latin typeface="Georgia"/><ns4:ea typeface="Georgia"/></ns4:defRPr></ns4:lvl1pPr><ns4:lvl2pPr algn="ctr"><ns4:buNone/><ns4:defRPr sz="6000" dirty="0" b="1"><ns4:solidFill><ns4:srgbClr val="1E2761"/></ns4:solidFill><ns4:latin typeface="Georgia"/><ns4:ea typeface="Georgia"/></ns4:defRPr></ns4:lvl2pPr><ns4:lvl3pPr algn="ctr"><ns4:buNone/><ns4:defRPr sz="6000" dirty="0" b="1"><ns4:solidFill><ns4:srgbClr val="1E2761"/></ns4:solidFill><ns4:latin typeface="Georgia"/><ns4:ea typeface="Georgia"/></ns4:defRPr></ns4:lvl3pPr><ns4:lvl4pPr algn="ctr"><ns4:buNone/><ns4:defRPr sz="6000" dirty="0" b="1"><ns4:solidFill><ns4:srgbClr val="1E2761"/></ns4:solidFill><ns4:latin typeface="Georgia"/><ns4:ea typeface="Georgia"/></ns4:defRPr></ns4:lvl4pPr><ns4:lvl5pPr algn="ctr"><ns4:buNone/><ns4:defRPr sz="6000" dirty="0" b="1"><ns4:solidFill><ns4:srgbClr val="1E2761"/></ns4:solidFill><ns4:latin typeface="Georgia"/><ns4:ea typeface="Georgia"/></ns4:defRPr></ns4:lvl5pPr><ns4:lvl6pPr algn="ctr"><ns4:buNone/><ns4:defRPr sz="6000" dirty="0" b="1"><ns4:solidFill><ns4:srgbClr val="1E2761"/></ns4:solidFill><ns4:latin typeface="Georgia"/><ns4:ea typeface="Georgia"/></ns4:defRPr></ns4:lvl6pPr><ns4:lvl7pPr algn="ctr"><ns4:buNone/><ns4:defRPr sz="6000" dirty="0" b="1"><ns4:solidFill><ns4:srgbClr val="1E2761"/></ns4:solidFill><ns4:latin typeface="Georgia"/><ns4:ea typeface="Georgia"/></ns4:defRPr></ns4:lvl7pPr><ns4:lvl8pPr algn="ctr"><ns4:buNone/><ns4:defRPr sz="6000" dirty="0" b="1"><ns4:solidFill><ns4:srgbClr val="1E2761"/></ns4:solidFill><ns4:latin typeface="Georgia"/><ns4:ea typeface="Georgia"/></ns4:defRPr></ns4:lvl8pPr><ns4:lvl9pPr algn="ctr"><ns4:buNone/><ns4:defRPr sz="6000" dirty="0" b="1"><ns4:solidFill><ns4:srgbClr val="1E2761"/></ns4:solidFill><ns4:latin typeface="Georgia"/><ns4:ea typeface="Georgia"/></ns4:defRPr></ns4:lvl9pPr></ns4:lstStyle/><ns5:p xmlns:ns5="http://schemas.openxmlformats.org/drawingml/2006/main"><ns5:pPr algn="ctr"><ns5:buNone/></ns5:pPr><ns5:r><ns5:rPr lang="ja-JP"/><ns5:t>指標名
-説明テキスト</ns5:t></ns5:r></ns5:p></ns0:txBody></ns0:sp><ns0:sp><ns0:nvSpPr><ns0:cNvPr id="30" name="SlideNum.Footer"/><ns0:cNvSpPr><ns1:spLocks xmlns:ns1="http://schemas.openxmlformats.org/drawingml/2006/main" noGrp="1"/></ns0:cNvSpPr><ns0:nvPr><ns0:ph idx="50" type="sldNum"/></ns0:nvPr></ns0:nvSpPr><ns0:spPr><ns2:xfrm xmlns:ns2="http://schemas.openxmlformats.org/drawingml/2006/main"><ns2:off x="10972800" y="6446520"/><ns2:ext cx="1097280" cy="274320"/></ns2:xfrm></ns0:spPr><ns0:txBody><ns3:bodyPr xmlns:ns3="http://schemas.openxmlformats.org/drawingml/2006/main" wrap="square" anchor="t" anchorCtr="0"/><ns4:lstStyle><ns4:defPPr algn="r"><ns4:defRPr sz="1000"><ns4:solidFill><ns4:srgbClr val="94A3B8"/></ns4:solidFill></ns4:defRPr></ns4:defPPr></ns4:lstStyle><ns4:defPPr algn="r"><ns4:buNone/><ns4:defRPr sz="1000" dirty="0"><ns4:solidFill><ns4:srgbClr val="94A3B8"/></ns4:solidFill><ns4:latin typeface="Calibri"/><ns4:ea typeface="Calibri"/></ns4:defRPr></ns4:defPPr><ns4:lvl1pPr algn="r"><ns4:buNone/><ns4:defRPr sz="1000" dirty="0"><ns4:solidFill><ns4:srgbClr val="94A3B8"/></ns4:solidFill><ns4:latin typeface="Calibri"/><ns4:ea typeface="Calibri"/></ns4:defRPr></ns4:lvl1pPr><ns4:lvl2pPr algn="r"><ns4:buNone/><ns4:defRPr sz="1000" dirty="0"><ns4:solidFill><ns4:srgbClr val="94A3B8"/></ns4:solidFill><ns4:latin typeface="Calibri"/><ns4:ea typeface="Calibri"/></ns4:defRPr></ns4:lvl2pPr><ns4:lvl3pPr algn="r"><ns4:buNone/><ns4:defRPr sz="1000" dirty="0"><ns4:solidFill><ns4:srgbClr val="94A3B8"/></ns4:solidFill><ns4:latin typeface="Calibri"/><ns4:ea typeface="Calibri"/></ns4:defRPr></ns4:lvl3pPr><ns4:lvl4pPr algn="r"><ns4:buNone/><ns4:defRPr sz="1000" dirty="0"><ns4:solidFill><ns4:srgbClr val="94A3B8"/></ns4:solidFill><ns4:latin typeface="Calibri"/><ns4:ea typeface="Calibri"/></ns4:defRPr></ns4:lvl4pPr><ns4:lvl5pPr algn="r"><ns4:buNone/><ns4:defRPr sz="1000" dirty="0"><ns4:solidFill><ns4:srgbClr val="94A3B8"/></ns4:solidFill><ns4:latin typeface="Calibri"/><ns4:ea typeface="Calibri"/></ns4:defRPr></ns4:lvl5pPr><ns4:lvl6pPr algn="r"><ns4:buNone/><ns4:defRPr sz="1000" dirty="0"><ns4:solidFill><ns4:srgbClr val="94A3B8"/></ns4:solidFill><ns4:latin typeface="Calibri"/><ns4:ea typeface="Calibri"/></ns4:defRPr></ns4:lvl6pPr><ns4:lvl7pPr algn="r"><ns4:buNone/><ns4:defRPr sz="1000" dirty="0"><ns4:solidFill><ns4:srgbClr val="94A3B8"/></ns4:solidFill><ns4:latin typeface="Calibri"/><ns4:ea typeface="Calibri"/></ns4:defRPr></ns4:lvl7pPr><ns4:lvl8pPr algn="r"><ns4:buNone/><ns4:defRPr sz="1000" dirty="0"><ns4:solidFill><ns4:srgbClr val="94A3B8"/></ns4:solidFill><ns4:latin typeface="Calibri"/><ns4:ea typeface="Calibri"/></ns4:defRPr></ns4:lvl8pPr><ns4:lvl9pPr algn="r"><ns4:buNone/><ns4:defRPr sz="1000" dirty="0"><ns4:solidFill><ns4:srgbClr val="94A3B8"/></ns4:solidFill><ns4:latin typeface="Calibri"/><ns4:ea typeface="Calibri"/></ns4:defRPr></ns4:lvl9pPr></ns4:lstStyle><ns5:p xmlns:ns5="http://schemas.openxmlformats.org/drawingml/2006/main"><ns5:pPr algn="r"><ns5:buNone/></ns5:pPr><ns5:r><ns5:rPr lang="ja-JP"/><ns5:t>&lt;#&gt;</ns5:t></ns5:r></ns5:p></ns0:txBody></ns0:sp></ns0:spTree></ns0:cSld><ns0:clrMapOvr/></ns0:sldLayout>
+<file path=ppt/slideLayouts/slideLayout15.xml><?xml version='1.0' encoding='UTF-8' standalone='yes'?><p:sldLayout xmlns:a="http://schemas.openxmlformats.org/drawingml/2006/main" xmlns:p="http://schemas.openxmlformats.org/presentationml/2006/main" xmlns:r="http://schemas.openxmlformats.org/officeDocument/2006/relationships" type="blank" preserve="1"><p:cSld name="KPI.2Value.Equal"><p:spTree><p:nvGrpSpPr><p:cNvPr id="1" name=""/><p:cNvGrpSpPr/><p:nvPr/></p:nvGrpSpPr><p:grpSpPr><a:xfrm><a:off x="0" y="0"/><a:ext cx="0" cy="0"/><a:chOff x="0" y="0"/><a:chExt cx="0" cy="0"/></a:xfrm></p:grpSpPr><p:sp><p:nvSpPr><p:cNvPr id="2" name="HeaderBar"/><p:cNvSpPr><a:spLocks xmlns:ns1="http://schemas.openxmlformats.org/drawingml/2006/main" noGrp="1" noSelect="0" noRot="1" noMove="1"/></p:cNvSpPr><p:nvPr/></p:nvSpPr><p:spPr><a:xfrm xmlns:ns2="http://schemas.openxmlformats.org/drawingml/2006/main"><a:off x="0" y="0"/><a:ext cx="12192000" cy="1051560"/></a:xfrm><a:prstGeom xmlns:ns3="http://schemas.openxmlformats.org/drawingml/2006/main" prst="rect"/><a:solidFill xmlns:ns4="http://schemas.openxmlformats.org/drawingml/2006/main"><a:srgbClr val="1E2761"/></a:solidFill><a:ln xmlns:ns5="http://schemas.openxmlformats.org/drawingml/2006/main"><a:noFill/></a:ln></p:spPr></p:sp><p:sp><p:nvSpPr><p:cNvPr id="3" name="Card1"/><p:cNvSpPr><a:spLocks xmlns:ns1="http://schemas.openxmlformats.org/drawingml/2006/main" noGrp="1" noSelect="0" noRot="1" noMove="1"/></p:cNvSpPr><p:nvPr/></p:nvSpPr><p:spPr><a:xfrm xmlns:ns2="http://schemas.openxmlformats.org/drawingml/2006/main"><a:off x="640080" y="1371600"/><a:ext cx="5120640" cy="4754880"/></a:xfrm><a:prstGeom xmlns:ns3="http://schemas.openxmlformats.org/drawingml/2006/main" prst="roundRect"><a:avLst><a:gd name="adj" fmla="val 10000"/></a:avLst></p:prstGeom><a:solidFill xmlns:ns4="http://schemas.openxmlformats.org/drawingml/2006/main"><a:srgbClr val="EDF0F7"/></a:solidFill><a:ln xmlns:ns5="http://schemas.openxmlformats.org/drawingml/2006/main"><a:noFill/></a:ln></p:spPr></p:sp><p:sp><p:nvSpPr><p:cNvPr id="4" name="Card2"/><p:cNvSpPr><a:spLocks xmlns:ns1="http://schemas.openxmlformats.org/drawingml/2006/main" noGrp="1" noSelect="0" noRot="1" noMove="1"/></p:cNvSpPr><p:nvPr/></p:nvSpPr><p:spPr><a:xfrm xmlns:ns2="http://schemas.openxmlformats.org/drawingml/2006/main"><a:off x="6126480" y="1371600"/><a:ext cx="5303520" cy="4754880"/></a:xfrm><a:prstGeom xmlns:ns3="http://schemas.openxmlformats.org/drawingml/2006/main" prst="roundRect"><a:avLst><a:gd name="adj" fmla="val 10000"/></a:avLst></p:prstGeom><a:solidFill xmlns:ns4="http://schemas.openxmlformats.org/drawingml/2006/main"><a:srgbClr val="EDF0F7"/></a:solidFill><a:ln xmlns:ns5="http://schemas.openxmlformats.org/drawingml/2006/main"><a:noFill/></a:ln></p:spPr></p:sp><p:sp><p:nvSpPr><p:cNvPr id="5" name="Accent1"/><p:cNvSpPr><a:spLocks xmlns:ns1="http://schemas.openxmlformats.org/drawingml/2006/main" noGrp="1" noSelect="0" noRot="1" noMove="1"/></p:cNvSpPr><p:nvPr/></p:nvSpPr><p:spPr><a:xfrm xmlns:ns2="http://schemas.openxmlformats.org/drawingml/2006/main"><a:off x="640080" y="1371600"/><a:ext cx="5120640" cy="73152"/></a:xfrm><a:prstGeom xmlns:ns3="http://schemas.openxmlformats.org/drawingml/2006/main" prst="rect"/><a:solidFill xmlns:ns4="http://schemas.openxmlformats.org/drawingml/2006/main"><a:srgbClr val="3B82F6"/></a:solidFill><a:ln xmlns:ns5="http://schemas.openxmlformats.org/drawingml/2006/main"><a:noFill/></a:ln></p:spPr></p:sp><p:sp><p:nvSpPr><p:cNvPr id="6" name="Accent2"/><p:cNvSpPr><a:spLocks xmlns:ns1="http://schemas.openxmlformats.org/drawingml/2006/main" noGrp="1" noSelect="0" noRot="1" noMove="1"/></p:cNvSpPr><p:nvPr/></p:nvSpPr><p:spPr><a:xfrm xmlns:ns2="http://schemas.openxmlformats.org/drawingml/2006/main"><a:off x="6126480" y="1371600"/><a:ext cx="5303520" cy="73152"/></a:xfrm><a:prstGeom xmlns:ns3="http://schemas.openxmlformats.org/drawingml/2006/main" prst="rect"/><a:solidFill xmlns:ns4="http://schemas.openxmlformats.org/drawingml/2006/main"><a:srgbClr val="06B6D4"/></a:solidFill><a:ln xmlns:ns5="http://schemas.openxmlformats.org/drawingml/2006/main"><a:noFill/></a:ln></p:spPr></p:sp><p:sp><p:nvSpPr><p:cNvPr id="7" name="SlideTitle.Header"/><p:cNvSpPr><a:spLocks noGrp="1"/></p:cNvSpPr><p:nvPr><p:ph type="body" idx="15"/></p:nvPr></p:nvSpPr><p:spPr><a:xfrm><a:off x="731520" y="91440"/><a:ext cx="9144000" cy="475488"/></a:xfrm></p:spPr><p:txBody><a:bodyPr wrap="square" anchor="t" anchorCtr="0"/><a:lstStyle><a:defPPr><a:defRPr sz="2800" b="1"><a:solidFill><a:srgbClr val="FFFFFF"/></a:solidFill></a:defRPr></a:defPPr></a:lstStyle><a:p><a:r><a:rPr lang="ja-JP"/><a:t> </a:t></a:r></a:p></p:txBody></p:sp><p:sp><p:nvSpPr><p:cNvPr id="8" name="SlideSubtitle.Header"/><p:cNvSpPr><a:spLocks noGrp="1"/></p:cNvSpPr><p:nvPr><p:ph type="body" idx="16"/></p:nvPr></p:nvSpPr><p:spPr><a:xfrm><a:off x="731520" y="658368"/><a:ext cx="9144000" cy="274320"/></a:xfrm></p:spPr><p:txBody><a:bodyPr wrap="square" anchor="t" anchorCtr="0"/><a:lstStyle><a:defPPr><a:defRPr sz="1200"><a:solidFill><a:srgbClr val="CADCFC"/></a:solidFill></a:defRPr></a:defPPr></a:lstStyle><a:p><a:r><a:rPr lang="ja-JP"/><a:t> </a:t></a:r></a:p></p:txBody></p:sp><p:sp><p:nvSpPr><p:cNvPr id="9" name="Value1.Left"/><p:cNvSpPr><a:spLocks noGrp="1"/></p:cNvSpPr><p:nvPr><p:ph type="body" idx="1"/></p:nvPr></p:nvSpPr><p:spPr><a:xfrm><a:off x="1097280" y="1828800"/><a:ext cx="4206240" cy="1645920"/></a:xfrm></p:spPr><p:txBody><a:bodyPr wrap="square" anchor="t" anchorCtr="0"/><a:lstStyle><a:defPPr algn="ctr"><a:defRPr sz="6000" b="1"><a:solidFill><a:srgbClr val="1E2761"/></a:solidFill></a:defRPr></a:defPPr></a:lstStyle><a:p><a:r><a:rPr lang="ja-JP"/><a:t> </a:t></a:r></a:p></p:txBody></p:sp><p:sp><p:nvSpPr><p:cNvPr id="10" name="ValueLabel1.Left"/><p:cNvSpPr><a:spLocks noGrp="1"/></p:cNvSpPr><p:nvPr><p:ph type="body" idx="2"/></p:nvPr></p:nvSpPr><p:spPr><a:xfrm><a:off x="1097280" y="3566160"/><a:ext cx="4206240" cy="2286000"/></a:xfrm></p:spPr><p:txBody><a:bodyPr wrap="square" anchor="t" anchorCtr="0"/><a:lstStyle><a:defPPr algn="ctr"><a:defRPr></a:defRPr></a:defPPr></a:lstStyle><a:p><a:r><a:rPr lang="ja-JP"/><a:t> </a:t></a:r></a:p></p:txBody></p:sp><p:sp><p:nvSpPr><p:cNvPr id="11" name="Value2.Right"/><p:cNvSpPr><a:spLocks noGrp="1"/></p:cNvSpPr><p:nvPr><p:ph type="body" idx="3"/></p:nvPr></p:nvSpPr><p:spPr><a:xfrm><a:off x="6583680" y="1828800"/><a:ext cx="4389120" cy="1645920"/></a:xfrm></p:spPr><p:txBody><a:bodyPr wrap="square" anchor="t" anchorCtr="0"/><a:lstStyle><a:defPPr algn="ctr"><a:defRPr sz="6000" b="1"><a:solidFill><a:srgbClr val="1E2761"/></a:solidFill></a:defRPr></a:defPPr></a:lstStyle><a:p><a:r><a:rPr lang="ja-JP"/><a:t> </a:t></a:r></a:p></p:txBody></p:sp><p:sp><p:nvSpPr><p:cNvPr id="12" name="ValueLabel2.Right"/><p:cNvSpPr><a:spLocks noGrp="1"/></p:cNvSpPr><p:nvPr><p:ph type="body" idx="4"/></p:nvPr></p:nvSpPr><p:spPr><a:xfrm><a:off x="6583680" y="3566160"/><a:ext cx="4389120" cy="2286000"/></a:xfrm></p:spPr><p:txBody><a:bodyPr wrap="square" anchor="t" anchorCtr="0"/><a:lstStyle><a:defPPr algn="ctr"><a:defRPr></a:defRPr></a:defPPr></a:lstStyle><a:p><a:r><a:rPr lang="ja-JP"/><a:t> </a:t></a:r></a:p></p:txBody></p:sp><p:sp><p:nvSpPr><p:cNvPr id="13" name="SlideNum.Footer"/><p:cNvSpPr><a:spLocks noGrp="1"/></p:cNvSpPr><p:nvPr><p:ph type="sldNum" idx="50"/></p:nvPr></p:nvSpPr><p:spPr><a:xfrm><a:off x="10972800" y="6446520"/><a:ext cx="1097280" cy="274320"/></a:xfrm></p:spPr><p:txBody><a:bodyPr wrap="square" anchor="t" anchorCtr="0"/><a:lstStyle><a:defPPr algn="r"><a:defRPr sz="1000"><a:solidFill><a:srgbClr val="94A3B8"/></a:solidFill></a:defRPr></a:defPPr></a:lstStyle><a:p><a:r><a:rPr lang="ja-JP"/><a:t> </a:t></a:r></a:p></p:txBody></p:sp></p:spTree></p:cSld><p:clrMapOvr/></p:sldLayout>
 </file>
 
-<file path=ppt/slideLayouts/slideLayout16.xml><?xml version='1.0' encoding='UTF-8' standalone='yes'?>
-<ns0:sldLayout xmlns:ns0="http://schemas.openxmlformats.org/presentationml/2006/main" type="blank" preserve="1"><ns0:cSld name="KPI.3Value.Equal"><ns0:spTree><ns0:nvGrpSpPr><ns0:cNvPr id="1" name=""/><ns0:cNvGrpSpPr/><ns0:nvPr/></ns0:nvGrpSpPr><ns0:grpSpPr><ns1:xfrm xmlns:ns1="http://schemas.openxmlformats.org/drawingml/2006/main"><ns1:off x="0" y="0"/><ns1:ext cx="0" cy="0"/><ns1:chOff x="0" y="0"/><ns1:chExt cx="0" cy="0"/></ns1:xfrm></ns0:grpSpPr><ns0:sp><ns0:nvSpPr><ns0:cNvPr id="2" name="HeaderBar"/><ns0:cNvSpPr><ns1:spLocks xmlns:ns1="http://schemas.openxmlformats.org/drawingml/2006/main" noGrp="1" noSelect="0" noRot="1" noMove="1"/></ns0:cNvSpPr><ns0:nvPr/></ns0:nvSpPr><ns0:spPr><ns2:xfrm xmlns:ns2="http://schemas.openxmlformats.org/drawingml/2006/main"><ns2:off x="0" y="0"/><ns2:ext cx="12192000" cy="1051560"/></ns2:xfrm><ns3:prstGeom xmlns:ns3="http://schemas.openxmlformats.org/drawingml/2006/main" prst="rect"/><ns4:solidFill xmlns:ns4="http://schemas.openxmlformats.org/drawingml/2006/main"><ns4:srgbClr val="1E2761"/></ns4:solidFill><ns5:ln xmlns:ns5="http://schemas.openxmlformats.org/drawingml/2006/main"><ns5:noFill/></ns5:ln></ns0:spPr></ns0:sp><ns0:sp><ns0:nvSpPr><ns0:cNvPr id="10" name="SlideTitle.Header"/><ns0:cNvSpPr><ns1:spLocks xmlns:ns1="http://schemas.openxmlformats.org/drawingml/2006/main" noGrp="1"/></ns0:cNvSpPr><ns0:nvPr><ns0:ph idx="15" type="body"/></ns0:nvPr></ns0:nvSpPr><ns0:spPr><ns2:xfrm xmlns:ns2="http://schemas.openxmlformats.org/drawingml/2006/main"><ns2:off x="731520" y="91440"/><ns2:ext cx="9144000" cy="475488"/></ns2:xfrm></ns0:spPr><ns0:txBody><ns3:bodyPr xmlns:ns3="http://schemas.openxmlformats.org/drawingml/2006/main" wrap="square" anchor="t" anchorCtr="0"/><ns4:lstStyle><ns4:defPPr><ns4:defRPr sz="2800" b="1"><ns4:solidFill><ns4:srgbClr val="FFFFFF"/></ns4:solidFill></ns4:defRPr></ns4:defPPr></ns4:lstStyle><ns4:defPPr algn="l"><ns4:buNone/><ns4:defRPr sz="2800" dirty="0" b="1"><ns4:solidFill><ns4:srgbClr val="FFFFFF"/></ns4:solidFill><ns4:latin typeface="Georgia"/><ns4:ea typeface="Georgia"/></ns4:defRPr></ns4:defPPr><ns4:lvl1pPr algn="l"><ns4:buNone/><ns4:defRPr sz="2800" dirty="0" b="1"><ns4:solidFill><ns4:srgbClr val="FFFFFF"/></ns4:solidFill><ns4:latin typeface="Georgia"/><ns4:ea typeface="Georgia"/></ns4:defRPr></ns4:lvl1pPr><ns4:lvl2pPr algn="l"><ns4:buNone/><ns4:defRPr sz="2800" dirty="0" b="1"><ns4:solidFill><ns4:srgbClr val="FFFFFF"/></ns4:solidFill><ns4:latin typeface="Georgia"/><ns4:ea typeface="Georgia"/></ns4:defRPr></ns4:lvl2pPr><ns4:lvl3pPr algn="l"><ns4:buNone/><ns4:defRPr sz="2800" dirty="0" b="1"><ns4:solidFill><ns4:srgbClr val="FFFFFF"/></ns4:solidFill><ns4:latin typeface="Georgia"/><ns4:ea typeface="Georgia"/></ns4:defRPr></ns4:lvl3pPr><ns4:lvl4pPr algn="l"><ns4:buNone/><ns4:defRPr sz="2800" dirty="0" b="1"><ns4:solidFill><ns4:srgbClr val="FFFFFF"/></ns4:solidFill><ns4:latin typeface="Georgia"/><ns4:ea typeface="Georgia"/></ns4:defRPr></ns4:lvl4pPr><ns4:lvl5pPr algn="l"><ns4:buNone/><ns4:defRPr sz="2800" dirty="0" b="1"><ns4:solidFill><ns4:srgbClr val="FFFFFF"/></ns4:solidFill><ns4:latin typeface="Georgia"/><ns4:ea typeface="Georgia"/></ns4:defRPr></ns4:lvl5pPr><ns4:lvl6pPr algn="l"><ns4:buNone/><ns4:defRPr sz="2800" dirty="0" b="1"><ns4:solidFill><ns4:srgbClr val="FFFFFF"/></ns4:solidFill><ns4:latin typeface="Georgia"/><ns4:ea typeface="Georgia"/></ns4:defRPr></ns4:lvl6pPr><ns4:lvl7pPr algn="l"><ns4:buNone/><ns4:defRPr sz="2800" dirty="0" b="1"><ns4:solidFill><ns4:srgbClr val="FFFFFF"/></ns4:solidFill><ns4:latin typeface="Georgia"/><ns4:ea typeface="Georgia"/></ns4:defRPr></ns4:lvl7pPr><ns4:lvl8pPr algn="l"><ns4:buNone/><ns4:defRPr sz="2800" dirty="0" b="1"><ns4:solidFill><ns4:srgbClr val="FFFFFF"/></ns4:solidFill><ns4:latin typeface="Georgia"/><ns4:ea typeface="Georgia"/></ns4:defRPr></ns4:lvl8pPr><ns4:lvl9pPr algn="l"><ns4:buNone/><ns4:defRPr sz="2800" dirty="0" b="1"><ns4:solidFill><ns4:srgbClr val="FFFFFF"/></ns4:solidFill><ns4:latin typeface="Georgia"/><ns4:ea typeface="Georgia"/></ns4:defRPr></ns4:lvl9pPr></ns4:lstStyle/><ns5:p xmlns:ns5="http://schemas.openxmlformats.org/drawingml/2006/main"><ns5:pPr algn="l"><ns5:buNone/></ns5:pPr><ns5:r><ns5:rPr lang="ja-JP"/><ns5:t>サブタイトル</ns5:t></ns5:r></ns5:p></ns0:txBody></ns0:sp><ns0:sp><ns0:nvSpPr><ns0:cNvPr id="5" name="Card1"/><ns0:cNvSpPr><ns1:spLocks xmlns:ns1="http://schemas.openxmlformats.org/drawingml/2006/main" noGrp="1" noSelect="0" noRot="1" noMove="1"/></ns0:cNvSpPr><ns0:nvPr/></ns0:nvSpPr><ns0:spPr><ns2:xfrm xmlns:ns2="http://schemas.openxmlformats.org/drawingml/2006/main"><ns2:off x="457200" y="1371600"/><ns2:ext cx="3474720" cy="4754880"/></ns2:xfrm><ns3:prstGeom xmlns:ns3="http://schemas.openxmlformats.org/drawingml/2006/main" prst="roundRect"><ns3:avLst><ns3:gd name="adj" fmla="val 10000"/></ns3:avLst></ns3:prstGeom><ns4:solidFill xmlns:ns4="http://schemas.openxmlformats.org/drawingml/2006/main"><ns4:srgbClr val="EDF0F7"/></ns4:solidFill><ns5:ln xmlns:ns5="http://schemas.openxmlformats.org/drawingml/2006/main"><ns5:noFill/></ns5:ln></ns0:spPr></ns0:sp><ns0:sp><ns0:nvSpPr><ns0:cNvPr id="6" name="Card2"/><ns0:cNvSpPr><ns1:spLocks xmlns:ns1="http://schemas.openxmlformats.org/drawingml/2006/main" noGrp="1" noSelect="0" noRot="1" noMove="1"/></ns0:cNvSpPr><ns0:nvPr/></ns0:nvSpPr><ns0:spPr><ns2:xfrm xmlns:ns2="http://schemas.openxmlformats.org/drawingml/2006/main"><ns2:off x="4206240" y="1371600"/><ns2:ext cx="3657600" cy="4754880"/></ns2:xfrm><ns3:prstGeom xmlns:ns3="http://schemas.openxmlformats.org/drawingml/2006/main" prst="roundRect"><ns3:avLst><ns3:gd name="adj" fmla="val 10000"/></ns3:avLst></ns3:prstGeom><ns4:solidFill xmlns:ns4="http://schemas.openxmlformats.org/drawingml/2006/main"><ns4:srgbClr val="EDF0F7"/></ns4:solidFill><ns5:ln xmlns:ns5="http://schemas.openxmlformats.org/drawingml/2006/main"><ns5:noFill/></ns5:ln></ns0:spPr></ns0:sp><ns0:sp><ns0:nvSpPr><ns0:cNvPr id="7" name="Card3"/><ns0:cNvSpPr><ns1:spLocks xmlns:ns1="http://schemas.openxmlformats.org/drawingml/2006/main" noGrp="1" noSelect="0" noRot="1" noMove="1"/></ns0:cNvSpPr><ns0:nvPr/></ns0:nvSpPr><ns0:spPr><ns2:xfrm xmlns:ns2="http://schemas.openxmlformats.org/drawingml/2006/main"><ns2:off x="8138160" y="1371600"/><ns2:ext cx="3566160" cy="4754880"/></ns2:xfrm><ns3:prstGeom xmlns:ns3="http://schemas.openxmlformats.org/drawingml/2006/main" prst="roundRect"><ns3:avLst><ns3:gd name="adj" fmla="val 10000"/></ns3:avLst></ns3:prstGeom><ns4:solidFill xmlns:ns4="http://schemas.openxmlformats.org/drawingml/2006/main"><ns4:srgbClr val="EDF0F7"/></ns4:solidFill><ns5:ln xmlns:ns5="http://schemas.openxmlformats.org/drawingml/2006/main"><ns5:noFill/></ns5:ln></ns0:spPr></ns0:sp><ns0:sp><ns0:nvSpPr><ns0:cNvPr id="8" name="A1"/><ns0:cNvSpPr><ns1:spLocks xmlns:ns1="http://schemas.openxmlformats.org/drawingml/2006/main" noGrp="1" noSelect="0" noRot="1" noMove="1"/></ns0:cNvSpPr><ns0:nvPr/></ns0:nvSpPr><ns0:spPr><ns2:xfrm xmlns:ns2="http://schemas.openxmlformats.org/drawingml/2006/main"><ns2:off x="457200" y="1371600"/><ns2:ext cx="3474720" cy="54864"/></ns2:xfrm><ns3:prstGeom xmlns:ns3="http://schemas.openxmlformats.org/drawingml/2006/main" prst="rect"/><ns4:solidFill xmlns:ns4="http://schemas.openxmlformats.org/drawingml/2006/main"><ns4:srgbClr val="3B82F6"/></ns4:solidFill><ns5:ln xmlns:ns5="http://schemas.openxmlformats.org/drawingml/2006/main"><ns5:noFill/></ns5:ln></ns0:spPr></ns0:sp><ns0:sp><ns0:nvSpPr><ns0:cNvPr id="9" name="A2"/><ns0:cNvSpPr><ns1:spLocks xmlns:ns1="http://schemas.openxmlformats.org/drawingml/2006/main" noGrp="1" noSelect="0" noRot="1" noMove="1"/></ns0:cNvSpPr><ns0:nvPr/></ns0:nvSpPr><ns0:spPr><ns2:xfrm xmlns:ns2="http://schemas.openxmlformats.org/drawingml/2006/main"><ns2:off x="4206240" y="1371600"/><ns2:ext cx="3657600" cy="54864"/></ns2:xfrm><ns3:prstGeom xmlns:ns3="http://schemas.openxmlformats.org/drawingml/2006/main" prst="rect"/><ns4:solidFill xmlns:ns4="http://schemas.openxmlformats.org/drawingml/2006/main"><ns4:srgbClr val="06B6D4"/></ns4:solidFill><ns5:ln xmlns:ns5="http://schemas.openxmlformats.org/drawingml/2006/main"><ns5:noFill/></ns5:ln></ns0:spPr></ns0:sp><ns0:sp><ns0:nvSpPr><ns0:cNvPr id="10" name="A3"/><ns0:cNvSpPr><ns1:spLocks xmlns:ns1="http://schemas.openxmlformats.org/drawingml/2006/main" noGrp="1" noSelect="0" noRot="1" noMove="1"/></ns0:cNvSpPr><ns0:nvPr/></ns0:nvSpPr><ns0:spPr><ns2:xfrm xmlns:ns2="http://schemas.openxmlformats.org/drawingml/2006/main"><ns2:off x="8138160" y="1371600"/><ns2:ext cx="3566160" cy="54864"/></ns2:xfrm><ns3:prstGeom xmlns:ns3="http://schemas.openxmlformats.org/drawingml/2006/main" prst="rect"/><ns4:solidFill xmlns:ns4="http://schemas.openxmlformats.org/drawingml/2006/main"><ns4:srgbClr val="F59E0B"/></ns4:solidFill><ns5:ln xmlns:ns5="http://schemas.openxmlformats.org/drawingml/2006/main"><ns5:noFill/></ns5:ln></ns0:spPr></ns0:sp><ns0:sp><ns0:nvSpPr><ns0:cNvPr id="20" name="Value1.Left"/><ns0:cNvSpPr><ns1:spLocks xmlns:ns1="http://schemas.openxmlformats.org/drawingml/2006/main" noGrp="1"/></ns0:cNvSpPr><ns0:nvPr><ns0:ph idx="1" type="body"/></ns0:nvPr></ns0:nvSpPr><ns0:spPr><ns2:xfrm xmlns:ns2="http://schemas.openxmlformats.org/drawingml/2006/main"><ns2:off x="731520" y="1828800"/><ns2:ext cx="2926080" cy="1371600"/></ns2:xfrm></ns0:spPr><ns0:txBody><ns3:bodyPr xmlns:ns3="http://schemas.openxmlformats.org/drawingml/2006/main" wrap="square" anchor="t" anchorCtr="0"/><ns4:lstStyle><ns4:defPPr algn="ctr"><ns4:defRPr sz="5200" b="1"><ns4:solidFill><ns4:srgbClr val="1E2761"/></ns4:solidFill></ns4:defRPr></ns4:defPPr></ns4:lstStyle><ns4:defPPr algn="ctr"><ns4:buNone/><ns4:defRPr sz="5200" dirty="0" b="1"><ns4:solidFill><ns4:srgbClr val="1E2761"/></ns4:solidFill><ns4:latin typeface="Georgia"/><ns4:ea typeface="Georgia"/></ns4:defRPr></ns4:defPPr><ns4:lvl1pPr algn="ctr"><ns4:buNone/><ns4:defRPr sz="5200" dirty="0" b="1"><ns4:solidFill><ns4:srgbClr val="1E2761"/></ns4:solidFill><ns4:latin typeface="Georgia"/><ns4:ea typeface="Georgia"/></ns4:defRPr></ns4:lvl1pPr><ns4:lvl2pPr algn="ctr"><ns4:buNone/><ns4:defRPr sz="5200" dirty="0" b="1"><ns4:solidFill><ns4:srgbClr val="1E2761"/></ns4:solidFill><ns4:latin typeface="Georgia"/><ns4:ea typeface="Georgia"/></ns4:defRPr></ns4:lvl2pPr><ns4:lvl3pPr algn="ctr"><ns4:buNone/><ns4:defRPr sz="5200" dirty="0" b="1"><ns4:solidFill><ns4:srgbClr val="1E2761"/></ns4:solidFill><ns4:latin typeface="Georgia"/><ns4:ea typeface="Georgia"/></ns4:defRPr></ns4:lvl3pPr><ns4:lvl4pPr algn="ctr"><ns4:buNone/><ns4:defRPr sz="5200" dirty="0" b="1"><ns4:solidFill><ns4:srgbClr val="1E2761"/></ns4:solidFill><ns4:latin typeface="Georgia"/><ns4:ea typeface="Georgia"/></ns4:defRPr></ns4:lvl4pPr><ns4:lvl5pPr algn="ctr"><ns4:buNone/><ns4:defRPr sz="5200" dirty="0" b="1"><ns4:solidFill><ns4:srgbClr val="1E2761"/></ns4:solidFill><ns4:latin typeface="Georgia"/><ns4:ea typeface="Georgia"/></ns4:defRPr></ns4:lvl5pPr><ns4:lvl6pPr algn="ctr"><ns4:buNone/><ns4:defRPr sz="5200" dirty="0" b="1"><ns4:solidFill><ns4:srgbClr val="1E2761"/></ns4:solidFill><ns4:latin typeface="Georgia"/><ns4:ea typeface="Georgia"/></ns4:defRPr></ns4:lvl6pPr><ns4:lvl7pPr algn="ctr"><ns4:buNone/><ns4:defRPr sz="5200" dirty="0" b="1"><ns4:solidFill><ns4:srgbClr val="1E2761"/></ns4:solidFill><ns4:latin typeface="Georgia"/><ns4:ea typeface="Georgia"/></ns4:defRPr></ns4:lvl7pPr><ns4:lvl8pPr algn="ctr"><ns4:buNone/><ns4:defRPr sz="5200" dirty="0" b="1"><ns4:solidFill><ns4:srgbClr val="1E2761"/></ns4:solidFill><ns4:latin typeface="Georgia"/><ns4:ea typeface="Georgia"/></ns4:defRPr></ns4:lvl8pPr><ns4:lvl9pPr algn="ctr"><ns4:buNone/><ns4:defRPr sz="5200" dirty="0" b="1"><ns4:solidFill><ns4:srgbClr val="1E2761"/></ns4:solidFill><ns4:latin typeface="Georgia"/><ns4:ea typeface="Georgia"/></ns4:defRPr></ns4:lvl9pPr></ns4:lstStyle/><ns5:p xmlns:ns5="http://schemas.openxmlformats.org/drawingml/2006/main"><ns5:pPr algn="ctr"><ns5:buNone/></ns5:pPr><ns5:r><ns5:rPr lang="ja-JP"/><ns5:t>指標名
-説明</ns5:t></ns5:r></ns5:p></ns0:txBody></ns0:sp><ns0:sp><ns0:nvSpPr><ns0:cNvPr id="22" name="Value2.Center"/><ns0:cNvSpPr><ns1:spLocks xmlns:ns1="http://schemas.openxmlformats.org/drawingml/2006/main" noGrp="1"/></ns0:cNvSpPr><ns0:nvPr><ns0:ph idx="3" type="body"/></ns0:nvPr></ns0:nvSpPr><ns0:spPr><ns2:xfrm xmlns:ns2="http://schemas.openxmlformats.org/drawingml/2006/main"><ns2:off x="4480560" y="1828800"/><ns2:ext cx="3108960" cy="1371600"/></ns2:xfrm></ns0:spPr><ns0:txBody><ns3:bodyPr xmlns:ns3="http://schemas.openxmlformats.org/drawingml/2006/main" wrap="square" anchor="t" anchorCtr="0"/><ns4:lstStyle><ns4:defPPr algn="ctr"><ns4:defRPr sz="5200" b="1"><ns4:solidFill><ns4:srgbClr val="1E2761"/></ns4:solidFill></ns4:defRPr></ns4:defPPr></ns4:lstStyle><ns4:defPPr algn="ctr"><ns4:buNone/><ns4:defRPr sz="5200" dirty="0" b="1"><ns4:solidFill><ns4:srgbClr val="1E2761"/></ns4:solidFill><ns4:latin typeface="Georgia"/><ns4:ea typeface="Georgia"/></ns4:defRPr></ns4:defPPr><ns4:lvl1pPr algn="ctr"><ns4:buNone/><ns4:defRPr sz="5200" dirty="0" b="1"><ns4:solidFill><ns4:srgbClr val="1E2761"/></ns4:solidFill><ns4:latin typeface="Georgia"/><ns4:ea typeface="Georgia"/></ns4:defRPr></ns4:lvl1pPr><ns4:lvl2pPr algn="ctr"><ns4:buNone/><ns4:defRPr sz="5200" dirty="0" b="1"><ns4:solidFill><ns4:srgbClr val="1E2761"/></ns4:solidFill><ns4:latin typeface="Georgia"/><ns4:ea typeface="Georgia"/></ns4:defRPr></ns4:lvl2pPr><ns4:lvl3pPr algn="ctr"><ns4:buNone/><ns4:defRPr sz="5200" dirty="0" b="1"><ns4:solidFill><ns4:srgbClr val="1E2761"/></ns4:solidFill><ns4:latin typeface="Georgia"/><ns4:ea typeface="Georgia"/></ns4:defRPr></ns4:lvl3pPr><ns4:lvl4pPr algn="ctr"><ns4:buNone/><ns4:defRPr sz="5200" dirty="0" b="1"><ns4:solidFill><ns4:srgbClr val="1E2761"/></ns4:solidFill><ns4:latin typeface="Georgia"/><ns4:ea typeface="Georgia"/></ns4:defRPr></ns4:lvl4pPr><ns4:lvl5pPr algn="ctr"><ns4:buNone/><ns4:defRPr sz="5200" dirty="0" b="1"><ns4:solidFill><ns4:srgbClr val="1E2761"/></ns4:solidFill><ns4:latin typeface="Georgia"/><ns4:ea typeface="Georgia"/></ns4:defRPr></ns4:lvl5pPr><ns4:lvl6pPr algn="ctr"><ns4:buNone/><ns4:defRPr sz="5200" dirty="0" b="1"><ns4:solidFill><ns4:srgbClr val="1E2761"/></ns4:solidFill><ns4:latin typeface="Georgia"/><ns4:ea typeface="Georgia"/></ns4:defRPr></ns4:lvl6pPr><ns4:lvl7pPr algn="ctr"><ns4:buNone/><ns4:defRPr sz="5200" dirty="0" b="1"><ns4:solidFill><ns4:srgbClr val="1E2761"/></ns4:solidFill><ns4:latin typeface="Georgia"/><ns4:ea typeface="Georgia"/></ns4:defRPr></ns4:lvl7pPr><ns4:lvl8pPr algn="ctr"><ns4:buNone/><ns4:defRPr sz="5200" dirty="0" b="1"><ns4:solidFill><ns4:srgbClr val="1E2761"/></ns4:solidFill><ns4:latin typeface="Georgia"/><ns4:ea typeface="Georgia"/></ns4:defRPr></ns4:lvl8pPr><ns4:lvl9pPr algn="ctr"><ns4:buNone/><ns4:defRPr sz="5200" dirty="0" b="1"><ns4:solidFill><ns4:srgbClr val="1E2761"/></ns4:solidFill><ns4:latin typeface="Georgia"/><ns4:ea typeface="Georgia"/></ns4:defRPr></ns4:lvl9pPr></ns4:lstStyle/><ns5:p xmlns:ns5="http://schemas.openxmlformats.org/drawingml/2006/main"><ns5:pPr algn="ctr"><ns5:buNone/></ns5:pPr><ns5:r><ns5:rPr lang="ja-JP"/><ns5:t>指標名
-説明</ns5:t></ns5:r></ns5:p></ns0:txBody></ns0:sp><ns0:sp><ns0:nvSpPr><ns0:cNvPr id="24" name="Value3.Right"/><ns0:cNvSpPr><ns1:spLocks xmlns:ns1="http://schemas.openxmlformats.org/drawingml/2006/main" noGrp="1"/></ns0:cNvSpPr><ns0:nvPr><ns0:ph idx="5" type="body"/></ns0:nvPr></ns0:nvSpPr><ns0:spPr><ns2:xfrm xmlns:ns2="http://schemas.openxmlformats.org/drawingml/2006/main"><ns2:off x="8412480" y="1828800"/><ns2:ext cx="3017520" cy="1371600"/></ns2:xfrm></ns0:spPr><ns0:txBody><ns3:bodyPr xmlns:ns3="http://schemas.openxmlformats.org/drawingml/2006/main" wrap="square" anchor="t" anchorCtr="0"/><ns4:lstStyle><ns4:defPPr algn="ctr"><ns4:defRPr sz="5200" b="1"><ns4:solidFill><ns4:srgbClr val="1E2761"/></ns4:solidFill></ns4:defRPr></ns4:defPPr></ns4:lstStyle><ns4:defPPr algn="ctr"><ns4:buNone/><ns4:defRPr sz="5200" dirty="0" b="1"><ns4:solidFill><ns4:srgbClr val="1E2761"/></ns4:solidFill><ns4:latin typeface="Georgia"/><ns4:ea typeface="Georgia"/></ns4:defRPr></ns4:defPPr><ns4:lvl1pPr algn="ctr"><ns4:buNone/><ns4:defRPr sz="5200" dirty="0" b="1"><ns4:solidFill><ns4:srgbClr val="1E2761"/></ns4:solidFill><ns4:latin typeface="Georgia"/><ns4:ea typeface="Georgia"/></ns4:defRPr></ns4:lvl1pPr><ns4:lvl2pPr algn="ctr"><ns4:buNone/><ns4:defRPr sz="5200" dirty="0" b="1"><ns4:solidFill><ns4:srgbClr val="1E2761"/></ns4:solidFill><ns4:latin typeface="Georgia"/><ns4:ea typeface="Georgia"/></ns4:defRPr></ns4:lvl2pPr><ns4:lvl3pPr algn="ctr"><ns4:buNone/><ns4:defRPr sz="5200" dirty="0" b="1"><ns4:solidFill><ns4:srgbClr val="1E2761"/></ns4:solidFill><ns4:latin typeface="Georgia"/><ns4:ea typeface="Georgia"/></ns4:defRPr></ns4:lvl3pPr><ns4:lvl4pPr algn="ctr"><ns4:buNone/><ns4:defRPr sz="5200" dirty="0" b="1"><ns4:solidFill><ns4:srgbClr val="1E2761"/></ns4:solidFill><ns4:latin typeface="Georgia"/><ns4:ea typeface="Georgia"/></ns4:defRPr></ns4:lvl4pPr><ns4:lvl5pPr algn="ctr"><ns4:buNone/><ns4:defRPr sz="5200" dirty="0" b="1"><ns4:solidFill><ns4:srgbClr val="1E2761"/></ns4:solidFill><ns4:latin typeface="Georgia"/><ns4:ea typeface="Georgia"/></ns4:defRPr></ns4:lvl5pPr><ns4:lvl6pPr algn="ctr"><ns4:buNone/><ns4:defRPr sz="5200" dirty="0" b="1"><ns4:solidFill><ns4:srgbClr val="1E2761"/></ns4:solidFill><ns4:latin typeface="Georgia"/><ns4:ea typeface="Georgia"/></ns4:defRPr></ns4:lvl6pPr><ns4:lvl7pPr algn="ctr"><ns4:buNone/><ns4:defRPr sz="5200" dirty="0" b="1"><ns4:solidFill><ns4:srgbClr val="1E2761"/></ns4:solidFill><ns4:latin typeface="Georgia"/><ns4:ea typeface="Georgia"/></ns4:defRPr></ns4:lvl7pPr><ns4:lvl8pPr algn="ctr"><ns4:buNone/><ns4:defRPr sz="5200" dirty="0" b="1"><ns4:solidFill><ns4:srgbClr val="1E2761"/></ns4:solidFill><ns4:latin typeface="Georgia"/><ns4:ea typeface="Georgia"/></ns4:defRPr></ns4:lvl8pPr><ns4:lvl9pPr algn="ctr"><ns4:buNone/><ns4:defRPr sz="5200" dirty="0" b="1"><ns4:solidFill><ns4:srgbClr val="1E2761"/></ns4:solidFill><ns4:latin typeface="Georgia"/><ns4:ea typeface="Georgia"/></ns4:defRPr></ns4:lvl9pPr></ns4:lstStyle/><ns5:p xmlns:ns5="http://schemas.openxmlformats.org/drawingml/2006/main"><ns5:pPr algn="ctr"><ns5:buNone/></ns5:pPr><ns5:r><ns5:rPr lang="ja-JP"/><ns5:t>指標名
-説明</ns5:t></ns5:r></ns5:p></ns0:txBody></ns0:sp><ns0:sp><ns0:nvSpPr><ns0:cNvPr id="31" name="SlideNum.Footer"/><ns0:cNvSpPr><ns1:spLocks xmlns:ns1="http://schemas.openxmlformats.org/drawingml/2006/main" noGrp="1"/></ns0:cNvSpPr><ns0:nvPr><ns0:ph idx="50" type="sldNum"/></ns0:nvPr></ns0:nvSpPr><ns0:spPr><ns2:xfrm xmlns:ns2="http://schemas.openxmlformats.org/drawingml/2006/main"><ns2:off x="10972800" y="6446520"/><ns2:ext cx="1097280" cy="274320"/></ns2:xfrm></ns0:spPr><ns0:txBody><ns3:bodyPr xmlns:ns3="http://schemas.openxmlformats.org/drawingml/2006/main" wrap="square" anchor="t" anchorCtr="0"/><ns4:lstStyle><ns4:defPPr algn="r"><ns4:defRPr sz="1000"><ns4:solidFill><ns4:srgbClr val="94A3B8"/></ns4:solidFill></ns4:defRPr></ns4:defPPr></ns4:lstStyle><ns4:defPPr algn="r"><ns4:buNone/><ns4:defRPr sz="1000" dirty="0"><ns4:solidFill><ns4:srgbClr val="94A3B8"/></ns4:solidFill><ns4:latin typeface="Calibri"/><ns4:ea typeface="Calibri"/></ns4:defRPr></ns4:defPPr><ns4:lvl1pPr algn="r"><ns4:buNone/><ns4:defRPr sz="1000" dirty="0"><ns4:solidFill><ns4:srgbClr val="94A3B8"/></ns4:solidFill><ns4:latin typeface="Calibri"/><ns4:ea typeface="Calibri"/></ns4:defRPr></ns4:lvl1pPr><ns4:lvl2pPr algn="r"><ns4:buNone/><ns4:defRPr sz="1000" dirty="0"><ns4:solidFill><ns4:srgbClr val="94A3B8"/></ns4:solidFill><ns4:latin typeface="Calibri"/><ns4:ea typeface="Calibri"/></ns4:defRPr></ns4:lvl2pPr><ns4:lvl3pPr algn="r"><ns4:buNone/><ns4:defRPr sz="1000" dirty="0"><ns4:solidFill><ns4:srgbClr val="94A3B8"/></ns4:solidFill><ns4:latin typeface="Calibri"/><ns4:ea typeface="Calibri"/></ns4:defRPr></ns4:lvl3pPr><ns4:lvl4pPr algn="r"><ns4:buNone/><ns4:defRPr sz="1000" dirty="0"><ns4:solidFill><ns4:srgbClr val="94A3B8"/></ns4:solidFill><ns4:latin typeface="Calibri"/><ns4:ea typeface="Calibri"/></ns4:defRPr></ns4:lvl4pPr><ns4:lvl5pPr algn="r"><ns4:buNone/><ns4:defRPr sz="1000" dirty="0"><ns4:solidFill><ns4:srgbClr val="94A3B8"/></ns4:solidFill><ns4:latin typeface="Calibri"/><ns4:ea typeface="Calibri"/></ns4:defRPr></ns4:lvl5pPr><ns4:lvl6pPr algn="r"><ns4:buNone/><ns4:defRPr sz="1000" dirty="0"><ns4:solidFill><ns4:srgbClr val="94A3B8"/></ns4:solidFill><ns4:latin typeface="Calibri"/><ns4:ea typeface="Calibri"/></ns4:defRPr></ns4:lvl6pPr><ns4:lvl7pPr algn="r"><ns4:buNone/><ns4:defRPr sz="1000" dirty="0"><ns4:solidFill><ns4:srgbClr val="94A3B8"/></ns4:solidFill><ns4:latin typeface="Calibri"/><ns4:ea typeface="Calibri"/></ns4:defRPr></ns4:lvl7pPr><ns4:lvl8pPr algn="r"><ns4:buNone/><ns4:defRPr sz="1000" dirty="0"><ns4:solidFill><ns4:srgbClr val="94A3B8"/></ns4:solidFill><ns4:latin typeface="Calibri"/><ns4:ea typeface="Calibri"/></ns4:defRPr></ns4:lvl8pPr><ns4:lvl9pPr algn="r"><ns4:buNone/><ns4:defRPr sz="1000" dirty="0"><ns4:solidFill><ns4:srgbClr val="94A3B8"/></ns4:solidFill><ns4:latin typeface="Calibri"/><ns4:ea typeface="Calibri"/></ns4:defRPr></ns4:lvl9pPr></ns4:lstStyle><ns5:p xmlns:ns5="http://schemas.openxmlformats.org/drawingml/2006/main"><ns5:pPr algn="r"><ns5:buNone/></ns5:pPr><ns5:r><ns5:rPr lang="ja-JP"/><ns5:t>&lt;#&gt;</ns5:t></ns5:r></ns5:p></ns0:txBody></ns0:sp></ns0:spTree></ns0:cSld><ns0:clrMapOvr/></ns0:sldLayout>
+<file path=ppt/slideLayouts/slideLayout16.xml><?xml version='1.0' encoding='UTF-8' standalone='yes'?><p:sldLayout xmlns:a="http://schemas.openxmlformats.org/drawingml/2006/main" xmlns:p="http://schemas.openxmlformats.org/presentationml/2006/main" xmlns:r="http://schemas.openxmlformats.org/officeDocument/2006/relationships" type="blank" preserve="1"><p:cSld name="KPI.3Value.Equal"><p:spTree><p:nvGrpSpPr><p:cNvPr id="1" name=""/><p:cNvGrpSpPr/><p:nvPr/></p:nvGrpSpPr><p:grpSpPr><a:xfrm><a:off x="0" y="0"/><a:ext cx="0" cy="0"/><a:chOff x="0" y="0"/><a:chExt cx="0" cy="0"/></a:xfrm></p:grpSpPr><p:sp><p:nvSpPr><p:cNvPr id="2" name="HeaderBar"/><p:cNvSpPr><a:spLocks xmlns:ns1="http://schemas.openxmlformats.org/drawingml/2006/main" noGrp="1" noSelect="0" noRot="1" noMove="1"/></p:cNvSpPr><p:nvPr/></p:nvSpPr><p:spPr><a:xfrm xmlns:ns2="http://schemas.openxmlformats.org/drawingml/2006/main"><a:off x="0" y="0"/><a:ext cx="12192000" cy="1051560"/></a:xfrm><a:prstGeom xmlns:ns3="http://schemas.openxmlformats.org/drawingml/2006/main" prst="rect"/><a:solidFill xmlns:ns4="http://schemas.openxmlformats.org/drawingml/2006/main"><a:srgbClr val="1E2761"/></a:solidFill><a:ln xmlns:ns5="http://schemas.openxmlformats.org/drawingml/2006/main"><a:noFill/></a:ln></p:spPr></p:sp><p:sp><p:nvSpPr><p:cNvPr id="3" name="Card1"/><p:cNvSpPr><a:spLocks xmlns:ns1="http://schemas.openxmlformats.org/drawingml/2006/main" noGrp="1" noSelect="0" noRot="1" noMove="1"/></p:cNvSpPr><p:nvPr/></p:nvSpPr><p:spPr><a:xfrm xmlns:ns2="http://schemas.openxmlformats.org/drawingml/2006/main"><a:off x="457200" y="1371600"/><a:ext cx="3474720" cy="4754880"/></a:xfrm><a:prstGeom xmlns:ns3="http://schemas.openxmlformats.org/drawingml/2006/main" prst="roundRect"><a:avLst><a:gd name="adj" fmla="val 10000"/></a:avLst></p:prstGeom><a:solidFill xmlns:ns4="http://schemas.openxmlformats.org/drawingml/2006/main"><a:srgbClr val="EDF0F7"/></a:solidFill><a:ln xmlns:ns5="http://schemas.openxmlformats.org/drawingml/2006/main"><a:noFill/></a:ln></p:spPr></p:sp><p:sp><p:nvSpPr><p:cNvPr id="4" name="Card2"/><p:cNvSpPr><a:spLocks xmlns:ns1="http://schemas.openxmlformats.org/drawingml/2006/main" noGrp="1" noSelect="0" noRot="1" noMove="1"/></p:cNvSpPr><p:nvPr/></p:nvSpPr><p:spPr><a:xfrm xmlns:ns2="http://schemas.openxmlformats.org/drawingml/2006/main"><a:off x="4206240" y="1371600"/><a:ext cx="3657600" cy="4754880"/></a:xfrm><a:prstGeom xmlns:ns3="http://schemas.openxmlformats.org/drawingml/2006/main" prst="roundRect"><a:avLst><a:gd name="adj" fmla="val 10000"/></a:avLst></p:prstGeom><a:solidFill xmlns:ns4="http://schemas.openxmlformats.org/drawingml/2006/main"><a:srgbClr val="EDF0F7"/></a:solidFill><a:ln xmlns:ns5="http://schemas.openxmlformats.org/drawingml/2006/main"><a:noFill/></a:ln></p:spPr></p:sp><p:sp><p:nvSpPr><p:cNvPr id="5" name="Card3"/><p:cNvSpPr><a:spLocks xmlns:ns1="http://schemas.openxmlformats.org/drawingml/2006/main" noGrp="1" noSelect="0" noRot="1" noMove="1"/></p:cNvSpPr><p:nvPr/></p:nvSpPr><p:spPr><a:xfrm xmlns:ns2="http://schemas.openxmlformats.org/drawingml/2006/main"><a:off x="8138160" y="1371600"/><a:ext cx="3566160" cy="4754880"/></a:xfrm><a:prstGeom xmlns:ns3="http://schemas.openxmlformats.org/drawingml/2006/main" prst="roundRect"><a:avLst><a:gd name="adj" fmla="val 10000"/></a:avLst></p:prstGeom><a:solidFill xmlns:ns4="http://schemas.openxmlformats.org/drawingml/2006/main"><a:srgbClr val="EDF0F7"/></a:solidFill><a:ln xmlns:ns5="http://schemas.openxmlformats.org/drawingml/2006/main"><a:noFill/></a:ln></p:spPr></p:sp><p:sp><p:nvSpPr><p:cNvPr id="6" name="A1"/><p:cNvSpPr><a:spLocks xmlns:ns1="http://schemas.openxmlformats.org/drawingml/2006/main" noGrp="1" noSelect="0" noRot="1" noMove="1"/></p:cNvSpPr><p:nvPr/></p:nvSpPr><p:spPr><a:xfrm xmlns:ns2="http://schemas.openxmlformats.org/drawingml/2006/main"><a:off x="457200" y="1371600"/><a:ext cx="3474720" cy="54864"/></a:xfrm><a:prstGeom xmlns:ns3="http://schemas.openxmlformats.org/drawingml/2006/main" prst="rect"/><a:solidFill xmlns:ns4="http://schemas.openxmlformats.org/drawingml/2006/main"><a:srgbClr val="3B82F6"/></a:solidFill><a:ln xmlns:ns5="http://schemas.openxmlformats.org/drawingml/2006/main"><a:noFill/></a:ln></p:spPr></p:sp><p:sp><p:nvSpPr><p:cNvPr id="7" name="A2"/><p:cNvSpPr><a:spLocks xmlns:ns1="http://schemas.openxmlformats.org/drawingml/2006/main" noGrp="1" noSelect="0" noRot="1" noMove="1"/></p:cNvSpPr><p:nvPr/></p:nvSpPr><p:spPr><a:xfrm xmlns:ns2="http://schemas.openxmlformats.org/drawingml/2006/main"><a:off x="4206240" y="1371600"/><a:ext cx="3657600" cy="54864"/></a:xfrm><a:prstGeom xmlns:ns3="http://schemas.openxmlformats.org/drawingml/2006/main" prst="rect"/><a:solidFill xmlns:ns4="http://schemas.openxmlformats.org/drawingml/2006/main"><a:srgbClr val="06B6D4"/></a:solidFill><a:ln xmlns:ns5="http://schemas.openxmlformats.org/drawingml/2006/main"><a:noFill/></a:ln></p:spPr></p:sp><p:sp><p:nvSpPr><p:cNvPr id="8" name="A3"/><p:cNvSpPr><a:spLocks xmlns:ns1="http://schemas.openxmlformats.org/drawingml/2006/main" noGrp="1" noSelect="0" noRot="1" noMove="1"/></p:cNvSpPr><p:nvPr/></p:nvSpPr><p:spPr><a:xfrm xmlns:ns2="http://schemas.openxmlformats.org/drawingml/2006/main"><a:off x="8138160" y="1371600"/><a:ext cx="3566160" cy="54864"/></a:xfrm><a:prstGeom xmlns:ns3="http://schemas.openxmlformats.org/drawingml/2006/main" prst="rect"/><a:solidFill xmlns:ns4="http://schemas.openxmlformats.org/drawingml/2006/main"><a:srgbClr val="F59E0B"/></a:solidFill><a:ln xmlns:ns5="http://schemas.openxmlformats.org/drawingml/2006/main"><a:noFill/></a:ln></p:spPr></p:sp><p:sp><p:nvSpPr><p:cNvPr id="9" name="SlideTitle.Header"/><p:cNvSpPr><a:spLocks noGrp="1"/></p:cNvSpPr><p:nvPr><p:ph type="body" idx="15"/></p:nvPr></p:nvSpPr><p:spPr><a:xfrm><a:off x="731520" y="91440"/><a:ext cx="9144000" cy="475488"/></a:xfrm></p:spPr><p:txBody><a:bodyPr wrap="square" anchor="t" anchorCtr="0"/><a:lstStyle><a:defPPr><a:defRPr sz="2800" b="1"><a:solidFill><a:srgbClr val="FFFFFF"/></a:solidFill></a:defRPr></a:defPPr></a:lstStyle><a:p><a:r><a:rPr lang="ja-JP"/><a:t> </a:t></a:r></a:p></p:txBody></p:sp><p:sp><p:nvSpPr><p:cNvPr id="10" name="SlideSubtitle.Header"/><p:cNvSpPr><a:spLocks noGrp="1"/></p:cNvSpPr><p:nvPr><p:ph type="body" idx="16"/></p:nvPr></p:nvSpPr><p:spPr><a:xfrm><a:off x="731520" y="658368"/><a:ext cx="9144000" cy="274320"/></a:xfrm></p:spPr><p:txBody><a:bodyPr wrap="square" anchor="t" anchorCtr="0"/><a:lstStyle><a:defPPr><a:defRPr sz="1200"><a:solidFill><a:srgbClr val="CADCFC"/></a:solidFill></a:defRPr></a:defPPr></a:lstStyle><a:p><a:r><a:rPr lang="ja-JP"/><a:t> </a:t></a:r></a:p></p:txBody></p:sp><p:sp><p:nvSpPr><p:cNvPr id="11" name="Value1"/><p:cNvSpPr><a:spLocks noGrp="1"/></p:cNvSpPr><p:nvPr><p:ph type="body" idx="1"/></p:nvPr></p:nvSpPr><p:spPr><a:xfrm><a:off x="731520" y="1828800"/><a:ext cx="2926080" cy="1371600"/></a:xfrm></p:spPr><p:txBody><a:bodyPr wrap="square" anchor="t" anchorCtr="0"/><a:lstStyle><a:defPPr algn="ctr"><a:defRPr sz="5200" b="1"><a:solidFill><a:srgbClr val="1E2761"/></a:solidFill></a:defRPr></a:defPPr></a:lstStyle><a:p><a:r><a:rPr lang="ja-JP"/><a:t> </a:t></a:r></a:p></p:txBody></p:sp><p:sp><p:nvSpPr><p:cNvPr id="12" name="Label1"/><p:cNvSpPr><a:spLocks noGrp="1"/></p:cNvSpPr><p:nvPr><p:ph type="body" idx="2"/></p:nvPr></p:nvSpPr><p:spPr><a:xfrm><a:off x="731520" y="3291840"/><a:ext cx="2926080" cy="2560320"/></a:xfrm></p:spPr><p:txBody><a:bodyPr wrap="square" anchor="t" anchorCtr="0"/><a:lstStyle><a:defPPr algn="ctr"><a:defRPr sz="1300"></a:defRPr></a:defPPr></a:lstStyle><a:p><a:r><a:rPr lang="ja-JP"/><a:t> </a:t></a:r></a:p></p:txBody></p:sp><p:sp><p:nvSpPr><p:cNvPr id="13" name="Value2"/><p:cNvSpPr><a:spLocks noGrp="1"/></p:cNvSpPr><p:nvPr><p:ph type="body" idx="3"/></p:nvPr></p:nvSpPr><p:spPr><a:xfrm><a:off x="4480560" y="1828800"/><a:ext cx="3108960" cy="1371600"/></a:xfrm></p:spPr><p:txBody><a:bodyPr wrap="square" anchor="t" anchorCtr="0"/><a:lstStyle><a:defPPr algn="ctr"><a:defRPr sz="5200" b="1"><a:solidFill><a:srgbClr val="1E2761"/></a:solidFill></a:defRPr></a:defPPr></a:lstStyle><a:p><a:r><a:rPr lang="ja-JP"/><a:t> </a:t></a:r></a:p></p:txBody></p:sp><p:sp><p:nvSpPr><p:cNvPr id="14" name="Label2"/><p:cNvSpPr><a:spLocks noGrp="1"/></p:cNvSpPr><p:nvPr><p:ph type="body" idx="4"/></p:nvPr></p:nvSpPr><p:spPr><a:xfrm><a:off x="4480560" y="3291840"/><a:ext cx="3108960" cy="2560320"/></a:xfrm></p:spPr><p:txBody><a:bodyPr wrap="square" anchor="t" anchorCtr="0"/><a:lstStyle><a:defPPr algn="ctr"><a:defRPr sz="1300"></a:defRPr></a:defPPr></a:lstStyle><a:p><a:r><a:rPr lang="ja-JP"/><a:t> </a:t></a:r></a:p></p:txBody></p:sp><p:sp><p:nvSpPr><p:cNvPr id="15" name="Value3"/><p:cNvSpPr><a:spLocks noGrp="1"/></p:cNvSpPr><p:nvPr><p:ph type="body" idx="5"/></p:nvPr></p:nvSpPr><p:spPr><a:xfrm><a:off x="8412480" y="1828800"/><a:ext cx="3017520" cy="1371600"/></a:xfrm></p:spPr><p:txBody><a:bodyPr wrap="square" anchor="t" anchorCtr="0"/><a:lstStyle><a:defPPr algn="ctr"><a:defRPr sz="5200" b="1"><a:solidFill><a:srgbClr val="1E2761"/></a:solidFill></a:defRPr></a:defPPr></a:lstStyle><a:p><a:r><a:rPr lang="ja-JP"/><a:t> </a:t></a:r></a:p></p:txBody></p:sp><p:sp><p:nvSpPr><p:cNvPr id="16" name="Label3"/><p:cNvSpPr><a:spLocks noGrp="1"/></p:cNvSpPr><p:nvPr><p:ph type="body" idx="6"/></p:nvPr></p:nvSpPr><p:spPr><a:xfrm><a:off x="8412480" y="3291840"/><a:ext cx="3017520" cy="2560320"/></a:xfrm></p:spPr><p:txBody><a:bodyPr wrap="square" anchor="t" anchorCtr="0"/><a:lstStyle><a:defPPr algn="ctr"><a:defRPr sz="1300"></a:defRPr></a:defPPr></a:lstStyle><a:p><a:r><a:rPr lang="ja-JP"/><a:t> </a:t></a:r></a:p></p:txBody></p:sp><p:sp><p:nvSpPr><p:cNvPr id="17" name="SlideNum.Footer"/><p:cNvSpPr><a:spLocks noGrp="1"/></p:cNvSpPr><p:nvPr><p:ph type="sldNum" idx="50"/></p:nvPr></p:nvSpPr><p:spPr><a:xfrm><a:off x="10972800" y="6446520"/><a:ext cx="1097280" cy="274320"/></a:xfrm></p:spPr><p:txBody><a:bodyPr wrap="square" anchor="t" anchorCtr="0"/><a:lstStyle><a:defPPr algn="r"><a:defRPr sz="1000"><a:solidFill><a:srgbClr val="94A3B8"/></a:solidFill></a:defRPr></a:defPPr></a:lstStyle><a:p><a:r><a:rPr lang="ja-JP"/><a:t> </a:t></a:r></a:p></p:txBody></p:sp></p:spTree></p:cSld><p:clrMapOvr/></p:sldLayout>
 </file>
 
-<file path=ppt/slideLayouts/slideLayout17.xml><?xml version='1.0' encoding='UTF-8' standalone='yes'?>
-<ns0:sldLayout xmlns:ns0="http://schemas.openxmlformats.org/presentationml/2006/main" type="blank" preserve="1"><ns0:cSld name="KPI.4Value.Grid"><ns0:spTree><ns0:nvGrpSpPr><ns0:cNvPr id="1" name=""/><ns0:cNvGrpSpPr/><ns0:nvPr/></ns0:nvGrpSpPr><ns0:grpSpPr><ns1:xfrm xmlns:ns1="http://schemas.openxmlformats.org/drawingml/2006/main"><ns1:off x="0" y="0"/><ns1:ext cx="0" cy="0"/><ns1:chOff x="0" y="0"/><ns1:chExt cx="0" cy="0"/></ns1:xfrm></ns0:grpSpPr><ns0:sp><ns0:nvSpPr><ns0:cNvPr id="2" name="HeaderBar"/><ns0:cNvSpPr><ns1:spLocks xmlns:ns1="http://schemas.openxmlformats.org/drawingml/2006/main" noGrp="1" noSelect="0" noRot="1" noMove="1"/></ns0:cNvSpPr><ns0:nvPr/></ns0:nvSpPr><ns0:spPr><ns2:xfrm xmlns:ns2="http://schemas.openxmlformats.org/drawingml/2006/main"><ns2:off x="0" y="0"/><ns2:ext cx="12192000" cy="1051560"/></ns2:xfrm><ns3:prstGeom xmlns:ns3="http://schemas.openxmlformats.org/drawingml/2006/main" prst="rect"/><ns4:solidFill xmlns:ns4="http://schemas.openxmlformats.org/drawingml/2006/main"><ns4:srgbClr val="1E2761"/></ns4:solidFill><ns5:ln xmlns:ns5="http://schemas.openxmlformats.org/drawingml/2006/main"><ns5:noFill/></ns5:ln></ns0:spPr></ns0:sp><ns0:sp><ns0:nvSpPr><ns0:cNvPr id="10" name="SlideTitle.Header"/><ns0:cNvSpPr><ns1:spLocks xmlns:ns1="http://schemas.openxmlformats.org/drawingml/2006/main" noGrp="1"/></ns0:cNvSpPr><ns0:nvPr><ns0:ph idx="15" type="body"/></ns0:nvPr></ns0:nvSpPr><ns0:spPr><ns2:xfrm xmlns:ns2="http://schemas.openxmlformats.org/drawingml/2006/main"><ns2:off x="731520" y="91440"/><ns2:ext cx="9144000" cy="475488"/></ns2:xfrm></ns0:spPr><ns0:txBody><ns3:bodyPr xmlns:ns3="http://schemas.openxmlformats.org/drawingml/2006/main" wrap="square" anchor="t" anchorCtr="0"/><ns4:lstStyle><ns4:defPPr><ns4:defRPr sz="2800" b="1"><ns4:solidFill><ns4:srgbClr val="FFFFFF"/></ns4:solidFill></ns4:defRPr></ns4:defPPr></ns4:lstStyle><ns4:defPPr algn="l"><ns4:buNone/><ns4:defRPr sz="2800" dirty="0" b="1"><ns4:solidFill><ns4:srgbClr val="FFFFFF"/></ns4:solidFill><ns4:latin typeface="Georgia"/><ns4:ea typeface="Georgia"/></ns4:defRPr></ns4:defPPr><ns4:lvl1pPr algn="l"><ns4:buNone/><ns4:defRPr sz="2800" dirty="0" b="1"><ns4:solidFill><ns4:srgbClr val="FFFFFF"/></ns4:solidFill><ns4:latin typeface="Georgia"/><ns4:ea typeface="Georgia"/></ns4:defRPr></ns4:lvl1pPr><ns4:lvl2pPr algn="l"><ns4:buNone/><ns4:defRPr sz="2800" dirty="0" b="1"><ns4:solidFill><ns4:srgbClr val="FFFFFF"/></ns4:solidFill><ns4:latin typeface="Georgia"/><ns4:ea typeface="Georgia"/></ns4:defRPr></ns4:lvl2pPr><ns4:lvl3pPr algn="l"><ns4:buNone/><ns4:defRPr sz="2800" dirty="0" b="1"><ns4:solidFill><ns4:srgbClr val="FFFFFF"/></ns4:solidFill><ns4:latin typeface="Georgia"/><ns4:ea typeface="Georgia"/></ns4:defRPr></ns4:lvl3pPr><ns4:lvl4pPr algn="l"><ns4:buNone/><ns4:defRPr sz="2800" dirty="0" b="1"><ns4:solidFill><ns4:srgbClr val="FFFFFF"/></ns4:solidFill><ns4:latin typeface="Georgia"/><ns4:ea typeface="Georgia"/></ns4:defRPr></ns4:lvl4pPr><ns4:lvl5pPr algn="l"><ns4:buNone/><ns4:defRPr sz="2800" dirty="0" b="1"><ns4:solidFill><ns4:srgbClr val="FFFFFF"/></ns4:solidFill><ns4:latin typeface="Georgia"/><ns4:ea typeface="Georgia"/></ns4:defRPr></ns4:lvl5pPr><ns4:lvl6pPr algn="l"><ns4:buNone/><ns4:defRPr sz="2800" dirty="0" b="1"><ns4:solidFill><ns4:srgbClr val="FFFFFF"/></ns4:solidFill><ns4:latin typeface="Georgia"/><ns4:ea typeface="Georgia"/></ns4:defRPr></ns4:lvl6pPr><ns4:lvl7pPr algn="l"><ns4:buNone/><ns4:defRPr sz="2800" dirty="0" b="1"><ns4:solidFill><ns4:srgbClr val="FFFFFF"/></ns4:solidFill><ns4:latin typeface="Georgia"/><ns4:ea typeface="Georgia"/></ns4:defRPr></ns4:lvl7pPr><ns4:lvl8pPr algn="l"><ns4:buNone/><ns4:defRPr sz="2800" dirty="0" b="1"><ns4:solidFill><ns4:srgbClr val="FFFFFF"/></ns4:solidFill><ns4:latin typeface="Georgia"/><ns4:ea typeface="Georgia"/></ns4:defRPr></ns4:lvl8pPr><ns4:lvl9pPr algn="l"><ns4:buNone/><ns4:defRPr sz="2800" dirty="0" b="1"><ns4:solidFill><ns4:srgbClr val="FFFFFF"/></ns4:solidFill><ns4:latin typeface="Georgia"/><ns4:ea typeface="Georgia"/></ns4:defRPr></ns4:lvl9pPr></ns4:lstStyle/><ns5:p xmlns:ns5="http://schemas.openxmlformats.org/drawingml/2006/main"><ns5:pPr algn="l"><ns5:buNone/></ns5:pPr><ns5:r><ns5:rPr lang="ja-JP"/><ns5:t>サブタイトル</ns5:t></ns5:r></ns5:p></ns0:txBody></ns0:sp><ns0:sp><ns0:nvSpPr><ns0:cNvPr id="5" name="TL"/><ns0:cNvSpPr><ns1:spLocks xmlns:ns1="http://schemas.openxmlformats.org/drawingml/2006/main" noGrp="1" noSelect="0" noRot="1" noMove="1"/></ns0:cNvSpPr><ns0:nvPr/></ns0:nvSpPr><ns0:spPr><ns2:xfrm xmlns:ns2="http://schemas.openxmlformats.org/drawingml/2006/main"><ns2:off x="457200" y="1280160"/><ns2:ext cx="5303520" cy="2286000"/></ns2:xfrm><ns3:prstGeom xmlns:ns3="http://schemas.openxmlformats.org/drawingml/2006/main" prst="roundRect"><ns3:avLst><ns3:gd name="adj" fmla="val 8000"/></ns3:avLst></ns3:prstGeom><ns4:solidFill xmlns:ns4="http://schemas.openxmlformats.org/drawingml/2006/main"><ns4:srgbClr val="EDF0F7"/></ns4:solidFill><ns5:ln xmlns:ns5="http://schemas.openxmlformats.org/drawingml/2006/main"><ns5:noFill/></ns5:ln></ns0:spPr></ns0:sp><ns0:sp><ns0:nvSpPr><ns0:cNvPr id="6" name="TR"/><ns0:cNvSpPr><ns1:spLocks xmlns:ns1="http://schemas.openxmlformats.org/drawingml/2006/main" noGrp="1" noSelect="0" noRot="1" noMove="1"/></ns0:cNvSpPr><ns0:nvPr/></ns0:nvSpPr><ns0:spPr><ns2:xfrm xmlns:ns2="http://schemas.openxmlformats.org/drawingml/2006/main"><ns2:off x="6126480" y="1280160"/><ns2:ext cx="5394960" cy="2286000"/></ns2:xfrm><ns3:prstGeom xmlns:ns3="http://schemas.openxmlformats.org/drawingml/2006/main" prst="roundRect"><ns3:avLst><ns3:gd name="adj" fmla="val 8000"/></ns3:avLst></ns3:prstGeom><ns4:solidFill xmlns:ns4="http://schemas.openxmlformats.org/drawingml/2006/main"><ns4:srgbClr val="EDF0F7"/></ns4:solidFill><ns5:ln xmlns:ns5="http://schemas.openxmlformats.org/drawingml/2006/main"><ns5:noFill/></ns5:ln></ns0:spPr></ns0:sp><ns0:sp><ns0:nvSpPr><ns0:cNvPr id="7" name="BL"/><ns0:cNvSpPr><ns1:spLocks xmlns:ns1="http://schemas.openxmlformats.org/drawingml/2006/main" noGrp="1" noSelect="0" noRot="1" noMove="1"/></ns0:cNvSpPr><ns0:nvPr/></ns0:nvSpPr><ns0:spPr><ns2:xfrm xmlns:ns2="http://schemas.openxmlformats.org/drawingml/2006/main"><ns2:off x="457200" y="3840480"/><ns2:ext cx="5303520" cy="2286000"/></ns2:xfrm><ns3:prstGeom xmlns:ns3="http://schemas.openxmlformats.org/drawingml/2006/main" prst="roundRect"><ns3:avLst><ns3:gd name="adj" fmla="val 8000"/></ns3:avLst></ns3:prstGeom><ns4:solidFill xmlns:ns4="http://schemas.openxmlformats.org/drawingml/2006/main"><ns4:srgbClr val="EDF0F7"/></ns4:solidFill><ns5:ln xmlns:ns5="http://schemas.openxmlformats.org/drawingml/2006/main"><ns5:noFill/></ns5:ln></ns0:spPr></ns0:sp><ns0:sp><ns0:nvSpPr><ns0:cNvPr id="8" name="BR"/><ns0:cNvSpPr><ns1:spLocks xmlns:ns1="http://schemas.openxmlformats.org/drawingml/2006/main" noGrp="1" noSelect="0" noRot="1" noMove="1"/></ns0:cNvSpPr><ns0:nvPr/></ns0:nvSpPr><ns0:spPr><ns2:xfrm xmlns:ns2="http://schemas.openxmlformats.org/drawingml/2006/main"><ns2:off x="6126480" y="3840480"/><ns2:ext cx="5394960" cy="2286000"/></ns2:xfrm><ns3:prstGeom xmlns:ns3="http://schemas.openxmlformats.org/drawingml/2006/main" prst="roundRect"><ns3:avLst><ns3:gd name="adj" fmla="val 8000"/></ns3:avLst></ns3:prstGeom><ns4:solidFill xmlns:ns4="http://schemas.openxmlformats.org/drawingml/2006/main"><ns4:srgbClr val="EDF0F7"/></ns4:solidFill><ns5:ln xmlns:ns5="http://schemas.openxmlformats.org/drawingml/2006/main"><ns5:noFill/></ns5:ln></ns0:spPr></ns0:sp><ns0:sp><ns0:nvSpPr><ns0:cNvPr id="9" name="A1"/><ns0:cNvSpPr><ns1:spLocks xmlns:ns1="http://schemas.openxmlformats.org/drawingml/2006/main" noGrp="1" noSelect="0" noRot="1" noMove="1"/></ns0:cNvSpPr><ns0:nvPr/></ns0:nvSpPr><ns0:spPr><ns2:xfrm xmlns:ns2="http://schemas.openxmlformats.org/drawingml/2006/main"><ns2:off x="457200" y="1280160"/><ns2:ext cx="54864" cy="2286000"/></ns2:xfrm><ns3:prstGeom xmlns:ns3="http://schemas.openxmlformats.org/drawingml/2006/main" prst="rect"/><ns4:solidFill xmlns:ns4="http://schemas.openxmlformats.org/drawingml/2006/main"><ns4:srgbClr val="3B82F6"/></ns4:solidFill><ns5:ln xmlns:ns5="http://schemas.openxmlformats.org/drawingml/2006/main"><ns5:noFill/></ns5:ln></ns0:spPr></ns0:sp><ns0:sp><ns0:nvSpPr><ns0:cNvPr id="10" name="A2"/><ns0:cNvSpPr><ns1:spLocks xmlns:ns1="http://schemas.openxmlformats.org/drawingml/2006/main" noGrp="1" noSelect="0" noRot="1" noMove="1"/></ns0:cNvSpPr><ns0:nvPr/></ns0:nvSpPr><ns0:spPr><ns2:xfrm xmlns:ns2="http://schemas.openxmlformats.org/drawingml/2006/main"><ns2:off x="6126480" y="1280160"/><ns2:ext cx="54864" cy="2286000"/></ns2:xfrm><ns3:prstGeom xmlns:ns3="http://schemas.openxmlformats.org/drawingml/2006/main" prst="rect"/><ns4:solidFill xmlns:ns4="http://schemas.openxmlformats.org/drawingml/2006/main"><ns4:srgbClr val="06B6D4"/></ns4:solidFill><ns5:ln xmlns:ns5="http://schemas.openxmlformats.org/drawingml/2006/main"><ns5:noFill/></ns5:ln></ns0:spPr></ns0:sp><ns0:sp><ns0:nvSpPr><ns0:cNvPr id="11" name="A3"/><ns0:cNvSpPr><ns1:spLocks xmlns:ns1="http://schemas.openxmlformats.org/drawingml/2006/main" noGrp="1" noSelect="0" noRot="1" noMove="1"/></ns0:cNvSpPr><ns0:nvPr/></ns0:nvSpPr><ns0:spPr><ns2:xfrm xmlns:ns2="http://schemas.openxmlformats.org/drawingml/2006/main"><ns2:off x="457200" y="3840480"/><ns2:ext cx="54864" cy="2286000"/></ns2:xfrm><ns3:prstGeom xmlns:ns3="http://schemas.openxmlformats.org/drawingml/2006/main" prst="rect"/><ns4:solidFill xmlns:ns4="http://schemas.openxmlformats.org/drawingml/2006/main"><ns4:srgbClr val="F59E0B"/></ns4:solidFill><ns5:ln xmlns:ns5="http://schemas.openxmlformats.org/drawingml/2006/main"><ns5:noFill/></ns5:ln></ns0:spPr></ns0:sp><ns0:sp><ns0:nvSpPr><ns0:cNvPr id="12" name="A4"/><ns0:cNvSpPr><ns1:spLocks xmlns:ns1="http://schemas.openxmlformats.org/drawingml/2006/main" noGrp="1" noSelect="0" noRot="1" noMove="1"/></ns0:cNvSpPr><ns0:nvPr/></ns0:nvSpPr><ns0:spPr><ns2:xfrm xmlns:ns2="http://schemas.openxmlformats.org/drawingml/2006/main"><ns2:off x="6126480" y="3840480"/><ns2:ext cx="54864" cy="2286000"/></ns2:xfrm><ns3:prstGeom xmlns:ns3="http://schemas.openxmlformats.org/drawingml/2006/main" prst="rect"/><ns4:solidFill xmlns:ns4="http://schemas.openxmlformats.org/drawingml/2006/main"><ns4:srgbClr val="2563EB"/></ns4:solidFill><ns5:ln xmlns:ns5="http://schemas.openxmlformats.org/drawingml/2006/main"><ns5:noFill/></ns5:ln></ns0:spPr></ns0:sp><ns0:sp><ns0:nvSpPr><ns0:cNvPr id="20" name="Value1.TopLeft"/><ns0:cNvSpPr><ns1:spLocks xmlns:ns1="http://schemas.openxmlformats.org/drawingml/2006/main" noGrp="1"/></ns0:cNvSpPr><ns0:nvPr><ns0:ph idx="1" type="body"/></ns0:nvPr></ns0:nvSpPr><ns0:spPr><ns2:xfrm xmlns:ns2="http://schemas.openxmlformats.org/drawingml/2006/main"><ns2:off x="914400" y="1463040"/><ns2:ext cx="4389120" cy="1828800"/></ns2:xfrm></ns0:spPr><ns0:txBody><ns3:bodyPr xmlns:ns3="http://schemas.openxmlformats.org/drawingml/2006/main" wrap="square" anchor="t" anchorCtr="0"/><ns4:lstStyle/><ns4:defPPr algn="l"><ns4:buNone/><ns4:defRPr sz="1400" dirty="0"><ns4:solidFill><ns4:srgbClr val="1E293B"/></ns4:solidFill><ns4:latin typeface="Calibri"/><ns4:ea typeface="Calibri"/></ns4:defRPr></ns4:defPPr><ns4:lvl1pPr algn="l"><ns4:buNone/><ns4:defRPr sz="1400" dirty="0"><ns4:solidFill><ns4:srgbClr val="1E293B"/></ns4:solidFill><ns4:latin typeface="Calibri"/><ns4:ea typeface="Calibri"/></ns4:defRPr></ns4:lvl1pPr><ns4:lvl2pPr algn="l"><ns4:buNone/><ns4:defRPr sz="1400" dirty="0"><ns4:solidFill><ns4:srgbClr val="1E293B"/></ns4:solidFill><ns4:latin typeface="Calibri"/><ns4:ea typeface="Calibri"/></ns4:defRPr></ns4:lvl2pPr><ns4:lvl3pPr algn="l"><ns4:buNone/><ns4:defRPr sz="1400" dirty="0"><ns4:solidFill><ns4:srgbClr val="1E293B"/></ns4:solidFill><ns4:latin typeface="Calibri"/><ns4:ea typeface="Calibri"/></ns4:defRPr></ns4:lvl3pPr><ns4:lvl4pPr algn="l"><ns4:buNone/><ns4:defRPr sz="1400" dirty="0"><ns4:solidFill><ns4:srgbClr val="1E293B"/></ns4:solidFill><ns4:latin typeface="Calibri"/><ns4:ea typeface="Calibri"/></ns4:defRPr></ns4:lvl4pPr><ns4:lvl5pPr algn="l"><ns4:buNone/><ns4:defRPr sz="1400" dirty="0"><ns4:solidFill><ns4:srgbClr val="1E293B"/></ns4:solidFill><ns4:latin typeface="Calibri"/><ns4:ea typeface="Calibri"/></ns4:defRPr></ns4:lvl5pPr><ns4:lvl6pPr algn="l"><ns4:buNone/><ns4:defRPr sz="1400" dirty="0"><ns4:solidFill><ns4:srgbClr val="1E293B"/></ns4:solidFill><ns4:latin typeface="Calibri"/><ns4:ea typeface="Calibri"/></ns4:defRPr></ns4:lvl6pPr><ns4:lvl7pPr algn="l"><ns4:buNone/><ns4:defRPr sz="1400" dirty="0"><ns4:solidFill><ns4:srgbClr val="1E293B"/></ns4:solidFill><ns4:latin typeface="Calibri"/><ns4:ea typeface="Calibri"/></ns4:defRPr></ns4:lvl7pPr><ns4:lvl8pPr algn="l"><ns4:buNone/><ns4:defRPr sz="1400" dirty="0"><ns4:solidFill><ns4:srgbClr val="1E293B"/></ns4:solidFill><ns4:latin typeface="Calibri"/><ns4:ea typeface="Calibri"/></ns4:defRPr></ns4:lvl8pPr><ns4:lvl9pPr algn="l"><ns4:buNone/><ns4:defRPr sz="1400" dirty="0"><ns4:solidFill><ns4:srgbClr val="1E293B"/></ns4:solidFill><ns4:latin typeface="Calibri"/><ns4:ea typeface="Calibri"/></ns4:defRPr></ns4:lvl9pPr></ns4:lstStyle/><ns5:p xmlns:ns5="http://schemas.openxmlformats.org/drawingml/2006/main"><ns5:pPr algn="l"><ns5:buNone/></ns5:pPr><ns5:r><ns5:rPr lang="ja-JP"/><ns5:t>指標 2
-値・説明</ns5:t></ns5:r></ns5:p></ns0:txBody></ns0:sp><ns0:sp><ns0:nvSpPr><ns0:cNvPr id="22" name="Value3.BottomLeft"/><ns0:cNvSpPr><ns1:spLocks xmlns:ns1="http://schemas.openxmlformats.org/drawingml/2006/main" noGrp="1"/></ns0:cNvSpPr><ns0:nvPr><ns0:ph idx="3" type="body"/></ns0:nvPr></ns0:nvSpPr><ns0:spPr><ns2:xfrm xmlns:ns2="http://schemas.openxmlformats.org/drawingml/2006/main"><ns2:off x="914400" y="4023360"/><ns2:ext cx="4389120" cy="1828800"/></ns2:xfrm></ns0:spPr><ns0:txBody><ns3:bodyPr xmlns:ns3="http://schemas.openxmlformats.org/drawingml/2006/main" wrap="square" anchor="t" anchorCtr="0"/><ns4:lstStyle/><ns4:defPPr algn="l"><ns4:buNone/><ns4:defRPr sz="1400" dirty="0"><ns4:solidFill><ns4:srgbClr val="1E293B"/></ns4:solidFill><ns4:latin typeface="Calibri"/><ns4:ea typeface="Calibri"/></ns4:defRPr></ns4:defPPr><ns4:lvl1pPr algn="l"><ns4:buNone/><ns4:defRPr sz="1400" dirty="0"><ns4:solidFill><ns4:srgbClr val="1E293B"/></ns4:solidFill><ns4:latin typeface="Calibri"/><ns4:ea typeface="Calibri"/></ns4:defRPr></ns4:lvl1pPr><ns4:lvl2pPr algn="l"><ns4:buNone/><ns4:defRPr sz="1400" dirty="0"><ns4:solidFill><ns4:srgbClr val="1E293B"/></ns4:solidFill><ns4:latin typeface="Calibri"/><ns4:ea typeface="Calibri"/></ns4:defRPr></ns4:lvl2pPr><ns4:lvl3pPr algn="l"><ns4:buNone/><ns4:defRPr sz="1400" dirty="0"><ns4:solidFill><ns4:srgbClr val="1E293B"/></ns4:solidFill><ns4:latin typeface="Calibri"/><ns4:ea typeface="Calibri"/></ns4:defRPr></ns4:lvl3pPr><ns4:lvl4pPr algn="l"><ns4:buNone/><ns4:defRPr sz="1400" dirty="0"><ns4:solidFill><ns4:srgbClr val="1E293B"/></ns4:solidFill><ns4:latin typeface="Calibri"/><ns4:ea typeface="Calibri"/></ns4:defRPr></ns4:lvl4pPr><ns4:lvl5pPr algn="l"><ns4:buNone/><ns4:defRPr sz="1400" dirty="0"><ns4:solidFill><ns4:srgbClr val="1E293B"/></ns4:solidFill><ns4:latin typeface="Calibri"/><ns4:ea typeface="Calibri"/></ns4:defRPr></ns4:lvl5pPr><ns4:lvl6pPr algn="l"><ns4:buNone/><ns4:defRPr sz="1400" dirty="0"><ns4:solidFill><ns4:srgbClr val="1E293B"/></ns4:solidFill><ns4:latin typeface="Calibri"/><ns4:ea typeface="Calibri"/></ns4:defRPr></ns4:lvl6pPr><ns4:lvl7pPr algn="l"><ns4:buNone/><ns4:defRPr sz="1400" dirty="0"><ns4:solidFill><ns4:srgbClr val="1E293B"/></ns4:solidFill><ns4:latin typeface="Calibri"/><ns4:ea typeface="Calibri"/></ns4:defRPr></ns4:lvl7pPr><ns4:lvl8pPr algn="l"><ns4:buNone/><ns4:defRPr sz="1400" dirty="0"><ns4:solidFill><ns4:srgbClr val="1E293B"/></ns4:solidFill><ns4:latin typeface="Calibri"/><ns4:ea typeface="Calibri"/></ns4:defRPr></ns4:lvl8pPr><ns4:lvl9pPr algn="l"><ns4:buNone/><ns4:defRPr sz="1400" dirty="0"><ns4:solidFill><ns4:srgbClr val="1E293B"/></ns4:solidFill><ns4:latin typeface="Calibri"/><ns4:ea typeface="Calibri"/></ns4:defRPr></ns4:lvl9pPr></ns4:lstStyle/><ns5:p xmlns:ns5="http://schemas.openxmlformats.org/drawingml/2006/main"><ns5:pPr algn="l"><ns5:buNone/></ns5:pPr><ns5:r><ns5:rPr lang="ja-JP"/><ns5:t>指標 4
-値・説明</ns5:t></ns5:r></ns5:p></ns0:txBody></ns0:sp><ns0:sp><ns0:nvSpPr><ns0:cNvPr id="31" name="SlideNum.Footer"/><ns0:cNvSpPr><ns1:spLocks xmlns:ns1="http://schemas.openxmlformats.org/drawingml/2006/main" noGrp="1"/></ns0:cNvSpPr><ns0:nvPr><ns0:ph idx="50" type="sldNum"/></ns0:nvPr></ns0:nvSpPr><ns0:spPr><ns2:xfrm xmlns:ns2="http://schemas.openxmlformats.org/drawingml/2006/main"><ns2:off x="10972800" y="6446520"/><ns2:ext cx="1097280" cy="274320"/></ns2:xfrm></ns0:spPr><ns0:txBody><ns3:bodyPr xmlns:ns3="http://schemas.openxmlformats.org/drawingml/2006/main" wrap="square" anchor="t" anchorCtr="0"/><ns4:lstStyle><ns4:defPPr algn="r"><ns4:defRPr sz="1000"><ns4:solidFill><ns4:srgbClr val="94A3B8"/></ns4:solidFill></ns4:defRPr></ns4:defPPr></ns4:lstStyle><ns4:defPPr algn="r"><ns4:buNone/><ns4:defRPr sz="1000" dirty="0"><ns4:solidFill><ns4:srgbClr val="94A3B8"/></ns4:solidFill><ns4:latin typeface="Calibri"/><ns4:ea typeface="Calibri"/></ns4:defRPr></ns4:defPPr><ns4:lvl1pPr algn="r"><ns4:buNone/><ns4:defRPr sz="1000" dirty="0"><ns4:solidFill><ns4:srgbClr val="94A3B8"/></ns4:solidFill><ns4:latin typeface="Calibri"/><ns4:ea typeface="Calibri"/></ns4:defRPr></ns4:lvl1pPr><ns4:lvl2pPr algn="r"><ns4:buNone/><ns4:defRPr sz="1000" dirty="0"><ns4:solidFill><ns4:srgbClr val="94A3B8"/></ns4:solidFill><ns4:latin typeface="Calibri"/><ns4:ea typeface="Calibri"/></ns4:defRPr></ns4:lvl2pPr><ns4:lvl3pPr algn="r"><ns4:buNone/><ns4:defRPr sz="1000" dirty="0"><ns4:solidFill><ns4:srgbClr val="94A3B8"/></ns4:solidFill><ns4:latin typeface="Calibri"/><ns4:ea typeface="Calibri"/></ns4:defRPr></ns4:lvl3pPr><ns4:lvl4pPr algn="r"><ns4:buNone/><ns4:defRPr sz="1000" dirty="0"><ns4:solidFill><ns4:srgbClr val="94A3B8"/></ns4:solidFill><ns4:latin typeface="Calibri"/><ns4:ea typeface="Calibri"/></ns4:defRPr></ns4:lvl4pPr><ns4:lvl5pPr algn="r"><ns4:buNone/><ns4:defRPr sz="1000" dirty="0"><ns4:solidFill><ns4:srgbClr val="94A3B8"/></ns4:solidFill><ns4:latin typeface="Calibri"/><ns4:ea typeface="Calibri"/></ns4:defRPr></ns4:lvl5pPr><ns4:lvl6pPr algn="r"><ns4:buNone/><ns4:defRPr sz="1000" dirty="0"><ns4:solidFill><ns4:srgbClr val="94A3B8"/></ns4:solidFill><ns4:latin typeface="Calibri"/><ns4:ea typeface="Calibri"/></ns4:defRPr></ns4:lvl6pPr><ns4:lvl7pPr algn="r"><ns4:buNone/><ns4:defRPr sz="1000" dirty="0"><ns4:solidFill><ns4:srgbClr val="94A3B8"/></ns4:solidFill><ns4:latin typeface="Calibri"/><ns4:ea typeface="Calibri"/></ns4:defRPr></ns4:lvl7pPr><ns4:lvl8pPr algn="r"><ns4:buNone/><ns4:defRPr sz="1000" dirty="0"><ns4:solidFill><ns4:srgbClr val="94A3B8"/></ns4:solidFill><ns4:latin typeface="Calibri"/><ns4:ea typeface="Calibri"/></ns4:defRPr></ns4:lvl8pPr><ns4:lvl9pPr algn="r"><ns4:buNone/><ns4:defRPr sz="1000" dirty="0"><ns4:solidFill><ns4:srgbClr val="94A3B8"/></ns4:solidFill><ns4:latin typeface="Calibri"/><ns4:ea typeface="Calibri"/></ns4:defRPr></ns4:lvl9pPr></ns4:lstStyle><ns5:p xmlns:ns5="http://schemas.openxmlformats.org/drawingml/2006/main"><ns5:pPr algn="r"><ns5:buNone/></ns5:pPr><ns5:r><ns5:rPr lang="ja-JP"/><ns5:t>&lt;#&gt;</ns5:t></ns5:r></ns5:p></ns0:txBody></ns0:sp></ns0:spTree></ns0:cSld><ns0:clrMapOvr/></ns0:sldLayout>
+<file path=ppt/slideLayouts/slideLayout17.xml><?xml version='1.0' encoding='UTF-8' standalone='yes'?><p:sldLayout xmlns:a="http://schemas.openxmlformats.org/drawingml/2006/main" xmlns:p="http://schemas.openxmlformats.org/presentationml/2006/main" xmlns:r="http://schemas.openxmlformats.org/officeDocument/2006/relationships" type="blank" preserve="1"><p:cSld name="KPI.4Value.Grid"><p:spTree><p:nvGrpSpPr><p:cNvPr id="1" name=""/><p:cNvGrpSpPr/><p:nvPr/></p:nvGrpSpPr><p:grpSpPr><a:xfrm><a:off x="0" y="0"/><a:ext cx="0" cy="0"/><a:chOff x="0" y="0"/><a:chExt cx="0" cy="0"/></a:xfrm></p:grpSpPr><p:sp><p:nvSpPr><p:cNvPr id="2" name="HeaderBar"/><p:cNvSpPr><a:spLocks xmlns:ns1="http://schemas.openxmlformats.org/drawingml/2006/main" noGrp="1" noSelect="0" noRot="1" noMove="1"/></p:cNvSpPr><p:nvPr/></p:nvSpPr><p:spPr><a:xfrm xmlns:ns2="http://schemas.openxmlformats.org/drawingml/2006/main"><a:off x="0" y="0"/><a:ext cx="12192000" cy="1051560"/></a:xfrm><a:prstGeom xmlns:ns3="http://schemas.openxmlformats.org/drawingml/2006/main" prst="rect"/><a:solidFill xmlns:ns4="http://schemas.openxmlformats.org/drawingml/2006/main"><a:srgbClr val="1E2761"/></a:solidFill><a:ln xmlns:ns5="http://schemas.openxmlformats.org/drawingml/2006/main"><a:noFill/></a:ln></p:spPr></p:sp><p:sp><p:nvSpPr><p:cNvPr id="3" name="TL"/><p:cNvSpPr><a:spLocks xmlns:ns1="http://schemas.openxmlformats.org/drawingml/2006/main" noGrp="1" noSelect="0" noRot="1" noMove="1"/></p:cNvSpPr><p:nvPr/></p:nvSpPr><p:spPr><a:xfrm xmlns:ns2="http://schemas.openxmlformats.org/drawingml/2006/main"><a:off x="457200" y="1280160"/><a:ext cx="5303520" cy="2286000"/></a:xfrm><a:prstGeom xmlns:ns3="http://schemas.openxmlformats.org/drawingml/2006/main" prst="roundRect"><a:avLst><a:gd name="adj" fmla="val 8000"/></a:avLst></p:prstGeom><a:solidFill xmlns:ns4="http://schemas.openxmlformats.org/drawingml/2006/main"><a:srgbClr val="EDF0F7"/></a:solidFill><a:ln xmlns:ns5="http://schemas.openxmlformats.org/drawingml/2006/main"><a:noFill/></a:ln></p:spPr></p:sp><p:sp><p:nvSpPr><p:cNvPr id="4" name="TR"/><p:cNvSpPr><a:spLocks xmlns:ns1="http://schemas.openxmlformats.org/drawingml/2006/main" noGrp="1" noSelect="0" noRot="1" noMove="1"/></p:cNvSpPr><p:nvPr/></p:nvSpPr><p:spPr><a:xfrm xmlns:ns2="http://schemas.openxmlformats.org/drawingml/2006/main"><a:off x="6126480" y="1280160"/><a:ext cx="5394960" cy="2286000"/></a:xfrm><a:prstGeom xmlns:ns3="http://schemas.openxmlformats.org/drawingml/2006/main" prst="roundRect"><a:avLst><a:gd name="adj" fmla="val 8000"/></a:avLst></p:prstGeom><a:solidFill xmlns:ns4="http://schemas.openxmlformats.org/drawingml/2006/main"><a:srgbClr val="EDF0F7"/></a:solidFill><a:ln xmlns:ns5="http://schemas.openxmlformats.org/drawingml/2006/main"><a:noFill/></a:ln></p:spPr></p:sp><p:sp><p:nvSpPr><p:cNvPr id="5" name="BL"/><p:cNvSpPr><a:spLocks xmlns:ns1="http://schemas.openxmlformats.org/drawingml/2006/main" noGrp="1" noSelect="0" noRot="1" noMove="1"/></p:cNvSpPr><p:nvPr/></p:nvSpPr><p:spPr><a:xfrm xmlns:ns2="http://schemas.openxmlformats.org/drawingml/2006/main"><a:off x="457200" y="3840480"/><a:ext cx="5303520" cy="2286000"/></a:xfrm><a:prstGeom xmlns:ns3="http://schemas.openxmlformats.org/drawingml/2006/main" prst="roundRect"><a:avLst><a:gd name="adj" fmla="val 8000"/></a:avLst></p:prstGeom><a:solidFill xmlns:ns4="http://schemas.openxmlformats.org/drawingml/2006/main"><a:srgbClr val="EDF0F7"/></a:solidFill><a:ln xmlns:ns5="http://schemas.openxmlformats.org/drawingml/2006/main"><a:noFill/></a:ln></p:spPr></p:sp><p:sp><p:nvSpPr><p:cNvPr id="6" name="BR"/><p:cNvSpPr><a:spLocks xmlns:ns1="http://schemas.openxmlformats.org/drawingml/2006/main" noGrp="1" noSelect="0" noRot="1" noMove="1"/></p:cNvSpPr><p:nvPr/></p:nvSpPr><p:spPr><a:xfrm xmlns:ns2="http://schemas.openxmlformats.org/drawingml/2006/main"><a:off x="6126480" y="3840480"/><a:ext cx="5394960" cy="2286000"/></a:xfrm><a:prstGeom xmlns:ns3="http://schemas.openxmlformats.org/drawingml/2006/main" prst="roundRect"><a:avLst><a:gd name="adj" fmla="val 8000"/></a:avLst></p:prstGeom><a:solidFill xmlns:ns4="http://schemas.openxmlformats.org/drawingml/2006/main"><a:srgbClr val="EDF0F7"/></a:solidFill><a:ln xmlns:ns5="http://schemas.openxmlformats.org/drawingml/2006/main"><a:noFill/></a:ln></p:spPr></p:sp><p:sp><p:nvSpPr><p:cNvPr id="7" name="A1"/><p:cNvSpPr><a:spLocks xmlns:ns1="http://schemas.openxmlformats.org/drawingml/2006/main" noGrp="1" noSelect="0" noRot="1" noMove="1"/></p:cNvSpPr><p:nvPr/></p:nvSpPr><p:spPr><a:xfrm xmlns:ns2="http://schemas.openxmlformats.org/drawingml/2006/main"><a:off x="457200" y="1280160"/><a:ext cx="54864" cy="2286000"/></a:xfrm><a:prstGeom xmlns:ns3="http://schemas.openxmlformats.org/drawingml/2006/main" prst="rect"/><a:solidFill xmlns:ns4="http://schemas.openxmlformats.org/drawingml/2006/main"><a:srgbClr val="3B82F6"/></a:solidFill><a:ln xmlns:ns5="http://schemas.openxmlformats.org/drawingml/2006/main"><a:noFill/></a:ln></p:spPr></p:sp><p:sp><p:nvSpPr><p:cNvPr id="8" name="A2"/><p:cNvSpPr><a:spLocks xmlns:ns1="http://schemas.openxmlformats.org/drawingml/2006/main" noGrp="1" noSelect="0" noRot="1" noMove="1"/></p:cNvSpPr><p:nvPr/></p:nvSpPr><p:spPr><a:xfrm xmlns:ns2="http://schemas.openxmlformats.org/drawingml/2006/main"><a:off x="6126480" y="1280160"/><a:ext cx="54864" cy="2286000"/></a:xfrm><a:prstGeom xmlns:ns3="http://schemas.openxmlformats.org/drawingml/2006/main" prst="rect"/><a:solidFill xmlns:ns4="http://schemas.openxmlformats.org/drawingml/2006/main"><a:srgbClr val="06B6D4"/></a:solidFill><a:ln xmlns:ns5="http://schemas.openxmlformats.org/drawingml/2006/main"><a:noFill/></a:ln></p:spPr></p:sp><p:sp><p:nvSpPr><p:cNvPr id="9" name="A3"/><p:cNvSpPr><a:spLocks xmlns:ns1="http://schemas.openxmlformats.org/drawingml/2006/main" noGrp="1" noSelect="0" noRot="1" noMove="1"/></p:cNvSpPr><p:nvPr/></p:nvSpPr><p:spPr><a:xfrm xmlns:ns2="http://schemas.openxmlformats.org/drawingml/2006/main"><a:off x="457200" y="3840480"/><a:ext cx="54864" cy="2286000"/></a:xfrm><a:prstGeom xmlns:ns3="http://schemas.openxmlformats.org/drawingml/2006/main" prst="rect"/><a:solidFill xmlns:ns4="http://schemas.openxmlformats.org/drawingml/2006/main"><a:srgbClr val="F59E0B"/></a:solidFill><a:ln xmlns:ns5="http://schemas.openxmlformats.org/drawingml/2006/main"><a:noFill/></a:ln></p:spPr></p:sp><p:sp><p:nvSpPr><p:cNvPr id="10" name="A4"/><p:cNvSpPr><a:spLocks xmlns:ns1="http://schemas.openxmlformats.org/drawingml/2006/main" noGrp="1" noSelect="0" noRot="1" noMove="1"/></p:cNvSpPr><p:nvPr/></p:nvSpPr><p:spPr><a:xfrm xmlns:ns2="http://schemas.openxmlformats.org/drawingml/2006/main"><a:off x="6126480" y="3840480"/><a:ext cx="54864" cy="2286000"/></a:xfrm><a:prstGeom xmlns:ns3="http://schemas.openxmlformats.org/drawingml/2006/main" prst="rect"/><a:solidFill xmlns:ns4="http://schemas.openxmlformats.org/drawingml/2006/main"><a:srgbClr val="2563EB"/></a:solidFill><a:ln xmlns:ns5="http://schemas.openxmlformats.org/drawingml/2006/main"><a:noFill/></a:ln></p:spPr></p:sp><p:sp><p:nvSpPr><p:cNvPr id="11" name="SlideTitle.Header"/><p:cNvSpPr><a:spLocks noGrp="1"/></p:cNvSpPr><p:nvPr><p:ph type="body" idx="15"/></p:nvPr></p:nvSpPr><p:spPr><a:xfrm><a:off x="731520" y="91440"/><a:ext cx="9144000" cy="475488"/></a:xfrm></p:spPr><p:txBody><a:bodyPr wrap="square" anchor="t" anchorCtr="0"/><a:lstStyle><a:defPPr><a:defRPr sz="2800" b="1"><a:solidFill><a:srgbClr val="FFFFFF"/></a:solidFill></a:defRPr></a:defPPr></a:lstStyle><a:p><a:r><a:rPr lang="ja-JP"/><a:t> </a:t></a:r></a:p></p:txBody></p:sp><p:sp><p:nvSpPr><p:cNvPr id="12" name="SlideSubtitle.Header"/><p:cNvSpPr><a:spLocks noGrp="1"/></p:cNvSpPr><p:nvPr><p:ph type="body" idx="16"/></p:nvPr></p:nvSpPr><p:spPr><a:xfrm><a:off x="731520" y="658368"/><a:ext cx="9144000" cy="274320"/></a:xfrm></p:spPr><p:txBody><a:bodyPr wrap="square" anchor="t" anchorCtr="0"/><a:lstStyle><a:defPPr><a:defRPr sz="1200"><a:solidFill><a:srgbClr val="CADCFC"/></a:solidFill></a:defRPr></a:defPPr></a:lstStyle><a:p><a:r><a:rPr lang="ja-JP"/><a:t> </a:t></a:r></a:p></p:txBody></p:sp><p:sp><p:nvSpPr><p:cNvPr id="13" name="Value1.TL"/><p:cNvSpPr><a:spLocks noGrp="1"/></p:cNvSpPr><p:nvPr><p:ph type="body" idx="1"/></p:nvPr></p:nvSpPr><p:spPr><a:xfrm><a:off x="914400" y="1463040"/><a:ext cx="4389120" cy="1828800"/></a:xfrm></p:spPr><p:txBody><a:bodyPr wrap="square" anchor="t" anchorCtr="0"/><a:lstStyle/><a:p><a:r><a:rPr lang="ja-JP"/><a:t> </a:t></a:r></a:p></p:txBody></p:sp><p:sp><p:nvSpPr><p:cNvPr id="14" name="Value2.TR"/><p:cNvSpPr><a:spLocks noGrp="1"/></p:cNvSpPr><p:nvPr><p:ph type="body" idx="2"/></p:nvPr></p:nvSpPr><p:spPr><a:xfrm><a:off x="6583680" y="1463040"/><a:ext cx="4572000" cy="1828800"/></a:xfrm></p:spPr><p:txBody><a:bodyPr wrap="square" anchor="t" anchorCtr="0"/><a:lstStyle/><a:p><a:r><a:rPr lang="ja-JP"/><a:t> </a:t></a:r></a:p></p:txBody></p:sp><p:sp><p:nvSpPr><p:cNvPr id="15" name="Value3.BL"/><p:cNvSpPr><a:spLocks noGrp="1"/></p:cNvSpPr><p:nvPr><p:ph type="body" idx="3"/></p:nvPr></p:nvSpPr><p:spPr><a:xfrm><a:off x="914400" y="4023360"/><a:ext cx="4389120" cy="1828800"/></a:xfrm></p:spPr><p:txBody><a:bodyPr wrap="square" anchor="t" anchorCtr="0"/><a:lstStyle/><a:p><a:r><a:rPr lang="ja-JP"/><a:t> </a:t></a:r></a:p></p:txBody></p:sp><p:sp><p:nvSpPr><p:cNvPr id="16" name="Value4.BR"/><p:cNvSpPr><a:spLocks noGrp="1"/></p:cNvSpPr><p:nvPr><p:ph type="body" idx="4"/></p:nvPr></p:nvSpPr><p:spPr><a:xfrm><a:off x="6583680" y="4023360"/><a:ext cx="4572000" cy="1828800"/></a:xfrm></p:spPr><p:txBody><a:bodyPr wrap="square" anchor="t" anchorCtr="0"/><a:lstStyle/><a:p><a:r><a:rPr lang="ja-JP"/><a:t> </a:t></a:r></a:p></p:txBody></p:sp><p:sp><p:nvSpPr><p:cNvPr id="17" name="SlideNum.Footer"/><p:cNvSpPr><a:spLocks noGrp="1"/></p:cNvSpPr><p:nvPr><p:ph type="sldNum" idx="50"/></p:nvPr></p:nvSpPr><p:spPr><a:xfrm><a:off x="10972800" y="6446520"/><a:ext cx="1097280" cy="274320"/></a:xfrm></p:spPr><p:txBody><a:bodyPr wrap="square" anchor="t" anchorCtr="0"/><a:lstStyle><a:defPPr algn="r"><a:defRPr sz="1000"><a:solidFill><a:srgbClr val="94A3B8"/></a:solidFill></a:defRPr></a:defPPr></a:lstStyle><a:p><a:r><a:rPr lang="ja-JP"/><a:t> </a:t></a:r></a:p></p:txBody></p:sp></p:spTree></p:cSld><p:clrMapOvr/></p:sldLayout>
 </file>
 
-<file path=ppt/slideLayouts/slideLayout18.xml><?xml version='1.0' encoding='UTF-8' standalone='yes'?>
-<ns0:sldLayout xmlns:ns0="http://schemas.openxmlformats.org/presentationml/2006/main" type="blank" preserve="1"><ns0:cSld name="Chart.1Chart.Single"><ns0:spTree><ns0:nvGrpSpPr><ns0:cNvPr id="1" name=""/><ns0:cNvGrpSpPr/><ns0:nvPr/></ns0:nvGrpSpPr><ns0:grpSpPr><ns1:xfrm xmlns:ns1="http://schemas.openxmlformats.org/drawingml/2006/main"><ns1:off x="0" y="0"/><ns1:ext cx="0" cy="0"/><ns1:chOff x="0" y="0"/><ns1:chExt cx="0" cy="0"/></ns1:xfrm></ns0:grpSpPr><ns0:sp><ns0:nvSpPr><ns0:cNvPr id="2" name="HeaderBar"/><ns0:cNvSpPr><ns1:spLocks xmlns:ns1="http://schemas.openxmlformats.org/drawingml/2006/main" noGrp="1" noSelect="0" noRot="1" noMove="1"/></ns0:cNvSpPr><ns0:nvPr/></ns0:nvSpPr><ns0:spPr><ns2:xfrm xmlns:ns2="http://schemas.openxmlformats.org/drawingml/2006/main"><ns2:off x="0" y="0"/><ns2:ext cx="12192000" cy="1051560"/></ns2:xfrm><ns3:prstGeom xmlns:ns3="http://schemas.openxmlformats.org/drawingml/2006/main" prst="rect"/><ns4:solidFill xmlns:ns4="http://schemas.openxmlformats.org/drawingml/2006/main"><ns4:srgbClr val="1E2761"/></ns4:solidFill><ns5:ln xmlns:ns5="http://schemas.openxmlformats.org/drawingml/2006/main"><ns5:noFill/></ns5:ln></ns0:spPr></ns0:sp><ns0:sp><ns0:nvSpPr><ns0:cNvPr id="10" name="SlideTitle.Header"/><ns0:cNvSpPr><ns1:spLocks xmlns:ns1="http://schemas.openxmlformats.org/drawingml/2006/main" noGrp="1"/></ns0:cNvSpPr><ns0:nvPr><ns0:ph idx="15" type="body"/></ns0:nvPr></ns0:nvSpPr><ns0:spPr><ns2:xfrm xmlns:ns2="http://schemas.openxmlformats.org/drawingml/2006/main"><ns2:off x="731520" y="91440"/><ns2:ext cx="9144000" cy="475488"/></ns2:xfrm></ns0:spPr><ns0:txBody><ns3:bodyPr xmlns:ns3="http://schemas.openxmlformats.org/drawingml/2006/main" wrap="square" anchor="t" anchorCtr="0"/><ns4:lstStyle><ns4:defPPr><ns4:defRPr sz="2800" b="1"><ns4:solidFill><ns4:srgbClr val="FFFFFF"/></ns4:solidFill></ns4:defRPr></ns4:defPPr></ns4:lstStyle><ns4:defPPr algn="l"><ns4:buNone/><ns4:defRPr sz="2800" dirty="0" b="1"><ns4:solidFill><ns4:srgbClr val="FFFFFF"/></ns4:solidFill><ns4:latin typeface="Georgia"/><ns4:ea typeface="Georgia"/></ns4:defRPr></ns4:defPPr><ns4:lvl1pPr algn="l"><ns4:buNone/><ns4:defRPr sz="2800" dirty="0" b="1"><ns4:solidFill><ns4:srgbClr val="FFFFFF"/></ns4:solidFill><ns4:latin typeface="Georgia"/><ns4:ea typeface="Georgia"/></ns4:defRPr></ns4:lvl1pPr><ns4:lvl2pPr algn="l"><ns4:buNone/><ns4:defRPr sz="2800" dirty="0" b="1"><ns4:solidFill><ns4:srgbClr val="FFFFFF"/></ns4:solidFill><ns4:latin typeface="Georgia"/><ns4:ea typeface="Georgia"/></ns4:defRPr></ns4:lvl2pPr><ns4:lvl3pPr algn="l"><ns4:buNone/><ns4:defRPr sz="2800" dirty="0" b="1"><ns4:solidFill><ns4:srgbClr val="FFFFFF"/></ns4:solidFill><ns4:latin typeface="Georgia"/><ns4:ea typeface="Georgia"/></ns4:defRPr></ns4:lvl3pPr><ns4:lvl4pPr algn="l"><ns4:buNone/><ns4:defRPr sz="2800" dirty="0" b="1"><ns4:solidFill><ns4:srgbClr val="FFFFFF"/></ns4:solidFill><ns4:latin typeface="Georgia"/><ns4:ea typeface="Georgia"/></ns4:defRPr></ns4:lvl4pPr><ns4:lvl5pPr algn="l"><ns4:buNone/><ns4:defRPr sz="2800" dirty="0" b="1"><ns4:solidFill><ns4:srgbClr val="FFFFFF"/></ns4:solidFill><ns4:latin typeface="Georgia"/><ns4:ea typeface="Georgia"/></ns4:defRPr></ns4:lvl5pPr><ns4:lvl6pPr algn="l"><ns4:buNone/><ns4:defRPr sz="2800" dirty="0" b="1"><ns4:solidFill><ns4:srgbClr val="FFFFFF"/></ns4:solidFill><ns4:latin typeface="Georgia"/><ns4:ea typeface="Georgia"/></ns4:defRPr></ns4:lvl6pPr><ns4:lvl7pPr algn="l"><ns4:buNone/><ns4:defRPr sz="2800" dirty="0" b="1"><ns4:solidFill><ns4:srgbClr val="FFFFFF"/></ns4:solidFill><ns4:latin typeface="Georgia"/><ns4:ea typeface="Georgia"/></ns4:defRPr></ns4:lvl7pPr><ns4:lvl8pPr algn="l"><ns4:buNone/><ns4:defRPr sz="2800" dirty="0" b="1"><ns4:solidFill><ns4:srgbClr val="FFFFFF"/></ns4:solidFill><ns4:latin typeface="Georgia"/><ns4:ea typeface="Georgia"/></ns4:defRPr></ns4:lvl8pPr><ns4:lvl9pPr algn="l"><ns4:buNone/><ns4:defRPr sz="2800" dirty="0" b="1"><ns4:solidFill><ns4:srgbClr val="FFFFFF"/></ns4:solidFill><ns4:latin typeface="Georgia"/><ns4:ea typeface="Georgia"/></ns4:defRPr></ns4:lvl9pPr></ns4:lstStyle/><ns5:p xmlns:ns5="http://schemas.openxmlformats.org/drawingml/2006/main"><ns5:pPr algn="l"><ns5:buNone/></ns5:pPr><ns5:r><ns5:rPr lang="ja-JP"/><ns5:t>サブタイトル</ns5:t></ns5:r></ns5:p></ns0:txBody></ns0:sp><ns0:sp><ns0:nvSpPr><ns0:cNvPr id="5" name="ChartArea"/><ns0:cNvSpPr><ns1:spLocks xmlns:ns1="http://schemas.openxmlformats.org/drawingml/2006/main" noGrp="1" noSelect="0" noRot="1" noMove="1"/></ns0:cNvSpPr><ns0:nvPr/></ns0:nvSpPr><ns0:spPr><ns2:xfrm xmlns:ns2="http://schemas.openxmlformats.org/drawingml/2006/main"><ns2:off x="457200" y="1280160"/><ns2:ext cx="11247120" cy="4937760"/></ns2:xfrm><ns3:prstGeom xmlns:ns3="http://schemas.openxmlformats.org/drawingml/2006/main" prst="roundRect"><ns3:avLst><ns3:gd name="adj" fmla="val 6000"/></ns3:avLst></ns3:prstGeom><ns4:solidFill xmlns:ns4="http://schemas.openxmlformats.org/drawingml/2006/main"><ns4:srgbClr val="EDF0F7"/></ns4:solidFill><ns5:ln xmlns:ns5="http://schemas.openxmlformats.org/drawingml/2006/main"><ns5:noFill/></ns5:ln></ns0:spPr></ns0:sp><ns0:sp><ns0:nvSpPr><ns0:cNvPr id="20" name="Body.Center"/><ns0:cNvSpPr><ns1:spLocks xmlns:ns1="http://schemas.openxmlformats.org/drawingml/2006/main" noGrp="1"/></ns0:cNvSpPr><ns0:nvPr><ns0:ph idx="1" type="body"/></ns0:nvPr></ns0:nvSpPr><ns0:spPr><ns2:xfrm xmlns:ns2="http://schemas.openxmlformats.org/drawingml/2006/main"><ns2:off x="731520" y="1463040"/><ns2:ext cx="10698480" cy="4572000"/></ns2:xfrm></ns0:spPr><ns0:txBody><ns3:bodyPr xmlns:ns3="http://schemas.openxmlformats.org/drawingml/2006/main" wrap="square" anchor="t" anchorCtr="0"/><ns4:lstStyle><ns4:defPPr algn="ctr"><ns4:defRPr><ns4:solidFill><ns4:srgbClr val="94A3B8"/></ns4:solidFill></ns4:defRPr></ns4:defPPr></ns4:lstStyle><ns4:defPPr algn="ctr"><ns4:buNone/><ns4:defRPr sz="1400" dirty="0"><ns4:solidFill><ns4:srgbClr val="94A3B8"/></ns4:solidFill><ns4:latin typeface="Calibri"/><ns4:ea typeface="Calibri"/></ns4:defRPr></ns4:defPPr><ns4:lvl1pPr algn="ctr"><ns4:buNone/><ns4:defRPr sz="1400" dirty="0"><ns4:solidFill><ns4:srgbClr val="94A3B8"/></ns4:solidFill><ns4:latin typeface="Calibri"/><ns4:ea typeface="Calibri"/></ns4:defRPr></ns4:lvl1pPr><ns4:lvl2pPr algn="ctr"><ns4:buNone/><ns4:defRPr sz="1400" dirty="0"><ns4:solidFill><ns4:srgbClr val="94A3B8"/></ns4:solidFill><ns4:latin typeface="Calibri"/><ns4:ea typeface="Calibri"/></ns4:defRPr></ns4:lvl2pPr><ns4:lvl3pPr algn="ctr"><ns4:buNone/><ns4:defRPr sz="1400" dirty="0"><ns4:solidFill><ns4:srgbClr val="94A3B8"/></ns4:solidFill><ns4:latin typeface="Calibri"/><ns4:ea typeface="Calibri"/></ns4:defRPr></ns4:lvl3pPr><ns4:lvl4pPr algn="ctr"><ns4:buNone/><ns4:defRPr sz="1400" dirty="0"><ns4:solidFill><ns4:srgbClr val="94A3B8"/></ns4:solidFill><ns4:latin typeface="Calibri"/><ns4:ea typeface="Calibri"/></ns4:defRPr></ns4:lvl4pPr><ns4:lvl5pPr algn="ctr"><ns4:buNone/><ns4:defRPr sz="1400" dirty="0"><ns4:solidFill><ns4:srgbClr val="94A3B8"/></ns4:solidFill><ns4:latin typeface="Calibri"/><ns4:ea typeface="Calibri"/></ns4:defRPr></ns4:lvl5pPr><ns4:lvl6pPr algn="ctr"><ns4:buNone/><ns4:defRPr sz="1400" dirty="0"><ns4:solidFill><ns4:srgbClr val="94A3B8"/></ns4:solidFill><ns4:latin typeface="Calibri"/><ns4:ea typeface="Calibri"/></ns4:defRPr></ns4:lvl6pPr><ns4:lvl7pPr algn="ctr"><ns4:buNone/><ns4:defRPr sz="1400" dirty="0"><ns4:solidFill><ns4:srgbClr val="94A3B8"/></ns4:solidFill><ns4:latin typeface="Calibri"/><ns4:ea typeface="Calibri"/></ns4:defRPr></ns4:lvl7pPr><ns4:lvl8pPr algn="ctr"><ns4:buNone/><ns4:defRPr sz="1400" dirty="0"><ns4:solidFill><ns4:srgbClr val="94A3B8"/></ns4:solidFill><ns4:latin typeface="Calibri"/><ns4:ea typeface="Calibri"/></ns4:defRPr></ns4:lvl8pPr><ns4:lvl9pPr algn="ctr"><ns4:buNone/><ns4:defRPr sz="1400" dirty="0"><ns4:solidFill><ns4:srgbClr val="94A3B8"/></ns4:solidFill><ns4:latin typeface="Calibri"/><ns4:ea typeface="Calibri"/></ns4:defRPr></ns4:lvl9pPr></ns4:lstStyle/><ns5:p xmlns:ns5="http://schemas.openxmlformats.org/drawingml/2006/main"><ns5:pPr algn="r"><ns5:buNone/></ns5:pPr><ns5:r><ns5:rPr lang="ja-JP"/><ns5:t>&lt;#&gt;</ns5:t></ns5:r></ns5:p></ns0:txBody></ns0:sp></ns0:spTree></ns0:cSld><ns0:clrMapOvr/></ns0:sldLayout>
+<file path=ppt/slideLayouts/slideLayout18.xml><?xml version='1.0' encoding='UTF-8' standalone='yes'?><p:sldLayout xmlns:a="http://schemas.openxmlformats.org/drawingml/2006/main" xmlns:p="http://schemas.openxmlformats.org/presentationml/2006/main" xmlns:r="http://schemas.openxmlformats.org/officeDocument/2006/relationships" type="blank" preserve="1"><p:cSld name="Chart.1Chart.Single"><p:spTree><p:nvGrpSpPr><p:cNvPr id="1" name=""/><p:cNvGrpSpPr/><p:nvPr/></p:nvGrpSpPr><p:grpSpPr><a:xfrm><a:off x="0" y="0"/><a:ext cx="0" cy="0"/><a:chOff x="0" y="0"/><a:chExt cx="0" cy="0"/></a:xfrm></p:grpSpPr><p:sp><p:nvSpPr><p:cNvPr id="2" name="HeaderBar"/><p:cNvSpPr><a:spLocks xmlns:ns1="http://schemas.openxmlformats.org/drawingml/2006/main" noGrp="1" noSelect="0" noRot="1" noMove="1"/></p:cNvSpPr><p:nvPr/></p:nvSpPr><p:spPr><a:xfrm xmlns:ns2="http://schemas.openxmlformats.org/drawingml/2006/main"><a:off x="0" y="0"/><a:ext cx="12192000" cy="1051560"/></a:xfrm><a:prstGeom xmlns:ns3="http://schemas.openxmlformats.org/drawingml/2006/main" prst="rect"/><a:solidFill xmlns:ns4="http://schemas.openxmlformats.org/drawingml/2006/main"><a:srgbClr val="1E2761"/></a:solidFill><a:ln xmlns:ns5="http://schemas.openxmlformats.org/drawingml/2006/main"><a:noFill/></a:ln></p:spPr></p:sp><p:sp><p:nvSpPr><p:cNvPr id="3" name="ChartArea"/><p:cNvSpPr><a:spLocks xmlns:ns1="http://schemas.openxmlformats.org/drawingml/2006/main" noGrp="1" noSelect="0" noRot="1" noMove="1"/></p:cNvSpPr><p:nvPr/></p:nvSpPr><p:spPr><a:xfrm xmlns:ns2="http://schemas.openxmlformats.org/drawingml/2006/main"><a:off x="457200" y="1280160"/><a:ext cx="11247120" cy="4937760"/></a:xfrm><a:prstGeom xmlns:ns3="http://schemas.openxmlformats.org/drawingml/2006/main" prst="roundRect"><a:avLst><a:gd name="adj" fmla="val 6000"/></a:avLst></p:prstGeom><a:solidFill xmlns:ns4="http://schemas.openxmlformats.org/drawingml/2006/main"><a:srgbClr val="EDF0F7"/></a:solidFill><a:ln xmlns:ns5="http://schemas.openxmlformats.org/drawingml/2006/main"><a:noFill/></a:ln></p:spPr></p:sp><p:sp><p:nvSpPr><p:cNvPr id="4" name="SlideTitle.Header"/><p:cNvSpPr><a:spLocks noGrp="1"/></p:cNvSpPr><p:nvPr><p:ph type="body" idx="15"/></p:nvPr></p:nvSpPr><p:spPr><a:xfrm><a:off x="731520" y="91440"/><a:ext cx="9144000" cy="475488"/></a:xfrm></p:spPr><p:txBody><a:bodyPr wrap="square" anchor="t" anchorCtr="0"/><a:lstStyle><a:defPPr><a:defRPr sz="2800" b="1"><a:solidFill><a:srgbClr val="FFFFFF"/></a:solidFill></a:defRPr></a:defPPr></a:lstStyle><a:p><a:r><a:rPr lang="ja-JP"/><a:t> </a:t></a:r></a:p></p:txBody></p:sp><p:sp><p:nvSpPr><p:cNvPr id="5" name="SlideSubtitle.Header"/><p:cNvSpPr><a:spLocks noGrp="1"/></p:cNvSpPr><p:nvPr><p:ph type="body" idx="16"/></p:nvPr></p:nvSpPr><p:spPr><a:xfrm><a:off x="731520" y="658368"/><a:ext cx="9144000" cy="274320"/></a:xfrm></p:spPr><p:txBody><a:bodyPr wrap="square" anchor="t" anchorCtr="0"/><a:lstStyle><a:defPPr><a:defRPr sz="1200"><a:solidFill><a:srgbClr val="CADCFC"/></a:solidFill></a:defRPr></a:defPPr></a:lstStyle><a:p><a:r><a:rPr lang="ja-JP"/><a:t> </a:t></a:r></a:p></p:txBody></p:sp><p:sp><p:nvSpPr><p:cNvPr id="6" name="Body.Center"/><p:cNvSpPr><a:spLocks noGrp="1"/></p:cNvSpPr><p:nvPr><p:ph type="body" idx="1"/></p:nvPr></p:nvSpPr><p:spPr><a:xfrm><a:off x="731520" y="1463040"/><a:ext cx="10698480" cy="4572000"/></a:xfrm></p:spPr><p:txBody><a:bodyPr wrap="square" anchor="t" anchorCtr="0"/><a:lstStyle><a:defPPr algn="ctr"><a:defRPr><a:solidFill><a:srgbClr val="94A3B8"/></a:solidFill></a:defRPr></a:defPPr></a:lstStyle><a:p><a:r><a:rPr lang="ja-JP"/><a:t> </a:t></a:r></a:p></p:txBody></p:sp><p:sp><p:nvSpPr><p:cNvPr id="7" name="SlideNum.Footer"/><p:cNvSpPr><a:spLocks noGrp="1"/></p:cNvSpPr><p:nvPr><p:ph type="sldNum" idx="50"/></p:nvPr></p:nvSpPr><p:spPr><a:xfrm><a:off x="10972800" y="6446520"/><a:ext cx="1097280" cy="274320"/></a:xfrm></p:spPr><p:txBody><a:bodyPr wrap="square" anchor="t" anchorCtr="0"/><a:lstStyle><a:defPPr algn="r"><a:defRPr sz="1000"><a:solidFill><a:srgbClr val="94A3B8"/></a:solidFill></a:defRPr></a:defPPr></a:lstStyle><a:p><a:r><a:rPr lang="ja-JP"/><a:t> </a:t></a:r></a:p></p:txBody></p:sp></p:spTree></p:cSld><p:clrMapOvr/></p:sldLayout>
 </file>
 
-<file path=ppt/slideLayouts/slideLayout19.xml><?xml version='1.0' encoding='UTF-8' standalone='yes'?>
-<ns0:sldLayout xmlns:ns0="http://schemas.openxmlformats.org/presentationml/2006/main" type="blank" preserve="1"><ns0:cSld name="Chart.1Chart.Single+1Analysis"><ns0:spTree><ns0:nvGrpSpPr><ns0:cNvPr id="1" name=""/><ns0:cNvGrpSpPr/><ns0:nvPr/></ns0:nvGrpSpPr><ns0:grpSpPr><ns1:xfrm xmlns:ns1="http://schemas.openxmlformats.org/drawingml/2006/main"><ns1:off x="0" y="0"/><ns1:ext cx="0" cy="0"/><ns1:chOff x="0" y="0"/><ns1:chExt cx="0" cy="0"/></ns1:xfrm></ns0:grpSpPr><ns0:sp><ns0:nvSpPr><ns0:cNvPr id="2" name="HeaderBar"/><ns0:cNvSpPr><ns1:spLocks xmlns:ns1="http://schemas.openxmlformats.org/drawingml/2006/main" noGrp="1" noSelect="0" noRot="1" noMove="1"/></ns0:cNvSpPr><ns0:nvPr/></ns0:nvSpPr><ns0:spPr><ns2:xfrm xmlns:ns2="http://schemas.openxmlformats.org/drawingml/2006/main"><ns2:off x="0" y="0"/><ns2:ext cx="12192000" cy="1051560"/></ns2:xfrm><ns3:prstGeom xmlns:ns3="http://schemas.openxmlformats.org/drawingml/2006/main" prst="rect"/><ns4:solidFill xmlns:ns4="http://schemas.openxmlformats.org/drawingml/2006/main"><ns4:srgbClr val="1E2761"/></ns4:solidFill><ns5:ln xmlns:ns5="http://schemas.openxmlformats.org/drawingml/2006/main"><ns5:noFill/></ns5:ln></ns0:spPr></ns0:sp><ns0:sp><ns0:nvSpPr><ns0:cNvPr id="10" name="SlideTitle.Header"/><ns0:cNvSpPr><ns1:spLocks xmlns:ns1="http://schemas.openxmlformats.org/drawingml/2006/main" noGrp="1"/></ns0:cNvSpPr><ns0:nvPr><ns0:ph idx="15" type="body"/></ns0:nvPr></ns0:nvSpPr><ns0:spPr><ns2:xfrm xmlns:ns2="http://schemas.openxmlformats.org/drawingml/2006/main"><ns2:off x="731520" y="91440"/><ns2:ext cx="9144000" cy="475488"/></ns2:xfrm></ns0:spPr><ns0:txBody><ns3:bodyPr xmlns:ns3="http://schemas.openxmlformats.org/drawingml/2006/main" wrap="square" anchor="t" anchorCtr="0"/><ns4:lstStyle><ns4:defPPr><ns4:defRPr sz="2800" b="1"><ns4:solidFill><ns4:srgbClr val="FFFFFF"/></ns4:solidFill></ns4:defRPr></ns4:defPPr></ns4:lstStyle><ns4:defPPr algn="l"><ns4:buNone/><ns4:defRPr sz="2800" dirty="0" b="1"><ns4:solidFill><ns4:srgbClr val="FFFFFF"/></ns4:solidFill><ns4:latin typeface="Georgia"/><ns4:ea typeface="Georgia"/></ns4:defRPr></ns4:defPPr><ns4:lvl1pPr algn="l"><ns4:buNone/><ns4:defRPr sz="2800" dirty="0" b="1"><ns4:solidFill><ns4:srgbClr val="FFFFFF"/></ns4:solidFill><ns4:latin typeface="Georgia"/><ns4:ea typeface="Georgia"/></ns4:defRPr></ns4:lvl1pPr><ns4:lvl2pPr algn="l"><ns4:buNone/><ns4:defRPr sz="2800" dirty="0" b="1"><ns4:solidFill><ns4:srgbClr val="FFFFFF"/></ns4:solidFill><ns4:latin typeface="Georgia"/><ns4:ea typeface="Georgia"/></ns4:defRPr></ns4:lvl2pPr><ns4:lvl3pPr algn="l"><ns4:buNone/><ns4:defRPr sz="2800" dirty="0" b="1"><ns4:solidFill><ns4:srgbClr val="FFFFFF"/></ns4:solidFill><ns4:latin typeface="Georgia"/><ns4:ea typeface="Georgia"/></ns4:defRPr></ns4:lvl3pPr><ns4:lvl4pPr algn="l"><ns4:buNone/><ns4:defRPr sz="2800" dirty="0" b="1"><ns4:solidFill><ns4:srgbClr val="FFFFFF"/></ns4:solidFill><ns4:latin typeface="Georgia"/><ns4:ea typeface="Georgia"/></ns4:defRPr></ns4:lvl4pPr><ns4:lvl5pPr algn="l"><ns4:buNone/><ns4:defRPr sz="2800" dirty="0" b="1"><ns4:solidFill><ns4:srgbClr val="FFFFFF"/></ns4:solidFill><ns4:latin typeface="Georgia"/><ns4:ea typeface="Georgia"/></ns4:defRPr></ns4:lvl5pPr><ns4:lvl6pPr algn="l"><ns4:buNone/><ns4:defRPr sz="2800" dirty="0" b="1"><ns4:solidFill><ns4:srgbClr val="FFFFFF"/></ns4:solidFill><ns4:latin typeface="Georgia"/><ns4:ea typeface="Georgia"/></ns4:defRPr></ns4:lvl6pPr><ns4:lvl7pPr algn="l"><ns4:buNone/><ns4:defRPr sz="2800" dirty="0" b="1"><ns4:solidFill><ns4:srgbClr val="FFFFFF"/></ns4:solidFill><ns4:latin typeface="Georgia"/><ns4:ea typeface="Georgia"/></ns4:defRPr></ns4:lvl7pPr><ns4:lvl8pPr algn="l"><ns4:buNone/><ns4:defRPr sz="2800" dirty="0" b="1"><ns4:solidFill><ns4:srgbClr val="FFFFFF"/></ns4:solidFill><ns4:latin typeface="Georgia"/><ns4:ea typeface="Georgia"/></ns4:defRPr></ns4:lvl8pPr><ns4:lvl9pPr algn="l"><ns4:buNone/><ns4:defRPr sz="2800" dirty="0" b="1"><ns4:solidFill><ns4:srgbClr val="FFFFFF"/></ns4:solidFill><ns4:latin typeface="Georgia"/><ns4:ea typeface="Georgia"/></ns4:defRPr></ns4:lvl9pPr></ns4:lstStyle/><ns5:p xmlns:ns5="http://schemas.openxmlformats.org/drawingml/2006/main"><ns5:pPr algn="l"><ns5:buNone/></ns5:pPr><ns5:r><ns5:rPr lang="ja-JP"/><ns5:t>サブタイトル</ns5:t></ns5:r></ns5:p></ns0:txBody></ns0:sp><ns0:sp><ns0:nvSpPr><ns0:cNvPr id="5" name="ChartArea"/><ns0:cNvSpPr><ns1:spLocks xmlns:ns1="http://schemas.openxmlformats.org/drawingml/2006/main" noGrp="1" noSelect="0" noRot="1" noMove="1"/></ns0:cNvSpPr><ns0:nvPr/></ns0:nvSpPr><ns0:spPr><ns2:xfrm xmlns:ns2="http://schemas.openxmlformats.org/drawingml/2006/main"><ns2:off x="457200" y="1280160"/><ns2:ext cx="6858000" cy="4937760"/></ns2:xfrm><ns3:prstGeom xmlns:ns3="http://schemas.openxmlformats.org/drawingml/2006/main" prst="roundRect"><ns3:avLst><ns3:gd name="adj" fmla="val 6000"/></ns3:avLst></ns3:prstGeom><ns4:solidFill xmlns:ns4="http://schemas.openxmlformats.org/drawingml/2006/main"><ns4:srgbClr val="EDF0F7"/></ns4:solidFill><ns5:ln xmlns:ns5="http://schemas.openxmlformats.org/drawingml/2006/main"><ns5:noFill/></ns5:ln></ns0:spPr></ns0:sp><ns0:sp><ns0:nvSpPr><ns0:cNvPr id="20" name="Body.Left"/><ns0:cNvSpPr><ns1:spLocks xmlns:ns1="http://schemas.openxmlformats.org/drawingml/2006/main" noGrp="1"/></ns0:cNvSpPr><ns0:nvPr><ns0:ph idx="1" type="body"/></ns0:nvPr></ns0:nvSpPr><ns0:spPr><ns2:xfrm xmlns:ns2="http://schemas.openxmlformats.org/drawingml/2006/main"><ns2:off x="731520" y="1463040"/><ns2:ext cx="6309360" cy="4572000"/></ns2:xfrm></ns0:spPr><ns0:txBody><ns3:bodyPr xmlns:ns3="http://schemas.openxmlformats.org/drawingml/2006/main" wrap="square" anchor="t" anchorCtr="0"/><ns4:lstStyle><ns4:defPPr algn="ctr"><ns4:defRPr><ns4:solidFill><ns4:srgbClr val="94A3B8"/></ns4:solidFill></ns4:defRPr></ns4:defPPr></ns4:lstStyle><ns4:defPPr algn="ctr"><ns4:buNone/><ns4:defRPr sz="1400" dirty="0"><ns4:solidFill><ns4:srgbClr val="94A3B8"/></ns4:solidFill><ns4:latin typeface="Calibri"/><ns4:ea typeface="Calibri"/></ns4:defRPr></ns4:defPPr><ns4:lvl1pPr algn="ctr"><ns4:buNone/><ns4:defRPr sz="1400" dirty="0"><ns4:solidFill><ns4:srgbClr val="94A3B8"/></ns4:solidFill><ns4:latin typeface="Calibri"/><ns4:ea typeface="Calibri"/></ns4:defRPr></ns4:lvl1pPr><ns4:lvl2pPr algn="ctr"><ns4:buNone/><ns4:defRPr sz="1400" dirty="0"><ns4:solidFill><ns4:srgbClr val="94A3B8"/></ns4:solidFill><ns4:latin typeface="Calibri"/><ns4:ea typeface="Calibri"/></ns4:defRPr></ns4:lvl2pPr><ns4:lvl3pPr algn="ctr"><ns4:buNone/><ns4:defRPr sz="1400" dirty="0"><ns4:solidFill><ns4:srgbClr val="94A3B8"/></ns4:solidFill><ns4:latin typeface="Calibri"/><ns4:ea typeface="Calibri"/></ns4:defRPr></ns4:lvl3pPr><ns4:lvl4pPr algn="ctr"><ns4:buNone/><ns4:defRPr sz="1400" dirty="0"><ns4:solidFill><ns4:srgbClr val="94A3B8"/></ns4:solidFill><ns4:latin typeface="Calibri"/><ns4:ea typeface="Calibri"/></ns4:defRPr></ns4:lvl4pPr><ns4:lvl5pPr algn="ctr"><ns4:buNone/><ns4:defRPr sz="1400" dirty="0"><ns4:solidFill><ns4:srgbClr val="94A3B8"/></ns4:solidFill><ns4:latin typeface="Calibri"/><ns4:ea typeface="Calibri"/></ns4:defRPr></ns4:lvl5pPr><ns4:lvl6pPr algn="ctr"><ns4:buNone/><ns4:defRPr sz="1400" dirty="0"><ns4:solidFill><ns4:srgbClr val="94A3B8"/></ns4:solidFill><ns4:latin typeface="Calibri"/><ns4:ea typeface="Calibri"/></ns4:defRPr></ns4:lvl6pPr><ns4:lvl7pPr algn="ctr"><ns4:buNone/><ns4:defRPr sz="1400" dirty="0"><ns4:solidFill><ns4:srgbClr val="94A3B8"/></ns4:solidFill><ns4:latin typeface="Calibri"/><ns4:ea typeface="Calibri"/></ns4:defRPr></ns4:lvl7pPr><ns4:lvl8pPr algn="ctr"><ns4:buNone/><ns4:defRPr sz="1400" dirty="0"><ns4:solidFill><ns4:srgbClr val="94A3B8"/></ns4:solidFill><ns4:latin typeface="Calibri"/><ns4:ea typeface="Calibri"/></ns4:defRPr></ns4:lvl8pPr><ns4:lvl9pPr algn="ctr"><ns4:buNone/><ns4:defRPr sz="1400" dirty="0"><ns4:solidFill><ns4:srgbClr val="94A3B8"/></ns4:solidFill><ns4:latin typeface="Calibri"/><ns4:ea typeface="Calibri"/></ns4:defRPr></ns4:lvl9pPr></ns4:lstStyle/><ns5:p xmlns:ns5="http://schemas.openxmlformats.org/drawingml/2006/main"><ns5:pPr algn="l"><ns5:buNone/></ns5:pPr><ns5:r><ns5:rPr lang="ja-JP"/><ns5:t>分析テキスト
-
-主要な発見事項や
-考察を記入</ns5:t></ns5:r></ns5:p></ns0:txBody></ns0:sp><ns0:sp><ns0:nvSpPr><ns0:cNvPr id="30" name="SlideNum.Footer"/><ns0:cNvSpPr><ns1:spLocks xmlns:ns1="http://schemas.openxmlformats.org/drawingml/2006/main" noGrp="1"/></ns0:cNvSpPr><ns0:nvPr><ns0:ph idx="50" type="sldNum"/></ns0:nvPr></ns0:nvSpPr><ns0:spPr><ns2:xfrm xmlns:ns2="http://schemas.openxmlformats.org/drawingml/2006/main"><ns2:off x="10972800" y="6446520"/><ns2:ext cx="1097280" cy="274320"/></ns2:xfrm></ns0:spPr><ns0:txBody><ns3:bodyPr xmlns:ns3="http://schemas.openxmlformats.org/drawingml/2006/main" wrap="square" anchor="t" anchorCtr="0"/><ns4:lstStyle><ns4:defPPr algn="r"><ns4:defRPr sz="1000"><ns4:solidFill><ns4:srgbClr val="94A3B8"/></ns4:solidFill></ns4:defRPr></ns4:defPPr></ns4:lstStyle><ns4:defPPr algn="r"><ns4:buNone/><ns4:defRPr sz="1000" dirty="0"><ns4:solidFill><ns4:srgbClr val="94A3B8"/></ns4:solidFill><ns4:latin typeface="Calibri"/><ns4:ea typeface="Calibri"/></ns4:defRPr></ns4:defPPr><ns4:lvl1pPr algn="r"><ns4:buNone/><ns4:defRPr sz="1000" dirty="0"><ns4:solidFill><ns4:srgbClr val="94A3B8"/></ns4:solidFill><ns4:latin typeface="Calibri"/><ns4:ea typeface="Calibri"/></ns4:defRPr></ns4:lvl1pPr><ns4:lvl2pPr algn="r"><ns4:buNone/><ns4:defRPr sz="1000" dirty="0"><ns4:solidFill><ns4:srgbClr val="94A3B8"/></ns4:solidFill><ns4:latin typeface="Calibri"/><ns4:ea typeface="Calibri"/></ns4:defRPr></ns4:lvl2pPr><ns4:lvl3pPr algn="r"><ns4:buNone/><ns4:defRPr sz="1000" dirty="0"><ns4:solidFill><ns4:srgbClr val="94A3B8"/></ns4:solidFill><ns4:latin typeface="Calibri"/><ns4:ea typeface="Calibri"/></ns4:defRPr></ns4:lvl3pPr><ns4:lvl4pPr algn="r"><ns4:buNone/><ns4:defRPr sz="1000" dirty="0"><ns4:solidFill><ns4:srgbClr val="94A3B8"/></ns4:solidFill><ns4:latin typeface="Calibri"/><ns4:ea typeface="Calibri"/></ns4:defRPr></ns4:lvl4pPr><ns4:lvl5pPr algn="r"><ns4:buNone/><ns4:defRPr sz="1000" dirty="0"><ns4:solidFill><ns4:srgbClr val="94A3B8"/></ns4:solidFill><ns4:latin typeface="Calibri"/><ns4:ea typeface="Calibri"/></ns4:defRPr></ns4:lvl5pPr><ns4:lvl6pPr algn="r"><ns4:buNone/><ns4:defRPr sz="1000" dirty="0"><ns4:solidFill><ns4:srgbClr val="94A3B8"/></ns4:solidFill><ns4:latin typeface="Calibri"/><ns4:ea typeface="Calibri"/></ns4:defRPr></ns4:lvl6pPr><ns4:lvl7pPr algn="r"><ns4:buNone/><ns4:defRPr sz="1000" dirty="0"><ns4:solidFill><ns4:srgbClr val="94A3B8"/></ns4:solidFill><ns4:latin typeface="Calibri"/><ns4:ea typeface="Calibri"/></ns4:defRPr></ns4:lvl7pPr><ns4:lvl8pPr algn="r"><ns4:buNone/><ns4:defRPr sz="1000" dirty="0"><ns4:solidFill><ns4:srgbClr val="94A3B8"/></ns4:solidFill><ns4:latin typeface="Calibri"/><ns4:ea typeface="Calibri"/></ns4:defRPr></ns4:lvl8pPr><ns4:lvl9pPr algn="r"><ns4:buNone/><ns4:defRPr sz="1000" dirty="0"><ns4:solidFill><ns4:srgbClr val="94A3B8"/></ns4:solidFill><ns4:latin typeface="Calibri"/><ns4:ea typeface="Calibri"/></ns4:defRPr></ns4:lvl9pPr></ns4:lstStyle><ns5:p xmlns:ns5="http://schemas.openxmlformats.org/drawingml/2006/main"><ns5:pPr algn="r"><ns5:buNone/></ns5:pPr><ns5:r><ns5:rPr lang="ja-JP"/><ns5:t>&lt;#&gt;</ns5:t></ns5:r></ns5:p></ns0:txBody></ns0:sp></ns0:spTree></ns0:cSld><ns0:clrMapOvr/></ns0:sldLayout>
+<file path=ppt/slideLayouts/slideLayout19.xml><?xml version='1.0' encoding='UTF-8' standalone='yes'?><p:sldLayout xmlns:a="http://schemas.openxmlformats.org/drawingml/2006/main" xmlns:p="http://schemas.openxmlformats.org/presentationml/2006/main" xmlns:r="http://schemas.openxmlformats.org/officeDocument/2006/relationships" type="blank" preserve="1"><p:cSld name="Chart.1Chart.Single+1Analysis"><p:spTree><p:nvGrpSpPr><p:cNvPr id="1" name=""/><p:cNvGrpSpPr/><p:nvPr/></p:nvGrpSpPr><p:grpSpPr><a:xfrm><a:off x="0" y="0"/><a:ext cx="0" cy="0"/><a:chOff x="0" y="0"/><a:chExt cx="0" cy="0"/></a:xfrm></p:grpSpPr><p:sp><p:nvSpPr><p:cNvPr id="2" name="HeaderBar"/><p:cNvSpPr><a:spLocks xmlns:ns1="http://schemas.openxmlformats.org/drawingml/2006/main" noGrp="1" noSelect="0" noRot="1" noMove="1"/></p:cNvSpPr><p:nvPr/></p:nvSpPr><p:spPr><a:xfrm xmlns:ns2="http://schemas.openxmlformats.org/drawingml/2006/main"><a:off x="0" y="0"/><a:ext cx="12192000" cy="1051560"/></a:xfrm><a:prstGeom xmlns:ns3="http://schemas.openxmlformats.org/drawingml/2006/main" prst="rect"/><a:solidFill xmlns:ns4="http://schemas.openxmlformats.org/drawingml/2006/main"><a:srgbClr val="1E2761"/></a:solidFill><a:ln xmlns:ns5="http://schemas.openxmlformats.org/drawingml/2006/main"><a:noFill/></a:ln></p:spPr></p:sp><p:sp><p:nvSpPr><p:cNvPr id="3" name="ChartArea"/><p:cNvSpPr><a:spLocks xmlns:ns1="http://schemas.openxmlformats.org/drawingml/2006/main" noGrp="1" noSelect="0" noRot="1" noMove="1"/></p:cNvSpPr><p:nvPr/></p:nvSpPr><p:spPr><a:xfrm xmlns:ns2="http://schemas.openxmlformats.org/drawingml/2006/main"><a:off x="457200" y="1280160"/><a:ext cx="6858000" cy="4937760"/></a:xfrm><a:prstGeom xmlns:ns3="http://schemas.openxmlformats.org/drawingml/2006/main" prst="roundRect"><a:avLst><a:gd name="adj" fmla="val 6000"/></a:avLst></p:prstGeom><a:solidFill xmlns:ns4="http://schemas.openxmlformats.org/drawingml/2006/main"><a:srgbClr val="EDF0F7"/></a:solidFill><a:ln xmlns:ns5="http://schemas.openxmlformats.org/drawingml/2006/main"><a:noFill/></a:ln></p:spPr></p:sp><p:sp><p:nvSpPr><p:cNvPr id="4" name="SlideTitle.Header"/><p:cNvSpPr><a:spLocks noGrp="1"/></p:cNvSpPr><p:nvPr><p:ph type="body" idx="15"/></p:nvPr></p:nvSpPr><p:spPr><a:xfrm><a:off x="731520" y="91440"/><a:ext cx="9144000" cy="475488"/></a:xfrm></p:spPr><p:txBody><a:bodyPr wrap="square" anchor="t" anchorCtr="0"/><a:lstStyle><a:defPPr><a:defRPr sz="2800" b="1"><a:solidFill><a:srgbClr val="FFFFFF"/></a:solidFill></a:defRPr></a:defPPr></a:lstStyle><a:p><a:r><a:rPr lang="ja-JP"/><a:t> </a:t></a:r></a:p></p:txBody></p:sp><p:sp><p:nvSpPr><p:cNvPr id="5" name="SlideSubtitle.Header"/><p:cNvSpPr><a:spLocks noGrp="1"/></p:cNvSpPr><p:nvPr><p:ph type="body" idx="16"/></p:nvPr></p:nvSpPr><p:spPr><a:xfrm><a:off x="731520" y="658368"/><a:ext cx="9144000" cy="274320"/></a:xfrm></p:spPr><p:txBody><a:bodyPr wrap="square" anchor="t" anchorCtr="0"/><a:lstStyle><a:defPPr><a:defRPr sz="1200"><a:solidFill><a:srgbClr val="CADCFC"/></a:solidFill></a:defRPr></a:defPPr></a:lstStyle><a:p><a:r><a:rPr lang="ja-JP"/><a:t> </a:t></a:r></a:p></p:txBody></p:sp><p:sp><p:nvSpPr><p:cNvPr id="6" name="Body.Left"/><p:cNvSpPr><a:spLocks noGrp="1"/></p:cNvSpPr><p:nvPr><p:ph type="body" idx="1"/></p:nvPr></p:nvSpPr><p:spPr><a:xfrm><a:off x="731520" y="1463040"/><a:ext cx="6309360" cy="4572000"/></a:xfrm></p:spPr><p:txBody><a:bodyPr wrap="square" anchor="t" anchorCtr="0"/><a:lstStyle><a:defPPr algn="ctr"><a:defRPr><a:solidFill><a:srgbClr val="94A3B8"/></a:solidFill></a:defRPr></a:defPPr></a:lstStyle><a:p><a:r><a:rPr lang="ja-JP"/><a:t> </a:t></a:r></a:p></p:txBody></p:sp><p:sp><p:nvSpPr><p:cNvPr id="7" name="Analysis.Right"/><p:cNvSpPr><a:spLocks noGrp="1"/></p:cNvSpPr><p:nvPr><p:ph type="body" idx="2"/></p:nvPr></p:nvSpPr><p:spPr><a:xfrm><a:off x="7680960" y="1371600"/><a:ext cx="4023360" cy="4846320"/></a:xfrm></p:spPr><p:txBody><a:bodyPr wrap="square" anchor="t" anchorCtr="0"/><a:lstStyle/><a:p><a:r><a:rPr lang="ja-JP"/><a:t> </a:t></a:r></a:p></p:txBody></p:sp><p:sp><p:nvSpPr><p:cNvPr id="8" name="SlideNum.Footer"/><p:cNvSpPr><a:spLocks noGrp="1"/></p:cNvSpPr><p:nvPr><p:ph type="sldNum" idx="50"/></p:nvPr></p:nvSpPr><p:spPr><a:xfrm><a:off x="10972800" y="6446520"/><a:ext cx="1097280" cy="274320"/></a:xfrm></p:spPr><p:txBody><a:bodyPr wrap="square" anchor="t" anchorCtr="0"/><a:lstStyle><a:defPPr algn="r"><a:defRPr sz="1000"><a:solidFill><a:srgbClr val="94A3B8"/></a:solidFill></a:defRPr></a:defPPr></a:lstStyle><a:p><a:r><a:rPr lang="ja-JP"/><a:t> </a:t></a:r></a:p></p:txBody></p:sp></p:spTree></p:cSld><p:clrMapOvr/></p:sldLayout>
 </file>
 
 <file path=ppt/slideLayouts/slideLayout2.xml><?xml version="1.0" encoding="utf-8"?>
-<p:sldLayout xmlns:a="http://schemas.openxmlformats.org/drawingml/2006/main" xmlns:r="http://schemas.openxmlformats.org/officeDocument/2006/relationships" xmlns:p="http://schemas.openxmlformats.org/presentationml/2006/main" type="title" preserve="1">
+<p:sldLayout xmlns:a="http://schemas.openxmlformats.org/drawingml/2006/main" xmlns:p="http://schemas.openxmlformats.org/presentationml/2006/main" xmlns:r="http://schemas.openxmlformats.org/officeDocument/2006/relationships" type="title" preserve="1">
   <p:cSld name="Title.1Title.Single+1Meta">
     <p:spTree>
       <p:nvGrpSpPr>
@@ -1005,12 +1371,12 @@
       </p:sp>
       <p:sp>
         <p:nvSpPr>
-          <p:cNvPr id="10" name="CategoryLabel.Top"/>
-          <p:cNvSpPr>
-            <a:spLocks noGrp="1"/>
-          </p:cNvSpPr>
-          <p:nvPr>
-            <p:ph idx="10" type="body"/>
+          <p:cNvPr id="5" name="CategoryLabel.Top"/>
+          <p:cNvSpPr>
+            <a:spLocks noGrp="1"/>
+          </p:cNvSpPr>
+          <p:nvPr>
+            <p:ph type="body" idx="10"/>
           </p:nvPr>
         </p:nvSpPr>
         <p:spPr>
@@ -1023,7 +1389,7 @@
           <a:bodyPr wrap="square" anchor="t" anchorCtr="0"/>
           <a:lstStyle>
             <a:defPPr>
-              <a:defRPr sz="1400" b="1">
+              <a:defRPr b="1">
                 <a:solidFill>
                   <a:srgbClr val="3B82F6"/>
                 </a:solidFill>
@@ -1031,24 +1397,21 @@
             </a:defPPr>
           </a:lstStyle>
           <a:p>
-            <a:pPr algn="l">
-              <a:buNone/>
-            </a:pPr>
-            <a:r>
-              <a:rPr lang="ja-JP"/>
-              <a:t>DATA ANALYSIS REPORT</a:t>
-            </a:r>
-          </a:p>
-        </p:txBody>
-      </p:sp>
-      <p:sp>
-        <p:nvSpPr>
-          <p:cNvPr id="11" name="Title.Left"/>
-          <p:cNvSpPr>
-            <a:spLocks noGrp="1"/>
-          </p:cNvSpPr>
-          <p:nvPr>
-            <p:ph idx="0" type="ctrTitle"/>
+            <a:r>
+              <a:rPr lang="ja-JP"/>
+              <a:t> </a:t>
+            </a:r>
+          </a:p>
+        </p:txBody>
+      </p:sp>
+      <p:sp>
+        <p:nvSpPr>
+          <p:cNvPr id="6" name="Title.Left"/>
+          <p:cNvSpPr>
+            <a:spLocks noGrp="1"/>
+          </p:cNvSpPr>
+          <p:nvPr>
+            <p:ph type="ctrTitle" idx="0"/>
           </p:nvPr>
         </p:nvSpPr>
         <p:spPr>
@@ -1059,30 +1422,23 @@
         </p:spPr>
         <p:txBody>
           <a:bodyPr wrap="square" anchor="t" anchorCtr="0"/>
-          <a:lstStyle>
-            <a:defPPr>
-              <a:defRPr sz="4400"/>
-            </a:defPPr>
-          </a:lstStyle>
-          <a:p>
-            <a:pPr algn="l">
-              <a:buNone/>
-            </a:pPr>
-            <a:r>
-              <a:rPr lang="ja-JP"/>
-              <a:t>レポートタイトル</a:t>
-            </a:r>
-          </a:p>
-        </p:txBody>
-      </p:sp>
-      <p:sp>
-        <p:nvSpPr>
-          <p:cNvPr id="12" name="Subtitle.Left"/>
-          <p:cNvSpPr>
-            <a:spLocks noGrp="1"/>
-          </p:cNvSpPr>
-          <p:nvPr>
-            <p:ph idx="1" type="subTitle"/>
+          <a:lstStyle/>
+          <a:p>
+            <a:r>
+              <a:rPr lang="ja-JP"/>
+              <a:t> </a:t>
+            </a:r>
+          </a:p>
+        </p:txBody>
+      </p:sp>
+      <p:sp>
+        <p:nvSpPr>
+          <p:cNvPr id="7" name="Subtitle.Left"/>
+          <p:cNvSpPr>
+            <a:spLocks noGrp="1"/>
+          </p:cNvSpPr>
+          <p:nvPr>
+            <p:ph type="subTitle" idx="1"/>
           </p:nvPr>
         </p:nvSpPr>
         <p:spPr>
@@ -1103,24 +1459,21 @@
             </a:defPPr>
           </a:lstStyle>
           <a:p>
-            <a:pPr algn="l">
-              <a:buNone/>
-            </a:pPr>
-            <a:r>
-              <a:rPr lang="ja-JP"/>
-              <a:t>サブタイトル</a:t>
-            </a:r>
-          </a:p>
-        </p:txBody>
-      </p:sp>
-      <p:sp>
-        <p:nvSpPr>
-          <p:cNvPr id="13" name="Meta.Right"/>
-          <p:cNvSpPr>
-            <a:spLocks noGrp="1"/>
-          </p:cNvSpPr>
-          <p:nvPr>
-            <p:ph idx="11" type="body"/>
+            <a:r>
+              <a:rPr lang="ja-JP"/>
+              <a:t> </a:t>
+            </a:r>
+          </a:p>
+        </p:txBody>
+      </p:sp>
+      <p:sp>
+        <p:nvSpPr>
+          <p:cNvPr id="8" name="Meta.Right"/>
+          <p:cNvSpPr>
+            <a:spLocks noGrp="1"/>
+          </p:cNvSpPr>
+          <p:nvPr>
+            <p:ph type="body" idx="11"/>
           </p:nvPr>
         </p:nvSpPr>
         <p:spPr>
@@ -1141,28 +1494,21 @@
             </a:defPPr>
           </a:lstStyle>
           <a:p>
-            <a:pPr algn="l">
-              <a:buNone/>
-            </a:pPr>
-            <a:r>
-              <a:rPr lang="ja-JP"/>
-              <a:t>作成日：
-作成者：
-バージョン：
-ステータス：
-配布先：</a:t>
-            </a:r>
-          </a:p>
-        </p:txBody>
-      </p:sp>
-      <p:sp>
-        <p:nvSpPr>
-          <p:cNvPr id="14" name="Footer.Bottom"/>
-          <p:cNvSpPr>
-            <a:spLocks noGrp="1"/>
-          </p:cNvSpPr>
-          <p:nvPr>
-            <p:ph idx="12" type="body"/>
+            <a:r>
+              <a:rPr lang="ja-JP"/>
+              <a:t> </a:t>
+            </a:r>
+          </a:p>
+        </p:txBody>
+      </p:sp>
+      <p:sp>
+        <p:nvSpPr>
+          <p:cNvPr id="9" name="Footer.Bottom"/>
+          <p:cNvSpPr>
+            <a:spLocks noGrp="1"/>
+          </p:cNvSpPr>
+          <p:nvPr>
+            <p:ph type="body" idx="12"/>
           </p:nvPr>
         </p:nvSpPr>
         <p:spPr>
@@ -1183,12 +1529,9 @@
             </a:defPPr>
           </a:lstStyle>
           <a:p>
-            <a:pPr algn="l">
-              <a:buNone/>
-            </a:pPr>
-            <a:r>
-              <a:rPr lang="ja-JP"/>
-              <a:t>Confidential</a:t>
+            <a:r>
+              <a:rPr lang="ja-JP"/>
+              <a:t> </a:t>
             </a:r>
           </a:p>
         </p:txBody>
@@ -1199,70 +1542,1727 @@
 </p:sldLayout>
 </file>
 
-<file path=ppt/slideLayouts/slideLayout20.xml><?xml version='1.0' encoding='UTF-8' standalone='yes'?>
-<ns0:sldLayout xmlns:ns0="http://schemas.openxmlformats.org/presentationml/2006/main" type="blank" preserve="1"><ns0:cSld name="Chart.2Chart.Equal"><ns0:spTree><ns0:nvGrpSpPr><ns0:cNvPr id="1" name=""/><ns0:cNvGrpSpPr/><ns0:nvPr/></ns0:nvGrpSpPr><ns0:grpSpPr><ns1:xfrm xmlns:ns1="http://schemas.openxmlformats.org/drawingml/2006/main"><ns1:off x="0" y="0"/><ns1:ext cx="0" cy="0"/><ns1:chOff x="0" y="0"/><ns1:chExt cx="0" cy="0"/></ns1:xfrm></ns0:grpSpPr><ns0:sp><ns0:nvSpPr><ns0:cNvPr id="2" name="HeaderBar"/><ns0:cNvSpPr><ns1:spLocks xmlns:ns1="http://schemas.openxmlformats.org/drawingml/2006/main" noGrp="1" noSelect="0" noRot="1" noMove="1"/></ns0:cNvSpPr><ns0:nvPr/></ns0:nvSpPr><ns0:spPr><ns2:xfrm xmlns:ns2="http://schemas.openxmlformats.org/drawingml/2006/main"><ns2:off x="0" y="0"/><ns2:ext cx="12192000" cy="1051560"/></ns2:xfrm><ns3:prstGeom xmlns:ns3="http://schemas.openxmlformats.org/drawingml/2006/main" prst="rect"/><ns4:solidFill xmlns:ns4="http://schemas.openxmlformats.org/drawingml/2006/main"><ns4:srgbClr val="1E2761"/></ns4:solidFill><ns5:ln xmlns:ns5="http://schemas.openxmlformats.org/drawingml/2006/main"><ns5:noFill/></ns5:ln></ns0:spPr></ns0:sp><ns0:sp><ns0:nvSpPr><ns0:cNvPr id="10" name="SlideTitle.Header"/><ns0:cNvSpPr><ns1:spLocks xmlns:ns1="http://schemas.openxmlformats.org/drawingml/2006/main" noGrp="1"/></ns0:cNvSpPr><ns0:nvPr><ns0:ph idx="15" type="body"/></ns0:nvPr></ns0:nvSpPr><ns0:spPr><ns2:xfrm xmlns:ns2="http://schemas.openxmlformats.org/drawingml/2006/main"><ns2:off x="731520" y="91440"/><ns2:ext cx="9144000" cy="475488"/></ns2:xfrm></ns0:spPr><ns0:txBody><ns3:bodyPr xmlns:ns3="http://schemas.openxmlformats.org/drawingml/2006/main" wrap="square" anchor="t" anchorCtr="0"/><ns4:lstStyle><ns4:defPPr><ns4:defRPr sz="2800" b="1"><ns4:solidFill><ns4:srgbClr val="FFFFFF"/></ns4:solidFill></ns4:defRPr></ns4:defPPr></ns4:lstStyle><ns4:defPPr algn="l"><ns4:buNone/><ns4:defRPr sz="2800" dirty="0" b="1"><ns4:solidFill><ns4:srgbClr val="FFFFFF"/></ns4:solidFill><ns4:latin typeface="Georgia"/><ns4:ea typeface="Georgia"/></ns4:defRPr></ns4:defPPr><ns4:lvl1pPr algn="l"><ns4:buNone/><ns4:defRPr sz="2800" dirty="0" b="1"><ns4:solidFill><ns4:srgbClr val="FFFFFF"/></ns4:solidFill><ns4:latin typeface="Georgia"/><ns4:ea typeface="Georgia"/></ns4:defRPr></ns4:lvl1pPr><ns4:lvl2pPr algn="l"><ns4:buNone/><ns4:defRPr sz="2800" dirty="0" b="1"><ns4:solidFill><ns4:srgbClr val="FFFFFF"/></ns4:solidFill><ns4:latin typeface="Georgia"/><ns4:ea typeface="Georgia"/></ns4:defRPr></ns4:lvl2pPr><ns4:lvl3pPr algn="l"><ns4:buNone/><ns4:defRPr sz="2800" dirty="0" b="1"><ns4:solidFill><ns4:srgbClr val="FFFFFF"/></ns4:solidFill><ns4:latin typeface="Georgia"/><ns4:ea typeface="Georgia"/></ns4:defRPr></ns4:lvl3pPr><ns4:lvl4pPr algn="l"><ns4:buNone/><ns4:defRPr sz="2800" dirty="0" b="1"><ns4:solidFill><ns4:srgbClr val="FFFFFF"/></ns4:solidFill><ns4:latin typeface="Georgia"/><ns4:ea typeface="Georgia"/></ns4:defRPr></ns4:lvl4pPr><ns4:lvl5pPr algn="l"><ns4:buNone/><ns4:defRPr sz="2800" dirty="0" b="1"><ns4:solidFill><ns4:srgbClr val="FFFFFF"/></ns4:solidFill><ns4:latin typeface="Georgia"/><ns4:ea typeface="Georgia"/></ns4:defRPr></ns4:lvl5pPr><ns4:lvl6pPr algn="l"><ns4:buNone/><ns4:defRPr sz="2800" dirty="0" b="1"><ns4:solidFill><ns4:srgbClr val="FFFFFF"/></ns4:solidFill><ns4:latin typeface="Georgia"/><ns4:ea typeface="Georgia"/></ns4:defRPr></ns4:lvl6pPr><ns4:lvl7pPr algn="l"><ns4:buNone/><ns4:defRPr sz="2800" dirty="0" b="1"><ns4:solidFill><ns4:srgbClr val="FFFFFF"/></ns4:solidFill><ns4:latin typeface="Georgia"/><ns4:ea typeface="Georgia"/></ns4:defRPr></ns4:lvl7pPr><ns4:lvl8pPr algn="l"><ns4:buNone/><ns4:defRPr sz="2800" dirty="0" b="1"><ns4:solidFill><ns4:srgbClr val="FFFFFF"/></ns4:solidFill><ns4:latin typeface="Georgia"/><ns4:ea typeface="Georgia"/></ns4:defRPr></ns4:lvl8pPr><ns4:lvl9pPr algn="l"><ns4:buNone/><ns4:defRPr sz="2800" dirty="0" b="1"><ns4:solidFill><ns4:srgbClr val="FFFFFF"/></ns4:solidFill><ns4:latin typeface="Georgia"/><ns4:ea typeface="Georgia"/></ns4:defRPr></ns4:lvl9pPr></ns4:lstStyle/><ns5:p xmlns:ns5="http://schemas.openxmlformats.org/drawingml/2006/main"><ns5:pPr algn="l"><ns5:buNone/></ns5:pPr><ns5:r><ns5:rPr lang="ja-JP"/><ns5:t>サブタイトル</ns5:t></ns5:r></ns5:p></ns0:txBody></ns0:sp><ns0:sp><ns0:nvSpPr><ns0:cNvPr id="5" name="ChartL"/><ns0:cNvSpPr><ns1:spLocks xmlns:ns1="http://schemas.openxmlformats.org/drawingml/2006/main" noGrp="1" noSelect="0" noRot="1" noMove="1"/></ns0:cNvSpPr><ns0:nvPr/></ns0:nvSpPr><ns0:spPr><ns2:xfrm xmlns:ns2="http://schemas.openxmlformats.org/drawingml/2006/main"><ns2:off x="457200" y="1280160"/><ns2:ext cx="5394960" cy="4937760"/></ns2:xfrm><ns3:prstGeom xmlns:ns3="http://schemas.openxmlformats.org/drawingml/2006/main" prst="roundRect"><ns3:avLst><ns3:gd name="adj" fmla="val 6000"/></ns3:avLst></ns3:prstGeom><ns4:solidFill xmlns:ns4="http://schemas.openxmlformats.org/drawingml/2006/main"><ns4:srgbClr val="EDF0F7"/></ns4:solidFill><ns5:ln xmlns:ns5="http://schemas.openxmlformats.org/drawingml/2006/main"><ns5:noFill/></ns5:ln></ns0:spPr></ns0:sp><ns0:sp><ns0:nvSpPr><ns0:cNvPr id="6" name="ChartR"/><ns0:cNvSpPr><ns1:spLocks xmlns:ns1="http://schemas.openxmlformats.org/drawingml/2006/main" noGrp="1" noSelect="0" noRot="1" noMove="1"/></ns0:cNvSpPr><ns0:nvPr/></ns0:nvSpPr><ns0:spPr><ns2:xfrm xmlns:ns2="http://schemas.openxmlformats.org/drawingml/2006/main"><ns2:off x="6126480" y="1280160"/><ns2:ext cx="5394960" cy="4937760"/></ns2:xfrm><ns3:prstGeom xmlns:ns3="http://schemas.openxmlformats.org/drawingml/2006/main" prst="roundRect"><ns3:avLst><ns3:gd name="adj" fmla="val 6000"/></ns3:avLst></ns3:prstGeom><ns4:solidFill xmlns:ns4="http://schemas.openxmlformats.org/drawingml/2006/main"><ns4:srgbClr val="EDF0F7"/></ns4:solidFill><ns5:ln xmlns:ns5="http://schemas.openxmlformats.org/drawingml/2006/main"><ns5:noFill/></ns5:ln></ns0:spPr></ns0:sp><ns0:sp><ns0:nvSpPr><ns0:cNvPr id="20" name="Body1.Left"/><ns0:cNvSpPr><ns1:spLocks xmlns:ns1="http://schemas.openxmlformats.org/drawingml/2006/main" noGrp="1"/></ns0:cNvSpPr><ns0:nvPr><ns0:ph idx="1" type="body"/></ns0:nvPr></ns0:nvSpPr><ns0:spPr><ns2:xfrm xmlns:ns2="http://schemas.openxmlformats.org/drawingml/2006/main"><ns2:off x="731520" y="1463040"/><ns2:ext cx="4846320" cy="4572000"/></ns2:xfrm></ns0:spPr><ns0:txBody><ns3:bodyPr xmlns:ns3="http://schemas.openxmlformats.org/drawingml/2006/main" wrap="square" anchor="t" anchorCtr="0"/><ns4:lstStyle><ns4:defPPr algn="ctr"><ns4:defRPr><ns4:solidFill><ns4:srgbClr val="94A3B8"/></ns4:solidFill></ns4:defRPr></ns4:defPPr></ns4:lstStyle><ns4:defPPr algn="ctr"><ns4:buNone/><ns4:defRPr sz="1400" dirty="0"><ns4:solidFill><ns4:srgbClr val="94A3B8"/></ns4:solidFill><ns4:latin typeface="Calibri"/><ns4:ea typeface="Calibri"/></ns4:defRPr></ns4:defPPr><ns4:lvl1pPr algn="ctr"><ns4:buNone/><ns4:defRPr sz="1400" dirty="0"><ns4:solidFill><ns4:srgbClr val="94A3B8"/></ns4:solidFill><ns4:latin typeface="Calibri"/><ns4:ea typeface="Calibri"/></ns4:defRPr></ns4:lvl1pPr><ns4:lvl2pPr algn="ctr"><ns4:buNone/><ns4:defRPr sz="1400" dirty="0"><ns4:solidFill><ns4:srgbClr val="94A3B8"/></ns4:solidFill><ns4:latin typeface="Calibri"/><ns4:ea typeface="Calibri"/></ns4:defRPr></ns4:lvl2pPr><ns4:lvl3pPr algn="ctr"><ns4:buNone/><ns4:defRPr sz="1400" dirty="0"><ns4:solidFill><ns4:srgbClr val="94A3B8"/></ns4:solidFill><ns4:latin typeface="Calibri"/><ns4:ea typeface="Calibri"/></ns4:defRPr></ns4:lvl3pPr><ns4:lvl4pPr algn="ctr"><ns4:buNone/><ns4:defRPr sz="1400" dirty="0"><ns4:solidFill><ns4:srgbClr val="94A3B8"/></ns4:solidFill><ns4:latin typeface="Calibri"/><ns4:ea typeface="Calibri"/></ns4:defRPr></ns4:lvl4pPr><ns4:lvl5pPr algn="ctr"><ns4:buNone/><ns4:defRPr sz="1400" dirty="0"><ns4:solidFill><ns4:srgbClr val="94A3B8"/></ns4:solidFill><ns4:latin typeface="Calibri"/><ns4:ea typeface="Calibri"/></ns4:defRPr></ns4:lvl5pPr><ns4:lvl6pPr algn="ctr"><ns4:buNone/><ns4:defRPr sz="1400" dirty="0"><ns4:solidFill><ns4:srgbClr val="94A3B8"/></ns4:solidFill><ns4:latin typeface="Calibri"/><ns4:ea typeface="Calibri"/></ns4:defRPr></ns4:lvl6pPr><ns4:lvl7pPr algn="ctr"><ns4:buNone/><ns4:defRPr sz="1400" dirty="0"><ns4:solidFill><ns4:srgbClr val="94A3B8"/></ns4:solidFill><ns4:latin typeface="Calibri"/><ns4:ea typeface="Calibri"/></ns4:defRPr></ns4:lvl7pPr><ns4:lvl8pPr algn="ctr"><ns4:buNone/><ns4:defRPr sz="1400" dirty="0"><ns4:solidFill><ns4:srgbClr val="94A3B8"/></ns4:solidFill><ns4:latin typeface="Calibri"/><ns4:ea typeface="Calibri"/></ns4:defRPr></ns4:lvl8pPr><ns4:lvl9pPr algn="ctr"><ns4:buNone/><ns4:defRPr sz="1400" dirty="0"><ns4:solidFill><ns4:srgbClr val="94A3B8"/></ns4:solidFill><ns4:latin typeface="Calibri"/><ns4:ea typeface="Calibri"/></ns4:defRPr></ns4:lvl9pPr></ns4:lstStyle/><ns5:p xmlns:ns5="http://schemas.openxmlformats.org/drawingml/2006/main"><ns5:pPr algn="ctr"><ns5:buNone/></ns5:pPr><ns5:r><ns5:rPr lang="ja-JP"/><ns5:t>チャート 2</ns5:t></ns5:r></ns5:p></ns0:txBody></ns0:sp><ns0:sp><ns0:nvSpPr><ns0:cNvPr id="30" name="SlideNum.Footer"/><ns0:cNvSpPr><ns1:spLocks xmlns:ns1="http://schemas.openxmlformats.org/drawingml/2006/main" noGrp="1"/></ns0:cNvSpPr><ns0:nvPr><ns0:ph idx="50" type="sldNum"/></ns0:nvPr></ns0:nvSpPr><ns0:spPr><ns2:xfrm xmlns:ns2="http://schemas.openxmlformats.org/drawingml/2006/main"><ns2:off x="10972800" y="6446520"/><ns2:ext cx="1097280" cy="274320"/></ns2:xfrm></ns0:spPr><ns0:txBody><ns3:bodyPr xmlns:ns3="http://schemas.openxmlformats.org/drawingml/2006/main" wrap="square" anchor="t" anchorCtr="0"/><ns4:lstStyle><ns4:defPPr algn="r"><ns4:defRPr sz="1000"><ns4:solidFill><ns4:srgbClr val="94A3B8"/></ns4:solidFill></ns4:defRPr></ns4:defPPr></ns4:lstStyle><ns4:defPPr algn="r"><ns4:buNone/><ns4:defRPr sz="1000" dirty="0"><ns4:solidFill><ns4:srgbClr val="94A3B8"/></ns4:solidFill><ns4:latin typeface="Calibri"/><ns4:ea typeface="Calibri"/></ns4:defRPr></ns4:defPPr><ns4:lvl1pPr algn="r"><ns4:buNone/><ns4:defRPr sz="1000" dirty="0"><ns4:solidFill><ns4:srgbClr val="94A3B8"/></ns4:solidFill><ns4:latin typeface="Calibri"/><ns4:ea typeface="Calibri"/></ns4:defRPr></ns4:lvl1pPr><ns4:lvl2pPr algn="r"><ns4:buNone/><ns4:defRPr sz="1000" dirty="0"><ns4:solidFill><ns4:srgbClr val="94A3B8"/></ns4:solidFill><ns4:latin typeface="Calibri"/><ns4:ea typeface="Calibri"/></ns4:defRPr></ns4:lvl2pPr><ns4:lvl3pPr algn="r"><ns4:buNone/><ns4:defRPr sz="1000" dirty="0"><ns4:solidFill><ns4:srgbClr val="94A3B8"/></ns4:solidFill><ns4:latin typeface="Calibri"/><ns4:ea typeface="Calibri"/></ns4:defRPr></ns4:lvl3pPr><ns4:lvl4pPr algn="r"><ns4:buNone/><ns4:defRPr sz="1000" dirty="0"><ns4:solidFill><ns4:srgbClr val="94A3B8"/></ns4:solidFill><ns4:latin typeface="Calibri"/><ns4:ea typeface="Calibri"/></ns4:defRPr></ns4:lvl4pPr><ns4:lvl5pPr algn="r"><ns4:buNone/><ns4:defRPr sz="1000" dirty="0"><ns4:solidFill><ns4:srgbClr val="94A3B8"/></ns4:solidFill><ns4:latin typeface="Calibri"/><ns4:ea typeface="Calibri"/></ns4:defRPr></ns4:lvl5pPr><ns4:lvl6pPr algn="r"><ns4:buNone/><ns4:defRPr sz="1000" dirty="0"><ns4:solidFill><ns4:srgbClr val="94A3B8"/></ns4:solidFill><ns4:latin typeface="Calibri"/><ns4:ea typeface="Calibri"/></ns4:defRPr></ns4:lvl6pPr><ns4:lvl7pPr algn="r"><ns4:buNone/><ns4:defRPr sz="1000" dirty="0"><ns4:solidFill><ns4:srgbClr val="94A3B8"/></ns4:solidFill><ns4:latin typeface="Calibri"/><ns4:ea typeface="Calibri"/></ns4:defRPr></ns4:lvl7pPr><ns4:lvl8pPr algn="r"><ns4:buNone/><ns4:defRPr sz="1000" dirty="0"><ns4:solidFill><ns4:srgbClr val="94A3B8"/></ns4:solidFill><ns4:latin typeface="Calibri"/><ns4:ea typeface="Calibri"/></ns4:defRPr></ns4:lvl8pPr><ns4:lvl9pPr algn="r"><ns4:buNone/><ns4:defRPr sz="1000" dirty="0"><ns4:solidFill><ns4:srgbClr val="94A3B8"/></ns4:solidFill><ns4:latin typeface="Calibri"/><ns4:ea typeface="Calibri"/></ns4:defRPr></ns4:lvl9pPr></ns4:lstStyle><ns5:p xmlns:ns5="http://schemas.openxmlformats.org/drawingml/2006/main"><ns5:pPr algn="r"><ns5:buNone/></ns5:pPr><ns5:r><ns5:rPr lang="ja-JP"/><ns5:t>&lt;#&gt;</ns5:t></ns5:r></ns5:p></ns0:txBody></ns0:sp></ns0:spTree></ns0:cSld><ns0:clrMapOvr/></ns0:sldLayout>
+<file path=ppt/slideLayouts/slideLayout20.xml><?xml version='1.0' encoding='UTF-8' standalone='yes'?><p:sldLayout xmlns:a="http://schemas.openxmlformats.org/drawingml/2006/main" xmlns:p="http://schemas.openxmlformats.org/presentationml/2006/main" xmlns:r="http://schemas.openxmlformats.org/officeDocument/2006/relationships" type="blank" preserve="1"><p:cSld name="Chart.2Chart.Equal"><p:spTree><p:nvGrpSpPr><p:cNvPr id="1" name=""/><p:cNvGrpSpPr/><p:nvPr/></p:nvGrpSpPr><p:grpSpPr><a:xfrm><a:off x="0" y="0"/><a:ext cx="0" cy="0"/><a:chOff x="0" y="0"/><a:chExt cx="0" cy="0"/></a:xfrm></p:grpSpPr><p:sp><p:nvSpPr><p:cNvPr id="2" name="HeaderBar"/><p:cNvSpPr><a:spLocks xmlns:ns1="http://schemas.openxmlformats.org/drawingml/2006/main" noGrp="1" noSelect="0" noRot="1" noMove="1"/></p:cNvSpPr><p:nvPr/></p:nvSpPr><p:spPr><a:xfrm xmlns:ns2="http://schemas.openxmlformats.org/drawingml/2006/main"><a:off x="0" y="0"/><a:ext cx="12192000" cy="1051560"/></a:xfrm><a:prstGeom xmlns:ns3="http://schemas.openxmlformats.org/drawingml/2006/main" prst="rect"/><a:solidFill xmlns:ns4="http://schemas.openxmlformats.org/drawingml/2006/main"><a:srgbClr val="1E2761"/></a:solidFill><a:ln xmlns:ns5="http://schemas.openxmlformats.org/drawingml/2006/main"><a:noFill/></a:ln></p:spPr></p:sp><p:sp><p:nvSpPr><p:cNvPr id="3" name="ChartL"/><p:cNvSpPr><a:spLocks xmlns:ns1="http://schemas.openxmlformats.org/drawingml/2006/main" noGrp="1" noSelect="0" noRot="1" noMove="1"/></p:cNvSpPr><p:nvPr/></p:nvSpPr><p:spPr><a:xfrm xmlns:ns2="http://schemas.openxmlformats.org/drawingml/2006/main"><a:off x="457200" y="1280160"/><a:ext cx="5394960" cy="4937760"/></a:xfrm><a:prstGeom xmlns:ns3="http://schemas.openxmlformats.org/drawingml/2006/main" prst="roundRect"><a:avLst><a:gd name="adj" fmla="val 6000"/></a:avLst></p:prstGeom><a:solidFill xmlns:ns4="http://schemas.openxmlformats.org/drawingml/2006/main"><a:srgbClr val="EDF0F7"/></a:solidFill><a:ln xmlns:ns5="http://schemas.openxmlformats.org/drawingml/2006/main"><a:noFill/></a:ln></p:spPr></p:sp><p:sp><p:nvSpPr><p:cNvPr id="4" name="ChartR"/><p:cNvSpPr><a:spLocks xmlns:ns1="http://schemas.openxmlformats.org/drawingml/2006/main" noGrp="1" noSelect="0" noRot="1" noMove="1"/></p:cNvSpPr><p:nvPr/></p:nvSpPr><p:spPr><a:xfrm xmlns:ns2="http://schemas.openxmlformats.org/drawingml/2006/main"><a:off x="6126480" y="1280160"/><a:ext cx="5394960" cy="4937760"/></a:xfrm><a:prstGeom xmlns:ns3="http://schemas.openxmlformats.org/drawingml/2006/main" prst="roundRect"><a:avLst><a:gd name="adj" fmla="val 6000"/></a:avLst></p:prstGeom><a:solidFill xmlns:ns4="http://schemas.openxmlformats.org/drawingml/2006/main"><a:srgbClr val="EDF0F7"/></a:solidFill><a:ln xmlns:ns5="http://schemas.openxmlformats.org/drawingml/2006/main"><a:noFill/></a:ln></p:spPr></p:sp><p:sp><p:nvSpPr><p:cNvPr id="5" name="SlideTitle.Header"/><p:cNvSpPr><a:spLocks noGrp="1"/></p:cNvSpPr><p:nvPr><p:ph type="body" idx="15"/></p:nvPr></p:nvSpPr><p:spPr><a:xfrm><a:off x="731520" y="91440"/><a:ext cx="9144000" cy="475488"/></a:xfrm></p:spPr><p:txBody><a:bodyPr wrap="square" anchor="t" anchorCtr="0"/><a:lstStyle><a:defPPr><a:defRPr sz="2800" b="1"><a:solidFill><a:srgbClr val="FFFFFF"/></a:solidFill></a:defRPr></a:defPPr></a:lstStyle><a:p><a:r><a:rPr lang="ja-JP"/><a:t> </a:t></a:r></a:p></p:txBody></p:sp><p:sp><p:nvSpPr><p:cNvPr id="6" name="SlideSubtitle.Header"/><p:cNvSpPr><a:spLocks noGrp="1"/></p:cNvSpPr><p:nvPr><p:ph type="body" idx="16"/></p:nvPr></p:nvSpPr><p:spPr><a:xfrm><a:off x="731520" y="658368"/><a:ext cx="9144000" cy="274320"/></a:xfrm></p:spPr><p:txBody><a:bodyPr wrap="square" anchor="t" anchorCtr="0"/><a:lstStyle><a:defPPr><a:defRPr sz="1200"><a:solidFill><a:srgbClr val="CADCFC"/></a:solidFill></a:defRPr></a:defPPr></a:lstStyle><a:p><a:r><a:rPr lang="ja-JP"/><a:t> </a:t></a:r></a:p></p:txBody></p:sp><p:sp><p:nvSpPr><p:cNvPr id="7" name="Body1.Left"/><p:cNvSpPr><a:spLocks noGrp="1"/></p:cNvSpPr><p:nvPr><p:ph type="body" idx="1"/></p:nvPr></p:nvSpPr><p:spPr><a:xfrm><a:off x="731520" y="1463040"/><a:ext cx="4846320" cy="4572000"/></a:xfrm></p:spPr><p:txBody><a:bodyPr wrap="square" anchor="t" anchorCtr="0"/><a:lstStyle><a:defPPr algn="ctr"><a:defRPr><a:solidFill><a:srgbClr val="94A3B8"/></a:solidFill></a:defRPr></a:defPPr></a:lstStyle><a:p><a:r><a:rPr lang="ja-JP"/><a:t> </a:t></a:r></a:p></p:txBody></p:sp><p:sp><p:nvSpPr><p:cNvPr id="8" name="Body2.Right"/><p:cNvSpPr><a:spLocks noGrp="1"/></p:cNvSpPr><p:nvPr><p:ph type="body" idx="2"/></p:nvPr></p:nvSpPr><p:spPr><a:xfrm><a:off x="6400800" y="1463040"/><a:ext cx="4846320" cy="4572000"/></a:xfrm></p:spPr><p:txBody><a:bodyPr wrap="square" anchor="t" anchorCtr="0"/><a:lstStyle><a:defPPr algn="ctr"><a:defRPr><a:solidFill><a:srgbClr val="94A3B8"/></a:solidFill></a:defRPr></a:defPPr></a:lstStyle><a:p><a:r><a:rPr lang="ja-JP"/><a:t> </a:t></a:r></a:p></p:txBody></p:sp><p:sp><p:nvSpPr><p:cNvPr id="9" name="SlideNum.Footer"/><p:cNvSpPr><a:spLocks noGrp="1"/></p:cNvSpPr><p:nvPr><p:ph type="sldNum" idx="50"/></p:nvPr></p:nvSpPr><p:spPr><a:xfrm><a:off x="10972800" y="6446520"/><a:ext cx="1097280" cy="274320"/></a:xfrm></p:spPr><p:txBody><a:bodyPr wrap="square" anchor="t" anchorCtr="0"/><a:lstStyle><a:defPPr algn="r"><a:defRPr sz="1000"><a:solidFill><a:srgbClr val="94A3B8"/></a:solidFill></a:defRPr></a:defPPr></a:lstStyle><a:p><a:r><a:rPr lang="ja-JP"/><a:t> </a:t></a:r></a:p></p:txBody></p:sp></p:spTree></p:cSld><p:clrMapOvr/></p:sldLayout>
 </file>
 
-<file path=ppt/slideLayouts/slideLayout21.xml><?xml version='1.0' encoding='UTF-8' standalone='yes'?>
-<ns0:sldLayout xmlns:ns0="http://schemas.openxmlformats.org/presentationml/2006/main" type="blank" preserve="1"><ns0:cSld name="Table.1Table.Single+1Source"><ns0:spTree><ns0:nvGrpSpPr><ns0:cNvPr id="1" name=""/><ns0:cNvGrpSpPr/><ns0:nvPr/></ns0:nvGrpSpPr><ns0:grpSpPr><ns1:xfrm xmlns:ns1="http://schemas.openxmlformats.org/drawingml/2006/main"><ns1:off x="0" y="0"/><ns1:ext cx="0" cy="0"/><ns1:chOff x="0" y="0"/><ns1:chExt cx="0" cy="0"/></ns1:xfrm></ns0:grpSpPr><ns0:sp><ns0:nvSpPr><ns0:cNvPr id="2" name="HeaderBar"/><ns0:cNvSpPr><ns1:spLocks xmlns:ns1="http://schemas.openxmlformats.org/drawingml/2006/main" noGrp="1" noSelect="0" noRot="1" noMove="1"/></ns0:cNvSpPr><ns0:nvPr/></ns0:nvSpPr><ns0:spPr><ns2:xfrm xmlns:ns2="http://schemas.openxmlformats.org/drawingml/2006/main"><ns2:off x="0" y="0"/><ns2:ext cx="12192000" cy="1051560"/></ns2:xfrm><ns3:prstGeom xmlns:ns3="http://schemas.openxmlformats.org/drawingml/2006/main" prst="rect"/><ns4:solidFill xmlns:ns4="http://schemas.openxmlformats.org/drawingml/2006/main"><ns4:srgbClr val="1E2761"/></ns4:solidFill><ns5:ln xmlns:ns5="http://schemas.openxmlformats.org/drawingml/2006/main"><ns5:noFill/></ns5:ln></ns0:spPr></ns0:sp><ns0:sp><ns0:nvSpPr><ns0:cNvPr id="10" name="SlideTitle.Header"/><ns0:cNvSpPr><ns1:spLocks xmlns:ns1="http://schemas.openxmlformats.org/drawingml/2006/main" noGrp="1"/></ns0:cNvSpPr><ns0:nvPr><ns0:ph idx="15" type="body"/></ns0:nvPr></ns0:nvSpPr><ns0:spPr><ns2:xfrm xmlns:ns2="http://schemas.openxmlformats.org/drawingml/2006/main"><ns2:off x="731520" y="91440"/><ns2:ext cx="9144000" cy="475488"/></ns2:xfrm></ns0:spPr><ns0:txBody><ns3:bodyPr xmlns:ns3="http://schemas.openxmlformats.org/drawingml/2006/main" wrap="square" anchor="t" anchorCtr="0"/><ns4:lstStyle><ns4:defPPr><ns4:defRPr sz="2800" b="1"><ns4:solidFill><ns4:srgbClr val="FFFFFF"/></ns4:solidFill></ns4:defRPr></ns4:defPPr></ns4:lstStyle><ns4:defPPr algn="l"><ns4:buNone/><ns4:defRPr sz="2800" dirty="0" b="1"><ns4:solidFill><ns4:srgbClr val="FFFFFF"/></ns4:solidFill><ns4:latin typeface="Georgia"/><ns4:ea typeface="Georgia"/></ns4:defRPr></ns4:defPPr><ns4:lvl1pPr algn="l"><ns4:buNone/><ns4:defRPr sz="2800" dirty="0" b="1"><ns4:solidFill><ns4:srgbClr val="FFFFFF"/></ns4:solidFill><ns4:latin typeface="Georgia"/><ns4:ea typeface="Georgia"/></ns4:defRPr></ns4:lvl1pPr><ns4:lvl2pPr algn="l"><ns4:buNone/><ns4:defRPr sz="2800" dirty="0" b="1"><ns4:solidFill><ns4:srgbClr val="FFFFFF"/></ns4:solidFill><ns4:latin typeface="Georgia"/><ns4:ea typeface="Georgia"/></ns4:defRPr></ns4:lvl2pPr><ns4:lvl3pPr algn="l"><ns4:buNone/><ns4:defRPr sz="2800" dirty="0" b="1"><ns4:solidFill><ns4:srgbClr val="FFFFFF"/></ns4:solidFill><ns4:latin typeface="Georgia"/><ns4:ea typeface="Georgia"/></ns4:defRPr></ns4:lvl3pPr><ns4:lvl4pPr algn="l"><ns4:buNone/><ns4:defRPr sz="2800" dirty="0" b="1"><ns4:solidFill><ns4:srgbClr val="FFFFFF"/></ns4:solidFill><ns4:latin typeface="Georgia"/><ns4:ea typeface="Georgia"/></ns4:defRPr></ns4:lvl4pPr><ns4:lvl5pPr algn="l"><ns4:buNone/><ns4:defRPr sz="2800" dirty="0" b="1"><ns4:solidFill><ns4:srgbClr val="FFFFFF"/></ns4:solidFill><ns4:latin typeface="Georgia"/><ns4:ea typeface="Georgia"/></ns4:defRPr></ns4:lvl5pPr><ns4:lvl6pPr algn="l"><ns4:buNone/><ns4:defRPr sz="2800" dirty="0" b="1"><ns4:solidFill><ns4:srgbClr val="FFFFFF"/></ns4:solidFill><ns4:latin typeface="Georgia"/><ns4:ea typeface="Georgia"/></ns4:defRPr></ns4:lvl6pPr><ns4:lvl7pPr algn="l"><ns4:buNone/><ns4:defRPr sz="2800" dirty="0" b="1"><ns4:solidFill><ns4:srgbClr val="FFFFFF"/></ns4:solidFill><ns4:latin typeface="Georgia"/><ns4:ea typeface="Georgia"/></ns4:defRPr></ns4:lvl7pPr><ns4:lvl8pPr algn="l"><ns4:buNone/><ns4:defRPr sz="2800" dirty="0" b="1"><ns4:solidFill><ns4:srgbClr val="FFFFFF"/></ns4:solidFill><ns4:latin typeface="Georgia"/><ns4:ea typeface="Georgia"/></ns4:defRPr></ns4:lvl8pPr><ns4:lvl9pPr algn="l"><ns4:buNone/><ns4:defRPr sz="2800" dirty="0" b="1"><ns4:solidFill><ns4:srgbClr val="FFFFFF"/></ns4:solidFill><ns4:latin typeface="Georgia"/><ns4:ea typeface="Georgia"/></ns4:defRPr></ns4:lvl9pPr></ns4:lstStyle/><ns5:p xmlns:ns5="http://schemas.openxmlformats.org/drawingml/2006/main"><ns5:pPr algn="l"><ns5:buNone/></ns5:pPr><ns5:r><ns5:rPr lang="ja-JP"/><ns5:t>サブタイトル</ns5:t></ns5:r></ns5:p></ns0:txBody></ns0:sp><ns0:sp><ns0:nvSpPr><ns0:cNvPr id="20" name="Body.Center"/><ns0:cNvSpPr><ns1:spLocks xmlns:ns1="http://schemas.openxmlformats.org/drawingml/2006/main" noGrp="1"/></ns0:cNvSpPr><ns0:nvPr><ns0:ph idx="1" type="body"/></ns0:nvPr></ns0:nvSpPr><ns0:spPr><ns2:xfrm xmlns:ns2="http://schemas.openxmlformats.org/drawingml/2006/main"><ns2:off x="457200" y="1325880"/><ns2:ext cx="11247120" cy="4572000"/></ns2:xfrm></ns0:spPr><ns0:txBody><ns3:bodyPr xmlns:ns3="http://schemas.openxmlformats.org/drawingml/2006/main" wrap="square" anchor="t" anchorCtr="0"/><ns4:lstStyle/><ns4:defPPr algn="l"><ns4:buNone/><ns4:defRPr sz="1400" dirty="0"><ns4:solidFill><ns4:srgbClr val="1E293B"/></ns4:solidFill><ns4:latin typeface="Calibri"/><ns4:ea typeface="Calibri"/></ns4:defRPr></ns4:defPPr><ns4:lvl1pPr algn="l"><ns4:buNone/><ns4:defRPr sz="1400" dirty="0"><ns4:solidFill><ns4:srgbClr val="1E293B"/></ns4:solidFill><ns4:latin typeface="Calibri"/><ns4:ea typeface="Calibri"/></ns4:defRPr></ns4:lvl1pPr><ns4:lvl2pPr algn="l"><ns4:buNone/><ns4:defRPr sz="1400" dirty="0"><ns4:solidFill><ns4:srgbClr val="1E293B"/></ns4:solidFill><ns4:latin typeface="Calibri"/><ns4:ea typeface="Calibri"/></ns4:defRPr></ns4:lvl2pPr><ns4:lvl3pPr algn="l"><ns4:buNone/><ns4:defRPr sz="1400" dirty="0"><ns4:solidFill><ns4:srgbClr val="1E293B"/></ns4:solidFill><ns4:latin typeface="Calibri"/><ns4:ea typeface="Calibri"/></ns4:defRPr></ns4:lvl3pPr><ns4:lvl4pPr algn="l"><ns4:buNone/><ns4:defRPr sz="1400" dirty="0"><ns4:solidFill><ns4:srgbClr val="1E293B"/></ns4:solidFill><ns4:latin typeface="Calibri"/><ns4:ea typeface="Calibri"/></ns4:defRPr></ns4:lvl4pPr><ns4:lvl5pPr algn="l"><ns4:buNone/><ns4:defRPr sz="1400" dirty="0"><ns4:solidFill><ns4:srgbClr val="1E293B"/></ns4:solidFill><ns4:latin typeface="Calibri"/><ns4:ea typeface="Calibri"/></ns4:defRPr></ns4:lvl5pPr><ns4:lvl6pPr algn="l"><ns4:buNone/><ns4:defRPr sz="1400" dirty="0"><ns4:solidFill><ns4:srgbClr val="1E293B"/></ns4:solidFill><ns4:latin typeface="Calibri"/><ns4:ea typeface="Calibri"/></ns4:defRPr></ns4:lvl6pPr><ns4:lvl7pPr algn="l"><ns4:buNone/><ns4:defRPr sz="1400" dirty="0"><ns4:solidFill><ns4:srgbClr val="1E293B"/></ns4:solidFill><ns4:latin typeface="Calibri"/><ns4:ea typeface="Calibri"/></ns4:defRPr></ns4:lvl7pPr><ns4:lvl8pPr algn="l"><ns4:buNone/><ns4:defRPr sz="1400" dirty="0"><ns4:solidFill><ns4:srgbClr val="1E293B"/></ns4:solidFill><ns4:latin typeface="Calibri"/><ns4:ea typeface="Calibri"/></ns4:defRPr></ns4:lvl8pPr><ns4:lvl9pPr algn="l"><ns4:buNone/><ns4:defRPr sz="1400" dirty="0"><ns4:solidFill><ns4:srgbClr val="1E293B"/></ns4:solidFill><ns4:latin typeface="Calibri"/><ns4:ea typeface="Calibri"/></ns4:defRPr></ns4:lvl9pPr></ns4:lstStyle/><ns5:p xmlns:ns5="http://schemas.openxmlformats.org/drawingml/2006/main"><ns5:pPr algn="l"><ns5:buNone/></ns5:pPr><ns5:r><ns5:rPr lang="ja-JP"/><ns5:t>出典：</ns5:t></ns5:r></ns5:p></ns0:txBody></ns0:sp><ns0:sp><ns0:nvSpPr><ns0:cNvPr id="30" name="SlideNum.Footer"/><ns0:cNvSpPr><ns1:spLocks xmlns:ns1="http://schemas.openxmlformats.org/drawingml/2006/main" noGrp="1"/></ns0:cNvSpPr><ns0:nvPr><ns0:ph idx="50" type="sldNum"/></ns0:nvPr></ns0:nvSpPr><ns0:spPr><ns2:xfrm xmlns:ns2="http://schemas.openxmlformats.org/drawingml/2006/main"><ns2:off x="10972800" y="6446520"/><ns2:ext cx="1097280" cy="274320"/></ns2:xfrm></ns0:spPr><ns0:txBody><ns3:bodyPr xmlns:ns3="http://schemas.openxmlformats.org/drawingml/2006/main" wrap="square" anchor="t" anchorCtr="0"/><ns4:lstStyle><ns4:defPPr algn="r"><ns4:defRPr sz="1000"><ns4:solidFill><ns4:srgbClr val="94A3B8"/></ns4:solidFill></ns4:defRPr></ns4:defPPr></ns4:lstStyle><ns4:defPPr algn="r"><ns4:buNone/><ns4:defRPr sz="1000" dirty="0"><ns4:solidFill><ns4:srgbClr val="94A3B8"/></ns4:solidFill><ns4:latin typeface="Calibri"/><ns4:ea typeface="Calibri"/></ns4:defRPr></ns4:defPPr><ns4:lvl1pPr algn="r"><ns4:buNone/><ns4:defRPr sz="1000" dirty="0"><ns4:solidFill><ns4:srgbClr val="94A3B8"/></ns4:solidFill><ns4:latin typeface="Calibri"/><ns4:ea typeface="Calibri"/></ns4:defRPr></ns4:lvl1pPr><ns4:lvl2pPr algn="r"><ns4:buNone/><ns4:defRPr sz="1000" dirty="0"><ns4:solidFill><ns4:srgbClr val="94A3B8"/></ns4:solidFill><ns4:latin typeface="Calibri"/><ns4:ea typeface="Calibri"/></ns4:defRPr></ns4:lvl2pPr><ns4:lvl3pPr algn="r"><ns4:buNone/><ns4:defRPr sz="1000" dirty="0"><ns4:solidFill><ns4:srgbClr val="94A3B8"/></ns4:solidFill><ns4:latin typeface="Calibri"/><ns4:ea typeface="Calibri"/></ns4:defRPr></ns4:lvl3pPr><ns4:lvl4pPr algn="r"><ns4:buNone/><ns4:defRPr sz="1000" dirty="0"><ns4:solidFill><ns4:srgbClr val="94A3B8"/></ns4:solidFill><ns4:latin typeface="Calibri"/><ns4:ea typeface="Calibri"/></ns4:defRPr></ns4:lvl4pPr><ns4:lvl5pPr algn="r"><ns4:buNone/><ns4:defRPr sz="1000" dirty="0"><ns4:solidFill><ns4:srgbClr val="94A3B8"/></ns4:solidFill><ns4:latin typeface="Calibri"/><ns4:ea typeface="Calibri"/></ns4:defRPr></ns4:lvl5pPr><ns4:lvl6pPr algn="r"><ns4:buNone/><ns4:defRPr sz="1000" dirty="0"><ns4:solidFill><ns4:srgbClr val="94A3B8"/></ns4:solidFill><ns4:latin typeface="Calibri"/><ns4:ea typeface="Calibri"/></ns4:defRPr></ns4:lvl6pPr><ns4:lvl7pPr algn="r"><ns4:buNone/><ns4:defRPr sz="1000" dirty="0"><ns4:solidFill><ns4:srgbClr val="94A3B8"/></ns4:solidFill><ns4:latin typeface="Calibri"/><ns4:ea typeface="Calibri"/></ns4:defRPr></ns4:lvl7pPr><ns4:lvl8pPr algn="r"><ns4:buNone/><ns4:defRPr sz="1000" dirty="0"><ns4:solidFill><ns4:srgbClr val="94A3B8"/></ns4:solidFill><ns4:latin typeface="Calibri"/><ns4:ea typeface="Calibri"/></ns4:defRPr></ns4:lvl8pPr><ns4:lvl9pPr algn="r"><ns4:buNone/><ns4:defRPr sz="1000" dirty="0"><ns4:solidFill><ns4:srgbClr val="94A3B8"/></ns4:solidFill><ns4:latin typeface="Calibri"/><ns4:ea typeface="Calibri"/></ns4:defRPr></ns4:lvl9pPr></ns4:lstStyle><ns5:p xmlns:ns5="http://schemas.openxmlformats.org/drawingml/2006/main"><ns5:pPr algn="r"><ns5:buNone/></ns5:pPr><ns5:r><ns5:rPr lang="ja-JP"/><ns5:t>&lt;#&gt;</ns5:t></ns5:r></ns5:p></ns0:txBody></ns0:sp></ns0:spTree></ns0:cSld><ns0:clrMapOvr/></ns0:sldLayout>
+<file path=ppt/slideLayouts/slideLayout21.xml><?xml version="1.0" encoding="utf-8"?>
+<p:sldLayout xmlns:a="http://schemas.openxmlformats.org/drawingml/2006/main" xmlns:p="http://schemas.openxmlformats.org/presentationml/2006/main" xmlns:r="http://schemas.openxmlformats.org/officeDocument/2006/relationships" type="blank" preserve="1">
+  <p:cSld name="Table.1Table.Single+1Source">
+    <p:spTree>
+      <p:nvGrpSpPr>
+        <p:cNvPr id="1" name=""/>
+        <p:cNvGrpSpPr/>
+        <p:nvPr/>
+      </p:nvGrpSpPr>
+      <p:grpSpPr>
+        <a:xfrm>
+          <a:off x="0" y="0"/>
+          <a:ext cx="0" cy="0"/>
+          <a:chOff x="0" y="0"/>
+          <a:chExt cx="0" cy="0"/>
+        </a:xfrm>
+      </p:grpSpPr>
+      <p:sp>
+        <p:nvSpPr>
+          <p:cNvPr id="2" name="HeaderBar"/>
+          <p:cNvSpPr>
+            <a:spLocks xmlns:ns1="http://schemas.openxmlformats.org/drawingml/2006/main" noGrp="1" noSelect="0" noRot="1" noMove="1"/>
+          </p:cNvSpPr>
+          <p:nvPr/>
+        </p:nvSpPr>
+        <p:spPr>
+          <a:xfrm xmlns:ns2="http://schemas.openxmlformats.org/drawingml/2006/main">
+            <a:off x="0" y="0"/>
+            <a:ext cx="12192000" cy="1051560"/>
+          </a:xfrm>
+          <a:prstGeom xmlns:ns3="http://schemas.openxmlformats.org/drawingml/2006/main" prst="rect"/>
+          <a:solidFill xmlns:ns4="http://schemas.openxmlformats.org/drawingml/2006/main">
+            <a:srgbClr val="1E2761"/>
+          </a:solidFill>
+          <a:ln xmlns:ns5="http://schemas.openxmlformats.org/drawingml/2006/main">
+            <a:noFill/>
+          </a:ln>
+        </p:spPr>
+      </p:sp>
+      <p:sp>
+        <p:nvSpPr>
+          <p:cNvPr id="3" name="SlideTitle.Header"/>
+          <p:cNvSpPr>
+            <a:spLocks noGrp="1"/>
+          </p:cNvSpPr>
+          <p:nvPr>
+            <p:ph type="body" idx="15"/>
+          </p:nvPr>
+        </p:nvSpPr>
+        <p:spPr>
+          <a:xfrm>
+            <a:off x="731520" y="91440"/>
+            <a:ext cx="9144000" cy="475488"/>
+          </a:xfrm>
+        </p:spPr>
+        <p:txBody>
+          <a:bodyPr wrap="square" anchor="t" anchorCtr="0"/>
+          <a:lstStyle>
+            <a:defPPr>
+              <a:defRPr sz="2800" b="1">
+                <a:solidFill>
+                  <a:srgbClr val="FFFFFF"/>
+                </a:solidFill>
+              </a:defRPr>
+            </a:defPPr>
+          </a:lstStyle>
+          <a:p>
+            <a:r>
+              <a:rPr lang="ja-JP"/>
+              <a:t> </a:t>
+            </a:r>
+          </a:p>
+        </p:txBody>
+      </p:sp>
+      <p:sp>
+        <p:nvSpPr>
+          <p:cNvPr id="4" name="SlideSubtitle.Header"/>
+          <p:cNvSpPr>
+            <a:spLocks noGrp="1"/>
+          </p:cNvSpPr>
+          <p:nvPr>
+            <p:ph type="body" idx="16"/>
+          </p:nvPr>
+        </p:nvSpPr>
+        <p:spPr>
+          <a:xfrm>
+            <a:off x="731520" y="658368"/>
+            <a:ext cx="9144000" cy="274320"/>
+          </a:xfrm>
+        </p:spPr>
+        <p:txBody>
+          <a:bodyPr wrap="square" anchor="t" anchorCtr="0"/>
+          <a:lstStyle>
+            <a:defPPr>
+              <a:defRPr sz="1200">
+                <a:solidFill>
+                  <a:srgbClr val="CADCFC"/>
+                </a:solidFill>
+              </a:defRPr>
+            </a:defPPr>
+          </a:lstStyle>
+          <a:p>
+            <a:r>
+              <a:rPr lang="ja-JP"/>
+              <a:t> </a:t>
+            </a:r>
+          </a:p>
+        </p:txBody>
+      </p:sp>
+      <p:sp>
+        <p:nvSpPr>
+          <p:cNvPr id="5" name="Body.Center"/>
+          <p:cNvSpPr>
+            <a:spLocks noGrp="1"/>
+          </p:cNvSpPr>
+          <p:nvPr>
+            <p:ph type="body" idx="1"/>
+          </p:nvPr>
+        </p:nvSpPr>
+        <p:spPr>
+          <a:xfrm>
+            <a:off x="457200" y="1325880"/>
+            <a:ext cx="11247120" cy="4572000"/>
+          </a:xfrm>
+        </p:spPr>
+        <p:txBody>
+          <a:bodyPr wrap="square" anchor="t" anchorCtr="0"/>
+          <a:lstStyle/>
+          <a:p>
+            <a:r>
+              <a:rPr lang="ja-JP"/>
+              <a:t> </a:t>
+            </a:r>
+          </a:p>
+        </p:txBody>
+      </p:sp>
+      <p:sp>
+        <p:nvSpPr>
+          <p:cNvPr id="6" name="Source.Bottom"/>
+          <p:cNvSpPr>
+            <a:spLocks noGrp="1"/>
+          </p:cNvSpPr>
+          <p:nvPr>
+            <p:ph type="body" idx="2"/>
+          </p:nvPr>
+        </p:nvSpPr>
+        <p:spPr>
+          <a:xfrm>
+            <a:off x="731520" y="6035040"/>
+            <a:ext cx="10058400" cy="365760"/>
+          </a:xfrm>
+        </p:spPr>
+        <p:txBody>
+          <a:bodyPr wrap="square" anchor="t" anchorCtr="0"/>
+          <a:lstStyle>
+            <a:defPPr>
+              <a:defRPr sz="1000">
+                <a:solidFill>
+                  <a:srgbClr val="94A3B8"/>
+                </a:solidFill>
+              </a:defRPr>
+            </a:defPPr>
+          </a:lstStyle>
+          <a:p>
+            <a:r>
+              <a:rPr lang="ja-JP"/>
+              <a:t> </a:t>
+            </a:r>
+          </a:p>
+        </p:txBody>
+      </p:sp>
+      <p:sp>
+        <p:nvSpPr>
+          <p:cNvPr id="7" name="SlideNum.Footer"/>
+          <p:cNvSpPr>
+            <a:spLocks noGrp="1"/>
+          </p:cNvSpPr>
+          <p:nvPr>
+            <p:ph type="sldNum" idx="50"/>
+          </p:nvPr>
+        </p:nvSpPr>
+        <p:spPr>
+          <a:xfrm>
+            <a:off x="10972800" y="6446520"/>
+            <a:ext cx="1097280" cy="274320"/>
+          </a:xfrm>
+        </p:spPr>
+        <p:txBody>
+          <a:bodyPr wrap="square" anchor="t" anchorCtr="0"/>
+          <a:lstStyle>
+            <a:defPPr algn="r">
+              <a:defRPr sz="1000">
+                <a:solidFill>
+                  <a:srgbClr val="94A3B8"/>
+                </a:solidFill>
+              </a:defRPr>
+            </a:defPPr>
+          </a:lstStyle>
+          <a:p>
+            <a:r>
+              <a:rPr lang="ja-JP"/>
+              <a:t> </a:t>
+            </a:r>
+          </a:p>
+        </p:txBody>
+      </p:sp>
+    </p:spTree>
+  </p:cSld>
+  <p:clrMapOvr/>
+</p:sldLayout>
 </file>
 
-<file path=ppt/slideLayouts/slideLayout22.xml><?xml version='1.0' encoding='UTF-8' standalone='yes'?>
-<ns0:sldLayout xmlns:ns0="http://schemas.openxmlformats.org/presentationml/2006/main" type="blank" preserve="1"><ns0:cSld name="Table.1Table.Single+1Notes"><ns0:spTree><ns0:nvGrpSpPr><ns0:cNvPr id="1" name=""/><ns0:cNvGrpSpPr/><ns0:nvPr/></ns0:nvGrpSpPr><ns0:grpSpPr><ns1:xfrm xmlns:ns1="http://schemas.openxmlformats.org/drawingml/2006/main"><ns1:off x="0" y="0"/><ns1:ext cx="0" cy="0"/><ns1:chOff x="0" y="0"/><ns1:chExt cx="0" cy="0"/></ns1:xfrm></ns0:grpSpPr><ns0:sp><ns0:nvSpPr><ns0:cNvPr id="2" name="HeaderBar"/><ns0:cNvSpPr><ns1:spLocks xmlns:ns1="http://schemas.openxmlformats.org/drawingml/2006/main" noGrp="1" noSelect="0" noRot="1" noMove="1"/></ns0:cNvSpPr><ns0:nvPr/></ns0:nvSpPr><ns0:spPr><ns2:xfrm xmlns:ns2="http://schemas.openxmlformats.org/drawingml/2006/main"><ns2:off x="0" y="0"/><ns2:ext cx="12192000" cy="1051560"/></ns2:xfrm><ns3:prstGeom xmlns:ns3="http://schemas.openxmlformats.org/drawingml/2006/main" prst="rect"/><ns4:solidFill xmlns:ns4="http://schemas.openxmlformats.org/drawingml/2006/main"><ns4:srgbClr val="1E2761"/></ns4:solidFill><ns5:ln xmlns:ns5="http://schemas.openxmlformats.org/drawingml/2006/main"><ns5:noFill/></ns5:ln></ns0:spPr></ns0:sp><ns0:sp><ns0:nvSpPr><ns0:cNvPr id="10" name="SlideTitle.Header"/><ns0:cNvSpPr><ns1:spLocks xmlns:ns1="http://schemas.openxmlformats.org/drawingml/2006/main" noGrp="1"/></ns0:cNvSpPr><ns0:nvPr><ns0:ph idx="15" type="body"/></ns0:nvPr></ns0:nvSpPr><ns0:spPr><ns2:xfrm xmlns:ns2="http://schemas.openxmlformats.org/drawingml/2006/main"><ns2:off x="731520" y="91440"/><ns2:ext cx="9144000" cy="475488"/></ns2:xfrm></ns0:spPr><ns0:txBody><ns3:bodyPr xmlns:ns3="http://schemas.openxmlformats.org/drawingml/2006/main" wrap="square" anchor="t" anchorCtr="0"/><ns4:lstStyle><ns4:defPPr><ns4:defRPr sz="2800" b="1"><ns4:solidFill><ns4:srgbClr val="FFFFFF"/></ns4:solidFill></ns4:defRPr></ns4:defPPr></ns4:lstStyle><ns4:defPPr algn="l"><ns4:buNone/><ns4:defRPr sz="2800" dirty="0" b="1"><ns4:solidFill><ns4:srgbClr val="FFFFFF"/></ns4:solidFill><ns4:latin typeface="Georgia"/><ns4:ea typeface="Georgia"/></ns4:defRPr></ns4:defPPr><ns4:lvl1pPr algn="l"><ns4:buNone/><ns4:defRPr sz="2800" dirty="0" b="1"><ns4:solidFill><ns4:srgbClr val="FFFFFF"/></ns4:solidFill><ns4:latin typeface="Georgia"/><ns4:ea typeface="Georgia"/></ns4:defRPr></ns4:lvl1pPr><ns4:lvl2pPr algn="l"><ns4:buNone/><ns4:defRPr sz="2800" dirty="0" b="1"><ns4:solidFill><ns4:srgbClr val="FFFFFF"/></ns4:solidFill><ns4:latin typeface="Georgia"/><ns4:ea typeface="Georgia"/></ns4:defRPr></ns4:lvl2pPr><ns4:lvl3pPr algn="l"><ns4:buNone/><ns4:defRPr sz="2800" dirty="0" b="1"><ns4:solidFill><ns4:srgbClr val="FFFFFF"/></ns4:solidFill><ns4:latin typeface="Georgia"/><ns4:ea typeface="Georgia"/></ns4:defRPr></ns4:lvl3pPr><ns4:lvl4pPr algn="l"><ns4:buNone/><ns4:defRPr sz="2800" dirty="0" b="1"><ns4:solidFill><ns4:srgbClr val="FFFFFF"/></ns4:solidFill><ns4:latin typeface="Georgia"/><ns4:ea typeface="Georgia"/></ns4:defRPr></ns4:lvl4pPr><ns4:lvl5pPr algn="l"><ns4:buNone/><ns4:defRPr sz="2800" dirty="0" b="1"><ns4:solidFill><ns4:srgbClr val="FFFFFF"/></ns4:solidFill><ns4:latin typeface="Georgia"/><ns4:ea typeface="Georgia"/></ns4:defRPr></ns4:lvl5pPr><ns4:lvl6pPr algn="l"><ns4:buNone/><ns4:defRPr sz="2800" dirty="0" b="1"><ns4:solidFill><ns4:srgbClr val="FFFFFF"/></ns4:solidFill><ns4:latin typeface="Georgia"/><ns4:ea typeface="Georgia"/></ns4:defRPr></ns4:lvl6pPr><ns4:lvl7pPr algn="l"><ns4:buNone/><ns4:defRPr sz="2800" dirty="0" b="1"><ns4:solidFill><ns4:srgbClr val="FFFFFF"/></ns4:solidFill><ns4:latin typeface="Georgia"/><ns4:ea typeface="Georgia"/></ns4:defRPr></ns4:lvl7pPr><ns4:lvl8pPr algn="l"><ns4:buNone/><ns4:defRPr sz="2800" dirty="0" b="1"><ns4:solidFill><ns4:srgbClr val="FFFFFF"/></ns4:solidFill><ns4:latin typeface="Georgia"/><ns4:ea typeface="Georgia"/></ns4:defRPr></ns4:lvl8pPr><ns4:lvl9pPr algn="l"><ns4:buNone/><ns4:defRPr sz="2800" dirty="0" b="1"><ns4:solidFill><ns4:srgbClr val="FFFFFF"/></ns4:solidFill><ns4:latin typeface="Georgia"/><ns4:ea typeface="Georgia"/></ns4:defRPr></ns4:lvl9pPr></ns4:lstStyle/><ns5:p xmlns:ns5="http://schemas.openxmlformats.org/drawingml/2006/main"><ns5:pPr algn="l"><ns5:buNone/></ns5:pPr><ns5:r><ns5:rPr lang="ja-JP"/><ns5:t>サブタイトル</ns5:t></ns5:r></ns5:p></ns0:txBody></ns0:sp><ns0:sp><ns0:nvSpPr><ns0:cNvPr id="20" name="Body.Left"/><ns0:cNvSpPr><ns1:spLocks xmlns:ns1="http://schemas.openxmlformats.org/drawingml/2006/main" noGrp="1"/></ns0:cNvSpPr><ns0:nvPr><ns0:ph idx="1" type="body"/></ns0:nvPr></ns0:nvSpPr><ns0:spPr><ns2:xfrm xmlns:ns2="http://schemas.openxmlformats.org/drawingml/2006/main"><ns2:off x="457200" y="1325880"/><ns2:ext cx="7772400" cy="4937760"/></ns2:xfrm></ns0:spPr><ns0:txBody><ns3:bodyPr xmlns:ns3="http://schemas.openxmlformats.org/drawingml/2006/main" wrap="square" anchor="t" anchorCtr="0"/><ns4:lstStyle/><ns4:defPPr algn="l"><ns4:buNone/><ns4:defRPr sz="1400" dirty="0"><ns4:solidFill><ns4:srgbClr val="1E293B"/></ns4:solidFill><ns4:latin typeface="Calibri"/><ns4:ea typeface="Calibri"/></ns4:defRPr></ns4:defPPr><ns4:lvl1pPr algn="l"><ns4:buNone/><ns4:defRPr sz="1400" dirty="0"><ns4:solidFill><ns4:srgbClr val="1E293B"/></ns4:solidFill><ns4:latin typeface="Calibri"/><ns4:ea typeface="Calibri"/></ns4:defRPr></ns4:lvl1pPr><ns4:lvl2pPr algn="l"><ns4:buNone/><ns4:defRPr sz="1400" dirty="0"><ns4:solidFill><ns4:srgbClr val="1E293B"/></ns4:solidFill><ns4:latin typeface="Calibri"/><ns4:ea typeface="Calibri"/></ns4:defRPr></ns4:lvl2pPr><ns4:lvl3pPr algn="l"><ns4:buNone/><ns4:defRPr sz="1400" dirty="0"><ns4:solidFill><ns4:srgbClr val="1E293B"/></ns4:solidFill><ns4:latin typeface="Calibri"/><ns4:ea typeface="Calibri"/></ns4:defRPr></ns4:lvl3pPr><ns4:lvl4pPr algn="l"><ns4:buNone/><ns4:defRPr sz="1400" dirty="0"><ns4:solidFill><ns4:srgbClr val="1E293B"/></ns4:solidFill><ns4:latin typeface="Calibri"/><ns4:ea typeface="Calibri"/></ns4:defRPr></ns4:lvl4pPr><ns4:lvl5pPr algn="l"><ns4:buNone/><ns4:defRPr sz="1400" dirty="0"><ns4:solidFill><ns4:srgbClr val="1E293B"/></ns4:solidFill><ns4:latin typeface="Calibri"/><ns4:ea typeface="Calibri"/></ns4:defRPr></ns4:lvl5pPr><ns4:lvl6pPr algn="l"><ns4:buNone/><ns4:defRPr sz="1400" dirty="0"><ns4:solidFill><ns4:srgbClr val="1E293B"/></ns4:solidFill><ns4:latin typeface="Calibri"/><ns4:ea typeface="Calibri"/></ns4:defRPr></ns4:lvl6pPr><ns4:lvl7pPr algn="l"><ns4:buNone/><ns4:defRPr sz="1400" dirty="0"><ns4:solidFill><ns4:srgbClr val="1E293B"/></ns4:solidFill><ns4:latin typeface="Calibri"/><ns4:ea typeface="Calibri"/></ns4:defRPr></ns4:lvl7pPr><ns4:lvl8pPr algn="l"><ns4:buNone/><ns4:defRPr sz="1400" dirty="0"><ns4:solidFill><ns4:srgbClr val="1E293B"/></ns4:solidFill><ns4:latin typeface="Calibri"/><ns4:ea typeface="Calibri"/></ns4:defRPr></ns4:lvl8pPr><ns4:lvl9pPr algn="l"><ns4:buNone/><ns4:defRPr sz="1400" dirty="0"><ns4:solidFill><ns4:srgbClr val="1E293B"/></ns4:solidFill><ns4:latin typeface="Calibri"/><ns4:ea typeface="Calibri"/></ns4:defRPr></ns4:lvl9pPr></ns4:lstStyle/><ns5:p xmlns:ns5="http://schemas.openxmlformats.org/drawingml/2006/main"><ns5:pPr algn="l"><ns5:buNone/></ns5:pPr><ns5:r><ns5:rPr lang="ja-JP"/><ns5:t>コメント・注記
-
-テーブルの補足情報</ns5:t></ns5:r></ns5:p></ns0:txBody></ns0:sp><ns0:sp><ns0:nvSpPr><ns0:cNvPr id="30" name="SlideNum.Footer"/><ns0:cNvSpPr><ns1:spLocks xmlns:ns1="http://schemas.openxmlformats.org/drawingml/2006/main" noGrp="1"/></ns0:cNvSpPr><ns0:nvPr><ns0:ph idx="50" type="sldNum"/></ns0:nvPr></ns0:nvSpPr><ns0:spPr><ns2:xfrm xmlns:ns2="http://schemas.openxmlformats.org/drawingml/2006/main"><ns2:off x="10972800" y="6446520"/><ns2:ext cx="1097280" cy="274320"/></ns2:xfrm></ns0:spPr><ns0:txBody><ns3:bodyPr xmlns:ns3="http://schemas.openxmlformats.org/drawingml/2006/main" wrap="square" anchor="t" anchorCtr="0"/><ns4:lstStyle><ns4:defPPr algn="r"><ns4:defRPr sz="1000"><ns4:solidFill><ns4:srgbClr val="94A3B8"/></ns4:solidFill></ns4:defRPr></ns4:defPPr></ns4:lstStyle><ns4:defPPr algn="r"><ns4:buNone/><ns4:defRPr sz="1000" dirty="0"><ns4:solidFill><ns4:srgbClr val="94A3B8"/></ns4:solidFill><ns4:latin typeface="Calibri"/><ns4:ea typeface="Calibri"/></ns4:defRPr></ns4:defPPr><ns4:lvl1pPr algn="r"><ns4:buNone/><ns4:defRPr sz="1000" dirty="0"><ns4:solidFill><ns4:srgbClr val="94A3B8"/></ns4:solidFill><ns4:latin typeface="Calibri"/><ns4:ea typeface="Calibri"/></ns4:defRPr></ns4:lvl1pPr><ns4:lvl2pPr algn="r"><ns4:buNone/><ns4:defRPr sz="1000" dirty="0"><ns4:solidFill><ns4:srgbClr val="94A3B8"/></ns4:solidFill><ns4:latin typeface="Calibri"/><ns4:ea typeface="Calibri"/></ns4:defRPr></ns4:lvl2pPr><ns4:lvl3pPr algn="r"><ns4:buNone/><ns4:defRPr sz="1000" dirty="0"><ns4:solidFill><ns4:srgbClr val="94A3B8"/></ns4:solidFill><ns4:latin typeface="Calibri"/><ns4:ea typeface="Calibri"/></ns4:defRPr></ns4:lvl3pPr><ns4:lvl4pPr algn="r"><ns4:buNone/><ns4:defRPr sz="1000" dirty="0"><ns4:solidFill><ns4:srgbClr val="94A3B8"/></ns4:solidFill><ns4:latin typeface="Calibri"/><ns4:ea typeface="Calibri"/></ns4:defRPr></ns4:lvl4pPr><ns4:lvl5pPr algn="r"><ns4:buNone/><ns4:defRPr sz="1000" dirty="0"><ns4:solidFill><ns4:srgbClr val="94A3B8"/></ns4:solidFill><ns4:latin typeface="Calibri"/><ns4:ea typeface="Calibri"/></ns4:defRPr></ns4:lvl5pPr><ns4:lvl6pPr algn="r"><ns4:buNone/><ns4:defRPr sz="1000" dirty="0"><ns4:solidFill><ns4:srgbClr val="94A3B8"/></ns4:solidFill><ns4:latin typeface="Calibri"/><ns4:ea typeface="Calibri"/></ns4:defRPr></ns4:lvl6pPr><ns4:lvl7pPr algn="r"><ns4:buNone/><ns4:defRPr sz="1000" dirty="0"><ns4:solidFill><ns4:srgbClr val="94A3B8"/></ns4:solidFill><ns4:latin typeface="Calibri"/><ns4:ea typeface="Calibri"/></ns4:defRPr></ns4:lvl7pPr><ns4:lvl8pPr algn="r"><ns4:buNone/><ns4:defRPr sz="1000" dirty="0"><ns4:solidFill><ns4:srgbClr val="94A3B8"/></ns4:solidFill><ns4:latin typeface="Calibri"/><ns4:ea typeface="Calibri"/></ns4:defRPr></ns4:lvl8pPr><ns4:lvl9pPr algn="r"><ns4:buNone/><ns4:defRPr sz="1000" dirty="0"><ns4:solidFill><ns4:srgbClr val="94A3B8"/></ns4:solidFill><ns4:latin typeface="Calibri"/><ns4:ea typeface="Calibri"/></ns4:defRPr></ns4:lvl9pPr></ns4:lstStyle><ns5:p xmlns:ns5="http://schemas.openxmlformats.org/drawingml/2006/main"><ns5:pPr algn="r"><ns5:buNone/></ns5:pPr><ns5:r><ns5:rPr lang="ja-JP"/><ns5:t>&lt;#&gt;</ns5:t></ns5:r></ns5:p></ns0:txBody></ns0:sp></ns0:spTree></ns0:cSld><ns0:clrMapOvr/></ns0:sldLayout>
+<file path=ppt/slideLayouts/slideLayout22.xml><?xml version="1.0" encoding="utf-8"?>
+<p:sldLayout xmlns:a="http://schemas.openxmlformats.org/drawingml/2006/main" xmlns:p="http://schemas.openxmlformats.org/presentationml/2006/main" xmlns:r="http://schemas.openxmlformats.org/officeDocument/2006/relationships" type="blank" preserve="1">
+  <p:cSld name="Table.1Table.Single+1Notes">
+    <p:spTree>
+      <p:nvGrpSpPr>
+        <p:cNvPr id="1" name=""/>
+        <p:cNvGrpSpPr/>
+        <p:nvPr/>
+      </p:nvGrpSpPr>
+      <p:grpSpPr>
+        <a:xfrm>
+          <a:off x="0" y="0"/>
+          <a:ext cx="0" cy="0"/>
+          <a:chOff x="0" y="0"/>
+          <a:chExt cx="0" cy="0"/>
+        </a:xfrm>
+      </p:grpSpPr>
+      <p:sp>
+        <p:nvSpPr>
+          <p:cNvPr id="2" name="HeaderBar"/>
+          <p:cNvSpPr>
+            <a:spLocks xmlns:ns1="http://schemas.openxmlformats.org/drawingml/2006/main" noGrp="1" noSelect="0" noRot="1" noMove="1"/>
+          </p:cNvSpPr>
+          <p:nvPr/>
+        </p:nvSpPr>
+        <p:spPr>
+          <a:xfrm xmlns:ns2="http://schemas.openxmlformats.org/drawingml/2006/main">
+            <a:off x="0" y="0"/>
+            <a:ext cx="12192000" cy="1051560"/>
+          </a:xfrm>
+          <a:prstGeom xmlns:ns3="http://schemas.openxmlformats.org/drawingml/2006/main" prst="rect"/>
+          <a:solidFill xmlns:ns4="http://schemas.openxmlformats.org/drawingml/2006/main">
+            <a:srgbClr val="1E2761"/>
+          </a:solidFill>
+          <a:ln xmlns:ns5="http://schemas.openxmlformats.org/drawingml/2006/main">
+            <a:noFill/>
+          </a:ln>
+        </p:spPr>
+      </p:sp>
+      <p:sp>
+        <p:nvSpPr>
+          <p:cNvPr id="3" name="SlideTitle.Header"/>
+          <p:cNvSpPr>
+            <a:spLocks noGrp="1"/>
+          </p:cNvSpPr>
+          <p:nvPr>
+            <p:ph type="body" idx="15"/>
+          </p:nvPr>
+        </p:nvSpPr>
+        <p:spPr>
+          <a:xfrm>
+            <a:off x="731520" y="91440"/>
+            <a:ext cx="9144000" cy="475488"/>
+          </a:xfrm>
+        </p:spPr>
+        <p:txBody>
+          <a:bodyPr wrap="square" anchor="t" anchorCtr="0"/>
+          <a:lstStyle>
+            <a:defPPr>
+              <a:defRPr sz="2800" b="1">
+                <a:solidFill>
+                  <a:srgbClr val="FFFFFF"/>
+                </a:solidFill>
+              </a:defRPr>
+            </a:defPPr>
+          </a:lstStyle>
+          <a:p>
+            <a:r>
+              <a:rPr lang="ja-JP"/>
+              <a:t> </a:t>
+            </a:r>
+          </a:p>
+        </p:txBody>
+      </p:sp>
+      <p:sp>
+        <p:nvSpPr>
+          <p:cNvPr id="4" name="SlideSubtitle.Header"/>
+          <p:cNvSpPr>
+            <a:spLocks noGrp="1"/>
+          </p:cNvSpPr>
+          <p:nvPr>
+            <p:ph type="body" idx="16"/>
+          </p:nvPr>
+        </p:nvSpPr>
+        <p:spPr>
+          <a:xfrm>
+            <a:off x="731520" y="658368"/>
+            <a:ext cx="9144000" cy="274320"/>
+          </a:xfrm>
+        </p:spPr>
+        <p:txBody>
+          <a:bodyPr wrap="square" anchor="t" anchorCtr="0"/>
+          <a:lstStyle>
+            <a:defPPr>
+              <a:defRPr sz="1200">
+                <a:solidFill>
+                  <a:srgbClr val="CADCFC"/>
+                </a:solidFill>
+              </a:defRPr>
+            </a:defPPr>
+          </a:lstStyle>
+          <a:p>
+            <a:r>
+              <a:rPr lang="ja-JP"/>
+              <a:t> </a:t>
+            </a:r>
+          </a:p>
+        </p:txBody>
+      </p:sp>
+      <p:sp>
+        <p:nvSpPr>
+          <p:cNvPr id="5" name="Body.Left"/>
+          <p:cNvSpPr>
+            <a:spLocks noGrp="1"/>
+          </p:cNvSpPr>
+          <p:nvPr>
+            <p:ph type="body" idx="1"/>
+          </p:nvPr>
+        </p:nvSpPr>
+        <p:spPr>
+          <a:xfrm>
+            <a:off x="457200" y="1325880"/>
+            <a:ext cx="7772400" cy="4937760"/>
+          </a:xfrm>
+        </p:spPr>
+        <p:txBody>
+          <a:bodyPr wrap="square" anchor="t" anchorCtr="0"/>
+          <a:lstStyle/>
+          <a:p>
+            <a:r>
+              <a:rPr lang="ja-JP"/>
+              <a:t> </a:t>
+            </a:r>
+          </a:p>
+        </p:txBody>
+      </p:sp>
+      <p:sp>
+        <p:nvSpPr>
+          <p:cNvPr id="6" name="Notes.Right"/>
+          <p:cNvSpPr>
+            <a:spLocks noGrp="1"/>
+          </p:cNvSpPr>
+          <p:nvPr>
+            <p:ph type="body" idx="2"/>
+          </p:nvPr>
+        </p:nvSpPr>
+        <p:spPr>
+          <a:xfrm>
+            <a:off x="8869680" y="1417320"/>
+            <a:ext cx="2651760" cy="4663440"/>
+          </a:xfrm>
+        </p:spPr>
+        <p:txBody>
+          <a:bodyPr wrap="square" anchor="t" anchorCtr="0"/>
+          <a:lstStyle>
+            <a:defPPr>
+              <a:defRPr sz="1200"/>
+            </a:defPPr>
+          </a:lstStyle>
+          <a:p>
+            <a:r>
+              <a:rPr lang="ja-JP"/>
+              <a:t> </a:t>
+            </a:r>
+          </a:p>
+        </p:txBody>
+      </p:sp>
+      <p:sp>
+        <p:nvSpPr>
+          <p:cNvPr id="7" name="SlideNum.Footer"/>
+          <p:cNvSpPr>
+            <a:spLocks noGrp="1"/>
+          </p:cNvSpPr>
+          <p:nvPr>
+            <p:ph type="sldNum" idx="50"/>
+          </p:nvPr>
+        </p:nvSpPr>
+        <p:spPr>
+          <a:xfrm>
+            <a:off x="10972800" y="6446520"/>
+            <a:ext cx="1097280" cy="274320"/>
+          </a:xfrm>
+        </p:spPr>
+        <p:txBody>
+          <a:bodyPr wrap="square" anchor="t" anchorCtr="0"/>
+          <a:lstStyle>
+            <a:defPPr algn="r">
+              <a:defRPr sz="1000">
+                <a:solidFill>
+                  <a:srgbClr val="94A3B8"/>
+                </a:solidFill>
+              </a:defRPr>
+            </a:defPPr>
+          </a:lstStyle>
+          <a:p>
+            <a:r>
+              <a:rPr lang="ja-JP"/>
+              <a:t> </a:t>
+            </a:r>
+          </a:p>
+        </p:txBody>
+      </p:sp>
+    </p:spTree>
+  </p:cSld>
+  <p:clrMapOvr/>
+</p:sldLayout>
 </file>
 
-<file path=ppt/slideLayouts/slideLayout23.xml><?xml version='1.0' encoding='UTF-8' standalone='yes'?>
-<ns0:sldLayout xmlns:ns0="http://schemas.openxmlformats.org/presentationml/2006/main" type="blank" preserve="1"><ns0:cSld name="Compare.2Option.Versus"><ns0:spTree><ns0:nvGrpSpPr><ns0:cNvPr id="1" name=""/><ns0:cNvGrpSpPr/><ns0:nvPr/></ns0:nvGrpSpPr><ns0:grpSpPr><ns1:xfrm xmlns:ns1="http://schemas.openxmlformats.org/drawingml/2006/main"><ns1:off x="0" y="0"/><ns1:ext cx="0" cy="0"/><ns1:chOff x="0" y="0"/><ns1:chExt cx="0" cy="0"/></ns1:xfrm></ns0:grpSpPr><ns0:sp><ns0:nvSpPr><ns0:cNvPr id="2" name="HeaderBar"/><ns0:cNvSpPr><ns1:spLocks xmlns:ns1="http://schemas.openxmlformats.org/drawingml/2006/main" noGrp="1" noSelect="0" noRot="1" noMove="1"/></ns0:cNvSpPr><ns0:nvPr/></ns0:nvSpPr><ns0:spPr><ns2:xfrm xmlns:ns2="http://schemas.openxmlformats.org/drawingml/2006/main"><ns2:off x="0" y="0"/><ns2:ext cx="12192000" cy="1051560"/></ns2:xfrm><ns3:prstGeom xmlns:ns3="http://schemas.openxmlformats.org/drawingml/2006/main" prst="rect"/><ns4:solidFill xmlns:ns4="http://schemas.openxmlformats.org/drawingml/2006/main"><ns4:srgbClr val="1E2761"/></ns4:solidFill><ns5:ln xmlns:ns5="http://schemas.openxmlformats.org/drawingml/2006/main"><ns5:noFill/></ns5:ln></ns0:spPr></ns0:sp><ns0:sp><ns0:nvSpPr><ns0:cNvPr id="10" name="SlideTitle.Header"/><ns0:cNvSpPr><ns1:spLocks xmlns:ns1="http://schemas.openxmlformats.org/drawingml/2006/main" noGrp="1"/></ns0:cNvSpPr><ns0:nvPr><ns0:ph idx="15" type="body"/></ns0:nvPr></ns0:nvSpPr><ns0:spPr><ns2:xfrm xmlns:ns2="http://schemas.openxmlformats.org/drawingml/2006/main"><ns2:off x="731520" y="91440"/><ns2:ext cx="9144000" cy="475488"/></ns2:xfrm></ns0:spPr><ns0:txBody><ns3:bodyPr xmlns:ns3="http://schemas.openxmlformats.org/drawingml/2006/main" wrap="square" anchor="t" anchorCtr="0"/><ns4:lstStyle><ns4:defPPr><ns4:defRPr sz="2800" b="1"><ns4:solidFill><ns4:srgbClr val="FFFFFF"/></ns4:solidFill></ns4:defRPr></ns4:defPPr></ns4:lstStyle><ns4:defPPr algn="l"><ns4:buNone/><ns4:defRPr sz="2800" dirty="0" b="1"><ns4:solidFill><ns4:srgbClr val="FFFFFF"/></ns4:solidFill><ns4:latin typeface="Georgia"/><ns4:ea typeface="Georgia"/></ns4:defRPr></ns4:defPPr><ns4:lvl1pPr algn="l"><ns4:buNone/><ns4:defRPr sz="2800" dirty="0" b="1"><ns4:solidFill><ns4:srgbClr val="FFFFFF"/></ns4:solidFill><ns4:latin typeface="Georgia"/><ns4:ea typeface="Georgia"/></ns4:defRPr></ns4:lvl1pPr><ns4:lvl2pPr algn="l"><ns4:buNone/><ns4:defRPr sz="2800" dirty="0" b="1"><ns4:solidFill><ns4:srgbClr val="FFFFFF"/></ns4:solidFill><ns4:latin typeface="Georgia"/><ns4:ea typeface="Georgia"/></ns4:defRPr></ns4:lvl2pPr><ns4:lvl3pPr algn="l"><ns4:buNone/><ns4:defRPr sz="2800" dirty="0" b="1"><ns4:solidFill><ns4:srgbClr val="FFFFFF"/></ns4:solidFill><ns4:latin typeface="Georgia"/><ns4:ea typeface="Georgia"/></ns4:defRPr></ns4:lvl3pPr><ns4:lvl4pPr algn="l"><ns4:buNone/><ns4:defRPr sz="2800" dirty="0" b="1"><ns4:solidFill><ns4:srgbClr val="FFFFFF"/></ns4:solidFill><ns4:latin typeface="Georgia"/><ns4:ea typeface="Georgia"/></ns4:defRPr></ns4:lvl4pPr><ns4:lvl5pPr algn="l"><ns4:buNone/><ns4:defRPr sz="2800" dirty="0" b="1"><ns4:solidFill><ns4:srgbClr val="FFFFFF"/></ns4:solidFill><ns4:latin typeface="Georgia"/><ns4:ea typeface="Georgia"/></ns4:defRPr></ns4:lvl5pPr><ns4:lvl6pPr algn="l"><ns4:buNone/><ns4:defRPr sz="2800" dirty="0" b="1"><ns4:solidFill><ns4:srgbClr val="FFFFFF"/></ns4:solidFill><ns4:latin typeface="Georgia"/><ns4:ea typeface="Georgia"/></ns4:defRPr></ns4:lvl6pPr><ns4:lvl7pPr algn="l"><ns4:buNone/><ns4:defRPr sz="2800" dirty="0" b="1"><ns4:solidFill><ns4:srgbClr val="FFFFFF"/></ns4:solidFill><ns4:latin typeface="Georgia"/><ns4:ea typeface="Georgia"/></ns4:defRPr></ns4:lvl7pPr><ns4:lvl8pPr algn="l"><ns4:buNone/><ns4:defRPr sz="2800" dirty="0" b="1"><ns4:solidFill><ns4:srgbClr val="FFFFFF"/></ns4:solidFill><ns4:latin typeface="Georgia"/><ns4:ea typeface="Georgia"/></ns4:defRPr></ns4:lvl8pPr><ns4:lvl9pPr algn="l"><ns4:buNone/><ns4:defRPr sz="2800" dirty="0" b="1"><ns4:solidFill><ns4:srgbClr val="FFFFFF"/></ns4:solidFill><ns4:latin typeface="Georgia"/><ns4:ea typeface="Georgia"/></ns4:defRPr></ns4:lvl9pPr></ns4:lstStyle/><ns5:p xmlns:ns5="http://schemas.openxmlformats.org/drawingml/2006/main"><ns5:pPr algn="l"><ns5:buNone/></ns5:pPr><ns5:r><ns5:rPr lang="ja-JP"/><ns5:t>サブタイトル</ns5:t></ns5:r></ns5:p></ns0:txBody></ns0:sp><ns0:sp><ns0:nvSpPr><ns0:cNvPr id="5" name="PanelL"/><ns0:cNvSpPr><ns1:spLocks xmlns:ns1="http://schemas.openxmlformats.org/drawingml/2006/main" noGrp="1" noSelect="0" noRot="1" noMove="1"/></ns0:cNvSpPr><ns0:nvPr/></ns0:nvSpPr><ns0:spPr><ns2:xfrm xmlns:ns2="http://schemas.openxmlformats.org/drawingml/2006/main"><ns2:off x="457200" y="1280160"/><ns2:ext cx="5303520" cy="4937760"/></ns2:xfrm><ns3:prstGeom xmlns:ns3="http://schemas.openxmlformats.org/drawingml/2006/main" prst="roundRect"><ns3:avLst><ns3:gd name="adj" fmla="val 8000"/></ns3:avLst></ns3:prstGeom><ns4:solidFill xmlns:ns4="http://schemas.openxmlformats.org/drawingml/2006/main"><ns4:srgbClr val="EDF0F7"/></ns4:solidFill><ns5:ln xmlns:ns5="http://schemas.openxmlformats.org/drawingml/2006/main"><ns5:noFill/></ns5:ln></ns0:spPr></ns0:sp><ns0:sp><ns0:nvSpPr><ns0:cNvPr id="6" name="PanelR"/><ns0:cNvSpPr><ns1:spLocks xmlns:ns1="http://schemas.openxmlformats.org/drawingml/2006/main" noGrp="1" noSelect="0" noRot="1" noMove="1"/></ns0:cNvSpPr><ns0:nvPr/></ns0:nvSpPr><ns0:spPr><ns2:xfrm xmlns:ns2="http://schemas.openxmlformats.org/drawingml/2006/main"><ns2:off x="6126480" y="1280160"/><ns2:ext cx="5394960" cy="4937760"/></ns2:xfrm><ns3:prstGeom xmlns:ns3="http://schemas.openxmlformats.org/drawingml/2006/main" prst="roundRect"><ns3:avLst><ns3:gd name="adj" fmla="val 8000"/></ns3:avLst></ns3:prstGeom><ns4:solidFill xmlns:ns4="http://schemas.openxmlformats.org/drawingml/2006/main"><ns4:srgbClr val="EDF0F7"/></ns4:solidFill><ns5:ln xmlns:ns5="http://schemas.openxmlformats.org/drawingml/2006/main"><ns5:noFill/></ns5:ln></ns0:spPr></ns0:sp><ns0:sp><ns0:nvSpPr><ns0:cNvPr id="7" name="AccentL"/><ns0:cNvSpPr><ns1:spLocks xmlns:ns1="http://schemas.openxmlformats.org/drawingml/2006/main" noGrp="1" noSelect="0" noRot="1" noMove="1"/></ns0:cNvSpPr><ns0:nvPr/></ns0:nvSpPr><ns0:spPr><ns2:xfrm xmlns:ns2="http://schemas.openxmlformats.org/drawingml/2006/main"><ns2:off x="457200" y="1280160"/><ns2:ext cx="5303520" cy="54864"/></ns2:xfrm><ns3:prstGeom xmlns:ns3="http://schemas.openxmlformats.org/drawingml/2006/main" prst="rect"/><ns4:solidFill xmlns:ns4="http://schemas.openxmlformats.org/drawingml/2006/main"><ns4:srgbClr val="3B82F6"/></ns4:solidFill><ns5:ln xmlns:ns5="http://schemas.openxmlformats.org/drawingml/2006/main"><ns5:noFill/></ns5:ln></ns0:spPr></ns0:sp><ns0:sp><ns0:nvSpPr><ns0:cNvPr id="8" name="AccentR"/><ns0:cNvSpPr><ns1:spLocks xmlns:ns1="http://schemas.openxmlformats.org/drawingml/2006/main" noGrp="1" noSelect="0" noRot="1" noMove="1"/></ns0:cNvSpPr><ns0:nvPr/></ns0:nvSpPr><ns0:spPr><ns2:xfrm xmlns:ns2="http://schemas.openxmlformats.org/drawingml/2006/main"><ns2:off x="6126480" y="1280160"/><ns2:ext cx="5394960" cy="54864"/></ns2:xfrm><ns3:prstGeom xmlns:ns3="http://schemas.openxmlformats.org/drawingml/2006/main" prst="rect"/><ns4:solidFill xmlns:ns4="http://schemas.openxmlformats.org/drawingml/2006/main"><ns4:srgbClr val="06B6D4"/></ns4:solidFill><ns5:ln xmlns:ns5="http://schemas.openxmlformats.org/drawingml/2006/main"><ns5:noFill/></ns5:ln></ns0:spPr></ns0:sp><ns0:sp><ns0:nvSpPr><ns0:cNvPr id="9" name="VS"/><ns0:cNvSpPr><ns1:spLocks xmlns:ns1="http://schemas.openxmlformats.org/drawingml/2006/main" noGrp="1"/></ns0:cNvSpPr><ns0:nvPr/></ns0:nvSpPr><ns0:spPr><ns2:xfrm xmlns:ns2="http://schemas.openxmlformats.org/drawingml/2006/main"><ns2:off x="5309408461680" y="3428121901679"/><ns2:ext cx="548640" cy="548640"/></ns2:xfrm><ns3:prstGeom xmlns:ns3="http://schemas.openxmlformats.org/drawingml/2006/main" prst="ellipse"/><ns4:solidFill xmlns:ns4="http://schemas.openxmlformats.org/drawingml/2006/main"><ns4:srgbClr val="1E2761"/></ns4:solidFill><ns5:ln xmlns:ns5="http://schemas.openxmlformats.org/drawingml/2006/main"><ns5:noFill/></ns5:ln></ns0:spPr></ns0:sp><ns0:sp><ns0:nvSpPr><ns0:cNvPr id="20" name="OptionLabel1.Left"/><ns0:cNvSpPr><ns1:spLocks xmlns:ns1="http://schemas.openxmlformats.org/drawingml/2006/main" noGrp="1"/></ns0:cNvSpPr><ns0:nvPr><ns0:ph idx="1" type="body"/></ns0:nvPr></ns0:nvSpPr><ns0:spPr><ns2:xfrm xmlns:ns2="http://schemas.openxmlformats.org/drawingml/2006/main"><ns2:off x="731520" y="1554480"/><ns2:ext cx="4754880" cy="457200"/></ns2:xfrm></ns0:spPr><ns0:txBody><ns3:bodyPr xmlns:ns3="http://schemas.openxmlformats.org/drawingml/2006/main" wrap="square" anchor="t" anchorCtr="0"/><ns4:lstStyle><ns4:defPPr><ns4:defRPr sz="1600" b="1"><ns4:solidFill><ns4:srgbClr val="3B82F6"/></ns4:solidFill></ns4:defRPr></ns4:defPPr></ns4:lstStyle><ns4:defPPr algn="l"><ns4:buNone/><ns4:defRPr sz="1600" dirty="0" b="1"><ns4:solidFill><ns4:srgbClr val="3B82F6"/></ns4:solidFill><ns4:latin typeface="Calibri"/><ns4:ea typeface="Calibri"/></ns4:defRPr></ns4:defPPr><ns4:lvl1pPr algn="l"><ns4:buNone/><ns4:defRPr sz="1600" dirty="0" b="1"><ns4:solidFill><ns4:srgbClr val="3B82F6"/></ns4:solidFill><ns4:latin typeface="Calibri"/><ns4:ea typeface="Calibri"/></ns4:defRPr></ns4:lvl1pPr><ns4:lvl2pPr algn="l"><ns4:buNone/><ns4:defRPr sz="1600" dirty="0" b="1"><ns4:solidFill><ns4:srgbClr val="3B82F6"/></ns4:solidFill><ns4:latin typeface="Calibri"/><ns4:ea typeface="Calibri"/></ns4:defRPr></ns4:lvl2pPr><ns4:lvl3pPr algn="l"><ns4:buNone/><ns4:defRPr sz="1600" dirty="0" b="1"><ns4:solidFill><ns4:srgbClr val="3B82F6"/></ns4:solidFill><ns4:latin typeface="Calibri"/><ns4:ea typeface="Calibri"/></ns4:defRPr></ns4:lvl3pPr><ns4:lvl4pPr algn="l"><ns4:buNone/><ns4:defRPr sz="1600" dirty="0" b="1"><ns4:solidFill><ns4:srgbClr val="3B82F6"/></ns4:solidFill><ns4:latin typeface="Calibri"/><ns4:ea typeface="Calibri"/></ns4:defRPr></ns4:lvl4pPr><ns4:lvl5pPr algn="l"><ns4:buNone/><ns4:defRPr sz="1600" dirty="0" b="1"><ns4:solidFill><ns4:srgbClr val="3B82F6"/></ns4:solidFill><ns4:latin typeface="Calibri"/><ns4:ea typeface="Calibri"/></ns4:defRPr></ns4:lvl5pPr><ns4:lvl6pPr algn="l"><ns4:buNone/><ns4:defRPr sz="1600" dirty="0" b="1"><ns4:solidFill><ns4:srgbClr val="3B82F6"/></ns4:solidFill><ns4:latin typeface="Calibri"/><ns4:ea typeface="Calibri"/></ns4:defRPr></ns4:lvl6pPr><ns4:lvl7pPr algn="l"><ns4:buNone/><ns4:defRPr sz="1600" dirty="0" b="1"><ns4:solidFill><ns4:srgbClr val="3B82F6"/></ns4:solidFill><ns4:latin typeface="Calibri"/><ns4:ea typeface="Calibri"/></ns4:defRPr></ns4:lvl7pPr><ns4:lvl8pPr algn="l"><ns4:buNone/><ns4:defRPr sz="1600" dirty="0" b="1"><ns4:solidFill><ns4:srgbClr val="3B82F6"/></ns4:solidFill><ns4:latin typeface="Calibri"/><ns4:ea typeface="Calibri"/></ns4:defRPr></ns4:lvl8pPr><ns4:lvl9pPr algn="l"><ns4:buNone/><ns4:defRPr sz="1600" dirty="0" b="1"><ns4:solidFill><ns4:srgbClr val="3B82F6"/></ns4:solidFill><ns4:latin typeface="Calibri"/><ns4:ea typeface="Calibri"/></ns4:defRPr></ns4:lvl9pPr></ns4:lstStyle/><ns5:p xmlns:ns5="http://schemas.openxmlformats.org/drawingml/2006/main"><ns5:pPr algn="l"><ns5:buNone/></ns5:pPr><ns5:r><ns5:rPr lang="ja-JP"/><ns5:t>内容を入力</ns5:t></ns5:r></ns5:p></ns0:txBody></ns0:sp><ns0:sp><ns0:nvSpPr><ns0:cNvPr id="22" name="OptionLabel2.Right"/><ns0:cNvSpPr><ns1:spLocks xmlns:ns1="http://schemas.openxmlformats.org/drawingml/2006/main" noGrp="1"/></ns0:cNvSpPr><ns0:nvPr><ns0:ph idx="3" type="body"/></ns0:nvPr></ns0:nvSpPr><ns0:spPr><ns2:xfrm xmlns:ns2="http://schemas.openxmlformats.org/drawingml/2006/main"><ns2:off x="6400800" y="1554480"/><ns2:ext cx="4846320" cy="457200"/></ns2:xfrm></ns0:spPr><ns0:txBody><ns3:bodyPr xmlns:ns3="http://schemas.openxmlformats.org/drawingml/2006/main" wrap="square" anchor="t" anchorCtr="0"/><ns4:lstStyle><ns4:defPPr><ns4:defRPr sz="1600" b="1"><ns4:solidFill><ns4:srgbClr val="06B6D4"/></ns4:solidFill></ns4:defRPr></ns4:defPPr></ns4:lstStyle><ns4:defPPr algn="l"><ns4:buNone/><ns4:defRPr sz="1600" dirty="0" b="1"><ns4:solidFill><ns4:srgbClr val="06B6D4"/></ns4:solidFill><ns4:latin typeface="Calibri"/><ns4:ea typeface="Calibri"/></ns4:defRPr></ns4:defPPr><ns4:lvl1pPr algn="l"><ns4:buNone/><ns4:defRPr sz="1600" dirty="0" b="1"><ns4:solidFill><ns4:srgbClr val="06B6D4"/></ns4:solidFill><ns4:latin typeface="Calibri"/><ns4:ea typeface="Calibri"/></ns4:defRPr></ns4:lvl1pPr><ns4:lvl2pPr algn="l"><ns4:buNone/><ns4:defRPr sz="1600" dirty="0" b="1"><ns4:solidFill><ns4:srgbClr val="06B6D4"/></ns4:solidFill><ns4:latin typeface="Calibri"/><ns4:ea typeface="Calibri"/></ns4:defRPr></ns4:lvl2pPr><ns4:lvl3pPr algn="l"><ns4:buNone/><ns4:defRPr sz="1600" dirty="0" b="1"><ns4:solidFill><ns4:srgbClr val="06B6D4"/></ns4:solidFill><ns4:latin typeface="Calibri"/><ns4:ea typeface="Calibri"/></ns4:defRPr></ns4:lvl3pPr><ns4:lvl4pPr algn="l"><ns4:buNone/><ns4:defRPr sz="1600" dirty="0" b="1"><ns4:solidFill><ns4:srgbClr val="06B6D4"/></ns4:solidFill><ns4:latin typeface="Calibri"/><ns4:ea typeface="Calibri"/></ns4:defRPr></ns4:lvl4pPr><ns4:lvl5pPr algn="l"><ns4:buNone/><ns4:defRPr sz="1600" dirty="0" b="1"><ns4:solidFill><ns4:srgbClr val="06B6D4"/></ns4:solidFill><ns4:latin typeface="Calibri"/><ns4:ea typeface="Calibri"/></ns4:defRPr></ns4:lvl5pPr><ns4:lvl6pPr algn="l"><ns4:buNone/><ns4:defRPr sz="1600" dirty="0" b="1"><ns4:solidFill><ns4:srgbClr val="06B6D4"/></ns4:solidFill><ns4:latin typeface="Calibri"/><ns4:ea typeface="Calibri"/></ns4:defRPr></ns4:lvl6pPr><ns4:lvl7pPr algn="l"><ns4:buNone/><ns4:defRPr sz="1600" dirty="0" b="1"><ns4:solidFill><ns4:srgbClr val="06B6D4"/></ns4:solidFill><ns4:latin typeface="Calibri"/><ns4:ea typeface="Calibri"/></ns4:defRPr></ns4:lvl7pPr><ns4:lvl8pPr algn="l"><ns4:buNone/><ns4:defRPr sz="1600" dirty="0" b="1"><ns4:solidFill><ns4:srgbClr val="06B6D4"/></ns4:solidFill><ns4:latin typeface="Calibri"/><ns4:ea typeface="Calibri"/></ns4:defRPr></ns4:lvl8pPr><ns4:lvl9pPr algn="l"><ns4:buNone/><ns4:defRPr sz="1600" dirty="0" b="1"><ns4:solidFill><ns4:srgbClr val="06B6D4"/></ns4:solidFill><ns4:latin typeface="Calibri"/><ns4:ea typeface="Calibri"/></ns4:defRPr></ns4:lvl9pPr></ns4:lstStyle/><ns5:p xmlns:ns5="http://schemas.openxmlformats.org/drawingml/2006/main"><ns5:pPr algn="l"><ns5:buNone/></ns5:pPr><ns5:r><ns5:rPr lang="ja-JP"/><ns5:t>内容を入力</ns5:t></ns5:r></ns5:p></ns0:txBody></ns0:sp><ns0:sp><ns0:nvSpPr><ns0:cNvPr id="30" name="SlideNum.Footer"/><ns0:cNvSpPr><ns1:spLocks xmlns:ns1="http://schemas.openxmlformats.org/drawingml/2006/main" noGrp="1"/></ns0:cNvSpPr><ns0:nvPr><ns0:ph idx="50" type="sldNum"/></ns0:nvPr></ns0:nvSpPr><ns0:spPr><ns2:xfrm xmlns:ns2="http://schemas.openxmlformats.org/drawingml/2006/main"><ns2:off x="10972800" y="6446520"/><ns2:ext cx="1097280" cy="274320"/></ns2:xfrm></ns0:spPr><ns0:txBody><ns3:bodyPr xmlns:ns3="http://schemas.openxmlformats.org/drawingml/2006/main" wrap="square" anchor="t" anchorCtr="0"/><ns4:lstStyle><ns4:defPPr algn="r"><ns4:defRPr sz="1000"><ns4:solidFill><ns4:srgbClr val="94A3B8"/></ns4:solidFill></ns4:defRPr></ns4:defPPr></ns4:lstStyle><ns4:defPPr algn="r"><ns4:buNone/><ns4:defRPr sz="1000" dirty="0"><ns4:solidFill><ns4:srgbClr val="94A3B8"/></ns4:solidFill><ns4:latin typeface="Calibri"/><ns4:ea typeface="Calibri"/></ns4:defRPr></ns4:defPPr><ns4:lvl1pPr algn="r"><ns4:buNone/><ns4:defRPr sz="1000" dirty="0"><ns4:solidFill><ns4:srgbClr val="94A3B8"/></ns4:solidFill><ns4:latin typeface="Calibri"/><ns4:ea typeface="Calibri"/></ns4:defRPr></ns4:lvl1pPr><ns4:lvl2pPr algn="r"><ns4:buNone/><ns4:defRPr sz="1000" dirty="0"><ns4:solidFill><ns4:srgbClr val="94A3B8"/></ns4:solidFill><ns4:latin typeface="Calibri"/><ns4:ea typeface="Calibri"/></ns4:defRPr></ns4:lvl2pPr><ns4:lvl3pPr algn="r"><ns4:buNone/><ns4:defRPr sz="1000" dirty="0"><ns4:solidFill><ns4:srgbClr val="94A3B8"/></ns4:solidFill><ns4:latin typeface="Calibri"/><ns4:ea typeface="Calibri"/></ns4:defRPr></ns4:lvl3pPr><ns4:lvl4pPr algn="r"><ns4:buNone/><ns4:defRPr sz="1000" dirty="0"><ns4:solidFill><ns4:srgbClr val="94A3B8"/></ns4:solidFill><ns4:latin typeface="Calibri"/><ns4:ea typeface="Calibri"/></ns4:defRPr></ns4:lvl4pPr><ns4:lvl5pPr algn="r"><ns4:buNone/><ns4:defRPr sz="1000" dirty="0"><ns4:solidFill><ns4:srgbClr val="94A3B8"/></ns4:solidFill><ns4:latin typeface="Calibri"/><ns4:ea typeface="Calibri"/></ns4:defRPr></ns4:lvl5pPr><ns4:lvl6pPr algn="r"><ns4:buNone/><ns4:defRPr sz="1000" dirty="0"><ns4:solidFill><ns4:srgbClr val="94A3B8"/></ns4:solidFill><ns4:latin typeface="Calibri"/><ns4:ea typeface="Calibri"/></ns4:defRPr></ns4:lvl6pPr><ns4:lvl7pPr algn="r"><ns4:buNone/><ns4:defRPr sz="1000" dirty="0"><ns4:solidFill><ns4:srgbClr val="94A3B8"/></ns4:solidFill><ns4:latin typeface="Calibri"/><ns4:ea typeface="Calibri"/></ns4:defRPr></ns4:lvl7pPr><ns4:lvl8pPr algn="r"><ns4:buNone/><ns4:defRPr sz="1000" dirty="0"><ns4:solidFill><ns4:srgbClr val="94A3B8"/></ns4:solidFill><ns4:latin typeface="Calibri"/><ns4:ea typeface="Calibri"/></ns4:defRPr></ns4:lvl8pPr><ns4:lvl9pPr algn="r"><ns4:buNone/><ns4:defRPr sz="1000" dirty="0"><ns4:solidFill><ns4:srgbClr val="94A3B8"/></ns4:solidFill><ns4:latin typeface="Calibri"/><ns4:ea typeface="Calibri"/></ns4:defRPr></ns4:lvl9pPr></ns4:lstStyle><ns5:p xmlns:ns5="http://schemas.openxmlformats.org/drawingml/2006/main"><ns5:pPr algn="r"><ns5:buNone/></ns5:pPr><ns5:r><ns5:rPr lang="ja-JP"/><ns5:t>&lt;#&gt;</ns5:t></ns5:r></ns5:p></ns0:txBody></ns0:sp></ns0:spTree></ns0:cSld><ns0:clrMapOvr/></ns0:sldLayout>
+<file path=ppt/slideLayouts/slideLayout23.xml><?xml version='1.0' encoding='UTF-8' standalone='yes'?><p:sldLayout xmlns:a="http://schemas.openxmlformats.org/drawingml/2006/main" xmlns:p="http://schemas.openxmlformats.org/presentationml/2006/main" xmlns:r="http://schemas.openxmlformats.org/officeDocument/2006/relationships" type="blank" preserve="1"><p:cSld name="Compare.2Option.Versus"><p:spTree><p:nvGrpSpPr><p:cNvPr id="1" name=""/><p:cNvGrpSpPr/><p:nvPr/></p:nvGrpSpPr><p:grpSpPr><a:xfrm><a:off x="0" y="0"/><a:ext cx="0" cy="0"/><a:chOff x="0" y="0"/><a:chExt cx="0" cy="0"/></a:xfrm></p:grpSpPr><p:sp><p:nvSpPr><p:cNvPr id="2" name="HeaderBar"/><p:cNvSpPr><a:spLocks xmlns:ns1="http://schemas.openxmlformats.org/drawingml/2006/main" noGrp="1" noSelect="0" noRot="1" noMove="1"/></p:cNvSpPr><p:nvPr/></p:nvSpPr><p:spPr><a:xfrm xmlns:ns2="http://schemas.openxmlformats.org/drawingml/2006/main"><a:off x="0" y="0"/><a:ext cx="12192000" cy="1051560"/></a:xfrm><a:prstGeom xmlns:ns3="http://schemas.openxmlformats.org/drawingml/2006/main" prst="rect"/><a:solidFill xmlns:ns4="http://schemas.openxmlformats.org/drawingml/2006/main"><a:srgbClr val="1E2761"/></a:solidFill><a:ln xmlns:ns5="http://schemas.openxmlformats.org/drawingml/2006/main"><a:noFill/></a:ln></p:spPr></p:sp><p:sp><p:nvSpPr><p:cNvPr id="3" name="PanelL"/><p:cNvSpPr><a:spLocks xmlns:ns1="http://schemas.openxmlformats.org/drawingml/2006/main" noGrp="1" noSelect="0" noRot="1" noMove="1"/></p:cNvSpPr><p:nvPr/></p:nvSpPr><p:spPr><a:xfrm xmlns:ns2="http://schemas.openxmlformats.org/drawingml/2006/main"><a:off x="457200" y="1280160"/><a:ext cx="5303520" cy="4937760"/></a:xfrm><a:prstGeom xmlns:ns3="http://schemas.openxmlformats.org/drawingml/2006/main" prst="roundRect"><a:avLst><a:gd name="adj" fmla="val 8000"/></a:avLst></p:prstGeom><a:solidFill xmlns:ns4="http://schemas.openxmlformats.org/drawingml/2006/main"><a:srgbClr val="EDF0F7"/></a:solidFill><a:ln xmlns:ns5="http://schemas.openxmlformats.org/drawingml/2006/main"><a:noFill/></a:ln></p:spPr></p:sp><p:sp><p:nvSpPr><p:cNvPr id="4" name="PanelR"/><p:cNvSpPr><a:spLocks xmlns:ns1="http://schemas.openxmlformats.org/drawingml/2006/main" noGrp="1" noSelect="0" noRot="1" noMove="1"/></p:cNvSpPr><p:nvPr/></p:nvSpPr><p:spPr><a:xfrm xmlns:ns2="http://schemas.openxmlformats.org/drawingml/2006/main"><a:off x="6126480" y="1280160"/><a:ext cx="5394960" cy="4937760"/></a:xfrm><a:prstGeom xmlns:ns3="http://schemas.openxmlformats.org/drawingml/2006/main" prst="roundRect"><a:avLst><a:gd name="adj" fmla="val 8000"/></a:avLst></p:prstGeom><a:solidFill xmlns:ns4="http://schemas.openxmlformats.org/drawingml/2006/main"><a:srgbClr val="EDF0F7"/></a:solidFill><a:ln xmlns:ns5="http://schemas.openxmlformats.org/drawingml/2006/main"><a:noFill/></a:ln></p:spPr></p:sp><p:sp><p:nvSpPr><p:cNvPr id="5" name="AccentL"/><p:cNvSpPr><a:spLocks xmlns:ns1="http://schemas.openxmlformats.org/drawingml/2006/main" noGrp="1" noSelect="0" noRot="1" noMove="1"/></p:cNvSpPr><p:nvPr/></p:nvSpPr><p:spPr><a:xfrm xmlns:ns2="http://schemas.openxmlformats.org/drawingml/2006/main"><a:off x="457200" y="1280160"/><a:ext cx="5303520" cy="54864"/></a:xfrm><a:prstGeom xmlns:ns3="http://schemas.openxmlformats.org/drawingml/2006/main" prst="rect"/><a:solidFill xmlns:ns4="http://schemas.openxmlformats.org/drawingml/2006/main"><a:srgbClr val="3B82F6"/></a:solidFill><a:ln xmlns:ns5="http://schemas.openxmlformats.org/drawingml/2006/main"><a:noFill/></a:ln></p:spPr></p:sp><p:sp><p:nvSpPr><p:cNvPr id="6" name="AccentR"/><p:cNvSpPr><a:spLocks xmlns:ns1="http://schemas.openxmlformats.org/drawingml/2006/main" noGrp="1" noSelect="0" noRot="1" noMove="1"/></p:cNvSpPr><p:nvPr/></p:nvSpPr><p:spPr><a:xfrm xmlns:ns2="http://schemas.openxmlformats.org/drawingml/2006/main"><a:off x="6126480" y="1280160"/><a:ext cx="5394960" cy="54864"/></a:xfrm><a:prstGeom xmlns:ns3="http://schemas.openxmlformats.org/drawingml/2006/main" prst="rect"/><a:solidFill xmlns:ns4="http://schemas.openxmlformats.org/drawingml/2006/main"><a:srgbClr val="06B6D4"/></a:solidFill><a:ln xmlns:ns5="http://schemas.openxmlformats.org/drawingml/2006/main"><a:noFill/></a:ln></p:spPr></p:sp><p:sp><p:nvSpPr><p:cNvPr id="7" name="VS"/><p:cNvSpPr><a:spLocks xmlns:ns1="http://schemas.openxmlformats.org/drawingml/2006/main" noGrp="1"/></p:cNvSpPr><p:nvPr/></p:nvSpPr><p:spPr><a:xfrm xmlns:ns2="http://schemas.openxmlformats.org/drawingml/2006/main"><a:off x="5309408461680" y="3428121901679"/><a:ext cx="548640" cy="548640"/></a:xfrm><a:prstGeom xmlns:ns3="http://schemas.openxmlformats.org/drawingml/2006/main" prst="ellipse"/><a:solidFill xmlns:ns4="http://schemas.openxmlformats.org/drawingml/2006/main"><a:srgbClr val="1E2761"/></a:solidFill><a:ln xmlns:ns5="http://schemas.openxmlformats.org/drawingml/2006/main"><a:noFill/></a:ln></p:spPr></p:sp><p:sp><p:nvSpPr><p:cNvPr id="8" name="SlideTitle.Header"/><p:cNvSpPr><a:spLocks noGrp="1"/></p:cNvSpPr><p:nvPr><p:ph type="body" idx="15"/></p:nvPr></p:nvSpPr><p:spPr><a:xfrm><a:off x="731520" y="91440"/><a:ext cx="9144000" cy="475488"/></a:xfrm></p:spPr><p:txBody><a:bodyPr wrap="square" anchor="t" anchorCtr="0"/><a:lstStyle><a:defPPr><a:defRPr sz="2800" b="1"><a:solidFill><a:srgbClr val="FFFFFF"/></a:solidFill></a:defRPr></a:defPPr></a:lstStyle><a:p><a:r><a:rPr lang="ja-JP"/><a:t> </a:t></a:r></a:p></p:txBody></p:sp><p:sp><p:nvSpPr><p:cNvPr id="9" name="SlideSubtitle.Header"/><p:cNvSpPr><a:spLocks noGrp="1"/></p:cNvSpPr><p:nvPr><p:ph type="body" idx="16"/></p:nvPr></p:nvSpPr><p:spPr><a:xfrm><a:off x="731520" y="658368"/><a:ext cx="9144000" cy="274320"/></a:xfrm></p:spPr><p:txBody><a:bodyPr wrap="square" anchor="t" anchorCtr="0"/><a:lstStyle><a:defPPr><a:defRPr sz="1200"><a:solidFill><a:srgbClr val="CADCFC"/></a:solidFill></a:defRPr></a:defPPr></a:lstStyle><a:p><a:r><a:rPr lang="ja-JP"/><a:t> </a:t></a:r></a:p></p:txBody></p:sp><p:sp><p:nvSpPr><p:cNvPr id="10" name="OptionLabel1.Left"/><p:cNvSpPr><a:spLocks noGrp="1"/></p:cNvSpPr><p:nvPr><p:ph type="body" idx="1"/></p:nvPr></p:nvSpPr><p:spPr><a:xfrm><a:off x="731520" y="1554480"/><a:ext cx="4754880" cy="457200"/></a:xfrm></p:spPr><p:txBody><a:bodyPr wrap="square" anchor="t" anchorCtr="0"/><a:lstStyle><a:defPPr><a:defRPr sz="1600" b="1"><a:solidFill><a:srgbClr val="3B82F6"/></a:solidFill></a:defRPr></a:defPPr></a:lstStyle><a:p><a:r><a:rPr lang="ja-JP"/><a:t> </a:t></a:r></a:p></p:txBody></p:sp><p:sp><p:nvSpPr><p:cNvPr id="11" name="OptionContent1.Left"/><p:cNvSpPr><a:spLocks noGrp="1"/></p:cNvSpPr><p:nvPr><p:ph type="body" idx="2"/></p:nvPr></p:nvSpPr><p:spPr><a:xfrm><a:off x="731520" y="2103120"/><a:ext cx="4754880" cy="3840480"/></a:xfrm></p:spPr><p:txBody><a:bodyPr wrap="square" anchor="t" anchorCtr="0"/><a:lstStyle/><a:p><a:r><a:rPr lang="ja-JP"/><a:t> </a:t></a:r></a:p></p:txBody></p:sp><p:sp><p:nvSpPr><p:cNvPr id="12" name="OptionLabel2.Right"/><p:cNvSpPr><a:spLocks noGrp="1"/></p:cNvSpPr><p:nvPr><p:ph type="body" idx="3"/></p:nvPr></p:nvSpPr><p:spPr><a:xfrm><a:off x="6400800" y="1554480"/><a:ext cx="4846320" cy="457200"/></a:xfrm></p:spPr><p:txBody><a:bodyPr wrap="square" anchor="t" anchorCtr="0"/><a:lstStyle><a:defPPr><a:defRPr sz="1600" b="1"><a:solidFill><a:srgbClr val="06B6D4"/></a:solidFill></a:defRPr></a:defPPr></a:lstStyle><a:p><a:r><a:rPr lang="ja-JP"/><a:t> </a:t></a:r></a:p></p:txBody></p:sp><p:sp><p:nvSpPr><p:cNvPr id="13" name="OptionContent2.Right"/><p:cNvSpPr><a:spLocks noGrp="1"/></p:cNvSpPr><p:nvPr><p:ph type="body" idx="4"/></p:nvPr></p:nvSpPr><p:spPr><a:xfrm><a:off x="6400800" y="2103120"/><a:ext cx="4846320" cy="3840480"/></a:xfrm></p:spPr><p:txBody><a:bodyPr wrap="square" anchor="t" anchorCtr="0"/><a:lstStyle/><a:p><a:r><a:rPr lang="ja-JP"/><a:t> </a:t></a:r></a:p></p:txBody></p:sp><p:sp><p:nvSpPr><p:cNvPr id="14" name="SlideNum.Footer"/><p:cNvSpPr><a:spLocks noGrp="1"/></p:cNvSpPr><p:nvPr><p:ph type="sldNum" idx="50"/></p:nvPr></p:nvSpPr><p:spPr><a:xfrm><a:off x="10972800" y="6446520"/><a:ext cx="1097280" cy="274320"/></a:xfrm></p:spPr><p:txBody><a:bodyPr wrap="square" anchor="t" anchorCtr="0"/><a:lstStyle><a:defPPr algn="r"><a:defRPr sz="1000"><a:solidFill><a:srgbClr val="94A3B8"/></a:solidFill></a:defRPr></a:defPPr></a:lstStyle><a:p><a:r><a:rPr lang="ja-JP"/><a:t> </a:t></a:r></a:p></p:txBody></p:sp></p:spTree></p:cSld><p:clrMapOvr/></p:sldLayout>
 </file>
 
-<file path=ppt/slideLayouts/slideLayout24.xml><?xml version='1.0' encoding='UTF-8' standalone='yes'?>
-<ns0:sldLayout xmlns:ns0="http://schemas.openxmlformats.org/presentationml/2006/main" type="blank" preserve="1"><ns0:cSld name="Compare.1Matrix.Single"><ns0:spTree><ns0:nvGrpSpPr><ns0:cNvPr id="1" name=""/><ns0:cNvGrpSpPr/><ns0:nvPr/></ns0:nvGrpSpPr><ns0:grpSpPr><ns1:xfrm xmlns:ns1="http://schemas.openxmlformats.org/drawingml/2006/main"><ns1:off x="0" y="0"/><ns1:ext cx="0" cy="0"/><ns1:chOff x="0" y="0"/><ns1:chExt cx="0" cy="0"/></ns1:xfrm></ns0:grpSpPr><ns0:sp><ns0:nvSpPr><ns0:cNvPr id="2" name="HeaderBar"/><ns0:cNvSpPr><ns1:spLocks xmlns:ns1="http://schemas.openxmlformats.org/drawingml/2006/main" noGrp="1" noSelect="0" noRot="1" noMove="1"/></ns0:cNvSpPr><ns0:nvPr/></ns0:nvSpPr><ns0:spPr><ns2:xfrm xmlns:ns2="http://schemas.openxmlformats.org/drawingml/2006/main"><ns2:off x="0" y="0"/><ns2:ext cx="12192000" cy="1051560"/></ns2:xfrm><ns3:prstGeom xmlns:ns3="http://schemas.openxmlformats.org/drawingml/2006/main" prst="rect"/><ns4:solidFill xmlns:ns4="http://schemas.openxmlformats.org/drawingml/2006/main"><ns4:srgbClr val="1E2761"/></ns4:solidFill><ns5:ln xmlns:ns5="http://schemas.openxmlformats.org/drawingml/2006/main"><ns5:noFill/></ns5:ln></ns0:spPr></ns0:sp><ns0:sp><ns0:nvSpPr><ns0:cNvPr id="10" name="SlideTitle.Header"/><ns0:cNvSpPr><ns1:spLocks xmlns:ns1="http://schemas.openxmlformats.org/drawingml/2006/main" noGrp="1"/></ns0:cNvSpPr><ns0:nvPr><ns0:ph idx="15" type="body"/></ns0:nvPr></ns0:nvSpPr><ns0:spPr><ns2:xfrm xmlns:ns2="http://schemas.openxmlformats.org/drawingml/2006/main"><ns2:off x="731520" y="91440"/><ns2:ext cx="9144000" cy="475488"/></ns2:xfrm></ns0:spPr><ns0:txBody><ns3:bodyPr xmlns:ns3="http://schemas.openxmlformats.org/drawingml/2006/main" wrap="square" anchor="t" anchorCtr="0"/><ns4:lstStyle><ns4:defPPr><ns4:defRPr sz="2800" b="1"><ns4:solidFill><ns4:srgbClr val="FFFFFF"/></ns4:solidFill></ns4:defRPr></ns4:defPPr></ns4:lstStyle><ns4:defPPr algn="l"><ns4:buNone/><ns4:defRPr sz="2800" dirty="0" b="1"><ns4:solidFill><ns4:srgbClr val="FFFFFF"/></ns4:solidFill><ns4:latin typeface="Georgia"/><ns4:ea typeface="Georgia"/></ns4:defRPr></ns4:defPPr><ns4:lvl1pPr algn="l"><ns4:buNone/><ns4:defRPr sz="2800" dirty="0" b="1"><ns4:solidFill><ns4:srgbClr val="FFFFFF"/></ns4:solidFill><ns4:latin typeface="Georgia"/><ns4:ea typeface="Georgia"/></ns4:defRPr></ns4:lvl1pPr><ns4:lvl2pPr algn="l"><ns4:buNone/><ns4:defRPr sz="2800" dirty="0" b="1"><ns4:solidFill><ns4:srgbClr val="FFFFFF"/></ns4:solidFill><ns4:latin typeface="Georgia"/><ns4:ea typeface="Georgia"/></ns4:defRPr></ns4:lvl2pPr><ns4:lvl3pPr algn="l"><ns4:buNone/><ns4:defRPr sz="2800" dirty="0" b="1"><ns4:solidFill><ns4:srgbClr val="FFFFFF"/></ns4:solidFill><ns4:latin typeface="Georgia"/><ns4:ea typeface="Georgia"/></ns4:defRPr></ns4:lvl3pPr><ns4:lvl4pPr algn="l"><ns4:buNone/><ns4:defRPr sz="2800" dirty="0" b="1"><ns4:solidFill><ns4:srgbClr val="FFFFFF"/></ns4:solidFill><ns4:latin typeface="Georgia"/><ns4:ea typeface="Georgia"/></ns4:defRPr></ns4:lvl4pPr><ns4:lvl5pPr algn="l"><ns4:buNone/><ns4:defRPr sz="2800" dirty="0" b="1"><ns4:solidFill><ns4:srgbClr val="FFFFFF"/></ns4:solidFill><ns4:latin typeface="Georgia"/><ns4:ea typeface="Georgia"/></ns4:defRPr></ns4:lvl5pPr><ns4:lvl6pPr algn="l"><ns4:buNone/><ns4:defRPr sz="2800" dirty="0" b="1"><ns4:solidFill><ns4:srgbClr val="FFFFFF"/></ns4:solidFill><ns4:latin typeface="Georgia"/><ns4:ea typeface="Georgia"/></ns4:defRPr></ns4:lvl6pPr><ns4:lvl7pPr algn="l"><ns4:buNone/><ns4:defRPr sz="2800" dirty="0" b="1"><ns4:solidFill><ns4:srgbClr val="FFFFFF"/></ns4:solidFill><ns4:latin typeface="Georgia"/><ns4:ea typeface="Georgia"/></ns4:defRPr></ns4:lvl7pPr><ns4:lvl8pPr algn="l"><ns4:buNone/><ns4:defRPr sz="2800" dirty="0" b="1"><ns4:solidFill><ns4:srgbClr val="FFFFFF"/></ns4:solidFill><ns4:latin typeface="Georgia"/><ns4:ea typeface="Georgia"/></ns4:defRPr></ns4:lvl8pPr><ns4:lvl9pPr algn="l"><ns4:buNone/><ns4:defRPr sz="2800" dirty="0" b="1"><ns4:solidFill><ns4:srgbClr val="FFFFFF"/></ns4:solidFill><ns4:latin typeface="Georgia"/><ns4:ea typeface="Georgia"/></ns4:defRPr></ns4:lvl9pPr></ns4:lstStyle/><ns5:p xmlns:ns5="http://schemas.openxmlformats.org/drawingml/2006/main"><ns5:pPr algn="l"><ns5:buNone/></ns5:pPr><ns5:r><ns5:rPr lang="ja-JP"/><ns5:t>サブタイトル</ns5:t></ns5:r></ns5:p></ns0:txBody></ns0:sp><ns0:sp><ns0:nvSpPr><ns0:cNvPr id="5" name="ContentBG"/><ns0:cNvSpPr><ns1:spLocks xmlns:ns1="http://schemas.openxmlformats.org/drawingml/2006/main" noGrp="1" noSelect="0" noRot="1" noMove="1"/></ns0:cNvSpPr><ns0:nvPr/></ns0:nvSpPr><ns0:spPr><ns2:xfrm xmlns:ns2="http://schemas.openxmlformats.org/drawingml/2006/main"><ns2:off x="457200" y="1280160"/><ns2:ext cx="11247120" cy="5029200"/></ns2:xfrm><ns3:prstGeom xmlns:ns3="http://schemas.openxmlformats.org/drawingml/2006/main" prst="rect"/><ns4:solidFill xmlns:ns4="http://schemas.openxmlformats.org/drawingml/2006/main"><ns4:srgbClr val="FFFFFF"/></ns4:solidFill><ns5:ln xmlns:ns5="http://schemas.openxmlformats.org/drawingml/2006/main"><ns5:noFill/></ns5:ln></ns0:spPr></ns0:sp><ns0:sp><ns0:nvSpPr><ns0:cNvPr id="30" name="SlideNum.Footer"/><ns0:cNvSpPr><ns1:spLocks xmlns:ns1="http://schemas.openxmlformats.org/drawingml/2006/main" noGrp="1"/></ns0:cNvSpPr><ns0:nvPr><ns0:ph idx="50" type="sldNum"/></ns0:nvPr></ns0:nvSpPr><ns0:spPr><ns2:xfrm xmlns:ns2="http://schemas.openxmlformats.org/drawingml/2006/main"><ns2:off x="10972800" y="6446520"/><ns2:ext cx="1097280" cy="274320"/></ns2:xfrm></ns0:spPr><ns0:txBody><ns3:bodyPr xmlns:ns3="http://schemas.openxmlformats.org/drawingml/2006/main" wrap="square" anchor="t" anchorCtr="0"/><ns4:lstStyle><ns4:defPPr algn="r"><ns4:defRPr sz="1000"><ns4:solidFill><ns4:srgbClr val="94A3B8"/></ns4:solidFill></ns4:defRPr></ns4:defPPr></ns4:lstStyle><ns4:defPPr algn="r"><ns4:buNone/><ns4:defRPr sz="1000" dirty="0"><ns4:solidFill><ns4:srgbClr val="94A3B8"/></ns4:solidFill><ns4:latin typeface="Calibri"/><ns4:ea typeface="Calibri"/></ns4:defRPr></ns4:defPPr><ns4:lvl1pPr algn="r"><ns4:buNone/><ns4:defRPr sz="1000" dirty="0"><ns4:solidFill><ns4:srgbClr val="94A3B8"/></ns4:solidFill><ns4:latin typeface="Calibri"/><ns4:ea typeface="Calibri"/></ns4:defRPr></ns4:lvl1pPr><ns4:lvl2pPr algn="r"><ns4:buNone/><ns4:defRPr sz="1000" dirty="0"><ns4:solidFill><ns4:srgbClr val="94A3B8"/></ns4:solidFill><ns4:latin typeface="Calibri"/><ns4:ea typeface="Calibri"/></ns4:defRPr></ns4:lvl2pPr><ns4:lvl3pPr algn="r"><ns4:buNone/><ns4:defRPr sz="1000" dirty="0"><ns4:solidFill><ns4:srgbClr val="94A3B8"/></ns4:solidFill><ns4:latin typeface="Calibri"/><ns4:ea typeface="Calibri"/></ns4:defRPr></ns4:lvl3pPr><ns4:lvl4pPr algn="r"><ns4:buNone/><ns4:defRPr sz="1000" dirty="0"><ns4:solidFill><ns4:srgbClr val="94A3B8"/></ns4:solidFill><ns4:latin typeface="Calibri"/><ns4:ea typeface="Calibri"/></ns4:defRPr></ns4:lvl4pPr><ns4:lvl5pPr algn="r"><ns4:buNone/><ns4:defRPr sz="1000" dirty="0"><ns4:solidFill><ns4:srgbClr val="94A3B8"/></ns4:solidFill><ns4:latin typeface="Calibri"/><ns4:ea typeface="Calibri"/></ns4:defRPr></ns4:lvl5pPr><ns4:lvl6pPr algn="r"><ns4:buNone/><ns4:defRPr sz="1000" dirty="0"><ns4:solidFill><ns4:srgbClr val="94A3B8"/></ns4:solidFill><ns4:latin typeface="Calibri"/><ns4:ea typeface="Calibri"/></ns4:defRPr></ns4:lvl6pPr><ns4:lvl7pPr algn="r"><ns4:buNone/><ns4:defRPr sz="1000" dirty="0"><ns4:solidFill><ns4:srgbClr val="94A3B8"/></ns4:solidFill><ns4:latin typeface="Calibri"/><ns4:ea typeface="Calibri"/></ns4:defRPr></ns4:lvl7pPr><ns4:lvl8pPr algn="r"><ns4:buNone/><ns4:defRPr sz="1000" dirty="0"><ns4:solidFill><ns4:srgbClr val="94A3B8"/></ns4:solidFill><ns4:latin typeface="Calibri"/><ns4:ea typeface="Calibri"/></ns4:defRPr></ns4:lvl8pPr><ns4:lvl9pPr algn="r"><ns4:buNone/><ns4:defRPr sz="1000" dirty="0"><ns4:solidFill><ns4:srgbClr val="94A3B8"/></ns4:solidFill><ns4:latin typeface="Calibri"/><ns4:ea typeface="Calibri"/></ns4:defRPr></ns4:lvl9pPr></ns4:lstStyle><ns5:p xmlns:ns5="http://schemas.openxmlformats.org/drawingml/2006/main"><ns5:pPr algn="r"><ns5:buNone/></ns5:pPr><ns5:r><ns5:rPr lang="ja-JP"/><ns5:t>&lt;#&gt;</ns5:t></ns5:r></ns5:p></ns0:txBody></ns0:sp></ns0:spTree></ns0:cSld><ns0:clrMapOvr/></ns0:sldLayout>
+<file path=ppt/slideLayouts/slideLayout24.xml><?xml version="1.0" encoding="utf-8"?>
+<p:sldLayout xmlns:a="http://schemas.openxmlformats.org/drawingml/2006/main" xmlns:p="http://schemas.openxmlformats.org/presentationml/2006/main" xmlns:r="http://schemas.openxmlformats.org/officeDocument/2006/relationships" type="blank" preserve="1">
+  <p:cSld name="Compare.1Matrix.Single">
+    <p:spTree>
+      <p:nvGrpSpPr>
+        <p:cNvPr id="1" name=""/>
+        <p:cNvGrpSpPr/>
+        <p:nvPr/>
+      </p:nvGrpSpPr>
+      <p:grpSpPr>
+        <a:xfrm>
+          <a:off x="0" y="0"/>
+          <a:ext cx="0" cy="0"/>
+          <a:chOff x="0" y="0"/>
+          <a:chExt cx="0" cy="0"/>
+        </a:xfrm>
+      </p:grpSpPr>
+      <p:sp>
+        <p:nvSpPr>
+          <p:cNvPr id="2" name="HeaderBar"/>
+          <p:cNvSpPr>
+            <a:spLocks xmlns:ns1="http://schemas.openxmlformats.org/drawingml/2006/main" noGrp="1" noSelect="0" noRot="1" noMove="1"/>
+          </p:cNvSpPr>
+          <p:nvPr/>
+        </p:nvSpPr>
+        <p:spPr>
+          <a:xfrm xmlns:ns2="http://schemas.openxmlformats.org/drawingml/2006/main">
+            <a:off x="0" y="0"/>
+            <a:ext cx="12192000" cy="1051560"/>
+          </a:xfrm>
+          <a:prstGeom xmlns:ns3="http://schemas.openxmlformats.org/drawingml/2006/main" prst="rect"/>
+          <a:solidFill xmlns:ns4="http://schemas.openxmlformats.org/drawingml/2006/main">
+            <a:srgbClr val="1E2761"/>
+          </a:solidFill>
+          <a:ln xmlns:ns5="http://schemas.openxmlformats.org/drawingml/2006/main">
+            <a:noFill/>
+          </a:ln>
+        </p:spPr>
+      </p:sp>
+      <p:sp>
+        <p:nvSpPr>
+          <p:cNvPr id="3" name="ContentBG"/>
+          <p:cNvSpPr>
+            <a:spLocks xmlns:ns1="http://schemas.openxmlformats.org/drawingml/2006/main" noGrp="1" noSelect="0" noRot="1" noMove="1"/>
+          </p:cNvSpPr>
+          <p:nvPr/>
+        </p:nvSpPr>
+        <p:spPr>
+          <a:xfrm xmlns:ns2="http://schemas.openxmlformats.org/drawingml/2006/main">
+            <a:off x="457200" y="1280160"/>
+            <a:ext cx="11247120" cy="5029200"/>
+          </a:xfrm>
+          <a:prstGeom xmlns:ns3="http://schemas.openxmlformats.org/drawingml/2006/main" prst="rect"/>
+          <a:solidFill xmlns:ns4="http://schemas.openxmlformats.org/drawingml/2006/main">
+            <a:srgbClr val="FFFFFF"/>
+          </a:solidFill>
+          <a:ln xmlns:ns5="http://schemas.openxmlformats.org/drawingml/2006/main">
+            <a:noFill/>
+          </a:ln>
+        </p:spPr>
+      </p:sp>
+      <p:sp>
+        <p:nvSpPr>
+          <p:cNvPr id="4" name="SlideTitle.Header"/>
+          <p:cNvSpPr>
+            <a:spLocks noGrp="1"/>
+          </p:cNvSpPr>
+          <p:nvPr>
+            <p:ph type="body" idx="15"/>
+          </p:nvPr>
+        </p:nvSpPr>
+        <p:spPr>
+          <a:xfrm>
+            <a:off x="731520" y="91440"/>
+            <a:ext cx="9144000" cy="475488"/>
+          </a:xfrm>
+        </p:spPr>
+        <p:txBody>
+          <a:bodyPr wrap="square" anchor="t" anchorCtr="0"/>
+          <a:lstStyle>
+            <a:defPPr>
+              <a:defRPr sz="2800" b="1">
+                <a:solidFill>
+                  <a:srgbClr val="FFFFFF"/>
+                </a:solidFill>
+              </a:defRPr>
+            </a:defPPr>
+          </a:lstStyle>
+          <a:p>
+            <a:r>
+              <a:rPr lang="ja-JP"/>
+              <a:t> </a:t>
+            </a:r>
+          </a:p>
+        </p:txBody>
+      </p:sp>
+      <p:sp>
+        <p:nvSpPr>
+          <p:cNvPr id="5" name="SlideSubtitle.Header"/>
+          <p:cNvSpPr>
+            <a:spLocks noGrp="1"/>
+          </p:cNvSpPr>
+          <p:nvPr>
+            <p:ph type="body" idx="16"/>
+          </p:nvPr>
+        </p:nvSpPr>
+        <p:spPr>
+          <a:xfrm>
+            <a:off x="731520" y="658368"/>
+            <a:ext cx="9144000" cy="274320"/>
+          </a:xfrm>
+        </p:spPr>
+        <p:txBody>
+          <a:bodyPr wrap="square" anchor="t" anchorCtr="0"/>
+          <a:lstStyle>
+            <a:defPPr>
+              <a:defRPr sz="1200">
+                <a:solidFill>
+                  <a:srgbClr val="CADCFC"/>
+                </a:solidFill>
+              </a:defRPr>
+            </a:defPPr>
+          </a:lstStyle>
+          <a:p>
+            <a:r>
+              <a:rPr lang="ja-JP"/>
+              <a:t> </a:t>
+            </a:r>
+          </a:p>
+        </p:txBody>
+      </p:sp>
+      <p:sp>
+        <p:nvSpPr>
+          <p:cNvPr id="6" name="SlideNum.Footer"/>
+          <p:cNvSpPr>
+            <a:spLocks noGrp="1"/>
+          </p:cNvSpPr>
+          <p:nvPr>
+            <p:ph type="sldNum" idx="50"/>
+          </p:nvPr>
+        </p:nvSpPr>
+        <p:spPr>
+          <a:xfrm>
+            <a:off x="10972800" y="6446520"/>
+            <a:ext cx="1097280" cy="274320"/>
+          </a:xfrm>
+        </p:spPr>
+        <p:txBody>
+          <a:bodyPr wrap="square" anchor="t" anchorCtr="0"/>
+          <a:lstStyle>
+            <a:defPPr algn="r">
+              <a:defRPr sz="1000">
+                <a:solidFill>
+                  <a:srgbClr val="94A3B8"/>
+                </a:solidFill>
+              </a:defRPr>
+            </a:defPPr>
+          </a:lstStyle>
+          <a:p>
+            <a:r>
+              <a:rPr lang="ja-JP"/>
+              <a:t> </a:t>
+            </a:r>
+          </a:p>
+        </p:txBody>
+      </p:sp>
+    </p:spTree>
+  </p:cSld>
+  <p:clrMapOvr/>
+</p:sldLayout>
 </file>
 
-<file path=ppt/slideLayouts/slideLayout25.xml><?xml version='1.0' encoding='UTF-8' standalone='yes'?>
-<ns0:sldLayout xmlns:ns0="http://schemas.openxmlformats.org/presentationml/2006/main" type="blank" preserve="1"><ns0:cSld name="Process.4Step.Sequential"><ns0:spTree><ns0:nvGrpSpPr><ns0:cNvPr id="1" name=""/><ns0:cNvGrpSpPr/><ns0:nvPr/></ns0:nvGrpSpPr><ns0:grpSpPr><ns1:xfrm xmlns:ns1="http://schemas.openxmlformats.org/drawingml/2006/main"><ns1:off x="0" y="0"/><ns1:ext cx="0" cy="0"/><ns1:chOff x="0" y="0"/><ns1:chExt cx="0" cy="0"/></ns1:xfrm></ns0:grpSpPr><ns0:sp><ns0:nvSpPr><ns0:cNvPr id="2" name="HeaderBar"/><ns0:cNvSpPr><ns1:spLocks xmlns:ns1="http://schemas.openxmlformats.org/drawingml/2006/main" noGrp="1" noSelect="0" noRot="1" noMove="1"/></ns0:cNvSpPr><ns0:nvPr/></ns0:nvSpPr><ns0:spPr><ns2:xfrm xmlns:ns2="http://schemas.openxmlformats.org/drawingml/2006/main"><ns2:off x="0" y="0"/><ns2:ext cx="12192000" cy="1051560"/></ns2:xfrm><ns3:prstGeom xmlns:ns3="http://schemas.openxmlformats.org/drawingml/2006/main" prst="rect"/><ns4:solidFill xmlns:ns4="http://schemas.openxmlformats.org/drawingml/2006/main"><ns4:srgbClr val="1E2761"/></ns4:solidFill><ns5:ln xmlns:ns5="http://schemas.openxmlformats.org/drawingml/2006/main"><ns5:noFill/></ns5:ln></ns0:spPr></ns0:sp><ns0:sp><ns0:nvSpPr><ns0:cNvPr id="10" name="SlideTitle.Header"/><ns0:cNvSpPr><ns1:spLocks xmlns:ns1="http://schemas.openxmlformats.org/drawingml/2006/main" noGrp="1"/></ns0:cNvSpPr><ns0:nvPr><ns0:ph idx="15" type="body"/></ns0:nvPr></ns0:nvSpPr><ns0:spPr><ns2:xfrm xmlns:ns2="http://schemas.openxmlformats.org/drawingml/2006/main"><ns2:off x="731520" y="91440"/><ns2:ext cx="9144000" cy="475488"/></ns2:xfrm></ns0:spPr><ns0:txBody><ns3:bodyPr xmlns:ns3="http://schemas.openxmlformats.org/drawingml/2006/main" wrap="square" anchor="t" anchorCtr="0"/><ns4:lstStyle><ns4:defPPr><ns4:defRPr sz="2800" b="1"><ns4:solidFill><ns4:srgbClr val="FFFFFF"/></ns4:solidFill></ns4:defRPr></ns4:defPPr></ns4:lstStyle><ns4:defPPr algn="l"><ns4:buNone/><ns4:defRPr sz="2800" dirty="0" b="1"><ns4:solidFill><ns4:srgbClr val="FFFFFF"/></ns4:solidFill><ns4:latin typeface="Georgia"/><ns4:ea typeface="Georgia"/></ns4:defRPr></ns4:defPPr><ns4:lvl1pPr algn="l"><ns4:buNone/><ns4:defRPr sz="2800" dirty="0" b="1"><ns4:solidFill><ns4:srgbClr val="FFFFFF"/></ns4:solidFill><ns4:latin typeface="Georgia"/><ns4:ea typeface="Georgia"/></ns4:defRPr></ns4:lvl1pPr><ns4:lvl2pPr algn="l"><ns4:buNone/><ns4:defRPr sz="2800" dirty="0" b="1"><ns4:solidFill><ns4:srgbClr val="FFFFFF"/></ns4:solidFill><ns4:latin typeface="Georgia"/><ns4:ea typeface="Georgia"/></ns4:defRPr></ns4:lvl2pPr><ns4:lvl3pPr algn="l"><ns4:buNone/><ns4:defRPr sz="2800" dirty="0" b="1"><ns4:solidFill><ns4:srgbClr val="FFFFFF"/></ns4:solidFill><ns4:latin typeface="Georgia"/><ns4:ea typeface="Georgia"/></ns4:defRPr></ns4:lvl3pPr><ns4:lvl4pPr algn="l"><ns4:buNone/><ns4:defRPr sz="2800" dirty="0" b="1"><ns4:solidFill><ns4:srgbClr val="FFFFFF"/></ns4:solidFill><ns4:latin typeface="Georgia"/><ns4:ea typeface="Georgia"/></ns4:defRPr></ns4:lvl4pPr><ns4:lvl5pPr algn="l"><ns4:buNone/><ns4:defRPr sz="2800" dirty="0" b="1"><ns4:solidFill><ns4:srgbClr val="FFFFFF"/></ns4:solidFill><ns4:latin typeface="Georgia"/><ns4:ea typeface="Georgia"/></ns4:defRPr></ns4:lvl5pPr><ns4:lvl6pPr algn="l"><ns4:buNone/><ns4:defRPr sz="2800" dirty="0" b="1"><ns4:solidFill><ns4:srgbClr val="FFFFFF"/></ns4:solidFill><ns4:latin typeface="Georgia"/><ns4:ea typeface="Georgia"/></ns4:defRPr></ns4:lvl6pPr><ns4:lvl7pPr algn="l"><ns4:buNone/><ns4:defRPr sz="2800" dirty="0" b="1"><ns4:solidFill><ns4:srgbClr val="FFFFFF"/></ns4:solidFill><ns4:latin typeface="Georgia"/><ns4:ea typeface="Georgia"/></ns4:defRPr></ns4:lvl7pPr><ns4:lvl8pPr algn="l"><ns4:buNone/><ns4:defRPr sz="2800" dirty="0" b="1"><ns4:solidFill><ns4:srgbClr val="FFFFFF"/></ns4:solidFill><ns4:latin typeface="Georgia"/><ns4:ea typeface="Georgia"/></ns4:defRPr></ns4:lvl8pPr><ns4:lvl9pPr algn="l"><ns4:buNone/><ns4:defRPr sz="2800" dirty="0" b="1"><ns4:solidFill><ns4:srgbClr val="FFFFFF"/></ns4:solidFill><ns4:latin typeface="Georgia"/><ns4:ea typeface="Georgia"/></ns4:defRPr></ns4:lvl9pPr></ns4:lstStyle/><ns5:p xmlns:ns5="http://schemas.openxmlformats.org/drawingml/2006/main"><ns5:pPr algn="l"><ns5:buNone/></ns5:pPr><ns5:r><ns5:rPr lang="ja-JP"/><ns5:t>サブタイトル</ns5:t></ns5:r></ns5:p></ns0:txBody></ns0:sp><ns0:sp><ns0:nvSpPr><ns0:cNvPr id="5" name="ConnLine"/><ns0:cNvSpPr><ns1:spLocks xmlns:ns1="http://schemas.openxmlformats.org/drawingml/2006/main" noGrp="1" noSelect="0" noRot="1" noMove="1"/></ns0:cNvSpPr><ns0:nvPr/></ns0:nvSpPr><ns0:spPr><ns2:xfrm xmlns:ns2="http://schemas.openxmlformats.org/drawingml/2006/main"><ns2:off x="1645920" y="2651760"/><ns2:ext cx="8869680" cy="36576"/></ns2:xfrm><ns3:prstGeom xmlns:ns3="http://schemas.openxmlformats.org/drawingml/2006/main" prst="rect"/><ns4:solidFill xmlns:ns4="http://schemas.openxmlformats.org/drawingml/2006/main"><ns4:srgbClr val="CADCFC"/></ns4:solidFill><ns5:ln xmlns:ns5="http://schemas.openxmlformats.org/drawingml/2006/main"><ns5:noFill/></ns5:ln></ns0:spPr></ns0:sp><ns0:sp><ns0:nvSpPr><ns0:cNvPr id="6" name="C1"/><ns0:cNvSpPr><ns1:spLocks xmlns:ns1="http://schemas.openxmlformats.org/drawingml/2006/main" noGrp="1"/></ns0:cNvSpPr><ns0:nvPr/></ns0:nvSpPr><ns0:spPr><ns2:xfrm xmlns:ns2="http://schemas.openxmlformats.org/drawingml/2006/main"><ns2:off x="1672254463968" y="2466575455968"/><ns2:ext cx="512064" cy="512064"/></ns2:xfrm><ns3:prstGeom xmlns:ns3="http://schemas.openxmlformats.org/drawingml/2006/main" prst="ellipse"/><ns4:solidFill xmlns:ns4="http://schemas.openxmlformats.org/drawingml/2006/main"><ns4:srgbClr val="3B82F6"/></ns4:solidFill><ns5:ln xmlns:ns5="http://schemas.openxmlformats.org/drawingml/2006/main"><ns5:noFill/></ns5:ln></ns0:spPr></ns0:sp><ns0:sp><ns0:nvSpPr><ns0:cNvPr id="7" name="C2"/><ns0:cNvSpPr><ns1:spLocks xmlns:ns1="http://schemas.openxmlformats.org/drawingml/2006/main" noGrp="1"/></ns0:cNvSpPr><ns0:nvPr/></ns0:nvSpPr><ns0:spPr><ns2:xfrm xmlns:ns2="http://schemas.openxmlformats.org/drawingml/2006/main"><ns2:off x="4347862015968" y="2466575455968"/><ns2:ext cx="512064" cy="512064"/></ns2:xfrm><ns3:prstGeom xmlns:ns3="http://schemas.openxmlformats.org/drawingml/2006/main" prst="ellipse"/><ns4:solidFill xmlns:ns4="http://schemas.openxmlformats.org/drawingml/2006/main"><ns4:srgbClr val="3B82F6"/></ns4:solidFill><ns5:ln xmlns:ns5="http://schemas.openxmlformats.org/drawingml/2006/main"><ns5:noFill/></ns5:ln></ns0:spPr></ns0:sp><ns0:sp><ns0:nvSpPr><ns0:cNvPr id="8" name="C3"/><ns0:cNvSpPr><ns1:spLocks xmlns:ns1="http://schemas.openxmlformats.org/drawingml/2006/main" noGrp="1"/></ns0:cNvSpPr><ns0:nvPr/></ns0:nvSpPr><ns0:spPr><ns2:xfrm xmlns:ns2="http://schemas.openxmlformats.org/drawingml/2006/main"><ns2:off x="7023469567968" y="2466575455968"/><ns2:ext cx="512064" cy="512064"/></ns2:xfrm><ns3:prstGeom xmlns:ns3="http://schemas.openxmlformats.org/drawingml/2006/main" prst="ellipse"/><ns4:solidFill xmlns:ns4="http://schemas.openxmlformats.org/drawingml/2006/main"><ns4:srgbClr val="3B82F6"/></ns4:solidFill><ns5:ln xmlns:ns5="http://schemas.openxmlformats.org/drawingml/2006/main"><ns5:noFill/></ns5:ln></ns0:spPr></ns0:sp><ns0:sp><ns0:nvSpPr><ns0:cNvPr id="9" name="C4"/><ns0:cNvSpPr><ns1:spLocks xmlns:ns1="http://schemas.openxmlformats.org/drawingml/2006/main" noGrp="1"/></ns0:cNvSpPr><ns0:nvPr/></ns0:nvSpPr><ns0:spPr><ns2:xfrm xmlns:ns2="http://schemas.openxmlformats.org/drawingml/2006/main"><ns2:off x="9615464383968" y="2466575455968"/><ns2:ext cx="512064" cy="512064"/></ns2:xfrm><ns3:prstGeom xmlns:ns3="http://schemas.openxmlformats.org/drawingml/2006/main" prst="ellipse"/><ns4:solidFill xmlns:ns4="http://schemas.openxmlformats.org/drawingml/2006/main"><ns4:srgbClr val="3B82F6"/></ns4:solidFill><ns5:ln xmlns:ns5="http://schemas.openxmlformats.org/drawingml/2006/main"><ns5:noFill/></ns5:ln></ns0:spPr></ns0:sp><ns0:sp><ns0:nvSpPr><ns0:cNvPr id="20" name="Step1.Left"/><ns0:cNvSpPr><ns1:spLocks xmlns:ns1="http://schemas.openxmlformats.org/drawingml/2006/main" noGrp="1"/></ns0:cNvSpPr><ns0:nvPr><ns0:ph idx="1" type="body"/></ns0:nvPr></ns0:nvSpPr><ns0:spPr><ns2:xfrm xmlns:ns2="http://schemas.openxmlformats.org/drawingml/2006/main"><ns2:off x="457200" y="3291840"/><ns2:ext cx="2560320" cy="2743200"/></ns2:xfrm></ns0:spPr><ns0:txBody><ns3:bodyPr xmlns:ns3="http://schemas.openxmlformats.org/drawingml/2006/main" wrap="square" anchor="t" anchorCtr="0"/><ns4:lstStyle><ns4:defPPr algn="ctr"><ns4:defRPr sz="1300"></ns4:defRPr></ns4:defPPr></ns4:lstStyle><ns4:defPPr algn="ctr"><ns4:buNone/><ns4:defRPr sz="1300" dirty="0"><ns4:solidFill><ns4:srgbClr val="1E293B"/></ns4:solidFill><ns4:latin typeface="Calibri"/><ns4:ea typeface="Calibri"/></ns4:defRPr></ns4:defPPr><ns4:lvl1pPr algn="ctr"><ns4:buNone/><ns4:defRPr sz="1300" dirty="0"><ns4:solidFill><ns4:srgbClr val="1E293B"/></ns4:solidFill><ns4:latin typeface="Calibri"/><ns4:ea typeface="Calibri"/></ns4:defRPr></ns4:lvl1pPr><ns4:lvl2pPr algn="ctr"><ns4:buNone/><ns4:defRPr sz="1300" dirty="0"><ns4:solidFill><ns4:srgbClr val="1E293B"/></ns4:solidFill><ns4:latin typeface="Calibri"/><ns4:ea typeface="Calibri"/></ns4:defRPr></ns4:lvl2pPr><ns4:lvl3pPr algn="ctr"><ns4:buNone/><ns4:defRPr sz="1300" dirty="0"><ns4:solidFill><ns4:srgbClr val="1E293B"/></ns4:solidFill><ns4:latin typeface="Calibri"/><ns4:ea typeface="Calibri"/></ns4:defRPr></ns4:lvl3pPr><ns4:lvl4pPr algn="ctr"><ns4:buNone/><ns4:defRPr sz="1300" dirty="0"><ns4:solidFill><ns4:srgbClr val="1E293B"/></ns4:solidFill><ns4:latin typeface="Calibri"/><ns4:ea typeface="Calibri"/></ns4:defRPr></ns4:lvl4pPr><ns4:lvl5pPr algn="ctr"><ns4:buNone/><ns4:defRPr sz="1300" dirty="0"><ns4:solidFill><ns4:srgbClr val="1E293B"/></ns4:solidFill><ns4:latin typeface="Calibri"/><ns4:ea typeface="Calibri"/></ns4:defRPr></ns4:lvl5pPr><ns4:lvl6pPr algn="ctr"><ns4:buNone/><ns4:defRPr sz="1300" dirty="0"><ns4:solidFill><ns4:srgbClr val="1E293B"/></ns4:solidFill><ns4:latin typeface="Calibri"/><ns4:ea typeface="Calibri"/></ns4:defRPr></ns4:lvl6pPr><ns4:lvl7pPr algn="ctr"><ns4:buNone/><ns4:defRPr sz="1300" dirty="0"><ns4:solidFill><ns4:srgbClr val="1E293B"/></ns4:solidFill><ns4:latin typeface="Calibri"/><ns4:ea typeface="Calibri"/></ns4:defRPr></ns4:lvl7pPr><ns4:lvl8pPr algn="ctr"><ns4:buNone/><ns4:defRPr sz="1300" dirty="0"><ns4:solidFill><ns4:srgbClr val="1E293B"/></ns4:solidFill><ns4:latin typeface="Calibri"/><ns4:ea typeface="Calibri"/></ns4:defRPr></ns4:lvl8pPr><ns4:lvl9pPr algn="ctr"><ns4:buNone/><ns4:defRPr sz="1300" dirty="0"><ns4:solidFill><ns4:srgbClr val="1E293B"/></ns4:solidFill><ns4:latin typeface="Calibri"/><ns4:ea typeface="Calibri"/></ns4:defRPr></ns4:lvl9pPr></ns4:lstStyle/><ns5:p xmlns:ns5="http://schemas.openxmlformats.org/drawingml/2006/main"><ns5:pPr algn="ctr"><ns5:buNone/></ns5:pPr><ns5:r><ns5:rPr lang="ja-JP"/><ns5:t>STEP 2
-タイトル
-説明テキスト</ns5:t></ns5:r></ns5:p></ns0:txBody></ns0:sp><ns0:sp><ns0:nvSpPr><ns0:cNvPr id="22" name="Step3.CenterRight"/><ns0:cNvSpPr><ns1:spLocks xmlns:ns1="http://schemas.openxmlformats.org/drawingml/2006/main" noGrp="1"/></ns0:cNvSpPr><ns0:nvPr><ns0:ph idx="3" type="body"/></ns0:nvPr></ns0:nvSpPr><ns0:spPr><ns2:xfrm xmlns:ns2="http://schemas.openxmlformats.org/drawingml/2006/main"><ns2:off x="6309360" y="3291840"/><ns2:ext cx="2560320" cy="2743200"/></ns2:xfrm></ns0:spPr><ns0:txBody><ns3:bodyPr xmlns:ns3="http://schemas.openxmlformats.org/drawingml/2006/main" wrap="square" anchor="t" anchorCtr="0"/><ns4:lstStyle><ns4:defPPr algn="ctr"><ns4:defRPr sz="1300"></ns4:defRPr></ns4:defPPr></ns4:lstStyle><ns4:defPPr algn="ctr"><ns4:buNone/><ns4:defRPr sz="1300" dirty="0"><ns4:solidFill><ns4:srgbClr val="1E293B"/></ns4:solidFill><ns4:latin typeface="Calibri"/><ns4:ea typeface="Calibri"/></ns4:defRPr></ns4:defPPr><ns4:lvl1pPr algn="ctr"><ns4:buNone/><ns4:defRPr sz="1300" dirty="0"><ns4:solidFill><ns4:srgbClr val="1E293B"/></ns4:solidFill><ns4:latin typeface="Calibri"/><ns4:ea typeface="Calibri"/></ns4:defRPr></ns4:lvl1pPr><ns4:lvl2pPr algn="ctr"><ns4:buNone/><ns4:defRPr sz="1300" dirty="0"><ns4:solidFill><ns4:srgbClr val="1E293B"/></ns4:solidFill><ns4:latin typeface="Calibri"/><ns4:ea typeface="Calibri"/></ns4:defRPr></ns4:lvl2pPr><ns4:lvl3pPr algn="ctr"><ns4:buNone/><ns4:defRPr sz="1300" dirty="0"><ns4:solidFill><ns4:srgbClr val="1E293B"/></ns4:solidFill><ns4:latin typeface="Calibri"/><ns4:ea typeface="Calibri"/></ns4:defRPr></ns4:lvl3pPr><ns4:lvl4pPr algn="ctr"><ns4:buNone/><ns4:defRPr sz="1300" dirty="0"><ns4:solidFill><ns4:srgbClr val="1E293B"/></ns4:solidFill><ns4:latin typeface="Calibri"/><ns4:ea typeface="Calibri"/></ns4:defRPr></ns4:lvl4pPr><ns4:lvl5pPr algn="ctr"><ns4:buNone/><ns4:defRPr sz="1300" dirty="0"><ns4:solidFill><ns4:srgbClr val="1E293B"/></ns4:solidFill><ns4:latin typeface="Calibri"/><ns4:ea typeface="Calibri"/></ns4:defRPr></ns4:lvl5pPr><ns4:lvl6pPr algn="ctr"><ns4:buNone/><ns4:defRPr sz="1300" dirty="0"><ns4:solidFill><ns4:srgbClr val="1E293B"/></ns4:solidFill><ns4:latin typeface="Calibri"/><ns4:ea typeface="Calibri"/></ns4:defRPr></ns4:lvl6pPr><ns4:lvl7pPr algn="ctr"><ns4:buNone/><ns4:defRPr sz="1300" dirty="0"><ns4:solidFill><ns4:srgbClr val="1E293B"/></ns4:solidFill><ns4:latin typeface="Calibri"/><ns4:ea typeface="Calibri"/></ns4:defRPr></ns4:lvl7pPr><ns4:lvl8pPr algn="ctr"><ns4:buNone/><ns4:defRPr sz="1300" dirty="0"><ns4:solidFill><ns4:srgbClr val="1E293B"/></ns4:solidFill><ns4:latin typeface="Calibri"/><ns4:ea typeface="Calibri"/></ns4:defRPr></ns4:lvl8pPr><ns4:lvl9pPr algn="ctr"><ns4:buNone/><ns4:defRPr sz="1300" dirty="0"><ns4:solidFill><ns4:srgbClr val="1E293B"/></ns4:solidFill><ns4:latin typeface="Calibri"/><ns4:ea typeface="Calibri"/></ns4:defRPr></ns4:lvl9pPr></ns4:lstStyle/><ns5:p xmlns:ns5="http://schemas.openxmlformats.org/drawingml/2006/main"><ns5:pPr algn="ctr"><ns5:buNone/></ns5:pPr><ns5:r><ns5:rPr lang="ja-JP"/><ns5:t>STEP 4
-タイトル
-説明テキスト</ns5:t></ns5:r></ns5:p></ns0:txBody></ns0:sp><ns0:sp><ns0:nvSpPr><ns0:cNvPr id="30" name="SlideNum.Footer"/><ns0:cNvSpPr><ns1:spLocks xmlns:ns1="http://schemas.openxmlformats.org/drawingml/2006/main" noGrp="1"/></ns0:cNvSpPr><ns0:nvPr><ns0:ph idx="50" type="sldNum"/></ns0:nvPr></ns0:nvSpPr><ns0:spPr><ns2:xfrm xmlns:ns2="http://schemas.openxmlformats.org/drawingml/2006/main"><ns2:off x="10972800" y="6446520"/><ns2:ext cx="1097280" cy="274320"/></ns2:xfrm></ns0:spPr><ns0:txBody><ns3:bodyPr xmlns:ns3="http://schemas.openxmlformats.org/drawingml/2006/main" wrap="square" anchor="t" anchorCtr="0"/><ns4:lstStyle><ns4:defPPr algn="r"><ns4:defRPr sz="1000"><ns4:solidFill><ns4:srgbClr val="94A3B8"/></ns4:solidFill></ns4:defRPr></ns4:defPPr></ns4:lstStyle><ns4:defPPr algn="r"><ns4:buNone/><ns4:defRPr sz="1000" dirty="0"><ns4:solidFill><ns4:srgbClr val="94A3B8"/></ns4:solidFill><ns4:latin typeface="Calibri"/><ns4:ea typeface="Calibri"/></ns4:defRPr></ns4:defPPr><ns4:lvl1pPr algn="r"><ns4:buNone/><ns4:defRPr sz="1000" dirty="0"><ns4:solidFill><ns4:srgbClr val="94A3B8"/></ns4:solidFill><ns4:latin typeface="Calibri"/><ns4:ea typeface="Calibri"/></ns4:defRPr></ns4:lvl1pPr><ns4:lvl2pPr algn="r"><ns4:buNone/><ns4:defRPr sz="1000" dirty="0"><ns4:solidFill><ns4:srgbClr val="94A3B8"/></ns4:solidFill><ns4:latin typeface="Calibri"/><ns4:ea typeface="Calibri"/></ns4:defRPr></ns4:lvl2pPr><ns4:lvl3pPr algn="r"><ns4:buNone/><ns4:defRPr sz="1000" dirty="0"><ns4:solidFill><ns4:srgbClr val="94A3B8"/></ns4:solidFill><ns4:latin typeface="Calibri"/><ns4:ea typeface="Calibri"/></ns4:defRPr></ns4:lvl3pPr><ns4:lvl4pPr algn="r"><ns4:buNone/><ns4:defRPr sz="1000" dirty="0"><ns4:solidFill><ns4:srgbClr val="94A3B8"/></ns4:solidFill><ns4:latin typeface="Calibri"/><ns4:ea typeface="Calibri"/></ns4:defRPr></ns4:lvl4pPr><ns4:lvl5pPr algn="r"><ns4:buNone/><ns4:defRPr sz="1000" dirty="0"><ns4:solidFill><ns4:srgbClr val="94A3B8"/></ns4:solidFill><ns4:latin typeface="Calibri"/><ns4:ea typeface="Calibri"/></ns4:defRPr></ns4:lvl5pPr><ns4:lvl6pPr algn="r"><ns4:buNone/><ns4:defRPr sz="1000" dirty="0"><ns4:solidFill><ns4:srgbClr val="94A3B8"/></ns4:solidFill><ns4:latin typeface="Calibri"/><ns4:ea typeface="Calibri"/></ns4:defRPr></ns4:lvl6pPr><ns4:lvl7pPr algn="r"><ns4:buNone/><ns4:defRPr sz="1000" dirty="0"><ns4:solidFill><ns4:srgbClr val="94A3B8"/></ns4:solidFill><ns4:latin typeface="Calibri"/><ns4:ea typeface="Calibri"/></ns4:defRPr></ns4:lvl7pPr><ns4:lvl8pPr algn="r"><ns4:buNone/><ns4:defRPr sz="1000" dirty="0"><ns4:solidFill><ns4:srgbClr val="94A3B8"/></ns4:solidFill><ns4:latin typeface="Calibri"/><ns4:ea typeface="Calibri"/></ns4:defRPr></ns4:lvl8pPr><ns4:lvl9pPr algn="r"><ns4:buNone/><ns4:defRPr sz="1000" dirty="0"><ns4:solidFill><ns4:srgbClr val="94A3B8"/></ns4:solidFill><ns4:latin typeface="Calibri"/><ns4:ea typeface="Calibri"/></ns4:defRPr></ns4:lvl9pPr></ns4:lstStyle><ns5:p xmlns:ns5="http://schemas.openxmlformats.org/drawingml/2006/main"><ns5:pPr algn="r"><ns5:buNone/></ns5:pPr><ns5:r><ns5:rPr lang="ja-JP"/><ns5:t>&lt;#&gt;</ns5:t></ns5:r></ns5:p></ns0:txBody></ns0:sp></ns0:spTree></ns0:cSld><ns0:clrMapOvr/></ns0:sldLayout>
+<file path=ppt/slideLayouts/slideLayout25.xml><?xml version="1.0" encoding="utf-8"?>
+<p:sldLayout xmlns:a="http://schemas.openxmlformats.org/drawingml/2006/main" xmlns:p="http://schemas.openxmlformats.org/presentationml/2006/main" xmlns:r="http://schemas.openxmlformats.org/officeDocument/2006/relationships" type="blank" preserve="1">
+  <p:cSld name="Process.4Step.Sequential">
+    <p:spTree>
+      <p:nvGrpSpPr>
+        <p:cNvPr id="1" name=""/>
+        <p:cNvGrpSpPr/>
+        <p:nvPr/>
+      </p:nvGrpSpPr>
+      <p:grpSpPr>
+        <a:xfrm>
+          <a:off x="0" y="0"/>
+          <a:ext cx="0" cy="0"/>
+          <a:chOff x="0" y="0"/>
+          <a:chExt cx="0" cy="0"/>
+        </a:xfrm>
+      </p:grpSpPr>
+      <p:sp>
+        <p:nvSpPr>
+          <p:cNvPr id="2" name="HeaderBar"/>
+          <p:cNvSpPr>
+            <a:spLocks xmlns:ns1="http://schemas.openxmlformats.org/drawingml/2006/main" noGrp="1" noSelect="0" noRot="1" noMove="1"/>
+          </p:cNvSpPr>
+          <p:nvPr/>
+        </p:nvSpPr>
+        <p:spPr>
+          <a:xfrm xmlns:ns2="http://schemas.openxmlformats.org/drawingml/2006/main">
+            <a:off x="0" y="0"/>
+            <a:ext cx="12192000" cy="1051560"/>
+          </a:xfrm>
+          <a:prstGeom xmlns:ns3="http://schemas.openxmlformats.org/drawingml/2006/main" prst="rect"/>
+          <a:solidFill xmlns:ns4="http://schemas.openxmlformats.org/drawingml/2006/main">
+            <a:srgbClr val="1E2761"/>
+          </a:solidFill>
+          <a:ln xmlns:ns5="http://schemas.openxmlformats.org/drawingml/2006/main">
+            <a:noFill/>
+          </a:ln>
+        </p:spPr>
+      </p:sp>
+      <p:sp>
+        <p:nvSpPr>
+          <p:cNvPr id="3" name="ConnLine"/>
+          <p:cNvSpPr>
+            <a:spLocks xmlns:ns1="http://schemas.openxmlformats.org/drawingml/2006/main" noGrp="1" noSelect="0" noRot="1" noMove="1"/>
+          </p:cNvSpPr>
+          <p:nvPr/>
+        </p:nvSpPr>
+        <p:spPr>
+          <a:xfrm xmlns:ns2="http://schemas.openxmlformats.org/drawingml/2006/main">
+            <a:off x="1645920" y="2651760"/>
+            <a:ext cx="8869680" cy="36576"/>
+          </a:xfrm>
+          <a:prstGeom xmlns:ns3="http://schemas.openxmlformats.org/drawingml/2006/main" prst="rect"/>
+          <a:solidFill xmlns:ns4="http://schemas.openxmlformats.org/drawingml/2006/main">
+            <a:srgbClr val="CADCFC"/>
+          </a:solidFill>
+          <a:ln xmlns:ns5="http://schemas.openxmlformats.org/drawingml/2006/main">
+            <a:noFill/>
+          </a:ln>
+        </p:spPr>
+      </p:sp>
+      <p:sp>
+        <p:nvSpPr>
+          <p:cNvPr id="4" name="C1"/>
+          <p:cNvSpPr>
+            <a:spLocks xmlns:ns1="http://schemas.openxmlformats.org/drawingml/2006/main" noGrp="1"/>
+          </p:cNvSpPr>
+          <p:nvPr/>
+        </p:nvSpPr>
+        <p:spPr>
+          <a:xfrm xmlns:ns2="http://schemas.openxmlformats.org/drawingml/2006/main">
+            <a:off x="1672254463968" y="2466575455968"/>
+            <a:ext cx="512064" cy="512064"/>
+          </a:xfrm>
+          <a:prstGeom xmlns:ns3="http://schemas.openxmlformats.org/drawingml/2006/main" prst="ellipse"/>
+          <a:solidFill xmlns:ns4="http://schemas.openxmlformats.org/drawingml/2006/main">
+            <a:srgbClr val="3B82F6"/>
+          </a:solidFill>
+          <a:ln xmlns:ns5="http://schemas.openxmlformats.org/drawingml/2006/main">
+            <a:noFill/>
+          </a:ln>
+        </p:spPr>
+      </p:sp>
+      <p:sp>
+        <p:nvSpPr>
+          <p:cNvPr id="5" name="C2"/>
+          <p:cNvSpPr>
+            <a:spLocks xmlns:ns1="http://schemas.openxmlformats.org/drawingml/2006/main" noGrp="1"/>
+          </p:cNvSpPr>
+          <p:nvPr/>
+        </p:nvSpPr>
+        <p:spPr>
+          <a:xfrm xmlns:ns2="http://schemas.openxmlformats.org/drawingml/2006/main">
+            <a:off x="4347862015968" y="2466575455968"/>
+            <a:ext cx="512064" cy="512064"/>
+          </a:xfrm>
+          <a:prstGeom xmlns:ns3="http://schemas.openxmlformats.org/drawingml/2006/main" prst="ellipse"/>
+          <a:solidFill xmlns:ns4="http://schemas.openxmlformats.org/drawingml/2006/main">
+            <a:srgbClr val="3B82F6"/>
+          </a:solidFill>
+          <a:ln xmlns:ns5="http://schemas.openxmlformats.org/drawingml/2006/main">
+            <a:noFill/>
+          </a:ln>
+        </p:spPr>
+      </p:sp>
+      <p:sp>
+        <p:nvSpPr>
+          <p:cNvPr id="6" name="C3"/>
+          <p:cNvSpPr>
+            <a:spLocks xmlns:ns1="http://schemas.openxmlformats.org/drawingml/2006/main" noGrp="1"/>
+          </p:cNvSpPr>
+          <p:nvPr/>
+        </p:nvSpPr>
+        <p:spPr>
+          <a:xfrm xmlns:ns2="http://schemas.openxmlformats.org/drawingml/2006/main">
+            <a:off x="7023469567968" y="2466575455968"/>
+            <a:ext cx="512064" cy="512064"/>
+          </a:xfrm>
+          <a:prstGeom xmlns:ns3="http://schemas.openxmlformats.org/drawingml/2006/main" prst="ellipse"/>
+          <a:solidFill xmlns:ns4="http://schemas.openxmlformats.org/drawingml/2006/main">
+            <a:srgbClr val="3B82F6"/>
+          </a:solidFill>
+          <a:ln xmlns:ns5="http://schemas.openxmlformats.org/drawingml/2006/main">
+            <a:noFill/>
+          </a:ln>
+        </p:spPr>
+      </p:sp>
+      <p:sp>
+        <p:nvSpPr>
+          <p:cNvPr id="7" name="C4"/>
+          <p:cNvSpPr>
+            <a:spLocks xmlns:ns1="http://schemas.openxmlformats.org/drawingml/2006/main" noGrp="1"/>
+          </p:cNvSpPr>
+          <p:nvPr/>
+        </p:nvSpPr>
+        <p:spPr>
+          <a:xfrm xmlns:ns2="http://schemas.openxmlformats.org/drawingml/2006/main">
+            <a:off x="9615464383968" y="2466575455968"/>
+            <a:ext cx="512064" cy="512064"/>
+          </a:xfrm>
+          <a:prstGeom xmlns:ns3="http://schemas.openxmlformats.org/drawingml/2006/main" prst="ellipse"/>
+          <a:solidFill xmlns:ns4="http://schemas.openxmlformats.org/drawingml/2006/main">
+            <a:srgbClr val="3B82F6"/>
+          </a:solidFill>
+          <a:ln xmlns:ns5="http://schemas.openxmlformats.org/drawingml/2006/main">
+            <a:noFill/>
+          </a:ln>
+        </p:spPr>
+      </p:sp>
+      <p:sp>
+        <p:nvSpPr>
+          <p:cNvPr id="8" name="SlideTitle.Header"/>
+          <p:cNvSpPr>
+            <a:spLocks noGrp="1"/>
+          </p:cNvSpPr>
+          <p:nvPr>
+            <p:ph type="body" idx="15"/>
+          </p:nvPr>
+        </p:nvSpPr>
+        <p:spPr>
+          <a:xfrm>
+            <a:off x="731520" y="91440"/>
+            <a:ext cx="9144000" cy="475488"/>
+          </a:xfrm>
+        </p:spPr>
+        <p:txBody>
+          <a:bodyPr wrap="square" anchor="t" anchorCtr="0"/>
+          <a:lstStyle>
+            <a:defPPr>
+              <a:defRPr sz="2800" b="1">
+                <a:solidFill>
+                  <a:srgbClr val="FFFFFF"/>
+                </a:solidFill>
+              </a:defRPr>
+            </a:defPPr>
+          </a:lstStyle>
+          <a:p>
+            <a:r>
+              <a:rPr lang="ja-JP"/>
+              <a:t> </a:t>
+            </a:r>
+          </a:p>
+        </p:txBody>
+      </p:sp>
+      <p:sp>
+        <p:nvSpPr>
+          <p:cNvPr id="9" name="SlideSubtitle.Header"/>
+          <p:cNvSpPr>
+            <a:spLocks noGrp="1"/>
+          </p:cNvSpPr>
+          <p:nvPr>
+            <p:ph type="body" idx="16"/>
+          </p:nvPr>
+        </p:nvSpPr>
+        <p:spPr>
+          <a:xfrm>
+            <a:off x="731520" y="658368"/>
+            <a:ext cx="9144000" cy="274320"/>
+          </a:xfrm>
+        </p:spPr>
+        <p:txBody>
+          <a:bodyPr wrap="square" anchor="t" anchorCtr="0"/>
+          <a:lstStyle>
+            <a:defPPr>
+              <a:defRPr sz="1200">
+                <a:solidFill>
+                  <a:srgbClr val="CADCFC"/>
+                </a:solidFill>
+              </a:defRPr>
+            </a:defPPr>
+          </a:lstStyle>
+          <a:p>
+            <a:r>
+              <a:rPr lang="ja-JP"/>
+              <a:t> </a:t>
+            </a:r>
+          </a:p>
+        </p:txBody>
+      </p:sp>
+      <p:sp>
+        <p:nvSpPr>
+          <p:cNvPr id="10" name="Step1"/>
+          <p:cNvSpPr>
+            <a:spLocks noGrp="1"/>
+          </p:cNvSpPr>
+          <p:nvPr>
+            <p:ph type="body" idx="1"/>
+          </p:nvPr>
+        </p:nvSpPr>
+        <p:spPr>
+          <a:xfrm>
+            <a:off x="457200" y="3291840"/>
+            <a:ext cx="2560320" cy="2743200"/>
+          </a:xfrm>
+        </p:spPr>
+        <p:txBody>
+          <a:bodyPr wrap="square" anchor="t" anchorCtr="0"/>
+          <a:lstStyle>
+            <a:defPPr algn="ctr">
+              <a:defRPr sz="1300"/>
+            </a:defPPr>
+          </a:lstStyle>
+          <a:p>
+            <a:r>
+              <a:rPr lang="ja-JP"/>
+              <a:t> </a:t>
+            </a:r>
+          </a:p>
+        </p:txBody>
+      </p:sp>
+      <p:sp>
+        <p:nvSpPr>
+          <p:cNvPr id="11" name="Step2"/>
+          <p:cNvSpPr>
+            <a:spLocks noGrp="1"/>
+          </p:cNvSpPr>
+          <p:nvPr>
+            <p:ph type="body" idx="2"/>
+          </p:nvPr>
+        </p:nvSpPr>
+        <p:spPr>
+          <a:xfrm>
+            <a:off x="3383280" y="3291840"/>
+            <a:ext cx="2560320" cy="2743200"/>
+          </a:xfrm>
+        </p:spPr>
+        <p:txBody>
+          <a:bodyPr wrap="square" anchor="t" anchorCtr="0"/>
+          <a:lstStyle>
+            <a:defPPr algn="ctr">
+              <a:defRPr sz="1300"/>
+            </a:defPPr>
+          </a:lstStyle>
+          <a:p>
+            <a:r>
+              <a:rPr lang="ja-JP"/>
+              <a:t> </a:t>
+            </a:r>
+          </a:p>
+        </p:txBody>
+      </p:sp>
+      <p:sp>
+        <p:nvSpPr>
+          <p:cNvPr id="12" name="Step3"/>
+          <p:cNvSpPr>
+            <a:spLocks noGrp="1"/>
+          </p:cNvSpPr>
+          <p:nvPr>
+            <p:ph type="body" idx="3"/>
+          </p:nvPr>
+        </p:nvSpPr>
+        <p:spPr>
+          <a:xfrm>
+            <a:off x="6309360" y="3291840"/>
+            <a:ext cx="2560320" cy="2743200"/>
+          </a:xfrm>
+        </p:spPr>
+        <p:txBody>
+          <a:bodyPr wrap="square" anchor="t" anchorCtr="0"/>
+          <a:lstStyle>
+            <a:defPPr algn="ctr">
+              <a:defRPr sz="1300"/>
+            </a:defPPr>
+          </a:lstStyle>
+          <a:p>
+            <a:r>
+              <a:rPr lang="ja-JP"/>
+              <a:t> </a:t>
+            </a:r>
+          </a:p>
+        </p:txBody>
+      </p:sp>
+      <p:sp>
+        <p:nvSpPr>
+          <p:cNvPr id="13" name="Step4"/>
+          <p:cNvSpPr>
+            <a:spLocks noGrp="1"/>
+          </p:cNvSpPr>
+          <p:nvPr>
+            <p:ph type="body" idx="4"/>
+          </p:nvPr>
+        </p:nvSpPr>
+        <p:spPr>
+          <a:xfrm>
+            <a:off x="9144000" y="3291840"/>
+            <a:ext cx="2560320" cy="2743200"/>
+          </a:xfrm>
+        </p:spPr>
+        <p:txBody>
+          <a:bodyPr wrap="square" anchor="t" anchorCtr="0"/>
+          <a:lstStyle>
+            <a:defPPr algn="ctr">
+              <a:defRPr sz="1300"/>
+            </a:defPPr>
+          </a:lstStyle>
+          <a:p>
+            <a:r>
+              <a:rPr lang="ja-JP"/>
+              <a:t> </a:t>
+            </a:r>
+          </a:p>
+        </p:txBody>
+      </p:sp>
+      <p:sp>
+        <p:nvSpPr>
+          <p:cNvPr id="14" name="SlideNum.Footer"/>
+          <p:cNvSpPr>
+            <a:spLocks noGrp="1"/>
+          </p:cNvSpPr>
+          <p:nvPr>
+            <p:ph type="sldNum" idx="50"/>
+          </p:nvPr>
+        </p:nvSpPr>
+        <p:spPr>
+          <a:xfrm>
+            <a:off x="10972800" y="6446520"/>
+            <a:ext cx="1097280" cy="274320"/>
+          </a:xfrm>
+        </p:spPr>
+        <p:txBody>
+          <a:bodyPr wrap="square" anchor="t" anchorCtr="0"/>
+          <a:lstStyle>
+            <a:defPPr algn="r">
+              <a:defRPr sz="1000">
+                <a:solidFill>
+                  <a:srgbClr val="94A3B8"/>
+                </a:solidFill>
+              </a:defRPr>
+            </a:defPPr>
+          </a:lstStyle>
+          <a:p>
+            <a:r>
+              <a:rPr lang="ja-JP"/>
+              <a:t> </a:t>
+            </a:r>
+          </a:p>
+        </p:txBody>
+      </p:sp>
+    </p:spTree>
+  </p:cSld>
+  <p:clrMapOvr/>
+</p:sldLayout>
 </file>
 
-<file path=ppt/slideLayouts/slideLayout26.xml><?xml version='1.0' encoding='UTF-8' standalone='yes'?>
-<ns0:sldLayout xmlns:ns0="http://schemas.openxmlformats.org/presentationml/2006/main" type="blank" preserve="1"><ns0:cSld name="Process.3Step.Sequential"><ns0:spTree><ns0:nvGrpSpPr><ns0:cNvPr id="1" name=""/><ns0:cNvGrpSpPr/><ns0:nvPr/></ns0:nvGrpSpPr><ns0:grpSpPr><ns1:xfrm xmlns:ns1="http://schemas.openxmlformats.org/drawingml/2006/main"><ns1:off x="0" y="0"/><ns1:ext cx="0" cy="0"/><ns1:chOff x="0" y="0"/><ns1:chExt cx="0" cy="0"/></ns1:xfrm></ns0:grpSpPr><ns0:sp><ns0:nvSpPr><ns0:cNvPr id="2" name="HeaderBar"/><ns0:cNvSpPr><ns1:spLocks xmlns:ns1="http://schemas.openxmlformats.org/drawingml/2006/main" noGrp="1" noSelect="0" noRot="1" noMove="1"/></ns0:cNvSpPr><ns0:nvPr/></ns0:nvSpPr><ns0:spPr><ns2:xfrm xmlns:ns2="http://schemas.openxmlformats.org/drawingml/2006/main"><ns2:off x="0" y="0"/><ns2:ext cx="12192000" cy="1051560"/></ns2:xfrm><ns3:prstGeom xmlns:ns3="http://schemas.openxmlformats.org/drawingml/2006/main" prst="rect"/><ns4:solidFill xmlns:ns4="http://schemas.openxmlformats.org/drawingml/2006/main"><ns4:srgbClr val="1E2761"/></ns4:solidFill><ns5:ln xmlns:ns5="http://schemas.openxmlformats.org/drawingml/2006/main"><ns5:noFill/></ns5:ln></ns0:spPr></ns0:sp><ns0:sp><ns0:nvSpPr><ns0:cNvPr id="10" name="SlideTitle.Header"/><ns0:cNvSpPr><ns1:spLocks xmlns:ns1="http://schemas.openxmlformats.org/drawingml/2006/main" noGrp="1"/></ns0:cNvSpPr><ns0:nvPr><ns0:ph idx="15" type="body"/></ns0:nvPr></ns0:nvSpPr><ns0:spPr><ns2:xfrm xmlns:ns2="http://schemas.openxmlformats.org/drawingml/2006/main"><ns2:off x="731520" y="91440"/><ns2:ext cx="9144000" cy="475488"/></ns2:xfrm></ns0:spPr><ns0:txBody><ns3:bodyPr xmlns:ns3="http://schemas.openxmlformats.org/drawingml/2006/main" wrap="square" anchor="t" anchorCtr="0"/><ns4:lstStyle><ns4:defPPr><ns4:defRPr sz="2800" b="1"><ns4:solidFill><ns4:srgbClr val="FFFFFF"/></ns4:solidFill></ns4:defRPr></ns4:defPPr></ns4:lstStyle><ns4:defPPr algn="l"><ns4:buNone/><ns4:defRPr sz="2800" dirty="0" b="1"><ns4:solidFill><ns4:srgbClr val="FFFFFF"/></ns4:solidFill><ns4:latin typeface="Georgia"/><ns4:ea typeface="Georgia"/></ns4:defRPr></ns4:defPPr><ns4:lvl1pPr algn="l"><ns4:buNone/><ns4:defRPr sz="2800" dirty="0" b="1"><ns4:solidFill><ns4:srgbClr val="FFFFFF"/></ns4:solidFill><ns4:latin typeface="Georgia"/><ns4:ea typeface="Georgia"/></ns4:defRPr></ns4:lvl1pPr><ns4:lvl2pPr algn="l"><ns4:buNone/><ns4:defRPr sz="2800" dirty="0" b="1"><ns4:solidFill><ns4:srgbClr val="FFFFFF"/></ns4:solidFill><ns4:latin typeface="Georgia"/><ns4:ea typeface="Georgia"/></ns4:defRPr></ns4:lvl2pPr><ns4:lvl3pPr algn="l"><ns4:buNone/><ns4:defRPr sz="2800" dirty="0" b="1"><ns4:solidFill><ns4:srgbClr val="FFFFFF"/></ns4:solidFill><ns4:latin typeface="Georgia"/><ns4:ea typeface="Georgia"/></ns4:defRPr></ns4:lvl3pPr><ns4:lvl4pPr algn="l"><ns4:buNone/><ns4:defRPr sz="2800" dirty="0" b="1"><ns4:solidFill><ns4:srgbClr val="FFFFFF"/></ns4:solidFill><ns4:latin typeface="Georgia"/><ns4:ea typeface="Georgia"/></ns4:defRPr></ns4:lvl4pPr><ns4:lvl5pPr algn="l"><ns4:buNone/><ns4:defRPr sz="2800" dirty="0" b="1"><ns4:solidFill><ns4:srgbClr val="FFFFFF"/></ns4:solidFill><ns4:latin typeface="Georgia"/><ns4:ea typeface="Georgia"/></ns4:defRPr></ns4:lvl5pPr><ns4:lvl6pPr algn="l"><ns4:buNone/><ns4:defRPr sz="2800" dirty="0" b="1"><ns4:solidFill><ns4:srgbClr val="FFFFFF"/></ns4:solidFill><ns4:latin typeface="Georgia"/><ns4:ea typeface="Georgia"/></ns4:defRPr></ns4:lvl6pPr><ns4:lvl7pPr algn="l"><ns4:buNone/><ns4:defRPr sz="2800" dirty="0" b="1"><ns4:solidFill><ns4:srgbClr val="FFFFFF"/></ns4:solidFill><ns4:latin typeface="Georgia"/><ns4:ea typeface="Georgia"/></ns4:defRPr></ns4:lvl7pPr><ns4:lvl8pPr algn="l"><ns4:buNone/><ns4:defRPr sz="2800" dirty="0" b="1"><ns4:solidFill><ns4:srgbClr val="FFFFFF"/></ns4:solidFill><ns4:latin typeface="Georgia"/><ns4:ea typeface="Georgia"/></ns4:defRPr></ns4:lvl8pPr><ns4:lvl9pPr algn="l"><ns4:buNone/><ns4:defRPr sz="2800" dirty="0" b="1"><ns4:solidFill><ns4:srgbClr val="FFFFFF"/></ns4:solidFill><ns4:latin typeface="Georgia"/><ns4:ea typeface="Georgia"/></ns4:defRPr></ns4:lvl9pPr></ns4:lstStyle/><ns5:p xmlns:ns5="http://schemas.openxmlformats.org/drawingml/2006/main"><ns5:pPr algn="l"><ns5:buNone/></ns5:pPr><ns5:r><ns5:rPr lang="ja-JP"/><ns5:t>サブタイトル</ns5:t></ns5:r></ns5:p></ns0:txBody></ns0:sp><ns0:sp><ns0:nvSpPr><ns0:cNvPr id="5" name="VLine"/><ns0:cNvSpPr><ns1:spLocks xmlns:ns1="http://schemas.openxmlformats.org/drawingml/2006/main" noGrp="1" noSelect="0" noRot="1" noMove="1"/></ns0:cNvSpPr><ns0:nvPr/></ns0:nvSpPr><ns0:spPr><ns2:xfrm xmlns:ns2="http://schemas.openxmlformats.org/drawingml/2006/main"><ns2:off x="1828800" y="1645920"/><ns2:ext cx="36576" cy="4389120"/></ns2:xfrm><ns3:prstGeom xmlns:ns3="http://schemas.openxmlformats.org/drawingml/2006/main" prst="rect"/><ns4:solidFill xmlns:ns4="http://schemas.openxmlformats.org/drawingml/2006/main"><ns4:srgbClr val="CADCFC"/></ns4:solidFill><ns5:ln xmlns:ns5="http://schemas.openxmlformats.org/drawingml/2006/main"><ns5:noFill/></ns5:ln></ns0:spPr></ns0:sp><ns0:sp><ns0:nvSpPr><ns0:cNvPr id="6" name="S1"/><ns0:cNvSpPr><ns1:spLocks xmlns:ns1="http://schemas.openxmlformats.org/drawingml/2006/main" noGrp="1"/></ns0:cNvSpPr><ns0:nvPr/></ns0:nvSpPr><ns0:spPr><ns2:xfrm xmlns:ns2="http://schemas.openxmlformats.org/drawingml/2006/main"><ns2:off x="1688977066032" y="1839479990832"/><ns2:ext cx="402336" cy="402336"/></ns2:xfrm><ns3:prstGeom xmlns:ns3="http://schemas.openxmlformats.org/drawingml/2006/main" prst="ellipse"/><ns4:solidFill xmlns:ns4="http://schemas.openxmlformats.org/drawingml/2006/main"><ns4:srgbClr val="3B82F6"/></ns4:solidFill><ns5:ln xmlns:ns5="http://schemas.openxmlformats.org/drawingml/2006/main"><ns5:noFill/></ns5:ln></ns0:spPr></ns0:sp><ns0:sp><ns0:nvSpPr><ns0:cNvPr id="7" name="S2"/><ns0:cNvSpPr><ns1:spLocks xmlns:ns1="http://schemas.openxmlformats.org/drawingml/2006/main" noGrp="1"/></ns0:cNvSpPr><ns0:nvPr/></ns0:nvSpPr><ns0:spPr><ns2:xfrm xmlns:ns2="http://schemas.openxmlformats.org/drawingml/2006/main"><ns2:off x="1688977066032" y="3177283766832"/><ns2:ext cx="402336" cy="402336"/></ns2:xfrm><ns3:prstGeom xmlns:ns3="http://schemas.openxmlformats.org/drawingml/2006/main" prst="ellipse"/><ns4:solidFill xmlns:ns4="http://schemas.openxmlformats.org/drawingml/2006/main"><ns4:srgbClr val="3B82F6"/></ns4:solidFill><ns5:ln xmlns:ns5="http://schemas.openxmlformats.org/drawingml/2006/main"><ns5:noFill/></ns5:ln></ns0:spPr></ns0:sp><ns0:sp><ns0:nvSpPr><ns0:cNvPr id="8" name="S3"/><ns0:cNvSpPr><ns1:spLocks xmlns:ns1="http://schemas.openxmlformats.org/drawingml/2006/main" noGrp="1"/></ns0:cNvSpPr><ns0:nvPr/></ns0:nvSpPr><ns0:spPr><ns2:xfrm xmlns:ns2="http://schemas.openxmlformats.org/drawingml/2006/main"><ns2:off x="1688977066032" y="4515087542832"/><ns2:ext cx="402336" cy="402336"/></ns2:xfrm><ns3:prstGeom xmlns:ns3="http://schemas.openxmlformats.org/drawingml/2006/main" prst="ellipse"/><ns4:solidFill xmlns:ns4="http://schemas.openxmlformats.org/drawingml/2006/main"><ns4:srgbClr val="3B82F6"/></ns4:solidFill><ns5:ln xmlns:ns5="http://schemas.openxmlformats.org/drawingml/2006/main"><ns5:noFill/></ns5:ln></ns0:spPr></ns0:sp><ns0:sp><ns0:nvSpPr><ns0:cNvPr id="20" name="Step1.Top"/><ns0:cNvSpPr><ns1:spLocks xmlns:ns1="http://schemas.openxmlformats.org/drawingml/2006/main" noGrp="1"/></ns0:cNvSpPr><ns0:nvPr><ns0:ph idx="1" type="body"/></ns0:nvPr></ns0:nvSpPr><ns0:spPr><ns2:xfrm xmlns:ns2="http://schemas.openxmlformats.org/drawingml/2006/main"><ns2:off x="2560320" y="1554480"/><ns2:ext cx="8686800" cy="1097280"/></ns2:xfrm></ns0:spPr><ns0:txBody><ns3:bodyPr xmlns:ns3="http://schemas.openxmlformats.org/drawingml/2006/main" wrap="square" anchor="t" anchorCtr="0"/><ns4:lstStyle/><ns4:defPPr algn="l"><ns4:buNone/><ns4:defRPr sz="1400" dirty="0"><ns4:solidFill><ns4:srgbClr val="1E293B"/></ns4:solidFill><ns4:latin typeface="Calibri"/><ns4:ea typeface="Calibri"/></ns4:defRPr></ns4:defPPr><ns4:lvl1pPr algn="l"><ns4:buNone/><ns4:defRPr sz="1400" dirty="0"><ns4:solidFill><ns4:srgbClr val="1E293B"/></ns4:solidFill><ns4:latin typeface="Calibri"/><ns4:ea typeface="Calibri"/></ns4:defRPr></ns4:lvl1pPr><ns4:lvl2pPr algn="l"><ns4:buNone/><ns4:defRPr sz="1400" dirty="0"><ns4:solidFill><ns4:srgbClr val="1E293B"/></ns4:solidFill><ns4:latin typeface="Calibri"/><ns4:ea typeface="Calibri"/></ns4:defRPr></ns4:lvl2pPr><ns4:lvl3pPr algn="l"><ns4:buNone/><ns4:defRPr sz="1400" dirty="0"><ns4:solidFill><ns4:srgbClr val="1E293B"/></ns4:solidFill><ns4:latin typeface="Calibri"/><ns4:ea typeface="Calibri"/></ns4:defRPr></ns4:lvl3pPr><ns4:lvl4pPr algn="l"><ns4:buNone/><ns4:defRPr sz="1400" dirty="0"><ns4:solidFill><ns4:srgbClr val="1E293B"/></ns4:solidFill><ns4:latin typeface="Calibri"/><ns4:ea typeface="Calibri"/></ns4:defRPr></ns4:lvl4pPr><ns4:lvl5pPr algn="l"><ns4:buNone/><ns4:defRPr sz="1400" dirty="0"><ns4:solidFill><ns4:srgbClr val="1E293B"/></ns4:solidFill><ns4:latin typeface="Calibri"/><ns4:ea typeface="Calibri"/></ns4:defRPr></ns4:lvl5pPr><ns4:lvl6pPr algn="l"><ns4:buNone/><ns4:defRPr sz="1400" dirty="0"><ns4:solidFill><ns4:srgbClr val="1E293B"/></ns4:solidFill><ns4:latin typeface="Calibri"/><ns4:ea typeface="Calibri"/></ns4:defRPr></ns4:lvl6pPr><ns4:lvl7pPr algn="l"><ns4:buNone/><ns4:defRPr sz="1400" dirty="0"><ns4:solidFill><ns4:srgbClr val="1E293B"/></ns4:solidFill><ns4:latin typeface="Calibri"/><ns4:ea typeface="Calibri"/></ns4:defRPr></ns4:lvl7pPr><ns4:lvl8pPr algn="l"><ns4:buNone/><ns4:defRPr sz="1400" dirty="0"><ns4:solidFill><ns4:srgbClr val="1E293B"/></ns4:solidFill><ns4:latin typeface="Calibri"/><ns4:ea typeface="Calibri"/></ns4:defRPr></ns4:lvl8pPr><ns4:lvl9pPr algn="l"><ns4:buNone/><ns4:defRPr sz="1400" dirty="0"><ns4:solidFill><ns4:srgbClr val="1E293B"/></ns4:solidFill><ns4:latin typeface="Calibri"/><ns4:ea typeface="Calibri"/></ns4:defRPr></ns4:lvl9pPr></ns4:lstStyle/><ns5:p xmlns:ns5="http://schemas.openxmlformats.org/drawingml/2006/main"><ns5:pPr algn="l"><ns5:buNone/></ns5:pPr><ns5:r><ns5:rPr lang="ja-JP"/><ns5:t>ステップ 2：タイトル
-説明テキスト</ns5:t></ns5:r></ns5:p></ns0:txBody></ns0:sp><ns0:sp><ns0:nvSpPr><ns0:cNvPr id="22" name="Step3.Bottom"/><ns0:cNvSpPr><ns1:spLocks xmlns:ns1="http://schemas.openxmlformats.org/drawingml/2006/main" noGrp="1"/></ns0:cNvSpPr><ns0:nvPr><ns0:ph idx="3" type="body"/></ns0:nvPr></ns0:nvSpPr><ns0:spPr><ns2:xfrm xmlns:ns2="http://schemas.openxmlformats.org/drawingml/2006/main"><ns2:off x="2560320" y="4480560"/><ns2:ext cx="8686800" cy="1097280"/></ns2:xfrm></ns0:spPr><ns0:txBody><ns3:bodyPr xmlns:ns3="http://schemas.openxmlformats.org/drawingml/2006/main" wrap="square" anchor="t" anchorCtr="0"/><ns4:lstStyle/><ns4:defPPr algn="l"><ns4:buNone/><ns4:defRPr sz="1400" dirty="0"><ns4:solidFill><ns4:srgbClr val="1E293B"/></ns4:solidFill><ns4:latin typeface="Calibri"/><ns4:ea typeface="Calibri"/></ns4:defRPr></ns4:defPPr><ns4:lvl1pPr algn="l"><ns4:buNone/><ns4:defRPr sz="1400" dirty="0"><ns4:solidFill><ns4:srgbClr val="1E293B"/></ns4:solidFill><ns4:latin typeface="Calibri"/><ns4:ea typeface="Calibri"/></ns4:defRPr></ns4:lvl1pPr><ns4:lvl2pPr algn="l"><ns4:buNone/><ns4:defRPr sz="1400" dirty="0"><ns4:solidFill><ns4:srgbClr val="1E293B"/></ns4:solidFill><ns4:latin typeface="Calibri"/><ns4:ea typeface="Calibri"/></ns4:defRPr></ns4:lvl2pPr><ns4:lvl3pPr algn="l"><ns4:buNone/><ns4:defRPr sz="1400" dirty="0"><ns4:solidFill><ns4:srgbClr val="1E293B"/></ns4:solidFill><ns4:latin typeface="Calibri"/><ns4:ea typeface="Calibri"/></ns4:defRPr></ns4:lvl3pPr><ns4:lvl4pPr algn="l"><ns4:buNone/><ns4:defRPr sz="1400" dirty="0"><ns4:solidFill><ns4:srgbClr val="1E293B"/></ns4:solidFill><ns4:latin typeface="Calibri"/><ns4:ea typeface="Calibri"/></ns4:defRPr></ns4:lvl4pPr><ns4:lvl5pPr algn="l"><ns4:buNone/><ns4:defRPr sz="1400" dirty="0"><ns4:solidFill><ns4:srgbClr val="1E293B"/></ns4:solidFill><ns4:latin typeface="Calibri"/><ns4:ea typeface="Calibri"/></ns4:defRPr></ns4:lvl5pPr><ns4:lvl6pPr algn="l"><ns4:buNone/><ns4:defRPr sz="1400" dirty="0"><ns4:solidFill><ns4:srgbClr val="1E293B"/></ns4:solidFill><ns4:latin typeface="Calibri"/><ns4:ea typeface="Calibri"/></ns4:defRPr></ns4:lvl6pPr><ns4:lvl7pPr algn="l"><ns4:buNone/><ns4:defRPr sz="1400" dirty="0"><ns4:solidFill><ns4:srgbClr val="1E293B"/></ns4:solidFill><ns4:latin typeface="Calibri"/><ns4:ea typeface="Calibri"/></ns4:defRPr></ns4:lvl7pPr><ns4:lvl8pPr algn="l"><ns4:buNone/><ns4:defRPr sz="1400" dirty="0"><ns4:solidFill><ns4:srgbClr val="1E293B"/></ns4:solidFill><ns4:latin typeface="Calibri"/><ns4:ea typeface="Calibri"/></ns4:defRPr></ns4:lvl8pPr><ns4:lvl9pPr algn="l"><ns4:buNone/><ns4:defRPr sz="1400" dirty="0"><ns4:solidFill><ns4:srgbClr val="1E293B"/></ns4:solidFill><ns4:latin typeface="Calibri"/><ns4:ea typeface="Calibri"/></ns4:defRPr></ns4:lvl9pPr></ns4:lstStyle/><ns5:p xmlns:ns5="http://schemas.openxmlformats.org/drawingml/2006/main"><ns5:pPr algn="r"><ns5:buNone/></ns5:pPr><ns5:r><ns5:rPr lang="ja-JP"/><ns5:t>&lt;#&gt;</ns5:t></ns5:r></ns5:p></ns0:txBody></ns0:sp></ns0:spTree></ns0:cSld><ns0:clrMapOvr/></ns0:sldLayout>
+<file path=ppt/slideLayouts/slideLayout26.xml><?xml version="1.0" encoding="utf-8"?>
+<p:sldLayout xmlns:a="http://schemas.openxmlformats.org/drawingml/2006/main" xmlns:p="http://schemas.openxmlformats.org/presentationml/2006/main" xmlns:r="http://schemas.openxmlformats.org/officeDocument/2006/relationships" type="blank" preserve="1">
+  <p:cSld name="Process.3Step.Sequential">
+    <p:spTree>
+      <p:nvGrpSpPr>
+        <p:cNvPr id="1" name=""/>
+        <p:cNvGrpSpPr/>
+        <p:nvPr/>
+      </p:nvGrpSpPr>
+      <p:grpSpPr>
+        <a:xfrm>
+          <a:off x="0" y="0"/>
+          <a:ext cx="0" cy="0"/>
+          <a:chOff x="0" y="0"/>
+          <a:chExt cx="0" cy="0"/>
+        </a:xfrm>
+      </p:grpSpPr>
+      <p:sp>
+        <p:nvSpPr>
+          <p:cNvPr id="2" name="HeaderBar"/>
+          <p:cNvSpPr>
+            <a:spLocks xmlns:ns1="http://schemas.openxmlformats.org/drawingml/2006/main" noGrp="1" noSelect="0" noRot="1" noMove="1"/>
+          </p:cNvSpPr>
+          <p:nvPr/>
+        </p:nvSpPr>
+        <p:spPr>
+          <a:xfrm xmlns:ns2="http://schemas.openxmlformats.org/drawingml/2006/main">
+            <a:off x="0" y="0"/>
+            <a:ext cx="12192000" cy="1051560"/>
+          </a:xfrm>
+          <a:prstGeom xmlns:ns3="http://schemas.openxmlformats.org/drawingml/2006/main" prst="rect"/>
+          <a:solidFill xmlns:ns4="http://schemas.openxmlformats.org/drawingml/2006/main">
+            <a:srgbClr val="1E2761"/>
+          </a:solidFill>
+          <a:ln xmlns:ns5="http://schemas.openxmlformats.org/drawingml/2006/main">
+            <a:noFill/>
+          </a:ln>
+        </p:spPr>
+      </p:sp>
+      <p:sp>
+        <p:nvSpPr>
+          <p:cNvPr id="3" name="VLine"/>
+          <p:cNvSpPr>
+            <a:spLocks xmlns:ns1="http://schemas.openxmlformats.org/drawingml/2006/main" noGrp="1" noSelect="0" noRot="1" noMove="1"/>
+          </p:cNvSpPr>
+          <p:nvPr/>
+        </p:nvSpPr>
+        <p:spPr>
+          <a:xfrm xmlns:ns2="http://schemas.openxmlformats.org/drawingml/2006/main">
+            <a:off x="1828800" y="1645920"/>
+            <a:ext cx="36576" cy="4389120"/>
+          </a:xfrm>
+          <a:prstGeom xmlns:ns3="http://schemas.openxmlformats.org/drawingml/2006/main" prst="rect"/>
+          <a:solidFill xmlns:ns4="http://schemas.openxmlformats.org/drawingml/2006/main">
+            <a:srgbClr val="CADCFC"/>
+          </a:solidFill>
+          <a:ln xmlns:ns5="http://schemas.openxmlformats.org/drawingml/2006/main">
+            <a:noFill/>
+          </a:ln>
+        </p:spPr>
+      </p:sp>
+      <p:sp>
+        <p:nvSpPr>
+          <p:cNvPr id="4" name="S1"/>
+          <p:cNvSpPr>
+            <a:spLocks xmlns:ns1="http://schemas.openxmlformats.org/drawingml/2006/main" noGrp="1"/>
+          </p:cNvSpPr>
+          <p:nvPr/>
+        </p:nvSpPr>
+        <p:spPr>
+          <a:xfrm xmlns:ns2="http://schemas.openxmlformats.org/drawingml/2006/main">
+            <a:off x="1688977066032" y="1839479990832"/>
+            <a:ext cx="402336" cy="402336"/>
+          </a:xfrm>
+          <a:prstGeom xmlns:ns3="http://schemas.openxmlformats.org/drawingml/2006/main" prst="ellipse"/>
+          <a:solidFill xmlns:ns4="http://schemas.openxmlformats.org/drawingml/2006/main">
+            <a:srgbClr val="3B82F6"/>
+          </a:solidFill>
+          <a:ln xmlns:ns5="http://schemas.openxmlformats.org/drawingml/2006/main">
+            <a:noFill/>
+          </a:ln>
+        </p:spPr>
+      </p:sp>
+      <p:sp>
+        <p:nvSpPr>
+          <p:cNvPr id="5" name="S2"/>
+          <p:cNvSpPr>
+            <a:spLocks xmlns:ns1="http://schemas.openxmlformats.org/drawingml/2006/main" noGrp="1"/>
+          </p:cNvSpPr>
+          <p:nvPr/>
+        </p:nvSpPr>
+        <p:spPr>
+          <a:xfrm xmlns:ns2="http://schemas.openxmlformats.org/drawingml/2006/main">
+            <a:off x="1688977066032" y="3177283766832"/>
+            <a:ext cx="402336" cy="402336"/>
+          </a:xfrm>
+          <a:prstGeom xmlns:ns3="http://schemas.openxmlformats.org/drawingml/2006/main" prst="ellipse"/>
+          <a:solidFill xmlns:ns4="http://schemas.openxmlformats.org/drawingml/2006/main">
+            <a:srgbClr val="3B82F6"/>
+          </a:solidFill>
+          <a:ln xmlns:ns5="http://schemas.openxmlformats.org/drawingml/2006/main">
+            <a:noFill/>
+          </a:ln>
+        </p:spPr>
+      </p:sp>
+      <p:sp>
+        <p:nvSpPr>
+          <p:cNvPr id="6" name="S3"/>
+          <p:cNvSpPr>
+            <a:spLocks xmlns:ns1="http://schemas.openxmlformats.org/drawingml/2006/main" noGrp="1"/>
+          </p:cNvSpPr>
+          <p:nvPr/>
+        </p:nvSpPr>
+        <p:spPr>
+          <a:xfrm xmlns:ns2="http://schemas.openxmlformats.org/drawingml/2006/main">
+            <a:off x="1688977066032" y="4515087542832"/>
+            <a:ext cx="402336" cy="402336"/>
+          </a:xfrm>
+          <a:prstGeom xmlns:ns3="http://schemas.openxmlformats.org/drawingml/2006/main" prst="ellipse"/>
+          <a:solidFill xmlns:ns4="http://schemas.openxmlformats.org/drawingml/2006/main">
+            <a:srgbClr val="3B82F6"/>
+          </a:solidFill>
+          <a:ln xmlns:ns5="http://schemas.openxmlformats.org/drawingml/2006/main">
+            <a:noFill/>
+          </a:ln>
+        </p:spPr>
+      </p:sp>
+      <p:sp>
+        <p:nvSpPr>
+          <p:cNvPr id="7" name="SlideTitle.Header"/>
+          <p:cNvSpPr>
+            <a:spLocks noGrp="1"/>
+          </p:cNvSpPr>
+          <p:nvPr>
+            <p:ph type="body" idx="15"/>
+          </p:nvPr>
+        </p:nvSpPr>
+        <p:spPr>
+          <a:xfrm>
+            <a:off x="731520" y="91440"/>
+            <a:ext cx="9144000" cy="475488"/>
+          </a:xfrm>
+        </p:spPr>
+        <p:txBody>
+          <a:bodyPr wrap="square" anchor="t" anchorCtr="0"/>
+          <a:lstStyle>
+            <a:defPPr>
+              <a:defRPr sz="2800" b="1">
+                <a:solidFill>
+                  <a:srgbClr val="FFFFFF"/>
+                </a:solidFill>
+              </a:defRPr>
+            </a:defPPr>
+          </a:lstStyle>
+          <a:p>
+            <a:r>
+              <a:rPr lang="ja-JP"/>
+              <a:t> </a:t>
+            </a:r>
+          </a:p>
+        </p:txBody>
+      </p:sp>
+      <p:sp>
+        <p:nvSpPr>
+          <p:cNvPr id="8" name="SlideSubtitle.Header"/>
+          <p:cNvSpPr>
+            <a:spLocks noGrp="1"/>
+          </p:cNvSpPr>
+          <p:nvPr>
+            <p:ph type="body" idx="16"/>
+          </p:nvPr>
+        </p:nvSpPr>
+        <p:spPr>
+          <a:xfrm>
+            <a:off x="731520" y="658368"/>
+            <a:ext cx="9144000" cy="274320"/>
+          </a:xfrm>
+        </p:spPr>
+        <p:txBody>
+          <a:bodyPr wrap="square" anchor="t" anchorCtr="0"/>
+          <a:lstStyle>
+            <a:defPPr>
+              <a:defRPr sz="1200">
+                <a:solidFill>
+                  <a:srgbClr val="CADCFC"/>
+                </a:solidFill>
+              </a:defRPr>
+            </a:defPPr>
+          </a:lstStyle>
+          <a:p>
+            <a:r>
+              <a:rPr lang="ja-JP"/>
+              <a:t> </a:t>
+            </a:r>
+          </a:p>
+        </p:txBody>
+      </p:sp>
+      <p:sp>
+        <p:nvSpPr>
+          <p:cNvPr id="9" name="Step1.Top"/>
+          <p:cNvSpPr>
+            <a:spLocks noGrp="1"/>
+          </p:cNvSpPr>
+          <p:nvPr>
+            <p:ph type="body" idx="1"/>
+          </p:nvPr>
+        </p:nvSpPr>
+        <p:spPr>
+          <a:xfrm>
+            <a:off x="2560320" y="1554480"/>
+            <a:ext cx="8686800" cy="1097280"/>
+          </a:xfrm>
+        </p:spPr>
+        <p:txBody>
+          <a:bodyPr wrap="square" anchor="t" anchorCtr="0"/>
+          <a:lstStyle/>
+          <a:p>
+            <a:r>
+              <a:rPr lang="ja-JP"/>
+              <a:t> </a:t>
+            </a:r>
+          </a:p>
+        </p:txBody>
+      </p:sp>
+      <p:sp>
+        <p:nvSpPr>
+          <p:cNvPr id="10" name="Step2.Center"/>
+          <p:cNvSpPr>
+            <a:spLocks noGrp="1"/>
+          </p:cNvSpPr>
+          <p:nvPr>
+            <p:ph type="body" idx="2"/>
+          </p:nvPr>
+        </p:nvSpPr>
+        <p:spPr>
+          <a:xfrm>
+            <a:off x="2560320" y="3017520"/>
+            <a:ext cx="8686800" cy="1097280"/>
+          </a:xfrm>
+        </p:spPr>
+        <p:txBody>
+          <a:bodyPr wrap="square" anchor="t" anchorCtr="0"/>
+          <a:lstStyle/>
+          <a:p>
+            <a:r>
+              <a:rPr lang="ja-JP"/>
+              <a:t> </a:t>
+            </a:r>
+          </a:p>
+        </p:txBody>
+      </p:sp>
+      <p:sp>
+        <p:nvSpPr>
+          <p:cNvPr id="11" name="Step3.Bottom"/>
+          <p:cNvSpPr>
+            <a:spLocks noGrp="1"/>
+          </p:cNvSpPr>
+          <p:nvPr>
+            <p:ph type="body" idx="3"/>
+          </p:nvPr>
+        </p:nvSpPr>
+        <p:spPr>
+          <a:xfrm>
+            <a:off x="2560320" y="4480560"/>
+            <a:ext cx="8686800" cy="1097280"/>
+          </a:xfrm>
+        </p:spPr>
+        <p:txBody>
+          <a:bodyPr wrap="square" anchor="t" anchorCtr="0"/>
+          <a:lstStyle/>
+          <a:p>
+            <a:r>
+              <a:rPr lang="ja-JP"/>
+              <a:t> </a:t>
+            </a:r>
+          </a:p>
+        </p:txBody>
+      </p:sp>
+      <p:sp>
+        <p:nvSpPr>
+          <p:cNvPr id="12" name="SlideNum.Footer"/>
+          <p:cNvSpPr>
+            <a:spLocks noGrp="1"/>
+          </p:cNvSpPr>
+          <p:nvPr>
+            <p:ph type="sldNum" idx="50"/>
+          </p:nvPr>
+        </p:nvSpPr>
+        <p:spPr>
+          <a:xfrm>
+            <a:off x="10972800" y="6446520"/>
+            <a:ext cx="1097280" cy="274320"/>
+          </a:xfrm>
+        </p:spPr>
+        <p:txBody>
+          <a:bodyPr wrap="square" anchor="t" anchorCtr="0"/>
+          <a:lstStyle>
+            <a:defPPr algn="r">
+              <a:defRPr sz="1000">
+                <a:solidFill>
+                  <a:srgbClr val="94A3B8"/>
+                </a:solidFill>
+              </a:defRPr>
+            </a:defPPr>
+          </a:lstStyle>
+          <a:p>
+            <a:r>
+              <a:rPr lang="ja-JP"/>
+              <a:t> </a:t>
+            </a:r>
+          </a:p>
+        </p:txBody>
+      </p:sp>
+    </p:spTree>
+  </p:cSld>
+  <p:clrMapOvr/>
+</p:sldLayout>
 </file>
 
-<file path=ppt/slideLayouts/slideLayout27.xml><?xml version='1.0' encoding='UTF-8' standalone='yes'?>
-<ns0:sldLayout xmlns:ns0="http://schemas.openxmlformats.org/presentationml/2006/main" type="blank" preserve="1"><ns0:cSld name="Summary.1Agenda.Single"><ns0:spTree><ns0:nvGrpSpPr><ns0:cNvPr id="1" name=""/><ns0:cNvGrpSpPr/><ns0:nvPr/></ns0:nvGrpSpPr><ns0:grpSpPr><ns1:xfrm xmlns:ns1="http://schemas.openxmlformats.org/drawingml/2006/main"><ns1:off x="0" y="0"/><ns1:ext cx="0" cy="0"/><ns1:chOff x="0" y="0"/><ns1:chExt cx="0" cy="0"/></ns1:xfrm></ns0:grpSpPr><ns0:sp><ns0:nvSpPr><ns0:cNvPr id="2" name="BG"/><ns0:cNvSpPr><ns1:spLocks xmlns:ns1="http://schemas.openxmlformats.org/drawingml/2006/main" noGrp="1" noSelect="0" noRot="1" noMove="1"/></ns0:cNvSpPr><ns0:nvPr/></ns0:nvSpPr><ns0:spPr><ns2:xfrm xmlns:ns2="http://schemas.openxmlformats.org/drawingml/2006/main"><ns2:off x="0" y="0"/><ns2:ext cx="12192000" cy="6858000"/></ns2:xfrm><ns3:prstGeom xmlns:ns3="http://schemas.openxmlformats.org/drawingml/2006/main" prst="rect"/><ns4:solidFill xmlns:ns4="http://schemas.openxmlformats.org/drawingml/2006/main"><ns4:srgbClr val="FFFFFF"/></ns4:solidFill><ns5:ln xmlns:ns5="http://schemas.openxmlformats.org/drawingml/2006/main"><ns5:noFill/></ns5:ln></ns0:spPr></ns0:sp><ns0:sp><ns0:nvSpPr><ns0:cNvPr id="3" name="LeftPanel"/><ns0:cNvSpPr><ns1:spLocks xmlns:ns1="http://schemas.openxmlformats.org/drawingml/2006/main" noGrp="1" noSelect="0" noRot="1" noMove="1"/></ns0:cNvSpPr><ns0:nvPr/></ns0:nvSpPr><ns0:spPr><ns2:xfrm xmlns:ns2="http://schemas.openxmlformats.org/drawingml/2006/main"><ns2:off x="0" y="0"/><ns2:ext cx="4114800" cy="6858000"/></ns2:xfrm><ns3:prstGeom xmlns:ns3="http://schemas.openxmlformats.org/drawingml/2006/main" prst="rect"/><ns4:solidFill xmlns:ns4="http://schemas.openxmlformats.org/drawingml/2006/main"><ns4:srgbClr val="1E2761"/></ns4:solidFill><ns5:ln xmlns:ns5="http://schemas.openxmlformats.org/drawingml/2006/main"><ns5:noFill/></ns5:ln></ns0:spPr></ns0:sp><ns0:sp><ns0:nvSpPr><ns0:cNvPr id="4" name="AccentBar"/><ns0:cNvSpPr><ns1:spLocks xmlns:ns1="http://schemas.openxmlformats.org/drawingml/2006/main" noGrp="1" noSelect="0" noRot="1" noMove="1"/></ns0:cNvSpPr><ns0:nvPr/></ns0:nvSpPr><ns0:spPr><ns2:xfrm xmlns:ns2="http://schemas.openxmlformats.org/drawingml/2006/main"><ns2:off x="0" y="0"/><ns2:ext cx="164592" cy="6858000"/></ns2:xfrm><ns3:prstGeom xmlns:ns3="http://schemas.openxmlformats.org/drawingml/2006/main" prst="rect"/><ns4:solidFill xmlns:ns4="http://schemas.openxmlformats.org/drawingml/2006/main"><ns4:srgbClr val="3B82F6"/></ns4:solidFill><ns5:ln xmlns:ns5="http://schemas.openxmlformats.org/drawingml/2006/main"><ns5:noFill/></ns5:ln></ns0:spPr></ns0:sp><ns0:sp><ns0:nvSpPr><ns0:cNvPr id="10" name="Title.Left"/><ns0:cNvSpPr><ns1:spLocks xmlns:ns1="http://schemas.openxmlformats.org/drawingml/2006/main" noGrp="1"/></ns0:cNvSpPr><ns0:nvPr><ns0:ph idx="15" type="body"/></ns0:nvPr></ns0:nvSpPr><ns0:spPr><ns2:xfrm xmlns:ns2="http://schemas.openxmlformats.org/drawingml/2006/main"><ns2:off x="548640" y="914400"/><ns2:ext cx="3200400" cy="1371600"/></ns2:xfrm></ns0:spPr><ns0:txBody><ns3:bodyPr xmlns:ns3="http://schemas.openxmlformats.org/drawingml/2006/main" wrap="square" anchor="t" anchorCtr="0"/><ns4:lstStyle><ns4:defPPr><ns4:defRPr sz="3600" b="1"><ns4:solidFill><ns4:srgbClr val="FFFFFF"/></ns4:solidFill></ns4:defRPr></ns4:defPPr></ns4:lstStyle><ns4:defPPr algn="l"><ns4:buNone/><ns4:defRPr sz="3600" dirty="0" b="1"><ns4:solidFill><ns4:srgbClr val="FFFFFF"/></ns4:solidFill><ns4:latin typeface="Georgia"/><ns4:ea typeface="Georgia"/></ns4:defRPr></ns4:defPPr><ns4:lvl1pPr algn="l"><ns4:buNone/><ns4:defRPr sz="3600" dirty="0" b="1"><ns4:solidFill><ns4:srgbClr val="FFFFFF"/></ns4:solidFill><ns4:latin typeface="Georgia"/><ns4:ea typeface="Georgia"/></ns4:defRPr></ns4:lvl1pPr><ns4:lvl2pPr algn="l"><ns4:buNone/><ns4:defRPr sz="3600" dirty="0" b="1"><ns4:solidFill><ns4:srgbClr val="FFFFFF"/></ns4:solidFill><ns4:latin typeface="Georgia"/><ns4:ea typeface="Georgia"/></ns4:defRPr></ns4:lvl2pPr><ns4:lvl3pPr algn="l"><ns4:buNone/><ns4:defRPr sz="3600" dirty="0" b="1"><ns4:solidFill><ns4:srgbClr val="FFFFFF"/></ns4:solidFill><ns4:latin typeface="Georgia"/><ns4:ea typeface="Georgia"/></ns4:defRPr></ns4:lvl3pPr><ns4:lvl4pPr algn="l"><ns4:buNone/><ns4:defRPr sz="3600" dirty="0" b="1"><ns4:solidFill><ns4:srgbClr val="FFFFFF"/></ns4:solidFill><ns4:latin typeface="Georgia"/><ns4:ea typeface="Georgia"/></ns4:defRPr></ns4:lvl4pPr><ns4:lvl5pPr algn="l"><ns4:buNone/><ns4:defRPr sz="3600" dirty="0" b="1"><ns4:solidFill><ns4:srgbClr val="FFFFFF"/></ns4:solidFill><ns4:latin typeface="Georgia"/><ns4:ea typeface="Georgia"/></ns4:defRPr></ns4:lvl5pPr><ns4:lvl6pPr algn="l"><ns4:buNone/><ns4:defRPr sz="3600" dirty="0" b="1"><ns4:solidFill><ns4:srgbClr val="FFFFFF"/></ns4:solidFill><ns4:latin typeface="Georgia"/><ns4:ea typeface="Georgia"/></ns4:defRPr></ns4:lvl6pPr><ns4:lvl7pPr algn="l"><ns4:buNone/><ns4:defRPr sz="3600" dirty="0" b="1"><ns4:solidFill><ns4:srgbClr val="FFFFFF"/></ns4:solidFill><ns4:latin typeface="Georgia"/><ns4:ea typeface="Georgia"/></ns4:defRPr></ns4:lvl7pPr><ns4:lvl8pPr algn="l"><ns4:buNone/><ns4:defRPr sz="3600" dirty="0" b="1"><ns4:solidFill><ns4:srgbClr val="FFFFFF"/></ns4:solidFill><ns4:latin typeface="Georgia"/><ns4:ea typeface="Georgia"/></ns4:defRPr></ns4:lvl8pPr><ns4:lvl9pPr algn="l"><ns4:buNone/><ns4:defRPr sz="3600" dirty="0" b="1"><ns4:solidFill><ns4:srgbClr val="FFFFFF"/></ns4:solidFill><ns4:latin typeface="Georgia"/><ns4:ea typeface="Georgia"/></ns4:defRPr></ns4:lvl9pPr></ns4:lstStyle/><ns5:p xmlns:ns5="http://schemas.openxmlformats.org/drawingml/2006/main"><ns5:pPr algn="l"><ns5:buNone/></ns5:pPr><ns5:r><ns5:rPr lang="ja-JP"/><ns5:t>日時：
-場所：
-所要時間：</ns5:t></ns5:r></ns5:p></ns0:txBody></ns0:sp><ns0:sp><ns0:nvSpPr><ns0:cNvPr id="20" name="AgendaItems.Right"/><ns0:cNvSpPr><ns1:spLocks xmlns:ns1="http://schemas.openxmlformats.org/drawingml/2006/main" noGrp="1"/></ns0:cNvSpPr><ns0:nvPr><ns0:ph idx="1" type="body"/></ns0:nvPr></ns0:nvSpPr><ns0:spPr><ns2:xfrm xmlns:ns2="http://schemas.openxmlformats.org/drawingml/2006/main"><ns2:off x="4572000" y="731520"/><ns2:ext cx="6858000" cy="5486400"/></ns2:xfrm></ns0:spPr><ns0:txBody><ns3:bodyPr xmlns:ns3="http://schemas.openxmlformats.org/drawingml/2006/main" wrap="square" anchor="t" anchorCtr="0"/><ns4:lstStyle><ns4:defPPr><ns4:defRPr sz="1500"></ns4:defRPr></ns4:defPPr></ns4:lstStyle><ns4:defPPr algn="l"><ns4:buNone/><ns4:defRPr sz="1500" dirty="0"><ns4:solidFill><ns4:srgbClr val="1E293B"/></ns4:solidFill><ns4:latin typeface="Calibri"/><ns4:ea typeface="Calibri"/></ns4:defRPr></ns4:defPPr><ns4:lvl1pPr algn="l"><ns4:buNone/><ns4:defRPr sz="1500" dirty="0"><ns4:solidFill><ns4:srgbClr val="1E293B"/></ns4:solidFill><ns4:latin typeface="Calibri"/><ns4:ea typeface="Calibri"/></ns4:defRPr></ns4:lvl1pPr><ns4:lvl2pPr algn="l"><ns4:buNone/><ns4:defRPr sz="1500" dirty="0"><ns4:solidFill><ns4:srgbClr val="1E293B"/></ns4:solidFill><ns4:latin typeface="Calibri"/><ns4:ea typeface="Calibri"/></ns4:defRPr></ns4:lvl2pPr><ns4:lvl3pPr algn="l"><ns4:buNone/><ns4:defRPr sz="1500" dirty="0"><ns4:solidFill><ns4:srgbClr val="1E293B"/></ns4:solidFill><ns4:latin typeface="Calibri"/><ns4:ea typeface="Calibri"/></ns4:defRPr></ns4:lvl3pPr><ns4:lvl4pPr algn="l"><ns4:buNone/><ns4:defRPr sz="1500" dirty="0"><ns4:solidFill><ns4:srgbClr val="1E293B"/></ns4:solidFill><ns4:latin typeface="Calibri"/><ns4:ea typeface="Calibri"/></ns4:defRPr></ns4:lvl4pPr><ns4:lvl5pPr algn="l"><ns4:buNone/><ns4:defRPr sz="1500" dirty="0"><ns4:solidFill><ns4:srgbClr val="1E293B"/></ns4:solidFill><ns4:latin typeface="Calibri"/><ns4:ea typeface="Calibri"/></ns4:defRPr></ns4:lvl5pPr><ns4:lvl6pPr algn="l"><ns4:buNone/><ns4:defRPr sz="1500" dirty="0"><ns4:solidFill><ns4:srgbClr val="1E293B"/></ns4:solidFill><ns4:latin typeface="Calibri"/><ns4:ea typeface="Calibri"/></ns4:defRPr></ns4:lvl6pPr><ns4:lvl7pPr algn="l"><ns4:buNone/><ns4:defRPr sz="1500" dirty="0"><ns4:solidFill><ns4:srgbClr val="1E293B"/></ns4:solidFill><ns4:latin typeface="Calibri"/><ns4:ea typeface="Calibri"/></ns4:defRPr></ns4:lvl7pPr><ns4:lvl8pPr algn="l"><ns4:buNone/><ns4:defRPr sz="1500" dirty="0"><ns4:solidFill><ns4:srgbClr val="1E293B"/></ns4:solidFill><ns4:latin typeface="Calibri"/><ns4:ea typeface="Calibri"/></ns4:defRPr></ns4:lvl8pPr><ns4:lvl9pPr algn="l"><ns4:buNone/><ns4:defRPr sz="1500" dirty="0"><ns4:solidFill><ns4:srgbClr val="1E293B"/></ns4:solidFill><ns4:latin typeface="Calibri"/><ns4:ea typeface="Calibri"/></ns4:defRPr></ns4:lvl9pPr></ns4:lstStyle><ns5:p xmlns:ns5="http://schemas.openxmlformats.org/drawingml/2006/main"><ns5:pPr algn="l"><ns5:buNone/></ns5:pPr><ns5:r><ns5:rPr lang="ja-JP"/><ns5:t>01  議題タイトル
-
-02  議題タイトル
-
-03  議題タイトル
-
-04  議題タイトル
-
-05  議題タイトル</ns5:t></ns5:r></ns5:p></ns0:txBody></ns0:sp></ns0:spTree></ns0:cSld><ns0:clrMapOvr/></ns0:sldLayout>
+<file path=ppt/slideLayouts/slideLayout27.xml><?xml version="1.0" encoding="utf-8"?>
+<p:sldLayout xmlns:a="http://schemas.openxmlformats.org/drawingml/2006/main" xmlns:p="http://schemas.openxmlformats.org/presentationml/2006/main" xmlns:r="http://schemas.openxmlformats.org/officeDocument/2006/relationships" type="blank" preserve="1">
+  <p:cSld name="Summary.1Agenda.Single">
+    <p:spTree>
+      <p:nvGrpSpPr>
+        <p:cNvPr id="1" name=""/>
+        <p:cNvGrpSpPr/>
+        <p:nvPr/>
+      </p:nvGrpSpPr>
+      <p:grpSpPr>
+        <a:xfrm>
+          <a:off x="0" y="0"/>
+          <a:ext cx="0" cy="0"/>
+          <a:chOff x="0" y="0"/>
+          <a:chExt cx="0" cy="0"/>
+        </a:xfrm>
+      </p:grpSpPr>
+      <p:sp>
+        <p:nvSpPr>
+          <p:cNvPr id="2" name="BG"/>
+          <p:cNvSpPr>
+            <a:spLocks xmlns:ns1="http://schemas.openxmlformats.org/drawingml/2006/main" noGrp="1" noSelect="0" noRot="1" noMove="1"/>
+          </p:cNvSpPr>
+          <p:nvPr/>
+        </p:nvSpPr>
+        <p:spPr>
+          <a:xfrm xmlns:ns2="http://schemas.openxmlformats.org/drawingml/2006/main">
+            <a:off x="0" y="0"/>
+            <a:ext cx="12192000" cy="6858000"/>
+          </a:xfrm>
+          <a:prstGeom xmlns:ns3="http://schemas.openxmlformats.org/drawingml/2006/main" prst="rect"/>
+          <a:solidFill xmlns:ns4="http://schemas.openxmlformats.org/drawingml/2006/main">
+            <a:srgbClr val="FFFFFF"/>
+          </a:solidFill>
+          <a:ln xmlns:ns5="http://schemas.openxmlformats.org/drawingml/2006/main">
+            <a:noFill/>
+          </a:ln>
+        </p:spPr>
+      </p:sp>
+      <p:sp>
+        <p:nvSpPr>
+          <p:cNvPr id="3" name="LeftPanel"/>
+          <p:cNvSpPr>
+            <a:spLocks xmlns:ns1="http://schemas.openxmlformats.org/drawingml/2006/main" noGrp="1" noSelect="0" noRot="1" noMove="1"/>
+          </p:cNvSpPr>
+          <p:nvPr/>
+        </p:nvSpPr>
+        <p:spPr>
+          <a:xfrm xmlns:ns2="http://schemas.openxmlformats.org/drawingml/2006/main">
+            <a:off x="0" y="0"/>
+            <a:ext cx="4114800" cy="6858000"/>
+          </a:xfrm>
+          <a:prstGeom xmlns:ns3="http://schemas.openxmlformats.org/drawingml/2006/main" prst="rect"/>
+          <a:solidFill xmlns:ns4="http://schemas.openxmlformats.org/drawingml/2006/main">
+            <a:srgbClr val="1E2761"/>
+          </a:solidFill>
+          <a:ln xmlns:ns5="http://schemas.openxmlformats.org/drawingml/2006/main">
+            <a:noFill/>
+          </a:ln>
+        </p:spPr>
+      </p:sp>
+      <p:sp>
+        <p:nvSpPr>
+          <p:cNvPr id="4" name="AccentBar"/>
+          <p:cNvSpPr>
+            <a:spLocks xmlns:ns1="http://schemas.openxmlformats.org/drawingml/2006/main" noGrp="1" noSelect="0" noRot="1" noMove="1"/>
+          </p:cNvSpPr>
+          <p:nvPr/>
+        </p:nvSpPr>
+        <p:spPr>
+          <a:xfrm xmlns:ns2="http://schemas.openxmlformats.org/drawingml/2006/main">
+            <a:off x="0" y="0"/>
+            <a:ext cx="164592" cy="6858000"/>
+          </a:xfrm>
+          <a:prstGeom xmlns:ns3="http://schemas.openxmlformats.org/drawingml/2006/main" prst="rect"/>
+          <a:solidFill xmlns:ns4="http://schemas.openxmlformats.org/drawingml/2006/main">
+            <a:srgbClr val="3B82F6"/>
+          </a:solidFill>
+          <a:ln xmlns:ns5="http://schemas.openxmlformats.org/drawingml/2006/main">
+            <a:noFill/>
+          </a:ln>
+        </p:spPr>
+      </p:sp>
+      <p:sp>
+        <p:nvSpPr>
+          <p:cNvPr id="5" name="Title.Left"/>
+          <p:cNvSpPr>
+            <a:spLocks noGrp="1"/>
+          </p:cNvSpPr>
+          <p:nvPr>
+            <p:ph type="body" idx="15"/>
+          </p:nvPr>
+        </p:nvSpPr>
+        <p:spPr>
+          <a:xfrm>
+            <a:off x="548640" y="914400"/>
+            <a:ext cx="3200400" cy="1371600"/>
+          </a:xfrm>
+        </p:spPr>
+        <p:txBody>
+          <a:bodyPr wrap="square" anchor="t" anchorCtr="0"/>
+          <a:lstStyle>
+            <a:defPPr>
+              <a:defRPr sz="3600" b="1">
+                <a:solidFill>
+                  <a:srgbClr val="FFFFFF"/>
+                </a:solidFill>
+              </a:defRPr>
+            </a:defPPr>
+          </a:lstStyle>
+          <a:p>
+            <a:r>
+              <a:rPr lang="ja-JP"/>
+              <a:t> </a:t>
+            </a:r>
+          </a:p>
+        </p:txBody>
+      </p:sp>
+      <p:sp>
+        <p:nvSpPr>
+          <p:cNvPr id="6" name="MeetingInfo.Left"/>
+          <p:cNvSpPr>
+            <a:spLocks noGrp="1"/>
+          </p:cNvSpPr>
+          <p:nvPr>
+            <p:ph type="body" idx="16"/>
+          </p:nvPr>
+        </p:nvSpPr>
+        <p:spPr>
+          <a:xfrm>
+            <a:off x="548640" y="2560320"/>
+            <a:ext cx="3200400" cy="3200400"/>
+          </a:xfrm>
+        </p:spPr>
+        <p:txBody>
+          <a:bodyPr wrap="square" anchor="t" anchorCtr="0"/>
+          <a:lstStyle>
+            <a:defPPr>
+              <a:defRPr>
+                <a:solidFill>
+                  <a:srgbClr val="CADCFC"/>
+                </a:solidFill>
+              </a:defRPr>
+            </a:defPPr>
+          </a:lstStyle>
+          <a:p>
+            <a:r>
+              <a:rPr lang="ja-JP"/>
+              <a:t> </a:t>
+            </a:r>
+          </a:p>
+        </p:txBody>
+      </p:sp>
+      <p:sp>
+        <p:nvSpPr>
+          <p:cNvPr id="7" name="AgendaItems.Right"/>
+          <p:cNvSpPr>
+            <a:spLocks noGrp="1"/>
+          </p:cNvSpPr>
+          <p:nvPr>
+            <p:ph type="body" idx="1"/>
+          </p:nvPr>
+        </p:nvSpPr>
+        <p:spPr>
+          <a:xfrm>
+            <a:off x="4572000" y="731520"/>
+            <a:ext cx="6858000" cy="5486400"/>
+          </a:xfrm>
+        </p:spPr>
+        <p:txBody>
+          <a:bodyPr wrap="square" anchor="t" anchorCtr="0"/>
+          <a:lstStyle>
+            <a:defPPr>
+              <a:defRPr sz="1500"/>
+            </a:defPPr>
+          </a:lstStyle>
+          <a:p>
+            <a:r>
+              <a:rPr lang="ja-JP"/>
+              <a:t> </a:t>
+            </a:r>
+          </a:p>
+        </p:txBody>
+      </p:sp>
+    </p:spTree>
+  </p:cSld>
+  <p:clrMapOvr/>
+</p:sldLayout>
 </file>
 
-<file path=ppt/slideLayouts/slideLayout28.xml><?xml version='1.0' encoding='UTF-8' standalone='yes'?>
-<ns0:sldLayout xmlns:ns0="http://schemas.openxmlformats.org/presentationml/2006/main" type="blank" preserve="1"><ns0:cSld name="Summary.2Block.Equal"><ns0:spTree><ns0:nvGrpSpPr><ns0:cNvPr id="1" name=""/><ns0:cNvGrpSpPr/><ns0:nvPr/></ns0:nvGrpSpPr><ns0:grpSpPr><ns1:xfrm xmlns:ns1="http://schemas.openxmlformats.org/drawingml/2006/main"><ns1:off x="0" y="0"/><ns1:ext cx="0" cy="0"/><ns1:chOff x="0" y="0"/><ns1:chExt cx="0" cy="0"/></ns1:xfrm></ns0:grpSpPr><ns0:sp><ns0:nvSpPr><ns0:cNvPr id="2" name="HeaderBar"/><ns0:cNvSpPr><ns1:spLocks xmlns:ns1="http://schemas.openxmlformats.org/drawingml/2006/main" noGrp="1" noSelect="0" noRot="1" noMove="1"/></ns0:cNvSpPr><ns0:nvPr/></ns0:nvSpPr><ns0:spPr><ns2:xfrm xmlns:ns2="http://schemas.openxmlformats.org/drawingml/2006/main"><ns2:off x="0" y="0"/><ns2:ext cx="12192000" cy="1051560"/></ns2:xfrm><ns3:prstGeom xmlns:ns3="http://schemas.openxmlformats.org/drawingml/2006/main" prst="rect"/><ns4:solidFill xmlns:ns4="http://schemas.openxmlformats.org/drawingml/2006/main"><ns4:srgbClr val="1E2761"/></ns4:solidFill><ns5:ln xmlns:ns5="http://schemas.openxmlformats.org/drawingml/2006/main"><ns5:noFill/></ns5:ln></ns0:spPr></ns0:sp><ns0:sp><ns0:nvSpPr><ns0:cNvPr id="10" name="SlideTitle.Header"/><ns0:cNvSpPr><ns1:spLocks xmlns:ns1="http://schemas.openxmlformats.org/drawingml/2006/main" noGrp="1"/></ns0:cNvSpPr><ns0:nvPr><ns0:ph idx="15" type="body"/></ns0:nvPr></ns0:nvSpPr><ns0:spPr><ns2:xfrm xmlns:ns2="http://schemas.openxmlformats.org/drawingml/2006/main"><ns2:off x="731520" y="91440"/><ns2:ext cx="9144000" cy="475488"/></ns2:xfrm></ns0:spPr><ns0:txBody><ns3:bodyPr xmlns:ns3="http://schemas.openxmlformats.org/drawingml/2006/main" wrap="square" anchor="t" anchorCtr="0"/><ns4:lstStyle><ns4:defPPr><ns4:defRPr sz="2800" b="1"><ns4:solidFill><ns4:srgbClr val="FFFFFF"/></ns4:solidFill></ns4:defRPr></ns4:defPPr></ns4:lstStyle><ns4:defPPr algn="l"><ns4:buNone/><ns4:defRPr sz="2800" dirty="0" b="1"><ns4:solidFill><ns4:srgbClr val="FFFFFF"/></ns4:solidFill><ns4:latin typeface="Georgia"/><ns4:ea typeface="Georgia"/></ns4:defRPr></ns4:defPPr><ns4:lvl1pPr algn="l"><ns4:buNone/><ns4:defRPr sz="2800" dirty="0" b="1"><ns4:solidFill><ns4:srgbClr val="FFFFFF"/></ns4:solidFill><ns4:latin typeface="Georgia"/><ns4:ea typeface="Georgia"/></ns4:defRPr></ns4:lvl1pPr><ns4:lvl2pPr algn="l"><ns4:buNone/><ns4:defRPr sz="2800" dirty="0" b="1"><ns4:solidFill><ns4:srgbClr val="FFFFFF"/></ns4:solidFill><ns4:latin typeface="Georgia"/><ns4:ea typeface="Georgia"/></ns4:defRPr></ns4:lvl2pPr><ns4:lvl3pPr algn="l"><ns4:buNone/><ns4:defRPr sz="2800" dirty="0" b="1"><ns4:solidFill><ns4:srgbClr val="FFFFFF"/></ns4:solidFill><ns4:latin typeface="Georgia"/><ns4:ea typeface="Georgia"/></ns4:defRPr></ns4:lvl3pPr><ns4:lvl4pPr algn="l"><ns4:buNone/><ns4:defRPr sz="2800" dirty="0" b="1"><ns4:solidFill><ns4:srgbClr val="FFFFFF"/></ns4:solidFill><ns4:latin typeface="Georgia"/><ns4:ea typeface="Georgia"/></ns4:defRPr></ns4:lvl4pPr><ns4:lvl5pPr algn="l"><ns4:buNone/><ns4:defRPr sz="2800" dirty="0" b="1"><ns4:solidFill><ns4:srgbClr val="FFFFFF"/></ns4:solidFill><ns4:latin typeface="Georgia"/><ns4:ea typeface="Georgia"/></ns4:defRPr></ns4:lvl5pPr><ns4:lvl6pPr algn="l"><ns4:buNone/><ns4:defRPr sz="2800" dirty="0" b="1"><ns4:solidFill><ns4:srgbClr val="FFFFFF"/></ns4:solidFill><ns4:latin typeface="Georgia"/><ns4:ea typeface="Georgia"/></ns4:defRPr></ns4:lvl6pPr><ns4:lvl7pPr algn="l"><ns4:buNone/><ns4:defRPr sz="2800" dirty="0" b="1"><ns4:solidFill><ns4:srgbClr val="FFFFFF"/></ns4:solidFill><ns4:latin typeface="Georgia"/><ns4:ea typeface="Georgia"/></ns4:defRPr></ns4:lvl7pPr><ns4:lvl8pPr algn="l"><ns4:buNone/><ns4:defRPr sz="2800" dirty="0" b="1"><ns4:solidFill><ns4:srgbClr val="FFFFFF"/></ns4:solidFill><ns4:latin typeface="Georgia"/><ns4:ea typeface="Georgia"/></ns4:defRPr></ns4:lvl8pPr><ns4:lvl9pPr algn="l"><ns4:buNone/><ns4:defRPr sz="2800" dirty="0" b="1"><ns4:solidFill><ns4:srgbClr val="FFFFFF"/></ns4:solidFill><ns4:latin typeface="Georgia"/><ns4:ea typeface="Georgia"/></ns4:defRPr></ns4:lvl9pPr></ns4:lstStyle/><ns5:p xmlns:ns5="http://schemas.openxmlformats.org/drawingml/2006/main"><ns5:pPr algn="l"><ns5:buNone/></ns5:pPr><ns5:r><ns5:rPr lang="ja-JP"/><ns5:t>サブタイトル</ns5:t></ns5:r></ns5:p></ns0:txBody></ns0:sp><ns0:sp><ns0:nvSpPr><ns0:cNvPr id="5" name="FindingsPanel"/><ns0:cNvSpPr><ns1:spLocks xmlns:ns1="http://schemas.openxmlformats.org/drawingml/2006/main" noGrp="1" noSelect="0" noRot="1" noMove="1"/></ns0:cNvSpPr><ns0:nvPr/></ns0:nvSpPr><ns0:spPr><ns2:xfrm xmlns:ns2="http://schemas.openxmlformats.org/drawingml/2006/main"><ns2:off x="457200" y="1280160"/><ns2:ext cx="7132320" cy="5029200"/></ns2:xfrm><ns3:prstGeom xmlns:ns3="http://schemas.openxmlformats.org/drawingml/2006/main" prst="roundRect"><ns3:avLst><ns3:gd name="adj" fmla="val 8000"/></ns3:avLst></ns3:prstGeom><ns4:solidFill xmlns:ns4="http://schemas.openxmlformats.org/drawingml/2006/main"><ns4:srgbClr val="EDF0F7"/></ns4:solidFill><ns5:ln xmlns:ns5="http://schemas.openxmlformats.org/drawingml/2006/main"><ns5:noFill/></ns5:ln></ns0:spPr></ns0:sp><ns0:sp><ns0:nvSpPr><ns0:cNvPr id="6" name="RecPanel"/><ns0:cNvSpPr><ns1:spLocks xmlns:ns1="http://schemas.openxmlformats.org/drawingml/2006/main" noGrp="1" noSelect="0" noRot="1" noMove="1"/></ns0:cNvSpPr><ns0:nvPr/></ns0:nvSpPr><ns0:spPr><ns2:xfrm xmlns:ns2="http://schemas.openxmlformats.org/drawingml/2006/main"><ns2:off x="7863840" y="1280160"/><ns2:ext cx="3749039" cy="5029200"/></ns2:xfrm><ns3:prstGeom xmlns:ns3="http://schemas.openxmlformats.org/drawingml/2006/main" prst="roundRect"><ns3:avLst><ns3:gd name="adj" fmla="val 8000"/></ns3:avLst></ns3:prstGeom><ns4:solidFill xmlns:ns4="http://schemas.openxmlformats.org/drawingml/2006/main"><ns4:srgbClr val="F0F4FF"/></ns4:solidFill><ns5:ln xmlns:ns5="http://schemas.openxmlformats.org/drawingml/2006/main"><ns5:noFill/></ns5:ln></ns0:spPr></ns0:sp><ns0:sp><ns0:nvSpPr><ns0:cNvPr id="7" name="RecAccent"/><ns0:cNvSpPr><ns1:spLocks xmlns:ns1="http://schemas.openxmlformats.org/drawingml/2006/main" noGrp="1" noSelect="0" noRot="1" noMove="1"/></ns0:cNvSpPr><ns0:nvPr/></ns0:nvSpPr><ns0:spPr><ns2:xfrm xmlns:ns2="http://schemas.openxmlformats.org/drawingml/2006/main"><ns2:off x="7863840" y="1280160"/><ns2:ext cx="54864" cy="5029200"/></ns2:xfrm><ns3:prstGeom xmlns:ns3="http://schemas.openxmlformats.org/drawingml/2006/main" prst="rect"/><ns4:solidFill xmlns:ns4="http://schemas.openxmlformats.org/drawingml/2006/main"><ns4:srgbClr val="3B82F6"/></ns4:solidFill><ns5:ln xmlns:ns5="http://schemas.openxmlformats.org/drawingml/2006/main"><ns5:noFill/></ns5:ln></ns0:spPr></ns0:sp><ns0:sp><ns0:nvSpPr><ns0:cNvPr id="20" name="Body1.Left"/><ns0:cNvSpPr><ns1:spLocks xmlns:ns1="http://schemas.openxmlformats.org/drawingml/2006/main" noGrp="1"/></ns0:cNvSpPr><ns0:nvPr><ns0:ph idx="1" type="body"/></ns0:nvPr></ns0:nvSpPr><ns0:spPr><ns2:xfrm xmlns:ns2="http://schemas.openxmlformats.org/drawingml/2006/main"><ns2:off x="822960" y="1554480"/><ns2:ext cx="6400800" cy="4572000"/></ns2:xfrm></ns0:spPr><ns0:txBody><ns3:bodyPr xmlns:ns3="http://schemas.openxmlformats.org/drawingml/2006/main" wrap="square" anchor="t" anchorCtr="0"/><ns4:lstStyle/><ns4:defPPr algn="l"><ns4:buNone/><ns4:defRPr sz="1400" dirty="0"><ns4:solidFill><ns4:srgbClr val="1E293B"/></ns4:solidFill><ns4:latin typeface="Calibri"/><ns4:ea typeface="Calibri"/></ns4:defRPr></ns4:defPPr><ns4:lvl1pPr algn="l"><ns4:buNone/><ns4:defRPr sz="1400" dirty="0"><ns4:solidFill><ns4:srgbClr val="1E293B"/></ns4:solidFill><ns4:latin typeface="Calibri"/><ns4:ea typeface="Calibri"/></ns4:defRPr></ns4:lvl1pPr><ns4:lvl2pPr algn="l"><ns4:buNone/><ns4:defRPr sz="1400" dirty="0"><ns4:solidFill><ns4:srgbClr val="1E293B"/></ns4:solidFill><ns4:latin typeface="Calibri"/><ns4:ea typeface="Calibri"/></ns4:defRPr></ns4:lvl2pPr><ns4:lvl3pPr algn="l"><ns4:buNone/><ns4:defRPr sz="1400" dirty="0"><ns4:solidFill><ns4:srgbClr val="1E293B"/></ns4:solidFill><ns4:latin typeface="Calibri"/><ns4:ea typeface="Calibri"/></ns4:defRPr></ns4:lvl3pPr><ns4:lvl4pPr algn="l"><ns4:buNone/><ns4:defRPr sz="1400" dirty="0"><ns4:solidFill><ns4:srgbClr val="1E293B"/></ns4:solidFill><ns4:latin typeface="Calibri"/><ns4:ea typeface="Calibri"/></ns4:defRPr></ns4:lvl4pPr><ns4:lvl5pPr algn="l"><ns4:buNone/><ns4:defRPr sz="1400" dirty="0"><ns4:solidFill><ns4:srgbClr val="1E293B"/></ns4:solidFill><ns4:latin typeface="Calibri"/><ns4:ea typeface="Calibri"/></ns4:defRPr></ns4:lvl5pPr><ns4:lvl6pPr algn="l"><ns4:buNone/><ns4:defRPr sz="1400" dirty="0"><ns4:solidFill><ns4:srgbClr val="1E293B"/></ns4:solidFill><ns4:latin typeface="Calibri"/><ns4:ea typeface="Calibri"/></ns4:defRPr></ns4:lvl6pPr><ns4:lvl7pPr algn="l"><ns4:buNone/><ns4:defRPr sz="1400" dirty="0"><ns4:solidFill><ns4:srgbClr val="1E293B"/></ns4:solidFill><ns4:latin typeface="Calibri"/><ns4:ea typeface="Calibri"/></ns4:defRPr></ns4:lvl7pPr><ns4:lvl8pPr algn="l"><ns4:buNone/><ns4:defRPr sz="1400" dirty="0"><ns4:solidFill><ns4:srgbClr val="1E293B"/></ns4:solidFill><ns4:latin typeface="Calibri"/><ns4:ea typeface="Calibri"/></ns4:defRPr></ns4:lvl8pPr><ns4:lvl9pPr algn="l"><ns4:buNone/><ns4:defRPr sz="1400" dirty="0"><ns4:solidFill><ns4:srgbClr val="1E293B"/></ns4:solidFill><ns4:latin typeface="Calibri"/><ns4:ea typeface="Calibri"/></ns4:defRPr></ns4:lvl9pPr></ns4:lstStyle/><ns5:p xmlns:ns5="http://schemas.openxmlformats.org/drawingml/2006/main"><ns5:pPr algn="l"><ns5:buNone/></ns5:pPr><ns5:r><ns5:rPr lang="ja-JP"/><ns5:t>推奨アクション
-
-優先度：高
-
-対応策を記入</ns5:t></ns5:r></ns5:p></ns0:txBody></ns0:sp><ns0:sp><ns0:nvSpPr><ns0:cNvPr id="30" name="SlideNum.Footer"/><ns0:cNvSpPr><ns1:spLocks xmlns:ns1="http://schemas.openxmlformats.org/drawingml/2006/main" noGrp="1"/></ns0:cNvSpPr><ns0:nvPr><ns0:ph idx="50" type="sldNum"/></ns0:nvPr></ns0:nvSpPr><ns0:spPr><ns2:xfrm xmlns:ns2="http://schemas.openxmlformats.org/drawingml/2006/main"><ns2:off x="10972800" y="6446520"/><ns2:ext cx="1097280" cy="274320"/></ns2:xfrm></ns0:spPr><ns0:txBody><ns3:bodyPr xmlns:ns3="http://schemas.openxmlformats.org/drawingml/2006/main" wrap="square" anchor="t" anchorCtr="0"/><ns4:lstStyle><ns4:defPPr algn="r"><ns4:defRPr sz="1000"><ns4:solidFill><ns4:srgbClr val="94A3B8"/></ns4:solidFill></ns4:defRPr></ns4:defPPr></ns4:lstStyle><ns4:defPPr algn="r"><ns4:buNone/><ns4:defRPr sz="1000" dirty="0"><ns4:solidFill><ns4:srgbClr val="94A3B8"/></ns4:solidFill><ns4:latin typeface="Calibri"/><ns4:ea typeface="Calibri"/></ns4:defRPr></ns4:defPPr><ns4:lvl1pPr algn="r"><ns4:buNone/><ns4:defRPr sz="1000" dirty="0"><ns4:solidFill><ns4:srgbClr val="94A3B8"/></ns4:solidFill><ns4:latin typeface="Calibri"/><ns4:ea typeface="Calibri"/></ns4:defRPr></ns4:lvl1pPr><ns4:lvl2pPr algn="r"><ns4:buNone/><ns4:defRPr sz="1000" dirty="0"><ns4:solidFill><ns4:srgbClr val="94A3B8"/></ns4:solidFill><ns4:latin typeface="Calibri"/><ns4:ea typeface="Calibri"/></ns4:defRPr></ns4:lvl2pPr><ns4:lvl3pPr algn="r"><ns4:buNone/><ns4:defRPr sz="1000" dirty="0"><ns4:solidFill><ns4:srgbClr val="94A3B8"/></ns4:solidFill><ns4:latin typeface="Calibri"/><ns4:ea typeface="Calibri"/></ns4:defRPr></ns4:lvl3pPr><ns4:lvl4pPr algn="r"><ns4:buNone/><ns4:defRPr sz="1000" dirty="0"><ns4:solidFill><ns4:srgbClr val="94A3B8"/></ns4:solidFill><ns4:latin typeface="Calibri"/><ns4:ea typeface="Calibri"/></ns4:defRPr></ns4:lvl4pPr><ns4:lvl5pPr algn="r"><ns4:buNone/><ns4:defRPr sz="1000" dirty="0"><ns4:solidFill><ns4:srgbClr val="94A3B8"/></ns4:solidFill><ns4:latin typeface="Calibri"/><ns4:ea typeface="Calibri"/></ns4:defRPr></ns4:lvl5pPr><ns4:lvl6pPr algn="r"><ns4:buNone/><ns4:defRPr sz="1000" dirty="0"><ns4:solidFill><ns4:srgbClr val="94A3B8"/></ns4:solidFill><ns4:latin typeface="Calibri"/><ns4:ea typeface="Calibri"/></ns4:defRPr></ns4:lvl6pPr><ns4:lvl7pPr algn="r"><ns4:buNone/><ns4:defRPr sz="1000" dirty="0"><ns4:solidFill><ns4:srgbClr val="94A3B8"/></ns4:solidFill><ns4:latin typeface="Calibri"/><ns4:ea typeface="Calibri"/></ns4:defRPr></ns4:lvl7pPr><ns4:lvl8pPr algn="r"><ns4:buNone/><ns4:defRPr sz="1000" dirty="0"><ns4:solidFill><ns4:srgbClr val="94A3B8"/></ns4:solidFill><ns4:latin typeface="Calibri"/><ns4:ea typeface="Calibri"/></ns4:defRPr></ns4:lvl8pPr><ns4:lvl9pPr algn="r"><ns4:buNone/><ns4:defRPr sz="1000" dirty="0"><ns4:solidFill><ns4:srgbClr val="94A3B8"/></ns4:solidFill><ns4:latin typeface="Calibri"/><ns4:ea typeface="Calibri"/></ns4:defRPr></ns4:lvl9pPr></ns4:lstStyle><ns5:p xmlns:ns5="http://schemas.openxmlformats.org/drawingml/2006/main"><ns5:pPr algn="r"><ns5:buNone/></ns5:pPr><ns5:r><ns5:rPr lang="ja-JP"/><ns5:t>&lt;#&gt;</ns5:t></ns5:r></ns5:p></ns0:txBody></ns0:sp></ns0:spTree></ns0:cSld><ns0:clrMapOvr/></ns0:sldLayout>
+<file path=ppt/slideLayouts/slideLayout28.xml><?xml version='1.0' encoding='UTF-8' standalone='yes'?><p:sldLayout xmlns:a="http://schemas.openxmlformats.org/drawingml/2006/main" xmlns:p="http://schemas.openxmlformats.org/presentationml/2006/main" xmlns:r="http://schemas.openxmlformats.org/officeDocument/2006/relationships" type="blank" preserve="1"><p:cSld name="Summary.2Block.Equal"><p:spTree><p:nvGrpSpPr><p:cNvPr id="1" name=""/><p:cNvGrpSpPr/><p:nvPr/></p:nvGrpSpPr><p:grpSpPr><a:xfrm><a:off x="0" y="0"/><a:ext cx="0" cy="0"/><a:chOff x="0" y="0"/><a:chExt cx="0" cy="0"/></a:xfrm></p:grpSpPr><p:sp><p:nvSpPr><p:cNvPr id="2" name="HeaderBar"/><p:cNvSpPr><a:spLocks xmlns:ns1="http://schemas.openxmlformats.org/drawingml/2006/main" noGrp="1" noSelect="0" noRot="1" noMove="1"/></p:cNvSpPr><p:nvPr/></p:nvSpPr><p:spPr><a:xfrm xmlns:ns2="http://schemas.openxmlformats.org/drawingml/2006/main"><a:off x="0" y="0"/><a:ext cx="12192000" cy="1051560"/></a:xfrm><a:prstGeom xmlns:ns3="http://schemas.openxmlformats.org/drawingml/2006/main" prst="rect"/><a:solidFill xmlns:ns4="http://schemas.openxmlformats.org/drawingml/2006/main"><a:srgbClr val="1E2761"/></a:solidFill><a:ln xmlns:ns5="http://schemas.openxmlformats.org/drawingml/2006/main"><a:noFill/></a:ln></p:spPr></p:sp><p:sp><p:nvSpPr><p:cNvPr id="3" name="FindingsPanel"/><p:cNvSpPr><a:spLocks xmlns:ns1="http://schemas.openxmlformats.org/drawingml/2006/main" noGrp="1" noSelect="0" noRot="1" noMove="1"/></p:cNvSpPr><p:nvPr/></p:nvSpPr><p:spPr><a:xfrm xmlns:ns2="http://schemas.openxmlformats.org/drawingml/2006/main"><a:off x="457200" y="1280160"/><a:ext cx="7132320" cy="5029200"/></a:xfrm><a:prstGeom xmlns:ns3="http://schemas.openxmlformats.org/drawingml/2006/main" prst="roundRect"><a:avLst><a:gd name="adj" fmla="val 8000"/></a:avLst></p:prstGeom><a:solidFill xmlns:ns4="http://schemas.openxmlformats.org/drawingml/2006/main"><a:srgbClr val="EDF0F7"/></a:solidFill><a:ln xmlns:ns5="http://schemas.openxmlformats.org/drawingml/2006/main"><a:noFill/></a:ln></p:spPr></p:sp><p:sp><p:nvSpPr><p:cNvPr id="4" name="RecPanel"/><p:cNvSpPr><a:spLocks xmlns:ns1="http://schemas.openxmlformats.org/drawingml/2006/main" noGrp="1" noSelect="0" noRot="1" noMove="1"/></p:cNvSpPr><p:nvPr/></p:nvSpPr><p:spPr><a:xfrm xmlns:ns2="http://schemas.openxmlformats.org/drawingml/2006/main"><a:off x="7863840" y="1280160"/><a:ext cx="3749039" cy="5029200"/></a:xfrm><a:prstGeom xmlns:ns3="http://schemas.openxmlformats.org/drawingml/2006/main" prst="roundRect"><a:avLst><a:gd name="adj" fmla="val 8000"/></a:avLst></p:prstGeom><a:solidFill xmlns:ns4="http://schemas.openxmlformats.org/drawingml/2006/main"><a:srgbClr val="F0F4FF"/></a:solidFill><a:ln xmlns:ns5="http://schemas.openxmlformats.org/drawingml/2006/main"><a:noFill/></a:ln></p:spPr></p:sp><p:sp><p:nvSpPr><p:cNvPr id="5" name="RecAccent"/><p:cNvSpPr><a:spLocks xmlns:ns1="http://schemas.openxmlformats.org/drawingml/2006/main" noGrp="1" noSelect="0" noRot="1" noMove="1"/></p:cNvSpPr><p:nvPr/></p:nvSpPr><p:spPr><a:xfrm xmlns:ns2="http://schemas.openxmlformats.org/drawingml/2006/main"><a:off x="7863840" y="1280160"/><a:ext cx="54864" cy="5029200"/></a:xfrm><a:prstGeom xmlns:ns3="http://schemas.openxmlformats.org/drawingml/2006/main" prst="rect"/><a:solidFill xmlns:ns4="http://schemas.openxmlformats.org/drawingml/2006/main"><a:srgbClr val="3B82F6"/></a:solidFill><a:ln xmlns:ns5="http://schemas.openxmlformats.org/drawingml/2006/main"><a:noFill/></a:ln></p:spPr></p:sp><p:sp><p:nvSpPr><p:cNvPr id="6" name="SlideTitle.Header"/><p:cNvSpPr><a:spLocks noGrp="1"/></p:cNvSpPr><p:nvPr><p:ph type="body" idx="15"/></p:nvPr></p:nvSpPr><p:spPr><a:xfrm><a:off x="731520" y="91440"/><a:ext cx="9144000" cy="475488"/></a:xfrm></p:spPr><p:txBody><a:bodyPr wrap="square" anchor="t" anchorCtr="0"/><a:lstStyle><a:defPPr><a:defRPr sz="2800" b="1"><a:solidFill><a:srgbClr val="FFFFFF"/></a:solidFill></a:defRPr></a:defPPr></a:lstStyle><a:p><a:r><a:rPr lang="ja-JP"/><a:t> </a:t></a:r></a:p></p:txBody></p:sp><p:sp><p:nvSpPr><p:cNvPr id="7" name="SlideSubtitle.Header"/><p:cNvSpPr><a:spLocks noGrp="1"/></p:cNvSpPr><p:nvPr><p:ph type="body" idx="16"/></p:nvPr></p:nvSpPr><p:spPr><a:xfrm><a:off x="731520" y="658368"/><a:ext cx="9144000" cy="274320"/></a:xfrm></p:spPr><p:txBody><a:bodyPr wrap="square" anchor="t" anchorCtr="0"/><a:lstStyle><a:defPPr><a:defRPr sz="1200"><a:solidFill><a:srgbClr val="CADCFC"/></a:solidFill></a:defRPr></a:defPPr></a:lstStyle><a:p><a:r><a:rPr lang="ja-JP"/><a:t> </a:t></a:r></a:p></p:txBody></p:sp><p:sp><p:nvSpPr><p:cNvPr id="8" name="Body1.Left"/><p:cNvSpPr><a:spLocks noGrp="1"/></p:cNvSpPr><p:nvPr><p:ph type="body" idx="1"/></p:nvPr></p:nvSpPr><p:spPr><a:xfrm><a:off x="822960" y="1554480"/><a:ext cx="6400800" cy="4572000"/></a:xfrm></p:spPr><p:txBody><a:bodyPr wrap="square" anchor="t" anchorCtr="0"/><a:lstStyle/><a:p><a:r><a:rPr lang="ja-JP"/><a:t> </a:t></a:r></a:p></p:txBody></p:sp><p:sp><p:nvSpPr><p:cNvPr id="9" name="Body2.Right"/><p:cNvSpPr><a:spLocks noGrp="1"/></p:cNvSpPr><p:nvPr><p:ph type="body" idx="2"/></p:nvPr></p:nvSpPr><p:spPr><a:xfrm><a:off x="8229600" y="1554480"/><a:ext cx="3108960" cy="4572000"/></a:xfrm></p:spPr><p:txBody><a:bodyPr wrap="square" anchor="t" anchorCtr="0"/><a:lstStyle><a:defPPr><a:defRPr sz="1300"></a:defRPr></a:defPPr></a:lstStyle><a:p><a:r><a:rPr lang="ja-JP"/><a:t> </a:t></a:r></a:p></p:txBody></p:sp><p:sp><p:nvSpPr><p:cNvPr id="10" name="SlideNum.Footer"/><p:cNvSpPr><a:spLocks noGrp="1"/></p:cNvSpPr><p:nvPr><p:ph type="sldNum" idx="50"/></p:nvPr></p:nvSpPr><p:spPr><a:xfrm><a:off x="10972800" y="6446520"/><a:ext cx="1097280" cy="274320"/></a:xfrm></p:spPr><p:txBody><a:bodyPr wrap="square" anchor="t" anchorCtr="0"/><a:lstStyle><a:defPPr algn="r"><a:defRPr sz="1000"><a:solidFill><a:srgbClr val="94A3B8"/></a:solidFill></a:defRPr></a:defPPr></a:lstStyle><a:p><a:r><a:rPr lang="ja-JP"/><a:t> </a:t></a:r></a:p></p:txBody></p:sp></p:spTree></p:cSld><p:clrMapOvr/></p:sldLayout>
 </file>
 
-<file path=ppt/slideLayouts/slideLayout29.xml><?xml version='1.0' encoding='UTF-8' standalone='yes'?>
-<ns0:sldLayout xmlns:ns0="http://schemas.openxmlformats.org/presentationml/2006/main" type="blank" preserve="1"><ns0:cSld name="Closing.1Message.Single"><ns0:spTree><ns0:nvGrpSpPr><ns0:cNvPr id="1" name=""/><ns0:cNvGrpSpPr/><ns0:nvPr/></ns0:nvGrpSpPr><ns0:grpSpPr><ns1:xfrm xmlns:ns1="http://schemas.openxmlformats.org/drawingml/2006/main"><ns1:off x="0" y="0"/><ns1:ext cx="0" cy="0"/><ns1:chOff x="0" y="0"/><ns1:chExt cx="0" cy="0"/></ns1:xfrm></ns0:grpSpPr><ns0:sp><ns0:nvSpPr><ns0:cNvPr id="2" name="BG"/><ns0:cNvSpPr><ns1:spLocks xmlns:ns1="http://schemas.openxmlformats.org/drawingml/2006/main" noGrp="1" noSelect="0" noRot="1" noMove="1"/></ns0:cNvSpPr><ns0:nvPr/></ns0:nvSpPr><ns0:spPr><ns2:xfrm xmlns:ns2="http://schemas.openxmlformats.org/drawingml/2006/main"><ns2:off x="0" y="0"/><ns2:ext cx="12192000" cy="6858000"/></ns2:xfrm><ns3:prstGeom xmlns:ns3="http://schemas.openxmlformats.org/drawingml/2006/main" prst="rect"/><ns4:solidFill xmlns:ns4="http://schemas.openxmlformats.org/drawingml/2006/main"><ns4:srgbClr val="1E2761"/></ns4:solidFill><ns5:ln xmlns:ns5="http://schemas.openxmlformats.org/drawingml/2006/main"><ns5:noFill/></ns5:ln></ns0:spPr></ns0:sp><ns0:sp><ns0:nvSpPr><ns0:cNvPr id="3" name="AccentBar"/><ns0:cNvSpPr><ns1:spLocks xmlns:ns1="http://schemas.openxmlformats.org/drawingml/2006/main" noGrp="1" noSelect="0" noRot="1" noMove="1"/></ns0:cNvSpPr><ns0:nvPr/></ns0:nvSpPr><ns0:spPr><ns2:xfrm xmlns:ns2="http://schemas.openxmlformats.org/drawingml/2006/main"><ns2:off x="0" y="0"/><ns2:ext cx="164592" cy="6858000"/></ns2:xfrm><ns3:prstGeom xmlns:ns3="http://schemas.openxmlformats.org/drawingml/2006/main" prst="rect"/><ns4:solidFill xmlns:ns4="http://schemas.openxmlformats.org/drawingml/2006/main"><ns4:srgbClr val="3B82F6"/></ns4:solidFill><ns5:ln xmlns:ns5="http://schemas.openxmlformats.org/drawingml/2006/main"><ns5:noFill/></ns5:ln></ns0:spPr></ns0:sp><ns0:sp><ns0:nvSpPr><ns0:cNvPr id="4" name="BottomPanel"/><ns0:cNvSpPr><ns1:spLocks xmlns:ns1="http://schemas.openxmlformats.org/drawingml/2006/main" noGrp="1" noSelect="0" noRot="1" noMove="1"/></ns0:cNvSpPr><ns0:nvPr/></ns0:nvSpPr><ns0:spPr><ns2:xfrm xmlns:ns2="http://schemas.openxmlformats.org/drawingml/2006/main"><ns2:off x="0" y="4389120"/><ns2:ext cx="12192000" cy="2468880"/></ns2:xfrm><ns3:prstGeom xmlns:ns3="http://schemas.openxmlformats.org/drawingml/2006/main" prst="rect"/><ns4:solidFill xmlns:ns4="http://schemas.openxmlformats.org/drawingml/2006/main"><ns4:srgbClr val="141B41"/></ns4:solidFill><ns5:ln xmlns:ns5="http://schemas.openxmlformats.org/drawingml/2006/main"><ns5:noFill/></ns5:ln></ns0:spPr></ns0:sp><ns0:sp><ns0:nvSpPr><ns0:cNvPr id="10" name="CategoryLabel.Top"/><ns0:cNvSpPr><ns1:spLocks xmlns:ns1="http://schemas.openxmlformats.org/drawingml/2006/main" noGrp="1"/></ns0:cNvSpPr><ns0:nvPr><ns0:ph idx="10" type="body"/></ns0:nvPr></ns0:nvSpPr><ns0:spPr><ns2:xfrm xmlns:ns2="http://schemas.openxmlformats.org/drawingml/2006/main"><ns2:off x="1097280" y="1371600"/><ns2:ext cx="9144000" cy="457200"/></ns2:xfrm></ns0:spPr><ns0:txBody><ns3:bodyPr xmlns:ns3="http://schemas.openxmlformats.org/drawingml/2006/main" wrap="square" anchor="t" anchorCtr="0"/><ns4:lstStyle><ns4:defPPr><ns4:defRPr sz="1800" b="1"><ns4:solidFill><ns4:srgbClr val="3B82F6"/></ns4:solidFill></ns4:defRPr></ns4:defPPr></ns4:lstStyle><ns4:defPPr algn="l"><ns4:buNone/><ns4:defRPr sz="1800" dirty="0" b="1"><ns4:solidFill><ns4:srgbClr val="3B82F6"/></ns4:solidFill><ns4:latin typeface="Calibri"/><ns4:ea typeface="Calibri"/></ns4:defRPr></ns4:defPPr><ns4:lvl1pPr algn="l"><ns4:buNone/><ns4:defRPr sz="1800" dirty="0" b="1"><ns4:solidFill><ns4:srgbClr val="3B82F6"/></ns4:solidFill><ns4:latin typeface="Calibri"/><ns4:ea typeface="Calibri"/></ns4:defRPr></ns4:lvl1pPr><ns4:lvl2pPr algn="l"><ns4:buNone/><ns4:defRPr sz="1800" dirty="0" b="1"><ns4:solidFill><ns4:srgbClr val="3B82F6"/></ns4:solidFill><ns4:latin typeface="Calibri"/><ns4:ea typeface="Calibri"/></ns4:defRPr></ns4:lvl2pPr><ns4:lvl3pPr algn="l"><ns4:buNone/><ns4:defRPr sz="1800" dirty="0" b="1"><ns4:solidFill><ns4:srgbClr val="3B82F6"/></ns4:solidFill><ns4:latin typeface="Calibri"/><ns4:ea typeface="Calibri"/></ns4:defRPr></ns4:lvl3pPr><ns4:lvl4pPr algn="l"><ns4:buNone/><ns4:defRPr sz="1800" dirty="0" b="1"><ns4:solidFill><ns4:srgbClr val="3B82F6"/></ns4:solidFill><ns4:latin typeface="Calibri"/><ns4:ea typeface="Calibri"/></ns4:defRPr></ns4:lvl4pPr><ns4:lvl5pPr algn="l"><ns4:buNone/><ns4:defRPr sz="1800" dirty="0" b="1"><ns4:solidFill><ns4:srgbClr val="3B82F6"/></ns4:solidFill><ns4:latin typeface="Calibri"/><ns4:ea typeface="Calibri"/></ns4:defRPr></ns4:lvl5pPr><ns4:lvl6pPr algn="l"><ns4:buNone/><ns4:defRPr sz="1800" dirty="0" b="1"><ns4:solidFill><ns4:srgbClr val="3B82F6"/></ns4:solidFill><ns4:latin typeface="Calibri"/><ns4:ea typeface="Calibri"/></ns4:defRPr></ns4:lvl6pPr><ns4:lvl7pPr algn="l"><ns4:buNone/><ns4:defRPr sz="1800" dirty="0" b="1"><ns4:solidFill><ns4:srgbClr val="3B82F6"/></ns4:solidFill><ns4:latin typeface="Calibri"/><ns4:ea typeface="Calibri"/></ns4:defRPr></ns4:lvl7pPr><ns4:lvl8pPr algn="l"><ns4:buNone/><ns4:defRPr sz="1800" dirty="0" b="1"><ns4:solidFill><ns4:srgbClr val="3B82F6"/></ns4:solidFill><ns4:latin typeface="Calibri"/><ns4:ea typeface="Calibri"/></ns4:defRPr></ns4:lvl8pPr><ns4:lvl9pPr algn="l"><ns4:buNone/><ns4:defRPr sz="1800" dirty="0" b="1"><ns4:solidFill><ns4:srgbClr val="3B82F6"/></ns4:solidFill><ns4:latin typeface="Calibri"/><ns4:ea typeface="Calibri"/></ns4:defRPr></ns4:lvl9pPr></ns4:lstStyle/><ns5:p xmlns:ns5="http://schemas.openxmlformats.org/drawingml/2006/main"><ns5:pPr algn="l"><ns5:buNone/></ns5:pPr><ns5:r><ns5:rPr lang="ja-JP"/><ns5:t>ご質問をお待ちしています</ns5:t></ns5:r></ns5:p></ns0:txBody></ns0:sp><ns0:sp><ns0:nvSpPr><ns0:cNvPr id="12" name="PresenterName.Bottom"/><ns0:cNvSpPr><ns1:spLocks xmlns:ns1="http://schemas.openxmlformats.org/drawingml/2006/main" noGrp="1"/></ns0:cNvSpPr><ns0:nvPr><ns0:ph idx="11" type="body"/></ns0:nvPr></ns0:nvSpPr><ns0:spPr><ns2:xfrm xmlns:ns2="http://schemas.openxmlformats.org/drawingml/2006/main"><ns2:off x="1097280" y="4754880"/><ns2:ext cx="7315200" cy="457200"/></ns2:xfrm></ns0:spPr><ns0:txBody><ns3:bodyPr xmlns:ns3="http://schemas.openxmlformats.org/drawingml/2006/main" wrap="square" anchor="t" anchorCtr="0"/><ns4:lstStyle><ns4:defPPr><ns4:defRPr sz="1600"><ns4:solidFill><ns4:srgbClr val="CADCFC"/></ns4:solidFill></ns4:defRPr></ns4:defPPr></ns4:lstStyle><ns4:defPPr algn="l"><ns4:buNone/><ns4:defRPr sz="1600" dirty="0"><ns4:solidFill><ns4:srgbClr val="CADCFC"/></ns4:solidFill><ns4:latin typeface="Calibri"/><ns4:ea typeface="Calibri"/></ns4:defRPr></ns4:defPPr><ns4:lvl1pPr algn="l"><ns4:buNone/><ns4:defRPr sz="1600" dirty="0"><ns4:solidFill><ns4:srgbClr val="CADCFC"/></ns4:solidFill><ns4:latin typeface="Calibri"/><ns4:ea typeface="Calibri"/></ns4:defRPr></ns4:lvl1pPr><ns4:lvl2pPr algn="l"><ns4:buNone/><ns4:defRPr sz="1600" dirty="0"><ns4:solidFill><ns4:srgbClr val="CADCFC"/></ns4:solidFill><ns4:latin typeface="Calibri"/><ns4:ea typeface="Calibri"/></ns4:defRPr></ns4:lvl2pPr><ns4:lvl3pPr algn="l"><ns4:buNone/><ns4:defRPr sz="1600" dirty="0"><ns4:solidFill><ns4:srgbClr val="CADCFC"/></ns4:solidFill><ns4:latin typeface="Calibri"/><ns4:ea typeface="Calibri"/></ns4:defRPr></ns4:lvl3pPr><ns4:lvl4pPr algn="l"><ns4:buNone/><ns4:defRPr sz="1600" dirty="0"><ns4:solidFill><ns4:srgbClr val="CADCFC"/></ns4:solidFill><ns4:latin typeface="Calibri"/><ns4:ea typeface="Calibri"/></ns4:defRPr></ns4:lvl4pPr><ns4:lvl5pPr algn="l"><ns4:buNone/><ns4:defRPr sz="1600" dirty="0"><ns4:solidFill><ns4:srgbClr val="CADCFC"/></ns4:solidFill><ns4:latin typeface="Calibri"/><ns4:ea typeface="Calibri"/></ns4:defRPr></ns4:lvl5pPr><ns4:lvl6pPr algn="l"><ns4:buNone/><ns4:defRPr sz="1600" dirty="0"><ns4:solidFill><ns4:srgbClr val="CADCFC"/></ns4:solidFill><ns4:latin typeface="Calibri"/><ns4:ea typeface="Calibri"/></ns4:defRPr></ns4:lvl6pPr><ns4:lvl7pPr algn="l"><ns4:buNone/><ns4:defRPr sz="1600" dirty="0"><ns4:solidFill><ns4:srgbClr val="CADCFC"/></ns4:solidFill><ns4:latin typeface="Calibri"/><ns4:ea typeface="Calibri"/></ns4:defRPr></ns4:lvl7pPr><ns4:lvl8pPr algn="l"><ns4:buNone/><ns4:defRPr sz="1600" dirty="0"><ns4:solidFill><ns4:srgbClr val="CADCFC"/></ns4:solidFill><ns4:latin typeface="Calibri"/><ns4:ea typeface="Calibri"/></ns4:defRPr></ns4:lvl8pPr><ns4:lvl9pPr algn="l"><ns4:buNone/><ns4:defRPr sz="1600" dirty="0"><ns4:solidFill><ns4:srgbClr val="CADCFC"/></ns4:solidFill><ns4:latin typeface="Calibri"/><ns4:ea typeface="Calibri"/></ns4:defRPr></ns4:lvl9pPr></ns4:lstStyle/><ns5:p xmlns:ns5="http://schemas.openxmlformats.org/drawingml/2006/main"><ns5:pPr algn="l"><ns5:buNone/></ns5:pPr><ns5:r><ns5:rPr lang="ja-JP"/><ns5:t>email@example.com  |  内線: 0000
-Slack: #channel</ns5:t></ns5:r></ns5:p></ns0:txBody></ns0:sp></ns0:spTree></ns0:cSld><ns0:clrMapOvr/></ns0:sldLayout>
+<file path=ppt/slideLayouts/slideLayout29.xml><?xml version="1.0" encoding="utf-8"?>
+<p:sldLayout xmlns:a="http://schemas.openxmlformats.org/drawingml/2006/main" xmlns:p="http://schemas.openxmlformats.org/presentationml/2006/main" xmlns:r="http://schemas.openxmlformats.org/officeDocument/2006/relationships" type="blank" preserve="1">
+  <p:cSld name="Closing.1Message.Single">
+    <p:spTree>
+      <p:nvGrpSpPr>
+        <p:cNvPr id="1" name=""/>
+        <p:cNvGrpSpPr/>
+        <p:nvPr/>
+      </p:nvGrpSpPr>
+      <p:grpSpPr>
+        <a:xfrm>
+          <a:off x="0" y="0"/>
+          <a:ext cx="0" cy="0"/>
+          <a:chOff x="0" y="0"/>
+          <a:chExt cx="0" cy="0"/>
+        </a:xfrm>
+      </p:grpSpPr>
+      <p:sp>
+        <p:nvSpPr>
+          <p:cNvPr id="2" name="BG"/>
+          <p:cNvSpPr>
+            <a:spLocks xmlns:ns1="http://schemas.openxmlformats.org/drawingml/2006/main" noGrp="1" noSelect="0" noRot="1" noMove="1"/>
+          </p:cNvSpPr>
+          <p:nvPr/>
+        </p:nvSpPr>
+        <p:spPr>
+          <a:xfrm xmlns:ns2="http://schemas.openxmlformats.org/drawingml/2006/main">
+            <a:off x="0" y="0"/>
+            <a:ext cx="12192000" cy="6858000"/>
+          </a:xfrm>
+          <a:prstGeom xmlns:ns3="http://schemas.openxmlformats.org/drawingml/2006/main" prst="rect"/>
+          <a:solidFill xmlns:ns4="http://schemas.openxmlformats.org/drawingml/2006/main">
+            <a:srgbClr val="1E2761"/>
+          </a:solidFill>
+          <a:ln xmlns:ns5="http://schemas.openxmlformats.org/drawingml/2006/main">
+            <a:noFill/>
+          </a:ln>
+        </p:spPr>
+      </p:sp>
+      <p:sp>
+        <p:nvSpPr>
+          <p:cNvPr id="3" name="AccentBar"/>
+          <p:cNvSpPr>
+            <a:spLocks xmlns:ns1="http://schemas.openxmlformats.org/drawingml/2006/main" noGrp="1" noSelect="0" noRot="1" noMove="1"/>
+          </p:cNvSpPr>
+          <p:nvPr/>
+        </p:nvSpPr>
+        <p:spPr>
+          <a:xfrm xmlns:ns2="http://schemas.openxmlformats.org/drawingml/2006/main">
+            <a:off x="0" y="0"/>
+            <a:ext cx="164592" cy="6858000"/>
+          </a:xfrm>
+          <a:prstGeom xmlns:ns3="http://schemas.openxmlformats.org/drawingml/2006/main" prst="rect"/>
+          <a:solidFill xmlns:ns4="http://schemas.openxmlformats.org/drawingml/2006/main">
+            <a:srgbClr val="3B82F6"/>
+          </a:solidFill>
+          <a:ln xmlns:ns5="http://schemas.openxmlformats.org/drawingml/2006/main">
+            <a:noFill/>
+          </a:ln>
+        </p:spPr>
+      </p:sp>
+      <p:sp>
+        <p:nvSpPr>
+          <p:cNvPr id="4" name="BottomPanel"/>
+          <p:cNvSpPr>
+            <a:spLocks xmlns:ns1="http://schemas.openxmlformats.org/drawingml/2006/main" noGrp="1" noSelect="0" noRot="1" noMove="1"/>
+          </p:cNvSpPr>
+          <p:nvPr/>
+        </p:nvSpPr>
+        <p:spPr>
+          <a:xfrm xmlns:ns2="http://schemas.openxmlformats.org/drawingml/2006/main">
+            <a:off x="0" y="4389120"/>
+            <a:ext cx="12192000" cy="2468880"/>
+          </a:xfrm>
+          <a:prstGeom xmlns:ns3="http://schemas.openxmlformats.org/drawingml/2006/main" prst="rect"/>
+          <a:solidFill xmlns:ns4="http://schemas.openxmlformats.org/drawingml/2006/main">
+            <a:srgbClr val="141B41"/>
+          </a:solidFill>
+          <a:ln xmlns:ns5="http://schemas.openxmlformats.org/drawingml/2006/main">
+            <a:noFill/>
+          </a:ln>
+        </p:spPr>
+      </p:sp>
+      <p:sp>
+        <p:nvSpPr>
+          <p:cNvPr id="5" name="CategoryLabel.Top"/>
+          <p:cNvSpPr>
+            <a:spLocks noGrp="1"/>
+          </p:cNvSpPr>
+          <p:nvPr>
+            <p:ph type="body" idx="10"/>
+          </p:nvPr>
+        </p:nvSpPr>
+        <p:spPr>
+          <a:xfrm>
+            <a:off x="1097280" y="1371600"/>
+            <a:ext cx="9144000" cy="457200"/>
+          </a:xfrm>
+        </p:spPr>
+        <p:txBody>
+          <a:bodyPr wrap="square" anchor="t" anchorCtr="0"/>
+          <a:lstStyle>
+            <a:defPPr>
+              <a:defRPr sz="1800" b="1">
+                <a:solidFill>
+                  <a:srgbClr val="3B82F6"/>
+                </a:solidFill>
+              </a:defRPr>
+            </a:defPPr>
+          </a:lstStyle>
+          <a:p>
+            <a:r>
+              <a:rPr lang="ja-JP"/>
+              <a:t> </a:t>
+            </a:r>
+          </a:p>
+        </p:txBody>
+      </p:sp>
+      <p:sp>
+        <p:nvSpPr>
+          <p:cNvPr id="6" name="Title.Center"/>
+          <p:cNvSpPr>
+            <a:spLocks noGrp="1"/>
+          </p:cNvSpPr>
+          <p:nvPr>
+            <p:ph type="ctrTitle" idx="0"/>
+          </p:nvPr>
+        </p:nvSpPr>
+        <p:spPr>
+          <a:xfrm>
+            <a:off x="1097280" y="2011680"/>
+            <a:ext cx="9601200" cy="1463040"/>
+          </a:xfrm>
+        </p:spPr>
+        <p:txBody>
+          <a:bodyPr wrap="square" anchor="t" anchorCtr="0"/>
+          <a:lstStyle>
+            <a:defPPr>
+              <a:defRPr sz="4200"/>
+            </a:defPPr>
+          </a:lstStyle>
+          <a:p>
+            <a:r>
+              <a:rPr lang="ja-JP"/>
+              <a:t> </a:t>
+            </a:r>
+          </a:p>
+        </p:txBody>
+      </p:sp>
+      <p:sp>
+        <p:nvSpPr>
+          <p:cNvPr id="7" name="PresenterName.Bottom"/>
+          <p:cNvSpPr>
+            <a:spLocks noGrp="1"/>
+          </p:cNvSpPr>
+          <p:nvPr>
+            <p:ph type="body" idx="11"/>
+          </p:nvPr>
+        </p:nvSpPr>
+        <p:spPr>
+          <a:xfrm>
+            <a:off x="1097280" y="4754880"/>
+            <a:ext cx="7315200" cy="457200"/>
+          </a:xfrm>
+        </p:spPr>
+        <p:txBody>
+          <a:bodyPr wrap="square" anchor="t" anchorCtr="0"/>
+          <a:lstStyle>
+            <a:defPPr>
+              <a:defRPr sz="1600">
+                <a:solidFill>
+                  <a:srgbClr val="CADCFC"/>
+                </a:solidFill>
+              </a:defRPr>
+            </a:defPPr>
+          </a:lstStyle>
+          <a:p>
+            <a:r>
+              <a:rPr lang="ja-JP"/>
+              <a:t> </a:t>
+            </a:r>
+          </a:p>
+        </p:txBody>
+      </p:sp>
+      <p:sp>
+        <p:nvSpPr>
+          <p:cNvPr id="8" name="Contact.Bottom"/>
+          <p:cNvSpPr>
+            <a:spLocks noGrp="1"/>
+          </p:cNvSpPr>
+          <p:nvPr>
+            <p:ph type="body" idx="12"/>
+          </p:nvPr>
+        </p:nvSpPr>
+        <p:spPr>
+          <a:xfrm>
+            <a:off x="1097280" y="5303520"/>
+            <a:ext cx="7315200" cy="731520"/>
+          </a:xfrm>
+        </p:spPr>
+        <p:txBody>
+          <a:bodyPr wrap="square" anchor="t" anchorCtr="0"/>
+          <a:lstStyle>
+            <a:defPPr>
+              <a:defRPr sz="1300">
+                <a:solidFill>
+                  <a:srgbClr val="CADCFC"/>
+                </a:solidFill>
+              </a:defRPr>
+            </a:defPPr>
+          </a:lstStyle>
+          <a:p>
+            <a:r>
+              <a:rPr lang="ja-JP"/>
+              <a:t> </a:t>
+            </a:r>
+          </a:p>
+        </p:txBody>
+      </p:sp>
+    </p:spTree>
+  </p:cSld>
+  <p:clrMapOvr/>
+</p:sldLayout>
 </file>
 
 <file path=ppt/slideLayouts/slideLayout3.xml><?xml version="1.0" encoding="utf-8"?>
-<p:sldLayout xmlns:a="http://schemas.openxmlformats.org/drawingml/2006/main" xmlns:r="http://schemas.openxmlformats.org/officeDocument/2006/relationships" xmlns:p="http://schemas.openxmlformats.org/presentationml/2006/main" type="title" preserve="1">
+<p:sldLayout xmlns:a="http://schemas.openxmlformats.org/drawingml/2006/main" xmlns:p="http://schemas.openxmlformats.org/presentationml/2006/main" xmlns:r="http://schemas.openxmlformats.org/officeDocument/2006/relationships" type="title" preserve="1">
   <p:cSld name="Title.1Title.Single+1Summary">
     <p:spTree>
       <p:nvGrpSpPr>
@@ -1368,12 +3368,12 @@
       </p:sp>
       <p:sp>
         <p:nvSpPr>
-          <p:cNvPr id="10" name="CategoryLabel.Left"/>
-          <p:cNvSpPr>
-            <a:spLocks noGrp="1"/>
-          </p:cNvSpPr>
-          <p:nvPr>
-            <p:ph idx="10" type="body"/>
+          <p:cNvPr id="6" name="CategoryLabel.Left"/>
+          <p:cNvSpPr>
+            <a:spLocks noGrp="1"/>
+          </p:cNvSpPr>
+          <p:nvPr>
+            <p:ph type="body" idx="10"/>
           </p:nvPr>
         </p:nvSpPr>
         <p:spPr>
@@ -1386,7 +3386,7 @@
           <a:bodyPr wrap="square" anchor="t" anchorCtr="0"/>
           <a:lstStyle>
             <a:defPPr>
-              <a:defRPr sz="1400" b="1">
+              <a:defRPr b="1">
                 <a:solidFill>
                   <a:srgbClr val="3B82F6"/>
                 </a:solidFill>
@@ -1394,24 +3394,21 @@
             </a:defPPr>
           </a:lstStyle>
           <a:p>
-            <a:pPr algn="l">
-              <a:buNone/>
-            </a:pPr>
-            <a:r>
-              <a:rPr lang="ja-JP"/>
-              <a:t>REPORT</a:t>
-            </a:r>
-          </a:p>
-        </p:txBody>
-      </p:sp>
-      <p:sp>
-        <p:nvSpPr>
-          <p:cNvPr id="11" name="Title.Left"/>
-          <p:cNvSpPr>
-            <a:spLocks noGrp="1"/>
-          </p:cNvSpPr>
-          <p:nvPr>
-            <p:ph idx="0" type="ctrTitle"/>
+            <a:r>
+              <a:rPr lang="ja-JP"/>
+              <a:t> </a:t>
+            </a:r>
+          </a:p>
+        </p:txBody>
+      </p:sp>
+      <p:sp>
+        <p:nvSpPr>
+          <p:cNvPr id="7" name="Title.Left"/>
+          <p:cNvSpPr>
+            <a:spLocks noGrp="1"/>
+          </p:cNvSpPr>
+          <p:nvPr>
+            <p:ph type="ctrTitle" idx="0"/>
           </p:nvPr>
         </p:nvSpPr>
         <p:spPr>
@@ -1428,24 +3425,21 @@
             </a:defPPr>
           </a:lstStyle>
           <a:p>
-            <a:pPr algn="l">
-              <a:buNone/>
-            </a:pPr>
-            <a:r>
-              <a:rPr lang="ja-JP"/>
-              <a:t>タイトル</a:t>
-            </a:r>
-          </a:p>
-        </p:txBody>
-      </p:sp>
-      <p:sp>
-        <p:nvSpPr>
-          <p:cNvPr id="12" name="Subtitle.Left"/>
-          <p:cNvSpPr>
-            <a:spLocks noGrp="1"/>
-          </p:cNvSpPr>
-          <p:nvPr>
-            <p:ph idx="1" type="subTitle"/>
+            <a:r>
+              <a:rPr lang="ja-JP"/>
+              <a:t> </a:t>
+            </a:r>
+          </a:p>
+        </p:txBody>
+      </p:sp>
+      <p:sp>
+        <p:nvSpPr>
+          <p:cNvPr id="8" name="Subtitle.Left"/>
+          <p:cNvSpPr>
+            <a:spLocks noGrp="1"/>
+          </p:cNvSpPr>
+          <p:nvPr>
+            <p:ph type="subTitle" idx="1"/>
           </p:nvPr>
         </p:nvSpPr>
         <p:spPr>
@@ -1466,24 +3460,21 @@
             </a:defPPr>
           </a:lstStyle>
           <a:p>
-            <a:pPr algn="l">
-              <a:buNone/>
-            </a:pPr>
-            <a:r>
-              <a:rPr lang="ja-JP"/>
-              <a:t>サブタイトル</a:t>
-            </a:r>
-          </a:p>
-        </p:txBody>
-      </p:sp>
-      <p:sp>
-        <p:nvSpPr>
-          <p:cNvPr id="13" name="Summary.Right"/>
-          <p:cNvSpPr>
-            <a:spLocks noGrp="1"/>
-          </p:cNvSpPr>
-          <p:nvPr>
-            <p:ph idx="11" type="body"/>
+            <a:r>
+              <a:rPr lang="ja-JP"/>
+              <a:t> </a:t>
+            </a:r>
+          </a:p>
+        </p:txBody>
+      </p:sp>
+      <p:sp>
+        <p:nvSpPr>
+          <p:cNvPr id="9" name="Summary.Right"/>
+          <p:cNvSpPr>
+            <a:spLocks noGrp="1"/>
+          </p:cNvSpPr>
+          <p:nvPr>
+            <p:ph type="body" idx="11"/>
           </p:nvPr>
         </p:nvSpPr>
         <p:spPr>
@@ -1494,35 +3485,23 @@
         </p:spPr>
         <p:txBody>
           <a:bodyPr wrap="square" anchor="t" anchorCtr="0"/>
-          <a:lstStyle>
-            <a:defPPr>
-              <a:defRPr>
-                <a:solidFill>
-                  <a:srgbClr val="1E293B"/>
-                </a:solidFill>
-              </a:defRPr>
-            </a:defPPr>
-          </a:lstStyle>
-          <a:p>
-            <a:pPr algn="l">
-              <a:buNone/>
-            </a:pPr>
-            <a:r>
-              <a:rPr lang="ja-JP"/>
-              <a:t>サマリー・概要テキスト
-または画像を配置</a:t>
-            </a:r>
-          </a:p>
-        </p:txBody>
-      </p:sp>
-      <p:sp>
-        <p:nvSpPr>
-          <p:cNvPr id="14" name="Date.Bottom"/>
-          <p:cNvSpPr>
-            <a:spLocks noGrp="1"/>
-          </p:cNvSpPr>
-          <p:nvPr>
-            <p:ph idx="12" type="body"/>
+          <a:lstStyle/>
+          <a:p>
+            <a:r>
+              <a:rPr lang="ja-JP"/>
+              <a:t> </a:t>
+            </a:r>
+          </a:p>
+        </p:txBody>
+      </p:sp>
+      <p:sp>
+        <p:nvSpPr>
+          <p:cNvPr id="10" name="Date.Bottom"/>
+          <p:cNvSpPr>
+            <a:spLocks noGrp="1"/>
+          </p:cNvSpPr>
+          <p:nvPr>
+            <p:ph type="body" idx="12"/>
           </p:nvPr>
         </p:nvSpPr>
         <p:spPr>
@@ -1543,12 +3522,9 @@
             </a:defPPr>
           </a:lstStyle>
           <a:p>
-            <a:pPr algn="l">
-              <a:buNone/>
-            </a:pPr>
-            <a:r>
-              <a:rPr lang="ja-JP"/>
-              <a:t>日付  |  組織名</a:t>
+            <a:r>
+              <a:rPr lang="ja-JP"/>
+              <a:t> </a:t>
             </a:r>
           </a:p>
         </p:txBody>
@@ -1559,22 +3535,11 @@
 </p:sldLayout>
 </file>
 
-<file path=ppt/slideLayouts/slideLayout30.xml><?xml version='1.0' encoding='UTF-8' standalone='yes'?>
-<ns0:sldLayout xmlns:ns0="http://schemas.openxmlformats.org/presentationml/2006/main" type="blank" preserve="1"><ns0:cSld name="Closing.1Steps.Single+1Notes"><ns0:spTree><ns0:nvGrpSpPr><ns0:cNvPr id="1" name=""/><ns0:cNvGrpSpPr/><ns0:nvPr/></ns0:nvGrpSpPr><ns0:grpSpPr><ns1:xfrm xmlns:ns1="http://schemas.openxmlformats.org/drawingml/2006/main"><ns1:off x="0" y="0"/><ns1:ext cx="0" cy="0"/><ns1:chOff x="0" y="0"/><ns1:chExt cx="0" cy="0"/></ns1:xfrm></ns0:grpSpPr><ns0:sp><ns0:nvSpPr><ns0:cNvPr id="2" name="BG"/><ns0:cNvSpPr><ns1:spLocks xmlns:ns1="http://schemas.openxmlformats.org/drawingml/2006/main" noGrp="1" noSelect="0" noRot="1" noMove="1"/></ns0:cNvSpPr><ns0:nvPr/></ns0:nvSpPr><ns0:spPr><ns2:xfrm xmlns:ns2="http://schemas.openxmlformats.org/drawingml/2006/main"><ns2:off x="0" y="0"/><ns2:ext cx="12192000" cy="6858000"/></ns2:xfrm><ns3:prstGeom xmlns:ns3="http://schemas.openxmlformats.org/drawingml/2006/main" prst="rect"/><ns4:solidFill xmlns:ns4="http://schemas.openxmlformats.org/drawingml/2006/main"><ns4:srgbClr val="1E2761"/></ns4:solidFill><ns5:ln xmlns:ns5="http://schemas.openxmlformats.org/drawingml/2006/main"><ns5:noFill/></ns5:ln></ns0:spPr></ns0:sp><ns0:sp><ns0:nvSpPr><ns0:cNvPr id="3" name="AccentBar"/><ns0:cNvSpPr><ns1:spLocks xmlns:ns1="http://schemas.openxmlformats.org/drawingml/2006/main" noGrp="1" noSelect="0" noRot="1" noMove="1"/></ns0:cNvSpPr><ns0:nvPr/></ns0:nvSpPr><ns0:spPr><ns2:xfrm xmlns:ns2="http://schemas.openxmlformats.org/drawingml/2006/main"><ns2:off x="0" y="0"/><ns2:ext cx="164592" cy="6858000"/></ns2:xfrm><ns3:prstGeom xmlns:ns3="http://schemas.openxmlformats.org/drawingml/2006/main" prst="rect"/><ns4:solidFill xmlns:ns4="http://schemas.openxmlformats.org/drawingml/2006/main"><ns4:srgbClr val="3B82F6"/></ns4:solidFill><ns5:ln xmlns:ns5="http://schemas.openxmlformats.org/drawingml/2006/main"><ns5:noFill/></ns5:ln></ns0:spPr></ns0:sp><ns0:sp><ns0:nvSpPr><ns0:cNvPr id="4" name="StepsPanel"/><ns0:cNvSpPr><ns1:spLocks xmlns:ns1="http://schemas.openxmlformats.org/drawingml/2006/main" noGrp="1" noSelect="0" noRot="1" noMove="1"/></ns0:cNvSpPr><ns0:nvPr/></ns0:nvSpPr><ns0:spPr><ns2:xfrm xmlns:ns2="http://schemas.openxmlformats.org/drawingml/2006/main"><ns2:off x="731520" y="914400"/><ns2:ext cx="6858000" cy="5029200"/></ns2:xfrm><ns3:prstGeom xmlns:ns3="http://schemas.openxmlformats.org/drawingml/2006/main" prst="roundRect"><ns3:avLst><ns3:gd name="adj" fmla="val 10000"/></ns3:avLst></ns3:prstGeom><ns4:solidFill xmlns:ns4="http://schemas.openxmlformats.org/drawingml/2006/main"><ns4:srgbClr val="141B41"/></ns4:solidFill><ns5:ln xmlns:ns5="http://schemas.openxmlformats.org/drawingml/2006/main"><ns5:noFill/></ns5:ln></ns0:spPr></ns0:sp><ns0:sp><ns0:nvSpPr><ns0:cNvPr id="5" name="CTAPanel"/><ns0:cNvSpPr><ns1:spLocks xmlns:ns1="http://schemas.openxmlformats.org/drawingml/2006/main" noGrp="1" noSelect="0" noRot="1" noMove="1"/></ns0:cNvSpPr><ns0:nvPr/></ns0:nvSpPr><ns0:spPr><ns2:xfrm xmlns:ns2="http://schemas.openxmlformats.org/drawingml/2006/main"><ns2:off x="8046720" y="914400"/><ns2:ext cx="3657600" cy="5029200"/></ns2:xfrm><ns3:prstGeom xmlns:ns3="http://schemas.openxmlformats.org/drawingml/2006/main" prst="roundRect"><ns3:avLst><ns3:gd name="adj" fmla="val 10000"/></ns3:avLst></ns3:prstGeom><ns4:solidFill xmlns:ns4="http://schemas.openxmlformats.org/drawingml/2006/main"><ns4:srgbClr val="2D3A6E"/></ns4:solidFill><ns5:ln xmlns:ns5="http://schemas.openxmlformats.org/drawingml/2006/main"><ns5:noFill/></ns5:ln></ns0:spPr></ns0:sp><ns0:sp><ns0:nvSpPr><ns0:cNvPr id="10" name="Title.Left"/><ns0:cNvSpPr><ns1:spLocks xmlns:ns1="http://schemas.openxmlformats.org/drawingml/2006/main" noGrp="1"/></ns0:cNvSpPr><ns0:nvPr><ns0:ph idx="15" type="body"/></ns0:nvPr></ns0:nvSpPr><ns0:spPr><ns2:xfrm xmlns:ns2="http://schemas.openxmlformats.org/drawingml/2006/main"><ns2:off x="1097280" y="1188720"/><ns2:ext cx="6217920" cy="640080"/></ns2:xfrm></ns0:spPr><ns0:txBody><ns3:bodyPr xmlns:ns3="http://schemas.openxmlformats.org/drawingml/2006/main" wrap="square" anchor="t" anchorCtr="0"/><ns4:lstStyle><ns4:defPPr><ns4:defRPr sz="2800" b="1"><ns4:solidFill><ns4:srgbClr val="FFFFFF"/></ns4:solidFill></ns4:defRPr></ns4:defPPr></ns4:lstStyle><ns4:defPPr algn="l"><ns4:buNone/><ns4:defRPr sz="2800" dirty="0" b="1"><ns4:solidFill><ns4:srgbClr val="FFFFFF"/></ns4:solidFill><ns4:latin typeface="Georgia"/><ns4:ea typeface="Georgia"/></ns4:defRPr></ns4:defPPr><ns4:lvl1pPr algn="l"><ns4:buNone/><ns4:defRPr sz="2800" dirty="0" b="1"><ns4:solidFill><ns4:srgbClr val="FFFFFF"/></ns4:solidFill><ns4:latin typeface="Georgia"/><ns4:ea typeface="Georgia"/></ns4:defRPr></ns4:lvl1pPr><ns4:lvl2pPr algn="l"><ns4:buNone/><ns4:defRPr sz="2800" dirty="0" b="1"><ns4:solidFill><ns4:srgbClr val="FFFFFF"/></ns4:solidFill><ns4:latin typeface="Georgia"/><ns4:ea typeface="Georgia"/></ns4:defRPr></ns4:lvl2pPr><ns4:lvl3pPr algn="l"><ns4:buNone/><ns4:defRPr sz="2800" dirty="0" b="1"><ns4:solidFill><ns4:srgbClr val="FFFFFF"/></ns4:solidFill><ns4:latin typeface="Georgia"/><ns4:ea typeface="Georgia"/></ns4:defRPr></ns4:lvl3pPr><ns4:lvl4pPr algn="l"><ns4:buNone/><ns4:defRPr sz="2800" dirty="0" b="1"><ns4:solidFill><ns4:srgbClr val="FFFFFF"/></ns4:solidFill><ns4:latin typeface="Georgia"/><ns4:ea typeface="Georgia"/></ns4:defRPr></ns4:lvl4pPr><ns4:lvl5pPr algn="l"><ns4:buNone/><ns4:defRPr sz="2800" dirty="0" b="1"><ns4:solidFill><ns4:srgbClr val="FFFFFF"/></ns4:solidFill><ns4:latin typeface="Georgia"/><ns4:ea typeface="Georgia"/></ns4:defRPr></ns4:lvl5pPr><ns4:lvl6pPr algn="l"><ns4:buNone/><ns4:defRPr sz="2800" dirty="0" b="1"><ns4:solidFill><ns4:srgbClr val="FFFFFF"/></ns4:solidFill><ns4:latin typeface="Georgia"/><ns4:ea typeface="Georgia"/></ns4:defRPr></ns4:lvl6pPr><ns4:lvl7pPr algn="l"><ns4:buNone/><ns4:defRPr sz="2800" dirty="0" b="1"><ns4:solidFill><ns4:srgbClr val="FFFFFF"/></ns4:solidFill><ns4:latin typeface="Georgia"/><ns4:ea typeface="Georgia"/></ns4:defRPr></ns4:lvl7pPr><ns4:lvl8pPr algn="l"><ns4:buNone/><ns4:defRPr sz="2800" dirty="0" b="1"><ns4:solidFill><ns4:srgbClr val="FFFFFF"/></ns4:solidFill><ns4:latin typeface="Georgia"/><ns4:ea typeface="Georgia"/></ns4:defRPr></ns4:lvl8pPr><ns4:lvl9pPr algn="l"><ns4:buNone/><ns4:defRPr sz="2800" dirty="0" b="1"><ns4:solidFill><ns4:srgbClr val="FFFFFF"/></ns4:solidFill><ns4:latin typeface="Georgia"/><ns4:ea typeface="Georgia"/></ns4:defRPr></ns4:lvl9pPr></ns4:lstStyle/><ns5:p xmlns:ns5="http://schemas.openxmlformats.org/drawingml/2006/main"><ns5:pPr algn="l"><ns5:buNone/></ns5:pPr><ns5:r><ns5:rPr lang="ja-JP"/><ns5:t>1. アクション項目
-
-2. アクション項目
-
-3. アクション項目</ns5:t></ns5:r></ns5:p></ns0:txBody></ns0:sp><ns0:sp><ns0:nvSpPr><ns0:cNvPr id="21" name="Notes.Right"/><ns0:cNvSpPr><ns1:spLocks xmlns:ns1="http://schemas.openxmlformats.org/drawingml/2006/main" noGrp="1"/></ns0:cNvSpPr><ns0:nvPr><ns0:ph idx="2" type="body"/></ns0:nvPr></ns0:nvSpPr><ns0:spPr><ns2:xfrm xmlns:ns2="http://schemas.openxmlformats.org/drawingml/2006/main"><ns2:off x="8321040" y="1188720"/><ns2:ext cx="3108960" cy="4572000"/></ns2:xfrm></ns0:spPr><ns0:txBody><ns3:bodyPr xmlns:ns3="http://schemas.openxmlformats.org/drawingml/2006/main" wrap="square" anchor="t" anchorCtr="0"/><ns4:lstStyle><ns4:defPPr><ns4:defRPr><ns4:solidFill><ns4:srgbClr val="FFFFFF"/></ns4:solidFill></ns4:defRPr></ns4:defPPr></ns4:lstStyle><ns4:defPPr algn="l"><ns4:buNone/><ns4:defRPr sz="1400" dirty="0"><ns4:solidFill><ns4:srgbClr val="FFFFFF"/></ns4:solidFill><ns4:latin typeface="Calibri"/><ns4:ea typeface="Calibri"/></ns4:defRPr></ns4:defPPr><ns4:lvl1pPr algn="l"><ns4:buNone/><ns4:defRPr sz="1400" dirty="0"><ns4:solidFill><ns4:srgbClr val="FFFFFF"/></ns4:solidFill><ns4:latin typeface="Calibri"/><ns4:ea typeface="Calibri"/></ns4:defRPr></ns4:lvl1pPr><ns4:lvl2pPr algn="l"><ns4:buNone/><ns4:defRPr sz="1400" dirty="0"><ns4:solidFill><ns4:srgbClr val="FFFFFF"/></ns4:solidFill><ns4:latin typeface="Calibri"/><ns4:ea typeface="Calibri"/></ns4:defRPr></ns4:lvl2pPr><ns4:lvl3pPr algn="l"><ns4:buNone/><ns4:defRPr sz="1400" dirty="0"><ns4:solidFill><ns4:srgbClr val="FFFFFF"/></ns4:solidFill><ns4:latin typeface="Calibri"/><ns4:ea typeface="Calibri"/></ns4:defRPr></ns4:lvl3pPr><ns4:lvl4pPr algn="l"><ns4:buNone/><ns4:defRPr sz="1400" dirty="0"><ns4:solidFill><ns4:srgbClr val="FFFFFF"/></ns4:solidFill><ns4:latin typeface="Calibri"/><ns4:ea typeface="Calibri"/></ns4:defRPr></ns4:lvl4pPr><ns4:lvl5pPr algn="l"><ns4:buNone/><ns4:defRPr sz="1400" dirty="0"><ns4:solidFill><ns4:srgbClr val="FFFFFF"/></ns4:solidFill><ns4:latin typeface="Calibri"/><ns4:ea typeface="Calibri"/></ns4:defRPr></ns4:lvl5pPr><ns4:lvl6pPr algn="l"><ns4:buNone/><ns4:defRPr sz="1400" dirty="0"><ns4:solidFill><ns4:srgbClr val="FFFFFF"/></ns4:solidFill><ns4:latin typeface="Calibri"/><ns4:ea typeface="Calibri"/></ns4:defRPr></ns4:lvl6pPr><ns4:lvl7pPr algn="l"><ns4:buNone/><ns4:defRPr sz="1400" dirty="0"><ns4:solidFill><ns4:srgbClr val="FFFFFF"/></ns4:solidFill><ns4:latin typeface="Calibri"/><ns4:ea typeface="Calibri"/></ns4:defRPr></ns4:lvl7pPr><ns4:lvl8pPr algn="l"><ns4:buNone/><ns4:defRPr sz="1400" dirty="0"><ns4:solidFill><ns4:srgbClr val="FFFFFF"/></ns4:solidFill><ns4:latin typeface="Calibri"/><ns4:ea typeface="Calibri"/></ns4:defRPr></ns4:lvl8pPr><ns4:lvl9pPr algn="l"><ns4:buNone/><ns4:defRPr sz="1400" dirty="0"><ns4:solidFill><ns4:srgbClr val="FFFFFF"/></ns4:solidFill><ns4:latin typeface="Calibri"/><ns4:ea typeface="Calibri"/></ns4:defRPr></ns4:lvl9pPr></ns4:lstStyle><ns5:p xmlns:ns5="http://schemas.openxmlformats.org/drawingml/2006/main"><ns5:pPr algn="l"><ns5:buNone/></ns5:pPr><ns5:r><ns5:rPr lang="ja-JP"/><ns5:t>期限
-
-担当者
-
-連絡先
-
-次回MTG日程</ns5:t></ns5:r></ns5:p></ns0:txBody></ns0:sp></ns0:spTree></ns0:cSld><ns0:clrMapOvr/></ns0:sldLayout>
+<file path=ppt/slideLayouts/slideLayout30.xml><?xml version='1.0' encoding='UTF-8' standalone='yes'?><p:sldLayout xmlns:a="http://schemas.openxmlformats.org/drawingml/2006/main" xmlns:p="http://schemas.openxmlformats.org/presentationml/2006/main" xmlns:r="http://schemas.openxmlformats.org/officeDocument/2006/relationships" type="blank" preserve="1"><p:cSld name="Closing.1Steps.Single+1Notes"><p:spTree><p:nvGrpSpPr><p:cNvPr id="1" name=""/><p:cNvGrpSpPr/><p:nvPr/></p:nvGrpSpPr><p:grpSpPr><a:xfrm><a:off x="0" y="0"/><a:ext cx="0" cy="0"/><a:chOff x="0" y="0"/><a:chExt cx="0" cy="0"/></a:xfrm></p:grpSpPr><p:sp><p:nvSpPr><p:cNvPr id="2" name="BG"/><p:cNvSpPr><a:spLocks xmlns:ns1="http://schemas.openxmlformats.org/drawingml/2006/main" noGrp="1" noSelect="0" noRot="1" noMove="1"/></p:cNvSpPr><p:nvPr/></p:nvSpPr><p:spPr><a:xfrm xmlns:ns2="http://schemas.openxmlformats.org/drawingml/2006/main"><a:off x="0" y="0"/><a:ext cx="12192000" cy="6858000"/></a:xfrm><a:prstGeom xmlns:ns3="http://schemas.openxmlformats.org/drawingml/2006/main" prst="rect"/><a:solidFill xmlns:ns4="http://schemas.openxmlformats.org/drawingml/2006/main"><a:srgbClr val="1E2761"/></a:solidFill><a:ln xmlns:ns5="http://schemas.openxmlformats.org/drawingml/2006/main"><a:noFill/></a:ln></p:spPr></p:sp><p:sp><p:nvSpPr><p:cNvPr id="3" name="AccentBar"/><p:cNvSpPr><a:spLocks xmlns:ns1="http://schemas.openxmlformats.org/drawingml/2006/main" noGrp="1" noSelect="0" noRot="1" noMove="1"/></p:cNvSpPr><p:nvPr/></p:nvSpPr><p:spPr><a:xfrm xmlns:ns2="http://schemas.openxmlformats.org/drawingml/2006/main"><a:off x="0" y="0"/><a:ext cx="164592" cy="6858000"/></a:xfrm><a:prstGeom xmlns:ns3="http://schemas.openxmlformats.org/drawingml/2006/main" prst="rect"/><a:solidFill xmlns:ns4="http://schemas.openxmlformats.org/drawingml/2006/main"><a:srgbClr val="3B82F6"/></a:solidFill><a:ln xmlns:ns5="http://schemas.openxmlformats.org/drawingml/2006/main"><a:noFill/></a:ln></p:spPr></p:sp><p:sp><p:nvSpPr><p:cNvPr id="4" name="StepsPanel"/><p:cNvSpPr><a:spLocks xmlns:ns1="http://schemas.openxmlformats.org/drawingml/2006/main" noGrp="1" noSelect="0" noRot="1" noMove="1"/></p:cNvSpPr><p:nvPr/></p:nvSpPr><p:spPr><a:xfrm xmlns:ns2="http://schemas.openxmlformats.org/drawingml/2006/main"><a:off x="731520" y="914400"/><a:ext cx="6858000" cy="5029200"/></a:xfrm><a:prstGeom xmlns:ns3="http://schemas.openxmlformats.org/drawingml/2006/main" prst="roundRect"><a:avLst><a:gd name="adj" fmla="val 10000"/></a:avLst></p:prstGeom><a:solidFill xmlns:ns4="http://schemas.openxmlformats.org/drawingml/2006/main"><a:srgbClr val="141B41"/></a:solidFill><a:ln xmlns:ns5="http://schemas.openxmlformats.org/drawingml/2006/main"><a:noFill/></a:ln></p:spPr></p:sp><p:sp><p:nvSpPr><p:cNvPr id="5" name="CTAPanel"/><p:cNvSpPr><a:spLocks xmlns:ns1="http://schemas.openxmlformats.org/drawingml/2006/main" noGrp="1" noSelect="0" noRot="1" noMove="1"/></p:cNvSpPr><p:nvPr/></p:nvSpPr><p:spPr><a:xfrm xmlns:ns2="http://schemas.openxmlformats.org/drawingml/2006/main"><a:off x="8046720" y="914400"/><a:ext cx="3657600" cy="5029200"/></a:xfrm><a:prstGeom xmlns:ns3="http://schemas.openxmlformats.org/drawingml/2006/main" prst="roundRect"><a:avLst><a:gd name="adj" fmla="val 10000"/></a:avLst></p:prstGeom><a:solidFill xmlns:ns4="http://schemas.openxmlformats.org/drawingml/2006/main"><a:srgbClr val="2D3A6E"/></a:solidFill><a:ln xmlns:ns5="http://schemas.openxmlformats.org/drawingml/2006/main"><a:noFill/></a:ln></p:spPr></p:sp><p:sp><p:nvSpPr><p:cNvPr id="6" name="Title.Left"/><p:cNvSpPr><a:spLocks noGrp="1"/></p:cNvSpPr><p:nvPr><p:ph type="body" idx="15"/></p:nvPr></p:nvSpPr><p:spPr><a:xfrm><a:off x="1097280" y="1188720"/><a:ext cx="6217920" cy="640080"/></a:xfrm></p:spPr><p:txBody><a:bodyPr wrap="square" anchor="t" anchorCtr="0"/><a:lstStyle><a:defPPr><a:defRPr sz="2800" b="1"><a:solidFill><a:srgbClr val="FFFFFF"/></a:solidFill></a:defRPr></a:defPPr></a:lstStyle><a:p><a:r><a:rPr lang="ja-JP"/><a:t> </a:t></a:r></a:p></p:txBody></p:sp><p:sp><p:nvSpPr><p:cNvPr id="7" name="ActionSteps.Left"/><p:cNvSpPr><a:spLocks noGrp="1"/></p:cNvSpPr><p:nvPr><p:ph type="body" idx="1"/></p:nvPr></p:nvSpPr><p:spPr><a:xfrm><a:off x="1097280" y="2011680"/><a:ext cx="6217920" cy="3657600"/></a:xfrm></p:spPr><p:txBody><a:bodyPr wrap="square" anchor="t" anchorCtr="0"/><a:lstStyle><a:defPPr><a:defRPr sz="1500"><a:solidFill><a:srgbClr val="CADCFC"/></a:solidFill></a:defRPr></a:defPPr></a:lstStyle><a:p><a:r><a:rPr lang="ja-JP"/><a:t> </a:t></a:r></a:p></p:txBody></p:sp><p:sp><p:nvSpPr><p:cNvPr id="8" name="Notes.Right"/><p:cNvSpPr><a:spLocks noGrp="1"/></p:cNvSpPr><p:nvPr><p:ph type="body" idx="2"/></p:nvPr></p:nvSpPr><p:spPr><a:xfrm><a:off x="8321040" y="1188720"/><a:ext cx="3108960" cy="4572000"/></a:xfrm></p:spPr><p:txBody><a:bodyPr wrap="square" anchor="t" anchorCtr="0"/><a:lstStyle><a:defPPr><a:defRPr><a:solidFill><a:srgbClr val="FFFFFF"/></a:solidFill></a:defRPr></a:defPPr></a:lstStyle><a:p><a:r><a:rPr lang="ja-JP"/><a:t> </a:t></a:r></a:p></p:txBody></p:sp></p:spTree></p:cSld><p:clrMapOvr/></p:sldLayout>
 </file>
 
 <file path=ppt/slideLayouts/slideLayout4.xml><?xml version="1.0" encoding="utf-8"?>
-<p:sldLayout xmlns:a="http://schemas.openxmlformats.org/drawingml/2006/main" xmlns:r="http://schemas.openxmlformats.org/officeDocument/2006/relationships" xmlns:p="http://schemas.openxmlformats.org/presentationml/2006/main" type="secHead" preserve="1">
+<p:sldLayout xmlns:a="http://schemas.openxmlformats.org/drawingml/2006/main" xmlns:p="http://schemas.openxmlformats.org/presentationml/2006/main" xmlns:r="http://schemas.openxmlformats.org/officeDocument/2006/relationships" type="secHead" preserve="1">
   <p:cSld name="Section.1Title.Single">
     <p:spTree>
       <p:nvGrpSpPr>
@@ -1658,12 +3623,12 @@
       </p:sp>
       <p:sp>
         <p:nvSpPr>
-          <p:cNvPr id="10" name="SectionLabel.Top"/>
-          <p:cNvSpPr>
-            <a:spLocks noGrp="1"/>
-          </p:cNvSpPr>
-          <p:nvPr>
-            <p:ph idx="10" type="body"/>
+          <p:cNvPr id="5" name="SectionLabel.Top"/>
+          <p:cNvSpPr>
+            <a:spLocks noGrp="1"/>
+          </p:cNvSpPr>
+          <p:nvPr>
+            <p:ph type="body" idx="10"/>
           </p:nvPr>
         </p:nvSpPr>
         <p:spPr>
@@ -1684,24 +3649,21 @@
             </a:defPPr>
           </a:lstStyle>
           <a:p>
-            <a:pPr algn="l">
-              <a:buNone/>
-            </a:pPr>
-            <a:r>
-              <a:rPr lang="ja-JP"/>
-              <a:t>SECTION</a:t>
-            </a:r>
-          </a:p>
-        </p:txBody>
-      </p:sp>
-      <p:sp>
-        <p:nvSpPr>
-          <p:cNvPr id="11" name="Title.Center"/>
-          <p:cNvSpPr>
-            <a:spLocks noGrp="1"/>
-          </p:cNvSpPr>
-          <p:nvPr>
-            <p:ph idx="15" type="body"/>
+            <a:r>
+              <a:rPr lang="ja-JP"/>
+              <a:t> </a:t>
+            </a:r>
+          </a:p>
+        </p:txBody>
+      </p:sp>
+      <p:sp>
+        <p:nvSpPr>
+          <p:cNvPr id="6" name="Title.Center"/>
+          <p:cNvSpPr>
+            <a:spLocks noGrp="1"/>
+          </p:cNvSpPr>
+          <p:nvPr>
+            <p:ph type="body" idx="15"/>
           </p:nvPr>
         </p:nvSpPr>
         <p:spPr>
@@ -1722,24 +3684,21 @@
             </a:defPPr>
           </a:lstStyle>
           <a:p>
-            <a:pPr algn="l">
-              <a:buNone/>
-            </a:pPr>
-            <a:r>
-              <a:rPr lang="ja-JP"/>
-              <a:t>セクションタイトル</a:t>
-            </a:r>
-          </a:p>
-        </p:txBody>
-      </p:sp>
-      <p:sp>
-        <p:nvSpPr>
-          <p:cNvPr id="12" name="Description.Bottom"/>
-          <p:cNvSpPr>
-            <a:spLocks noGrp="1"/>
-          </p:cNvSpPr>
-          <p:nvPr>
-            <p:ph idx="11" type="body"/>
+            <a:r>
+              <a:rPr lang="ja-JP"/>
+              <a:t> </a:t>
+            </a:r>
+          </a:p>
+        </p:txBody>
+      </p:sp>
+      <p:sp>
+        <p:nvSpPr>
+          <p:cNvPr id="7" name="Description.Bottom"/>
+          <p:cNvSpPr>
+            <a:spLocks noGrp="1"/>
+          </p:cNvSpPr>
+          <p:nvPr>
+            <p:ph type="body" idx="11"/>
           </p:nvPr>
         </p:nvSpPr>
         <p:spPr>
@@ -1760,12 +3719,9 @@
             </a:defPPr>
           </a:lstStyle>
           <a:p>
-            <a:pPr algn="l">
-              <a:buNone/>
-            </a:pPr>
-            <a:r>
-              <a:rPr lang="ja-JP"/>
-              <a:t>説明テキストを入力</a:t>
+            <a:r>
+              <a:rPr lang="ja-JP"/>
+              <a:t> </a:t>
             </a:r>
           </a:p>
         </p:txBody>
@@ -1777,7 +3733,7 @@
 </file>
 
 <file path=ppt/slideLayouts/slideLayout5.xml><?xml version="1.0" encoding="utf-8"?>
-<p:sldLayout xmlns:a="http://schemas.openxmlformats.org/drawingml/2006/main" xmlns:r="http://schemas.openxmlformats.org/officeDocument/2006/relationships" xmlns:p="http://schemas.openxmlformats.org/presentationml/2006/main" type="secHead" preserve="1">
+<p:sldLayout xmlns:a="http://schemas.openxmlformats.org/drawingml/2006/main" xmlns:p="http://schemas.openxmlformats.org/presentationml/2006/main" xmlns:r="http://schemas.openxmlformats.org/officeDocument/2006/relationships" type="secHead" preserve="1">
   <p:cSld name="SectionNav.1Title.Single">
     <p:spTree>
       <p:nvGrpSpPr>
@@ -1843,12 +3799,12 @@
       </p:sp>
       <p:sp>
         <p:nvSpPr>
-          <p:cNvPr id="10" name="SectionNumber.Left"/>
-          <p:cNvSpPr>
-            <a:spLocks noGrp="1"/>
-          </p:cNvSpPr>
-          <p:nvPr>
-            <p:ph idx="10" type="body"/>
+          <p:cNvPr id="4" name="SectionNumber.Left"/>
+          <p:cNvSpPr>
+            <a:spLocks noGrp="1"/>
+          </p:cNvSpPr>
+          <p:nvPr>
+            <p:ph type="body" idx="10"/>
           </p:nvPr>
         </p:nvSpPr>
         <p:spPr>
@@ -1869,24 +3825,21 @@
             </a:defPPr>
           </a:lstStyle>
           <a:p>
-            <a:pPr algn="ctr">
-              <a:buNone/>
-            </a:pPr>
-            <a:r>
-              <a:rPr lang="ja-JP"/>
-              <a:t>01</a:t>
-            </a:r>
-          </a:p>
-        </p:txBody>
-      </p:sp>
-      <p:sp>
-        <p:nvSpPr>
-          <p:cNvPr id="11" name="SectionLabel.Left"/>
-          <p:cNvSpPr>
-            <a:spLocks noGrp="1"/>
-          </p:cNvSpPr>
-          <p:nvPr>
-            <p:ph idx="11" type="body"/>
+            <a:r>
+              <a:rPr lang="ja-JP"/>
+              <a:t> </a:t>
+            </a:r>
+          </a:p>
+        </p:txBody>
+      </p:sp>
+      <p:sp>
+        <p:nvSpPr>
+          <p:cNvPr id="5" name="SectionLabel.Left"/>
+          <p:cNvSpPr>
+            <a:spLocks noGrp="1"/>
+          </p:cNvSpPr>
+          <p:nvPr>
+            <p:ph type="body" idx="11"/>
           </p:nvPr>
         </p:nvSpPr>
         <p:spPr>
@@ -1907,24 +3860,21 @@
             </a:defPPr>
           </a:lstStyle>
           <a:p>
-            <a:pPr algn="ctr">
-              <a:buNone/>
-            </a:pPr>
-            <a:r>
-              <a:rPr lang="ja-JP"/>
-              <a:t>SECTION</a:t>
-            </a:r>
-          </a:p>
-        </p:txBody>
-      </p:sp>
-      <p:sp>
-        <p:nvSpPr>
-          <p:cNvPr id="12" name="Title.Right"/>
-          <p:cNvSpPr>
-            <a:spLocks noGrp="1"/>
-          </p:cNvSpPr>
-          <p:nvPr>
-            <p:ph idx="15" type="body"/>
+            <a:r>
+              <a:rPr lang="ja-JP"/>
+              <a:t> </a:t>
+            </a:r>
+          </a:p>
+        </p:txBody>
+      </p:sp>
+      <p:sp>
+        <p:nvSpPr>
+          <p:cNvPr id="6" name="Title.Right"/>
+          <p:cNvSpPr>
+            <a:spLocks noGrp="1"/>
+          </p:cNvSpPr>
+          <p:nvPr>
+            <p:ph type="body" idx="15"/>
           </p:nvPr>
         </p:nvSpPr>
         <p:spPr>
@@ -1945,24 +3895,21 @@
             </a:defPPr>
           </a:lstStyle>
           <a:p>
-            <a:pPr algn="l">
-              <a:buNone/>
-            </a:pPr>
-            <a:r>
-              <a:rPr lang="ja-JP"/>
-              <a:t>セクションタイトル</a:t>
-            </a:r>
-          </a:p>
-        </p:txBody>
-      </p:sp>
-      <p:sp>
-        <p:nvSpPr>
-          <p:cNvPr id="13" name="Description.Right"/>
-          <p:cNvSpPr>
-            <a:spLocks noGrp="1"/>
-          </p:cNvSpPr>
-          <p:nvPr>
-            <p:ph idx="12" type="body"/>
+            <a:r>
+              <a:rPr lang="ja-JP"/>
+              <a:t> </a:t>
+            </a:r>
+          </a:p>
+        </p:txBody>
+      </p:sp>
+      <p:sp>
+        <p:nvSpPr>
+          <p:cNvPr id="7" name="Description.Right"/>
+          <p:cNvSpPr>
+            <a:spLocks noGrp="1"/>
+          </p:cNvSpPr>
+          <p:nvPr>
+            <p:ph type="body" idx="12"/>
           </p:nvPr>
         </p:nvSpPr>
         <p:spPr>
@@ -1983,12 +3930,9 @@
             </a:defPPr>
           </a:lstStyle>
           <a:p>
-            <a:pPr algn="l">
-              <a:buNone/>
-            </a:pPr>
-            <a:r>
-              <a:rPr lang="ja-JP"/>
-              <a:t>説明テキストを入力</a:t>
+            <a:r>
+              <a:rPr lang="ja-JP"/>
+              <a:t> </a:t>
             </a:r>
           </a:p>
         </p:txBody>
@@ -2000,7 +3944,7 @@
 </file>
 
 <file path=ppt/slideLayouts/slideLayout6.xml><?xml version="1.0" encoding="utf-8"?>
-<p:sldLayout xmlns:a="http://schemas.openxmlformats.org/drawingml/2006/main" xmlns:r="http://schemas.openxmlformats.org/officeDocument/2006/relationships" xmlns:p="http://schemas.openxmlformats.org/presentationml/2006/main" type="secHead" preserve="1">
+<p:sldLayout xmlns:a="http://schemas.openxmlformats.org/drawingml/2006/main" xmlns:p="http://schemas.openxmlformats.org/presentationml/2006/main" xmlns:r="http://schemas.openxmlformats.org/officeDocument/2006/relationships" type="secHead" preserve="1">
   <p:cSld name="SectionBreak.1Title.Single">
     <p:spTree>
       <p:nvGrpSpPr>
@@ -2128,12 +4072,12 @@
       </p:sp>
       <p:sp>
         <p:nvSpPr>
-          <p:cNvPr id="10" name="SectionLabel.Top"/>
-          <p:cNvSpPr>
-            <a:spLocks noGrp="1"/>
-          </p:cNvSpPr>
-          <p:nvPr>
-            <p:ph idx="10" type="body"/>
+          <p:cNvPr id="7" name="SectionLabel.Top"/>
+          <p:cNvSpPr>
+            <a:spLocks noGrp="1"/>
+          </p:cNvSpPr>
+          <p:nvPr>
+            <p:ph type="body" idx="10"/>
           </p:nvPr>
         </p:nvSpPr>
         <p:spPr>
@@ -2154,24 +4098,21 @@
             </a:defPPr>
           </a:lstStyle>
           <a:p>
-            <a:pPr algn="l">
-              <a:buNone/>
-            </a:pPr>
-            <a:r>
-              <a:rPr lang="ja-JP"/>
-              <a:t>SECTION 01</a:t>
-            </a:r>
-          </a:p>
-        </p:txBody>
-      </p:sp>
-      <p:sp>
-        <p:nvSpPr>
-          <p:cNvPr id="11" name="Title.Center"/>
-          <p:cNvSpPr>
-            <a:spLocks noGrp="1"/>
-          </p:cNvSpPr>
-          <p:nvPr>
-            <p:ph idx="15" type="body"/>
+            <a:r>
+              <a:rPr lang="ja-JP"/>
+              <a:t> </a:t>
+            </a:r>
+          </a:p>
+        </p:txBody>
+      </p:sp>
+      <p:sp>
+        <p:nvSpPr>
+          <p:cNvPr id="8" name="Title.Center"/>
+          <p:cNvSpPr>
+            <a:spLocks noGrp="1"/>
+          </p:cNvSpPr>
+          <p:nvPr>
+            <p:ph type="body" idx="15"/>
           </p:nvPr>
         </p:nvSpPr>
         <p:spPr>
@@ -2192,24 +4133,21 @@
             </a:defPPr>
           </a:lstStyle>
           <a:p>
-            <a:pPr algn="l">
-              <a:buNone/>
-            </a:pPr>
-            <a:r>
-              <a:rPr lang="ja-JP"/>
-              <a:t>セクションタイトル</a:t>
-            </a:r>
-          </a:p>
-        </p:txBody>
-      </p:sp>
-      <p:sp>
-        <p:nvSpPr>
-          <p:cNvPr id="12" name="Description.Bottom"/>
-          <p:cNvSpPr>
-            <a:spLocks noGrp="1"/>
-          </p:cNvSpPr>
-          <p:nvPr>
-            <p:ph idx="11" type="body"/>
+            <a:r>
+              <a:rPr lang="ja-JP"/>
+              <a:t> </a:t>
+            </a:r>
+          </a:p>
+        </p:txBody>
+      </p:sp>
+      <p:sp>
+        <p:nvSpPr>
+          <p:cNvPr id="9" name="Description.Bottom"/>
+          <p:cNvSpPr>
+            <a:spLocks noGrp="1"/>
+          </p:cNvSpPr>
+          <p:nvPr>
+            <p:ph type="body" idx="11"/>
           </p:nvPr>
         </p:nvSpPr>
         <p:spPr>
@@ -2230,12 +4168,9 @@
             </a:defPPr>
           </a:lstStyle>
           <a:p>
-            <a:pPr algn="l">
-              <a:buNone/>
-            </a:pPr>
-            <a:r>
-              <a:rPr lang="ja-JP"/>
-              <a:t>説明テキスト</a:t>
+            <a:r>
+              <a:rPr lang="ja-JP"/>
+              <a:t> </a:t>
             </a:r>
           </a:p>
         </p:txBody>
@@ -2247,7 +4182,7 @@
 </file>
 
 <file path=ppt/slideLayouts/slideLayout7.xml><?xml version="1.0" encoding="utf-8"?>
-<p:sldLayout xmlns:a="http://schemas.openxmlformats.org/drawingml/2006/main" xmlns:r="http://schemas.openxmlformats.org/officeDocument/2006/relationships" xmlns:p="http://schemas.openxmlformats.org/presentationml/2006/main" type="obj" preserve="1">
+<p:sldLayout xmlns:a="http://schemas.openxmlformats.org/drawingml/2006/main" xmlns:p="http://schemas.openxmlformats.org/presentationml/2006/main" xmlns:r="http://schemas.openxmlformats.org/officeDocument/2006/relationships" type="obj" preserve="1">
   <p:cSld name="Content.1Body.Single">
     <p:spTree>
       <p:nvGrpSpPr>
@@ -2287,12 +4222,12 @@
       </p:sp>
       <p:sp>
         <p:nvSpPr>
-          <p:cNvPr id="10" name="SlideTitle.Header"/>
-          <p:cNvSpPr>
-            <a:spLocks noGrp="1"/>
-          </p:cNvSpPr>
-          <p:nvPr>
-            <p:ph idx="15" type="body"/>
+          <p:cNvPr id="3" name="SlideTitle.Header"/>
+          <p:cNvSpPr>
+            <a:spLocks noGrp="1"/>
+          </p:cNvSpPr>
+          <p:nvPr>
+            <p:ph type="body" idx="15"/>
           </p:nvPr>
         </p:nvSpPr>
         <p:spPr>
@@ -2313,24 +4248,21 @@
             </a:defPPr>
           </a:lstStyle>
           <a:p>
-            <a:pPr algn="l">
-              <a:buNone/>
-            </a:pPr>
-            <a:r>
-              <a:rPr lang="ja-JP"/>
-              <a:t>スライドタイトル</a:t>
-            </a:r>
-          </a:p>
-        </p:txBody>
-      </p:sp>
-      <p:sp>
-        <p:nvSpPr>
-          <p:cNvPr id="11" name="SlideSubtitle.Header"/>
-          <p:cNvSpPr>
-            <a:spLocks noGrp="1"/>
-          </p:cNvSpPr>
-          <p:nvPr>
-            <p:ph idx="16" type="body"/>
+            <a:r>
+              <a:rPr lang="ja-JP"/>
+              <a:t> </a:t>
+            </a:r>
+          </a:p>
+        </p:txBody>
+      </p:sp>
+      <p:sp>
+        <p:nvSpPr>
+          <p:cNvPr id="4" name="SlideSubtitle.Header"/>
+          <p:cNvSpPr>
+            <a:spLocks noGrp="1"/>
+          </p:cNvSpPr>
+          <p:nvPr>
+            <p:ph type="body" idx="16"/>
           </p:nvPr>
         </p:nvSpPr>
         <p:spPr>
@@ -2351,24 +4283,21 @@
             </a:defPPr>
           </a:lstStyle>
           <a:p>
-            <a:pPr algn="l">
-              <a:buNone/>
-            </a:pPr>
-            <a:r>
-              <a:rPr lang="ja-JP"/>
-              <a:t>サブタイトル</a:t>
-            </a:r>
-          </a:p>
-        </p:txBody>
-      </p:sp>
-      <p:sp>
-        <p:nvSpPr>
-          <p:cNvPr id="20" name="Body.Center"/>
-          <p:cNvSpPr>
-            <a:spLocks noGrp="1"/>
-          </p:cNvSpPr>
-          <p:nvPr>
-            <p:ph idx="1" type="body"/>
+            <a:r>
+              <a:rPr lang="ja-JP"/>
+              <a:t> </a:t>
+            </a:r>
+          </a:p>
+        </p:txBody>
+      </p:sp>
+      <p:sp>
+        <p:nvSpPr>
+          <p:cNvPr id="5" name="Body.Center"/>
+          <p:cNvSpPr>
+            <a:spLocks noGrp="1"/>
+          </p:cNvSpPr>
+          <p:nvPr>
+            <p:ph type="body" idx="1"/>
           </p:nvPr>
         </p:nvSpPr>
         <p:spPr>
@@ -2381,24 +4310,21 @@
           <a:bodyPr wrap="square" anchor="t" anchorCtr="0"/>
           <a:lstStyle/>
           <a:p>
-            <a:pPr algn="l">
-              <a:buNone/>
-            </a:pPr>
-            <a:r>
-              <a:rPr lang="ja-JP"/>
-              <a:t>コンテンツを入力</a:t>
-            </a:r>
-          </a:p>
-        </p:txBody>
-      </p:sp>
-      <p:sp>
-        <p:nvSpPr>
-          <p:cNvPr id="30" name="SlideNum.Footer"/>
-          <p:cNvSpPr>
-            <a:spLocks noGrp="1"/>
-          </p:cNvSpPr>
-          <p:nvPr>
-            <p:ph idx="50" type="sldNum"/>
+            <a:r>
+              <a:rPr lang="ja-JP"/>
+              <a:t> </a:t>
+            </a:r>
+          </a:p>
+        </p:txBody>
+      </p:sp>
+      <p:sp>
+        <p:nvSpPr>
+          <p:cNvPr id="6" name="SlideNum.Footer"/>
+          <p:cNvSpPr>
+            <a:spLocks noGrp="1"/>
+          </p:cNvSpPr>
+          <p:nvPr>
+            <p:ph type="sldNum" idx="50"/>
           </p:nvPr>
         </p:nvSpPr>
         <p:spPr>
@@ -2419,12 +4345,9 @@
             </a:defPPr>
           </a:lstStyle>
           <a:p>
-            <a:pPr algn="r">
-              <a:buNone/>
-            </a:pPr>
-            <a:r>
-              <a:rPr lang="ja-JP"/>
-              <a:t>&lt;#&gt;</a:t>
+            <a:r>
+              <a:rPr lang="ja-JP"/>
+              <a:t> </a:t>
             </a:r>
           </a:p>
         </p:txBody>
@@ -2436,7 +4359,7 @@
 </file>
 
 <file path=ppt/slideLayouts/slideLayout8.xml><?xml version="1.0" encoding="utf-8"?>
-<p:sldLayout xmlns:a="http://schemas.openxmlformats.org/drawingml/2006/main" xmlns:r="http://schemas.openxmlformats.org/officeDocument/2006/relationships" xmlns:p="http://schemas.openxmlformats.org/presentationml/2006/main" type="obj" preserve="1">
+<p:sldLayout xmlns:a="http://schemas.openxmlformats.org/drawingml/2006/main" xmlns:p="http://schemas.openxmlformats.org/presentationml/2006/main" xmlns:r="http://schemas.openxmlformats.org/officeDocument/2006/relationships" type="obj" preserve="1">
   <p:cSld name="Content.1Body.Single+1Notes">
     <p:spTree>
       <p:nvGrpSpPr>
@@ -2476,83 +4399,7 @@
       </p:sp>
       <p:sp>
         <p:nvSpPr>
-          <p:cNvPr id="10" name="SlideTitle.Header"/>
-          <p:cNvSpPr>
-            <a:spLocks noGrp="1"/>
-          </p:cNvSpPr>
-          <p:nvPr>
-            <p:ph idx="15" type="body"/>
-          </p:nvPr>
-        </p:nvSpPr>
-        <p:spPr>
-          <a:xfrm>
-            <a:off x="731520" y="91440"/>
-            <a:ext cx="9144000" cy="475488"/>
-          </a:xfrm>
-        </p:spPr>
-        <p:txBody>
-          <a:bodyPr wrap="square" anchor="t" anchorCtr="0"/>
-          <a:lstStyle>
-            <a:defPPr>
-              <a:defRPr sz="2800" b="1">
-                <a:solidFill>
-                  <a:srgbClr val="FFFFFF"/>
-                </a:solidFill>
-              </a:defRPr>
-            </a:defPPr>
-          </a:lstStyle>
-          <a:p>
-            <a:pPr algn="l">
-              <a:buNone/>
-            </a:pPr>
-            <a:r>
-              <a:rPr lang="ja-JP"/>
-              <a:t>スライドタイトル</a:t>
-            </a:r>
-          </a:p>
-        </p:txBody>
-      </p:sp>
-      <p:sp>
-        <p:nvSpPr>
-          <p:cNvPr id="11" name="SlideSubtitle.Header"/>
-          <p:cNvSpPr>
-            <a:spLocks noGrp="1"/>
-          </p:cNvSpPr>
-          <p:nvPr>
-            <p:ph idx="16" type="body"/>
-          </p:nvPr>
-        </p:nvSpPr>
-        <p:spPr>
-          <a:xfrm>
-            <a:off x="731520" y="658368"/>
-            <a:ext cx="9144000" cy="274320"/>
-          </a:xfrm>
-        </p:spPr>
-        <p:txBody>
-          <a:bodyPr wrap="square" anchor="t" anchorCtr="0"/>
-          <a:lstStyle>
-            <a:defPPr>
-              <a:defRPr sz="1200">
-                <a:solidFill>
-                  <a:srgbClr val="CADCFC"/>
-                </a:solidFill>
-              </a:defRPr>
-            </a:defPPr>
-          </a:lstStyle>
-          <a:p>
-            <a:pPr algn="l">
-              <a:buNone/>
-            </a:pPr>
-            <a:r>
-              <a:rPr lang="ja-JP"/>
-              <a:t>サブタイトル</a:t>
-            </a:r>
-          </a:p>
-        </p:txBody>
-      </p:sp>
-      <p:sp>
-        <p:nvSpPr>
-          <p:cNvPr id="5" name="SidePanel"/>
+          <p:cNvPr id="3" name="SidePanel"/>
           <p:cNvSpPr>
             <a:spLocks noGrp="1" noSelect="0" noRot="1" noMove="1"/>
           </p:cNvSpPr>
@@ -2578,42 +4425,109 @@
       </p:sp>
       <p:sp>
         <p:nvSpPr>
-          <p:cNvPr id="20" name="Body.Left"/>
-          <p:cNvSpPr>
-            <a:spLocks noGrp="1"/>
-          </p:cNvSpPr>
-          <p:nvPr>
-            <p:ph idx="1" type="body"/>
+          <p:cNvPr id="4" name="SlideTitle.Header"/>
+          <p:cNvSpPr>
+            <a:spLocks noGrp="1"/>
+          </p:cNvSpPr>
+          <p:nvPr>
+            <p:ph type="body" idx="15"/>
+          </p:nvPr>
+        </p:nvSpPr>
+        <p:spPr>
+          <a:xfrm>
+            <a:off x="731520" y="91440"/>
+            <a:ext cx="9144000" cy="475488"/>
+          </a:xfrm>
+        </p:spPr>
+        <p:txBody>
+          <a:bodyPr wrap="square" anchor="t" anchorCtr="0"/>
+          <a:lstStyle>
+            <a:defPPr>
+              <a:defRPr sz="2800" b="1">
+                <a:solidFill>
+                  <a:srgbClr val="FFFFFF"/>
+                </a:solidFill>
+              </a:defRPr>
+            </a:defPPr>
+          </a:lstStyle>
+          <a:p>
+            <a:r>
+              <a:rPr lang="ja-JP"/>
+              <a:t> </a:t>
+            </a:r>
+          </a:p>
+        </p:txBody>
+      </p:sp>
+      <p:sp>
+        <p:nvSpPr>
+          <p:cNvPr id="5" name="SlideSubtitle.Header"/>
+          <p:cNvSpPr>
+            <a:spLocks noGrp="1"/>
+          </p:cNvSpPr>
+          <p:nvPr>
+            <p:ph type="body" idx="16"/>
+          </p:nvPr>
+        </p:nvSpPr>
+        <p:spPr>
+          <a:xfrm>
+            <a:off x="731520" y="658368"/>
+            <a:ext cx="9144000" cy="274320"/>
+          </a:xfrm>
+        </p:spPr>
+        <p:txBody>
+          <a:bodyPr wrap="square" anchor="t" anchorCtr="0"/>
+          <a:lstStyle>
+            <a:defPPr>
+              <a:defRPr sz="1200">
+                <a:solidFill>
+                  <a:srgbClr val="CADCFC"/>
+                </a:solidFill>
+              </a:defRPr>
+            </a:defPPr>
+          </a:lstStyle>
+          <a:p>
+            <a:r>
+              <a:rPr lang="ja-JP"/>
+              <a:t> </a:t>
+            </a:r>
+          </a:p>
+        </p:txBody>
+      </p:sp>
+      <p:sp>
+        <p:nvSpPr>
+          <p:cNvPr id="6" name="Body.Left"/>
+          <p:cNvSpPr>
+            <a:spLocks noGrp="1"/>
+          </p:cNvSpPr>
+          <p:nvPr>
+            <p:ph type="body" idx="1"/>
           </p:nvPr>
         </p:nvSpPr>
         <p:spPr>
           <a:xfrm>
             <a:off x="731520" y="1325880"/>
-            <a:ext cx="7498079" cy="4937760"/>
+            <a:ext cx="7498080" cy="4937760"/>
           </a:xfrm>
         </p:spPr>
         <p:txBody>
           <a:bodyPr wrap="square" anchor="t" anchorCtr="0"/>
           <a:lstStyle/>
           <a:p>
-            <a:pPr algn="l">
-              <a:buNone/>
-            </a:pPr>
-            <a:r>
-              <a:rPr lang="ja-JP"/>
-              <a:t>メインコンテンツ</a:t>
-            </a:r>
-          </a:p>
-        </p:txBody>
-      </p:sp>
-      <p:sp>
-        <p:nvSpPr>
-          <p:cNvPr id="21" name="Notes.Right"/>
-          <p:cNvSpPr>
-            <a:spLocks noGrp="1"/>
-          </p:cNvSpPr>
-          <p:nvPr>
-            <p:ph idx="2" type="body"/>
+            <a:r>
+              <a:rPr lang="ja-JP"/>
+              <a:t> </a:t>
+            </a:r>
+          </a:p>
+        </p:txBody>
+      </p:sp>
+      <p:sp>
+        <p:nvSpPr>
+          <p:cNvPr id="7" name="Notes.Right"/>
+          <p:cNvSpPr>
+            <a:spLocks noGrp="1"/>
+          </p:cNvSpPr>
+          <p:nvPr>
+            <p:ph type="body" idx="2"/>
           </p:nvPr>
         </p:nvSpPr>
         <p:spPr>
@@ -2630,26 +4544,21 @@
             </a:defPPr>
           </a:lstStyle>
           <a:p>
-            <a:pPr algn="l">
-              <a:buNone/>
-            </a:pPr>
-            <a:r>
-              <a:rPr lang="ja-JP"/>
-              <a:t>サイドバー
-補足情報・メモ・
-関連リンク等</a:t>
-            </a:r>
-          </a:p>
-        </p:txBody>
-      </p:sp>
-      <p:sp>
-        <p:nvSpPr>
-          <p:cNvPr id="30" name="SlideNum.Footer"/>
-          <p:cNvSpPr>
-            <a:spLocks noGrp="1"/>
-          </p:cNvSpPr>
-          <p:nvPr>
-            <p:ph idx="50" type="sldNum"/>
+            <a:r>
+              <a:rPr lang="ja-JP"/>
+              <a:t> </a:t>
+            </a:r>
+          </a:p>
+        </p:txBody>
+      </p:sp>
+      <p:sp>
+        <p:nvSpPr>
+          <p:cNvPr id="8" name="SlideNum.Footer"/>
+          <p:cNvSpPr>
+            <a:spLocks noGrp="1"/>
+          </p:cNvSpPr>
+          <p:nvPr>
+            <p:ph type="sldNum" idx="50"/>
           </p:nvPr>
         </p:nvSpPr>
         <p:spPr>
@@ -2670,12 +4579,9 @@
             </a:defPPr>
           </a:lstStyle>
           <a:p>
-            <a:pPr algn="r">
-              <a:buNone/>
-            </a:pPr>
-            <a:r>
-              <a:rPr lang="ja-JP"/>
-              <a:t>&lt;#&gt;</a:t>
+            <a:r>
+              <a:rPr lang="ja-JP"/>
+              <a:t> </a:t>
             </a:r>
           </a:p>
         </p:txBody>
@@ -2687,7 +4593,7 @@
 </file>
 
 <file path=ppt/slideLayouts/slideLayout9.xml><?xml version="1.0" encoding="utf-8"?>
-<p:sldLayout xmlns:a="http://schemas.openxmlformats.org/drawingml/2006/main" xmlns:r="http://schemas.openxmlformats.org/officeDocument/2006/relationships" xmlns:p="http://schemas.openxmlformats.org/presentationml/2006/main" type="obj" preserve="1">
+<p:sldLayout xmlns:a="http://schemas.openxmlformats.org/drawingml/2006/main" xmlns:p="http://schemas.openxmlformats.org/presentationml/2006/main" xmlns:r="http://schemas.openxmlformats.org/officeDocument/2006/relationships" type="obj" preserve="1">
   <p:cSld name="Content.1Body.Single+1Source">
     <p:spTree>
       <p:nvGrpSpPr>
@@ -2727,83 +4633,7 @@
       </p:sp>
       <p:sp>
         <p:nvSpPr>
-          <p:cNvPr id="10" name="SlideTitle.Header"/>
-          <p:cNvSpPr>
-            <a:spLocks noGrp="1"/>
-          </p:cNvSpPr>
-          <p:nvPr>
-            <p:ph idx="15" type="body"/>
-          </p:nvPr>
-        </p:nvSpPr>
-        <p:spPr>
-          <a:xfrm>
-            <a:off x="731520" y="91440"/>
-            <a:ext cx="9144000" cy="475488"/>
-          </a:xfrm>
-        </p:spPr>
-        <p:txBody>
-          <a:bodyPr wrap="square" anchor="t" anchorCtr="0"/>
-          <a:lstStyle>
-            <a:defPPr>
-              <a:defRPr sz="2800" b="1">
-                <a:solidFill>
-                  <a:srgbClr val="FFFFFF"/>
-                </a:solidFill>
-              </a:defRPr>
-            </a:defPPr>
-          </a:lstStyle>
-          <a:p>
-            <a:pPr algn="l">
-              <a:buNone/>
-            </a:pPr>
-            <a:r>
-              <a:rPr lang="ja-JP"/>
-              <a:t>スライドタイトル</a:t>
-            </a:r>
-          </a:p>
-        </p:txBody>
-      </p:sp>
-      <p:sp>
-        <p:nvSpPr>
-          <p:cNvPr id="11" name="SlideSubtitle.Header"/>
-          <p:cNvSpPr>
-            <a:spLocks noGrp="1"/>
-          </p:cNvSpPr>
-          <p:nvPr>
-            <p:ph idx="16" type="body"/>
-          </p:nvPr>
-        </p:nvSpPr>
-        <p:spPr>
-          <a:xfrm>
-            <a:off x="731520" y="658368"/>
-            <a:ext cx="9144000" cy="274320"/>
-          </a:xfrm>
-        </p:spPr>
-        <p:txBody>
-          <a:bodyPr wrap="square" anchor="t" anchorCtr="0"/>
-          <a:lstStyle>
-            <a:defPPr>
-              <a:defRPr sz="1200">
-                <a:solidFill>
-                  <a:srgbClr val="CADCFC"/>
-                </a:solidFill>
-              </a:defRPr>
-            </a:defPPr>
-          </a:lstStyle>
-          <a:p>
-            <a:pPr algn="l">
-              <a:buNone/>
-            </a:pPr>
-            <a:r>
-              <a:rPr lang="ja-JP"/>
-              <a:t>サブタイトル</a:t>
-            </a:r>
-          </a:p>
-        </p:txBody>
-      </p:sp>
-      <p:sp>
-        <p:nvSpPr>
-          <p:cNvPr id="5" name="FooterBar"/>
+          <p:cNvPr id="3" name="FooterBar"/>
           <p:cNvSpPr>
             <a:spLocks noGrp="1" noSelect="0" noRot="1" noMove="1"/>
           </p:cNvSpPr>
@@ -2825,12 +4655,82 @@
       </p:sp>
       <p:sp>
         <p:nvSpPr>
-          <p:cNvPr id="20" name="Body.Center"/>
-          <p:cNvSpPr>
-            <a:spLocks noGrp="1"/>
-          </p:cNvSpPr>
-          <p:nvPr>
-            <p:ph idx="1" type="body"/>
+          <p:cNvPr id="4" name="SlideTitle.Header"/>
+          <p:cNvSpPr>
+            <a:spLocks noGrp="1"/>
+          </p:cNvSpPr>
+          <p:nvPr>
+            <p:ph type="body" idx="15"/>
+          </p:nvPr>
+        </p:nvSpPr>
+        <p:spPr>
+          <a:xfrm>
+            <a:off x="731520" y="91440"/>
+            <a:ext cx="9144000" cy="475488"/>
+          </a:xfrm>
+        </p:spPr>
+        <p:txBody>
+          <a:bodyPr wrap="square" anchor="t" anchorCtr="0"/>
+          <a:lstStyle>
+            <a:defPPr>
+              <a:defRPr sz="2800" b="1">
+                <a:solidFill>
+                  <a:srgbClr val="FFFFFF"/>
+                </a:solidFill>
+              </a:defRPr>
+            </a:defPPr>
+          </a:lstStyle>
+          <a:p>
+            <a:r>
+              <a:rPr lang="ja-JP"/>
+              <a:t> </a:t>
+            </a:r>
+          </a:p>
+        </p:txBody>
+      </p:sp>
+      <p:sp>
+        <p:nvSpPr>
+          <p:cNvPr id="5" name="SlideSubtitle.Header"/>
+          <p:cNvSpPr>
+            <a:spLocks noGrp="1"/>
+          </p:cNvSpPr>
+          <p:nvPr>
+            <p:ph type="body" idx="16"/>
+          </p:nvPr>
+        </p:nvSpPr>
+        <p:spPr>
+          <a:xfrm>
+            <a:off x="731520" y="658368"/>
+            <a:ext cx="9144000" cy="274320"/>
+          </a:xfrm>
+        </p:spPr>
+        <p:txBody>
+          <a:bodyPr wrap="square" anchor="t" anchorCtr="0"/>
+          <a:lstStyle>
+            <a:defPPr>
+              <a:defRPr sz="1200">
+                <a:solidFill>
+                  <a:srgbClr val="CADCFC"/>
+                </a:solidFill>
+              </a:defRPr>
+            </a:defPPr>
+          </a:lstStyle>
+          <a:p>
+            <a:r>
+              <a:rPr lang="ja-JP"/>
+              <a:t> </a:t>
+            </a:r>
+          </a:p>
+        </p:txBody>
+      </p:sp>
+      <p:sp>
+        <p:nvSpPr>
+          <p:cNvPr id="6" name="Body.Center"/>
+          <p:cNvSpPr>
+            <a:spLocks noGrp="1"/>
+          </p:cNvSpPr>
+          <p:nvPr>
+            <p:ph type="body" idx="1"/>
           </p:nvPr>
         </p:nvSpPr>
         <p:spPr>
@@ -2843,24 +4743,21 @@
           <a:bodyPr wrap="square" anchor="t" anchorCtr="0"/>
           <a:lstStyle/>
           <a:p>
-            <a:pPr algn="l">
-              <a:buNone/>
-            </a:pPr>
-            <a:r>
-              <a:rPr lang="ja-JP"/>
-              <a:t>コンテンツを入力</a:t>
-            </a:r>
-          </a:p>
-        </p:txBody>
-      </p:sp>
-      <p:sp>
-        <p:nvSpPr>
-          <p:cNvPr id="21" name="Source.Bottom"/>
-          <p:cNvSpPr>
-            <a:spLocks noGrp="1"/>
-          </p:cNvSpPr>
-          <p:nvPr>
-            <p:ph idx="2" type="body"/>
+            <a:r>
+              <a:rPr lang="ja-JP"/>
+              <a:t> </a:t>
+            </a:r>
+          </a:p>
+        </p:txBody>
+      </p:sp>
+      <p:sp>
+        <p:nvSpPr>
+          <p:cNvPr id="7" name="Source.Bottom"/>
+          <p:cNvSpPr>
+            <a:spLocks noGrp="1"/>
+          </p:cNvSpPr>
+          <p:nvPr>
+            <p:ph type="body" idx="2"/>
           </p:nvPr>
         </p:nvSpPr>
         <p:spPr>
@@ -2881,24 +4778,21 @@
             </a:defPPr>
           </a:lstStyle>
           <a:p>
-            <a:pPr algn="l">
-              <a:buNone/>
-            </a:pPr>
-            <a:r>
-              <a:rPr lang="ja-JP"/>
-              <a:t>出典：データソースを記載</a:t>
-            </a:r>
-          </a:p>
-        </p:txBody>
-      </p:sp>
-      <p:sp>
-        <p:nvSpPr>
-          <p:cNvPr id="30" name="SlideNum.Footer"/>
-          <p:cNvSpPr>
-            <a:spLocks noGrp="1"/>
-          </p:cNvSpPr>
-          <p:nvPr>
-            <p:ph idx="50" type="sldNum"/>
+            <a:r>
+              <a:rPr lang="ja-JP"/>
+              <a:t> </a:t>
+            </a:r>
+          </a:p>
+        </p:txBody>
+      </p:sp>
+      <p:sp>
+        <p:nvSpPr>
+          <p:cNvPr id="8" name="SlideNum.Footer"/>
+          <p:cNvSpPr>
+            <a:spLocks noGrp="1"/>
+          </p:cNvSpPr>
+          <p:nvPr>
+            <p:ph type="sldNum" idx="50"/>
           </p:nvPr>
         </p:nvSpPr>
         <p:spPr>
@@ -2919,12 +4813,9 @@
             </a:defPPr>
           </a:lstStyle>
           <a:p>
-            <a:pPr algn="r">
-              <a:buNone/>
-            </a:pPr>
-            <a:r>
-              <a:rPr lang="ja-JP"/>
-              <a:t>&lt;#&gt;</a:t>
+            <a:r>
+              <a:rPr lang="ja-JP"/>
+              <a:t> </a:t>
             </a:r>
           </a:p>
         </p:txBody>

</xml_diff>